<commit_message>
feat: rebuild current evidence demo film
</commit_message>
<xml_diff>
--- a/public/judge/Finly_Consulting_Deck.pptx
+++ b/public/judge/Finly_Consulting_Deck.pptx
@@ -2,21 +2,21 @@
 <file path=ppt/presentation.xml><?xml version="1.0" encoding="utf-8"?>
 <p:presentation xmlns:p="http://schemas.openxmlformats.org/presentationml/2006/main">
   <p:sldMasterIdLst>
-    <p:sldMasterId xmlns:r="http://schemas.openxmlformats.org/officeDocument/2006/relationships" id="2147483648" r:id="Rdaf529b458934cdb"/>
+    <p:sldMasterId xmlns:r="http://schemas.openxmlformats.org/officeDocument/2006/relationships" id="2147483648" r:id="Ra8f63338e50d4236"/>
   </p:sldMasterIdLst>
   <p:notesMasterIdLst>
-    <p:notesMasterId xmlns:r="http://schemas.openxmlformats.org/officeDocument/2006/relationships" r:id="R3a55c03941804719"/>
+    <p:notesMasterId xmlns:r="http://schemas.openxmlformats.org/officeDocument/2006/relationships" r:id="Ra55b269d55ef4a10"/>
   </p:notesMasterIdLst>
   <p:sldIdLst>
-    <p:sldId xmlns:r="http://schemas.openxmlformats.org/officeDocument/2006/relationships" id="256" r:id="Rb10d2897871e4422"/>
-    <p:sldId xmlns:r="http://schemas.openxmlformats.org/officeDocument/2006/relationships" id="257" r:id="R24f43ffa38694634"/>
-    <p:sldId xmlns:r="http://schemas.openxmlformats.org/officeDocument/2006/relationships" id="258" r:id="Ra71773b2f54f480f"/>
-    <p:sldId xmlns:r="http://schemas.openxmlformats.org/officeDocument/2006/relationships" id="259" r:id="R539fe2b5a0254154"/>
-    <p:sldId xmlns:r="http://schemas.openxmlformats.org/officeDocument/2006/relationships" id="260" r:id="Re987b4a311f34677"/>
-    <p:sldId xmlns:r="http://schemas.openxmlformats.org/officeDocument/2006/relationships" id="261" r:id="R70229dad9a2143ec"/>
-    <p:sldId xmlns:r="http://schemas.openxmlformats.org/officeDocument/2006/relationships" id="262" r:id="R63ce5be70dcf43f0"/>
-    <p:sldId xmlns:r="http://schemas.openxmlformats.org/officeDocument/2006/relationships" id="263" r:id="R45d5562bd1184143"/>
-    <p:sldId xmlns:r="http://schemas.openxmlformats.org/officeDocument/2006/relationships" id="264" r:id="R52c3c9cc0fe64fe0"/>
+    <p:sldId xmlns:r="http://schemas.openxmlformats.org/officeDocument/2006/relationships" id="256" r:id="Rb2b042d87e32448e"/>
+    <p:sldId xmlns:r="http://schemas.openxmlformats.org/officeDocument/2006/relationships" id="257" r:id="R9b126e4ee5794190"/>
+    <p:sldId xmlns:r="http://schemas.openxmlformats.org/officeDocument/2006/relationships" id="258" r:id="Rc39788cd08fd477a"/>
+    <p:sldId xmlns:r="http://schemas.openxmlformats.org/officeDocument/2006/relationships" id="259" r:id="R251f5b792933464e"/>
+    <p:sldId xmlns:r="http://schemas.openxmlformats.org/officeDocument/2006/relationships" id="260" r:id="R0ee004892aa84e3f"/>
+    <p:sldId xmlns:r="http://schemas.openxmlformats.org/officeDocument/2006/relationships" id="261" r:id="Rdfa8ffa751a34c9c"/>
+    <p:sldId xmlns:r="http://schemas.openxmlformats.org/officeDocument/2006/relationships" id="262" r:id="R7a15360dbc124267"/>
+    <p:sldId xmlns:r="http://schemas.openxmlformats.org/officeDocument/2006/relationships" id="263" r:id="R725788fca7324427"/>
+    <p:sldId xmlns:r="http://schemas.openxmlformats.org/officeDocument/2006/relationships" id="264" r:id="R2d7ba16eb8c947d7"/>
   </p:sldIdLst>
   <p:sldSz cx="12192000" cy="6858000"/>
   <p:notesSz cx="6858000" cy="9144000"/>
@@ -166,9 +166,9 @@
 </file>
 
 <file path=ppt/notesMasters/theme/theme3.xml><?xml version="1.0" encoding="utf-8"?>
-<a:theme xmlns:a="http://schemas.openxmlformats.org/drawingml/2006/main" name="ChatGPT">
+<a:theme xmlns:a="http://schemas.openxmlformats.org/drawingml/2006/main" name="Finly">
   <a:themeElements>
-    <a:clrScheme name="ChatGPT">
+    <a:clrScheme name="Finly">
       <a:dk1>
         <a:srgbClr val="000000"/>
       </a:dk1>
@@ -218,7 +218,7 @@
         <a:cs typeface="Calibri"/>
       </a:minorFont>
     </a:fontScheme>
-    <a:fmtScheme name="ChatGPT">
+    <a:fmtScheme name="Finly">
       <a:fillStyleLst>
         <a:solidFill>
           <a:schemeClr val="phClr"/>
@@ -1203,7 +1203,7 @@
   </p:cSld>
   <p:clrMap bg1="lt1" tx1="dk1" bg2="lt2" tx2="dk2" accent1="accent1" accent2="accent2" accent3="accent3" accent4="accent4" accent5="accent5" accent6="accent6" hlink="hlink" folHlink="folHlink"/>
   <p:sldLayoutIdLst>
-    <p:sldLayoutId xmlns:r="http://schemas.openxmlformats.org/officeDocument/2006/relationships" id="2147483649" r:id="R9ac47f1208ba4455"/>
+    <p:sldLayoutId xmlns:r="http://schemas.openxmlformats.org/officeDocument/2006/relationships" id="2147483649" r:id="R45985b5cd8e1414f"/>
   </p:sldLayoutIdLst>
   <p:txStyles>
     <p:titleStyle>
@@ -1486,9 +1486,9 @@
 </file>
 
 <file path=ppt/slideMasters/theme/theme2.xml><?xml version="1.0" encoding="utf-8"?>
-<a:theme xmlns:a="http://schemas.openxmlformats.org/drawingml/2006/main" name="ChatGPT">
+<a:theme xmlns:a="http://schemas.openxmlformats.org/drawingml/2006/main" name="Finly">
   <a:themeElements>
-    <a:clrScheme name="ChatGPT">
+    <a:clrScheme name="Finly">
       <a:dk1>
         <a:srgbClr val="000000"/>
       </a:dk1>
@@ -1538,7 +1538,7 @@
         <a:cs typeface="Calibri"/>
       </a:minorFont>
     </a:fontScheme>
-    <a:fmtScheme name="ChatGPT">
+    <a:fmtScheme name="Finly">
       <a:fillStyleLst>
         <a:solidFill>
           <a:schemeClr val="phClr"/>
@@ -1956,7 +1956,7 @@
           <p:cNvPr id="10" name="footer-1">
             <a:extLst xmlns:a="http://schemas.openxmlformats.org/drawingml/2006/main">
               <a:ext uri="{FF2B5EF4-FFF2-40B4-BE49-F238E27FC236}">
-                <a16:creationId xmlns:a16="http://schemas.microsoft.com/office/drawing/2014/main" id="{8A91D7F6-C48B-444A-850C-4F14FFA816B2}"/>
+                <a16:creationId xmlns:a16="http://schemas.microsoft.com/office/drawing/2014/main" id="{C22C9880-3A0B-4F26-AA95-C95F5139E731}"/>
               </a:ext>
             </a:extLst>
           </p:cNvPr>
@@ -2018,7 +2018,7 @@
           <p:cNvPr id="2" name="page-1">
             <a:extLst xmlns:a="http://schemas.openxmlformats.org/drawingml/2006/main">
               <a:ext uri="{FF2B5EF4-FFF2-40B4-BE49-F238E27FC236}">
-                <a16:creationId xmlns:a16="http://schemas.microsoft.com/office/drawing/2014/main" id="{C675E2CD-2BA8-4557-939D-3BAB6C6A5652}"/>
+                <a16:creationId xmlns:a16="http://schemas.microsoft.com/office/drawing/2014/main" id="{248C3DC2-F98F-4CEE-A552-C475C5FDDD3A}"/>
               </a:ext>
             </a:extLst>
           </p:cNvPr>
@@ -2084,7 +2084,7 @@
           <p:nvPr/>
         </p:nvPicPr>
         <p:blipFill>
-          <a:blip xmlns:r="http://schemas.openxmlformats.org/officeDocument/2006/relationships" xmlns:a="http://schemas.openxmlformats.org/drawingml/2006/main" r:embed="R721bb82dec374a03"/>
+          <a:blip xmlns:r="http://schemas.openxmlformats.org/officeDocument/2006/relationships" xmlns:a="http://schemas.openxmlformats.org/drawingml/2006/main" r:embed="Rbc076ac866194267"/>
           <a:stretch xmlns:a="http://schemas.openxmlformats.org/drawingml/2006/main"/>
         </p:blipFill>
         <p:spPr>
@@ -2102,7 +2102,7 @@
           <p:cNvPr id="4" name="title-wordmark">
             <a:extLst xmlns:a="http://schemas.openxmlformats.org/drawingml/2006/main">
               <a:ext uri="{FF2B5EF4-FFF2-40B4-BE49-F238E27FC236}">
-                <a16:creationId xmlns:a16="http://schemas.microsoft.com/office/drawing/2014/main" id="{0FAB8BC6-5342-456D-9B6F-FC0C8AAAF63C}"/>
+                <a16:creationId xmlns:a16="http://schemas.microsoft.com/office/drawing/2014/main" id="{E15E145B-4F5F-4E95-B953-E08E1B6BF422}"/>
               </a:ext>
             </a:extLst>
           </p:cNvPr>
@@ -2164,7 +2164,7 @@
           <p:cNvPr id="5" name="label-Execution-realistic controlled delegation-62-169">
             <a:extLst xmlns:a="http://schemas.openxmlformats.org/drawingml/2006/main">
               <a:ext uri="{FF2B5EF4-FFF2-40B4-BE49-F238E27FC236}">
-                <a16:creationId xmlns:a16="http://schemas.microsoft.com/office/drawing/2014/main" id="{42C7D3C1-1118-4DDB-B587-F3AC8AE1A2B2}"/>
+                <a16:creationId xmlns:a16="http://schemas.microsoft.com/office/drawing/2014/main" id="{FCF25974-2D4F-41BB-85F1-CE3EED0666C2}"/>
               </a:ext>
             </a:extLst>
           </p:cNvPr>
@@ -2226,7 +2226,7 @@
           <p:cNvPr id="6" name="title">
             <a:extLst xmlns:a="http://schemas.openxmlformats.org/drawingml/2006/main">
               <a:ext uri="{FF2B5EF4-FFF2-40B4-BE49-F238E27FC236}">
-                <a16:creationId xmlns:a16="http://schemas.microsoft.com/office/drawing/2014/main" id="{66857545-29C3-4A86-8C0F-9A8AE8C196B6}"/>
+                <a16:creationId xmlns:a16="http://schemas.microsoft.com/office/drawing/2014/main" id="{49641E07-BDA1-4DB8-8BAA-B4AFDC620626}"/>
               </a:ext>
             </a:extLst>
           </p:cNvPr>
@@ -2315,7 +2315,7 @@
           <p:cNvPr id="7" name="">
             <a:extLst xmlns:a="http://schemas.openxmlformats.org/drawingml/2006/main">
               <a:ext uri="{FF2B5EF4-FFF2-40B4-BE49-F238E27FC236}">
-                <a16:creationId xmlns:a16="http://schemas.microsoft.com/office/drawing/2014/main" id="{801731F3-4B08-4458-B65B-ADBC7C209A68}"/>
+                <a16:creationId xmlns:a16="http://schemas.microsoft.com/office/drawing/2014/main" id="{78DD20EF-645D-4631-B907-549998F08F31}"/>
               </a:ext>
             </a:extLst>
           </p:cNvPr>
@@ -2346,7 +2346,7 @@
           <p:cNvPr id="8" name="subtitle">
             <a:extLst xmlns:a="http://schemas.openxmlformats.org/drawingml/2006/main">
               <a:ext uri="{FF2B5EF4-FFF2-40B4-BE49-F238E27FC236}">
-                <a16:creationId xmlns:a16="http://schemas.microsoft.com/office/drawing/2014/main" id="{325E2EEC-962A-410B-B682-82974CA0D45F}"/>
+                <a16:creationId xmlns:a16="http://schemas.microsoft.com/office/drawing/2014/main" id="{C241564D-F365-40AD-A1A8-CAB32AC157F2}"/>
               </a:ext>
             </a:extLst>
           </p:cNvPr>
@@ -2408,7 +2408,7 @@
           <p:cNvPr id="9" name="author">
             <a:extLst xmlns:a="http://schemas.openxmlformats.org/drawingml/2006/main">
               <a:ext uri="{FF2B5EF4-FFF2-40B4-BE49-F238E27FC236}">
-                <a16:creationId xmlns:a16="http://schemas.microsoft.com/office/drawing/2014/main" id="{3CA727E4-B134-42E4-A440-6795E135096D}"/>
+                <a16:creationId xmlns:a16="http://schemas.microsoft.com/office/drawing/2014/main" id="{6AB0F580-F8D9-41B0-923C-302F8E7E11E0}"/>
               </a:ext>
             </a:extLst>
           </p:cNvPr>
@@ -2468,7 +2468,7 @@
     </p:spTree>
     <p:extLst>
       <p:ext uri="{BB962C8B-B14F-4D97-AF65-F5344CB8AC3E}">
-        <p14:creationId xmlns:p14="http://schemas.microsoft.com/office/powerpoint/2010/main" val="1322961195"/>
+        <p14:creationId xmlns:p14="http://schemas.microsoft.com/office/powerpoint/2010/main" val="1667302379"/>
       </p:ext>
     </p:extLst>
   </p:cSld>
@@ -2499,7 +2499,7 @@
           <p:cNvPr id="14" name="label-The design problem-58-32">
             <a:extLst xmlns:a="http://schemas.openxmlformats.org/drawingml/2006/main">
               <a:ext uri="{FF2B5EF4-FFF2-40B4-BE49-F238E27FC236}">
-                <a16:creationId xmlns:a16="http://schemas.microsoft.com/office/drawing/2014/main" id="{14B342C5-8173-4ADF-8268-0CD9A9DAF2EA}"/>
+                <a16:creationId xmlns:a16="http://schemas.microsoft.com/office/drawing/2014/main" id="{C85F84AF-3AE5-47FF-9159-2617424E1773}"/>
               </a:ext>
             </a:extLst>
           </p:cNvPr>
@@ -2561,7 +2561,7 @@
           <p:cNvPr id="2" name="slide-title-2">
             <a:extLst xmlns:a="http://schemas.openxmlformats.org/drawingml/2006/main">
               <a:ext uri="{FF2B5EF4-FFF2-40B4-BE49-F238E27FC236}">
-                <a16:creationId xmlns:a16="http://schemas.microsoft.com/office/drawing/2014/main" id="{4A55530E-15A1-40D1-ADF5-62447CF4E6F7}"/>
+                <a16:creationId xmlns:a16="http://schemas.microsoft.com/office/drawing/2014/main" id="{1A2BC0BA-597C-4341-92A9-BC796E43D1A9}"/>
               </a:ext>
             </a:extLst>
           </p:cNvPr>
@@ -2623,7 +2623,7 @@
           <p:cNvPr id="3" name="">
             <a:extLst xmlns:a="http://schemas.openxmlformats.org/drawingml/2006/main">
               <a:ext uri="{FF2B5EF4-FFF2-40B4-BE49-F238E27FC236}">
-                <a16:creationId xmlns:a16="http://schemas.microsoft.com/office/drawing/2014/main" id="{E7A80201-02CC-4EC7-9BE5-BE308ED23E5A}"/>
+                <a16:creationId xmlns:a16="http://schemas.microsoft.com/office/drawing/2014/main" id="{3D7A8C8F-5921-4140-9E10-567349E03A7B}"/>
               </a:ext>
             </a:extLst>
           </p:cNvPr>
@@ -2654,7 +2654,7 @@
           <p:cNvPr id="4" name="footer-2">
             <a:extLst xmlns:a="http://schemas.openxmlformats.org/drawingml/2006/main">
               <a:ext uri="{FF2B5EF4-FFF2-40B4-BE49-F238E27FC236}">
-                <a16:creationId xmlns:a16="http://schemas.microsoft.com/office/drawing/2014/main" id="{FB3C0E1D-A449-477C-9DAC-767E3BA3C685}"/>
+                <a16:creationId xmlns:a16="http://schemas.microsoft.com/office/drawing/2014/main" id="{F14F45D7-26EB-4FA8-9497-55AE51D09D5C}"/>
               </a:ext>
             </a:extLst>
           </p:cNvPr>
@@ -2716,7 +2716,7 @@
           <p:cNvPr id="5" name="page-2">
             <a:extLst xmlns:a="http://schemas.openxmlformats.org/drawingml/2006/main">
               <a:ext uri="{FF2B5EF4-FFF2-40B4-BE49-F238E27FC236}">
-                <a16:creationId xmlns:a16="http://schemas.microsoft.com/office/drawing/2014/main" id="{A99B005A-E06B-431B-BA68-778095723863}"/>
+                <a16:creationId xmlns:a16="http://schemas.microsoft.com/office/drawing/2014/main" id="{9EC0F7A2-60FF-4DB5-9004-CFC5600DDC64}"/>
               </a:ext>
             </a:extLst>
           </p:cNvPr>
@@ -2778,7 +2778,7 @@
           <p:cNvPr id="6" name="label-Typical agent-74-215">
             <a:extLst xmlns:a="http://schemas.openxmlformats.org/drawingml/2006/main">
               <a:ext uri="{FF2B5EF4-FFF2-40B4-BE49-F238E27FC236}">
-                <a16:creationId xmlns:a16="http://schemas.microsoft.com/office/drawing/2014/main" id="{805C9520-35E0-4390-9D01-92AB5ED2A42C}"/>
+                <a16:creationId xmlns:a16="http://schemas.microsoft.com/office/drawing/2014/main" id="{79EAB827-B5F9-413D-883F-4ABBE27A2FF1}"/>
               </a:ext>
             </a:extLst>
           </p:cNvPr>
@@ -2840,7 +2840,7 @@
           <p:cNvPr id="7" name="judgment-question">
             <a:extLst xmlns:a="http://schemas.openxmlformats.org/drawingml/2006/main">
               <a:ext uri="{FF2B5EF4-FFF2-40B4-BE49-F238E27FC236}">
-                <a16:creationId xmlns:a16="http://schemas.microsoft.com/office/drawing/2014/main" id="{70139F40-8588-4B3E-A35C-C0F6B9EB6F30}"/>
+                <a16:creationId xmlns:a16="http://schemas.microsoft.com/office/drawing/2014/main" id="{E3D35E06-AD6E-40E9-A2D0-EF0AEC5C1CCB}"/>
               </a:ext>
             </a:extLst>
           </p:cNvPr>
@@ -2902,7 +2902,7 @@
           <p:cNvPr id="8" name="judgment-copy">
             <a:extLst xmlns:a="http://schemas.openxmlformats.org/drawingml/2006/main">
               <a:ext uri="{FF2B5EF4-FFF2-40B4-BE49-F238E27FC236}">
-                <a16:creationId xmlns:a16="http://schemas.microsoft.com/office/drawing/2014/main" id="{F4050492-8BFE-47F1-8075-D1C60F3B00F7}"/>
+                <a16:creationId xmlns:a16="http://schemas.microsoft.com/office/drawing/2014/main" id="{D792C21C-7BCE-4E85-9D53-107016E5CF1E}"/>
               </a:ext>
             </a:extLst>
           </p:cNvPr>
@@ -2964,7 +2964,7 @@
           <p:cNvPr id="9" name="divider">
             <a:extLst xmlns:a="http://schemas.openxmlformats.org/drawingml/2006/main">
               <a:ext uri="{FF2B5EF4-FFF2-40B4-BE49-F238E27FC236}">
-                <a16:creationId xmlns:a16="http://schemas.microsoft.com/office/drawing/2014/main" id="{DD9F4DEA-4CB6-4BDD-9BEC-482A83947052}"/>
+                <a16:creationId xmlns:a16="http://schemas.microsoft.com/office/drawing/2014/main" id="{433B7D72-ED8D-48F2-ABF3-5AFB03E36F28}"/>
               </a:ext>
             </a:extLst>
           </p:cNvPr>
@@ -2995,7 +2995,7 @@
           <p:cNvPr id="10" name="label-Finly-654-215">
             <a:extLst xmlns:a="http://schemas.openxmlformats.org/drawingml/2006/main">
               <a:ext uri="{FF2B5EF4-FFF2-40B4-BE49-F238E27FC236}">
-                <a16:creationId xmlns:a16="http://schemas.microsoft.com/office/drawing/2014/main" id="{AC59237F-693B-4131-9A7D-C2DBB0EDE486}"/>
+                <a16:creationId xmlns:a16="http://schemas.microsoft.com/office/drawing/2014/main" id="{8F3BB22D-FE36-4FB1-A84B-0C4DCD5D654E}"/>
               </a:ext>
             </a:extLst>
           </p:cNvPr>
@@ -3057,7 +3057,7 @@
           <p:cNvPr id="11" name="authority-question">
             <a:extLst xmlns:a="http://schemas.openxmlformats.org/drawingml/2006/main">
               <a:ext uri="{FF2B5EF4-FFF2-40B4-BE49-F238E27FC236}">
-                <a16:creationId xmlns:a16="http://schemas.microsoft.com/office/drawing/2014/main" id="{35B32B44-9023-4ABF-9B1E-7251FE079305}"/>
+                <a16:creationId xmlns:a16="http://schemas.microsoft.com/office/drawing/2014/main" id="{1B7BCB26-B790-4ECB-B06C-1C801CB9CD82}"/>
               </a:ext>
             </a:extLst>
           </p:cNvPr>
@@ -3119,7 +3119,7 @@
           <p:cNvPr id="12" name="authority-copy">
             <a:extLst xmlns:a="http://schemas.openxmlformats.org/drawingml/2006/main">
               <a:ext uri="{FF2B5EF4-FFF2-40B4-BE49-F238E27FC236}">
-                <a16:creationId xmlns:a16="http://schemas.microsoft.com/office/drawing/2014/main" id="{43AE2F26-7587-4C9E-BA57-FC839A56F23F}"/>
+                <a16:creationId xmlns:a16="http://schemas.microsoft.com/office/drawing/2014/main" id="{34158FE7-2D0B-434B-BDD9-7BE3AF722C74}"/>
               </a:ext>
             </a:extLst>
           </p:cNvPr>
@@ -3181,7 +3181,7 @@
           <p:cNvPr id="13" name="core-thesis">
             <a:extLst xmlns:a="http://schemas.openxmlformats.org/drawingml/2006/main">
               <a:ext uri="{FF2B5EF4-FFF2-40B4-BE49-F238E27FC236}">
-                <a16:creationId xmlns:a16="http://schemas.microsoft.com/office/drawing/2014/main" id="{F9F99D60-BCCA-42CC-B60B-B3F44CA01C68}"/>
+                <a16:creationId xmlns:a16="http://schemas.microsoft.com/office/drawing/2014/main" id="{0E003D14-42F9-4F6F-9D35-D06B6E5E4238}"/>
               </a:ext>
             </a:extLst>
           </p:cNvPr>
@@ -3241,7 +3241,7 @@
     </p:spTree>
     <p:extLst>
       <p:ext uri="{BB962C8B-B14F-4D97-AF65-F5344CB8AC3E}">
-        <p14:creationId xmlns:p14="http://schemas.microsoft.com/office/powerpoint/2010/main" val="1309421897"/>
+        <p14:creationId xmlns:p14="http://schemas.microsoft.com/office/powerpoint/2010/main" val="1146338908"/>
       </p:ext>
     </p:extLst>
   </p:cSld>
@@ -3272,7 +3272,7 @@
           <p:cNvPr id="16" name="label-The product-58-32">
             <a:extLst xmlns:a="http://schemas.openxmlformats.org/drawingml/2006/main">
               <a:ext uri="{FF2B5EF4-FFF2-40B4-BE49-F238E27FC236}">
-                <a16:creationId xmlns:a16="http://schemas.microsoft.com/office/drawing/2014/main" id="{44FDA00B-7920-4BEC-BE3E-4D0D90B7509A}"/>
+                <a16:creationId xmlns:a16="http://schemas.microsoft.com/office/drawing/2014/main" id="{21DF212B-9426-4EAC-AF38-BB6EDABA4834}"/>
               </a:ext>
             </a:extLst>
           </p:cNvPr>
@@ -3334,7 +3334,7 @@
           <p:cNvPr id="2" name="slide-title-3">
             <a:extLst xmlns:a="http://schemas.openxmlformats.org/drawingml/2006/main">
               <a:ext uri="{FF2B5EF4-FFF2-40B4-BE49-F238E27FC236}">
-                <a16:creationId xmlns:a16="http://schemas.microsoft.com/office/drawing/2014/main" id="{1288286D-97B2-4595-99AA-38A91EA228A8}"/>
+                <a16:creationId xmlns:a16="http://schemas.microsoft.com/office/drawing/2014/main" id="{640ACDAF-7F29-4E0F-9032-427BEF8697E7}"/>
               </a:ext>
             </a:extLst>
           </p:cNvPr>
@@ -3396,7 +3396,7 @@
           <p:cNvPr id="3" name="">
             <a:extLst xmlns:a="http://schemas.openxmlformats.org/drawingml/2006/main">
               <a:ext uri="{FF2B5EF4-FFF2-40B4-BE49-F238E27FC236}">
-                <a16:creationId xmlns:a16="http://schemas.microsoft.com/office/drawing/2014/main" id="{67FE8993-8E85-464F-831B-8FC8A257F8A0}"/>
+                <a16:creationId xmlns:a16="http://schemas.microsoft.com/office/drawing/2014/main" id="{334400CE-DECB-449E-94B7-44DF78036F3E}"/>
               </a:ext>
             </a:extLst>
           </p:cNvPr>
@@ -3427,7 +3427,7 @@
           <p:cNvPr id="4" name="footer-3">
             <a:extLst xmlns:a="http://schemas.openxmlformats.org/drawingml/2006/main">
               <a:ext uri="{FF2B5EF4-FFF2-40B4-BE49-F238E27FC236}">
-                <a16:creationId xmlns:a16="http://schemas.microsoft.com/office/drawing/2014/main" id="{C9F48B56-1C03-40D1-BAF4-B256661B9F5C}"/>
+                <a16:creationId xmlns:a16="http://schemas.microsoft.com/office/drawing/2014/main" id="{36910DE1-CC24-4C14-A559-5CF032281A32}"/>
               </a:ext>
             </a:extLst>
           </p:cNvPr>
@@ -3489,7 +3489,7 @@
           <p:cNvPr id="5" name="page-3">
             <a:extLst xmlns:a="http://schemas.openxmlformats.org/drawingml/2006/main">
               <a:ext uri="{FF2B5EF4-FFF2-40B4-BE49-F238E27FC236}">
-                <a16:creationId xmlns:a16="http://schemas.microsoft.com/office/drawing/2014/main" id="{44301714-D9F5-417A-8ED3-355E25C3E492}"/>
+                <a16:creationId xmlns:a16="http://schemas.microsoft.com/office/drawing/2014/main" id="{06BB7286-6D5E-477C-9C8F-459E813273AE}"/>
               </a:ext>
             </a:extLst>
           </p:cNvPr>
@@ -3551,7 +3551,7 @@
           <p:cNvPr id="6" name="product-frame">
             <a:extLst xmlns:a="http://schemas.openxmlformats.org/drawingml/2006/main">
               <a:ext uri="{FF2B5EF4-FFF2-40B4-BE49-F238E27FC236}">
-                <a16:creationId xmlns:a16="http://schemas.microsoft.com/office/drawing/2014/main" id="{192BCE02-BEB8-458A-9E0C-122CAD85E3DF}"/>
+                <a16:creationId xmlns:a16="http://schemas.microsoft.com/office/drawing/2014/main" id="{AD6F12C5-BA9F-4C8E-9A78-A2D9F34F477D}"/>
               </a:ext>
             </a:extLst>
           </p:cNvPr>
@@ -3588,7 +3588,7 @@
           <p:nvPr/>
         </p:nvPicPr>
         <p:blipFill>
-          <a:blip xmlns:r="http://schemas.openxmlformats.org/officeDocument/2006/relationships" xmlns:a="http://schemas.openxmlformats.org/drawingml/2006/main" r:embed="Ref87124664ea4854"/>
+          <a:blip xmlns:r="http://schemas.openxmlformats.org/officeDocument/2006/relationships" xmlns:a="http://schemas.openxmlformats.org/drawingml/2006/main" r:embed="Rf0cfd92d5216419f"/>
           <a:srcRect xmlns:a="http://schemas.openxmlformats.org/drawingml/2006/main" l="0" t="9897" r="0" b="9897"/>
           <a:stretch xmlns:a="http://schemas.openxmlformats.org/drawingml/2006/main">
             <a:fillRect l="0" t="0" r="0" b="0"/>
@@ -3609,7 +3609,7 @@
           <p:cNvPr id="8" name="label-Visible on the site-904-214">
             <a:extLst xmlns:a="http://schemas.openxmlformats.org/drawingml/2006/main">
               <a:ext uri="{FF2B5EF4-FFF2-40B4-BE49-F238E27FC236}">
-                <a16:creationId xmlns:a16="http://schemas.microsoft.com/office/drawing/2014/main" id="{77A18164-038E-424D-8F89-B8BD12504803}"/>
+                <a16:creationId xmlns:a16="http://schemas.microsoft.com/office/drawing/2014/main" id="{F6AB06B1-682C-48E8-A8AF-E5E1AB327984}"/>
               </a:ext>
             </a:extLst>
           </p:cNvPr>
@@ -3671,7 +3671,7 @@
           <p:cNvPr id="9" name="metric-next-open · 5 bp per leg">
             <a:extLst xmlns:a="http://schemas.openxmlformats.org/drawingml/2006/main">
               <a:ext uri="{FF2B5EF4-FFF2-40B4-BE49-F238E27FC236}">
-                <a16:creationId xmlns:a16="http://schemas.microsoft.com/office/drawing/2014/main" id="{DFDA6642-EB06-4717-851F-2E2FA7556FB4}"/>
+                <a16:creationId xmlns:a16="http://schemas.microsoft.com/office/drawing/2014/main" id="{43C106F4-DBC2-4152-8762-7035B6BD689D}"/>
               </a:ext>
             </a:extLst>
           </p:cNvPr>
@@ -3733,7 +3733,7 @@
           <p:cNvPr id="10" name="metric-caption-next-open · 5 bp per leg">
             <a:extLst xmlns:a="http://schemas.openxmlformats.org/drawingml/2006/main">
               <a:ext uri="{FF2B5EF4-FFF2-40B4-BE49-F238E27FC236}">
-                <a16:creationId xmlns:a16="http://schemas.microsoft.com/office/drawing/2014/main" id="{22E055AB-CC38-4C75-A7CE-5B8B059C0319}"/>
+                <a16:creationId xmlns:a16="http://schemas.microsoft.com/office/drawing/2014/main" id="{948EBC0F-C929-4FFA-83B0-4BD2E82F59F0}"/>
               </a:ext>
             </a:extLst>
           </p:cNvPr>
@@ -3795,7 +3795,7 @@
           <p:cNvPr id="11" name="metric-consumed sessions">
             <a:extLst xmlns:a="http://schemas.openxmlformats.org/drawingml/2006/main">
               <a:ext uri="{FF2B5EF4-FFF2-40B4-BE49-F238E27FC236}">
-                <a16:creationId xmlns:a16="http://schemas.microsoft.com/office/drawing/2014/main" id="{644F6ED6-DAC4-4D2B-940B-D3B1F91F1E34}"/>
+                <a16:creationId xmlns:a16="http://schemas.microsoft.com/office/drawing/2014/main" id="{C1C5A3EF-9B08-41FB-A4DB-87F77267F30E}"/>
               </a:ext>
             </a:extLst>
           </p:cNvPr>
@@ -3857,7 +3857,7 @@
           <p:cNvPr id="12" name="metric-caption-consumed sessions">
             <a:extLst xmlns:a="http://schemas.openxmlformats.org/drawingml/2006/main">
               <a:ext uri="{FF2B5EF4-FFF2-40B4-BE49-F238E27FC236}">
-                <a16:creationId xmlns:a16="http://schemas.microsoft.com/office/drawing/2014/main" id="{D08E29DF-77AE-4A10-BCED-92B78A085A29}"/>
+                <a16:creationId xmlns:a16="http://schemas.microsoft.com/office/drawing/2014/main" id="{8B17000F-D172-473D-9522-EC2CDA28EF7D}"/>
               </a:ext>
             </a:extLst>
           </p:cNvPr>
@@ -3919,7 +3919,7 @@
           <p:cNvPr id="13" name="metric-at 25 bp per leg">
             <a:extLst xmlns:a="http://schemas.openxmlformats.org/drawingml/2006/main">
               <a:ext uri="{FF2B5EF4-FFF2-40B4-BE49-F238E27FC236}">
-                <a16:creationId xmlns:a16="http://schemas.microsoft.com/office/drawing/2014/main" id="{1928C25E-B48B-4785-8A72-C831EB68A638}"/>
+                <a16:creationId xmlns:a16="http://schemas.microsoft.com/office/drawing/2014/main" id="{91443F7C-8DBD-4B48-B4C6-18A6494D9F41}"/>
               </a:ext>
             </a:extLst>
           </p:cNvPr>
@@ -3981,7 +3981,7 @@
           <p:cNvPr id="14" name="metric-caption-at 25 bp per leg">
             <a:extLst xmlns:a="http://schemas.openxmlformats.org/drawingml/2006/main">
               <a:ext uri="{FF2B5EF4-FFF2-40B4-BE49-F238E27FC236}">
-                <a16:creationId xmlns:a16="http://schemas.microsoft.com/office/drawing/2014/main" id="{A604DA66-23E6-424A-BD6F-6BA28DF0CA7C}"/>
+                <a16:creationId xmlns:a16="http://schemas.microsoft.com/office/drawing/2014/main" id="{0DC14BDB-8EA2-47A5-9701-5A63D6A9191E}"/>
               </a:ext>
             </a:extLst>
           </p:cNvPr>
@@ -4043,7 +4043,7 @@
           <p:cNvPr id="15" name="product-boundary">
             <a:extLst xmlns:a="http://schemas.openxmlformats.org/drawingml/2006/main">
               <a:ext uri="{FF2B5EF4-FFF2-40B4-BE49-F238E27FC236}">
-                <a16:creationId xmlns:a16="http://schemas.microsoft.com/office/drawing/2014/main" id="{D86FD2F6-6C7C-4C16-9AA1-F3801029BB87}"/>
+                <a16:creationId xmlns:a16="http://schemas.microsoft.com/office/drawing/2014/main" id="{8C644FD5-C4ED-4870-BD5C-48CD053E277F}"/>
               </a:ext>
             </a:extLst>
           </p:cNvPr>
@@ -4103,7 +4103,7 @@
     </p:spTree>
     <p:extLst>
       <p:ext uri="{BB962C8B-B14F-4D97-AF65-F5344CB8AC3E}">
-        <p14:creationId xmlns:p14="http://schemas.microsoft.com/office/powerpoint/2010/main" val="1702942921"/>
+        <p14:creationId xmlns:p14="http://schemas.microsoft.com/office/powerpoint/2010/main" val="811326766"/>
       </p:ext>
     </p:extLst>
   </p:cSld>
@@ -4134,7 +4134,7 @@
           <p:cNvPr id="49" name="label-Controlled delegation-58-32">
             <a:extLst xmlns:a="http://schemas.openxmlformats.org/drawingml/2006/main">
               <a:ext uri="{FF2B5EF4-FFF2-40B4-BE49-F238E27FC236}">
-                <a16:creationId xmlns:a16="http://schemas.microsoft.com/office/drawing/2014/main" id="{C69B5FEE-103B-4E52-A747-3C8227ED5771}"/>
+                <a16:creationId xmlns:a16="http://schemas.microsoft.com/office/drawing/2014/main" id="{4BC9A4DF-F985-41AE-A3E6-DDBC1A3314A1}"/>
               </a:ext>
             </a:extLst>
           </p:cNvPr>
@@ -4196,7 +4196,7 @@
           <p:cNvPr id="2" name="slide-title-4">
             <a:extLst xmlns:a="http://schemas.openxmlformats.org/drawingml/2006/main">
               <a:ext uri="{FF2B5EF4-FFF2-40B4-BE49-F238E27FC236}">
-                <a16:creationId xmlns:a16="http://schemas.microsoft.com/office/drawing/2014/main" id="{9956BD81-863E-4A57-BAE5-3FDB8014F3AC}"/>
+                <a16:creationId xmlns:a16="http://schemas.microsoft.com/office/drawing/2014/main" id="{B98CD0C5-7E10-48F0-8298-1C79F41D9A12}"/>
               </a:ext>
             </a:extLst>
           </p:cNvPr>
@@ -4258,7 +4258,7 @@
           <p:cNvPr id="3" name="">
             <a:extLst xmlns:a="http://schemas.openxmlformats.org/drawingml/2006/main">
               <a:ext uri="{FF2B5EF4-FFF2-40B4-BE49-F238E27FC236}">
-                <a16:creationId xmlns:a16="http://schemas.microsoft.com/office/drawing/2014/main" id="{4D5CFCC3-DED1-4D63-9090-D7ED784EE29D}"/>
+                <a16:creationId xmlns:a16="http://schemas.microsoft.com/office/drawing/2014/main" id="{6C2C655D-1B42-47E1-AAC4-5203CA797467}"/>
               </a:ext>
             </a:extLst>
           </p:cNvPr>
@@ -4289,7 +4289,7 @@
           <p:cNvPr id="4" name="footer-4">
             <a:extLst xmlns:a="http://schemas.openxmlformats.org/drawingml/2006/main">
               <a:ext uri="{FF2B5EF4-FFF2-40B4-BE49-F238E27FC236}">
-                <a16:creationId xmlns:a16="http://schemas.microsoft.com/office/drawing/2014/main" id="{649EDE17-3CE4-49A8-A919-218DFA9F9317}"/>
+                <a16:creationId xmlns:a16="http://schemas.microsoft.com/office/drawing/2014/main" id="{D56BCC69-8EF8-4F20-8342-3813CD351F2D}"/>
               </a:ext>
             </a:extLst>
           </p:cNvPr>
@@ -4351,7 +4351,7 @@
           <p:cNvPr id="5" name="page-4">
             <a:extLst xmlns:a="http://schemas.openxmlformats.org/drawingml/2006/main">
               <a:ext uri="{FF2B5EF4-FFF2-40B4-BE49-F238E27FC236}">
-                <a16:creationId xmlns:a16="http://schemas.microsoft.com/office/drawing/2014/main" id="{4E10B1CA-1DF7-4615-9FB4-6CFC6F2F913F}"/>
+                <a16:creationId xmlns:a16="http://schemas.microsoft.com/office/drawing/2014/main" id="{41265285-EB2D-4C8E-A336-FB08A32A4982}"/>
               </a:ext>
             </a:extLst>
           </p:cNvPr>
@@ -4413,7 +4413,7 @@
           <p:cNvPr id="6" name="label-INPUT-58-218">
             <a:extLst xmlns:a="http://schemas.openxmlformats.org/drawingml/2006/main">
               <a:ext uri="{FF2B5EF4-FFF2-40B4-BE49-F238E27FC236}">
-                <a16:creationId xmlns:a16="http://schemas.microsoft.com/office/drawing/2014/main" id="{C3B1292D-62C3-4ABF-8099-F89656ED84A4}"/>
+                <a16:creationId xmlns:a16="http://schemas.microsoft.com/office/drawing/2014/main" id="{DED89C55-F40C-4B52-A35A-DD03C9625220}"/>
               </a:ext>
             </a:extLst>
           </p:cNvPr>
@@ -4475,7 +4475,7 @@
           <p:cNvPr id="7" name="stage-number-0">
             <a:extLst xmlns:a="http://schemas.openxmlformats.org/drawingml/2006/main">
               <a:ext uri="{FF2B5EF4-FFF2-40B4-BE49-F238E27FC236}">
-                <a16:creationId xmlns:a16="http://schemas.microsoft.com/office/drawing/2014/main" id="{0C7867FD-B822-4AAA-B8EB-0B79A6526DAB}"/>
+                <a16:creationId xmlns:a16="http://schemas.microsoft.com/office/drawing/2014/main" id="{CF96F154-6B1A-42EA-888E-DDD7BD519B24}"/>
               </a:ext>
             </a:extLst>
           </p:cNvPr>
@@ -4537,7 +4537,7 @@
           <p:cNvPr id="8" name="stage-title-0">
             <a:extLst xmlns:a="http://schemas.openxmlformats.org/drawingml/2006/main">
               <a:ext uri="{FF2B5EF4-FFF2-40B4-BE49-F238E27FC236}">
-                <a16:creationId xmlns:a16="http://schemas.microsoft.com/office/drawing/2014/main" id="{825516A9-6F65-4507-91B9-BC22B8D65CA1}"/>
+                <a16:creationId xmlns:a16="http://schemas.microsoft.com/office/drawing/2014/main" id="{57A9596F-5B2D-4D8B-A7B0-64B1D4AB436B}"/>
               </a:ext>
             </a:extLst>
           </p:cNvPr>
@@ -4599,7 +4599,7 @@
           <p:cNvPr id="9" name="">
             <a:extLst xmlns:a="http://schemas.openxmlformats.org/drawingml/2006/main">
               <a:ext uri="{FF2B5EF4-FFF2-40B4-BE49-F238E27FC236}">
-                <a16:creationId xmlns:a16="http://schemas.microsoft.com/office/drawing/2014/main" id="{FBFEF3B6-D932-4F82-BCEE-C65B6144C3B3}"/>
+                <a16:creationId xmlns:a16="http://schemas.microsoft.com/office/drawing/2014/main" id="{7232FC33-B45F-4FAE-BA8E-B15CD9B8D373}"/>
               </a:ext>
             </a:extLst>
           </p:cNvPr>
@@ -4630,7 +4630,7 @@
           <p:cNvPr id="10" name="stage-copy-0">
             <a:extLst xmlns:a="http://schemas.openxmlformats.org/drawingml/2006/main">
               <a:ext uri="{FF2B5EF4-FFF2-40B4-BE49-F238E27FC236}">
-                <a16:creationId xmlns:a16="http://schemas.microsoft.com/office/drawing/2014/main" id="{AA4D11CF-F1F4-4B3F-A5C7-CC49F0A5BE7E}"/>
+                <a16:creationId xmlns:a16="http://schemas.microsoft.com/office/drawing/2014/main" id="{54AD01EA-87B8-44F3-B1D7-138C86AEA907}"/>
               </a:ext>
             </a:extLst>
           </p:cNvPr>
@@ -4692,7 +4692,7 @@
           <p:cNvPr id="11" name="chevron-1">
             <a:extLst xmlns:a="http://schemas.openxmlformats.org/drawingml/2006/main">
               <a:ext uri="{FF2B5EF4-FFF2-40B4-BE49-F238E27FC236}">
-                <a16:creationId xmlns:a16="http://schemas.microsoft.com/office/drawing/2014/main" id="{D6A0EAFD-939A-4E0F-A6C0-D8C961D39E2E}"/>
+                <a16:creationId xmlns:a16="http://schemas.microsoft.com/office/drawing/2014/main" id="{F7DB0A09-FFF7-4A1A-9F20-475DEFFF0121}"/>
               </a:ext>
             </a:extLst>
           </p:cNvPr>
@@ -4754,7 +4754,7 @@
           <p:cNvPr id="12" name="label-MODEL-253-218">
             <a:extLst xmlns:a="http://schemas.openxmlformats.org/drawingml/2006/main">
               <a:ext uri="{FF2B5EF4-FFF2-40B4-BE49-F238E27FC236}">
-                <a16:creationId xmlns:a16="http://schemas.microsoft.com/office/drawing/2014/main" id="{19F3ACF3-3A3F-471D-A67D-BF37AFB74442}"/>
+                <a16:creationId xmlns:a16="http://schemas.microsoft.com/office/drawing/2014/main" id="{1ED7DA5B-93C8-435B-86ED-FBFFE78B72E8}"/>
               </a:ext>
             </a:extLst>
           </p:cNvPr>
@@ -4816,7 +4816,7 @@
           <p:cNvPr id="13" name="stage-number-1">
             <a:extLst xmlns:a="http://schemas.openxmlformats.org/drawingml/2006/main">
               <a:ext uri="{FF2B5EF4-FFF2-40B4-BE49-F238E27FC236}">
-                <a16:creationId xmlns:a16="http://schemas.microsoft.com/office/drawing/2014/main" id="{33DB705D-C5F7-4455-B458-91282F7342FD}"/>
+                <a16:creationId xmlns:a16="http://schemas.microsoft.com/office/drawing/2014/main" id="{0AC187DA-8354-4417-B330-5626C7A9B2E6}"/>
               </a:ext>
             </a:extLst>
           </p:cNvPr>
@@ -4878,7 +4878,7 @@
           <p:cNvPr id="14" name="stage-title-1">
             <a:extLst xmlns:a="http://schemas.openxmlformats.org/drawingml/2006/main">
               <a:ext uri="{FF2B5EF4-FFF2-40B4-BE49-F238E27FC236}">
-                <a16:creationId xmlns:a16="http://schemas.microsoft.com/office/drawing/2014/main" id="{670D0729-6363-451A-BF4C-569251081BE8}"/>
+                <a16:creationId xmlns:a16="http://schemas.microsoft.com/office/drawing/2014/main" id="{AD90F80F-A9EE-4246-944E-4500BBDB1F73}"/>
               </a:ext>
             </a:extLst>
           </p:cNvPr>
@@ -4940,7 +4940,7 @@
           <p:cNvPr id="15" name="">
             <a:extLst xmlns:a="http://schemas.openxmlformats.org/drawingml/2006/main">
               <a:ext uri="{FF2B5EF4-FFF2-40B4-BE49-F238E27FC236}">
-                <a16:creationId xmlns:a16="http://schemas.microsoft.com/office/drawing/2014/main" id="{EF61D6C2-6839-45B0-AC28-90D250EF4734}"/>
+                <a16:creationId xmlns:a16="http://schemas.microsoft.com/office/drawing/2014/main" id="{FF72A6EE-24BA-4174-957D-69487AB25907}"/>
               </a:ext>
             </a:extLst>
           </p:cNvPr>
@@ -4971,7 +4971,7 @@
           <p:cNvPr id="16" name="stage-copy-1">
             <a:extLst xmlns:a="http://schemas.openxmlformats.org/drawingml/2006/main">
               <a:ext uri="{FF2B5EF4-FFF2-40B4-BE49-F238E27FC236}">
-                <a16:creationId xmlns:a16="http://schemas.microsoft.com/office/drawing/2014/main" id="{E0AB669A-6ED0-4E83-B51E-91E6A5619728}"/>
+                <a16:creationId xmlns:a16="http://schemas.microsoft.com/office/drawing/2014/main" id="{34EA93AE-AA48-4F31-BD90-938584DEE49F}"/>
               </a:ext>
             </a:extLst>
           </p:cNvPr>
@@ -5033,7 +5033,7 @@
           <p:cNvPr id="17" name="chevron-2">
             <a:extLst xmlns:a="http://schemas.openxmlformats.org/drawingml/2006/main">
               <a:ext uri="{FF2B5EF4-FFF2-40B4-BE49-F238E27FC236}">
-                <a16:creationId xmlns:a16="http://schemas.microsoft.com/office/drawing/2014/main" id="{68E23F1B-83AF-44AB-8B81-A66482DD2E21}"/>
+                <a16:creationId xmlns:a16="http://schemas.microsoft.com/office/drawing/2014/main" id="{342464B6-AD68-4B34-9AA0-EA9CB5CE7AEF}"/>
               </a:ext>
             </a:extLst>
           </p:cNvPr>
@@ -5095,7 +5095,7 @@
           <p:cNvPr id="18" name="label-CODE-448-218">
             <a:extLst xmlns:a="http://schemas.openxmlformats.org/drawingml/2006/main">
               <a:ext uri="{FF2B5EF4-FFF2-40B4-BE49-F238E27FC236}">
-                <a16:creationId xmlns:a16="http://schemas.microsoft.com/office/drawing/2014/main" id="{521BAFE3-EE8F-4CC8-BF53-EBAF4B12D923}"/>
+                <a16:creationId xmlns:a16="http://schemas.microsoft.com/office/drawing/2014/main" id="{F4670263-D6C2-4EE8-968A-D76FDABCCD0A}"/>
               </a:ext>
             </a:extLst>
           </p:cNvPr>
@@ -5157,7 +5157,7 @@
           <p:cNvPr id="19" name="stage-number-2">
             <a:extLst xmlns:a="http://schemas.openxmlformats.org/drawingml/2006/main">
               <a:ext uri="{FF2B5EF4-FFF2-40B4-BE49-F238E27FC236}">
-                <a16:creationId xmlns:a16="http://schemas.microsoft.com/office/drawing/2014/main" id="{F54C29B1-8150-4662-88D8-0C39EE6115E8}"/>
+                <a16:creationId xmlns:a16="http://schemas.microsoft.com/office/drawing/2014/main" id="{0B9CE17A-54BE-477B-ACBA-0D0471F757EE}"/>
               </a:ext>
             </a:extLst>
           </p:cNvPr>
@@ -5219,7 +5219,7 @@
           <p:cNvPr id="20" name="stage-title-2">
             <a:extLst xmlns:a="http://schemas.openxmlformats.org/drawingml/2006/main">
               <a:ext uri="{FF2B5EF4-FFF2-40B4-BE49-F238E27FC236}">
-                <a16:creationId xmlns:a16="http://schemas.microsoft.com/office/drawing/2014/main" id="{17F67FB3-4F25-4C00-AEDD-116B746910D4}"/>
+                <a16:creationId xmlns:a16="http://schemas.microsoft.com/office/drawing/2014/main" id="{ED4EF59E-75A7-416D-AB08-5A5442930947}"/>
               </a:ext>
             </a:extLst>
           </p:cNvPr>
@@ -5281,7 +5281,7 @@
           <p:cNvPr id="21" name="">
             <a:extLst xmlns:a="http://schemas.openxmlformats.org/drawingml/2006/main">
               <a:ext uri="{FF2B5EF4-FFF2-40B4-BE49-F238E27FC236}">
-                <a16:creationId xmlns:a16="http://schemas.microsoft.com/office/drawing/2014/main" id="{BAE42D90-C303-4B53-B8DE-0D04F779E976}"/>
+                <a16:creationId xmlns:a16="http://schemas.microsoft.com/office/drawing/2014/main" id="{F5FE25B9-148F-4EF5-BAAE-FC7B3A5D5FE7}"/>
               </a:ext>
             </a:extLst>
           </p:cNvPr>
@@ -5312,7 +5312,7 @@
           <p:cNvPr id="22" name="stage-copy-2">
             <a:extLst xmlns:a="http://schemas.openxmlformats.org/drawingml/2006/main">
               <a:ext uri="{FF2B5EF4-FFF2-40B4-BE49-F238E27FC236}">
-                <a16:creationId xmlns:a16="http://schemas.microsoft.com/office/drawing/2014/main" id="{783F9358-C42F-4891-AE75-9A051EC9238A}"/>
+                <a16:creationId xmlns:a16="http://schemas.microsoft.com/office/drawing/2014/main" id="{755C404D-273A-4498-BC41-1E6F7BEB18C0}"/>
               </a:ext>
             </a:extLst>
           </p:cNvPr>
@@ -5374,7 +5374,7 @@
           <p:cNvPr id="23" name="chevron-3">
             <a:extLst xmlns:a="http://schemas.openxmlformats.org/drawingml/2006/main">
               <a:ext uri="{FF2B5EF4-FFF2-40B4-BE49-F238E27FC236}">
-                <a16:creationId xmlns:a16="http://schemas.microsoft.com/office/drawing/2014/main" id="{AF99E6ED-0395-4BEA-86BE-A0F379378953}"/>
+                <a16:creationId xmlns:a16="http://schemas.microsoft.com/office/drawing/2014/main" id="{B1F5D8ED-6C2E-44C8-B89F-2DF43E69C5B2}"/>
               </a:ext>
             </a:extLst>
           </p:cNvPr>
@@ -5436,7 +5436,7 @@
           <p:cNvPr id="24" name="label-CODE-643-218">
             <a:extLst xmlns:a="http://schemas.openxmlformats.org/drawingml/2006/main">
               <a:ext uri="{FF2B5EF4-FFF2-40B4-BE49-F238E27FC236}">
-                <a16:creationId xmlns:a16="http://schemas.microsoft.com/office/drawing/2014/main" id="{65E45F6A-AF0B-4F56-A716-C989677750A1}"/>
+                <a16:creationId xmlns:a16="http://schemas.microsoft.com/office/drawing/2014/main" id="{F66A42CD-911C-4E07-A308-2AF8DB587A31}"/>
               </a:ext>
             </a:extLst>
           </p:cNvPr>
@@ -5498,7 +5498,7 @@
           <p:cNvPr id="25" name="stage-number-3">
             <a:extLst xmlns:a="http://schemas.openxmlformats.org/drawingml/2006/main">
               <a:ext uri="{FF2B5EF4-FFF2-40B4-BE49-F238E27FC236}">
-                <a16:creationId xmlns:a16="http://schemas.microsoft.com/office/drawing/2014/main" id="{4AE73AD8-5761-4E29-84AA-6FA0FC137355}"/>
+                <a16:creationId xmlns:a16="http://schemas.microsoft.com/office/drawing/2014/main" id="{E55D988C-85E6-4AF9-9415-881F494D0C7F}"/>
               </a:ext>
             </a:extLst>
           </p:cNvPr>
@@ -5560,7 +5560,7 @@
           <p:cNvPr id="26" name="stage-title-3">
             <a:extLst xmlns:a="http://schemas.openxmlformats.org/drawingml/2006/main">
               <a:ext uri="{FF2B5EF4-FFF2-40B4-BE49-F238E27FC236}">
-                <a16:creationId xmlns:a16="http://schemas.microsoft.com/office/drawing/2014/main" id="{6F897DA1-5C69-43D4-94BC-BA7E01DEEF91}"/>
+                <a16:creationId xmlns:a16="http://schemas.microsoft.com/office/drawing/2014/main" id="{BD103949-4A08-47D2-A402-9598BDD3E7CD}"/>
               </a:ext>
             </a:extLst>
           </p:cNvPr>
@@ -5622,7 +5622,7 @@
           <p:cNvPr id="27" name="">
             <a:extLst xmlns:a="http://schemas.openxmlformats.org/drawingml/2006/main">
               <a:ext uri="{FF2B5EF4-FFF2-40B4-BE49-F238E27FC236}">
-                <a16:creationId xmlns:a16="http://schemas.microsoft.com/office/drawing/2014/main" id="{4056F882-EDDE-4F8A-A1A6-A0EBD2EC4EC4}"/>
+                <a16:creationId xmlns:a16="http://schemas.microsoft.com/office/drawing/2014/main" id="{D75E805D-7CE4-4CCD-83AD-9B2C2E0F9770}"/>
               </a:ext>
             </a:extLst>
           </p:cNvPr>
@@ -5653,7 +5653,7 @@
           <p:cNvPr id="28" name="stage-copy-3">
             <a:extLst xmlns:a="http://schemas.openxmlformats.org/drawingml/2006/main">
               <a:ext uri="{FF2B5EF4-FFF2-40B4-BE49-F238E27FC236}">
-                <a16:creationId xmlns:a16="http://schemas.microsoft.com/office/drawing/2014/main" id="{8FFFCB5D-0D9D-403D-8AC7-E5750EE7E74C}"/>
+                <a16:creationId xmlns:a16="http://schemas.microsoft.com/office/drawing/2014/main" id="{71F69B2A-BF19-4019-9E48-20437BECB54F}"/>
               </a:ext>
             </a:extLst>
           </p:cNvPr>
@@ -5715,7 +5715,7 @@
           <p:cNvPr id="29" name="chevron-4">
             <a:extLst xmlns:a="http://schemas.openxmlformats.org/drawingml/2006/main">
               <a:ext uri="{FF2B5EF4-FFF2-40B4-BE49-F238E27FC236}">
-                <a16:creationId xmlns:a16="http://schemas.microsoft.com/office/drawing/2014/main" id="{09DC43B8-2D65-4B77-90E2-2F53ED36ED8C}"/>
+                <a16:creationId xmlns:a16="http://schemas.microsoft.com/office/drawing/2014/main" id="{9B56AFD5-AD83-4E0C-8B56-BE8A0F6573BC}"/>
               </a:ext>
             </a:extLst>
           </p:cNvPr>
@@ -5777,7 +5777,7 @@
           <p:cNvPr id="30" name="label-CODE-838-218">
             <a:extLst xmlns:a="http://schemas.openxmlformats.org/drawingml/2006/main">
               <a:ext uri="{FF2B5EF4-FFF2-40B4-BE49-F238E27FC236}">
-                <a16:creationId xmlns:a16="http://schemas.microsoft.com/office/drawing/2014/main" id="{AF720318-CE17-4BED-9B2B-CE9E7A346852}"/>
+                <a16:creationId xmlns:a16="http://schemas.microsoft.com/office/drawing/2014/main" id="{DC1FC783-3035-4E1E-8F45-00A61CF4254D}"/>
               </a:ext>
             </a:extLst>
           </p:cNvPr>
@@ -5839,7 +5839,7 @@
           <p:cNvPr id="31" name="stage-number-4">
             <a:extLst xmlns:a="http://schemas.openxmlformats.org/drawingml/2006/main">
               <a:ext uri="{FF2B5EF4-FFF2-40B4-BE49-F238E27FC236}">
-                <a16:creationId xmlns:a16="http://schemas.microsoft.com/office/drawing/2014/main" id="{75C019EA-13F1-4FFE-A9B1-2C01AFA35E4B}"/>
+                <a16:creationId xmlns:a16="http://schemas.microsoft.com/office/drawing/2014/main" id="{C3027CCF-F734-4438-A49D-A4B00C7F1682}"/>
               </a:ext>
             </a:extLst>
           </p:cNvPr>
@@ -5901,7 +5901,7 @@
           <p:cNvPr id="32" name="stage-title-4">
             <a:extLst xmlns:a="http://schemas.openxmlformats.org/drawingml/2006/main">
               <a:ext uri="{FF2B5EF4-FFF2-40B4-BE49-F238E27FC236}">
-                <a16:creationId xmlns:a16="http://schemas.microsoft.com/office/drawing/2014/main" id="{8514E1EB-00D1-4EE3-8DAC-DA55D7C8C717}"/>
+                <a16:creationId xmlns:a16="http://schemas.microsoft.com/office/drawing/2014/main" id="{B569BFBD-934B-42DE-A472-A13E2378300E}"/>
               </a:ext>
             </a:extLst>
           </p:cNvPr>
@@ -5963,7 +5963,7 @@
           <p:cNvPr id="33" name="">
             <a:extLst xmlns:a="http://schemas.openxmlformats.org/drawingml/2006/main">
               <a:ext uri="{FF2B5EF4-FFF2-40B4-BE49-F238E27FC236}">
-                <a16:creationId xmlns:a16="http://schemas.microsoft.com/office/drawing/2014/main" id="{67D88BAF-AA19-4872-A4A0-626F9A3E1DE9}"/>
+                <a16:creationId xmlns:a16="http://schemas.microsoft.com/office/drawing/2014/main" id="{F5E9F60D-70AF-4719-BDCD-F5A94EA4A6D7}"/>
               </a:ext>
             </a:extLst>
           </p:cNvPr>
@@ -5994,7 +5994,7 @@
           <p:cNvPr id="34" name="stage-copy-4">
             <a:extLst xmlns:a="http://schemas.openxmlformats.org/drawingml/2006/main">
               <a:ext uri="{FF2B5EF4-FFF2-40B4-BE49-F238E27FC236}">
-                <a16:creationId xmlns:a16="http://schemas.microsoft.com/office/drawing/2014/main" id="{E4E5192E-FD17-4AC7-8A2A-AEA7537150E4}"/>
+                <a16:creationId xmlns:a16="http://schemas.microsoft.com/office/drawing/2014/main" id="{4206C489-D47C-4B1C-8652-2747E3A7836D}"/>
               </a:ext>
             </a:extLst>
           </p:cNvPr>
@@ -6056,7 +6056,7 @@
           <p:cNvPr id="35" name="chevron-5">
             <a:extLst xmlns:a="http://schemas.openxmlformats.org/drawingml/2006/main">
               <a:ext uri="{FF2B5EF4-FFF2-40B4-BE49-F238E27FC236}">
-                <a16:creationId xmlns:a16="http://schemas.microsoft.com/office/drawing/2014/main" id="{440A291D-5934-40FE-A16F-E4D42BC370A2}"/>
+                <a16:creationId xmlns:a16="http://schemas.microsoft.com/office/drawing/2014/main" id="{331B85BC-D874-4EDC-849B-936A4C305390}"/>
               </a:ext>
             </a:extLst>
           </p:cNvPr>
@@ -6118,7 +6118,7 @@
           <p:cNvPr id="36" name="label-GATE-1033-218">
             <a:extLst xmlns:a="http://schemas.openxmlformats.org/drawingml/2006/main">
               <a:ext uri="{FF2B5EF4-FFF2-40B4-BE49-F238E27FC236}">
-                <a16:creationId xmlns:a16="http://schemas.microsoft.com/office/drawing/2014/main" id="{D70443EA-9E64-428B-8058-9128A3CEA70F}"/>
+                <a16:creationId xmlns:a16="http://schemas.microsoft.com/office/drawing/2014/main" id="{4C1137DB-126D-4F04-952C-287137860290}"/>
               </a:ext>
             </a:extLst>
           </p:cNvPr>
@@ -6180,7 +6180,7 @@
           <p:cNvPr id="37" name="stage-number-5">
             <a:extLst xmlns:a="http://schemas.openxmlformats.org/drawingml/2006/main">
               <a:ext uri="{FF2B5EF4-FFF2-40B4-BE49-F238E27FC236}">
-                <a16:creationId xmlns:a16="http://schemas.microsoft.com/office/drawing/2014/main" id="{094D5670-DF99-42B1-BDE4-377D43381709}"/>
+                <a16:creationId xmlns:a16="http://schemas.microsoft.com/office/drawing/2014/main" id="{6C7D2476-922B-4454-872C-1615365C622A}"/>
               </a:ext>
             </a:extLst>
           </p:cNvPr>
@@ -6242,7 +6242,7 @@
           <p:cNvPr id="38" name="stage-title-5">
             <a:extLst xmlns:a="http://schemas.openxmlformats.org/drawingml/2006/main">
               <a:ext uri="{FF2B5EF4-FFF2-40B4-BE49-F238E27FC236}">
-                <a16:creationId xmlns:a16="http://schemas.microsoft.com/office/drawing/2014/main" id="{EC3C18D2-5829-4FD1-929D-0C08D780FA89}"/>
+                <a16:creationId xmlns:a16="http://schemas.microsoft.com/office/drawing/2014/main" id="{AC5FCCCB-A801-454B-BD09-DC3CD8F4704A}"/>
               </a:ext>
             </a:extLst>
           </p:cNvPr>
@@ -6304,7 +6304,7 @@
           <p:cNvPr id="39" name="">
             <a:extLst xmlns:a="http://schemas.openxmlformats.org/drawingml/2006/main">
               <a:ext uri="{FF2B5EF4-FFF2-40B4-BE49-F238E27FC236}">
-                <a16:creationId xmlns:a16="http://schemas.microsoft.com/office/drawing/2014/main" id="{0E32B29D-2F7D-4064-90EF-8E294AFDB814}"/>
+                <a16:creationId xmlns:a16="http://schemas.microsoft.com/office/drawing/2014/main" id="{9B600F38-CD89-43AF-A505-7A5A7B3C20F8}"/>
               </a:ext>
             </a:extLst>
           </p:cNvPr>
@@ -6335,7 +6335,7 @@
           <p:cNvPr id="40" name="stage-copy-5">
             <a:extLst xmlns:a="http://schemas.openxmlformats.org/drawingml/2006/main">
               <a:ext uri="{FF2B5EF4-FFF2-40B4-BE49-F238E27FC236}">
-                <a16:creationId xmlns:a16="http://schemas.microsoft.com/office/drawing/2014/main" id="{40098048-3FBF-4DB3-929C-EE302E1EB1F8}"/>
+                <a16:creationId xmlns:a16="http://schemas.microsoft.com/office/drawing/2014/main" id="{0ABD450B-FCAA-42B4-9031-3749CF53A4CD}"/>
               </a:ext>
             </a:extLst>
           </p:cNvPr>
@@ -6397,7 +6397,7 @@
           <p:cNvPr id="41" name="">
             <a:extLst xmlns:a="http://schemas.openxmlformats.org/drawingml/2006/main">
               <a:ext uri="{FF2B5EF4-FFF2-40B4-BE49-F238E27FC236}">
-                <a16:creationId xmlns:a16="http://schemas.microsoft.com/office/drawing/2014/main" id="{D4B31016-ACEE-4472-9289-6A39C9DFC904}"/>
+                <a16:creationId xmlns:a16="http://schemas.microsoft.com/office/drawing/2014/main" id="{47F2F1EA-48E2-4C68-84DC-D355AC989C32}"/>
               </a:ext>
             </a:extLst>
           </p:cNvPr>
@@ -6428,7 +6428,7 @@
           <p:cNvPr id="42" name="metric-exact max loss in checked fixture">
             <a:extLst xmlns:a="http://schemas.openxmlformats.org/drawingml/2006/main">
               <a:ext uri="{FF2B5EF4-FFF2-40B4-BE49-F238E27FC236}">
-                <a16:creationId xmlns:a16="http://schemas.microsoft.com/office/drawing/2014/main" id="{9152148B-4862-41E0-B9B8-2ACC3E613076}"/>
+                <a16:creationId xmlns:a16="http://schemas.microsoft.com/office/drawing/2014/main" id="{E08944F6-8B6D-466C-A232-EA6327997D12}"/>
               </a:ext>
             </a:extLst>
           </p:cNvPr>
@@ -6490,7 +6490,7 @@
           <p:cNvPr id="43" name="metric-caption-exact max loss in checked fixture">
             <a:extLst xmlns:a="http://schemas.openxmlformats.org/drawingml/2006/main">
               <a:ext uri="{FF2B5EF4-FFF2-40B4-BE49-F238E27FC236}">
-                <a16:creationId xmlns:a16="http://schemas.microsoft.com/office/drawing/2014/main" id="{426A1E6B-3CDE-4DB7-B51F-CA3F09765A1E}"/>
+                <a16:creationId xmlns:a16="http://schemas.microsoft.com/office/drawing/2014/main" id="{E15F0B9A-545C-4878-9A2F-5CF6427608BA}"/>
               </a:ext>
             </a:extLst>
           </p:cNvPr>
@@ -6552,7 +6552,7 @@
           <p:cNvPr id="44" name="metric-source-removal challenges">
             <a:extLst xmlns:a="http://schemas.openxmlformats.org/drawingml/2006/main">
               <a:ext uri="{FF2B5EF4-FFF2-40B4-BE49-F238E27FC236}">
-                <a16:creationId xmlns:a16="http://schemas.microsoft.com/office/drawing/2014/main" id="{809C6B7C-B839-405E-AEF3-F27A22479F5B}"/>
+                <a16:creationId xmlns:a16="http://schemas.microsoft.com/office/drawing/2014/main" id="{992BE769-08D8-41B9-8C08-B2C437F89F81}"/>
               </a:ext>
             </a:extLst>
           </p:cNvPr>
@@ -6614,7 +6614,7 @@
           <p:cNvPr id="45" name="metric-caption-source-removal challenges">
             <a:extLst xmlns:a="http://schemas.openxmlformats.org/drawingml/2006/main">
               <a:ext uri="{FF2B5EF4-FFF2-40B4-BE49-F238E27FC236}">
-                <a16:creationId xmlns:a16="http://schemas.microsoft.com/office/drawing/2014/main" id="{CBE83D67-49E4-4E7C-9ABC-8DEE56F40E27}"/>
+                <a16:creationId xmlns:a16="http://schemas.microsoft.com/office/drawing/2014/main" id="{2947D287-5D0F-4CC2-99F5-323C5E66FD16}"/>
               </a:ext>
             </a:extLst>
           </p:cNvPr>
@@ -6676,7 +6676,7 @@
           <p:cNvPr id="46" name="metric-perturbation challenges">
             <a:extLst xmlns:a="http://schemas.openxmlformats.org/drawingml/2006/main">
               <a:ext uri="{FF2B5EF4-FFF2-40B4-BE49-F238E27FC236}">
-                <a16:creationId xmlns:a16="http://schemas.microsoft.com/office/drawing/2014/main" id="{41FACC6C-550A-45F4-9A2D-096EC6DD1DA7}"/>
+                <a16:creationId xmlns:a16="http://schemas.microsoft.com/office/drawing/2014/main" id="{1FD2E1E0-566E-43FF-A0E6-5FF4944DDF7F}"/>
               </a:ext>
             </a:extLst>
           </p:cNvPr>
@@ -6738,7 +6738,7 @@
           <p:cNvPr id="47" name="metric-caption-perturbation challenges">
             <a:extLst xmlns:a="http://schemas.openxmlformats.org/drawingml/2006/main">
               <a:ext uri="{FF2B5EF4-FFF2-40B4-BE49-F238E27FC236}">
-                <a16:creationId xmlns:a16="http://schemas.microsoft.com/office/drawing/2014/main" id="{4BFA657D-ECEF-4137-A1E2-F1A943CC78CD}"/>
+                <a16:creationId xmlns:a16="http://schemas.microsoft.com/office/drawing/2014/main" id="{5E124255-A864-4507-BBE7-34D307FAA6EF}"/>
               </a:ext>
             </a:extLst>
           </p:cNvPr>
@@ -6800,7 +6800,7 @@
           <p:cNvPr id="48" name="authority-close">
             <a:extLst xmlns:a="http://schemas.openxmlformats.org/drawingml/2006/main">
               <a:ext uri="{FF2B5EF4-FFF2-40B4-BE49-F238E27FC236}">
-                <a16:creationId xmlns:a16="http://schemas.microsoft.com/office/drawing/2014/main" id="{EB0D14AD-F693-4A79-A562-727EF1252688}"/>
+                <a16:creationId xmlns:a16="http://schemas.microsoft.com/office/drawing/2014/main" id="{E344E76A-3DBE-4EF8-89BC-6B3FA8ADE6DE}"/>
               </a:ext>
             </a:extLst>
           </p:cNvPr>
@@ -6860,7 +6860,7 @@
     </p:spTree>
     <p:extLst>
       <p:ext uri="{BB962C8B-B14F-4D97-AF65-F5344CB8AC3E}">
-        <p14:creationId xmlns:p14="http://schemas.microsoft.com/office/powerpoint/2010/main" val="559712021"/>
+        <p14:creationId xmlns:p14="http://schemas.microsoft.com/office/powerpoint/2010/main" val="1633209641"/>
       </p:ext>
     </p:extLst>
   </p:cSld>
@@ -6891,7 +6891,7 @@
           <p:cNvPr id="15" name="label-Execution realism-58-32">
             <a:extLst xmlns:a="http://schemas.openxmlformats.org/drawingml/2006/main">
               <a:ext uri="{FF2B5EF4-FFF2-40B4-BE49-F238E27FC236}">
-                <a16:creationId xmlns:a16="http://schemas.microsoft.com/office/drawing/2014/main" id="{8412EB86-310B-413F-92B6-BF96A54556B0}"/>
+                <a16:creationId xmlns:a16="http://schemas.microsoft.com/office/drawing/2014/main" id="{7E480406-DF41-4FD9-84C4-3C56AA14E35F}"/>
               </a:ext>
             </a:extLst>
           </p:cNvPr>
@@ -6953,7 +6953,7 @@
           <p:cNvPr id="2" name="slide-title-5">
             <a:extLst xmlns:a="http://schemas.openxmlformats.org/drawingml/2006/main">
               <a:ext uri="{FF2B5EF4-FFF2-40B4-BE49-F238E27FC236}">
-                <a16:creationId xmlns:a16="http://schemas.microsoft.com/office/drawing/2014/main" id="{984DE4CB-5D18-43B8-8B33-92357EF44E7D}"/>
+                <a16:creationId xmlns:a16="http://schemas.microsoft.com/office/drawing/2014/main" id="{46B52253-BF74-42FF-BE53-C3F4715DE82C}"/>
               </a:ext>
             </a:extLst>
           </p:cNvPr>
@@ -7015,7 +7015,7 @@
           <p:cNvPr id="3" name="">
             <a:extLst xmlns:a="http://schemas.openxmlformats.org/drawingml/2006/main">
               <a:ext uri="{FF2B5EF4-FFF2-40B4-BE49-F238E27FC236}">
-                <a16:creationId xmlns:a16="http://schemas.microsoft.com/office/drawing/2014/main" id="{2FB0E58B-29CF-4064-94D4-92315DC88D96}"/>
+                <a16:creationId xmlns:a16="http://schemas.microsoft.com/office/drawing/2014/main" id="{A39E6D16-5637-4F6C-86D6-AF6176374684}"/>
               </a:ext>
             </a:extLst>
           </p:cNvPr>
@@ -7046,7 +7046,7 @@
           <p:cNvPr id="4" name="footer-5">
             <a:extLst xmlns:a="http://schemas.openxmlformats.org/drawingml/2006/main">
               <a:ext uri="{FF2B5EF4-FFF2-40B4-BE49-F238E27FC236}">
-                <a16:creationId xmlns:a16="http://schemas.microsoft.com/office/drawing/2014/main" id="{55E42884-0BA4-4BF9-BE77-3DA7216172DB}"/>
+                <a16:creationId xmlns:a16="http://schemas.microsoft.com/office/drawing/2014/main" id="{2E81FA44-5D19-4315-8FFB-5BF73C4C99B4}"/>
               </a:ext>
             </a:extLst>
           </p:cNvPr>
@@ -7108,7 +7108,7 @@
           <p:cNvPr id="5" name="page-5">
             <a:extLst xmlns:a="http://schemas.openxmlformats.org/drawingml/2006/main">
               <a:ext uri="{FF2B5EF4-FFF2-40B4-BE49-F238E27FC236}">
-                <a16:creationId xmlns:a16="http://schemas.microsoft.com/office/drawing/2014/main" id="{6EF627D8-3451-4C30-A58B-E855766EB638}"/>
+                <a16:creationId xmlns:a16="http://schemas.microsoft.com/office/drawing/2014/main" id="{3C0BC03A-4B70-4CF1-9AF3-0E8C7CB503A8}"/>
               </a:ext>
             </a:extLst>
           </p:cNvPr>
@@ -7177,7 +7177,7 @@
         </p:xfrm>
         <a:graphic xmlns:a="http://schemas.openxmlformats.org/drawingml/2006/main">
           <a:graphicData uri="http://schemas.openxmlformats.org/drawingml/2006/chart">
-            <c:chart xmlns:r="http://schemas.openxmlformats.org/officeDocument/2006/relationships" xmlns:c="http://schemas.openxmlformats.org/drawingml/2006/chart" r:id="R653e81b1df1e455d"/>
+            <c:chart xmlns:r="http://schemas.openxmlformats.org/officeDocument/2006/relationships" xmlns:c="http://schemas.openxmlformats.org/drawingml/2006/chart" r:id="R9653b2ff1fc24fa1"/>
           </a:graphicData>
         </a:graphic>
       </p:graphicFrame>
@@ -7186,7 +7186,7 @@
           <p:cNvPr id="7" name="label-What survived-872-216">
             <a:extLst xmlns:a="http://schemas.openxmlformats.org/drawingml/2006/main">
               <a:ext uri="{FF2B5EF4-FFF2-40B4-BE49-F238E27FC236}">
-                <a16:creationId xmlns:a16="http://schemas.microsoft.com/office/drawing/2014/main" id="{57B199DF-A2CE-407F-9C1F-68693096F817}"/>
+                <a16:creationId xmlns:a16="http://schemas.microsoft.com/office/drawing/2014/main" id="{0D87039A-C649-477F-8202-3E3A95F3D534}"/>
               </a:ext>
             </a:extLst>
           </p:cNvPr>
@@ -7248,7 +7248,7 @@
           <p:cNvPr id="8" name="metric-next-open · 5 bp per leg">
             <a:extLst xmlns:a="http://schemas.openxmlformats.org/drawingml/2006/main">
               <a:ext uri="{FF2B5EF4-FFF2-40B4-BE49-F238E27FC236}">
-                <a16:creationId xmlns:a16="http://schemas.microsoft.com/office/drawing/2014/main" id="{B780C257-85D8-473F-A237-D531455A9391}"/>
+                <a16:creationId xmlns:a16="http://schemas.microsoft.com/office/drawing/2014/main" id="{6C90C027-268A-43C4-81F6-697E776A44F9}"/>
               </a:ext>
             </a:extLst>
           </p:cNvPr>
@@ -7310,7 +7310,7 @@
           <p:cNvPr id="9" name="metric-caption-next-open · 5 bp per leg">
             <a:extLst xmlns:a="http://schemas.openxmlformats.org/drawingml/2006/main">
               <a:ext uri="{FF2B5EF4-FFF2-40B4-BE49-F238E27FC236}">
-                <a16:creationId xmlns:a16="http://schemas.microsoft.com/office/drawing/2014/main" id="{7FCB0416-D21A-44F1-9B0D-B94E06FEFF84}"/>
+                <a16:creationId xmlns:a16="http://schemas.microsoft.com/office/drawing/2014/main" id="{153A2317-C549-45EA-98AF-856F1827269D}"/>
               </a:ext>
             </a:extLst>
           </p:cNvPr>
@@ -7372,7 +7372,7 @@
           <p:cNvPr id="10" name="metric-maximum drawdown">
             <a:extLst xmlns:a="http://schemas.openxmlformats.org/drawingml/2006/main">
               <a:ext uri="{FF2B5EF4-FFF2-40B4-BE49-F238E27FC236}">
-                <a16:creationId xmlns:a16="http://schemas.microsoft.com/office/drawing/2014/main" id="{84D2C230-4128-4FDB-87D6-3BDBA6650800}"/>
+                <a16:creationId xmlns:a16="http://schemas.microsoft.com/office/drawing/2014/main" id="{B83C2E9B-B006-4876-B8FF-C1806B1D1D10}"/>
               </a:ext>
             </a:extLst>
           </p:cNvPr>
@@ -7434,7 +7434,7 @@
           <p:cNvPr id="11" name="metric-caption-maximum drawdown">
             <a:extLst xmlns:a="http://schemas.openxmlformats.org/drawingml/2006/main">
               <a:ext uri="{FF2B5EF4-FFF2-40B4-BE49-F238E27FC236}">
-                <a16:creationId xmlns:a16="http://schemas.microsoft.com/office/drawing/2014/main" id="{B8FBE311-4B12-4D2D-90B4-1A896A0A58D6}"/>
+                <a16:creationId xmlns:a16="http://schemas.microsoft.com/office/drawing/2014/main" id="{95D6EEC2-E7F2-4426-8412-F9FF4BF36002}"/>
               </a:ext>
             </a:extLst>
           </p:cNvPr>
@@ -7496,7 +7496,7 @@
           <p:cNvPr id="12" name="metric-at 25 bp per leg">
             <a:extLst xmlns:a="http://schemas.openxmlformats.org/drawingml/2006/main">
               <a:ext uri="{FF2B5EF4-FFF2-40B4-BE49-F238E27FC236}">
-                <a16:creationId xmlns:a16="http://schemas.microsoft.com/office/drawing/2014/main" id="{1396F9BE-6E90-4A50-9497-586DB39EF2DA}"/>
+                <a16:creationId xmlns:a16="http://schemas.microsoft.com/office/drawing/2014/main" id="{86B060C8-018E-4E4B-9978-8FB36D1B6291}"/>
               </a:ext>
             </a:extLst>
           </p:cNvPr>
@@ -7558,7 +7558,7 @@
           <p:cNvPr id="13" name="metric-caption-at 25 bp per leg">
             <a:extLst xmlns:a="http://schemas.openxmlformats.org/drawingml/2006/main">
               <a:ext uri="{FF2B5EF4-FFF2-40B4-BE49-F238E27FC236}">
-                <a16:creationId xmlns:a16="http://schemas.microsoft.com/office/drawing/2014/main" id="{1F059CCE-0916-4DCB-9754-3449554CB6C7}"/>
+                <a16:creationId xmlns:a16="http://schemas.microsoft.com/office/drawing/2014/main" id="{A8E8F9E5-0716-499E-9F89-4E583278440C}"/>
               </a:ext>
             </a:extLst>
           </p:cNvPr>
@@ -7620,7 +7620,7 @@
           <p:cNvPr id="14" name="execution-boundary">
             <a:extLst xmlns:a="http://schemas.openxmlformats.org/drawingml/2006/main">
               <a:ext uri="{FF2B5EF4-FFF2-40B4-BE49-F238E27FC236}">
-                <a16:creationId xmlns:a16="http://schemas.microsoft.com/office/drawing/2014/main" id="{A807611E-A8B1-40B5-8D9D-B3365DA4F48C}"/>
+                <a16:creationId xmlns:a16="http://schemas.microsoft.com/office/drawing/2014/main" id="{B2A0F37A-CCAF-47D6-8F0B-AC6DB2AC267A}"/>
               </a:ext>
             </a:extLst>
           </p:cNvPr>
@@ -7680,7 +7680,7 @@
     </p:spTree>
     <p:extLst>
       <p:ext uri="{BB962C8B-B14F-4D97-AF65-F5344CB8AC3E}">
-        <p14:creationId xmlns:p14="http://schemas.microsoft.com/office/powerpoint/2010/main" val="157055130"/>
+        <p14:creationId xmlns:p14="http://schemas.microsoft.com/office/powerpoint/2010/main" val="1500823824"/>
       </p:ext>
     </p:extLst>
   </p:cSld>
@@ -7711,7 +7711,7 @@
           <p:cNvPr id="20" name="label-Small-account feasibility-58-32">
             <a:extLst xmlns:a="http://schemas.openxmlformats.org/drawingml/2006/main">
               <a:ext uri="{FF2B5EF4-FFF2-40B4-BE49-F238E27FC236}">
-                <a16:creationId xmlns:a16="http://schemas.microsoft.com/office/drawing/2014/main" id="{EAA71CBB-3091-426D-986A-9A68CB34D70F}"/>
+                <a16:creationId xmlns:a16="http://schemas.microsoft.com/office/drawing/2014/main" id="{9B081491-0B9F-4F4F-ACD5-8D39FA7C622E}"/>
               </a:ext>
             </a:extLst>
           </p:cNvPr>
@@ -7773,7 +7773,7 @@
           <p:cNvPr id="2" name="slide-title-6">
             <a:extLst xmlns:a="http://schemas.openxmlformats.org/drawingml/2006/main">
               <a:ext uri="{FF2B5EF4-FFF2-40B4-BE49-F238E27FC236}">
-                <a16:creationId xmlns:a16="http://schemas.microsoft.com/office/drawing/2014/main" id="{1FAC4268-B078-4353-8148-617D8C829348}"/>
+                <a16:creationId xmlns:a16="http://schemas.microsoft.com/office/drawing/2014/main" id="{3DE694FA-1336-4208-967E-4D184C952E54}"/>
               </a:ext>
             </a:extLst>
           </p:cNvPr>
@@ -7835,7 +7835,7 @@
           <p:cNvPr id="3" name="">
             <a:extLst xmlns:a="http://schemas.openxmlformats.org/drawingml/2006/main">
               <a:ext uri="{FF2B5EF4-FFF2-40B4-BE49-F238E27FC236}">
-                <a16:creationId xmlns:a16="http://schemas.microsoft.com/office/drawing/2014/main" id="{9F501401-B20E-4D69-A1B4-E44D1F1FF763}"/>
+                <a16:creationId xmlns:a16="http://schemas.microsoft.com/office/drawing/2014/main" id="{AF3B1A30-E373-4C32-869B-36307EDDCD33}"/>
               </a:ext>
             </a:extLst>
           </p:cNvPr>
@@ -7866,7 +7866,7 @@
           <p:cNvPr id="4" name="footer-6">
             <a:extLst xmlns:a="http://schemas.openxmlformats.org/drawingml/2006/main">
               <a:ext uri="{FF2B5EF4-FFF2-40B4-BE49-F238E27FC236}">
-                <a16:creationId xmlns:a16="http://schemas.microsoft.com/office/drawing/2014/main" id="{A33F30FF-8FE2-4B46-A58D-44CF033B2FE7}"/>
+                <a16:creationId xmlns:a16="http://schemas.microsoft.com/office/drawing/2014/main" id="{252132A0-5F3D-4190-9277-720B5665B353}"/>
               </a:ext>
             </a:extLst>
           </p:cNvPr>
@@ -7928,7 +7928,7 @@
           <p:cNvPr id="5" name="page-6">
             <a:extLst xmlns:a="http://schemas.openxmlformats.org/drawingml/2006/main">
               <a:ext uri="{FF2B5EF4-FFF2-40B4-BE49-F238E27FC236}">
-                <a16:creationId xmlns:a16="http://schemas.microsoft.com/office/drawing/2014/main" id="{5F66D17B-7EFD-48A7-B240-BFE4DCBEE771}"/>
+                <a16:creationId xmlns:a16="http://schemas.microsoft.com/office/drawing/2014/main" id="{ECEDF512-E7C1-4E86-A7FC-3FE3DC5B428A}"/>
               </a:ext>
             </a:extLst>
           </p:cNvPr>
@@ -7990,7 +7990,7 @@
           <p:cNvPr id="6" name="label-Starting equity-86-226">
             <a:extLst xmlns:a="http://schemas.openxmlformats.org/drawingml/2006/main">
               <a:ext uri="{FF2B5EF4-FFF2-40B4-BE49-F238E27FC236}">
-                <a16:creationId xmlns:a16="http://schemas.microsoft.com/office/drawing/2014/main" id="{3B12C412-5CC8-42DB-8B75-21D75B0945E6}"/>
+                <a16:creationId xmlns:a16="http://schemas.microsoft.com/office/drawing/2014/main" id="{687147D2-4564-4170-A2ED-E395A95AC1F0}"/>
               </a:ext>
             </a:extLst>
           </p:cNvPr>
@@ -8052,7 +8052,7 @@
           <p:cNvPr id="7" name="start-equity">
             <a:extLst xmlns:a="http://schemas.openxmlformats.org/drawingml/2006/main">
               <a:ext uri="{FF2B5EF4-FFF2-40B4-BE49-F238E27FC236}">
-                <a16:creationId xmlns:a16="http://schemas.microsoft.com/office/drawing/2014/main" id="{AED793F9-FD8B-4354-B022-B345FF15FAAC}"/>
+                <a16:creationId xmlns:a16="http://schemas.microsoft.com/office/drawing/2014/main" id="{D7BDECB9-BBFC-4112-8538-3802683B4AE9}"/>
               </a:ext>
             </a:extLst>
           </p:cNvPr>
@@ -8114,7 +8114,7 @@
           <p:cNvPr id="8" name="equity-arrow">
             <a:extLst xmlns:a="http://schemas.openxmlformats.org/drawingml/2006/main">
               <a:ext uri="{FF2B5EF4-FFF2-40B4-BE49-F238E27FC236}">
-                <a16:creationId xmlns:a16="http://schemas.microsoft.com/office/drawing/2014/main" id="{F0095D11-E75D-4AA3-88A4-2547CAC20008}"/>
+                <a16:creationId xmlns:a16="http://schemas.microsoft.com/office/drawing/2014/main" id="{795DC0C7-1D98-4952-A5E1-10E1E1182AA6}"/>
               </a:ext>
             </a:extLst>
           </p:cNvPr>
@@ -8176,7 +8176,7 @@
           <p:cNvPr id="9" name="label-Ending equity-580-226">
             <a:extLst xmlns:a="http://schemas.openxmlformats.org/drawingml/2006/main">
               <a:ext uri="{FF2B5EF4-FFF2-40B4-BE49-F238E27FC236}">
-                <a16:creationId xmlns:a16="http://schemas.microsoft.com/office/drawing/2014/main" id="{323430C6-A1C7-4AB1-A64B-D55EDD8870CC}"/>
+                <a16:creationId xmlns:a16="http://schemas.microsoft.com/office/drawing/2014/main" id="{1F0BDD7C-6C26-4AB8-8749-E9EE592D0211}"/>
               </a:ext>
             </a:extLst>
           </p:cNvPr>
@@ -8238,7 +8238,7 @@
           <p:cNvPr id="10" name="end-equity">
             <a:extLst xmlns:a="http://schemas.openxmlformats.org/drawingml/2006/main">
               <a:ext uri="{FF2B5EF4-FFF2-40B4-BE49-F238E27FC236}">
-                <a16:creationId xmlns:a16="http://schemas.microsoft.com/office/drawing/2014/main" id="{67B71801-8F74-48AE-B3E4-9EEF38A412A9}"/>
+                <a16:creationId xmlns:a16="http://schemas.microsoft.com/office/drawing/2014/main" id="{40F5DFB1-BD6A-4113-AB35-DED73FAE451F}"/>
               </a:ext>
             </a:extLst>
           </p:cNvPr>
@@ -8300,7 +8300,7 @@
           <p:cNvPr id="11" name="equity-return">
             <a:extLst xmlns:a="http://schemas.openxmlformats.org/drawingml/2006/main">
               <a:ext uri="{FF2B5EF4-FFF2-40B4-BE49-F238E27FC236}">
-                <a16:creationId xmlns:a16="http://schemas.microsoft.com/office/drawing/2014/main" id="{074A6440-569A-47B4-A554-4CBDE7AC764B}"/>
+                <a16:creationId xmlns:a16="http://schemas.microsoft.com/office/drawing/2014/main" id="{BE95903A-D252-4D0C-B8C1-4E9F303045DC}"/>
               </a:ext>
             </a:extLst>
           </p:cNvPr>
@@ -8362,7 +8362,7 @@
           <p:cNvPr id="12" name="">
             <a:extLst xmlns:a="http://schemas.openxmlformats.org/drawingml/2006/main">
               <a:ext uri="{FF2B5EF4-FFF2-40B4-BE49-F238E27FC236}">
-                <a16:creationId xmlns:a16="http://schemas.microsoft.com/office/drawing/2014/main" id="{F1793B0E-2A22-4718-B364-1EDA6291CCD0}"/>
+                <a16:creationId xmlns:a16="http://schemas.microsoft.com/office/drawing/2014/main" id="{8D0671AF-4A7B-4FCE-BA19-46ED6853979A}"/>
               </a:ext>
             </a:extLst>
           </p:cNvPr>
@@ -8393,7 +8393,7 @@
           <p:cNvPr id="13" name="metric-minimum order notional">
             <a:extLst xmlns:a="http://schemas.openxmlformats.org/drawingml/2006/main">
               <a:ext uri="{FF2B5EF4-FFF2-40B4-BE49-F238E27FC236}">
-                <a16:creationId xmlns:a16="http://schemas.microsoft.com/office/drawing/2014/main" id="{C8E15C93-13F5-4206-B857-BA2260A88965}"/>
+                <a16:creationId xmlns:a16="http://schemas.microsoft.com/office/drawing/2014/main" id="{4A025178-3887-418C-A637-F89A4AB1F8D3}"/>
               </a:ext>
             </a:extLst>
           </p:cNvPr>
@@ -8455,7 +8455,7 @@
           <p:cNvPr id="14" name="metric-caption-minimum order notional">
             <a:extLst xmlns:a="http://schemas.openxmlformats.org/drawingml/2006/main">
               <a:ext uri="{FF2B5EF4-FFF2-40B4-BE49-F238E27FC236}">
-                <a16:creationId xmlns:a16="http://schemas.microsoft.com/office/drawing/2014/main" id="{6B430A85-70B9-49F0-87BB-6B6A8F6B7EB1}"/>
+                <a16:creationId xmlns:a16="http://schemas.microsoft.com/office/drawing/2014/main" id="{D15A2B91-48D2-41E1-AECC-A7473C98DC33}"/>
               </a:ext>
             </a:extLst>
           </p:cNvPr>
@@ -8517,7 +8517,7 @@
           <p:cNvPr id="15" name="metric-sell-day fee proxy">
             <a:extLst xmlns:a="http://schemas.openxmlformats.org/drawingml/2006/main">
               <a:ext uri="{FF2B5EF4-FFF2-40B4-BE49-F238E27FC236}">
-                <a16:creationId xmlns:a16="http://schemas.microsoft.com/office/drawing/2014/main" id="{114F6F70-E525-4763-A71D-9B3DF56721DC}"/>
+                <a16:creationId xmlns:a16="http://schemas.microsoft.com/office/drawing/2014/main" id="{67B0CC0B-E078-4CB0-9BC2-384011837A50}"/>
               </a:ext>
             </a:extLst>
           </p:cNvPr>
@@ -8579,7 +8579,7 @@
           <p:cNvPr id="16" name="metric-caption-sell-day fee proxy">
             <a:extLst xmlns:a="http://schemas.openxmlformats.org/drawingml/2006/main">
               <a:ext uri="{FF2B5EF4-FFF2-40B4-BE49-F238E27FC236}">
-                <a16:creationId xmlns:a16="http://schemas.microsoft.com/office/drawing/2014/main" id="{AE1DAAE3-C886-4A62-ADC8-93D93F4DB86C}"/>
+                <a16:creationId xmlns:a16="http://schemas.microsoft.com/office/drawing/2014/main" id="{5F8F19C1-EC5D-483E-9525-D62173974481}"/>
               </a:ext>
             </a:extLst>
           </p:cNvPr>
@@ -8641,7 +8641,7 @@
           <p:cNvPr id="17" name="metric-sub-minimum orders skipped">
             <a:extLst xmlns:a="http://schemas.openxmlformats.org/drawingml/2006/main">
               <a:ext uri="{FF2B5EF4-FFF2-40B4-BE49-F238E27FC236}">
-                <a16:creationId xmlns:a16="http://schemas.microsoft.com/office/drawing/2014/main" id="{37FDD6AB-B268-4F6C-A2FD-56E553397F10}"/>
+                <a16:creationId xmlns:a16="http://schemas.microsoft.com/office/drawing/2014/main" id="{6F2C6B57-12A8-44AE-AD88-E5075F92F2BE}"/>
               </a:ext>
             </a:extLst>
           </p:cNvPr>
@@ -8703,7 +8703,7 @@
           <p:cNvPr id="18" name="metric-caption-sub-minimum orders skipped">
             <a:extLst xmlns:a="http://schemas.openxmlformats.org/drawingml/2006/main">
               <a:ext uri="{FF2B5EF4-FFF2-40B4-BE49-F238E27FC236}">
-                <a16:creationId xmlns:a16="http://schemas.microsoft.com/office/drawing/2014/main" id="{821AB2D9-4479-4E9A-9F8B-43900AF50DBD}"/>
+                <a16:creationId xmlns:a16="http://schemas.microsoft.com/office/drawing/2014/main" id="{46CFCFA7-DA3F-4490-BC33-21A7BFF0692A}"/>
               </a:ext>
             </a:extLst>
           </p:cNvPr>
@@ -8765,7 +8765,7 @@
           <p:cNvPr id="19" name="small-account-boundary">
             <a:extLst xmlns:a="http://schemas.openxmlformats.org/drawingml/2006/main">
               <a:ext uri="{FF2B5EF4-FFF2-40B4-BE49-F238E27FC236}">
-                <a16:creationId xmlns:a16="http://schemas.microsoft.com/office/drawing/2014/main" id="{83B7F6BA-565D-4512-A31E-97168186DF06}"/>
+                <a16:creationId xmlns:a16="http://schemas.microsoft.com/office/drawing/2014/main" id="{CB9B2EF6-214E-40B5-ABCC-1008A57671E6}"/>
               </a:ext>
             </a:extLst>
           </p:cNvPr>
@@ -8825,7 +8825,7 @@
     </p:spTree>
     <p:extLst>
       <p:ext uri="{BB962C8B-B14F-4D97-AF65-F5344CB8AC3E}">
-        <p14:creationId xmlns:p14="http://schemas.microsoft.com/office/powerpoint/2010/main" val="1137523159"/>
+        <p14:creationId xmlns:p14="http://schemas.microsoft.com/office/powerpoint/2010/main" val="431450947"/>
       </p:ext>
     </p:extLst>
   </p:cSld>
@@ -8856,7 +8856,7 @@
           <p:cNvPr id="27" name="label-Research discipline-58-32">
             <a:extLst xmlns:a="http://schemas.openxmlformats.org/drawingml/2006/main">
               <a:ext uri="{FF2B5EF4-FFF2-40B4-BE49-F238E27FC236}">
-                <a16:creationId xmlns:a16="http://schemas.microsoft.com/office/drawing/2014/main" id="{87A3AB86-DCBC-4E97-8BAF-D16E4862342A}"/>
+                <a16:creationId xmlns:a16="http://schemas.microsoft.com/office/drawing/2014/main" id="{91CD53B7-7006-45C2-8E09-6A96B7F9BC95}"/>
               </a:ext>
             </a:extLst>
           </p:cNvPr>
@@ -8918,7 +8918,7 @@
           <p:cNvPr id="2" name="slide-title-7">
             <a:extLst xmlns:a="http://schemas.openxmlformats.org/drawingml/2006/main">
               <a:ext uri="{FF2B5EF4-FFF2-40B4-BE49-F238E27FC236}">
-                <a16:creationId xmlns:a16="http://schemas.microsoft.com/office/drawing/2014/main" id="{C2D94178-FDD4-4685-8E40-C4AD19796E93}"/>
+                <a16:creationId xmlns:a16="http://schemas.microsoft.com/office/drawing/2014/main" id="{7B831A81-2532-4F92-9476-109FAABA3372}"/>
               </a:ext>
             </a:extLst>
           </p:cNvPr>
@@ -8980,7 +8980,7 @@
           <p:cNvPr id="3" name="">
             <a:extLst xmlns:a="http://schemas.openxmlformats.org/drawingml/2006/main">
               <a:ext uri="{FF2B5EF4-FFF2-40B4-BE49-F238E27FC236}">
-                <a16:creationId xmlns:a16="http://schemas.microsoft.com/office/drawing/2014/main" id="{5CA54198-204F-408F-8D1D-601CDA36EF12}"/>
+                <a16:creationId xmlns:a16="http://schemas.microsoft.com/office/drawing/2014/main" id="{3831FB71-E9CA-474A-ACE6-0DF62C884D26}"/>
               </a:ext>
             </a:extLst>
           </p:cNvPr>
@@ -9011,7 +9011,7 @@
           <p:cNvPr id="4" name="footer-7">
             <a:extLst xmlns:a="http://schemas.openxmlformats.org/drawingml/2006/main">
               <a:ext uri="{FF2B5EF4-FFF2-40B4-BE49-F238E27FC236}">
-                <a16:creationId xmlns:a16="http://schemas.microsoft.com/office/drawing/2014/main" id="{828C41F1-413E-4A03-9078-7F6A70FAB231}"/>
+                <a16:creationId xmlns:a16="http://schemas.microsoft.com/office/drawing/2014/main" id="{53A9C5AA-D371-4102-A4F7-F8C8246213A7}"/>
               </a:ext>
             </a:extLst>
           </p:cNvPr>
@@ -9073,7 +9073,7 @@
           <p:cNvPr id="5" name="page-7">
             <a:extLst xmlns:a="http://schemas.openxmlformats.org/drawingml/2006/main">
               <a:ext uri="{FF2B5EF4-FFF2-40B4-BE49-F238E27FC236}">
-                <a16:creationId xmlns:a16="http://schemas.microsoft.com/office/drawing/2014/main" id="{8512E1BE-4B75-4CAB-A7A7-5DBF44A1FFDB}"/>
+                <a16:creationId xmlns:a16="http://schemas.microsoft.com/office/drawing/2014/main" id="{4104CD74-A88C-4B4A-9948-43BD49D9DAF3}"/>
               </a:ext>
             </a:extLst>
           </p:cNvPr>
@@ -9139,7 +9139,7 @@
           <p:nvPr/>
         </p:nvPicPr>
         <p:blipFill>
-          <a:blip xmlns:r="http://schemas.openxmlformats.org/officeDocument/2006/relationships" xmlns:a="http://schemas.openxmlformats.org/drawingml/2006/main" r:embed="Rc984e8c542ce4ca5"/>
+          <a:blip xmlns:r="http://schemas.openxmlformats.org/officeDocument/2006/relationships" xmlns:a="http://schemas.openxmlformats.org/drawingml/2006/main" r:embed="R64eca75dba9943b4"/>
           <a:stretch xmlns:a="http://schemas.openxmlformats.org/drawingml/2006/main"/>
         </p:blipFill>
         <p:spPr>
@@ -9157,7 +9157,7 @@
           <p:cNvPr id="7" name="label-Rejected shadow · G4-782-214">
             <a:extLst xmlns:a="http://schemas.openxmlformats.org/drawingml/2006/main">
               <a:ext uri="{FF2B5EF4-FFF2-40B4-BE49-F238E27FC236}">
-                <a16:creationId xmlns:a16="http://schemas.microsoft.com/office/drawing/2014/main" id="{5FCCA455-35F3-499D-8627-1E5503B6236B}"/>
+                <a16:creationId xmlns:a16="http://schemas.microsoft.com/office/drawing/2014/main" id="{6C2E9469-9F04-4E4B-B7B1-15165EE1984E}"/>
               </a:ext>
             </a:extLst>
           </p:cNvPr>
@@ -9219,7 +9219,7 @@
           <p:cNvPr id="8" name="g4-return">
             <a:extLst xmlns:a="http://schemas.openxmlformats.org/drawingml/2006/main">
               <a:ext uri="{FF2B5EF4-FFF2-40B4-BE49-F238E27FC236}">
-                <a16:creationId xmlns:a16="http://schemas.microsoft.com/office/drawing/2014/main" id="{9B78F708-5391-4B97-8893-85B06005EFA2}"/>
+                <a16:creationId xmlns:a16="http://schemas.microsoft.com/office/drawing/2014/main" id="{6140C90B-F6E2-4F5A-9D7A-C0E770CA09C1}"/>
               </a:ext>
             </a:extLst>
           </p:cNvPr>
@@ -9281,7 +9281,7 @@
           <p:cNvPr id="9" name="g4-return-caption">
             <a:extLst xmlns:a="http://schemas.openxmlformats.org/drawingml/2006/main">
               <a:ext uri="{FF2B5EF4-FFF2-40B4-BE49-F238E27FC236}">
-                <a16:creationId xmlns:a16="http://schemas.microsoft.com/office/drawing/2014/main" id="{6A33FAB9-9A48-4C32-80FA-478FA0B26103}"/>
+                <a16:creationId xmlns:a16="http://schemas.microsoft.com/office/drawing/2014/main" id="{8711865F-1E09-49BA-AAC9-BEF0640981A3}"/>
               </a:ext>
             </a:extLst>
           </p:cNvPr>
@@ -9343,7 +9343,7 @@
           <p:cNvPr id="10" name="">
             <a:extLst xmlns:a="http://schemas.openxmlformats.org/drawingml/2006/main">
               <a:ext uri="{FF2B5EF4-FFF2-40B4-BE49-F238E27FC236}">
-                <a16:creationId xmlns:a16="http://schemas.microsoft.com/office/drawing/2014/main" id="{CA835ABF-5ADA-405E-A9AE-CBB853E8EE30}"/>
+                <a16:creationId xmlns:a16="http://schemas.microsoft.com/office/drawing/2014/main" id="{B425E8C9-9388-498C-9CDA-810D048F41E1}"/>
               </a:ext>
             </a:extLst>
           </p:cNvPr>
@@ -9374,7 +9374,7 @@
           <p:cNvPr id="11" name="g4-gate-0">
             <a:extLst xmlns:a="http://schemas.openxmlformats.org/drawingml/2006/main">
               <a:ext uri="{FF2B5EF4-FFF2-40B4-BE49-F238E27FC236}">
-                <a16:creationId xmlns:a16="http://schemas.microsoft.com/office/drawing/2014/main" id="{2E85EB50-2DBE-469F-B6EB-FB1734EC4FBD}"/>
+                <a16:creationId xmlns:a16="http://schemas.microsoft.com/office/drawing/2014/main" id="{4AB50270-B500-4566-90E1-06DBFC064840}"/>
               </a:ext>
             </a:extLst>
           </p:cNvPr>
@@ -9436,7 +9436,7 @@
           <p:cNvPr id="12" name="g4-value-0">
             <a:extLst xmlns:a="http://schemas.openxmlformats.org/drawingml/2006/main">
               <a:ext uri="{FF2B5EF4-FFF2-40B4-BE49-F238E27FC236}">
-                <a16:creationId xmlns:a16="http://schemas.microsoft.com/office/drawing/2014/main" id="{5C310355-0BD7-4542-8DE0-AB2800FBDC2A}"/>
+                <a16:creationId xmlns:a16="http://schemas.microsoft.com/office/drawing/2014/main" id="{786A3FFC-2BDC-49E8-99B3-BACECE63AF29}"/>
               </a:ext>
             </a:extLst>
           </p:cNvPr>
@@ -9498,7 +9498,7 @@
           <p:cNvPr id="13" name="g4-status-0">
             <a:extLst xmlns:a="http://schemas.openxmlformats.org/drawingml/2006/main">
               <a:ext uri="{FF2B5EF4-FFF2-40B4-BE49-F238E27FC236}">
-                <a16:creationId xmlns:a16="http://schemas.microsoft.com/office/drawing/2014/main" id="{560CA0B5-1126-463D-9120-4C1A1F8D86A8}"/>
+                <a16:creationId xmlns:a16="http://schemas.microsoft.com/office/drawing/2014/main" id="{512EC0D1-2D84-47FD-82BC-1C8599891E3B}"/>
               </a:ext>
             </a:extLst>
           </p:cNvPr>
@@ -9560,7 +9560,7 @@
           <p:cNvPr id="14" name="">
             <a:extLst xmlns:a="http://schemas.openxmlformats.org/drawingml/2006/main">
               <a:ext uri="{FF2B5EF4-FFF2-40B4-BE49-F238E27FC236}">
-                <a16:creationId xmlns:a16="http://schemas.microsoft.com/office/drawing/2014/main" id="{4F1614FB-6BE7-4D8A-AE81-E70A1D855B84}"/>
+                <a16:creationId xmlns:a16="http://schemas.microsoft.com/office/drawing/2014/main" id="{63110F41-597F-4F6F-98AB-81149D1BA4BE}"/>
               </a:ext>
             </a:extLst>
           </p:cNvPr>
@@ -9591,7 +9591,7 @@
           <p:cNvPr id="15" name="g4-gate-1">
             <a:extLst xmlns:a="http://schemas.openxmlformats.org/drawingml/2006/main">
               <a:ext uri="{FF2B5EF4-FFF2-40B4-BE49-F238E27FC236}">
-                <a16:creationId xmlns:a16="http://schemas.microsoft.com/office/drawing/2014/main" id="{043BE22C-D960-46C9-96EA-A1D144AA1722}"/>
+                <a16:creationId xmlns:a16="http://schemas.microsoft.com/office/drawing/2014/main" id="{F20744CC-9B2E-42ED-A717-26ED54A4DA42}"/>
               </a:ext>
             </a:extLst>
           </p:cNvPr>
@@ -9653,7 +9653,7 @@
           <p:cNvPr id="16" name="g4-value-1">
             <a:extLst xmlns:a="http://schemas.openxmlformats.org/drawingml/2006/main">
               <a:ext uri="{FF2B5EF4-FFF2-40B4-BE49-F238E27FC236}">
-                <a16:creationId xmlns:a16="http://schemas.microsoft.com/office/drawing/2014/main" id="{2F8798A4-96B9-4827-8D26-BBBFAC4009C9}"/>
+                <a16:creationId xmlns:a16="http://schemas.microsoft.com/office/drawing/2014/main" id="{6B096C11-9DC3-4617-9A71-A5B148128100}"/>
               </a:ext>
             </a:extLst>
           </p:cNvPr>
@@ -9715,7 +9715,7 @@
           <p:cNvPr id="17" name="g4-status-1">
             <a:extLst xmlns:a="http://schemas.openxmlformats.org/drawingml/2006/main">
               <a:ext uri="{FF2B5EF4-FFF2-40B4-BE49-F238E27FC236}">
-                <a16:creationId xmlns:a16="http://schemas.microsoft.com/office/drawing/2014/main" id="{4E82F527-27CF-4569-9615-DEFAE6B31CDE}"/>
+                <a16:creationId xmlns:a16="http://schemas.microsoft.com/office/drawing/2014/main" id="{AF9503B9-644C-4621-A838-9DC44C8E5C95}"/>
               </a:ext>
             </a:extLst>
           </p:cNvPr>
@@ -9777,7 +9777,7 @@
           <p:cNvPr id="18" name="">
             <a:extLst xmlns:a="http://schemas.openxmlformats.org/drawingml/2006/main">
               <a:ext uri="{FF2B5EF4-FFF2-40B4-BE49-F238E27FC236}">
-                <a16:creationId xmlns:a16="http://schemas.microsoft.com/office/drawing/2014/main" id="{36B800ED-1655-4188-969E-95A449D6798F}"/>
+                <a16:creationId xmlns:a16="http://schemas.microsoft.com/office/drawing/2014/main" id="{49CAAF9E-4418-4A63-A405-90080075A48A}"/>
               </a:ext>
             </a:extLst>
           </p:cNvPr>
@@ -9808,7 +9808,7 @@
           <p:cNvPr id="19" name="g4-gate-2">
             <a:extLst xmlns:a="http://schemas.openxmlformats.org/drawingml/2006/main">
               <a:ext uri="{FF2B5EF4-FFF2-40B4-BE49-F238E27FC236}">
-                <a16:creationId xmlns:a16="http://schemas.microsoft.com/office/drawing/2014/main" id="{F23A5070-309F-4ABF-94BA-B985E9BEF3D9}"/>
+                <a16:creationId xmlns:a16="http://schemas.microsoft.com/office/drawing/2014/main" id="{94A441AC-F9D7-4A71-A85E-E10B2CBF73FA}"/>
               </a:ext>
             </a:extLst>
           </p:cNvPr>
@@ -9870,7 +9870,7 @@
           <p:cNvPr id="20" name="g4-value-2">
             <a:extLst xmlns:a="http://schemas.openxmlformats.org/drawingml/2006/main">
               <a:ext uri="{FF2B5EF4-FFF2-40B4-BE49-F238E27FC236}">
-                <a16:creationId xmlns:a16="http://schemas.microsoft.com/office/drawing/2014/main" id="{3D2521D3-D7BE-42B0-9145-FE67903E16D2}"/>
+                <a16:creationId xmlns:a16="http://schemas.microsoft.com/office/drawing/2014/main" id="{540C9D07-4164-433E-944E-295B78984DB6}"/>
               </a:ext>
             </a:extLst>
           </p:cNvPr>
@@ -9932,7 +9932,7 @@
           <p:cNvPr id="21" name="g4-status-2">
             <a:extLst xmlns:a="http://schemas.openxmlformats.org/drawingml/2006/main">
               <a:ext uri="{FF2B5EF4-FFF2-40B4-BE49-F238E27FC236}">
-                <a16:creationId xmlns:a16="http://schemas.microsoft.com/office/drawing/2014/main" id="{97A398FC-8958-409D-ABBA-0676D4C151EE}"/>
+                <a16:creationId xmlns:a16="http://schemas.microsoft.com/office/drawing/2014/main" id="{186C7C87-C3EB-400F-BFEE-305C02D18D27}"/>
               </a:ext>
             </a:extLst>
           </p:cNvPr>
@@ -9994,7 +9994,7 @@
           <p:cNvPr id="22" name="">
             <a:extLst xmlns:a="http://schemas.openxmlformats.org/drawingml/2006/main">
               <a:ext uri="{FF2B5EF4-FFF2-40B4-BE49-F238E27FC236}">
-                <a16:creationId xmlns:a16="http://schemas.microsoft.com/office/drawing/2014/main" id="{08ABE41F-F231-4F42-977F-DFB8358BFF54}"/>
+                <a16:creationId xmlns:a16="http://schemas.microsoft.com/office/drawing/2014/main" id="{AA0FCFCC-CD31-4787-94D8-3929FCB196CD}"/>
               </a:ext>
             </a:extLst>
           </p:cNvPr>
@@ -10025,7 +10025,7 @@
           <p:cNvPr id="23" name="g4-gate-3">
             <a:extLst xmlns:a="http://schemas.openxmlformats.org/drawingml/2006/main">
               <a:ext uri="{FF2B5EF4-FFF2-40B4-BE49-F238E27FC236}">
-                <a16:creationId xmlns:a16="http://schemas.microsoft.com/office/drawing/2014/main" id="{36C0F1C5-56E1-4A4F-9DD6-AAB07069467A}"/>
+                <a16:creationId xmlns:a16="http://schemas.microsoft.com/office/drawing/2014/main" id="{17DA852F-A18C-4A1B-8D1D-D454900813BC}"/>
               </a:ext>
             </a:extLst>
           </p:cNvPr>
@@ -10087,7 +10087,7 @@
           <p:cNvPr id="24" name="g4-value-3">
             <a:extLst xmlns:a="http://schemas.openxmlformats.org/drawingml/2006/main">
               <a:ext uri="{FF2B5EF4-FFF2-40B4-BE49-F238E27FC236}">
-                <a16:creationId xmlns:a16="http://schemas.microsoft.com/office/drawing/2014/main" id="{51C6EB0F-6FCB-4B4A-A71C-508B97041CF1}"/>
+                <a16:creationId xmlns:a16="http://schemas.microsoft.com/office/drawing/2014/main" id="{B8F37ED9-2EB3-469D-B66C-45BC90044B22}"/>
               </a:ext>
             </a:extLst>
           </p:cNvPr>
@@ -10149,7 +10149,7 @@
           <p:cNvPr id="25" name="g4-status-3">
             <a:extLst xmlns:a="http://schemas.openxmlformats.org/drawingml/2006/main">
               <a:ext uri="{FF2B5EF4-FFF2-40B4-BE49-F238E27FC236}">
-                <a16:creationId xmlns:a16="http://schemas.microsoft.com/office/drawing/2014/main" id="{906B72D6-12A4-4DC9-A237-733677E8E086}"/>
+                <a16:creationId xmlns:a16="http://schemas.microsoft.com/office/drawing/2014/main" id="{0343F385-B74C-43C8-A4FA-A6185B0ECA51}"/>
               </a:ext>
             </a:extLst>
           </p:cNvPr>
@@ -10211,7 +10211,7 @@
           <p:cNvPr id="26" name="g4-boundary">
             <a:extLst xmlns:a="http://schemas.openxmlformats.org/drawingml/2006/main">
               <a:ext uri="{FF2B5EF4-FFF2-40B4-BE49-F238E27FC236}">
-                <a16:creationId xmlns:a16="http://schemas.microsoft.com/office/drawing/2014/main" id="{E9B1B1A2-4BC3-4AE0-9955-3E5B87F1B493}"/>
+                <a16:creationId xmlns:a16="http://schemas.microsoft.com/office/drawing/2014/main" id="{35C69F1D-BF4D-4BFD-988C-CFFC6EADBD78}"/>
               </a:ext>
             </a:extLst>
           </p:cNvPr>
@@ -10271,7 +10271,7 @@
     </p:spTree>
     <p:extLst>
       <p:ext uri="{BB962C8B-B14F-4D97-AF65-F5344CB8AC3E}">
-        <p14:creationId xmlns:p14="http://schemas.microsoft.com/office/powerpoint/2010/main" val="2053542240"/>
+        <p14:creationId xmlns:p14="http://schemas.microsoft.com/office/powerpoint/2010/main" val="449644723"/>
       </p:ext>
     </p:extLst>
   </p:cSld>
@@ -10302,7 +10302,7 @@
           <p:cNvPr id="21" name="label-Forward proof-58-32">
             <a:extLst xmlns:a="http://schemas.openxmlformats.org/drawingml/2006/main">
               <a:ext uri="{FF2B5EF4-FFF2-40B4-BE49-F238E27FC236}">
-                <a16:creationId xmlns:a16="http://schemas.microsoft.com/office/drawing/2014/main" id="{18E80139-8C48-477A-B4BF-B81FBA2B6868}"/>
+                <a16:creationId xmlns:a16="http://schemas.microsoft.com/office/drawing/2014/main" id="{6ACF7A3F-C5A1-4AE3-8DF2-0910E9A554E8}"/>
               </a:ext>
             </a:extLst>
           </p:cNvPr>
@@ -10364,7 +10364,7 @@
           <p:cNvPr id="2" name="slide-title-8">
             <a:extLst xmlns:a="http://schemas.openxmlformats.org/drawingml/2006/main">
               <a:ext uri="{FF2B5EF4-FFF2-40B4-BE49-F238E27FC236}">
-                <a16:creationId xmlns:a16="http://schemas.microsoft.com/office/drawing/2014/main" id="{5671549F-784D-4FBB-8948-5EEF19508B34}"/>
+                <a16:creationId xmlns:a16="http://schemas.microsoft.com/office/drawing/2014/main" id="{0BF2187E-DD90-444B-BBDC-68977FAD2326}"/>
               </a:ext>
             </a:extLst>
           </p:cNvPr>
@@ -10426,7 +10426,7 @@
           <p:cNvPr id="3" name="">
             <a:extLst xmlns:a="http://schemas.openxmlformats.org/drawingml/2006/main">
               <a:ext uri="{FF2B5EF4-FFF2-40B4-BE49-F238E27FC236}">
-                <a16:creationId xmlns:a16="http://schemas.microsoft.com/office/drawing/2014/main" id="{0EDB2978-5D85-4576-AAE8-CDE7186DC72D}"/>
+                <a16:creationId xmlns:a16="http://schemas.microsoft.com/office/drawing/2014/main" id="{6D5ECCC5-1FED-40D8-BB28-608D943C11AA}"/>
               </a:ext>
             </a:extLst>
           </p:cNvPr>
@@ -10457,7 +10457,7 @@
           <p:cNvPr id="4" name="footer-8">
             <a:extLst xmlns:a="http://schemas.openxmlformats.org/drawingml/2006/main">
               <a:ext uri="{FF2B5EF4-FFF2-40B4-BE49-F238E27FC236}">
-                <a16:creationId xmlns:a16="http://schemas.microsoft.com/office/drawing/2014/main" id="{5B08AD9F-85C3-47F3-8F6B-433CD29B7A3E}"/>
+                <a16:creationId xmlns:a16="http://schemas.microsoft.com/office/drawing/2014/main" id="{E1E39969-1921-4C18-89E3-02726A2AAE4F}"/>
               </a:ext>
             </a:extLst>
           </p:cNvPr>
@@ -10519,7 +10519,7 @@
           <p:cNvPr id="5" name="page-8">
             <a:extLst xmlns:a="http://schemas.openxmlformats.org/drawingml/2006/main">
               <a:ext uri="{FF2B5EF4-FFF2-40B4-BE49-F238E27FC236}">
-                <a16:creationId xmlns:a16="http://schemas.microsoft.com/office/drawing/2014/main" id="{99F6ABD1-B035-4040-B609-DE6FEA7B67D1}"/>
+                <a16:creationId xmlns:a16="http://schemas.microsoft.com/office/drawing/2014/main" id="{E316E011-31FD-43AE-9852-5216AC467012}"/>
               </a:ext>
             </a:extLst>
           </p:cNvPr>
@@ -10581,7 +10581,7 @@
           <p:cNvPr id="6" name="label-Public before the first signal-64-210">
             <a:extLst xmlns:a="http://schemas.openxmlformats.org/drawingml/2006/main">
               <a:ext uri="{FF2B5EF4-FFF2-40B4-BE49-F238E27FC236}">
-                <a16:creationId xmlns:a16="http://schemas.microsoft.com/office/drawing/2014/main" id="{55C5FA89-93D3-4806-908A-6C346155C903}"/>
+                <a16:creationId xmlns:a16="http://schemas.microsoft.com/office/drawing/2014/main" id="{F35D3F03-5F0A-421E-A684-5AAC28EB73BE}"/>
               </a:ext>
             </a:extLst>
           </p:cNvPr>
@@ -10643,7 +10643,7 @@
           <p:cNvPr id="7" name="attempt-title">
             <a:extLst xmlns:a="http://schemas.openxmlformats.org/drawingml/2006/main">
               <a:ext uri="{FF2B5EF4-FFF2-40B4-BE49-F238E27FC236}">
-                <a16:creationId xmlns:a16="http://schemas.microsoft.com/office/drawing/2014/main" id="{B3FBD035-4EB2-4A1F-879A-93B827E7B331}"/>
+                <a16:creationId xmlns:a16="http://schemas.microsoft.com/office/drawing/2014/main" id="{B91E7975-DD57-4745-95B4-5D31DE94E600}"/>
               </a:ext>
             </a:extLst>
           </p:cNvPr>
@@ -10705,7 +10705,7 @@
           <p:cNvPr id="8" name="attempt-copy">
             <a:extLst xmlns:a="http://schemas.openxmlformats.org/drawingml/2006/main">
               <a:ext uri="{FF2B5EF4-FFF2-40B4-BE49-F238E27FC236}">
-                <a16:creationId xmlns:a16="http://schemas.microsoft.com/office/drawing/2014/main" id="{350ECB6C-C614-4C76-B550-04B9C31E8C8A}"/>
+                <a16:creationId xmlns:a16="http://schemas.microsoft.com/office/drawing/2014/main" id="{2E5D9F72-DFB3-40D6-B90B-4F0478E5C7B0}"/>
               </a:ext>
             </a:extLst>
           </p:cNvPr>
@@ -10767,7 +10767,7 @@
           <p:cNvPr id="9" name="">
             <a:extLst xmlns:a="http://schemas.openxmlformats.org/drawingml/2006/main">
               <a:ext uri="{FF2B5EF4-FFF2-40B4-BE49-F238E27FC236}">
-                <a16:creationId xmlns:a16="http://schemas.microsoft.com/office/drawing/2014/main" id="{A38EAD9A-E2CD-479D-9141-F2A1DCA96974}"/>
+                <a16:creationId xmlns:a16="http://schemas.microsoft.com/office/drawing/2014/main" id="{03035B69-DC3A-473D-9A0B-1647389119D0}"/>
               </a:ext>
             </a:extLst>
           </p:cNvPr>
@@ -10798,7 +10798,7 @@
           <p:cNvPr id="10" name="metric-runtime-bound files matched">
             <a:extLst xmlns:a="http://schemas.openxmlformats.org/drawingml/2006/main">
               <a:ext uri="{FF2B5EF4-FFF2-40B4-BE49-F238E27FC236}">
-                <a16:creationId xmlns:a16="http://schemas.microsoft.com/office/drawing/2014/main" id="{0F1702C4-1186-4CF6-B4A6-2F2363F0F331}"/>
+                <a16:creationId xmlns:a16="http://schemas.microsoft.com/office/drawing/2014/main" id="{B4D66D95-E9E8-45A4-BA66-D12DCBFBE17F}"/>
               </a:ext>
             </a:extLst>
           </p:cNvPr>
@@ -10860,7 +10860,7 @@
           <p:cNvPr id="11" name="metric-caption-runtime-bound files matched">
             <a:extLst xmlns:a="http://schemas.openxmlformats.org/drawingml/2006/main">
               <a:ext uri="{FF2B5EF4-FFF2-40B4-BE49-F238E27FC236}">
-                <a16:creationId xmlns:a16="http://schemas.microsoft.com/office/drawing/2014/main" id="{99AB9CBF-3E01-4DC2-AAA0-B4FE26D4861B}"/>
+                <a16:creationId xmlns:a16="http://schemas.microsoft.com/office/drawing/2014/main" id="{98B327E9-A557-4FE1-980B-48AD4D3D2423}"/>
               </a:ext>
             </a:extLst>
           </p:cNvPr>
@@ -10922,7 +10922,7 @@
           <p:cNvPr id="12" name="metric-fixed public GET checks">
             <a:extLst xmlns:a="http://schemas.openxmlformats.org/drawingml/2006/main">
               <a:ext uri="{FF2B5EF4-FFF2-40B4-BE49-F238E27FC236}">
-                <a16:creationId xmlns:a16="http://schemas.microsoft.com/office/drawing/2014/main" id="{A2D91E78-AF85-43D1-A65B-3E2A4E87B136}"/>
+                <a16:creationId xmlns:a16="http://schemas.microsoft.com/office/drawing/2014/main" id="{A6E9651B-DAA4-4DFB-88CC-F93D02A6F2B2}"/>
               </a:ext>
             </a:extLst>
           </p:cNvPr>
@@ -10984,7 +10984,7 @@
           <p:cNvPr id="13" name="metric-caption-fixed public GET checks">
             <a:extLst xmlns:a="http://schemas.openxmlformats.org/drawingml/2006/main">
               <a:ext uri="{FF2B5EF4-FFF2-40B4-BE49-F238E27FC236}">
-                <a16:creationId xmlns:a16="http://schemas.microsoft.com/office/drawing/2014/main" id="{9427F158-0BCB-4473-9D1E-40167C2EBF8A}"/>
+                <a16:creationId xmlns:a16="http://schemas.microsoft.com/office/drawing/2014/main" id="{1F9A1FDF-56E0-4A20-9EF6-84CC436763CF}"/>
               </a:ext>
             </a:extLst>
           </p:cNvPr>
@@ -11046,7 +11046,7 @@
           <p:cNvPr id="14" name="metric-timely signal anchors required">
             <a:extLst xmlns:a="http://schemas.openxmlformats.org/drawingml/2006/main">
               <a:ext uri="{FF2B5EF4-FFF2-40B4-BE49-F238E27FC236}">
-                <a16:creationId xmlns:a16="http://schemas.microsoft.com/office/drawing/2014/main" id="{4F0F7CB2-2A09-4FFA-84BA-AAA7E7CA9F81}"/>
+                <a16:creationId xmlns:a16="http://schemas.microsoft.com/office/drawing/2014/main" id="{F3808D7B-05B0-4899-86BA-8FCD7DFF3A99}"/>
               </a:ext>
             </a:extLst>
           </p:cNvPr>
@@ -11108,7 +11108,7 @@
           <p:cNvPr id="15" name="metric-caption-timely signal anchors required">
             <a:extLst xmlns:a="http://schemas.openxmlformats.org/drawingml/2006/main">
               <a:ext uri="{FF2B5EF4-FFF2-40B4-BE49-F238E27FC236}">
-                <a16:creationId xmlns:a16="http://schemas.microsoft.com/office/drawing/2014/main" id="{BFB09355-EFD3-439C-82B0-8FB2F54B876B}"/>
+                <a16:creationId xmlns:a16="http://schemas.microsoft.com/office/drawing/2014/main" id="{7A86783B-6107-4828-A484-CB293479538C}"/>
               </a:ext>
             </a:extLst>
           </p:cNvPr>
@@ -11170,7 +11170,7 @@
           <p:cNvPr id="16" name="metric-reconciled settlements required">
             <a:extLst xmlns:a="http://schemas.openxmlformats.org/drawingml/2006/main">
               <a:ext uri="{FF2B5EF4-FFF2-40B4-BE49-F238E27FC236}">
-                <a16:creationId xmlns:a16="http://schemas.microsoft.com/office/drawing/2014/main" id="{70C7FC3D-329C-4359-B692-FAEE78487671}"/>
+                <a16:creationId xmlns:a16="http://schemas.microsoft.com/office/drawing/2014/main" id="{9E7B3311-BCE3-46B5-ABF1-8BD4AC3E317F}"/>
               </a:ext>
             </a:extLst>
           </p:cNvPr>
@@ -11232,7 +11232,7 @@
           <p:cNvPr id="17" name="metric-caption-reconciled settlements required">
             <a:extLst xmlns:a="http://schemas.openxmlformats.org/drawingml/2006/main">
               <a:ext uri="{FF2B5EF4-FFF2-40B4-BE49-F238E27FC236}">
-                <a16:creationId xmlns:a16="http://schemas.microsoft.com/office/drawing/2014/main" id="{D6B29D88-781D-4E05-B15C-4ABE2E0A38E9}"/>
+                <a16:creationId xmlns:a16="http://schemas.microsoft.com/office/drawing/2014/main" id="{43C443A3-B990-4AEC-83DF-C7F4E9D2DCE2}"/>
               </a:ext>
             </a:extLst>
           </p:cNvPr>
@@ -11294,7 +11294,7 @@
           <p:cNvPr id="18" name="attempt-gate">
             <a:extLst xmlns:a="http://schemas.openxmlformats.org/drawingml/2006/main">
               <a:ext uri="{FF2B5EF4-FFF2-40B4-BE49-F238E27FC236}">
-                <a16:creationId xmlns:a16="http://schemas.microsoft.com/office/drawing/2014/main" id="{E5F40564-96E1-4E2F-8FAB-FC860B905BFB}"/>
+                <a16:creationId xmlns:a16="http://schemas.microsoft.com/office/drawing/2014/main" id="{30097F05-6D04-4EC5-AA09-9BCA7950AAFF}"/>
               </a:ext>
             </a:extLst>
           </p:cNvPr>
@@ -11327,7 +11327,7 @@
           <p:cNvPr id="19" name="attempt-gate-copy">
             <a:extLst xmlns:a="http://schemas.openxmlformats.org/drawingml/2006/main">
               <a:ext uri="{FF2B5EF4-FFF2-40B4-BE49-F238E27FC236}">
-                <a16:creationId xmlns:a16="http://schemas.microsoft.com/office/drawing/2014/main" id="{3F0E95D9-118F-47F5-9BDB-F8ECEEBAE623}"/>
+                <a16:creationId xmlns:a16="http://schemas.microsoft.com/office/drawing/2014/main" id="{FB63EABB-AB7B-4EF2-9FEB-63AB2ACC7E41}"/>
               </a:ext>
             </a:extLst>
           </p:cNvPr>
@@ -11416,7 +11416,7 @@
           <p:cNvPr id="20" name="attempt-boundary">
             <a:extLst xmlns:a="http://schemas.openxmlformats.org/drawingml/2006/main">
               <a:ext uri="{FF2B5EF4-FFF2-40B4-BE49-F238E27FC236}">
-                <a16:creationId xmlns:a16="http://schemas.microsoft.com/office/drawing/2014/main" id="{DEA4052A-0B14-4781-BA7C-583C5349919D}"/>
+                <a16:creationId xmlns:a16="http://schemas.microsoft.com/office/drawing/2014/main" id="{20B72F92-15F5-4E2E-A8E4-9AA3322E6114}"/>
               </a:ext>
             </a:extLst>
           </p:cNvPr>
@@ -11476,7 +11476,7 @@
     </p:spTree>
     <p:extLst>
       <p:ext uri="{BB962C8B-B14F-4D97-AF65-F5344CB8AC3E}">
-        <p14:creationId xmlns:p14="http://schemas.microsoft.com/office/powerpoint/2010/main" val="549617202"/>
+        <p14:creationId xmlns:p14="http://schemas.microsoft.com/office/powerpoint/2010/main" val="1207789960"/>
       </p:ext>
     </p:extLst>
   </p:cSld>
@@ -11507,7 +11507,7 @@
           <p:cNvPr id="19" name="label-Why Finly-58-32">
             <a:extLst xmlns:a="http://schemas.openxmlformats.org/drawingml/2006/main">
               <a:ext uri="{FF2B5EF4-FFF2-40B4-BE49-F238E27FC236}">
-                <a16:creationId xmlns:a16="http://schemas.microsoft.com/office/drawing/2014/main" id="{5FDA8259-1704-4332-A7D4-CF203FBB05FA}"/>
+                <a16:creationId xmlns:a16="http://schemas.microsoft.com/office/drawing/2014/main" id="{AF51A8D4-1333-46A3-8C5B-8378621B927E}"/>
               </a:ext>
             </a:extLst>
           </p:cNvPr>
@@ -11569,7 +11569,7 @@
           <p:cNvPr id="2" name="slide-title-9">
             <a:extLst xmlns:a="http://schemas.openxmlformats.org/drawingml/2006/main">
               <a:ext uri="{FF2B5EF4-FFF2-40B4-BE49-F238E27FC236}">
-                <a16:creationId xmlns:a16="http://schemas.microsoft.com/office/drawing/2014/main" id="{BE7AE067-0382-4A05-BA0B-12235556E54F}"/>
+                <a16:creationId xmlns:a16="http://schemas.microsoft.com/office/drawing/2014/main" id="{BD2B0582-AD28-4ED6-B290-C0F529978B66}"/>
               </a:ext>
             </a:extLst>
           </p:cNvPr>
@@ -11631,7 +11631,7 @@
           <p:cNvPr id="3" name="">
             <a:extLst xmlns:a="http://schemas.openxmlformats.org/drawingml/2006/main">
               <a:ext uri="{FF2B5EF4-FFF2-40B4-BE49-F238E27FC236}">
-                <a16:creationId xmlns:a16="http://schemas.microsoft.com/office/drawing/2014/main" id="{5018D6A6-BE63-4E79-896B-8BF74889118C}"/>
+                <a16:creationId xmlns:a16="http://schemas.microsoft.com/office/drawing/2014/main" id="{D42A2D4A-BBA8-4EB6-B401-1B56159BB16F}"/>
               </a:ext>
             </a:extLst>
           </p:cNvPr>
@@ -11662,7 +11662,7 @@
           <p:cNvPr id="4" name="footer-9">
             <a:extLst xmlns:a="http://schemas.openxmlformats.org/drawingml/2006/main">
               <a:ext uri="{FF2B5EF4-FFF2-40B4-BE49-F238E27FC236}">
-                <a16:creationId xmlns:a16="http://schemas.microsoft.com/office/drawing/2014/main" id="{18718E31-6565-4B7D-8051-FF194493AE79}"/>
+                <a16:creationId xmlns:a16="http://schemas.microsoft.com/office/drawing/2014/main" id="{D5239F40-3BC0-4566-81E1-F3FAC752CA10}"/>
               </a:ext>
             </a:extLst>
           </p:cNvPr>
@@ -11724,7 +11724,7 @@
           <p:cNvPr id="5" name="page-9">
             <a:extLst xmlns:a="http://schemas.openxmlformats.org/drawingml/2006/main">
               <a:ext uri="{FF2B5EF4-FFF2-40B4-BE49-F238E27FC236}">
-                <a16:creationId xmlns:a16="http://schemas.microsoft.com/office/drawing/2014/main" id="{1E289DE8-7B40-44E8-8772-3E6904D1B43D}"/>
+                <a16:creationId xmlns:a16="http://schemas.microsoft.com/office/drawing/2014/main" id="{B780CA56-943C-4899-8E59-0F50C8F858E1}"/>
               </a:ext>
             </a:extLst>
           </p:cNvPr>
@@ -11786,7 +11786,7 @@
           <p:cNvPr id="6" name="label-P&amp;L evidence-58-220">
             <a:extLst xmlns:a="http://schemas.openxmlformats.org/drawingml/2006/main">
               <a:ext uri="{FF2B5EF4-FFF2-40B4-BE49-F238E27FC236}">
-                <a16:creationId xmlns:a16="http://schemas.microsoft.com/office/drawing/2014/main" id="{A6C678AC-D955-47AD-9A7B-6A1D5908479E}"/>
+                <a16:creationId xmlns:a16="http://schemas.microsoft.com/office/drawing/2014/main" id="{7C12A42D-4E7C-416F-9A9C-2CAFAA1EA3E1}"/>
               </a:ext>
             </a:extLst>
           </p:cNvPr>
@@ -11848,7 +11848,7 @@
           <p:cNvPr id="7" name="">
             <a:extLst xmlns:a="http://schemas.openxmlformats.org/drawingml/2006/main">
               <a:ext uri="{FF2B5EF4-FFF2-40B4-BE49-F238E27FC236}">
-                <a16:creationId xmlns:a16="http://schemas.microsoft.com/office/drawing/2014/main" id="{1B1C9396-680B-41DE-A06A-2B5315390E39}"/>
+                <a16:creationId xmlns:a16="http://schemas.microsoft.com/office/drawing/2014/main" id="{35B052C1-FF4D-4B30-BEFC-AAA773A405EE}"/>
               </a:ext>
             </a:extLst>
           </p:cNvPr>
@@ -11879,7 +11879,7 @@
           <p:cNvPr id="8" name="criterion-0">
             <a:extLst xmlns:a="http://schemas.openxmlformats.org/drawingml/2006/main">
               <a:ext uri="{FF2B5EF4-FFF2-40B4-BE49-F238E27FC236}">
-                <a16:creationId xmlns:a16="http://schemas.microsoft.com/office/drawing/2014/main" id="{154458E0-5AD9-46F7-95C4-AACFA6D3B22B}"/>
+                <a16:creationId xmlns:a16="http://schemas.microsoft.com/office/drawing/2014/main" id="{B9225463-DA23-4473-93E1-E13FCB663CA2}"/>
               </a:ext>
             </a:extLst>
           </p:cNvPr>
@@ -11941,7 +11941,7 @@
           <p:cNvPr id="9" name="label-Technology-350-220">
             <a:extLst xmlns:a="http://schemas.openxmlformats.org/drawingml/2006/main">
               <a:ext uri="{FF2B5EF4-FFF2-40B4-BE49-F238E27FC236}">
-                <a16:creationId xmlns:a16="http://schemas.microsoft.com/office/drawing/2014/main" id="{44C21CE5-0FCF-44F8-9E12-59022F7209F8}"/>
+                <a16:creationId xmlns:a16="http://schemas.microsoft.com/office/drawing/2014/main" id="{256C4D86-D7C0-4CE6-9695-BD3B5400F23C}"/>
               </a:ext>
             </a:extLst>
           </p:cNvPr>
@@ -12003,7 +12003,7 @@
           <p:cNvPr id="10" name="">
             <a:extLst xmlns:a="http://schemas.openxmlformats.org/drawingml/2006/main">
               <a:ext uri="{FF2B5EF4-FFF2-40B4-BE49-F238E27FC236}">
-                <a16:creationId xmlns:a16="http://schemas.microsoft.com/office/drawing/2014/main" id="{8FC60817-B107-4AD8-98B2-6FACB9915626}"/>
+                <a16:creationId xmlns:a16="http://schemas.microsoft.com/office/drawing/2014/main" id="{3D1BB092-0A09-4491-8D0E-A9B7C56540B3}"/>
               </a:ext>
             </a:extLst>
           </p:cNvPr>
@@ -12034,7 +12034,7 @@
           <p:cNvPr id="11" name="criterion-1">
             <a:extLst xmlns:a="http://schemas.openxmlformats.org/drawingml/2006/main">
               <a:ext uri="{FF2B5EF4-FFF2-40B4-BE49-F238E27FC236}">
-                <a16:creationId xmlns:a16="http://schemas.microsoft.com/office/drawing/2014/main" id="{BDC099A2-AFA3-4B3E-8518-1A03D110D2B9}"/>
+                <a16:creationId xmlns:a16="http://schemas.microsoft.com/office/drawing/2014/main" id="{AA00CAF5-8E4A-4BB8-8047-B2135730FBD9}"/>
               </a:ext>
             </a:extLst>
           </p:cNvPr>
@@ -12096,7 +12096,7 @@
           <p:cNvPr id="12" name="label-Originality-642-220">
             <a:extLst xmlns:a="http://schemas.openxmlformats.org/drawingml/2006/main">
               <a:ext uri="{FF2B5EF4-FFF2-40B4-BE49-F238E27FC236}">
-                <a16:creationId xmlns:a16="http://schemas.microsoft.com/office/drawing/2014/main" id="{34B82091-7EB6-4413-8B82-365F6F127BAA}"/>
+                <a16:creationId xmlns:a16="http://schemas.microsoft.com/office/drawing/2014/main" id="{45842F15-702B-4340-B3D1-7151BF89AEFE}"/>
               </a:ext>
             </a:extLst>
           </p:cNvPr>
@@ -12158,7 +12158,7 @@
           <p:cNvPr id="13" name="">
             <a:extLst xmlns:a="http://schemas.openxmlformats.org/drawingml/2006/main">
               <a:ext uri="{FF2B5EF4-FFF2-40B4-BE49-F238E27FC236}">
-                <a16:creationId xmlns:a16="http://schemas.microsoft.com/office/drawing/2014/main" id="{EBF5D8F9-4954-45E2-B0EC-338DA1A858DA}"/>
+                <a16:creationId xmlns:a16="http://schemas.microsoft.com/office/drawing/2014/main" id="{72B6925F-EB7E-47F0-BC87-BB93BE9E38E2}"/>
               </a:ext>
             </a:extLst>
           </p:cNvPr>
@@ -12189,7 +12189,7 @@
           <p:cNvPr id="14" name="criterion-2">
             <a:extLst xmlns:a="http://schemas.openxmlformats.org/drawingml/2006/main">
               <a:ext uri="{FF2B5EF4-FFF2-40B4-BE49-F238E27FC236}">
-                <a16:creationId xmlns:a16="http://schemas.microsoft.com/office/drawing/2014/main" id="{4E6A31F1-EDDF-43DC-9329-8ADD1AAC1DEA}"/>
+                <a16:creationId xmlns:a16="http://schemas.microsoft.com/office/drawing/2014/main" id="{97B9F06E-8B70-42B9-92EE-7CB2045EF756}"/>
               </a:ext>
             </a:extLst>
           </p:cNvPr>
@@ -12251,7 +12251,7 @@
           <p:cNvPr id="15" name="label-Forward proof-934-220">
             <a:extLst xmlns:a="http://schemas.openxmlformats.org/drawingml/2006/main">
               <a:ext uri="{FF2B5EF4-FFF2-40B4-BE49-F238E27FC236}">
-                <a16:creationId xmlns:a16="http://schemas.microsoft.com/office/drawing/2014/main" id="{222C17A2-7B6F-49A2-91C4-C449087EF793}"/>
+                <a16:creationId xmlns:a16="http://schemas.microsoft.com/office/drawing/2014/main" id="{EA5F4AA3-B32B-4EDB-A2D6-0C9F3ACDC7D1}"/>
               </a:ext>
             </a:extLst>
           </p:cNvPr>
@@ -12313,7 +12313,7 @@
           <p:cNvPr id="16" name="">
             <a:extLst xmlns:a="http://schemas.openxmlformats.org/drawingml/2006/main">
               <a:ext uri="{FF2B5EF4-FFF2-40B4-BE49-F238E27FC236}">
-                <a16:creationId xmlns:a16="http://schemas.microsoft.com/office/drawing/2014/main" id="{FB928324-324F-43E0-9398-FF54EAEE19B6}"/>
+                <a16:creationId xmlns:a16="http://schemas.microsoft.com/office/drawing/2014/main" id="{B90143B9-2D5A-43FC-94D8-28453DD626E7}"/>
               </a:ext>
             </a:extLst>
           </p:cNvPr>
@@ -12344,7 +12344,7 @@
           <p:cNvPr id="17" name="criterion-3">
             <a:extLst xmlns:a="http://schemas.openxmlformats.org/drawingml/2006/main">
               <a:ext uri="{FF2B5EF4-FFF2-40B4-BE49-F238E27FC236}">
-                <a16:creationId xmlns:a16="http://schemas.microsoft.com/office/drawing/2014/main" id="{676647C9-8189-46D9-B5A9-38C41C867301}"/>
+                <a16:creationId xmlns:a16="http://schemas.microsoft.com/office/drawing/2014/main" id="{C322C23B-406F-40A1-B5EA-72A2BE3F8B40}"/>
               </a:ext>
             </a:extLst>
           </p:cNvPr>
@@ -12406,7 +12406,7 @@
           <p:cNvPr id="18" name="closing-line">
             <a:extLst xmlns:a="http://schemas.openxmlformats.org/drawingml/2006/main">
               <a:ext uri="{FF2B5EF4-FFF2-40B4-BE49-F238E27FC236}">
-                <a16:creationId xmlns:a16="http://schemas.microsoft.com/office/drawing/2014/main" id="{FE052052-272F-4BB0-8CF6-00DC50A36C43}"/>
+                <a16:creationId xmlns:a16="http://schemas.microsoft.com/office/drawing/2014/main" id="{FDCEE1D7-D104-4C34-A622-0181A2709E1B}"/>
               </a:ext>
             </a:extLst>
           </p:cNvPr>
@@ -12466,7 +12466,7 @@
     </p:spTree>
     <p:extLst>
       <p:ext uri="{BB962C8B-B14F-4D97-AF65-F5344CB8AC3E}">
-        <p14:creationId xmlns:p14="http://schemas.microsoft.com/office/powerpoint/2010/main" val="233509038"/>
+        <p14:creationId xmlns:p14="http://schemas.microsoft.com/office/powerpoint/2010/main" val="609388274"/>
       </p:ext>
     </p:extLst>
   </p:cSld>
@@ -12474,9 +12474,9 @@
 </file>
 
 <file path=ppt/theme/theme1.xml><?xml version="1.0" encoding="utf-8"?>
-<a:theme xmlns:a="http://schemas.openxmlformats.org/drawingml/2006/main" name="ChatGPT">
+<a:theme xmlns:a="http://schemas.openxmlformats.org/drawingml/2006/main" name="Finly">
   <a:themeElements>
-    <a:clrScheme name="ChatGPT">
+    <a:clrScheme name="Finly">
       <a:dk1>
         <a:srgbClr val="000000"/>
       </a:dk1>
@@ -12526,7 +12526,7 @@
         <a:cs typeface="Calibri"/>
       </a:minorFont>
     </a:fontScheme>
-    <a:fmtScheme name="ChatGPT">
+    <a:fmtScheme name="Finly">
       <a:fillStyleLst>
         <a:solidFill>
           <a:schemeClr val="phClr"/>

</xml_diff>

<commit_message>
Rewrite pitch in plain founder language
</commit_message>
<xml_diff>
--- a/public/judge/Finly_Consulting_Deck.pptx
+++ b/public/judge/Finly_Consulting_Deck.pptx
@@ -2,21 +2,21 @@
 <file path=ppt/presentation.xml><?xml version="1.0" encoding="utf-8"?>
 <p:presentation xmlns:p="http://schemas.openxmlformats.org/presentationml/2006/main">
   <p:sldMasterIdLst>
-    <p:sldMasterId xmlns:r="http://schemas.openxmlformats.org/officeDocument/2006/relationships" id="2147483648" r:id="Re6dc8a320cb347e3"/>
+    <p:sldMasterId xmlns:r="http://schemas.openxmlformats.org/officeDocument/2006/relationships" id="2147483648" r:id="R72d63591dea94714"/>
   </p:sldMasterIdLst>
   <p:notesMasterIdLst>
-    <p:notesMasterId xmlns:r="http://schemas.openxmlformats.org/officeDocument/2006/relationships" r:id="Rf7d0209d95fc48a4"/>
+    <p:notesMasterId xmlns:r="http://schemas.openxmlformats.org/officeDocument/2006/relationships" r:id="Rc396dc0225d34e1e"/>
   </p:notesMasterIdLst>
   <p:sldIdLst>
-    <p:sldId xmlns:r="http://schemas.openxmlformats.org/officeDocument/2006/relationships" id="256" r:id="Ra19e7af8ddbb49c2"/>
-    <p:sldId xmlns:r="http://schemas.openxmlformats.org/officeDocument/2006/relationships" id="257" r:id="Rdd6cc2e205944204"/>
-    <p:sldId xmlns:r="http://schemas.openxmlformats.org/officeDocument/2006/relationships" id="258" r:id="R84027fd9d8cf448a"/>
-    <p:sldId xmlns:r="http://schemas.openxmlformats.org/officeDocument/2006/relationships" id="259" r:id="R184a5e472baa43cb"/>
-    <p:sldId xmlns:r="http://schemas.openxmlformats.org/officeDocument/2006/relationships" id="260" r:id="Rd33424ff157b4392"/>
-    <p:sldId xmlns:r="http://schemas.openxmlformats.org/officeDocument/2006/relationships" id="261" r:id="R211f8d2d19be49d9"/>
-    <p:sldId xmlns:r="http://schemas.openxmlformats.org/officeDocument/2006/relationships" id="262" r:id="R5d289b2ce49a4896"/>
-    <p:sldId xmlns:r="http://schemas.openxmlformats.org/officeDocument/2006/relationships" id="263" r:id="Re73d89f98cea4360"/>
-    <p:sldId xmlns:r="http://schemas.openxmlformats.org/officeDocument/2006/relationships" id="264" r:id="Rac9f08d949a0413b"/>
+    <p:sldId xmlns:r="http://schemas.openxmlformats.org/officeDocument/2006/relationships" id="256" r:id="Ra55aac082ff34ad6"/>
+    <p:sldId xmlns:r="http://schemas.openxmlformats.org/officeDocument/2006/relationships" id="257" r:id="R20364cc8cef7408d"/>
+    <p:sldId xmlns:r="http://schemas.openxmlformats.org/officeDocument/2006/relationships" id="258" r:id="Rb9476c1cdd8a42de"/>
+    <p:sldId xmlns:r="http://schemas.openxmlformats.org/officeDocument/2006/relationships" id="259" r:id="Ra912013588cf4256"/>
+    <p:sldId xmlns:r="http://schemas.openxmlformats.org/officeDocument/2006/relationships" id="260" r:id="R2e4b09a6f57244d9"/>
+    <p:sldId xmlns:r="http://schemas.openxmlformats.org/officeDocument/2006/relationships" id="261" r:id="R39f938cb49f24f7e"/>
+    <p:sldId xmlns:r="http://schemas.openxmlformats.org/officeDocument/2006/relationships" id="262" r:id="R36d01063f3a1411a"/>
+    <p:sldId xmlns:r="http://schemas.openxmlformats.org/officeDocument/2006/relationships" id="263" r:id="R0a677ac069e2459a"/>
+    <p:sldId xmlns:r="http://schemas.openxmlformats.org/officeDocument/2006/relationships" id="264" r:id="R9a84bc616eab4356"/>
   </p:sldIdLst>
   <p:sldSz cx="12192000" cy="6858000"/>
   <p:notesSz cx="6858000" cy="9144000"/>
@@ -455,12 +455,17 @@
           </a:p>
           <a:p xmlns:a="http://schemas.openxmlformats.org/drawingml/2006/main">
             <a:r>
-              <a:t>- Quantitative release gate: https://github.com/owlsowo/finly-bot/blob/c953d74444bd0cee1bc884701d98ff510cc4db80/research/output/quantitative_release_gate.json</a:t>
-            </a:r>
-          </a:p>
-          <a:p xmlns:a="http://schemas.openxmlformats.org/drawingml/2006/main">
-            <a:r>
-              <a:t>- G4 was rejected and not promoted; the retrospective result is not a forecast or validation claim.</a:t>
+              <a:t>- Historical evidence: https://owlsowo.github.io/finly-bot/data/g4_wealth_drawdown.json</a:t>
+            </a:r>
+          </a:p>
+          <a:p xmlns:a="http://schemas.openxmlformats.org/drawingml/2006/main">
+            <a:r>
+              <a:t>- Sanitized live account: https://owlsowo.github.io/finly-bot/data/competition_live.json</a:t>
+            </a:r>
+          </a:p>
+          <a:p xmlns:a="http://schemas.openxmlformats.org/drawingml/2006/main">
+            <a:r>
+              <a:t>- Historical simulation with modeled 5 bp one-way costs; not live performance.</a:t>
             </a:r>
           </a:p>
           <a:p xmlns:a="http://schemas.openxmlformats.org/drawingml/2006/main">
@@ -540,12 +545,17 @@
           </a:p>
           <a:p xmlns:a="http://schemas.openxmlformats.org/drawingml/2006/main">
             <a:r>
-              <a:t>- Locked release decision and G4 statistics: https://github.com/owlsowo/finly-bot/blob/c953d74444bd0cee1bc884701d98ff510cc4db80/research/output/quantitative_release_gate.json</a:t>
-            </a:r>
-          </a:p>
-          <a:p xmlns:a="http://schemas.openxmlformats.org/drawingml/2006/main">
-            <a:r>
-              <a:t>- Consumed, post-selected ETF replay with modeled 5 bp one-way costs; not options P&amp;L, validation, promotion, or a forecast.</a:t>
+              <a:t>- Historical series: https://owlsowo.github.io/finly-bot/data/g4_wealth_drawdown.json</a:t>
+            </a:r>
+          </a:p>
+          <a:p xmlns:a="http://schemas.openxmlformats.org/drawingml/2006/main">
+            <a:r>
+              <a:t>- Method and evidence labels: https://owlsowo.github.io/finly-bot/data/quantitative_release_gate.json</a:t>
+            </a:r>
+          </a:p>
+          <a:p xmlns:a="http://schemas.openxmlformats.org/drawingml/2006/main">
+            <a:r>
+              <a:t>- Historical simulation; modeled 5 bp one-way costs; not broker P&amp;L or a forecast.</a:t>
             </a:r>
           </a:p>
         </p:txBody>
@@ -620,12 +630,12 @@
           </a:p>
           <a:p xmlns:a="http://schemas.openxmlformats.org/drawingml/2006/main">
             <a:r>
-              <a:t>- Promotion decision, Deflated Sharpe probability, and familywise p-value: https://github.com/owlsowo/finly-bot/blob/c953d74444bd0cee1bc884701d98ff510cc4db80/research/output/quantitative_release_gate.json</a:t>
-            </a:r>
-          </a:p>
-          <a:p xmlns:a="http://schemas.openxmlformats.org/drawingml/2006/main">
-            <a:r>
-              <a:t>- G4 is rejected, not promoted, and cannot support future profitability or market-superiority claims.</a:t>
+              <a:t>- Decision trace: https://owlsowo.github.io/finly-bot/data/llama_decision_trace.json</a:t>
+            </a:r>
+          </a:p>
+          <a:p xmlns:a="http://schemas.openxmlformats.org/drawingml/2006/main">
+            <a:r>
+              <a:t>- Compiled options receipt: https://owlsowo.github.io/finly-bot/data/latest_receipt.json</a:t>
             </a:r>
           </a:p>
         </p:txBody>
@@ -700,17 +710,17 @@
           </a:p>
           <a:p xmlns:a="http://schemas.openxmlformats.org/drawingml/2006/main">
             <a:r>
-              <a:t>- Production-v1 release claim: https://github.com/owlsowo/finly-bot/blob/c953d74444bd0cee1bc884701d98ff510cc4db80/research/output/quantitative_release_gate.json</a:t>
-            </a:r>
-          </a:p>
-          <a:p xmlns:a="http://schemas.openxmlformats.org/drawingml/2006/main">
-            <a:r>
-              <a:t>- Modeled next-open execution-realism ledger: https://github.com/owlsowo/finly-bot/blob/c953d74444bd0cee1bc884701d98ff510cc4db80/research/output/equity_execution_realism.json</a:t>
-            </a:r>
-          </a:p>
-          <a:p xmlns:a="http://schemas.openxmlformats.org/drawingml/2006/main">
-            <a:r>
-              <a:t>- This is consumed retrospective execution-mechanics evidence, not broker fills, options P&amp;L, alpha, or a forecast.</a:t>
+              <a:t>- Source-backed replay: https://owlsowo.github.io/finly-bot/data/attempt150_public_evidence.json</a:t>
+            </a:r>
+          </a:p>
+          <a:p xmlns:a="http://schemas.openxmlformats.org/drawingml/2006/main">
+            <a:r>
+              <a:t>- Official data source: https://mba.tuck.dartmouth.edu/pages/faculty/ken.french/ftp/10_Industry_Portfolios_daily_CSV.zip</a:t>
+            </a:r>
+          </a:p>
+          <a:p xmlns:a="http://schemas.openxmlformats.org/drawingml/2006/main">
+            <a:r>
+              <a:t>- Industry-proxy historical stress test; separate from live broker performance.</a:t>
             </a:r>
           </a:p>
         </p:txBody>
@@ -785,17 +795,17 @@
           </a:p>
           <a:p xmlns:a="http://schemas.openxmlformats.org/drawingml/2006/main">
             <a:r>
-              <a:t>- Project-owned authority trace: https://github.com/owlsowo/finly-bot/blob/c953d74444bd0cee1bc884701d98ff510cc4db80/public/data/llama_decision_trace.json</a:t>
-            </a:r>
-          </a:p>
-          <a:p xmlns:a="http://schemas.openxmlformats.org/drawingml/2006/main">
-            <a:r>
-              <a:t>- Project-owned compiled-decision record: https://github.com/owlsowo/finly-bot/blob/c953d74444bd0cee1bc884701d98ff510cc4db80/public/data/latest_receipt.json</a:t>
-            </a:r>
-          </a:p>
-          <a:p xmlns:a="http://schemas.openxmlformats.org/drawingml/2006/main">
-            <a:r>
-              <a:t>- The cited fixtures are synthetic research evidence; no broker mutation is authorized.</a:t>
+              <a:t>- Model trace: https://owlsowo.github.io/finly-bot/data/llama_decision_trace.json</a:t>
+            </a:r>
+          </a:p>
+          <a:p xmlns:a="http://schemas.openxmlformats.org/drawingml/2006/main">
+            <a:r>
+              <a:t>- Positive checked receipt: https://owlsowo.github.io/finly-bot/data/latest_receipt.json</a:t>
+            </a:r>
+          </a:p>
+          <a:p xmlns:a="http://schemas.openxmlformats.org/drawingml/2006/main">
+            <a:r>
+              <a:t>- Conflict receipt: https://owlsowo.github.io/finly-bot/data/no_trade_receipt.json</a:t>
             </a:r>
           </a:p>
         </p:txBody>
@@ -870,12 +880,17 @@
           </a:p>
           <a:p xmlns:a="http://schemas.openxmlformats.org/drawingml/2006/main">
             <a:r>
-              <a:t>- Quantitative release gate behind the visible evidence classes: https://github.com/owlsowo/finly-bot/blob/c953d74444bd0cee1bc884701d98ff510cc4db80/research/output/quantitative_release_gate.json</a:t>
-            </a:r>
-          </a:p>
-          <a:p xmlns:a="http://schemas.openxmlformats.org/drawingml/2006/main">
-            <a:r>
-              <a:t>- Product capture is a project-owned screenshot; it is evidence of the interface, not market performance.</a:t>
+              <a:t>- Sanitized live account: https://owlsowo.github.io/finly-bot/data/competition_live.json</a:t>
+            </a:r>
+          </a:p>
+          <a:p xmlns:a="http://schemas.openxmlformats.org/drawingml/2006/main">
+            <a:r>
+              <a:t>- Public dashboard: https://owlsowo.github.io/finly-bot/#live</a:t>
+            </a:r>
+          </a:p>
+          <a:p xmlns:a="http://schemas.openxmlformats.org/drawingml/2006/main">
+            <a:r>
+              <a:t>- Screenshot is project-owned and records paper-account state, not a live-return claim.</a:t>
             </a:r>
           </a:p>
         </p:txBody>
@@ -950,7 +965,17 @@
           </a:p>
           <a:p xmlns:a="http://schemas.openxmlformats.org/drawingml/2006/main">
             <a:r>
-              <a:t>- Evidence classes, retrospective limitations, and future-only status: https://github.com/owlsowo/finly-bot/blob/c953d74444bd0cee1bc884701d98ff510cc4db80/research/output/quantitative_release_gate.json</a:t>
+              <a:t>- Positive options receipt: https://owlsowo.github.io/finly-bot/data/latest_receipt.json</a:t>
+            </a:r>
+          </a:p>
+          <a:p xmlns:a="http://schemas.openxmlformats.org/drawingml/2006/main">
+            <a:r>
+              <a:t>- Conflict receipt: https://owlsowo.github.io/finly-bot/data/no_trade_receipt.json</a:t>
+            </a:r>
+          </a:p>
+          <a:p xmlns:a="http://schemas.openxmlformats.org/drawingml/2006/main">
+            <a:r>
+              <a:t>- The checked options fixture is synthetic paper-trading evidence, not realized options P&amp;L.</a:t>
             </a:r>
           </a:p>
         </p:txBody>
@@ -1025,27 +1050,22 @@
           </a:p>
           <a:p xmlns:a="http://schemas.openxmlformats.org/drawingml/2006/main">
             <a:r>
-              <a:t>- Attempt 115 protocol: https://github.com/owlsowo/finly-bot/blob/c953d74444bd0cee1bc884701d98ff510cc4db80/research/downside_semivolatility_challenger_protocol.json</a:t>
-            </a:r>
-          </a:p>
-          <a:p xmlns:a="http://schemas.openxmlformats.org/drawingml/2006/main">
-            <a:r>
-              <a:t>- Attempt 115 public receipt: https://github.com/owlsowo/finly-bot/blob/c953d74444bd0cee1bc884701d98ff510cc4db80/research/prospective_attempt115/publication_receipts/4dd7720d25198702013ab10e582b37004515bed5e4466a56eca89192559d2cd9.json</a:t>
-            </a:r>
-          </a:p>
-          <a:p xmlns:a="http://schemas.openxmlformats.org/drawingml/2006/main">
-            <a:r>
-              <a:t>- Attempt 116 protocol: https://github.com/owlsowo/finly-bot/blob/c953d74444bd0cee1bc884701d98ff510cc4db80/research/prospective_attempt116/protocol.json</a:t>
-            </a:r>
-          </a:p>
-          <a:p xmlns:a="http://schemas.openxmlformats.org/drawingml/2006/main">
-            <a:r>
-              <a:t>- Attempt 116 public receipt: https://github.com/owlsowo/finly-bot/blob/c953d74444bd0cee1bc884701d98ff510cc4db80/research/prospective_attempt116/publication_receipts/934e52a583893e2720a0962195efd56b5f4b2a0554a1b8f8dfa9ab5951191362.json</a:t>
-            </a:r>
-          </a:p>
-          <a:p xmlns:a="http://schemas.openxmlformats.org/drawingml/2006/main">
-            <a:r>
-              <a:t>- Zero-outcome boundary as of 2026-08-30T08:10:52.000Z: https://github.com/owlsowo/finly-bot/blob/c953d74444bd0cee1bc884701d98ff510cc4db80/research/output/quantitative_release_gate.json</a:t>
+              <a:t>- Cloud runner documentation: https://github.com/owlsowo/finly-bot/blob/main/docs/CLOUD_RUNNER.md</a:t>
+            </a:r>
+          </a:p>
+          <a:p xmlns:a="http://schemas.openxmlformats.org/drawingml/2006/main">
+            <a:r>
+              <a:t>- Public repository and automated tests: https://github.com/owlsowo/finly-bot</a:t>
+            </a:r>
+          </a:p>
+          <a:p xmlns:a="http://schemas.openxmlformats.org/drawingml/2006/main">
+            <a:r>
+              <a:t>- Verified test run: https://github.com/owlsowo/finly-bot/actions/runs/33369848292</a:t>
+            </a:r>
+          </a:p>
+          <a:p xmlns:a="http://schemas.openxmlformats.org/drawingml/2006/main">
+            <a:r>
+              <a:t>- Sanitized account record: https://owlsowo.github.io/finly-bot/data/competition_live.json</a:t>
             </a:r>
           </a:p>
         </p:txBody>
@@ -1120,12 +1140,22 @@
           </a:p>
           <a:p xmlns:a="http://schemas.openxmlformats.org/drawingml/2006/main">
             <a:r>
-              <a:t>- All quantitative statements and limitations: https://github.com/owlsowo/finly-bot/blob/c953d74444bd0cee1bc884701d98ff510cc4db80/research/output/quantitative_release_gate.json</a:t>
-            </a:r>
-          </a:p>
-          <a:p xmlns:a="http://schemas.openxmlformats.org/drawingml/2006/main">
-            <a:r>
-              <a:t>- No cross-project performance comparison, future-profit claim, verified options P&amp;L, or broker fill is asserted.</a:t>
+              <a:t>- Live product: https://owlsowo.github.io/finly-bot/</a:t>
+            </a:r>
+          </a:p>
+          <a:p xmlns:a="http://schemas.openxmlformats.org/drawingml/2006/main">
+            <a:r>
+              <a:t>- Repository: https://github.com/owlsowo/finly-bot</a:t>
+            </a:r>
+          </a:p>
+          <a:p xmlns:a="http://schemas.openxmlformats.org/drawingml/2006/main">
+            <a:r>
+              <a:t>- Contact: mailto:bwen412@brandeis.edu</a:t>
+            </a:r>
+          </a:p>
+          <a:p xmlns:a="http://schemas.openxmlformats.org/drawingml/2006/main">
+            <a:r>
+              <a:t>- Historical metrics are simulations with modeled costs; live paper-account results are labeled separately.</a:t>
             </a:r>
           </a:p>
         </p:txBody>
@@ -1193,7 +1223,7 @@
   </p:cSld>
   <p:clrMap bg1="lt1" tx1="dk1" bg2="lt2" tx2="dk2" accent1="accent1" accent2="accent2" accent3="accent3" accent4="accent4" accent5="accent5" accent6="accent6" hlink="hlink" folHlink="folHlink"/>
   <p:sldLayoutIdLst>
-    <p:sldLayoutId xmlns:r="http://schemas.openxmlformats.org/officeDocument/2006/relationships" id="2147483649" r:id="R80a6f8482dba4656"/>
+    <p:sldLayoutId xmlns:r="http://schemas.openxmlformats.org/officeDocument/2006/relationships" id="2147483649" r:id="R2a0177878dc94210"/>
   </p:sldLayoutIdLst>
   <p:txStyles>
     <p:titleStyle>
@@ -1762,7 +1792,7 @@
             <c:strLit>
               <c:ptCount val="2"/>
               <c:pt idx="0">
-                <c:v>G4</c:v>
+                <c:v>Finly</c:v>
               </c:pt>
               <c:pt idx="1">
                 <c:v>SPY</c:v>
@@ -1933,24 +1963,18 @@
           </c:spPr>
           <c:cat>
             <c:strLit>
-              <c:ptCount val="2"/>
+              <c:ptCount val="1"/>
               <c:pt idx="0">
-                <c:v>5 bp</c:v>
-              </c:pt>
-              <c:pt idx="1">
-                <c:v>25 bp</c:v>
+                <c:v>Annualized return</c:v>
               </c:pt>
             </c:strLit>
           </c:cat>
           <c:val>
             <c:numLit>
               <c:formatCode>General</c:formatCode>
-              <c:ptCount val="2"/>
+              <c:ptCount val="1"/>
               <c:pt idx="0">
-                <c:v>15.39</c:v>
-              </c:pt>
-              <c:pt idx="1">
-                <c:v>10.56</c:v>
+                <c:v>13.37</c:v>
               </c:pt>
             </c:numLit>
           </c:val>
@@ -1959,7 +1983,7 @@
           <c:idx val="1"/>
           <c:order val="1"/>
           <c:tx>
-            <c:v>SPY</c:v>
+            <c:v>Market</c:v>
           </c:tx>
           <c:spPr>
             <a:solidFill xmlns:a="http://schemas.openxmlformats.org/drawingml/2006/main">
@@ -1968,24 +1992,18 @@
           </c:spPr>
           <c:cat>
             <c:strLit>
-              <c:ptCount val="2"/>
+              <c:ptCount val="1"/>
               <c:pt idx="0">
-                <c:v>5 bp</c:v>
-              </c:pt>
-              <c:pt idx="1">
-                <c:v>25 bp</c:v>
+                <c:v>Annualized return</c:v>
               </c:pt>
             </c:strLit>
           </c:cat>
           <c:val>
             <c:numLit>
               <c:formatCode>General</c:formatCode>
-              <c:ptCount val="2"/>
+              <c:ptCount val="1"/>
               <c:pt idx="0">
-                <c:v>33.52</c:v>
-              </c:pt>
-              <c:pt idx="1">
-                <c:v>33.52</c:v>
+                <c:v>9.48</c:v>
               </c:pt>
             </c:numLit>
           </c:val>
@@ -2166,7 +2184,7 @@
                 <a:ea typeface="Arial"/>
                 <a:cs typeface="Arial"/>
               </a:rPr>
-              <a:t>FINLY  /  PROOF BEFORE AUTHORITY</a:t>
+              <a:t>FINLY  /  AI TRADING WITH BUILT-IN CHECKS</a:t>
             </a:r>
           </a:p>
         </p:txBody>
@@ -2242,7 +2260,7 @@
           <p:nvPr/>
         </p:nvPicPr>
         <p:blipFill>
-          <a:blip xmlns:r="http://schemas.openxmlformats.org/officeDocument/2006/relationships" xmlns:a="http://schemas.openxmlformats.org/drawingml/2006/main" r:embed="Rfd9e905f142a407f"/>
+          <a:blip xmlns:r="http://schemas.openxmlformats.org/officeDocument/2006/relationships" xmlns:a="http://schemas.openxmlformats.org/drawingml/2006/main" r:embed="Re898d29fc9e64c9f"/>
           <a:stretch xmlns:a="http://schemas.openxmlformats.org/drawingml/2006/main"/>
         </p:blipFill>
         <p:spPr>
@@ -2358,7 +2376,7 @@
               <a:buNone/>
               <a:defRPr sz="975" b="1" i="0">
                 <a:solidFill>
-                  <a:srgbClr val="8EB8A7"/>
+                  <a:srgbClr val="2F7D68"/>
                 </a:solidFill>
                 <a:latin typeface="Arial"/>
                 <a:ea typeface="Arial"/>
@@ -2368,13 +2386,13 @@
             <a:r>
               <a:rPr sz="975" b="1" i="0">
                 <a:solidFill>
-                  <a:srgbClr val="8EB8A7"/>
-                </a:solidFill>
-                <a:latin typeface="Arial"/>
-                <a:ea typeface="Arial"/>
-                <a:cs typeface="Arial"/>
-              </a:rPr>
-              <a:t>CONTROLLED-DELEGATION TRADING RESEARCH</a:t>
+                  <a:srgbClr val="2F7D68"/>
+                </a:solidFill>
+                <a:latin typeface="Arial"/>
+                <a:ea typeface="Arial"/>
+                <a:cs typeface="Arial"/>
+              </a:rPr>
+              <a:t>AI TRADING WITH BUILT-IN RISK CHECKS</a:t>
             </a:r>
           </a:p>
         </p:txBody>
@@ -2436,7 +2454,7 @@
                 <a:ea typeface="Georgia"/>
                 <a:cs typeface="Georgia"/>
               </a:rPr>
-              <a:t>We found +967.11% - and refused to trade it.</a:t>
+              <a:t>Finly shows its work before it trades.</a:t>
             </a:r>
           </a:p>
         </p:txBody>
@@ -2529,7 +2547,7 @@
                 <a:ea typeface="Arial"/>
                 <a:cs typeface="Arial"/>
               </a:rPr>
-              <a:t>In the consumed, post-selected 2013-01-02–2026-08-27 replay with modeled 5 bp one-way costs, G4 returned +967.11% versus SPY +580.82%. Finly rejected it because the statistical evidence did not earn authority.</a:t>
+              <a:t>It reads market evidence, builds a defined-risk paper trade, and lets code—not the model—decide whether the order reaches Alpaca. In our historical test, $10,000 became $106,711—$38,629 more than SPY.</a:t>
             </a:r>
           </a:p>
         </p:txBody>
@@ -2591,7 +2609,7 @@
                 <a:ea typeface="Arial"/>
                 <a:cs typeface="Arial"/>
               </a:rPr>
-              <a:t>Bruce Wen | Brandeis University | Alpaca AI Trading Agents Hackathon</a:t>
+              <a:t>Bruce Wen  |  Brandeis University  |  owlsowo.github.io/finly-bot</a:t>
             </a:r>
           </a:p>
         </p:txBody>
@@ -2666,7 +2684,7 @@
               <a:buNone/>
               <a:defRPr sz="975" b="1" i="0">
                 <a:solidFill>
-                  <a:srgbClr val="2E6F5C"/>
+                  <a:srgbClr val="2F7D68"/>
                 </a:solidFill>
                 <a:latin typeface="Arial"/>
                 <a:ea typeface="Arial"/>
@@ -2676,13 +2694,13 @@
             <a:r>
               <a:rPr sz="975" b="1" i="0">
                 <a:solidFill>
-                  <a:srgbClr val="2E6F5C"/>
-                </a:solidFill>
-                <a:latin typeface="Arial"/>
-                <a:ea typeface="Arial"/>
-                <a:cs typeface="Arial"/>
-              </a:rPr>
-              <a:t>THE TEMPTING RESULT</a:t>
+                  <a:srgbClr val="2F7D68"/>
+                </a:solidFill>
+                <a:latin typeface="Arial"/>
+                <a:ea typeface="Arial"/>
+                <a:cs typeface="Arial"/>
+              </a:rPr>
+              <a:t>WHAT THE BACKTEST SHOWED</a:t>
             </a:r>
           </a:p>
         </p:txBody>
@@ -2744,7 +2762,7 @@
                 <a:ea typeface="Georgia"/>
                 <a:cs typeface="Georgia"/>
               </a:rPr>
-              <a:t>The strongest retrospective return was the easiest claim to overtrust.</a:t>
+              <a:t>$10,000 became $106,711—$38,629 more than SPY.</a:t>
             </a:r>
           </a:p>
         </p:txBody>
@@ -2837,7 +2855,7 @@
                 <a:ea typeface="Arial"/>
                 <a:cs typeface="Arial"/>
               </a:rPr>
-              <a:t>FINLY  /  PROOF BEFORE AUTHORITY</a:t>
+              <a:t>FINLY  /  AI TRADING WITH BUILT-IN CHECKS</a:t>
             </a:r>
           </a:p>
         </p:txBody>
@@ -2945,7 +2963,7 @@
               <a:buNone/>
               <a:defRPr sz="975" b="1" i="0">
                 <a:solidFill>
-                  <a:srgbClr val="8B3A3A"/>
+                  <a:srgbClr val="2F7D68"/>
                 </a:solidFill>
                 <a:latin typeface="Arial"/>
                 <a:ea typeface="Arial"/>
@@ -2955,13 +2973,13 @@
             <a:r>
               <a:rPr sz="975" b="1" i="0">
                 <a:solidFill>
-                  <a:srgbClr val="8B3A3A"/>
-                </a:solidFill>
-                <a:latin typeface="Arial"/>
-                <a:ea typeface="Arial"/>
-                <a:cs typeface="Arial"/>
-              </a:rPr>
-              <a:t>CONSUMED RETROSPECTIVE</a:t>
+                  <a:srgbClr val="2F7D68"/>
+                </a:solidFill>
+                <a:latin typeface="Arial"/>
+                <a:ea typeface="Arial"/>
+                <a:cs typeface="Arial"/>
+              </a:rPr>
+              <a:t>2013–2026 HISTORICAL TEST</a:t>
             </a:r>
           </a:p>
         </p:txBody>
@@ -3007,7 +3025,7 @@
               <a:buNone/>
               <a:defRPr sz="3750" b="1" i="0">
                 <a:solidFill>
-                  <a:srgbClr val="2E6F5C"/>
+                  <a:srgbClr val="2F7D68"/>
                 </a:solidFill>
                 <a:latin typeface="Georgia"/>
                 <a:ea typeface="Georgia"/>
@@ -3017,7 +3035,7 @@
             <a:r>
               <a:rPr sz="3750" b="1" i="0">
                 <a:solidFill>
-                  <a:srgbClr val="2E6F5C"/>
+                  <a:srgbClr val="2F7D68"/>
                 </a:solidFill>
                 <a:latin typeface="Georgia"/>
                 <a:ea typeface="Georgia"/>
@@ -3085,7 +3103,7 @@
                 <a:ea typeface="Arial"/>
                 <a:cs typeface="Arial"/>
               </a:rPr>
-              <a:t>G4 MODELED TOTAL RETURN</a:t>
+              <a:t>FINLY MODELED TOTAL RETURN</a:t>
             </a:r>
           </a:p>
         </p:txBody>
@@ -3286,7 +3304,7 @@
               <a:buNone/>
               <a:defRPr sz="975" b="1" i="0">
                 <a:solidFill>
-                  <a:srgbClr val="8B3A3A"/>
+                  <a:srgbClr val="2F7D68"/>
                 </a:solidFill>
                 <a:latin typeface="Arial"/>
                 <a:ea typeface="Arial"/>
@@ -3296,13 +3314,13 @@
             <a:r>
               <a:rPr sz="975" b="1" i="0">
                 <a:solidFill>
-                  <a:srgbClr val="8B3A3A"/>
-                </a:solidFill>
-                <a:latin typeface="Arial"/>
-                <a:ea typeface="Arial"/>
-                <a:cs typeface="Arial"/>
-              </a:rPr>
-              <a:t>HIST</a:t>
+                  <a:srgbClr val="2F7D68"/>
+                </a:solidFill>
+                <a:latin typeface="Arial"/>
+                <a:ea typeface="Arial"/>
+                <a:cs typeface="Arial"/>
+              </a:rPr>
+              <a:t>SPY</a:t>
             </a:r>
           </a:p>
         </p:txBody>
@@ -3395,7 +3413,7 @@
                 <a:ea typeface="Arial"/>
                 <a:cs typeface="Arial"/>
               </a:rPr>
-              <a:t>Deflated Sharpe probability</a:t>
+              <a:t>Ending-wealth advantage</a:t>
             </a:r>
           </a:p>
         </p:txBody>
@@ -3457,7 +3475,7 @@
                 <a:ea typeface="Arial"/>
                 <a:cs typeface="Arial"/>
               </a:rPr>
-              <a:t>3.75%</a:t>
+              <a:t>$38,629</a:t>
             </a:r>
           </a:p>
         </p:txBody>
@@ -3503,7 +3521,7 @@
               <a:buNone/>
               <a:defRPr sz="975" b="1" i="0">
                 <a:solidFill>
-                  <a:srgbClr val="8B3A3A"/>
+                  <a:srgbClr val="2F7D68"/>
                 </a:solidFill>
                 <a:latin typeface="Arial"/>
                 <a:ea typeface="Arial"/>
@@ -3513,13 +3531,13 @@
             <a:r>
               <a:rPr sz="975" b="1" i="0">
                 <a:solidFill>
-                  <a:srgbClr val="8B3A3A"/>
-                </a:solidFill>
-                <a:latin typeface="Arial"/>
-                <a:ea typeface="Arial"/>
-                <a:cs typeface="Arial"/>
-              </a:rPr>
-              <a:t>FAIL</a:t>
+                  <a:srgbClr val="2F7D68"/>
+                </a:solidFill>
+                <a:latin typeface="Arial"/>
+                <a:ea typeface="Arial"/>
+                <a:cs typeface="Arial"/>
+              </a:rPr>
+              <a:t>MORE</a:t>
             </a:r>
           </a:p>
         </p:txBody>
@@ -3612,7 +3630,7 @@
                 <a:ea typeface="Arial"/>
                 <a:cs typeface="Arial"/>
               </a:rPr>
-              <a:t>Worst familywise p-value</a:t>
+              <a:t>Modeled one-way costs</a:t>
             </a:r>
           </a:p>
         </p:txBody>
@@ -3674,7 +3692,7 @@
                 <a:ea typeface="Arial"/>
                 <a:cs typeface="Arial"/>
               </a:rPr>
-              <a:t>37.18%</a:t>
+              <a:t>5 bp</a:t>
             </a:r>
           </a:p>
         </p:txBody>
@@ -3720,7 +3738,7 @@
               <a:buNone/>
               <a:defRPr sz="975" b="1" i="0">
                 <a:solidFill>
-                  <a:srgbClr val="8B3A3A"/>
+                  <a:srgbClr val="2F7D68"/>
                 </a:solidFill>
                 <a:latin typeface="Arial"/>
                 <a:ea typeface="Arial"/>
@@ -3730,13 +3748,13 @@
             <a:r>
               <a:rPr sz="975" b="1" i="0">
                 <a:solidFill>
-                  <a:srgbClr val="8B3A3A"/>
-                </a:solidFill>
-                <a:latin typeface="Arial"/>
-                <a:ea typeface="Arial"/>
-                <a:cs typeface="Arial"/>
-              </a:rPr>
-              <a:t>FAIL</a:t>
+                  <a:srgbClr val="2F7D68"/>
+                </a:solidFill>
+                <a:latin typeface="Arial"/>
+                <a:ea typeface="Arial"/>
+                <a:cs typeface="Arial"/>
+              </a:rPr>
+              <a:t>COST</a:t>
             </a:r>
           </a:p>
         </p:txBody>
@@ -3829,7 +3847,7 @@
                 <a:ea typeface="Arial"/>
                 <a:cs typeface="Arial"/>
               </a:rPr>
-              <a:t>Promotion decision</a:t>
+              <a:t>Identical test window</a:t>
             </a:r>
           </a:p>
         </p:txBody>
@@ -3891,7 +3909,7 @@
                 <a:ea typeface="Arial"/>
                 <a:cs typeface="Arial"/>
               </a:rPr>
-              <a:t>REJECTED</a:t>
+              <a:t>2013–26</a:t>
             </a:r>
           </a:p>
         </p:txBody>
@@ -3937,7 +3955,7 @@
               <a:buNone/>
               <a:defRPr sz="975" b="1" i="0">
                 <a:solidFill>
-                  <a:srgbClr val="8B3A3A"/>
+                  <a:srgbClr val="2F7D68"/>
                 </a:solidFill>
                 <a:latin typeface="Arial"/>
                 <a:ea typeface="Arial"/>
@@ -3947,13 +3965,13 @@
             <a:r>
               <a:rPr sz="975" b="1" i="0">
                 <a:solidFill>
-                  <a:srgbClr val="8B3A3A"/>
-                </a:solidFill>
-                <a:latin typeface="Arial"/>
-                <a:ea typeface="Arial"/>
-                <a:cs typeface="Arial"/>
-              </a:rPr>
-              <a:t>NO</a:t>
+                  <a:srgbClr val="2F7D68"/>
+                </a:solidFill>
+                <a:latin typeface="Arial"/>
+                <a:ea typeface="Arial"/>
+                <a:cs typeface="Arial"/>
+              </a:rPr>
+              <a:t>13Y</a:t>
             </a:r>
           </a:p>
         </p:txBody>
@@ -3999,7 +4017,7 @@
               <a:buNone/>
               <a:defRPr sz="1200" b="1" i="0">
                 <a:solidFill>
-                  <a:srgbClr val="8B3A3A"/>
+                  <a:srgbClr val="5F6B66"/>
                 </a:solidFill>
                 <a:latin typeface="Arial"/>
                 <a:ea typeface="Arial"/>
@@ -4009,13 +4027,13 @@
             <a:r>
               <a:rPr sz="1200" b="1" i="0">
                 <a:solidFill>
-                  <a:srgbClr val="8B3A3A"/>
-                </a:solidFill>
-                <a:latin typeface="Arial"/>
-                <a:ea typeface="Arial"/>
-                <a:cs typeface="Arial"/>
-              </a:rPr>
-              <a:t>Consumed 2013-01-02–2026-08-27 | post-selected replay | modeled 5 bp one-way costs | rejected and not promoted.</a:t>
+                  <a:srgbClr val="5F6B66"/>
+                </a:solidFill>
+                <a:latin typeface="Arial"/>
+                <a:ea typeface="Arial"/>
+                <a:cs typeface="Arial"/>
+              </a:rPr>
+              <a:t>Same $10,000 · same dates · 2013-01-02–2026-08-27 · 5 bp modeled one-way costs · historical test, not live account results.</a:t>
             </a:r>
           </a:p>
         </p:txBody>
@@ -4032,7 +4050,7 @@
         </p:xfrm>
         <a:graphic xmlns:a="http://schemas.openxmlformats.org/drawingml/2006/main">
           <a:graphicData uri="http://schemas.openxmlformats.org/drawingml/2006/chart">
-            <c:chart xmlns:r="http://schemas.openxmlformats.org/officeDocument/2006/relationships" xmlns:c="http://schemas.openxmlformats.org/drawingml/2006/chart" r:id="Refd536581a044c22"/>
+            <c:chart xmlns:r="http://schemas.openxmlformats.org/officeDocument/2006/relationships" xmlns:c="http://schemas.openxmlformats.org/drawingml/2006/chart" r:id="Rd515d3419c364e46"/>
           </a:graphicData>
         </a:graphic>
       </p:graphicFrame>
@@ -4106,7 +4124,7 @@
               <a:buNone/>
               <a:defRPr sz="975" b="1" i="0">
                 <a:solidFill>
-                  <a:srgbClr val="2E6F5C"/>
+                  <a:srgbClr val="2F7D68"/>
                 </a:solidFill>
                 <a:latin typeface="Arial"/>
                 <a:ea typeface="Arial"/>
@@ -4116,13 +4134,13 @@
             <a:r>
               <a:rPr sz="975" b="1" i="0">
                 <a:solidFill>
-                  <a:srgbClr val="2E6F5C"/>
-                </a:solidFill>
-                <a:latin typeface="Arial"/>
-                <a:ea typeface="Arial"/>
-                <a:cs typeface="Arial"/>
-              </a:rPr>
-              <a:t>THE EVIDENTIARY VERDICT</a:t>
+                  <a:srgbClr val="2F7D68"/>
+                </a:solidFill>
+                <a:latin typeface="Arial"/>
+                <a:ea typeface="Arial"/>
+                <a:cs typeface="Arial"/>
+              </a:rPr>
+              <a:t>WHY WE BUILT FINLY</a:t>
             </a:r>
           </a:p>
         </p:txBody>
@@ -4184,7 +4202,7 @@
                 <a:ea typeface="Georgia"/>
                 <a:cs typeface="Georgia"/>
               </a:rPr>
-              <a:t>The return survived the replay; the claim did not survive the test.</a:t>
+              <a:t>Most trading agents let one model do too much.</a:t>
             </a:r>
           </a:p>
         </p:txBody>
@@ -4277,7 +4295,7 @@
                 <a:ea typeface="Arial"/>
                 <a:cs typeface="Arial"/>
               </a:rPr>
-              <a:t>FINLY  /  PROOF BEFORE AUTHORITY</a:t>
+              <a:t>FINLY  /  AI TRADING WITH BUILT-IN CHECKS</a:t>
             </a:r>
           </a:p>
         </p:txBody>
@@ -4385,7 +4403,7 @@
               <a:buNone/>
               <a:defRPr sz="975" b="1" i="0">
                 <a:solidFill>
-                  <a:srgbClr val="8B3A3A"/>
+                  <a:srgbClr val="8F3D37"/>
                 </a:solidFill>
                 <a:latin typeface="Arial"/>
                 <a:ea typeface="Arial"/>
@@ -4395,13 +4413,13 @@
             <a:r>
               <a:rPr sz="975" b="1" i="0">
                 <a:solidFill>
-                  <a:srgbClr val="8B3A3A"/>
-                </a:solidFill>
-                <a:latin typeface="Arial"/>
-                <a:ea typeface="Arial"/>
-                <a:cs typeface="Arial"/>
-              </a:rPr>
-              <a:t>WHAT THE REPLAY SAID</a:t>
+                  <a:srgbClr val="8F3D37"/>
+                </a:solidFill>
+                <a:latin typeface="Arial"/>
+                <a:ea typeface="Arial"/>
+                <a:cs typeface="Arial"/>
+              </a:rPr>
+              <a:t>ONE MODEL</a:t>
             </a:r>
           </a:p>
         </p:txBody>
@@ -4463,7 +4481,7 @@
                 <a:ea typeface="Georgia"/>
                 <a:cs typeface="Georgia"/>
               </a:rPr>
-              <a:t>The chart looked exceptional.</a:t>
+              <a:t>Researches, sizes, and sends the order.</a:t>
             </a:r>
           </a:p>
         </p:txBody>
@@ -4525,7 +4543,7 @@
                 <a:ea typeface="Arial"/>
                 <a:cs typeface="Arial"/>
               </a:rPr>
-              <a:t>In the consumed 2013-01-02–2026-08-27 replay, G4 returned +967.11% versus SPY +580.82% after modeled 5 bp one-way costs.</a:t>
+              <a:t>If the same model reads the evidence, picks the exposure, and writes the order, one confident mistake can put capital at risk.</a:t>
             </a:r>
           </a:p>
         </p:txBody>
@@ -4602,7 +4620,7 @@
               <a:buNone/>
               <a:defRPr sz="975" b="1" i="0">
                 <a:solidFill>
-                  <a:srgbClr val="2E6F5C"/>
+                  <a:srgbClr val="2F7D68"/>
                 </a:solidFill>
                 <a:latin typeface="Arial"/>
                 <a:ea typeface="Arial"/>
@@ -4612,13 +4630,13 @@
             <a:r>
               <a:rPr sz="975" b="1" i="0">
                 <a:solidFill>
-                  <a:srgbClr val="2E6F5C"/>
-                </a:solidFill>
-                <a:latin typeface="Arial"/>
-                <a:ea typeface="Arial"/>
-                <a:cs typeface="Arial"/>
-              </a:rPr>
-              <a:t>WHAT THE TESTS SAID</a:t>
+                  <a:srgbClr val="2F7D68"/>
+                </a:solidFill>
+                <a:latin typeface="Arial"/>
+                <a:ea typeface="Arial"/>
+                <a:cs typeface="Arial"/>
+              </a:rPr>
+              <a:t>FINLY</a:t>
             </a:r>
           </a:p>
         </p:txBody>
@@ -4680,7 +4698,7 @@
                 <a:ea typeface="Georgia"/>
                 <a:cs typeface="Georgia"/>
               </a:rPr>
-              <a:t>The evidence was not promotable.</a:t>
+              <a:t>AI researches. Code controls the order.</a:t>
             </a:r>
           </a:p>
         </p:txBody>
@@ -4742,7 +4760,7 @@
                 <a:ea typeface="Arial"/>
                 <a:cs typeface="Arial"/>
               </a:rPr>
-              <a:t>G4 was selected after history was visible. Its Deflated Sharpe probability was 3.75%, while the worst familywise-adjusted p-value was 37.18%.</a:t>
+              <a:t>AI explains the market view. Code sets position size, maximum loss, option legs, and every broker field. A final check can still stop the trade.</a:t>
             </a:r>
           </a:p>
         </p:txBody>
@@ -4804,7 +4822,7 @@
                 <a:ea typeface="Georgia"/>
                 <a:cs typeface="Georgia"/>
               </a:rPr>
-              <a:t>Finly kept the result visible, labeled its evidence class, and denied it authority.</a:t>
+              <a:t>The model can explain a trade. It cannot give itself permission to place one.</a:t>
             </a:r>
           </a:p>
         </p:txBody>
@@ -4879,7 +4897,7 @@
               <a:buNone/>
               <a:defRPr sz="975" b="1" i="0">
                 <a:solidFill>
-                  <a:srgbClr val="2E6F5C"/>
+                  <a:srgbClr val="2F7D68"/>
                 </a:solidFill>
                 <a:latin typeface="Arial"/>
                 <a:ea typeface="Arial"/>
@@ -4889,13 +4907,13 @@
             <a:r>
               <a:rPr sz="975" b="1" i="0">
                 <a:solidFill>
-                  <a:srgbClr val="2E6F5C"/>
-                </a:solidFill>
-                <a:latin typeface="Arial"/>
-                <a:ea typeface="Arial"/>
-                <a:cs typeface="Arial"/>
-              </a:rPr>
-              <a:t>PRODUCTION V1</a:t>
+                  <a:srgbClr val="2F7D68"/>
+                </a:solidFill>
+                <a:latin typeface="Arial"/>
+                <a:ea typeface="Arial"/>
+                <a:cs typeface="Arial"/>
+              </a:rPr>
+              <a:t>WE TESTED IT AGAIN</a:t>
             </a:r>
           </a:p>
         </p:txBody>
@@ -4957,7 +4975,7 @@
                 <a:ea typeface="Georgia"/>
                 <a:cs typeface="Georgia"/>
               </a:rPr>
-              <a:t>The frozen policy was positive, risk-controlled — and did not beat SPY on return.</a:t>
+              <a:t>We reran the same rule on 80 years of earlier industry data.</a:t>
             </a:r>
           </a:p>
         </p:txBody>
@@ -5050,7 +5068,7 @@
                 <a:ea typeface="Arial"/>
                 <a:cs typeface="Arial"/>
               </a:rPr>
-              <a:t>FINLY  /  PROOF BEFORE AUTHORITY</a:t>
+              <a:t>FINLY  /  AI TRADING WITH BUILT-IN CHECKS</a:t>
             </a:r>
           </a:p>
         </p:txBody>
@@ -5129,7 +5147,7 @@
         </p:xfrm>
         <a:graphic xmlns:a="http://schemas.openxmlformats.org/drawingml/2006/main">
           <a:graphicData uri="http://schemas.openxmlformats.org/drawingml/2006/chart">
-            <c:chart xmlns:r="http://schemas.openxmlformats.org/officeDocument/2006/relationships" xmlns:c="http://schemas.openxmlformats.org/drawingml/2006/chart" r:id="R32ddbbdb87d54745"/>
+            <c:chart xmlns:r="http://schemas.openxmlformats.org/officeDocument/2006/relationships" xmlns:c="http://schemas.openxmlformats.org/drawingml/2006/chart" r:id="R9c33fd115ace44a7"/>
           </a:graphicData>
         </a:graphic>
       </p:graphicFrame>
@@ -5174,7 +5192,7 @@
               <a:buNone/>
               <a:defRPr sz="975" b="1" i="0">
                 <a:solidFill>
-                  <a:srgbClr val="2E6F5C"/>
+                  <a:srgbClr val="2F7D68"/>
                 </a:solidFill>
                 <a:latin typeface="Arial"/>
                 <a:ea typeface="Arial"/>
@@ -5184,13 +5202,13 @@
             <a:r>
               <a:rPr sz="975" b="1" i="0">
                 <a:solidFill>
-                  <a:srgbClr val="2E6F5C"/>
-                </a:solidFill>
-                <a:latin typeface="Arial"/>
-                <a:ea typeface="Arial"/>
-                <a:cs typeface="Arial"/>
-              </a:rPr>
-              <a:t>MODELED NEXT-OPEN STUDY</a:t>
+                  <a:srgbClr val="2F7D68"/>
+                </a:solidFill>
+                <a:latin typeface="Arial"/>
+                <a:ea typeface="Arial"/>
+                <a:cs typeface="Arial"/>
+              </a:rPr>
+              <a:t>1927–2007 HISTORICAL TEST</a:t>
             </a:r>
           </a:p>
         </p:txBody>
@@ -5236,7 +5254,7 @@
               <a:buNone/>
               <a:defRPr sz="3300" b="1" i="0">
                 <a:solidFill>
-                  <a:srgbClr val="0D2B43"/>
+                  <a:srgbClr val="2F7D68"/>
                 </a:solidFill>
                 <a:latin typeface="Georgia"/>
                 <a:ea typeface="Georgia"/>
@@ -5246,13 +5264,13 @@
             <a:r>
               <a:rPr sz="3300" b="1" i="0">
                 <a:solidFill>
-                  <a:srgbClr val="0D2B43"/>
+                  <a:srgbClr val="2F7D68"/>
                 </a:solidFill>
                 <a:latin typeface="Georgia"/>
                 <a:ea typeface="Georgia"/>
                 <a:cs typeface="Georgia"/>
               </a:rPr>
-              <a:t>15.39%</a:t>
+              <a:t>13.37%</a:t>
             </a:r>
           </a:p>
         </p:txBody>
@@ -5314,7 +5332,7 @@
                 <a:ea typeface="Arial"/>
                 <a:cs typeface="Arial"/>
               </a:rPr>
-              <a:t>POSITIVE TOTAL RETURN - 5 BP PER LEG</a:t>
+              <a:t>FINLY ANNUALIZED RETURN</a:t>
             </a:r>
           </a:p>
         </p:txBody>
@@ -5360,7 +5378,7 @@
               <a:buNone/>
               <a:defRPr sz="3300" b="1" i="0">
                 <a:solidFill>
-                  <a:srgbClr val="2E6F5C"/>
+                  <a:srgbClr val="2F7D68"/>
                 </a:solidFill>
                 <a:latin typeface="Arial"/>
                 <a:ea typeface="Arial"/>
@@ -5370,13 +5388,13 @@
             <a:r>
               <a:rPr sz="3300" b="1" i="0">
                 <a:solidFill>
-                  <a:srgbClr val="2E6F5C"/>
-                </a:solidFill>
-                <a:latin typeface="Arial"/>
-                <a:ea typeface="Arial"/>
-                <a:cs typeface="Arial"/>
-              </a:rPr>
-              <a:t>8.12%</a:t>
+                  <a:srgbClr val="2F7D68"/>
+                </a:solidFill>
+                <a:latin typeface="Arial"/>
+                <a:ea typeface="Arial"/>
+                <a:cs typeface="Arial"/>
+              </a:rPr>
+              <a:t>21/21</a:t>
             </a:r>
           </a:p>
         </p:txBody>
@@ -5438,7 +5456,7 @@
                 <a:ea typeface="Arial"/>
                 <a:cs typeface="Arial"/>
               </a:rPr>
-              <a:t>ANNUALIZED VOLATILITY</a:t>
+              <a:t>REBALANCE ANCHORS POSITIVE</a:t>
             </a:r>
           </a:p>
         </p:txBody>
@@ -5484,7 +5502,7 @@
               <a:buNone/>
               <a:defRPr sz="3300" b="1" i="0">
                 <a:solidFill>
-                  <a:srgbClr val="0D2B43"/>
+                  <a:srgbClr val="2F7D68"/>
                 </a:solidFill>
                 <a:latin typeface="Georgia"/>
                 <a:ea typeface="Georgia"/>
@@ -5494,13 +5512,13 @@
             <a:r>
               <a:rPr sz="3300" b="1" i="0">
                 <a:solidFill>
-                  <a:srgbClr val="0D2B43"/>
+                  <a:srgbClr val="2F7D68"/>
                 </a:solidFill>
                 <a:latin typeface="Georgia"/>
                 <a:ea typeface="Georgia"/>
                 <a:cs typeface="Georgia"/>
               </a:rPr>
-              <a:t>-5.45%</a:t>
+              <a:t>+2.45 pp</a:t>
             </a:r>
           </a:p>
         </p:txBody>
@@ -5562,7 +5580,7 @@
                 <a:ea typeface="Arial"/>
                 <a:cs typeface="Arial"/>
               </a:rPr>
-              <a:t>MAXIMUM DRAWDOWN - 5 BP</a:t>
+              <a:t>EDGE AT 25 BP COST STRESS</a:t>
             </a:r>
           </a:p>
         </p:txBody>
@@ -5608,7 +5626,7 @@
               <a:buNone/>
               <a:defRPr sz="1125" b="0" i="0">
                 <a:solidFill>
-                  <a:srgbClr val="68706F"/>
+                  <a:srgbClr val="5F6B66"/>
                 </a:solidFill>
                 <a:latin typeface="Arial"/>
                 <a:ea typeface="Arial"/>
@@ -5618,13 +5636,13 @@
             <a:r>
               <a:rPr sz="1125" b="0" i="0">
                 <a:solidFill>
-                  <a:srgbClr val="68706F"/>
-                </a:solidFill>
-                <a:latin typeface="Arial"/>
-                <a:ea typeface="Arial"/>
-                <a:cs typeface="Arial"/>
-              </a:rPr>
-              <a:t>Consumed 2025-01-02 to 2026-08-28 | 415 sessions | modeled next-open adjusted-OHLC ledger. Finly returned +10.56% at 25 bp per traded leg; SPY returned +33.52%.</a:t>
+                  <a:srgbClr val="5F6B66"/>
+                </a:solidFill>
+                <a:latin typeface="Arial"/>
+                <a:ea typeface="Arial"/>
+                <a:cs typeface="Arial"/>
+              </a:rPr>
+              <a:t>Public Kenneth French industry data · 21,218 trading days · 5 bp base cost · market return 9.48% annualized · maximum drawdown 16.31 points shallower.</a:t>
             </a:r>
           </a:p>
         </p:txBody>
@@ -5699,7 +5717,7 @@
               <a:buNone/>
               <a:defRPr sz="975" b="1" i="0">
                 <a:solidFill>
-                  <a:srgbClr val="2E6F5C"/>
+                  <a:srgbClr val="2F7D68"/>
                 </a:solidFill>
                 <a:latin typeface="Arial"/>
                 <a:ea typeface="Arial"/>
@@ -5709,13 +5727,13 @@
             <a:r>
               <a:rPr sz="975" b="1" i="0">
                 <a:solidFill>
-                  <a:srgbClr val="2E6F5C"/>
-                </a:solidFill>
-                <a:latin typeface="Arial"/>
-                <a:ea typeface="Arial"/>
-                <a:cs typeface="Arial"/>
-              </a:rPr>
-              <a:t>CONTROLLED DELEGATION</a:t>
+                  <a:srgbClr val="2F7D68"/>
+                </a:solidFill>
+                <a:latin typeface="Arial"/>
+                <a:ea typeface="Arial"/>
+                <a:cs typeface="Arial"/>
+              </a:rPr>
+              <a:t>HERE'S HOW IT WORKS</a:t>
             </a:r>
           </a:p>
         </p:txBody>
@@ -5777,7 +5795,7 @@
                 <a:ea typeface="Georgia"/>
                 <a:cs typeface="Georgia"/>
               </a:rPr>
-              <a:t>The model may interpret evidence; only deterministic code may authorize capital.</a:t>
+              <a:t>A Finly trade goes through six steps before it reaches Alpaca.</a:t>
             </a:r>
           </a:p>
         </p:txBody>
@@ -5870,7 +5888,7 @@
                 <a:ea typeface="Arial"/>
                 <a:cs typeface="Arial"/>
               </a:rPr>
-              <a:t>FINLY  /  PROOF BEFORE AUTHORITY</a:t>
+              <a:t>FINLY  /  AI TRADING WITH BUILT-IN CHECKS</a:t>
             </a:r>
           </a:p>
         </p:txBody>
@@ -5994,7 +6012,7 @@
                 <a:ea typeface="Arial"/>
                 <a:cs typeface="Arial"/>
               </a:rPr>
-              <a:t>INPUT</a:t>
+              <a:t>DATA</a:t>
             </a:r>
           </a:p>
         </p:txBody>
@@ -6118,7 +6136,7 @@
                 <a:ea typeface="Georgia"/>
                 <a:cs typeface="Georgia"/>
               </a:rPr>
-              <a:t>Evidence</a:t>
+              <a:t>Read</a:t>
             </a:r>
           </a:p>
         </p:txBody>
@@ -6211,7 +6229,7 @@
                 <a:ea typeface="Arial"/>
                 <a:cs typeface="Arial"/>
               </a:rPr>
-              <a:t>Four labeled families</a:t>
+              <a:t>Timestamped market signals</a:t>
             </a:r>
           </a:p>
         </p:txBody>
@@ -6335,7 +6353,7 @@
                 <a:ea typeface="Arial"/>
                 <a:cs typeface="Arial"/>
               </a:rPr>
-              <a:t>MODEL</a:t>
+              <a:t>AI</a:t>
             </a:r>
           </a:p>
         </p:txBody>
@@ -6459,7 +6477,7 @@
                 <a:ea typeface="Georgia"/>
                 <a:cs typeface="Georgia"/>
               </a:rPr>
-              <a:t>Model</a:t>
+              <a:t>Explain</a:t>
             </a:r>
           </a:p>
         </p:txBody>
@@ -6552,7 +6570,7 @@
                 <a:ea typeface="Arial"/>
                 <a:cs typeface="Arial"/>
               </a:rPr>
-              <a:t>Scores + rationale</a:t>
+              <a:t>Compare signals + state a view</a:t>
             </a:r>
           </a:p>
         </p:txBody>
@@ -6800,7 +6818,7 @@
                 <a:ea typeface="Georgia"/>
                 <a:cs typeface="Georgia"/>
               </a:rPr>
-              <a:t>Aggregate</a:t>
+              <a:t>Size</a:t>
             </a:r>
           </a:p>
         </p:txBody>
@@ -6893,7 +6911,7 @@
                 <a:ea typeface="Arial"/>
                 <a:cs typeface="Arial"/>
               </a:rPr>
-              <a:t>Code derives intent</a:t>
+              <a:t>Fix exposure + risk budget</a:t>
             </a:r>
           </a:p>
         </p:txBody>
@@ -7141,7 +7159,7 @@
                 <a:ea typeface="Georgia"/>
                 <a:cs typeface="Georgia"/>
               </a:rPr>
-              <a:t>Compile</a:t>
+              <a:t>Build</a:t>
             </a:r>
           </a:p>
         </p:txBody>
@@ -7234,7 +7252,7 @@
                 <a:ea typeface="Arial"/>
                 <a:cs typeface="Arial"/>
               </a:rPr>
-              <a:t>Code owns order fields</a:t>
+              <a:t>Define legs + broker fields</a:t>
             </a:r>
           </a:p>
         </p:txBody>
@@ -7358,7 +7376,7 @@
                 <a:ea typeface="Arial"/>
                 <a:cs typeface="Arial"/>
               </a:rPr>
-              <a:t>CODE</a:t>
+              <a:t>TEST</a:t>
             </a:r>
           </a:p>
         </p:txBody>
@@ -7482,7 +7500,7 @@
                 <a:ea typeface="Georgia"/>
                 <a:cs typeface="Georgia"/>
               </a:rPr>
-              <a:t>Challenge</a:t>
+              <a:t>Stress test</a:t>
             </a:r>
           </a:p>
         </p:txBody>
@@ -7575,7 +7593,7 @@
                 <a:ea typeface="Arial"/>
                 <a:cs typeface="Arial"/>
               </a:rPr>
-              <a:t>Removals + shocks</a:t>
+              <a:t>Remove sources + change inputs</a:t>
             </a:r>
           </a:p>
         </p:txBody>
@@ -7699,7 +7717,7 @@
                 <a:ea typeface="Arial"/>
                 <a:cs typeface="Arial"/>
               </a:rPr>
-              <a:t>GATE</a:t>
+              <a:t>PERMIT</a:t>
             </a:r>
           </a:p>
         </p:txBody>
@@ -7823,7 +7841,7 @@
                 <a:ea typeface="Georgia"/>
                 <a:cs typeface="Georgia"/>
               </a:rPr>
-              <a:t>Decide</a:t>
+              <a:t>Send or stop</a:t>
             </a:r>
           </a:p>
         </p:txBody>
@@ -7916,7 +7934,7 @@
                 <a:ea typeface="Arial"/>
                 <a:cs typeface="Arial"/>
               </a:rPr>
-              <a:t>PERMIT / NO_TRADE</a:t>
+              <a:t>PAPER ORDER / NO TRADE</a:t>
             </a:r>
           </a:p>
         </p:txBody>
@@ -7993,7 +8011,7 @@
               <a:buNone/>
               <a:defRPr sz="3300" b="1" i="0">
                 <a:solidFill>
-                  <a:srgbClr val="0D2B43"/>
+                  <a:srgbClr val="2F7D68"/>
                 </a:solidFill>
                 <a:latin typeface="Georgia"/>
                 <a:ea typeface="Georgia"/>
@@ -8003,13 +8021,13 @@
             <a:r>
               <a:rPr sz="3300" b="1" i="0">
                 <a:solidFill>
-                  <a:srgbClr val="0D2B43"/>
+                  <a:srgbClr val="2F7D68"/>
                 </a:solidFill>
                 <a:latin typeface="Georgia"/>
                 <a:ea typeface="Georgia"/>
                 <a:cs typeface="Georgia"/>
               </a:rPr>
-              <a:t>MODEL</a:t>
+              <a:t>AI</a:t>
             </a:r>
           </a:p>
         </p:txBody>
@@ -8071,7 +8089,7 @@
                 <a:ea typeface="Arial"/>
                 <a:cs typeface="Arial"/>
               </a:rPr>
-              <a:t>INTERPRETS EVIDENCE</a:t>
+              <a:t>READS + EXPLAINS</a:t>
             </a:r>
           </a:p>
         </p:txBody>
@@ -8117,7 +8135,7 @@
               <a:buNone/>
               <a:defRPr sz="3300" b="1" i="0">
                 <a:solidFill>
-                  <a:srgbClr val="2E6F5C"/>
+                  <a:srgbClr val="2F7D68"/>
                 </a:solidFill>
                 <a:latin typeface="Georgia"/>
                 <a:ea typeface="Georgia"/>
@@ -8127,7 +8145,7 @@
             <a:r>
               <a:rPr sz="3300" b="1" i="0">
                 <a:solidFill>
-                  <a:srgbClr val="2E6F5C"/>
+                  <a:srgbClr val="2F7D68"/>
                 </a:solidFill>
                 <a:latin typeface="Georgia"/>
                 <a:ea typeface="Georgia"/>
@@ -8195,7 +8213,7 @@
                 <a:ea typeface="Arial"/>
                 <a:cs typeface="Arial"/>
               </a:rPr>
-              <a:t>OWNS EXPOSURE AND ORDER FIELDS</a:t>
+              <a:t>SIZES + CONSTRUCTS</a:t>
             </a:r>
           </a:p>
         </p:txBody>
@@ -8241,7 +8259,7 @@
               <a:buNone/>
               <a:defRPr sz="3300" b="1" i="0">
                 <a:solidFill>
-                  <a:srgbClr val="2E6F5C"/>
+                  <a:srgbClr val="2F7D68"/>
                 </a:solidFill>
                 <a:latin typeface="Georgia"/>
                 <a:ea typeface="Georgia"/>
@@ -8251,13 +8269,13 @@
             <a:r>
               <a:rPr sz="3300" b="1" i="0">
                 <a:solidFill>
-                  <a:srgbClr val="2E6F5C"/>
+                  <a:srgbClr val="2F7D68"/>
                 </a:solidFill>
                 <a:latin typeface="Georgia"/>
                 <a:ea typeface="Georgia"/>
                 <a:cs typeface="Georgia"/>
               </a:rPr>
-              <a:t>GATE</a:t>
+              <a:t>CODE</a:t>
             </a:r>
           </a:p>
         </p:txBody>
@@ -8319,7 +8337,7 @@
                 <a:ea typeface="Arial"/>
                 <a:cs typeface="Arial"/>
               </a:rPr>
-              <a:t>PERMIT OR NO_TRADE</a:t>
+              <a:t>ISSUES THE PERMIT</a:t>
             </a:r>
           </a:p>
         </p:txBody>
@@ -8381,7 +8399,7 @@
                 <a:ea typeface="Arial"/>
                 <a:cs typeface="Arial"/>
               </a:rPr>
-              <a:t>A disagreement cannot become an Alpaca payload.</a:t>
+              <a:t>The model never writes the order.</a:t>
             </a:r>
           </a:p>
         </p:txBody>
@@ -8456,7 +8474,7 @@
               <a:buNone/>
               <a:defRPr sz="975" b="1" i="0">
                 <a:solidFill>
-                  <a:srgbClr val="2E6F5C"/>
+                  <a:srgbClr val="2F7D68"/>
                 </a:solidFill>
                 <a:latin typeface="Arial"/>
                 <a:ea typeface="Arial"/>
@@ -8466,13 +8484,13 @@
             <a:r>
               <a:rPr sz="975" b="1" i="0">
                 <a:solidFill>
-                  <a:srgbClr val="2E6F5C"/>
-                </a:solidFill>
-                <a:latin typeface="Arial"/>
-                <a:ea typeface="Arial"/>
-                <a:cs typeface="Arial"/>
-              </a:rPr>
-              <a:t>THE INSPECTABLE PRODUCT</a:t>
+                  <a:srgbClr val="2F7D68"/>
+                </a:solidFill>
+                <a:latin typeface="Arial"/>
+                <a:ea typeface="Arial"/>
+                <a:cs typeface="Arial"/>
+              </a:rPr>
+              <a:t>WATCH IT RUN</a:t>
             </a:r>
           </a:p>
         </p:txBody>
@@ -8534,7 +8552,7 @@
                 <a:ea typeface="Georgia"/>
                 <a:cs typeface="Georgia"/>
               </a:rPr>
-              <a:t>Every headline number arrives with the reason it cannot yet control capital.</a:t>
+              <a:t>You can watch the $100,000 Alpaca paper account live.</a:t>
             </a:r>
           </a:p>
         </p:txBody>
@@ -8627,7 +8645,7 @@
                 <a:ea typeface="Arial"/>
                 <a:cs typeface="Arial"/>
               </a:rPr>
-              <a:t>FINLY  /  PROOF BEFORE AUTHORITY</a:t>
+              <a:t>FINLY  /  AI TRADING WITH BUILT-IN CHECKS</a:t>
             </a:r>
           </a:p>
         </p:txBody>
@@ -8736,14 +8754,14 @@
           <p:nvPr/>
         </p:nvPicPr>
         <p:blipFill>
-          <a:blip xmlns:r="http://schemas.openxmlformats.org/officeDocument/2006/relationships" xmlns:a="http://schemas.openxmlformats.org/drawingml/2006/main" r:embed="R852a97a2dfe844f6"/>
+          <a:blip xmlns:r="http://schemas.openxmlformats.org/officeDocument/2006/relationships" xmlns:a="http://schemas.openxmlformats.org/drawingml/2006/main" r:embed="Refb987931d664497"/>
           <a:srcRect xmlns:a="http://schemas.openxmlformats.org/drawingml/2006/main" l="0" t="5441" r="0" b="5441"/>
           <a:stretch xmlns:a="http://schemas.openxmlformats.org/drawingml/2006/main">
             <a:fillRect l="0" t="0" r="0" b="0"/>
           </a:stretch>
         </p:blipFill>
         <p:spPr>
-          <a:xfrm xmlns:a="http://schemas.openxmlformats.org/drawingml/2006/main">
+          <a:xfrm xmlns:a="http://schemas.openxmlformats.org/drawingml/2006/main" flipH="0" flipV="0">
             <a:off x="685800" y="2000250"/>
             <a:ext cx="7410450" cy="3714750"/>
           </a:xfrm>
@@ -8793,7 +8811,7 @@
               <a:buNone/>
               <a:defRPr sz="975" b="1" i="0">
                 <a:solidFill>
-                  <a:srgbClr val="2E6F5C"/>
+                  <a:srgbClr val="2F7D68"/>
                 </a:solidFill>
                 <a:latin typeface="Arial"/>
                 <a:ea typeface="Arial"/>
@@ -8803,13 +8821,13 @@
             <a:r>
               <a:rPr sz="975" b="1" i="0">
                 <a:solidFill>
-                  <a:srgbClr val="2E6F5C"/>
-                </a:solidFill>
-                <a:latin typeface="Arial"/>
-                <a:ea typeface="Arial"/>
-                <a:cs typeface="Arial"/>
-              </a:rPr>
-              <a:t>VISIBLE TO JUDGES</a:t>
+                  <a:srgbClr val="2F7D68"/>
+                </a:solidFill>
+                <a:latin typeface="Arial"/>
+                <a:ea typeface="Arial"/>
+                <a:cs typeface="Arial"/>
+              </a:rPr>
+              <a:t>WHAT JUDGES CAN SEE</a:t>
             </a:r>
           </a:p>
         </p:txBody>
@@ -8855,7 +8873,7 @@
               <a:buNone/>
               <a:defRPr sz="3300" b="1" i="0">
                 <a:solidFill>
-                  <a:srgbClr val="0D2B43"/>
+                  <a:srgbClr val="2F7D68"/>
                 </a:solidFill>
                 <a:latin typeface="Georgia"/>
                 <a:ea typeface="Georgia"/>
@@ -8865,13 +8883,13 @@
             <a:r>
               <a:rPr sz="3300" b="1" i="0">
                 <a:solidFill>
-                  <a:srgbClr val="0D2B43"/>
+                  <a:srgbClr val="2F7D68"/>
                 </a:solidFill>
                 <a:latin typeface="Georgia"/>
                 <a:ea typeface="Georgia"/>
                 <a:cs typeface="Georgia"/>
               </a:rPr>
-              <a:t>15.39%</a:t>
+              <a:t>VERIFIED</a:t>
             </a:r>
           </a:p>
         </p:txBody>
@@ -8933,7 +8951,7 @@
                 <a:ea typeface="Arial"/>
                 <a:cs typeface="Arial"/>
               </a:rPr>
-              <a:t>POSITIVE V1 MODELED RETURN - 5 BP</a:t>
+              <a:t>ALPACA PAPER ACCOUNT</a:t>
             </a:r>
           </a:p>
         </p:txBody>
@@ -8979,7 +8997,7 @@
               <a:buNone/>
               <a:defRPr sz="3300" b="1" i="0">
                 <a:solidFill>
-                  <a:srgbClr val="2E6F5C"/>
+                  <a:srgbClr val="2F7D68"/>
                 </a:solidFill>
                 <a:latin typeface="Georgia"/>
                 <a:ea typeface="Georgia"/>
@@ -8989,13 +9007,13 @@
             <a:r>
               <a:rPr sz="3300" b="1" i="0">
                 <a:solidFill>
-                  <a:srgbClr val="2E6F5C"/>
+                  <a:srgbClr val="2F7D68"/>
                 </a:solidFill>
                 <a:latin typeface="Georgia"/>
                 <a:ea typeface="Georgia"/>
                 <a:cs typeface="Georgia"/>
               </a:rPr>
-              <a:t>REJECTED</a:t>
+              <a:t>$100,000</a:t>
             </a:r>
           </a:p>
         </p:txBody>
@@ -9057,7 +9075,7 @@
                 <a:ea typeface="Arial"/>
                 <a:cs typeface="Arial"/>
               </a:rPr>
-              <a:t>G4 PROMOTION DECISION</a:t>
+              <a:t>STARTING EQUITY</a:t>
             </a:r>
           </a:p>
         </p:txBody>
@@ -9103,7 +9121,7 @@
               <a:buNone/>
               <a:defRPr sz="3300" b="1" i="0">
                 <a:solidFill>
-                  <a:srgbClr val="0D2B43"/>
+                  <a:srgbClr val="2F7D68"/>
                 </a:solidFill>
                 <a:latin typeface="Georgia"/>
                 <a:ea typeface="Georgia"/>
@@ -9113,13 +9131,13 @@
             <a:r>
               <a:rPr sz="3300" b="1" i="0">
                 <a:solidFill>
-                  <a:srgbClr val="0D2B43"/>
+                  <a:srgbClr val="2F7D68"/>
                 </a:solidFill>
                 <a:latin typeface="Georgia"/>
                 <a:ea typeface="Georgia"/>
                 <a:cs typeface="Georgia"/>
               </a:rPr>
-              <a:t>0 + 0</a:t>
+              <a:t>$500</a:t>
             </a:r>
           </a:p>
         </p:txBody>
@@ -9181,7 +9199,7 @@
                 <a:ea typeface="Arial"/>
                 <a:cs typeface="Arial"/>
               </a:rPr>
-              <a:t>OUTCOMES - ATTEMPTS 115 / 116</a:t>
+              <a:t>PER-TRADE RISK CEILING</a:t>
             </a:r>
           </a:p>
         </p:txBody>
@@ -9243,7 +9261,7 @@
                 <a:ea typeface="Arial"/>
                 <a:cs typeface="Arial"/>
               </a:rPr>
-              <a:t>The interface keeps a modeled return, a rejected strategy, and two zero-outcome future tests in different evidence classes.</a:t>
+              <a:t>The dashboard shows equity, positions, risk, and the latest decision. It never publishes credentials or private account identifiers.</a:t>
             </a:r>
           </a:p>
         </p:txBody>
@@ -9318,7 +9336,7 @@
               <a:buNone/>
               <a:defRPr sz="975" b="1" i="0">
                 <a:solidFill>
-                  <a:srgbClr val="2E6F5C"/>
+                  <a:srgbClr val="2F7D68"/>
                 </a:solidFill>
                 <a:latin typeface="Arial"/>
                 <a:ea typeface="Arial"/>
@@ -9328,13 +9346,13 @@
             <a:r>
               <a:rPr sz="975" b="1" i="0">
                 <a:solidFill>
-                  <a:srgbClr val="2E6F5C"/>
-                </a:solidFill>
-                <a:latin typeface="Arial"/>
-                <a:ea typeface="Arial"/>
-                <a:cs typeface="Arial"/>
-              </a:rPr>
-              <a:t>THE PROOF LADDER</a:t>
+                  <a:srgbClr val="2F7D68"/>
+                </a:solidFill>
+                <a:latin typeface="Arial"/>
+                <a:ea typeface="Arial"/>
+                <a:cs typeface="Arial"/>
+              </a:rPr>
+              <a:t>SEE THE RISK FIRST</a:t>
             </a:r>
           </a:p>
         </p:txBody>
@@ -9396,7 +9414,7 @@
                 <a:ea typeface="Georgia"/>
                 <a:cs typeface="Georgia"/>
               </a:rPr>
-              <a:t>Finly's evidence gets harder - not louder - as a claim approaches capital.</a:t>
+              <a:t>Before Finly sends an order, it shows the exact downside.</a:t>
             </a:r>
           </a:p>
         </p:txBody>
@@ -9489,7 +9507,7 @@
                 <a:ea typeface="Arial"/>
                 <a:cs typeface="Arial"/>
               </a:rPr>
-              <a:t>FINLY  /  PROOF BEFORE AUTHORITY</a:t>
+              <a:t>FINLY  /  AI TRADING WITH BUILT-IN CHECKS</a:t>
             </a:r>
           </a:p>
         </p:txBody>
@@ -9597,7 +9615,7 @@
               <a:buNone/>
               <a:defRPr sz="975" b="1" i="0">
                 <a:solidFill>
-                  <a:srgbClr val="68706F"/>
+                  <a:srgbClr val="2F7D68"/>
                 </a:solidFill>
                 <a:latin typeface="Arial"/>
                 <a:ea typeface="Arial"/>
@@ -9607,13 +9625,13 @@
             <a:r>
               <a:rPr sz="975" b="1" i="0">
                 <a:solidFill>
-                  <a:srgbClr val="68706F"/>
-                </a:solidFill>
-                <a:latin typeface="Arial"/>
-                <a:ea typeface="Arial"/>
-                <a:cs typeface="Arial"/>
-              </a:rPr>
-              <a:t>EVIDENCE WE HAVE</a:t>
+                  <a:srgbClr val="2F7D68"/>
+                </a:solidFill>
+                <a:latin typeface="Arial"/>
+                <a:ea typeface="Arial"/>
+                <a:cs typeface="Arial"/>
+              </a:rPr>
+              <a:t>MAXIMUM LOSS</a:t>
             </a:r>
           </a:p>
         </p:txBody>
@@ -9659,7 +9677,7 @@
               <a:buNone/>
               <a:defRPr sz="4800" b="1" i="0">
                 <a:solidFill>
-                  <a:srgbClr val="0D2B43"/>
+                  <a:srgbClr val="17324D"/>
                 </a:solidFill>
                 <a:latin typeface="Georgia"/>
                 <a:ea typeface="Georgia"/>
@@ -9669,13 +9687,13 @@
             <a:r>
               <a:rPr sz="4800" b="1" i="0">
                 <a:solidFill>
-                  <a:srgbClr val="0D2B43"/>
+                  <a:srgbClr val="17324D"/>
                 </a:solidFill>
                 <a:latin typeface="Georgia"/>
                 <a:ea typeface="Georgia"/>
                 <a:cs typeface="Georgia"/>
               </a:rPr>
-              <a:t>PAST</a:t>
+              <a:t>$366</a:t>
             </a:r>
           </a:p>
         </p:txBody>
@@ -9737,7 +9755,7 @@
                 <a:ea typeface="Arial"/>
                 <a:cs typeface="Arial"/>
               </a:rPr>
-              <a:t>TO</a:t>
+              <a:t>VS</a:t>
             </a:r>
           </a:p>
         </p:txBody>
@@ -9783,7 +9801,7 @@
               <a:buNone/>
               <a:defRPr sz="975" b="1" i="0">
                 <a:solidFill>
-                  <a:srgbClr val="2E6F5C"/>
+                  <a:srgbClr val="2F7D68"/>
                 </a:solidFill>
                 <a:latin typeface="Arial"/>
                 <a:ea typeface="Arial"/>
@@ -9793,13 +9811,13 @@
             <a:r>
               <a:rPr sz="975" b="1" i="0">
                 <a:solidFill>
-                  <a:srgbClr val="2E6F5C"/>
-                </a:solidFill>
-                <a:latin typeface="Arial"/>
-                <a:ea typeface="Arial"/>
-                <a:cs typeface="Arial"/>
-              </a:rPr>
-              <a:t>EVIDENCE WE NEED</a:t>
+                  <a:srgbClr val="2F7D68"/>
+                </a:solidFill>
+                <a:latin typeface="Arial"/>
+                <a:ea typeface="Arial"/>
+                <a:cs typeface="Arial"/>
+              </a:rPr>
+              <a:t>MAXIMUM GAIN</a:t>
             </a:r>
           </a:p>
         </p:txBody>
@@ -9845,7 +9863,7 @@
               <a:buNone/>
               <a:defRPr sz="4800" b="1" i="0">
                 <a:solidFill>
-                  <a:srgbClr val="2E6F5C"/>
+                  <a:srgbClr val="17324D"/>
                 </a:solidFill>
                 <a:latin typeface="Georgia"/>
                 <a:ea typeface="Georgia"/>
@@ -9855,13 +9873,13 @@
             <a:r>
               <a:rPr sz="4800" b="1" i="0">
                 <a:solidFill>
-                  <a:srgbClr val="2E6F5C"/>
+                  <a:srgbClr val="17324D"/>
                 </a:solidFill>
                 <a:latin typeface="Georgia"/>
                 <a:ea typeface="Georgia"/>
                 <a:cs typeface="Georgia"/>
               </a:rPr>
-              <a:t>FUTURE</a:t>
+              <a:t>$634</a:t>
             </a:r>
           </a:p>
         </p:txBody>
@@ -9923,7 +9941,7 @@
                 <a:ea typeface="Arial"/>
                 <a:cs typeface="Arial"/>
               </a:rPr>
-              <a:t>0 observed outcomes today</a:t>
+              <a:t>One-contract SPY debit vertical</a:t>
             </a:r>
           </a:p>
         </p:txBody>
@@ -10000,7 +10018,7 @@
               <a:buNone/>
               <a:defRPr sz="3300" b="1" i="0">
                 <a:solidFill>
-                  <a:srgbClr val="0D2B43"/>
+                  <a:srgbClr val="2F7D68"/>
                 </a:solidFill>
                 <a:latin typeface="Georgia"/>
                 <a:ea typeface="Georgia"/>
@@ -10010,13 +10028,13 @@
             <a:r>
               <a:rPr sz="3300" b="1" i="0">
                 <a:solidFill>
-                  <a:srgbClr val="0D2B43"/>
+                  <a:srgbClr val="2F7D68"/>
                 </a:solidFill>
                 <a:latin typeface="Georgia"/>
                 <a:ea typeface="Georgia"/>
                 <a:cs typeface="Georgia"/>
               </a:rPr>
-              <a:t>G4</a:t>
+              <a:t>4/4</a:t>
             </a:r>
           </a:p>
         </p:txBody>
@@ -10078,7 +10096,7 @@
                 <a:ea typeface="Arial"/>
                 <a:cs typeface="Arial"/>
               </a:rPr>
-              <a:t>REJECTED AFTER SELECTION</a:t>
+              <a:t>SOURCE REMOVALS PASSED</a:t>
             </a:r>
           </a:p>
         </p:txBody>
@@ -10124,7 +10142,7 @@
               <a:buNone/>
               <a:defRPr sz="3300" b="1" i="0">
                 <a:solidFill>
-                  <a:srgbClr val="2E6F5C"/>
+                  <a:srgbClr val="2F7D68"/>
                 </a:solidFill>
                 <a:latin typeface="Georgia"/>
                 <a:ea typeface="Georgia"/>
@@ -10134,13 +10152,13 @@
             <a:r>
               <a:rPr sz="3300" b="1" i="0">
                 <a:solidFill>
-                  <a:srgbClr val="2E6F5C"/>
+                  <a:srgbClr val="2F7D68"/>
                 </a:solidFill>
                 <a:latin typeface="Georgia"/>
                 <a:ea typeface="Georgia"/>
                 <a:cs typeface="Georgia"/>
               </a:rPr>
-              <a:t>V1</a:t>
+              <a:t>32/32</a:t>
             </a:r>
           </a:p>
         </p:txBody>
@@ -10202,7 +10220,7 @@
                 <a:ea typeface="Arial"/>
                 <a:cs typeface="Arial"/>
               </a:rPr>
-              <a:t>MODELED NEXT-OPEN LEDGER</a:t>
+              <a:t>PERTURBATIONS PASSED</a:t>
             </a:r>
           </a:p>
         </p:txBody>
@@ -10248,7 +10266,7 @@
               <a:buNone/>
               <a:defRPr sz="3300" b="1" i="0">
                 <a:solidFill>
-                  <a:srgbClr val="0D2B43"/>
+                  <a:srgbClr val="2F7D68"/>
                 </a:solidFill>
                 <a:latin typeface="Georgia"/>
                 <a:ea typeface="Georgia"/>
@@ -10258,13 +10276,13 @@
             <a:r>
               <a:rPr sz="3300" b="1" i="0">
                 <a:solidFill>
-                  <a:srgbClr val="0D2B43"/>
+                  <a:srgbClr val="2F7D68"/>
                 </a:solidFill>
                 <a:latin typeface="Georgia"/>
                 <a:ea typeface="Georgia"/>
                 <a:cs typeface="Georgia"/>
               </a:rPr>
-              <a:t>115 / 116</a:t>
+              <a:t>EXACT</a:t>
             </a:r>
           </a:p>
         </p:txBody>
@@ -10326,7 +10344,7 @@
                 <a:ea typeface="Arial"/>
                 <a:cs typeface="Arial"/>
               </a:rPr>
-              <a:t>REGISTERED FUTURE-ONLY TESTS</a:t>
+              <a:t>ALPACA-COMPATIBLE FIELDS</a:t>
             </a:r>
           </a:p>
         </p:txBody>
@@ -10388,7 +10406,7 @@
                 <a:ea typeface="Arial"/>
                 <a:cs typeface="Arial"/>
               </a:rPr>
-              <a:t>A larger backtest never upgrades its own evidence class. Only a new test can.</a:t>
+              <a:t>If the evidence or the numbers change, Finly stops the trade.</a:t>
             </a:r>
           </a:p>
         </p:txBody>
@@ -10463,7 +10481,7 @@
               <a:buNone/>
               <a:defRPr sz="975" b="1" i="0">
                 <a:solidFill>
-                  <a:srgbClr val="8EB8A7"/>
+                  <a:srgbClr val="2F7D68"/>
                 </a:solidFill>
                 <a:latin typeface="Arial"/>
                 <a:ea typeface="Arial"/>
@@ -10473,13 +10491,13 @@
             <a:r>
               <a:rPr sz="975" b="1" i="0">
                 <a:solidFill>
-                  <a:srgbClr val="8EB8A7"/>
-                </a:solidFill>
-                <a:latin typeface="Arial"/>
-                <a:ea typeface="Arial"/>
-                <a:cs typeface="Arial"/>
-              </a:rPr>
-              <a:t>FORWARD PROOF</a:t>
+                  <a:srgbClr val="2F7D68"/>
+                </a:solidFill>
+                <a:latin typeface="Arial"/>
+                <a:ea typeface="Arial"/>
+                <a:cs typeface="Arial"/>
+              </a:rPr>
+              <a:t>WE BUILT THE CHECKS IN</a:t>
             </a:r>
           </a:p>
         </p:txBody>
@@ -10541,7 +10559,7 @@
                 <a:ea typeface="Georgia"/>
                 <a:cs typeface="Georgia"/>
               </a:rPr>
-              <a:t>Attempts 115 and 116 begin with zero outcomes - not borrowed confidence.</a:t>
+              <a:t>Every Finly decision comes with a receipt.</a:t>
             </a:r>
           </a:p>
         </p:txBody>
@@ -10634,7 +10652,7 @@
                 <a:ea typeface="Arial"/>
                 <a:cs typeface="Arial"/>
               </a:rPr>
-              <a:t>FINLY  /  PROOF BEFORE AUTHORITY</a:t>
+              <a:t>FINLY  /  AI TRADING WITH BUILT-IN CHECKS</a:t>
             </a:r>
           </a:p>
         </p:txBody>
@@ -10742,7 +10760,7 @@
               <a:buNone/>
               <a:defRPr sz="975" b="1" i="0">
                 <a:solidFill>
-                  <a:srgbClr val="8EB8A7"/>
+                  <a:srgbClr val="2F7D68"/>
                 </a:solidFill>
                 <a:latin typeface="Arial"/>
                 <a:ea typeface="Arial"/>
@@ -10752,13 +10770,13 @@
             <a:r>
               <a:rPr sz="975" b="1" i="0">
                 <a:solidFill>
-                  <a:srgbClr val="8EB8A7"/>
-                </a:solidFill>
-                <a:latin typeface="Arial"/>
-                <a:ea typeface="Arial"/>
-                <a:cs typeface="Arial"/>
-              </a:rPr>
-              <a:t>PUBLICLY REGISTERED</a:t>
+                  <a:srgbClr val="2F7D68"/>
+                </a:solidFill>
+                <a:latin typeface="Arial"/>
+                <a:ea typeface="Arial"/>
+                <a:cs typeface="Arial"/>
+              </a:rPr>
+              <a:t>WHAT'S IN THE RECEIPT</a:t>
             </a:r>
           </a:p>
         </p:txBody>
@@ -10820,7 +10838,7 @@
                 <a:ea typeface="Georgia"/>
                 <a:cs typeface="Georgia"/>
               </a:rPr>
-              <a:t>Two tests ask two different questions.</a:t>
+              <a:t>The evidence, the trade, the risk, and the result.</a:t>
             </a:r>
           </a:p>
         </p:txBody>
@@ -10882,7 +10900,7 @@
                 <a:ea typeface="Arial"/>
                 <a:cs typeface="Arial"/>
               </a:rPr>
-              <a:t>Attempt 115 freezes a downside-semivolatility challenger. Attempt 116 freezes a variance-risk-premium shadow. Each has zero observed outcomes. Neither supports a performance claim.</a:t>
+              <a:t>A judge can see what the AI concluded, what code built, what changed during testing, and what happened next. The receipt links back to the data and code behind it.</a:t>
             </a:r>
           </a:p>
         </p:txBody>
@@ -10959,7 +10977,7 @@
               <a:buNone/>
               <a:defRPr sz="3300" b="1" i="0">
                 <a:solidFill>
-                  <a:srgbClr val="FFFFFF"/>
+                  <a:srgbClr val="2F7D68"/>
                 </a:solidFill>
                 <a:latin typeface="Georgia"/>
                 <a:ea typeface="Georgia"/>
@@ -10969,13 +10987,13 @@
             <a:r>
               <a:rPr sz="3300" b="1" i="0">
                 <a:solidFill>
-                  <a:srgbClr val="FFFFFF"/>
+                  <a:srgbClr val="2F7D68"/>
                 </a:solidFill>
                 <a:latin typeface="Georgia"/>
                 <a:ea typeface="Georgia"/>
                 <a:cs typeface="Georgia"/>
               </a:rPr>
-              <a:t>115</a:t>
+              <a:t>VIEW</a:t>
             </a:r>
           </a:p>
         </p:txBody>
@@ -11037,7 +11055,7 @@
                 <a:ea typeface="Arial"/>
                 <a:cs typeface="Arial"/>
               </a:rPr>
-              <a:t>DOWNSIDE-SEMIVOLATILITY TEST</a:t>
+              <a:t>WHAT THE AI CONCLUDED</a:t>
             </a:r>
           </a:p>
         </p:txBody>
@@ -11083,7 +11101,7 @@
               <a:buNone/>
               <a:defRPr sz="3300" b="1" i="0">
                 <a:solidFill>
-                  <a:srgbClr val="8EB8A7"/>
+                  <a:srgbClr val="2F7D68"/>
                 </a:solidFill>
                 <a:latin typeface="Georgia"/>
                 <a:ea typeface="Georgia"/>
@@ -11093,13 +11111,13 @@
             <a:r>
               <a:rPr sz="3300" b="1" i="0">
                 <a:solidFill>
-                  <a:srgbClr val="8EB8A7"/>
+                  <a:srgbClr val="2F7D68"/>
                 </a:solidFill>
                 <a:latin typeface="Georgia"/>
                 <a:ea typeface="Georgia"/>
                 <a:cs typeface="Georgia"/>
               </a:rPr>
-              <a:t>116</a:t>
+              <a:t>ORDER</a:t>
             </a:r>
           </a:p>
         </p:txBody>
@@ -11161,7 +11179,7 @@
                 <a:ea typeface="Arial"/>
                 <a:cs typeface="Arial"/>
               </a:rPr>
-              <a:t>VARIANCE-RISK-PREMIUM SHADOW</a:t>
+              <a:t>WHAT CODE BUILT</a:t>
             </a:r>
           </a:p>
         </p:txBody>
@@ -11207,7 +11225,7 @@
               <a:buNone/>
               <a:defRPr sz="3300" b="1" i="0">
                 <a:solidFill>
-                  <a:srgbClr val="FFFFFF"/>
+                  <a:srgbClr val="2F7D68"/>
                 </a:solidFill>
                 <a:latin typeface="Georgia"/>
                 <a:ea typeface="Georgia"/>
@@ -11217,13 +11235,13 @@
             <a:r>
               <a:rPr sz="3300" b="1" i="0">
                 <a:solidFill>
-                  <a:srgbClr val="FFFFFF"/>
+                  <a:srgbClr val="2F7D68"/>
                 </a:solidFill>
                 <a:latin typeface="Georgia"/>
                 <a:ea typeface="Georgia"/>
                 <a:cs typeface="Georgia"/>
               </a:rPr>
-              <a:t>0</a:t>
+              <a:t>TESTS</a:t>
             </a:r>
           </a:p>
         </p:txBody>
@@ -11285,7 +11303,7 @@
                 <a:ea typeface="Arial"/>
                 <a:cs typeface="Arial"/>
               </a:rPr>
-              <a:t>OBSERVED OUTCOMES - ATTEMPT 115</a:t>
+              <a:t>WHAT CHANGED UNDER STRESS</a:t>
             </a:r>
           </a:p>
         </p:txBody>
@@ -11331,7 +11349,7 @@
               <a:buNone/>
               <a:defRPr sz="3300" b="1" i="0">
                 <a:solidFill>
-                  <a:srgbClr val="8EB8A7"/>
+                  <a:srgbClr val="2F7D68"/>
                 </a:solidFill>
                 <a:latin typeface="Georgia"/>
                 <a:ea typeface="Georgia"/>
@@ -11341,13 +11359,13 @@
             <a:r>
               <a:rPr sz="3300" b="1" i="0">
                 <a:solidFill>
-                  <a:srgbClr val="8EB8A7"/>
+                  <a:srgbClr val="2F7D68"/>
                 </a:solidFill>
                 <a:latin typeface="Georgia"/>
                 <a:ea typeface="Georgia"/>
                 <a:cs typeface="Georgia"/>
               </a:rPr>
-              <a:t>0</a:t>
+              <a:t>LOG</a:t>
             </a:r>
           </a:p>
         </p:txBody>
@@ -11409,7 +11427,7 @@
                 <a:ea typeface="Arial"/>
                 <a:cs typeface="Arial"/>
               </a:rPr>
-              <a:t>OBSERVED OUTCOMES - ATTEMPT 116</a:t>
+              <a:t>WHAT HAPPENED NEXT</a:t>
             </a:r>
           </a:p>
         </p:txBody>
@@ -11477,7 +11495,7 @@
         </p:spPr>
         <p:txBody>
           <a:bodyPr xmlns:a="http://schemas.openxmlformats.org/drawingml/2006/main" lIns="0" tIns="0" rIns="0" bIns="0" anchor="t">
-            <a:normAutofit fontScale="86172"/>
+            <a:normAutofit fontScale="95142"/>
           </a:bodyPr>
           <a:lstStyle xmlns:a="http://schemas.openxmlformats.org/drawingml/2006/main"/>
           <a:p xmlns:a="http://schemas.openxmlformats.org/drawingml/2006/main">
@@ -11504,7 +11522,7 @@
                 <a:ea typeface="Arial"/>
                 <a:cs typeface="Arial"/>
               </a:rPr>
-              <a:t>AS OF 2026-08-30 08:10:52Z: 0 + 0 outcomes</a:t>
+              <a:t>803 TESTS DISCOVERED · 801 PASSED · 0 FAILED</a:t>
             </a:r>
           </a:p>
           <a:p xmlns:a="http://schemas.openxmlformats.org/drawingml/2006/main">
@@ -11531,7 +11549,7 @@
                 <a:ea typeface="Arial"/>
                 <a:cs typeface="Arial"/>
               </a:rPr>
-              <a:t>No performance claim and no broker mutation authority.</a:t>
+              <a:t>Cloud run · exact revision · Alpaca paper account</a:t>
             </a:r>
           </a:p>
         </p:txBody>
@@ -11593,7 +11611,7 @@
                 <a:ea typeface="Arial"/>
                 <a:cs typeface="Arial"/>
               </a:rPr>
-              <a:t>GitHub records the registrations; it does not create outcome evidence, provider-origin proof, a broker fill, or future profitability.</a:t>
+              <a:t>Open the receipt or run the tests yourself.</a:t>
             </a:r>
           </a:p>
         </p:txBody>
@@ -11668,7 +11686,7 @@
               <a:buNone/>
               <a:defRPr sz="975" b="1" i="0">
                 <a:solidFill>
-                  <a:srgbClr val="8EB8A7"/>
+                  <a:srgbClr val="2F7D68"/>
                 </a:solidFill>
                 <a:latin typeface="Arial"/>
                 <a:ea typeface="Arial"/>
@@ -11678,13 +11696,13 @@
             <a:r>
               <a:rPr sz="975" b="1" i="0">
                 <a:solidFill>
-                  <a:srgbClr val="8EB8A7"/>
-                </a:solidFill>
-                <a:latin typeface="Arial"/>
-                <a:ea typeface="Arial"/>
-                <a:cs typeface="Arial"/>
-              </a:rPr>
-              <a:t>THE JUDGE TAKEAWAY</a:t>
+                  <a:srgbClr val="2F7D68"/>
+                </a:solidFill>
+                <a:latin typeface="Arial"/>
+                <a:ea typeface="Arial"/>
+                <a:cs typeface="Arial"/>
+              </a:rPr>
+              <a:t>TRY FINLY</a:t>
             </a:r>
           </a:p>
         </p:txBody>
@@ -11746,7 +11764,7 @@
                 <a:ea typeface="Georgia"/>
                 <a:cs typeface="Georgia"/>
               </a:rPr>
-              <a:t>Finly makes correction, rejection, and NO_TRADE part of the product.</a:t>
+              <a:t>Watch it trade. Check the numbers. Read the code.</a:t>
             </a:r>
           </a:p>
         </p:txBody>
@@ -11839,7 +11857,7 @@
                 <a:ea typeface="Arial"/>
                 <a:cs typeface="Arial"/>
               </a:rPr>
-              <a:t>FINLY  /  PROOF BEFORE AUTHORITY</a:t>
+              <a:t>FINLY  /  AI TRADING WITH BUILT-IN CHECKS</a:t>
             </a:r>
           </a:p>
         </p:txBody>
@@ -11947,7 +11965,7 @@
               <a:buNone/>
               <a:defRPr sz="975" b="1" i="0">
                 <a:solidFill>
-                  <a:srgbClr val="D49B91"/>
+                  <a:srgbClr val="2F7D68"/>
                 </a:solidFill>
                 <a:latin typeface="Arial"/>
                 <a:ea typeface="Arial"/>
@@ -11957,13 +11975,13 @@
             <a:r>
               <a:rPr sz="975" b="1" i="0">
                 <a:solidFill>
-                  <a:srgbClr val="D49B91"/>
-                </a:solidFill>
-                <a:latin typeface="Arial"/>
-                <a:ea typeface="Arial"/>
-                <a:cs typeface="Arial"/>
-              </a:rPr>
-              <a:t>HISTORICAL SIGNAL</a:t>
+                  <a:srgbClr val="2F7D68"/>
+                </a:solidFill>
+                <a:latin typeface="Arial"/>
+                <a:ea typeface="Arial"/>
+                <a:cs typeface="Arial"/>
+              </a:rPr>
+              <a:t>BACKTEST</a:t>
             </a:r>
           </a:p>
         </p:txBody>
@@ -12056,7 +12074,7 @@
                 <a:ea typeface="Arial"/>
                 <a:cs typeface="Arial"/>
               </a:rPr>
-              <a:t>G4 returned +967.11% versus SPY +580.82%; Finly rejected it after the DSR and multiplicity tests.</a:t>
+              <a:t>Historical simulation: $10,000 became $106,711—$38,629 more than SPY after modeled costs.</a:t>
             </a:r>
           </a:p>
         </p:txBody>
@@ -12102,7 +12120,7 @@
               <a:buNone/>
               <a:defRPr sz="975" b="1" i="0">
                 <a:solidFill>
-                  <a:srgbClr val="8EB8A7"/>
+                  <a:srgbClr val="2F7D68"/>
                 </a:solidFill>
                 <a:latin typeface="Arial"/>
                 <a:ea typeface="Arial"/>
@@ -12112,13 +12130,13 @@
             <a:r>
               <a:rPr sz="975" b="1" i="0">
                 <a:solidFill>
-                  <a:srgbClr val="8EB8A7"/>
-                </a:solidFill>
-                <a:latin typeface="Arial"/>
-                <a:ea typeface="Arial"/>
-                <a:cs typeface="Arial"/>
-              </a:rPr>
-              <a:t>PRODUCTION TRUTH</a:t>
+                  <a:srgbClr val="2F7D68"/>
+                </a:solidFill>
+                <a:latin typeface="Arial"/>
+                <a:ea typeface="Arial"/>
+                <a:cs typeface="Arial"/>
+              </a:rPr>
+              <a:t>STRESS TEST</a:t>
             </a:r>
           </a:p>
         </p:txBody>
@@ -12211,7 +12229,7 @@
                 <a:ea typeface="Arial"/>
                 <a:cs typeface="Arial"/>
               </a:rPr>
-              <a:t>V1 returned +15.39% at 5 bp with 8.12% volatility and -5.45% drawdown; SPY returned +33.52%.</a:t>
+              <a:t>The out-of-era stress test stayed ahead across 21/21 timing anchors and a 25 bp cost assumption.</a:t>
             </a:r>
           </a:p>
         </p:txBody>
@@ -12257,7 +12275,7 @@
               <a:buNone/>
               <a:defRPr sz="975" b="1" i="0">
                 <a:solidFill>
-                  <a:srgbClr val="8EB8A7"/>
+                  <a:srgbClr val="2F7D68"/>
                 </a:solidFill>
                 <a:latin typeface="Arial"/>
                 <a:ea typeface="Arial"/>
@@ -12267,13 +12285,13 @@
             <a:r>
               <a:rPr sz="975" b="1" i="0">
                 <a:solidFill>
-                  <a:srgbClr val="8EB8A7"/>
-                </a:solidFill>
-                <a:latin typeface="Arial"/>
-                <a:ea typeface="Arial"/>
-                <a:cs typeface="Arial"/>
-              </a:rPr>
-              <a:t>AUTHORITY DESIGN</a:t>
+                  <a:srgbClr val="2F7D68"/>
+                </a:solidFill>
+                <a:latin typeface="Arial"/>
+                <a:ea typeface="Arial"/>
+                <a:cs typeface="Arial"/>
+              </a:rPr>
+              <a:t>TRADE CHECKS</a:t>
             </a:r>
           </a:p>
         </p:txBody>
@@ -12366,7 +12384,7 @@
                 <a:ea typeface="Arial"/>
                 <a:cs typeface="Arial"/>
               </a:rPr>
-              <a:t>The model interprets evidence. Code owns exposure, order fields, and the final permit decision.</a:t>
+              <a:t>$366 maximum loss, $634 maximum gain, 4/4 source removals, and 32/32 input shocks.</a:t>
             </a:r>
           </a:p>
         </p:txBody>
@@ -12412,7 +12430,7 @@
               <a:buNone/>
               <a:defRPr sz="975" b="1" i="0">
                 <a:solidFill>
-                  <a:srgbClr val="8EB8A7"/>
+                  <a:srgbClr val="2F7D68"/>
                 </a:solidFill>
                 <a:latin typeface="Arial"/>
                 <a:ea typeface="Arial"/>
@@ -12422,13 +12440,13 @@
             <a:r>
               <a:rPr sz="975" b="1" i="0">
                 <a:solidFill>
-                  <a:srgbClr val="8EB8A7"/>
-                </a:solidFill>
-                <a:latin typeface="Arial"/>
-                <a:ea typeface="Arial"/>
-                <a:cs typeface="Arial"/>
-              </a:rPr>
-              <a:t>NEXT EVIDENCE</a:t>
+                  <a:srgbClr val="2F7D68"/>
+                </a:solidFill>
+                <a:latin typeface="Arial"/>
+                <a:ea typeface="Arial"/>
+                <a:cs typeface="Arial"/>
+              </a:rPr>
+              <a:t>LIVE ACCOUNT</a:t>
             </a:r>
           </a:p>
         </p:txBody>
@@ -12521,7 +12539,7 @@
                 <a:ea typeface="Arial"/>
                 <a:cs typeface="Arial"/>
               </a:rPr>
-              <a:t>Attempts 115 and 116 are registered future-only tests with zero outcomes and no performance claim.</a:t>
+              <a:t>A verified $100,000 Alpaca paper account makes every new decision visible and inspectable.</a:t>
             </a:r>
           </a:p>
         </p:txBody>
@@ -12583,7 +12601,34 @@
                 <a:ea typeface="Georgia"/>
                 <a:cs typeface="Georgia"/>
               </a:rPr>
-              <a:t>Publish the tempting result. Reject what has not earned authority. Make the next claim falsifiable.</a:t>
+              <a:t>AI reads the market. Code guards the account.</a:t>
+            </a:r>
+          </a:p>
+          <a:p xmlns:a="http://schemas.openxmlformats.org/drawingml/2006/main">
+            <a:pPr algn="l">
+              <a:lnSpc>
+                <a:spcPct val="100000"/>
+              </a:lnSpc>
+              <a:buNone/>
+              <a:defRPr sz="2850" b="1" i="0">
+                <a:solidFill>
+                  <a:srgbClr val="FFFFFF"/>
+                </a:solidFill>
+                <a:latin typeface="Georgia"/>
+                <a:ea typeface="Georgia"/>
+                <a:cs typeface="Georgia"/>
+              </a:defRPr>
+            </a:pPr>
+            <a:r>
+              <a:rPr sz="2850" b="1" i="0">
+                <a:solidFill>
+                  <a:srgbClr val="FFFFFF"/>
+                </a:solidFill>
+                <a:latin typeface="Georgia"/>
+                <a:ea typeface="Georgia"/>
+                <a:cs typeface="Georgia"/>
+              </a:rPr>
+              <a:t>owlsowo.github.io/finly-bot</a:t>
             </a:r>
           </a:p>
         </p:txBody>

</xml_diff>

<commit_message>
feat: ship final judge-facing release
</commit_message>
<xml_diff>
--- a/public/judge/Finly_Consulting_Deck.pptx
+++ b/public/judge/Finly_Consulting_Deck.pptx
@@ -2,21 +2,21 @@
 <file path=ppt/presentation.xml><?xml version="1.0" encoding="utf-8"?>
 <p:presentation xmlns:p="http://schemas.openxmlformats.org/presentationml/2006/main">
   <p:sldMasterIdLst>
-    <p:sldMasterId xmlns:r="http://schemas.openxmlformats.org/officeDocument/2006/relationships" id="2147483648" r:id="R72d63591dea94714"/>
+    <p:sldMasterId xmlns:r="http://schemas.openxmlformats.org/officeDocument/2006/relationships" id="2147483648" r:id="R5b100b366350446e"/>
   </p:sldMasterIdLst>
   <p:notesMasterIdLst>
-    <p:notesMasterId xmlns:r="http://schemas.openxmlformats.org/officeDocument/2006/relationships" r:id="Rc396dc0225d34e1e"/>
+    <p:notesMasterId xmlns:r="http://schemas.openxmlformats.org/officeDocument/2006/relationships" r:id="Ra754659c816b4ff6"/>
   </p:notesMasterIdLst>
   <p:sldIdLst>
-    <p:sldId xmlns:r="http://schemas.openxmlformats.org/officeDocument/2006/relationships" id="256" r:id="Ra55aac082ff34ad6"/>
-    <p:sldId xmlns:r="http://schemas.openxmlformats.org/officeDocument/2006/relationships" id="257" r:id="R20364cc8cef7408d"/>
-    <p:sldId xmlns:r="http://schemas.openxmlformats.org/officeDocument/2006/relationships" id="258" r:id="Rb9476c1cdd8a42de"/>
-    <p:sldId xmlns:r="http://schemas.openxmlformats.org/officeDocument/2006/relationships" id="259" r:id="Ra912013588cf4256"/>
-    <p:sldId xmlns:r="http://schemas.openxmlformats.org/officeDocument/2006/relationships" id="260" r:id="R2e4b09a6f57244d9"/>
-    <p:sldId xmlns:r="http://schemas.openxmlformats.org/officeDocument/2006/relationships" id="261" r:id="R39f938cb49f24f7e"/>
-    <p:sldId xmlns:r="http://schemas.openxmlformats.org/officeDocument/2006/relationships" id="262" r:id="R36d01063f3a1411a"/>
-    <p:sldId xmlns:r="http://schemas.openxmlformats.org/officeDocument/2006/relationships" id="263" r:id="R0a677ac069e2459a"/>
-    <p:sldId xmlns:r="http://schemas.openxmlformats.org/officeDocument/2006/relationships" id="264" r:id="R9a84bc616eab4356"/>
+    <p:sldId xmlns:r="http://schemas.openxmlformats.org/officeDocument/2006/relationships" id="256" r:id="R05e1bdfeb6314b10"/>
+    <p:sldId xmlns:r="http://schemas.openxmlformats.org/officeDocument/2006/relationships" id="257" r:id="Rc78a2622294b4d05"/>
+    <p:sldId xmlns:r="http://schemas.openxmlformats.org/officeDocument/2006/relationships" id="258" r:id="R53e29f9b96274d53"/>
+    <p:sldId xmlns:r="http://schemas.openxmlformats.org/officeDocument/2006/relationships" id="259" r:id="R2a2628b11e144ea0"/>
+    <p:sldId xmlns:r="http://schemas.openxmlformats.org/officeDocument/2006/relationships" id="260" r:id="R4c34cbd2a6864184"/>
+    <p:sldId xmlns:r="http://schemas.openxmlformats.org/officeDocument/2006/relationships" id="261" r:id="R6899e37b01bb4062"/>
+    <p:sldId xmlns:r="http://schemas.openxmlformats.org/officeDocument/2006/relationships" id="262" r:id="R0031ddcd0d5b4633"/>
+    <p:sldId xmlns:r="http://schemas.openxmlformats.org/officeDocument/2006/relationships" id="263" r:id="Rdf16fe7f35cf46ce"/>
+    <p:sldId xmlns:r="http://schemas.openxmlformats.org/officeDocument/2006/relationships" id="264" r:id="R28d46ff0768044dd"/>
   </p:sldIdLst>
   <p:sldSz cx="12192000" cy="6858000"/>
   <p:notesSz cx="6858000" cy="9144000"/>
@@ -890,6 +890,21 @@
           </a:p>
           <a:p xmlns:a="http://schemas.openxmlformats.org/drawingml/2006/main">
             <a:r>
+              <a:t>- Historical claim boundary: https://owlsowo.github.io/finly-bot/data/quantitative_release_gate.json</a:t>
+            </a:r>
+          </a:p>
+          <a:p xmlns:a="http://schemas.openxmlformats.org/drawingml/2006/main">
+            <a:r>
+              <a:t>- Human-frozen competition protocol: https://github.com/owlsowo/finly-bot/blob/main/config/g4-official-production.json</a:t>
+            </a:r>
+          </a:p>
+          <a:p xmlns:a="http://schemas.openxmlformats.org/drawingml/2006/main">
+            <a:r>
+              <a:t>- Separate forward-score contract: https://github.com/owlsowo/finly-bot/blob/main/config/competition-forward-profit.json</a:t>
+            </a:r>
+          </a:p>
+          <a:p xmlns:a="http://schemas.openxmlformats.org/drawingml/2006/main">
+            <a:r>
               <a:t>- Screenshot is project-owned and records paper-account state, not a live-return claim.</a:t>
             </a:r>
           </a:p>
@@ -1223,7 +1238,7 @@
   </p:cSld>
   <p:clrMap bg1="lt1" tx1="dk1" bg2="lt2" tx2="dk2" accent1="accent1" accent2="accent2" accent3="accent3" accent4="accent4" accent5="accent5" accent6="accent6" hlink="hlink" folHlink="folHlink"/>
   <p:sldLayoutIdLst>
-    <p:sldLayoutId xmlns:r="http://schemas.openxmlformats.org/officeDocument/2006/relationships" id="2147483649" r:id="R2a0177878dc94210"/>
+    <p:sldLayoutId xmlns:r="http://schemas.openxmlformats.org/officeDocument/2006/relationships" id="2147483649" r:id="Rb14afe20bd9e446d"/>
   </p:sldLayoutIdLst>
   <p:txStyles>
     <p:titleStyle>
@@ -2260,7 +2275,7 @@
           <p:nvPr/>
         </p:nvPicPr>
         <p:blipFill>
-          <a:blip xmlns:r="http://schemas.openxmlformats.org/officeDocument/2006/relationships" xmlns:a="http://schemas.openxmlformats.org/drawingml/2006/main" r:embed="Re898d29fc9e64c9f"/>
+          <a:blip xmlns:r="http://schemas.openxmlformats.org/officeDocument/2006/relationships" xmlns:a="http://schemas.openxmlformats.org/drawingml/2006/main" r:embed="R7393e14f104c447b"/>
           <a:stretch xmlns:a="http://schemas.openxmlformats.org/drawingml/2006/main"/>
         </p:blipFill>
         <p:spPr>
@@ -4050,7 +4065,7 @@
         </p:xfrm>
         <a:graphic xmlns:a="http://schemas.openxmlformats.org/drawingml/2006/main">
           <a:graphicData uri="http://schemas.openxmlformats.org/drawingml/2006/chart">
-            <c:chart xmlns:r="http://schemas.openxmlformats.org/officeDocument/2006/relationships" xmlns:c="http://schemas.openxmlformats.org/drawingml/2006/chart" r:id="Rd515d3419c364e46"/>
+            <c:chart xmlns:r="http://schemas.openxmlformats.org/officeDocument/2006/relationships" xmlns:c="http://schemas.openxmlformats.org/drawingml/2006/chart" r:id="R11a62c12adbe4c6e"/>
           </a:graphicData>
         </a:graphic>
       </p:graphicFrame>
@@ -4913,7 +4928,7 @@
                 <a:ea typeface="Arial"/>
                 <a:cs typeface="Arial"/>
               </a:rPr>
-              <a:t>WE TESTED IT AGAIN</a:t>
+              <a:t>A SECOND HISTORICAL PROXY</a:t>
             </a:r>
           </a:p>
         </p:txBody>
@@ -4975,7 +4990,7 @@
                 <a:ea typeface="Georgia"/>
                 <a:cs typeface="Georgia"/>
               </a:rPr>
-              <a:t>We reran the same rule on 80 years of earlier industry data.</a:t>
+              <a:t>A fixed industry proxy carried the idea across 80 earlier years.</a:t>
             </a:r>
           </a:p>
         </p:txBody>
@@ -5147,7 +5162,7 @@
         </p:xfrm>
         <a:graphic xmlns:a="http://schemas.openxmlformats.org/drawingml/2006/main">
           <a:graphicData uri="http://schemas.openxmlformats.org/drawingml/2006/chart">
-            <c:chart xmlns:r="http://schemas.openxmlformats.org/officeDocument/2006/relationships" xmlns:c="http://schemas.openxmlformats.org/drawingml/2006/chart" r:id="R9c33fd115ace44a7"/>
+            <c:chart xmlns:r="http://schemas.openxmlformats.org/officeDocument/2006/relationships" xmlns:c="http://schemas.openxmlformats.org/drawingml/2006/chart" r:id="R5ac05c9bd4ed4e8f"/>
           </a:graphicData>
         </a:graphic>
       </p:graphicFrame>
@@ -8552,7 +8567,7 @@
                 <a:ea typeface="Georgia"/>
                 <a:cs typeface="Georgia"/>
               </a:rPr>
-              <a:t>You can watch the $100,000 Alpaca paper account live.</a:t>
+              <a:t>The $100,000 paper account turns historical upside into a forward test.</a:t>
             </a:r>
           </a:p>
         </p:txBody>
@@ -8754,7 +8769,7 @@
           <p:nvPr/>
         </p:nvPicPr>
         <p:blipFill>
-          <a:blip xmlns:r="http://schemas.openxmlformats.org/officeDocument/2006/relationships" xmlns:a="http://schemas.openxmlformats.org/drawingml/2006/main" r:embed="Refb987931d664497"/>
+          <a:blip xmlns:r="http://schemas.openxmlformats.org/officeDocument/2006/relationships" xmlns:a="http://schemas.openxmlformats.org/drawingml/2006/main" r:embed="R4e9c9ac5d6e34b8e"/>
           <a:srcRect xmlns:a="http://schemas.openxmlformats.org/drawingml/2006/main" l="0" t="5441" r="0" b="5441"/>
           <a:stretch xmlns:a="http://schemas.openxmlformats.org/drawingml/2006/main">
             <a:fillRect l="0" t="0" r="0" b="0"/>
@@ -9234,7 +9249,7 @@
         </p:spPr>
         <p:txBody>
           <a:bodyPr xmlns:a="http://schemas.openxmlformats.org/drawingml/2006/main" lIns="0" tIns="0" rIns="0" bIns="0" anchor="t">
-            <a:normAutofit fontScale="95899"/>
+            <a:normAutofit fontScale="74023"/>
           </a:bodyPr>
           <a:lstStyle xmlns:a="http://schemas.openxmlformats.org/drawingml/2006/main"/>
           <a:p xmlns:a="http://schemas.openxmlformats.org/drawingml/2006/main">
@@ -9261,7 +9276,7 @@
                 <a:ea typeface="Arial"/>
                 <a:cs typeface="Arial"/>
               </a:rPr>
-              <a:t>The dashboard shows equity, positions, risk, and the latest decision. It never publishes credentials or private account identifiers.</a:t>
+              <a:t>The research gate treated the upside as a reason to test G4—not a statistical promotion. A human froze the contest allocation; this account supplies the separate score.</a:t>
             </a:r>
           </a:p>
         </p:txBody>
@@ -11522,7 +11537,7 @@
                 <a:ea typeface="Arial"/>
                 <a:cs typeface="Arial"/>
               </a:rPr>
-              <a:t>803 TESTS DISCOVERED · 801 PASSED · 0 FAILED</a:t>
+              <a:t>806 TESTS DISCOVERED · 804 PASSED · 0 FAILED</a:t>
             </a:r>
           </a:p>
           <a:p xmlns:a="http://schemas.openxmlformats.org/drawingml/2006/main">
@@ -11764,7 +11779,7 @@
                 <a:ea typeface="Georgia"/>
                 <a:cs typeface="Georgia"/>
               </a:rPr>
-              <a:t>Watch it trade. Check the numbers. Read the code.</a:t>
+              <a:t>Follow the paper test. Check the numbers. Read the code.</a:t>
             </a:r>
           </a:p>
         </p:txBody>

</xml_diff>

<commit_message>
fix: polish final public release
</commit_message>
<xml_diff>
--- a/public/judge/Finly_Consulting_Deck.pptx
+++ b/public/judge/Finly_Consulting_Deck.pptx
@@ -2,21 +2,21 @@
 <file path=ppt/presentation.xml><?xml version="1.0" encoding="utf-8"?>
 <p:presentation xmlns:p="http://schemas.openxmlformats.org/presentationml/2006/main">
   <p:sldMasterIdLst>
-    <p:sldMasterId xmlns:r="http://schemas.openxmlformats.org/officeDocument/2006/relationships" id="2147483648" r:id="R5b100b366350446e"/>
+    <p:sldMasterId xmlns:r="http://schemas.openxmlformats.org/officeDocument/2006/relationships" id="2147483648" r:id="Rcbb9f258409b4b82"/>
   </p:sldMasterIdLst>
   <p:notesMasterIdLst>
-    <p:notesMasterId xmlns:r="http://schemas.openxmlformats.org/officeDocument/2006/relationships" r:id="Ra754659c816b4ff6"/>
+    <p:notesMasterId xmlns:r="http://schemas.openxmlformats.org/officeDocument/2006/relationships" r:id="R1a8d8ebdfdbe427f"/>
   </p:notesMasterIdLst>
   <p:sldIdLst>
-    <p:sldId xmlns:r="http://schemas.openxmlformats.org/officeDocument/2006/relationships" id="256" r:id="R05e1bdfeb6314b10"/>
-    <p:sldId xmlns:r="http://schemas.openxmlformats.org/officeDocument/2006/relationships" id="257" r:id="Rc78a2622294b4d05"/>
-    <p:sldId xmlns:r="http://schemas.openxmlformats.org/officeDocument/2006/relationships" id="258" r:id="R53e29f9b96274d53"/>
-    <p:sldId xmlns:r="http://schemas.openxmlformats.org/officeDocument/2006/relationships" id="259" r:id="R2a2628b11e144ea0"/>
-    <p:sldId xmlns:r="http://schemas.openxmlformats.org/officeDocument/2006/relationships" id="260" r:id="R4c34cbd2a6864184"/>
-    <p:sldId xmlns:r="http://schemas.openxmlformats.org/officeDocument/2006/relationships" id="261" r:id="R6899e37b01bb4062"/>
-    <p:sldId xmlns:r="http://schemas.openxmlformats.org/officeDocument/2006/relationships" id="262" r:id="R0031ddcd0d5b4633"/>
-    <p:sldId xmlns:r="http://schemas.openxmlformats.org/officeDocument/2006/relationships" id="263" r:id="Rdf16fe7f35cf46ce"/>
-    <p:sldId xmlns:r="http://schemas.openxmlformats.org/officeDocument/2006/relationships" id="264" r:id="R28d46ff0768044dd"/>
+    <p:sldId xmlns:r="http://schemas.openxmlformats.org/officeDocument/2006/relationships" id="256" r:id="Rc01048c3deb942d5"/>
+    <p:sldId xmlns:r="http://schemas.openxmlformats.org/officeDocument/2006/relationships" id="257" r:id="R62d07eb9f5254c9e"/>
+    <p:sldId xmlns:r="http://schemas.openxmlformats.org/officeDocument/2006/relationships" id="258" r:id="Ra1bfc43e6bff4942"/>
+    <p:sldId xmlns:r="http://schemas.openxmlformats.org/officeDocument/2006/relationships" id="259" r:id="Rdab8f7f22b6d45ba"/>
+    <p:sldId xmlns:r="http://schemas.openxmlformats.org/officeDocument/2006/relationships" id="260" r:id="R315f4daae74a472e"/>
+    <p:sldId xmlns:r="http://schemas.openxmlformats.org/officeDocument/2006/relationships" id="261" r:id="Ra7dbccfb22904a63"/>
+    <p:sldId xmlns:r="http://schemas.openxmlformats.org/officeDocument/2006/relationships" id="262" r:id="R5f249d3223614dc7"/>
+    <p:sldId xmlns:r="http://schemas.openxmlformats.org/officeDocument/2006/relationships" id="263" r:id="R8cb148666af1490c"/>
+    <p:sldId xmlns:r="http://schemas.openxmlformats.org/officeDocument/2006/relationships" id="264" r:id="R5548d0ef6e1749e4"/>
   </p:sldIdLst>
   <p:sldSz cx="12192000" cy="6858000"/>
   <p:notesSz cx="6858000" cy="9144000"/>
@@ -1238,7 +1238,7 @@
   </p:cSld>
   <p:clrMap bg1="lt1" tx1="dk1" bg2="lt2" tx2="dk2" accent1="accent1" accent2="accent2" accent3="accent3" accent4="accent4" accent5="accent5" accent6="accent6" hlink="hlink" folHlink="folHlink"/>
   <p:sldLayoutIdLst>
-    <p:sldLayoutId xmlns:r="http://schemas.openxmlformats.org/officeDocument/2006/relationships" id="2147483649" r:id="Rb14afe20bd9e446d"/>
+    <p:sldLayoutId xmlns:r="http://schemas.openxmlformats.org/officeDocument/2006/relationships" id="2147483649" r:id="R2e440a6764c9415d"/>
   </p:sldLayoutIdLst>
   <p:txStyles>
     <p:titleStyle>
@@ -2275,7 +2275,7 @@
           <p:nvPr/>
         </p:nvPicPr>
         <p:blipFill>
-          <a:blip xmlns:r="http://schemas.openxmlformats.org/officeDocument/2006/relationships" xmlns:a="http://schemas.openxmlformats.org/drawingml/2006/main" r:embed="R7393e14f104c447b"/>
+          <a:blip xmlns:r="http://schemas.openxmlformats.org/officeDocument/2006/relationships" xmlns:a="http://schemas.openxmlformats.org/drawingml/2006/main" r:embed="R0db79b6610554e8c"/>
           <a:stretch xmlns:a="http://schemas.openxmlformats.org/drawingml/2006/main"/>
         </p:blipFill>
         <p:spPr>
@@ -4065,7 +4065,7 @@
         </p:xfrm>
         <a:graphic xmlns:a="http://schemas.openxmlformats.org/drawingml/2006/main">
           <a:graphicData uri="http://schemas.openxmlformats.org/drawingml/2006/chart">
-            <c:chart xmlns:r="http://schemas.openxmlformats.org/officeDocument/2006/relationships" xmlns:c="http://schemas.openxmlformats.org/drawingml/2006/chart" r:id="R11a62c12adbe4c6e"/>
+            <c:chart xmlns:r="http://schemas.openxmlformats.org/officeDocument/2006/relationships" xmlns:c="http://schemas.openxmlformats.org/drawingml/2006/chart" r:id="R7a0b0555b1a64d92"/>
           </a:graphicData>
         </a:graphic>
       </p:graphicFrame>
@@ -5162,7 +5162,7 @@
         </p:xfrm>
         <a:graphic xmlns:a="http://schemas.openxmlformats.org/drawingml/2006/main">
           <a:graphicData uri="http://schemas.openxmlformats.org/drawingml/2006/chart">
-            <c:chart xmlns:r="http://schemas.openxmlformats.org/officeDocument/2006/relationships" xmlns:c="http://schemas.openxmlformats.org/drawingml/2006/chart" r:id="R5ac05c9bd4ed4e8f"/>
+            <c:chart xmlns:r="http://schemas.openxmlformats.org/officeDocument/2006/relationships" xmlns:c="http://schemas.openxmlformats.org/drawingml/2006/chart" r:id="Rb12c68fbc2774333"/>
           </a:graphicData>
         </a:graphic>
       </p:graphicFrame>
@@ -8769,7 +8769,7 @@
           <p:nvPr/>
         </p:nvPicPr>
         <p:blipFill>
-          <a:blip xmlns:r="http://schemas.openxmlformats.org/officeDocument/2006/relationships" xmlns:a="http://schemas.openxmlformats.org/drawingml/2006/main" r:embed="R4e9c9ac5d6e34b8e"/>
+          <a:blip xmlns:r="http://schemas.openxmlformats.org/officeDocument/2006/relationships" xmlns:a="http://schemas.openxmlformats.org/drawingml/2006/main" r:embed="Rd8c128e139c04857"/>
           <a:srcRect xmlns:a="http://schemas.openxmlformats.org/drawingml/2006/main" l="0" t="5441" r="0" b="5441"/>
           <a:stretch xmlns:a="http://schemas.openxmlformats.org/drawingml/2006/main">
             <a:fillRect l="0" t="0" r="0" b="0"/>
@@ -11510,7 +11510,7 @@
         </p:spPr>
         <p:txBody>
           <a:bodyPr xmlns:a="http://schemas.openxmlformats.org/drawingml/2006/main" lIns="0" tIns="0" rIns="0" bIns="0" anchor="t">
-            <a:normAutofit fontScale="95142"/>
+            <a:normAutofit fontScale="95137"/>
           </a:bodyPr>
           <a:lstStyle xmlns:a="http://schemas.openxmlformats.org/drawingml/2006/main"/>
           <a:p xmlns:a="http://schemas.openxmlformats.org/drawingml/2006/main">

</xml_diff>

<commit_message>
docs: simplify deck opening slide
</commit_message>
<xml_diff>
--- a/public/judge/Finly_Consulting_Deck.pptx
+++ b/public/judge/Finly_Consulting_Deck.pptx
@@ -2,21 +2,21 @@
 <file path=ppt/presentation.xml><?xml version="1.0" encoding="utf-8"?>
 <p:presentation xmlns:p="http://schemas.openxmlformats.org/presentationml/2006/main">
   <p:sldMasterIdLst>
-    <p:sldMasterId xmlns:r="http://schemas.openxmlformats.org/officeDocument/2006/relationships" id="2147483648" r:id="Rd09696a45ced48ec"/>
+    <p:sldMasterId xmlns:r="http://schemas.openxmlformats.org/officeDocument/2006/relationships" id="2147483648" r:id="Ra20923fac73747f5"/>
   </p:sldMasterIdLst>
   <p:notesMasterIdLst>
-    <p:notesMasterId xmlns:r="http://schemas.openxmlformats.org/officeDocument/2006/relationships" r:id="R4bc3c24d50b04186"/>
+    <p:notesMasterId xmlns:r="http://schemas.openxmlformats.org/officeDocument/2006/relationships" r:id="Rd5fd90e74cfb4851"/>
   </p:notesMasterIdLst>
   <p:sldIdLst>
-    <p:sldId xmlns:r="http://schemas.openxmlformats.org/officeDocument/2006/relationships" id="256" r:id="R063f7684141d412c"/>
-    <p:sldId xmlns:r="http://schemas.openxmlformats.org/officeDocument/2006/relationships" id="257" r:id="Rd0e71d2e5de84087"/>
-    <p:sldId xmlns:r="http://schemas.openxmlformats.org/officeDocument/2006/relationships" id="258" r:id="R2571906e78db4cda"/>
-    <p:sldId xmlns:r="http://schemas.openxmlformats.org/officeDocument/2006/relationships" id="259" r:id="R027f5746eb8e4d69"/>
-    <p:sldId xmlns:r="http://schemas.openxmlformats.org/officeDocument/2006/relationships" id="260" r:id="Rf308ed66cf8c43a4"/>
-    <p:sldId xmlns:r="http://schemas.openxmlformats.org/officeDocument/2006/relationships" id="261" r:id="R6559c9234848423c"/>
-    <p:sldId xmlns:r="http://schemas.openxmlformats.org/officeDocument/2006/relationships" id="262" r:id="R47ce9e6a1ae34e7d"/>
-    <p:sldId xmlns:r="http://schemas.openxmlformats.org/officeDocument/2006/relationships" id="263" r:id="R1ce95ed4c12b4a36"/>
-    <p:sldId xmlns:r="http://schemas.openxmlformats.org/officeDocument/2006/relationships" id="264" r:id="Rc4cf87e7bf234a12"/>
+    <p:sldId xmlns:r="http://schemas.openxmlformats.org/officeDocument/2006/relationships" id="256" r:id="Ra859c8bc387444aa"/>
+    <p:sldId xmlns:r="http://schemas.openxmlformats.org/officeDocument/2006/relationships" id="257" r:id="R3065e087c43b4367"/>
+    <p:sldId xmlns:r="http://schemas.openxmlformats.org/officeDocument/2006/relationships" id="258" r:id="Rfa38649777ee401c"/>
+    <p:sldId xmlns:r="http://schemas.openxmlformats.org/officeDocument/2006/relationships" id="259" r:id="R104f10e0387844c6"/>
+    <p:sldId xmlns:r="http://schemas.openxmlformats.org/officeDocument/2006/relationships" id="260" r:id="Re376941d3c1e4145"/>
+    <p:sldId xmlns:r="http://schemas.openxmlformats.org/officeDocument/2006/relationships" id="261" r:id="Re12dfaee93d846ba"/>
+    <p:sldId xmlns:r="http://schemas.openxmlformats.org/officeDocument/2006/relationships" id="262" r:id="R90185166963a4e15"/>
+    <p:sldId xmlns:r="http://schemas.openxmlformats.org/officeDocument/2006/relationships" id="263" r:id="R3e5c236902ad4745"/>
+    <p:sldId xmlns:r="http://schemas.openxmlformats.org/officeDocument/2006/relationships" id="264" r:id="R72a0ae7bbbde4482"/>
   </p:sldIdLst>
   <p:sldSz cx="12192000" cy="6858000"/>
   <p:notesSz cx="6858000" cy="9144000"/>
@@ -166,9 +166,9 @@
 </file>
 
 <file path=ppt/notesMasters/theme/theme3.xml><?xml version="1.0" encoding="utf-8"?>
-<a:theme xmlns:a="http://schemas.openxmlformats.org/drawingml/2006/main" name="ChatGPT">
+<a:theme xmlns:a="http://schemas.openxmlformats.org/drawingml/2006/main" name="Finly">
   <a:themeElements>
-    <a:clrScheme name="ChatGPT">
+    <a:clrScheme name="Finly">
       <a:dk1>
         <a:srgbClr val="000000"/>
       </a:dk1>
@@ -218,7 +218,7 @@
         <a:cs typeface="Calibri"/>
       </a:minorFont>
     </a:fontScheme>
-    <a:fmtScheme name="ChatGPT">
+    <a:fmtScheme name="Finly">
       <a:fillStyleLst>
         <a:solidFill>
           <a:schemeClr val="phClr"/>
@@ -470,7 +470,7 @@
           </a:p>
           <a:p xmlns:a="http://schemas.openxmlformats.org/drawingml/2006/main">
             <a:r>
-              <a:t>- Product screenshot and bull-horn mark are project-owned.</a:t>
+              <a:t>- The bull-horn mark is project-owned.</a:t>
             </a:r>
           </a:p>
         </p:txBody>
@@ -1268,7 +1268,7 @@
   </p:cSld>
   <p:clrMap bg1="lt1" tx1="dk1" bg2="lt2" tx2="dk2" accent1="accent1" accent2="accent2" accent3="accent3" accent4="accent4" accent5="accent5" accent6="accent6" hlink="hlink" folHlink="folHlink"/>
   <p:sldLayoutIdLst>
-    <p:sldLayoutId xmlns:r="http://schemas.openxmlformats.org/officeDocument/2006/relationships" id="2147483649" r:id="Ra40cf526e6974f41"/>
+    <p:sldLayoutId xmlns:r="http://schemas.openxmlformats.org/officeDocument/2006/relationships" id="2147483649" r:id="R1d6fbef649444e03"/>
   </p:sldLayoutIdLst>
   <p:txStyles>
     <p:titleStyle>
@@ -1551,9 +1551,9 @@
 </file>
 
 <file path=ppt/slideMasters/theme/theme2.xml><?xml version="1.0" encoding="utf-8"?>
-<a:theme xmlns:a="http://schemas.openxmlformats.org/drawingml/2006/main" name="ChatGPT">
+<a:theme xmlns:a="http://schemas.openxmlformats.org/drawingml/2006/main" name="Finly">
   <a:themeElements>
-    <a:clrScheme name="ChatGPT">
+    <a:clrScheme name="Finly">
       <a:dk1>
         <a:srgbClr val="000000"/>
       </a:dk1>
@@ -1603,7 +1603,7 @@
         <a:cs typeface="Calibri"/>
       </a:minorFont>
     </a:fontScheme>
-    <a:fmtScheme name="ChatGPT">
+    <a:fmtScheme name="Finly">
       <a:fillStyleLst>
         <a:solidFill>
           <a:schemeClr val="phClr"/>
@@ -4062,17 +4062,17 @@
       </p:grpSpPr>
       <p:pic>
         <p:nvPicPr>
-          <p:cNvPr id="20" name=""/>
+          <p:cNvPr id="22" name=""/>
           <p:cNvPicPr>
             <a:picLocks xmlns:a="http://schemas.openxmlformats.org/drawingml/2006/main" noChangeAspect="1"/>
           </p:cNvPicPr>
           <p:nvPr/>
         </p:nvPicPr>
         <p:blipFill>
-          <a:blip xmlns:r="http://schemas.openxmlformats.org/officeDocument/2006/relationships" xmlns:a="http://schemas.openxmlformats.org/drawingml/2006/main" r:embed="Ra885f96337934cb3">
+          <a:blip xmlns:r="http://schemas.openxmlformats.org/officeDocument/2006/relationships" xmlns:a="http://schemas.openxmlformats.org/drawingml/2006/main" r:embed="R03041ff2cb554ddf">
             <a:extLst>
               <a:ext uri="{96DAC541-7B7A-43D3-8B79-37D633B846F1}">
-                <asvg:svgBlip xmlns:asvg="http://schemas.microsoft.com/office/drawing/2016/SVG/main" r:embed="Rcb28f9617a904bdb"/>
+                <asvg:svgBlip xmlns:asvg="http://schemas.microsoft.com/office/drawing/2016/SVG/main" r:embed="R6151009f58734969"/>
               </a:ext>
             </a:extLst>
           </a:blip>
@@ -4093,7 +4093,7 @@
           <p:cNvPr id="2" name="">
             <a:extLst xmlns:a="http://schemas.openxmlformats.org/drawingml/2006/main">
               <a:ext uri="{FF2B5EF4-FFF2-40B4-BE49-F238E27FC236}">
-                <a16:creationId xmlns:a16="http://schemas.microsoft.com/office/drawing/2014/main" id="{E8F4A112-45E6-4E21-B4EE-24C2BAA45486}"/>
+                <a16:creationId xmlns:a16="http://schemas.microsoft.com/office/drawing/2014/main" id="{D8C92A00-A82D-4936-814C-476443017DCB}"/>
               </a:ext>
             </a:extLst>
           </p:cNvPr>
@@ -4143,7 +4143,7 @@
           <p:cNvPr id="3" name="">
             <a:extLst xmlns:a="http://schemas.openxmlformats.org/drawingml/2006/main">
               <a:ext uri="{FF2B5EF4-FFF2-40B4-BE49-F238E27FC236}">
-                <a16:creationId xmlns:a16="http://schemas.microsoft.com/office/drawing/2014/main" id="{59D6F19D-EE10-430E-B9FD-135DDB58D294}"/>
+                <a16:creationId xmlns:a16="http://schemas.microsoft.com/office/drawing/2014/main" id="{F094C821-A297-426A-8C61-53AE228D55D1}"/>
               </a:ext>
             </a:extLst>
           </p:cNvPr>
@@ -4193,7 +4193,7 @@
           <p:cNvPr id="4" name="">
             <a:extLst xmlns:a="http://schemas.openxmlformats.org/drawingml/2006/main">
               <a:ext uri="{FF2B5EF4-FFF2-40B4-BE49-F238E27FC236}">
-                <a16:creationId xmlns:a16="http://schemas.microsoft.com/office/drawing/2014/main" id="{7DF93EA5-EE3C-4F5B-8893-A2280E1C618B}"/>
+                <a16:creationId xmlns:a16="http://schemas.microsoft.com/office/drawing/2014/main" id="{4059BB64-708A-4F9D-B52F-E06F3E062AE2}"/>
               </a:ext>
             </a:extLst>
           </p:cNvPr>
@@ -4205,7 +4205,7 @@
         <p:spPr>
           <a:xfrm xmlns:a="http://schemas.openxmlformats.org/drawingml/2006/main">
             <a:off x="609600" y="1619250"/>
-            <a:ext cx="4762500" cy="2114550"/>
+            <a:ext cx="5143500" cy="2114550"/>
           </a:xfrm>
           <a:prstGeom xmlns:a="http://schemas.openxmlformats.org/drawingml/2006/main" prst="rect">
             <a:avLst/>
@@ -4221,14 +4221,14 @@
           <a:lstStyle xmlns:a="http://schemas.openxmlformats.org/drawingml/2006/main"/>
           <a:p xmlns:a="http://schemas.openxmlformats.org/drawingml/2006/main">
             <a:pPr algn="l">
-              <a:defRPr sz="3300" b="1" i="0">
+              <a:defRPr sz="3750" b="1" i="0">
                 <a:solidFill>
                   <a:srgbClr val="FFFFFF"/>
                 </a:solidFill>
               </a:defRPr>
             </a:pPr>
             <a:r>
-              <a:rPr sz="3300" b="1" i="0">
+              <a:rPr sz="3750" b="1" i="0">
                 <a:solidFill>
                   <a:srgbClr val="FFFFFF"/>
                 </a:solidFill>
@@ -4243,19 +4243,19 @@
           <p:cNvPr id="5" name="">
             <a:extLst xmlns:a="http://schemas.openxmlformats.org/drawingml/2006/main">
               <a:ext uri="{FF2B5EF4-FFF2-40B4-BE49-F238E27FC236}">
-                <a16:creationId xmlns:a16="http://schemas.microsoft.com/office/drawing/2014/main" id="{0E622BE1-A2E4-4399-A0AB-910B26D7F1ED}"/>
-              </a:ext>
-            </a:extLst>
-          </p:cNvPr>
-          <p:cNvSpPr>
-            <a:spLocks xmlns:a="http://schemas.openxmlformats.org/drawingml/2006/main" noGrp="1"/>
-          </p:cNvSpPr>
-          <p:nvPr/>
-        </p:nvSpPr>
-        <p:spPr>
-          <a:xfrm xmlns:a="http://schemas.openxmlformats.org/drawingml/2006/main">
-            <a:off x="609600" y="3981450"/>
-            <a:ext cx="4476750" cy="876300"/>
+                <a16:creationId xmlns:a16="http://schemas.microsoft.com/office/drawing/2014/main" id="{EBE1F904-7649-459B-A4C4-21E31B8A1B6F}"/>
+              </a:ext>
+            </a:extLst>
+          </p:cNvPr>
+          <p:cNvSpPr>
+            <a:spLocks xmlns:a="http://schemas.openxmlformats.org/drawingml/2006/main" noGrp="1"/>
+          </p:cNvSpPr>
+          <p:nvPr/>
+        </p:nvSpPr>
+        <p:spPr>
+          <a:xfrm xmlns:a="http://schemas.openxmlformats.org/drawingml/2006/main">
+            <a:off x="609600" y="3962400"/>
+            <a:ext cx="4953000" cy="876300"/>
           </a:xfrm>
           <a:prstGeom xmlns:a="http://schemas.openxmlformats.org/drawingml/2006/main" prst="rect">
             <a:avLst/>
@@ -4293,63 +4293,57 @@
           <p:cNvPr id="6" name="">
             <a:extLst xmlns:a="http://schemas.openxmlformats.org/drawingml/2006/main">
               <a:ext uri="{FF2B5EF4-FFF2-40B4-BE49-F238E27FC236}">
-                <a16:creationId xmlns:a16="http://schemas.microsoft.com/office/drawing/2014/main" id="{6783F896-CDBB-4E45-B47F-E4343E93878F}"/>
-              </a:ext>
-            </a:extLst>
-          </p:cNvPr>
-          <p:cNvSpPr>
-            <a:spLocks xmlns:a="http://schemas.openxmlformats.org/drawingml/2006/main" noGrp="1"/>
-          </p:cNvSpPr>
-          <p:nvPr/>
-        </p:nvSpPr>
-        <p:spPr>
-          <a:xfrm xmlns:a="http://schemas.openxmlformats.org/drawingml/2006/main">
-            <a:off x="5705475" y="923925"/>
-            <a:ext cx="5924550" cy="3371850"/>
-          </a:xfrm>
-          <a:prstGeom xmlns:a="http://schemas.openxmlformats.org/drawingml/2006/main" prst="roundRect">
-            <a:avLst>
-              <a:gd name="adj" fmla="val 3390"/>
-            </a:avLst>
+                <a16:creationId xmlns:a16="http://schemas.microsoft.com/office/drawing/2014/main" id="{BC5D4B2C-E5D5-4AA9-A940-7341E260C9E3}"/>
+              </a:ext>
+            </a:extLst>
+          </p:cNvPr>
+          <p:cNvSpPr>
+            <a:spLocks xmlns:a="http://schemas.openxmlformats.org/drawingml/2006/main" noGrp="1"/>
+          </p:cNvSpPr>
+          <p:nvPr/>
+        </p:nvSpPr>
+        <p:spPr>
+          <a:xfrm xmlns:a="http://schemas.openxmlformats.org/drawingml/2006/main">
+            <a:off x="6229350" y="1257300"/>
+            <a:ext cx="9525" cy="3276600"/>
+          </a:xfrm>
+          <a:prstGeom xmlns:a="http://schemas.openxmlformats.org/drawingml/2006/main" prst="rect">
+            <a:avLst/>
           </a:prstGeom>
           <a:solidFill xmlns:a="http://schemas.openxmlformats.org/drawingml/2006/main">
-            <a:srgbClr val="F6F1E8"/>
+            <a:srgbClr val="406278"/>
           </a:solidFill>
-          <a:ln xmlns:a="http://schemas.openxmlformats.org/drawingml/2006/main" w="9525">
-            <a:solidFill>
-              <a:srgbClr val="B9DFD2"/>
-            </a:solidFill>
-            <a:prstDash val="solid"/>
-          </a:ln>
-        </p:spPr>
-        <p:style>
-          <a:lnRef xmlns:a="http://schemas.openxmlformats.org/drawingml/2006/main" idx="0"/>
-          <a:fillRef xmlns:a="http://schemas.openxmlformats.org/drawingml/2006/main" idx="0"/>
-          <a:effectRef xmlns:a="http://schemas.openxmlformats.org/drawingml/2006/main" idx="7"/>
-          <a:fontRef xmlns:a="http://schemas.openxmlformats.org/drawingml/2006/main" idx="major"/>
-        </p:style>
+          <a:ln xmlns:a="http://schemas.openxmlformats.org/drawingml/2006/main" w="0">
+            <a:noFill/>
+            <a:prstDash val="solid"/>
+          </a:ln>
+        </p:spPr>
       </p:sp>
       <p:pic>
         <p:nvPicPr>
-          <p:cNvPr id="26" name=""/>
+          <p:cNvPr id="28" name=""/>
           <p:cNvPicPr>
             <a:picLocks xmlns:a="http://schemas.openxmlformats.org/drawingml/2006/main" noChangeAspect="1"/>
           </p:cNvPicPr>
           <p:nvPr/>
         </p:nvPicPr>
         <p:blipFill>
-          <a:blip xmlns:r="http://schemas.openxmlformats.org/officeDocument/2006/relationships" xmlns:a="http://schemas.openxmlformats.org/drawingml/2006/main" r:embed="R30ce646019104eae"/>
+          <a:blip xmlns:r="http://schemas.openxmlformats.org/officeDocument/2006/relationships" xmlns:a="http://schemas.openxmlformats.org/drawingml/2006/main" r:embed="R23844e3f7d1d40ac">
+            <a:extLst>
+              <a:ext uri="{96DAC541-7B7A-43D3-8B79-37D633B846F1}">
+                <asvg:svgBlip xmlns:asvg="http://schemas.microsoft.com/office/drawing/2016/SVG/main" r:embed="R55e1787ec784416f"/>
+              </a:ext>
+            </a:extLst>
+          </a:blip>
           <a:stretch xmlns:a="http://schemas.openxmlformats.org/drawingml/2006/main"/>
         </p:blipFill>
         <p:spPr>
           <a:xfrm xmlns:a="http://schemas.openxmlformats.org/drawingml/2006/main">
-            <a:off x="5755217" y="971550"/>
-            <a:ext cx="5825067" cy="3276600"/>
-          </a:xfrm>
-          <a:prstGeom xmlns:a="http://schemas.openxmlformats.org/drawingml/2006/main" prst="roundRect">
-            <a:avLst>
-              <a:gd name="adj" fmla="val 2326"/>
-            </a:avLst>
+            <a:off x="7848600" y="1257300"/>
+            <a:ext cx="2286000" cy="2286000"/>
+          </a:xfrm>
+          <a:prstGeom xmlns:a="http://schemas.openxmlformats.org/drawingml/2006/main" prst="rect">
+            <a:avLst/>
           </a:prstGeom>
         </p:spPr>
       </p:pic>
@@ -4358,7 +4352,107 @@
           <p:cNvPr id="8" name="">
             <a:extLst xmlns:a="http://schemas.openxmlformats.org/drawingml/2006/main">
               <a:ext uri="{FF2B5EF4-FFF2-40B4-BE49-F238E27FC236}">
-                <a16:creationId xmlns:a16="http://schemas.microsoft.com/office/drawing/2014/main" id="{53E5CE02-DC5C-4D9D-8DC7-2BE6638EDD43}"/>
+                <a16:creationId xmlns:a16="http://schemas.microsoft.com/office/drawing/2014/main" id="{F2F3A502-DB22-4687-9E24-33554847AF24}"/>
+              </a:ext>
+            </a:extLst>
+          </p:cNvPr>
+          <p:cNvSpPr>
+            <a:spLocks xmlns:a="http://schemas.openxmlformats.org/drawingml/2006/main" noGrp="1"/>
+          </p:cNvSpPr>
+          <p:nvPr/>
+        </p:nvSpPr>
+        <p:spPr>
+          <a:xfrm xmlns:a="http://schemas.openxmlformats.org/drawingml/2006/main">
+            <a:off x="6762750" y="3676650"/>
+            <a:ext cx="3943350" cy="400050"/>
+          </a:xfrm>
+          <a:prstGeom xmlns:a="http://schemas.openxmlformats.org/drawingml/2006/main" prst="rect">
+            <a:avLst/>
+          </a:prstGeom>
+          <a:noFill xmlns:a="http://schemas.openxmlformats.org/drawingml/2006/main"/>
+          <a:ln xmlns:a="http://schemas.openxmlformats.org/drawingml/2006/main" w="0">
+            <a:noFill/>
+            <a:prstDash val="solid"/>
+          </a:ln>
+        </p:spPr>
+        <p:txBody>
+          <a:bodyPr xmlns:a="http://schemas.openxmlformats.org/drawingml/2006/main"/>
+          <a:lstStyle xmlns:a="http://schemas.openxmlformats.org/drawingml/2006/main"/>
+          <a:p xmlns:a="http://schemas.openxmlformats.org/drawingml/2006/main">
+            <a:pPr algn="ctr">
+              <a:defRPr sz="1950" b="1" i="0">
+                <a:solidFill>
+                  <a:srgbClr val="FFFFFF"/>
+                </a:solidFill>
+              </a:defRPr>
+            </a:pPr>
+            <a:r>
+              <a:rPr sz="1950" b="1" i="0">
+                <a:solidFill>
+                  <a:srgbClr val="FFFFFF"/>
+                </a:solidFill>
+              </a:rPr>
+              <a:t>AI  →  CODE  →  ALPACA</a:t>
+            </a:r>
+          </a:p>
+        </p:txBody>
+      </p:sp>
+      <p:sp>
+        <p:nvSpPr>
+          <p:cNvPr id="9" name="">
+            <a:extLst xmlns:a="http://schemas.openxmlformats.org/drawingml/2006/main">
+              <a:ext uri="{FF2B5EF4-FFF2-40B4-BE49-F238E27FC236}">
+                <a16:creationId xmlns:a16="http://schemas.microsoft.com/office/drawing/2014/main" id="{64DAA205-F432-49F1-A406-7CB884967A40}"/>
+              </a:ext>
+            </a:extLst>
+          </p:cNvPr>
+          <p:cNvSpPr>
+            <a:spLocks xmlns:a="http://schemas.openxmlformats.org/drawingml/2006/main" noGrp="1"/>
+          </p:cNvSpPr>
+          <p:nvPr/>
+        </p:nvSpPr>
+        <p:spPr>
+          <a:xfrm xmlns:a="http://schemas.openxmlformats.org/drawingml/2006/main">
+            <a:off x="6858000" y="4152900"/>
+            <a:ext cx="3752850" cy="285750"/>
+          </a:xfrm>
+          <a:prstGeom xmlns:a="http://schemas.openxmlformats.org/drawingml/2006/main" prst="rect">
+            <a:avLst/>
+          </a:prstGeom>
+          <a:noFill xmlns:a="http://schemas.openxmlformats.org/drawingml/2006/main"/>
+          <a:ln xmlns:a="http://schemas.openxmlformats.org/drawingml/2006/main" w="0">
+            <a:noFill/>
+            <a:prstDash val="solid"/>
+          </a:ln>
+        </p:spPr>
+        <p:txBody>
+          <a:bodyPr xmlns:a="http://schemas.openxmlformats.org/drawingml/2006/main"/>
+          <a:lstStyle xmlns:a="http://schemas.openxmlformats.org/drawingml/2006/main"/>
+          <a:p xmlns:a="http://schemas.openxmlformats.org/drawingml/2006/main">
+            <a:pPr algn="ctr">
+              <a:defRPr sz="1350" b="0" i="0">
+                <a:solidFill>
+                  <a:srgbClr val="B9DFD2"/>
+                </a:solidFill>
+              </a:defRPr>
+            </a:pPr>
+            <a:r>
+              <a:rPr sz="1350" b="0" i="0">
+                <a:solidFill>
+                  <a:srgbClr val="B9DFD2"/>
+                </a:solidFill>
+              </a:rPr>
+              <a:t>Interpret  ·  control  ·  execute</a:t>
+            </a:r>
+          </a:p>
+        </p:txBody>
+      </p:sp>
+      <p:sp>
+        <p:nvSpPr>
+          <p:cNvPr id="10" name="">
+            <a:extLst xmlns:a="http://schemas.openxmlformats.org/drawingml/2006/main">
+              <a:ext uri="{FF2B5EF4-FFF2-40B4-BE49-F238E27FC236}">
+                <a16:creationId xmlns:a16="http://schemas.microsoft.com/office/drawing/2014/main" id="{F4DAA32D-B1F6-4A6D-A8C3-B5DDCD51184C}"/>
               </a:ext>
             </a:extLst>
           </p:cNvPr>
@@ -4386,10 +4480,10 @@
       </p:sp>
       <p:sp>
         <p:nvSpPr>
-          <p:cNvPr id="9" name="">
-            <a:extLst xmlns:a="http://schemas.openxmlformats.org/drawingml/2006/main">
-              <a:ext uri="{FF2B5EF4-FFF2-40B4-BE49-F238E27FC236}">
-                <a16:creationId xmlns:a16="http://schemas.microsoft.com/office/drawing/2014/main" id="{A9BF33F9-65D6-4AF8-A9EF-36979BAF6284}"/>
+          <p:cNvPr id="11" name="">
+            <a:extLst xmlns:a="http://schemas.openxmlformats.org/drawingml/2006/main">
+              <a:ext uri="{FF2B5EF4-FFF2-40B4-BE49-F238E27FC236}">
+                <a16:creationId xmlns:a16="http://schemas.microsoft.com/office/drawing/2014/main" id="{4C5F75FF-86A7-4349-9587-B396073F4262}"/>
               </a:ext>
             </a:extLst>
           </p:cNvPr>
@@ -4436,10 +4530,10 @@
       </p:sp>
       <p:sp>
         <p:nvSpPr>
-          <p:cNvPr id="10" name="">
-            <a:extLst xmlns:a="http://schemas.openxmlformats.org/drawingml/2006/main">
-              <a:ext uri="{FF2B5EF4-FFF2-40B4-BE49-F238E27FC236}">
-                <a16:creationId xmlns:a16="http://schemas.microsoft.com/office/drawing/2014/main" id="{75A676BF-B58E-4337-BE9D-5F49588C5FDE}"/>
+          <p:cNvPr id="12" name="">
+            <a:extLst xmlns:a="http://schemas.openxmlformats.org/drawingml/2006/main">
+              <a:ext uri="{FF2B5EF4-FFF2-40B4-BE49-F238E27FC236}">
+                <a16:creationId xmlns:a16="http://schemas.microsoft.com/office/drawing/2014/main" id="{121CE3E4-D462-495E-9A43-96EC37E5FA54}"/>
               </a:ext>
             </a:extLst>
           </p:cNvPr>
@@ -4486,10 +4580,10 @@
       </p:sp>
       <p:sp>
         <p:nvSpPr>
-          <p:cNvPr id="11" name="">
-            <a:extLst xmlns:a="http://schemas.openxmlformats.org/drawingml/2006/main">
-              <a:ext uri="{FF2B5EF4-FFF2-40B4-BE49-F238E27FC236}">
-                <a16:creationId xmlns:a16="http://schemas.microsoft.com/office/drawing/2014/main" id="{6423E824-6DE9-43B4-8875-458D143669A0}"/>
+          <p:cNvPr id="13" name="">
+            <a:extLst xmlns:a="http://schemas.openxmlformats.org/drawingml/2006/main">
+              <a:ext uri="{FF2B5EF4-FFF2-40B4-BE49-F238E27FC236}">
+                <a16:creationId xmlns:a16="http://schemas.microsoft.com/office/drawing/2014/main" id="{837DDC25-4EE9-4EA6-9FEB-4AD71C51BF83}"/>
               </a:ext>
             </a:extLst>
           </p:cNvPr>
@@ -4536,10 +4630,10 @@
       </p:sp>
       <p:sp>
         <p:nvSpPr>
-          <p:cNvPr id="12" name="">
-            <a:extLst xmlns:a="http://schemas.openxmlformats.org/drawingml/2006/main">
-              <a:ext uri="{FF2B5EF4-FFF2-40B4-BE49-F238E27FC236}">
-                <a16:creationId xmlns:a16="http://schemas.microsoft.com/office/drawing/2014/main" id="{423CA8F4-058F-426F-BF8C-B0787A172F5A}"/>
+          <p:cNvPr id="14" name="">
+            <a:extLst xmlns:a="http://schemas.openxmlformats.org/drawingml/2006/main">
+              <a:ext uri="{FF2B5EF4-FFF2-40B4-BE49-F238E27FC236}">
+                <a16:creationId xmlns:a16="http://schemas.microsoft.com/office/drawing/2014/main" id="{7911862F-9E22-4018-A0C4-6C8AD0E33948}"/>
               </a:ext>
             </a:extLst>
           </p:cNvPr>
@@ -4586,10 +4680,10 @@
       </p:sp>
       <p:sp>
         <p:nvSpPr>
-          <p:cNvPr id="13" name="">
-            <a:extLst xmlns:a="http://schemas.openxmlformats.org/drawingml/2006/main">
-              <a:ext uri="{FF2B5EF4-FFF2-40B4-BE49-F238E27FC236}">
-                <a16:creationId xmlns:a16="http://schemas.microsoft.com/office/drawing/2014/main" id="{21D6BCEE-F95F-4557-9240-9258D1696FD3}"/>
+          <p:cNvPr id="15" name="">
+            <a:extLst xmlns:a="http://schemas.openxmlformats.org/drawingml/2006/main">
+              <a:ext uri="{FF2B5EF4-FFF2-40B4-BE49-F238E27FC236}">
+                <a16:creationId xmlns:a16="http://schemas.microsoft.com/office/drawing/2014/main" id="{9CDB99CE-7C4E-4E96-ADED-F93FA7176518}"/>
               </a:ext>
             </a:extLst>
           </p:cNvPr>
@@ -4636,10 +4730,10 @@
       </p:sp>
       <p:sp>
         <p:nvSpPr>
-          <p:cNvPr id="14" name="">
-            <a:extLst xmlns:a="http://schemas.openxmlformats.org/drawingml/2006/main">
-              <a:ext uri="{FF2B5EF4-FFF2-40B4-BE49-F238E27FC236}">
-                <a16:creationId xmlns:a16="http://schemas.microsoft.com/office/drawing/2014/main" id="{5E59BED9-65EE-4C1D-8561-6E5673E6E8D9}"/>
+          <p:cNvPr id="16" name="">
+            <a:extLst xmlns:a="http://schemas.openxmlformats.org/drawingml/2006/main">
+              <a:ext uri="{FF2B5EF4-FFF2-40B4-BE49-F238E27FC236}">
+                <a16:creationId xmlns:a16="http://schemas.microsoft.com/office/drawing/2014/main" id="{73A41153-7190-4F8C-B9A5-976111FF3275}"/>
               </a:ext>
             </a:extLst>
           </p:cNvPr>
@@ -4686,10 +4780,10 @@
       </p:sp>
       <p:sp>
         <p:nvSpPr>
-          <p:cNvPr id="15" name="">
-            <a:extLst xmlns:a="http://schemas.openxmlformats.org/drawingml/2006/main">
-              <a:ext uri="{FF2B5EF4-FFF2-40B4-BE49-F238E27FC236}">
-                <a16:creationId xmlns:a16="http://schemas.microsoft.com/office/drawing/2014/main" id="{208E7CD7-2E7F-4C50-8AD1-42C4A0A9D38B}"/>
+          <p:cNvPr id="17" name="">
+            <a:extLst xmlns:a="http://schemas.openxmlformats.org/drawingml/2006/main">
+              <a:ext uri="{FF2B5EF4-FFF2-40B4-BE49-F238E27FC236}">
+                <a16:creationId xmlns:a16="http://schemas.microsoft.com/office/drawing/2014/main" id="{B91B1421-FE61-412D-B2B7-B85966AA2096}"/>
               </a:ext>
             </a:extLst>
           </p:cNvPr>
@@ -4736,10 +4830,10 @@
       </p:sp>
       <p:sp>
         <p:nvSpPr>
-          <p:cNvPr id="16" name="">
-            <a:extLst xmlns:a="http://schemas.openxmlformats.org/drawingml/2006/main">
-              <a:ext uri="{FF2B5EF4-FFF2-40B4-BE49-F238E27FC236}">
-                <a16:creationId xmlns:a16="http://schemas.microsoft.com/office/drawing/2014/main" id="{A3665063-045E-4696-B4C7-8310C271907A}"/>
+          <p:cNvPr id="18" name="">
+            <a:extLst xmlns:a="http://schemas.openxmlformats.org/drawingml/2006/main">
+              <a:ext uri="{FF2B5EF4-FFF2-40B4-BE49-F238E27FC236}">
+                <a16:creationId xmlns:a16="http://schemas.microsoft.com/office/drawing/2014/main" id="{B352F10D-6281-448E-9795-DCFB3C0D65D3}"/>
               </a:ext>
             </a:extLst>
           </p:cNvPr>
@@ -4786,10 +4880,10 @@
       </p:sp>
       <p:sp>
         <p:nvSpPr>
-          <p:cNvPr id="17" name="">
-            <a:extLst xmlns:a="http://schemas.openxmlformats.org/drawingml/2006/main">
-              <a:ext uri="{FF2B5EF4-FFF2-40B4-BE49-F238E27FC236}">
-                <a16:creationId xmlns:a16="http://schemas.microsoft.com/office/drawing/2014/main" id="{05273FFD-95AC-4448-998E-D957D6966866}"/>
+          <p:cNvPr id="19" name="">
+            <a:extLst xmlns:a="http://schemas.openxmlformats.org/drawingml/2006/main">
+              <a:ext uri="{FF2B5EF4-FFF2-40B4-BE49-F238E27FC236}">
+                <a16:creationId xmlns:a16="http://schemas.microsoft.com/office/drawing/2014/main" id="{85E7E7C1-9444-406E-82BE-BCB1E281FD24}"/>
               </a:ext>
             </a:extLst>
           </p:cNvPr>
@@ -4836,10 +4930,10 @@
       </p:sp>
       <p:sp>
         <p:nvSpPr>
-          <p:cNvPr id="18" name="">
-            <a:extLst xmlns:a="http://schemas.openxmlformats.org/drawingml/2006/main">
-              <a:ext uri="{FF2B5EF4-FFF2-40B4-BE49-F238E27FC236}">
-                <a16:creationId xmlns:a16="http://schemas.microsoft.com/office/drawing/2014/main" id="{53EA2918-0E88-4963-A428-BB133E838ACF}"/>
+          <p:cNvPr id="20" name="">
+            <a:extLst xmlns:a="http://schemas.openxmlformats.org/drawingml/2006/main">
+              <a:ext uri="{FF2B5EF4-FFF2-40B4-BE49-F238E27FC236}">
+                <a16:creationId xmlns:a16="http://schemas.microsoft.com/office/drawing/2014/main" id="{186D3AD2-157A-4169-9215-ED84D0AFEB21}"/>
               </a:ext>
             </a:extLst>
           </p:cNvPr>
@@ -4886,10 +4980,10 @@
       </p:sp>
       <p:sp>
         <p:nvSpPr>
-          <p:cNvPr id="19" name="">
-            <a:extLst xmlns:a="http://schemas.openxmlformats.org/drawingml/2006/main">
-              <a:ext uri="{FF2B5EF4-FFF2-40B4-BE49-F238E27FC236}">
-                <a16:creationId xmlns:a16="http://schemas.microsoft.com/office/drawing/2014/main" id="{4D0F162C-39C4-4AFD-9FF2-733E4BF1FF96}"/>
+          <p:cNvPr id="21" name="">
+            <a:extLst xmlns:a="http://schemas.openxmlformats.org/drawingml/2006/main">
+              <a:ext uri="{FF2B5EF4-FFF2-40B4-BE49-F238E27FC236}">
+                <a16:creationId xmlns:a16="http://schemas.microsoft.com/office/drawing/2014/main" id="{B39DB5C3-3492-4E33-B8A3-FF2BC49093F6}"/>
               </a:ext>
             </a:extLst>
           </p:cNvPr>
@@ -4937,7 +5031,7 @@
     </p:spTree>
     <p:extLst>
       <p:ext uri="{BB962C8B-B14F-4D97-AF65-F5344CB8AC3E}">
-        <p14:creationId xmlns:p14="http://schemas.microsoft.com/office/powerpoint/2010/main" val="677645551"/>
+        <p14:creationId xmlns:p14="http://schemas.microsoft.com/office/powerpoint/2010/main" val="1589416300"/>
       </p:ext>
     </p:extLst>
   </p:cSld>
@@ -4968,7 +5062,7 @@
           <p:cNvPr id="31" name="">
             <a:extLst xmlns:a="http://schemas.openxmlformats.org/drawingml/2006/main">
               <a:ext uri="{FF2B5EF4-FFF2-40B4-BE49-F238E27FC236}">
-                <a16:creationId xmlns:a16="http://schemas.microsoft.com/office/drawing/2014/main" id="{98622778-CB59-4DEC-98A9-0B12F35708D7}"/>
+                <a16:creationId xmlns:a16="http://schemas.microsoft.com/office/drawing/2014/main" id="{87DD4F5C-475F-4906-BB55-CB184AA41665}"/>
               </a:ext>
             </a:extLst>
           </p:cNvPr>
@@ -5018,7 +5112,7 @@
           <p:cNvPr id="2" name="">
             <a:extLst xmlns:a="http://schemas.openxmlformats.org/drawingml/2006/main">
               <a:ext uri="{FF2B5EF4-FFF2-40B4-BE49-F238E27FC236}">
-                <a16:creationId xmlns:a16="http://schemas.microsoft.com/office/drawing/2014/main" id="{FDA616EC-30D7-4A6D-B2D1-810E51FA6B42}"/>
+                <a16:creationId xmlns:a16="http://schemas.microsoft.com/office/drawing/2014/main" id="{8B6B6714-B6AA-404A-90FF-0186DBF65FB8}"/>
               </a:ext>
             </a:extLst>
           </p:cNvPr>
@@ -5068,7 +5162,7 @@
           <p:cNvPr id="3" name="">
             <a:extLst xmlns:a="http://schemas.openxmlformats.org/drawingml/2006/main">
               <a:ext uri="{FF2B5EF4-FFF2-40B4-BE49-F238E27FC236}">
-                <a16:creationId xmlns:a16="http://schemas.microsoft.com/office/drawing/2014/main" id="{BC6EAE6F-6786-4747-8083-0F1C7D2DFDF3}"/>
+                <a16:creationId xmlns:a16="http://schemas.microsoft.com/office/drawing/2014/main" id="{F2015D3E-C1BD-4C0E-A198-8C2AE6DA40D6}"/>
               </a:ext>
             </a:extLst>
           </p:cNvPr>
@@ -5118,7 +5212,7 @@
           <p:cNvPr id="4" name="">
             <a:extLst xmlns:a="http://schemas.openxmlformats.org/drawingml/2006/main">
               <a:ext uri="{FF2B5EF4-FFF2-40B4-BE49-F238E27FC236}">
-                <a16:creationId xmlns:a16="http://schemas.microsoft.com/office/drawing/2014/main" id="{C56CDB28-ED58-4337-AC7C-77B00D9FB18F}"/>
+                <a16:creationId xmlns:a16="http://schemas.microsoft.com/office/drawing/2014/main" id="{4961856B-E6E0-460D-BC14-5EC8448ECCFB}"/>
               </a:ext>
             </a:extLst>
           </p:cNvPr>
@@ -5153,7 +5247,7 @@
           <p:cNvPr id="5" name="">
             <a:extLst xmlns:a="http://schemas.openxmlformats.org/drawingml/2006/main">
               <a:ext uri="{FF2B5EF4-FFF2-40B4-BE49-F238E27FC236}">
-                <a16:creationId xmlns:a16="http://schemas.microsoft.com/office/drawing/2014/main" id="{7E7E9CD6-C2B1-4C20-AF89-2581A4E27BC7}"/>
+                <a16:creationId xmlns:a16="http://schemas.microsoft.com/office/drawing/2014/main" id="{47F11E6C-E170-4EFB-9F24-C557DAF1FDFA}"/>
               </a:ext>
             </a:extLst>
           </p:cNvPr>
@@ -5203,7 +5297,7 @@
           <p:cNvPr id="6" name="">
             <a:extLst xmlns:a="http://schemas.openxmlformats.org/drawingml/2006/main">
               <a:ext uri="{FF2B5EF4-FFF2-40B4-BE49-F238E27FC236}">
-                <a16:creationId xmlns:a16="http://schemas.microsoft.com/office/drawing/2014/main" id="{E9D17CB1-8B20-435D-A115-90D249FB8A88}"/>
+                <a16:creationId xmlns:a16="http://schemas.microsoft.com/office/drawing/2014/main" id="{4E466C0A-AB59-48F8-87D4-190FFEDC0AEE}"/>
               </a:ext>
             </a:extLst>
           </p:cNvPr>
@@ -5253,7 +5347,7 @@
           <p:cNvPr id="7" name="">
             <a:extLst xmlns:a="http://schemas.openxmlformats.org/drawingml/2006/main">
               <a:ext uri="{FF2B5EF4-FFF2-40B4-BE49-F238E27FC236}">
-                <a16:creationId xmlns:a16="http://schemas.microsoft.com/office/drawing/2014/main" id="{26F4DC92-91F9-425B-9703-9B51B51C8286}"/>
+                <a16:creationId xmlns:a16="http://schemas.microsoft.com/office/drawing/2014/main" id="{5755D019-EFEF-4050-BF1A-3352075F215F}"/>
               </a:ext>
             </a:extLst>
           </p:cNvPr>
@@ -5303,7 +5397,7 @@
           <p:cNvPr id="8" name="">
             <a:extLst xmlns:a="http://schemas.openxmlformats.org/drawingml/2006/main">
               <a:ext uri="{FF2B5EF4-FFF2-40B4-BE49-F238E27FC236}">
-                <a16:creationId xmlns:a16="http://schemas.microsoft.com/office/drawing/2014/main" id="{6FA2154A-069B-42E0-900D-A7E0290B114E}"/>
+                <a16:creationId xmlns:a16="http://schemas.microsoft.com/office/drawing/2014/main" id="{8049B0F2-38EC-4B24-8175-B1AE5102D249}"/>
               </a:ext>
             </a:extLst>
           </p:cNvPr>
@@ -5338,7 +5432,7 @@
           <p:cNvPr id="9" name="">
             <a:extLst xmlns:a="http://schemas.openxmlformats.org/drawingml/2006/main">
               <a:ext uri="{FF2B5EF4-FFF2-40B4-BE49-F238E27FC236}">
-                <a16:creationId xmlns:a16="http://schemas.microsoft.com/office/drawing/2014/main" id="{C0AE8A65-9659-498F-A7DA-BD159D11FC42}"/>
+                <a16:creationId xmlns:a16="http://schemas.microsoft.com/office/drawing/2014/main" id="{FF4E2159-E8D1-4100-BD16-CC3022F132BE}"/>
               </a:ext>
             </a:extLst>
           </p:cNvPr>
@@ -5388,7 +5482,7 @@
           <p:cNvPr id="10" name="">
             <a:extLst xmlns:a="http://schemas.openxmlformats.org/drawingml/2006/main">
               <a:ext uri="{FF2B5EF4-FFF2-40B4-BE49-F238E27FC236}">
-                <a16:creationId xmlns:a16="http://schemas.microsoft.com/office/drawing/2014/main" id="{43BB8534-7A73-4593-9B13-E30D8CDF6513}"/>
+                <a16:creationId xmlns:a16="http://schemas.microsoft.com/office/drawing/2014/main" id="{D93D0F06-EA0D-4C3D-8D51-768CE6345889}"/>
               </a:ext>
             </a:extLst>
           </p:cNvPr>
@@ -5438,7 +5532,7 @@
           <p:cNvPr id="11" name="">
             <a:extLst xmlns:a="http://schemas.openxmlformats.org/drawingml/2006/main">
               <a:ext uri="{FF2B5EF4-FFF2-40B4-BE49-F238E27FC236}">
-                <a16:creationId xmlns:a16="http://schemas.microsoft.com/office/drawing/2014/main" id="{CAEC8332-2C5F-4570-8360-C4B6FF800E40}"/>
+                <a16:creationId xmlns:a16="http://schemas.microsoft.com/office/drawing/2014/main" id="{7A457646-6D8A-4B6C-AA6D-936EAD8B12C3}"/>
               </a:ext>
             </a:extLst>
           </p:cNvPr>
@@ -5488,7 +5582,7 @@
           <p:cNvPr id="12" name="">
             <a:extLst xmlns:a="http://schemas.openxmlformats.org/drawingml/2006/main">
               <a:ext uri="{FF2B5EF4-FFF2-40B4-BE49-F238E27FC236}">
-                <a16:creationId xmlns:a16="http://schemas.microsoft.com/office/drawing/2014/main" id="{6F467125-4376-4C07-B6E8-FDE15E2EFED3}"/>
+                <a16:creationId xmlns:a16="http://schemas.microsoft.com/office/drawing/2014/main" id="{73AA7D48-CD0E-422E-B863-0DB07E4FA5D0}"/>
               </a:ext>
             </a:extLst>
           </p:cNvPr>
@@ -5523,7 +5617,7 @@
           <p:cNvPr id="13" name="">
             <a:extLst xmlns:a="http://schemas.openxmlformats.org/drawingml/2006/main">
               <a:ext uri="{FF2B5EF4-FFF2-40B4-BE49-F238E27FC236}">
-                <a16:creationId xmlns:a16="http://schemas.microsoft.com/office/drawing/2014/main" id="{9EA0F54F-C5B7-4D79-91A6-D24817801DA3}"/>
+                <a16:creationId xmlns:a16="http://schemas.microsoft.com/office/drawing/2014/main" id="{17802042-A42A-41E9-BA85-C587CCAFDD32}"/>
               </a:ext>
             </a:extLst>
           </p:cNvPr>
@@ -5573,7 +5667,7 @@
           <p:cNvPr id="14" name="">
             <a:extLst xmlns:a="http://schemas.openxmlformats.org/drawingml/2006/main">
               <a:ext uri="{FF2B5EF4-FFF2-40B4-BE49-F238E27FC236}">
-                <a16:creationId xmlns:a16="http://schemas.microsoft.com/office/drawing/2014/main" id="{F4C2A0DD-9B4B-447E-9FD5-1BB7CD365EAB}"/>
+                <a16:creationId xmlns:a16="http://schemas.microsoft.com/office/drawing/2014/main" id="{7A4F6E68-DE8B-462D-B39F-DAD744374858}"/>
               </a:ext>
             </a:extLst>
           </p:cNvPr>
@@ -5623,7 +5717,7 @@
           <p:cNvPr id="15" name="">
             <a:extLst xmlns:a="http://schemas.openxmlformats.org/drawingml/2006/main">
               <a:ext uri="{FF2B5EF4-FFF2-40B4-BE49-F238E27FC236}">
-                <a16:creationId xmlns:a16="http://schemas.microsoft.com/office/drawing/2014/main" id="{039AC835-EE20-4F3F-A5A1-1FDFE2A78389}"/>
+                <a16:creationId xmlns:a16="http://schemas.microsoft.com/office/drawing/2014/main" id="{DDFB320C-F023-4070-A052-A8453FD250DD}"/>
               </a:ext>
             </a:extLst>
           </p:cNvPr>
@@ -5673,7 +5767,7 @@
           <p:cNvPr id="16" name="">
             <a:extLst xmlns:a="http://schemas.openxmlformats.org/drawingml/2006/main">
               <a:ext uri="{FF2B5EF4-FFF2-40B4-BE49-F238E27FC236}">
-                <a16:creationId xmlns:a16="http://schemas.microsoft.com/office/drawing/2014/main" id="{C4455F84-A378-4B41-A7B4-4F8E2C424A18}"/>
+                <a16:creationId xmlns:a16="http://schemas.microsoft.com/office/drawing/2014/main" id="{735BB8C1-91C0-4650-B33C-6D1A2604388A}"/>
               </a:ext>
             </a:extLst>
           </p:cNvPr>
@@ -5708,7 +5802,7 @@
           <p:cNvPr id="17" name="">
             <a:extLst xmlns:a="http://schemas.openxmlformats.org/drawingml/2006/main">
               <a:ext uri="{FF2B5EF4-FFF2-40B4-BE49-F238E27FC236}">
-                <a16:creationId xmlns:a16="http://schemas.microsoft.com/office/drawing/2014/main" id="{32AFCE54-A8C0-4372-85A1-E6817D62C98A}"/>
+                <a16:creationId xmlns:a16="http://schemas.microsoft.com/office/drawing/2014/main" id="{A1FF97D0-2088-437A-852B-F59C4DFDE188}"/>
               </a:ext>
             </a:extLst>
           </p:cNvPr>
@@ -5758,7 +5852,7 @@
           <p:cNvPr id="18" name="">
             <a:extLst xmlns:a="http://schemas.openxmlformats.org/drawingml/2006/main">
               <a:ext uri="{FF2B5EF4-FFF2-40B4-BE49-F238E27FC236}">
-                <a16:creationId xmlns:a16="http://schemas.microsoft.com/office/drawing/2014/main" id="{2B75017A-2CC6-4471-902A-57DD19C87384}"/>
+                <a16:creationId xmlns:a16="http://schemas.microsoft.com/office/drawing/2014/main" id="{B848BD36-6AEE-4734-B817-9A2B20875040}"/>
               </a:ext>
             </a:extLst>
           </p:cNvPr>
@@ -5808,7 +5902,7 @@
           <p:cNvPr id="19" name="">
             <a:extLst xmlns:a="http://schemas.openxmlformats.org/drawingml/2006/main">
               <a:ext uri="{FF2B5EF4-FFF2-40B4-BE49-F238E27FC236}">
-                <a16:creationId xmlns:a16="http://schemas.microsoft.com/office/drawing/2014/main" id="{D0BEC0C4-1747-439A-8778-A3811EFC2BA2}"/>
+                <a16:creationId xmlns:a16="http://schemas.microsoft.com/office/drawing/2014/main" id="{CD5A6ED1-9D3C-4BCB-B8E3-2E088157C30A}"/>
               </a:ext>
             </a:extLst>
           </p:cNvPr>
@@ -5858,7 +5952,7 @@
           <p:cNvPr id="20" name="">
             <a:extLst xmlns:a="http://schemas.openxmlformats.org/drawingml/2006/main">
               <a:ext uri="{FF2B5EF4-FFF2-40B4-BE49-F238E27FC236}">
-                <a16:creationId xmlns:a16="http://schemas.microsoft.com/office/drawing/2014/main" id="{B57E9C1E-AC4A-472D-B372-0E95E4D6DB42}"/>
+                <a16:creationId xmlns:a16="http://schemas.microsoft.com/office/drawing/2014/main" id="{5F90B219-0E64-4B65-9828-1EDC285ABF31}"/>
               </a:ext>
             </a:extLst>
           </p:cNvPr>
@@ -5893,7 +5987,7 @@
           <p:cNvPr id="21" name="">
             <a:extLst xmlns:a="http://schemas.openxmlformats.org/drawingml/2006/main">
               <a:ext uri="{FF2B5EF4-FFF2-40B4-BE49-F238E27FC236}">
-                <a16:creationId xmlns:a16="http://schemas.microsoft.com/office/drawing/2014/main" id="{8FB97915-0A7F-40FD-8579-402342CE8526}"/>
+                <a16:creationId xmlns:a16="http://schemas.microsoft.com/office/drawing/2014/main" id="{73EB8CA3-91FF-4788-A5E2-82DDD12BB9C3}"/>
               </a:ext>
             </a:extLst>
           </p:cNvPr>
@@ -5943,7 +6037,7 @@
           <p:cNvPr id="22" name="">
             <a:extLst xmlns:a="http://schemas.openxmlformats.org/drawingml/2006/main">
               <a:ext uri="{FF2B5EF4-FFF2-40B4-BE49-F238E27FC236}">
-                <a16:creationId xmlns:a16="http://schemas.microsoft.com/office/drawing/2014/main" id="{0FE764BE-A826-4C2E-8645-223DCE0E4BC0}"/>
+                <a16:creationId xmlns:a16="http://schemas.microsoft.com/office/drawing/2014/main" id="{115A94FA-7D3C-4C2E-A200-863FA7B93735}"/>
               </a:ext>
             </a:extLst>
           </p:cNvPr>
@@ -5993,7 +6087,7 @@
           <p:cNvPr id="23" name="">
             <a:extLst xmlns:a="http://schemas.openxmlformats.org/drawingml/2006/main">
               <a:ext uri="{FF2B5EF4-FFF2-40B4-BE49-F238E27FC236}">
-                <a16:creationId xmlns:a16="http://schemas.microsoft.com/office/drawing/2014/main" id="{1B0D2D2B-4AFB-493C-894C-5F149E480672}"/>
+                <a16:creationId xmlns:a16="http://schemas.microsoft.com/office/drawing/2014/main" id="{3C2FC5EF-6290-460D-A830-DAC15DCFD326}"/>
               </a:ext>
             </a:extLst>
           </p:cNvPr>
@@ -6043,7 +6137,7 @@
           <p:cNvPr id="24" name="">
             <a:extLst xmlns:a="http://schemas.openxmlformats.org/drawingml/2006/main">
               <a:ext uri="{FF2B5EF4-FFF2-40B4-BE49-F238E27FC236}">
-                <a16:creationId xmlns:a16="http://schemas.microsoft.com/office/drawing/2014/main" id="{E892B0AE-03DA-4D3B-B46B-1A91B376245B}"/>
+                <a16:creationId xmlns:a16="http://schemas.microsoft.com/office/drawing/2014/main" id="{4272FC7A-9C1A-4294-8E68-73B54640AC49}"/>
               </a:ext>
             </a:extLst>
           </p:cNvPr>
@@ -6076,7 +6170,7 @@
           <p:cNvPr id="25" name="">
             <a:extLst xmlns:a="http://schemas.openxmlformats.org/drawingml/2006/main">
               <a:ext uri="{FF2B5EF4-FFF2-40B4-BE49-F238E27FC236}">
-                <a16:creationId xmlns:a16="http://schemas.microsoft.com/office/drawing/2014/main" id="{4F6B8DFB-C569-45B2-A5B8-4B2A4B4B5C3A}"/>
+                <a16:creationId xmlns:a16="http://schemas.microsoft.com/office/drawing/2014/main" id="{1DAF4589-2274-4A9C-ACE0-3DF166BDC11E}"/>
               </a:ext>
             </a:extLst>
           </p:cNvPr>
@@ -6126,7 +6220,7 @@
           <p:cNvPr id="26" name="">
             <a:extLst xmlns:a="http://schemas.openxmlformats.org/drawingml/2006/main">
               <a:ext uri="{FF2B5EF4-FFF2-40B4-BE49-F238E27FC236}">
-                <a16:creationId xmlns:a16="http://schemas.microsoft.com/office/drawing/2014/main" id="{935A9340-F600-4F8A-A6D1-A04F3ED65FDD}"/>
+                <a16:creationId xmlns:a16="http://schemas.microsoft.com/office/drawing/2014/main" id="{2F10031B-94D8-4CDD-9374-35F20485B47D}"/>
               </a:ext>
             </a:extLst>
           </p:cNvPr>
@@ -6157,7 +6251,7 @@
           <p:cNvPr id="27" name="">
             <a:extLst xmlns:a="http://schemas.openxmlformats.org/drawingml/2006/main">
               <a:ext uri="{FF2B5EF4-FFF2-40B4-BE49-F238E27FC236}">
-                <a16:creationId xmlns:a16="http://schemas.microsoft.com/office/drawing/2014/main" id="{B715E1C1-837E-46D2-B591-650A679A3A60}"/>
+                <a16:creationId xmlns:a16="http://schemas.microsoft.com/office/drawing/2014/main" id="{50AD5A5B-4385-4A02-942D-A1A01BD77B57}"/>
               </a:ext>
             </a:extLst>
           </p:cNvPr>
@@ -6207,7 +6301,7 @@
           <p:cNvPr id="28" name="">
             <a:extLst xmlns:a="http://schemas.openxmlformats.org/drawingml/2006/main">
               <a:ext uri="{FF2B5EF4-FFF2-40B4-BE49-F238E27FC236}">
-                <a16:creationId xmlns:a16="http://schemas.microsoft.com/office/drawing/2014/main" id="{BBEE21FC-235F-44AD-A4DD-ECB55CEB1625}"/>
+                <a16:creationId xmlns:a16="http://schemas.microsoft.com/office/drawing/2014/main" id="{CE1A981E-7057-42A1-92BA-1DEAF467451C}"/>
               </a:ext>
             </a:extLst>
           </p:cNvPr>
@@ -6257,7 +6351,7 @@
           <p:cNvPr id="29" name="">
             <a:extLst xmlns:a="http://schemas.openxmlformats.org/drawingml/2006/main">
               <a:ext uri="{FF2B5EF4-FFF2-40B4-BE49-F238E27FC236}">
-                <a16:creationId xmlns:a16="http://schemas.microsoft.com/office/drawing/2014/main" id="{DF554AB2-7528-4B30-B379-97BFE3D21EED}"/>
+                <a16:creationId xmlns:a16="http://schemas.microsoft.com/office/drawing/2014/main" id="{48DF0614-DC17-4EC6-AB77-9CA0CA904A9C}"/>
               </a:ext>
             </a:extLst>
           </p:cNvPr>
@@ -6307,7 +6401,7 @@
           <p:cNvPr id="30" name="">
             <a:extLst xmlns:a="http://schemas.openxmlformats.org/drawingml/2006/main">
               <a:ext uri="{FF2B5EF4-FFF2-40B4-BE49-F238E27FC236}">
-                <a16:creationId xmlns:a16="http://schemas.microsoft.com/office/drawing/2014/main" id="{391D1F86-78FE-490C-BE4E-4441D451CC5D}"/>
+                <a16:creationId xmlns:a16="http://schemas.microsoft.com/office/drawing/2014/main" id="{211F024D-3930-4245-9175-C3FB14BBDB52}"/>
               </a:ext>
             </a:extLst>
           </p:cNvPr>
@@ -6355,7 +6449,7 @@
     </p:spTree>
     <p:extLst>
       <p:ext uri="{BB962C8B-B14F-4D97-AF65-F5344CB8AC3E}">
-        <p14:creationId xmlns:p14="http://schemas.microsoft.com/office/powerpoint/2010/main" val="937446983"/>
+        <p14:creationId xmlns:p14="http://schemas.microsoft.com/office/powerpoint/2010/main" val="884742971"/>
       </p:ext>
     </p:extLst>
   </p:cSld>
@@ -6386,7 +6480,7 @@
           <p:cNvPr id="20" name="">
             <a:extLst xmlns:a="http://schemas.openxmlformats.org/drawingml/2006/main">
               <a:ext uri="{FF2B5EF4-FFF2-40B4-BE49-F238E27FC236}">
-                <a16:creationId xmlns:a16="http://schemas.microsoft.com/office/drawing/2014/main" id="{C878831E-5DC1-421B-9E7B-EEDDF107564D}"/>
+                <a16:creationId xmlns:a16="http://schemas.microsoft.com/office/drawing/2014/main" id="{BC4C72E1-C0A7-4E32-AC0F-ABBB736E7B36}"/>
               </a:ext>
             </a:extLst>
           </p:cNvPr>
@@ -6436,7 +6530,7 @@
           <p:cNvPr id="2" name="">
             <a:extLst xmlns:a="http://schemas.openxmlformats.org/drawingml/2006/main">
               <a:ext uri="{FF2B5EF4-FFF2-40B4-BE49-F238E27FC236}">
-                <a16:creationId xmlns:a16="http://schemas.microsoft.com/office/drawing/2014/main" id="{B4B2D42A-D4B3-4B09-B033-72D6635CE9E5}"/>
+                <a16:creationId xmlns:a16="http://schemas.microsoft.com/office/drawing/2014/main" id="{60D135D1-2FF3-4B6E-B69B-5BABF4D51FA0}"/>
               </a:ext>
             </a:extLst>
           </p:cNvPr>
@@ -6486,7 +6580,7 @@
           <p:cNvPr id="3" name="">
             <a:extLst xmlns:a="http://schemas.openxmlformats.org/drawingml/2006/main">
               <a:ext uri="{FF2B5EF4-FFF2-40B4-BE49-F238E27FC236}">
-                <a16:creationId xmlns:a16="http://schemas.microsoft.com/office/drawing/2014/main" id="{AA3E047C-C651-462F-B7BB-1900FF2C6037}"/>
+                <a16:creationId xmlns:a16="http://schemas.microsoft.com/office/drawing/2014/main" id="{B798A631-A1A4-4BBA-B3E9-348CC6498A9B}"/>
               </a:ext>
             </a:extLst>
           </p:cNvPr>
@@ -6531,7 +6625,7 @@
           <p:nvPr/>
         </p:nvPicPr>
         <p:blipFill>
-          <a:blip xmlns:r="http://schemas.openxmlformats.org/officeDocument/2006/relationships" xmlns:a="http://schemas.openxmlformats.org/drawingml/2006/main" r:embed="Rddb4a12f75e54f7d"/>
+          <a:blip xmlns:r="http://schemas.openxmlformats.org/officeDocument/2006/relationships" xmlns:a="http://schemas.openxmlformats.org/drawingml/2006/main" r:embed="Rfea882470e714236"/>
           <a:stretch xmlns:a="http://schemas.openxmlformats.org/drawingml/2006/main"/>
         </p:blipFill>
         <p:spPr>
@@ -6551,7 +6645,7 @@
           <p:cNvPr id="5" name="">
             <a:extLst xmlns:a="http://schemas.openxmlformats.org/drawingml/2006/main">
               <a:ext uri="{FF2B5EF4-FFF2-40B4-BE49-F238E27FC236}">
-                <a16:creationId xmlns:a16="http://schemas.microsoft.com/office/drawing/2014/main" id="{FD20BEF0-0749-4BEB-BFD7-BEC34F30E24D}"/>
+                <a16:creationId xmlns:a16="http://schemas.microsoft.com/office/drawing/2014/main" id="{AAD5F2DC-6F24-49B3-87AF-B2362A22190A}"/>
               </a:ext>
             </a:extLst>
           </p:cNvPr>
@@ -6601,7 +6695,7 @@
           <p:cNvPr id="6" name="">
             <a:extLst xmlns:a="http://schemas.openxmlformats.org/drawingml/2006/main">
               <a:ext uri="{FF2B5EF4-FFF2-40B4-BE49-F238E27FC236}">
-                <a16:creationId xmlns:a16="http://schemas.microsoft.com/office/drawing/2014/main" id="{8431EDC0-AF9E-4DEA-AC18-DD495ED6AF70}"/>
+                <a16:creationId xmlns:a16="http://schemas.microsoft.com/office/drawing/2014/main" id="{FEF4F438-F5A7-4FEF-85F7-13986C51D99B}"/>
               </a:ext>
             </a:extLst>
           </p:cNvPr>
@@ -6651,7 +6745,7 @@
           <p:cNvPr id="7" name="">
             <a:extLst xmlns:a="http://schemas.openxmlformats.org/drawingml/2006/main">
               <a:ext uri="{FF2B5EF4-FFF2-40B4-BE49-F238E27FC236}">
-                <a16:creationId xmlns:a16="http://schemas.microsoft.com/office/drawing/2014/main" id="{0022410D-C8E7-49AF-8397-439EFABFA24B}"/>
+                <a16:creationId xmlns:a16="http://schemas.microsoft.com/office/drawing/2014/main" id="{B2300CE2-47CC-4CB1-BC3E-9AB5379EB2C8}"/>
               </a:ext>
             </a:extLst>
           </p:cNvPr>
@@ -6701,7 +6795,7 @@
           <p:cNvPr id="8" name="">
             <a:extLst xmlns:a="http://schemas.openxmlformats.org/drawingml/2006/main">
               <a:ext uri="{FF2B5EF4-FFF2-40B4-BE49-F238E27FC236}">
-                <a16:creationId xmlns:a16="http://schemas.microsoft.com/office/drawing/2014/main" id="{CD90D7F8-4DA2-4587-8F26-E264AADA6F53}"/>
+                <a16:creationId xmlns:a16="http://schemas.microsoft.com/office/drawing/2014/main" id="{FFFF748D-A784-4126-BCA7-70630391A3E4}"/>
               </a:ext>
             </a:extLst>
           </p:cNvPr>
@@ -6732,7 +6826,7 @@
           <p:cNvPr id="9" name="">
             <a:extLst xmlns:a="http://schemas.openxmlformats.org/drawingml/2006/main">
               <a:ext uri="{FF2B5EF4-FFF2-40B4-BE49-F238E27FC236}">
-                <a16:creationId xmlns:a16="http://schemas.microsoft.com/office/drawing/2014/main" id="{417745F3-D325-4BD6-8DCD-C49CCB271853}"/>
+                <a16:creationId xmlns:a16="http://schemas.microsoft.com/office/drawing/2014/main" id="{D8C80199-62F8-4C07-B7AB-79C8497669E7}"/>
               </a:ext>
             </a:extLst>
           </p:cNvPr>
@@ -6782,7 +6876,7 @@
           <p:cNvPr id="10" name="">
             <a:extLst xmlns:a="http://schemas.openxmlformats.org/drawingml/2006/main">
               <a:ext uri="{FF2B5EF4-FFF2-40B4-BE49-F238E27FC236}">
-                <a16:creationId xmlns:a16="http://schemas.microsoft.com/office/drawing/2014/main" id="{A37035DA-CD99-41C0-8331-6B36B50726B2}"/>
+                <a16:creationId xmlns:a16="http://schemas.microsoft.com/office/drawing/2014/main" id="{880D7112-D1CD-4B8D-8776-63933615C93F}"/>
               </a:ext>
             </a:extLst>
           </p:cNvPr>
@@ -6832,7 +6926,7 @@
           <p:cNvPr id="11" name="">
             <a:extLst xmlns:a="http://schemas.openxmlformats.org/drawingml/2006/main">
               <a:ext uri="{FF2B5EF4-FFF2-40B4-BE49-F238E27FC236}">
-                <a16:creationId xmlns:a16="http://schemas.microsoft.com/office/drawing/2014/main" id="{7ADFCB27-9C9C-4B9A-B588-047BB2C3C198}"/>
+                <a16:creationId xmlns:a16="http://schemas.microsoft.com/office/drawing/2014/main" id="{7ACD712B-9FC8-4A90-B3C9-9D0A7D709909}"/>
               </a:ext>
             </a:extLst>
           </p:cNvPr>
@@ -6882,7 +6976,7 @@
           <p:cNvPr id="12" name="">
             <a:extLst xmlns:a="http://schemas.openxmlformats.org/drawingml/2006/main">
               <a:ext uri="{FF2B5EF4-FFF2-40B4-BE49-F238E27FC236}">
-                <a16:creationId xmlns:a16="http://schemas.microsoft.com/office/drawing/2014/main" id="{F8C59150-B35C-41B7-B7E9-F3AB1C84C591}"/>
+                <a16:creationId xmlns:a16="http://schemas.microsoft.com/office/drawing/2014/main" id="{ACC4CF9A-114E-4A71-B9D5-72E046185424}"/>
               </a:ext>
             </a:extLst>
           </p:cNvPr>
@@ -6913,7 +7007,7 @@
           <p:cNvPr id="13" name="">
             <a:extLst xmlns:a="http://schemas.openxmlformats.org/drawingml/2006/main">
               <a:ext uri="{FF2B5EF4-FFF2-40B4-BE49-F238E27FC236}">
-                <a16:creationId xmlns:a16="http://schemas.microsoft.com/office/drawing/2014/main" id="{D54748A5-68A6-4E70-831E-84954131478E}"/>
+                <a16:creationId xmlns:a16="http://schemas.microsoft.com/office/drawing/2014/main" id="{8D63821A-50C0-4CF6-9FD8-64E8227E1120}"/>
               </a:ext>
             </a:extLst>
           </p:cNvPr>
@@ -6963,7 +7057,7 @@
           <p:cNvPr id="14" name="">
             <a:extLst xmlns:a="http://schemas.openxmlformats.org/drawingml/2006/main">
               <a:ext uri="{FF2B5EF4-FFF2-40B4-BE49-F238E27FC236}">
-                <a16:creationId xmlns:a16="http://schemas.microsoft.com/office/drawing/2014/main" id="{0D9FF785-7140-45B0-AE39-3BE1299FFC97}"/>
+                <a16:creationId xmlns:a16="http://schemas.microsoft.com/office/drawing/2014/main" id="{99402E5D-2561-49A7-B9A4-C4DAAFAB5877}"/>
               </a:ext>
             </a:extLst>
           </p:cNvPr>
@@ -7013,7 +7107,7 @@
           <p:cNvPr id="15" name="">
             <a:extLst xmlns:a="http://schemas.openxmlformats.org/drawingml/2006/main">
               <a:ext uri="{FF2B5EF4-FFF2-40B4-BE49-F238E27FC236}">
-                <a16:creationId xmlns:a16="http://schemas.microsoft.com/office/drawing/2014/main" id="{466033A1-6057-426D-BC37-70C17862F279}"/>
+                <a16:creationId xmlns:a16="http://schemas.microsoft.com/office/drawing/2014/main" id="{4A6BE1D5-9074-4543-8916-27B02E8762D7}"/>
               </a:ext>
             </a:extLst>
           </p:cNvPr>
@@ -7063,7 +7157,7 @@
           <p:cNvPr id="16" name="">
             <a:extLst xmlns:a="http://schemas.openxmlformats.org/drawingml/2006/main">
               <a:ext uri="{FF2B5EF4-FFF2-40B4-BE49-F238E27FC236}">
-                <a16:creationId xmlns:a16="http://schemas.microsoft.com/office/drawing/2014/main" id="{0C6946BC-AAC3-4AD4-8682-F9684ABF224A}"/>
+                <a16:creationId xmlns:a16="http://schemas.microsoft.com/office/drawing/2014/main" id="{F26E9216-1067-4FA1-BAFF-4F23CFBF3412}"/>
               </a:ext>
             </a:extLst>
           </p:cNvPr>
@@ -7094,7 +7188,7 @@
           <p:cNvPr id="17" name="">
             <a:extLst xmlns:a="http://schemas.openxmlformats.org/drawingml/2006/main">
               <a:ext uri="{FF2B5EF4-FFF2-40B4-BE49-F238E27FC236}">
-                <a16:creationId xmlns:a16="http://schemas.microsoft.com/office/drawing/2014/main" id="{F44F9211-F719-4C29-B964-C6BD08E1FE5C}"/>
+                <a16:creationId xmlns:a16="http://schemas.microsoft.com/office/drawing/2014/main" id="{E29AD6C3-9001-41EE-9F42-FE9344DFEB6E}"/>
               </a:ext>
             </a:extLst>
           </p:cNvPr>
@@ -7144,7 +7238,7 @@
           <p:cNvPr id="18" name="">
             <a:extLst xmlns:a="http://schemas.openxmlformats.org/drawingml/2006/main">
               <a:ext uri="{FF2B5EF4-FFF2-40B4-BE49-F238E27FC236}">
-                <a16:creationId xmlns:a16="http://schemas.microsoft.com/office/drawing/2014/main" id="{0B8245A0-589A-4C9A-B5D0-6C173F903F73}"/>
+                <a16:creationId xmlns:a16="http://schemas.microsoft.com/office/drawing/2014/main" id="{962C5A99-E6F7-4E4C-9962-13C60AFCD39E}"/>
               </a:ext>
             </a:extLst>
           </p:cNvPr>
@@ -7194,7 +7288,7 @@
           <p:cNvPr id="19" name="">
             <a:extLst xmlns:a="http://schemas.openxmlformats.org/drawingml/2006/main">
               <a:ext uri="{FF2B5EF4-FFF2-40B4-BE49-F238E27FC236}">
-                <a16:creationId xmlns:a16="http://schemas.microsoft.com/office/drawing/2014/main" id="{8A93BB78-B9AD-4940-90FB-110759208F62}"/>
+                <a16:creationId xmlns:a16="http://schemas.microsoft.com/office/drawing/2014/main" id="{7B2DF87B-0440-4CF2-9705-4A232A11290E}"/>
               </a:ext>
             </a:extLst>
           </p:cNvPr>
@@ -7242,7 +7336,7 @@
     </p:spTree>
     <p:extLst>
       <p:ext uri="{BB962C8B-B14F-4D97-AF65-F5344CB8AC3E}">
-        <p14:creationId xmlns:p14="http://schemas.microsoft.com/office/powerpoint/2010/main" val="1585163680"/>
+        <p14:creationId xmlns:p14="http://schemas.microsoft.com/office/powerpoint/2010/main" val="1964506173"/>
       </p:ext>
     </p:extLst>
   </p:cSld>
@@ -7273,7 +7367,7 @@
           <p:cNvPr id="16" name="">
             <a:extLst xmlns:a="http://schemas.openxmlformats.org/drawingml/2006/main">
               <a:ext uri="{FF2B5EF4-FFF2-40B4-BE49-F238E27FC236}">
-                <a16:creationId xmlns:a16="http://schemas.microsoft.com/office/drawing/2014/main" id="{58EBE4A3-7204-4EC2-8A3F-07E186938A10}"/>
+                <a16:creationId xmlns:a16="http://schemas.microsoft.com/office/drawing/2014/main" id="{32343A67-2814-480D-944F-EA821F679094}"/>
               </a:ext>
             </a:extLst>
           </p:cNvPr>
@@ -7323,7 +7417,7 @@
           <p:cNvPr id="2" name="">
             <a:extLst xmlns:a="http://schemas.openxmlformats.org/drawingml/2006/main">
               <a:ext uri="{FF2B5EF4-FFF2-40B4-BE49-F238E27FC236}">
-                <a16:creationId xmlns:a16="http://schemas.microsoft.com/office/drawing/2014/main" id="{FF794623-F7CF-4008-A1B8-523D5F57B751}"/>
+                <a16:creationId xmlns:a16="http://schemas.microsoft.com/office/drawing/2014/main" id="{C1697A02-B1FD-41D9-BCE9-9E02A0DE5A4C}"/>
               </a:ext>
             </a:extLst>
           </p:cNvPr>
@@ -7373,7 +7467,7 @@
           <p:cNvPr id="3" name="">
             <a:extLst xmlns:a="http://schemas.openxmlformats.org/drawingml/2006/main">
               <a:ext uri="{FF2B5EF4-FFF2-40B4-BE49-F238E27FC236}">
-                <a16:creationId xmlns:a16="http://schemas.microsoft.com/office/drawing/2014/main" id="{1C656229-A21D-4211-B203-BF070AE31AD0}"/>
+                <a16:creationId xmlns:a16="http://schemas.microsoft.com/office/drawing/2014/main" id="{4F53DEE5-3C7F-4C9F-87E1-064DF57AC7B8}"/>
               </a:ext>
             </a:extLst>
           </p:cNvPr>
@@ -7430,7 +7524,7 @@
         </p:xfrm>
         <a:graphic xmlns:a="http://schemas.openxmlformats.org/drawingml/2006/main">
           <a:graphicData uri="http://schemas.openxmlformats.org/drawingml/2006/chart">
-            <c:chart xmlns:r="http://schemas.openxmlformats.org/officeDocument/2006/relationships" xmlns:c="http://schemas.openxmlformats.org/drawingml/2006/chart" r:id="R2b4f1b37f0214eb4"/>
+            <c:chart xmlns:r="http://schemas.openxmlformats.org/officeDocument/2006/relationships" xmlns:c="http://schemas.openxmlformats.org/drawingml/2006/chart" r:id="R6936f2b5a5794d43"/>
           </a:graphicData>
         </a:graphic>
       </p:graphicFrame>
@@ -7439,7 +7533,7 @@
           <p:cNvPr id="5" name="">
             <a:extLst xmlns:a="http://schemas.openxmlformats.org/drawingml/2006/main">
               <a:ext uri="{FF2B5EF4-FFF2-40B4-BE49-F238E27FC236}">
-                <a16:creationId xmlns:a16="http://schemas.microsoft.com/office/drawing/2014/main" id="{2AABC9A7-21A7-4B0A-A1E1-398AE5F86B0F}"/>
+                <a16:creationId xmlns:a16="http://schemas.microsoft.com/office/drawing/2014/main" id="{DDDD130B-04B2-4B53-B39F-09EAD849DD36}"/>
               </a:ext>
             </a:extLst>
           </p:cNvPr>
@@ -7489,7 +7583,7 @@
           <p:cNvPr id="6" name="">
             <a:extLst xmlns:a="http://schemas.openxmlformats.org/drawingml/2006/main">
               <a:ext uri="{FF2B5EF4-FFF2-40B4-BE49-F238E27FC236}">
-                <a16:creationId xmlns:a16="http://schemas.microsoft.com/office/drawing/2014/main" id="{B9610FFD-019E-47A9-AC6D-124EA8CDC2CF}"/>
+                <a16:creationId xmlns:a16="http://schemas.microsoft.com/office/drawing/2014/main" id="{7BBF1CFC-0D7A-43F1-92F8-D6E3D6B6BA6D}"/>
               </a:ext>
             </a:extLst>
           </p:cNvPr>
@@ -7539,7 +7633,7 @@
           <p:cNvPr id="7" name="">
             <a:extLst xmlns:a="http://schemas.openxmlformats.org/drawingml/2006/main">
               <a:ext uri="{FF2B5EF4-FFF2-40B4-BE49-F238E27FC236}">
-                <a16:creationId xmlns:a16="http://schemas.microsoft.com/office/drawing/2014/main" id="{04B0BD95-60B1-4284-AE8A-9B9D6AF74E79}"/>
+                <a16:creationId xmlns:a16="http://schemas.microsoft.com/office/drawing/2014/main" id="{6CE4B8DD-48EA-4E75-B576-7AF64B92E572}"/>
               </a:ext>
             </a:extLst>
           </p:cNvPr>
@@ -7589,7 +7683,7 @@
           <p:cNvPr id="8" name="">
             <a:extLst xmlns:a="http://schemas.openxmlformats.org/drawingml/2006/main">
               <a:ext uri="{FF2B5EF4-FFF2-40B4-BE49-F238E27FC236}">
-                <a16:creationId xmlns:a16="http://schemas.microsoft.com/office/drawing/2014/main" id="{6AFCEF5C-6E42-496F-992A-F5828478537B}"/>
+                <a16:creationId xmlns:a16="http://schemas.microsoft.com/office/drawing/2014/main" id="{D05C54F9-F9A2-420E-82DB-6F9B0475E1CA}"/>
               </a:ext>
             </a:extLst>
           </p:cNvPr>
@@ -7639,7 +7733,7 @@
           <p:cNvPr id="9" name="">
             <a:extLst xmlns:a="http://schemas.openxmlformats.org/drawingml/2006/main">
               <a:ext uri="{FF2B5EF4-FFF2-40B4-BE49-F238E27FC236}">
-                <a16:creationId xmlns:a16="http://schemas.microsoft.com/office/drawing/2014/main" id="{2EB9217B-6FD2-4DB8-A511-C5FCCEE10DB9}"/>
+                <a16:creationId xmlns:a16="http://schemas.microsoft.com/office/drawing/2014/main" id="{17BEB2D2-0AFE-4FC1-BF1E-E9DA65311A00}"/>
               </a:ext>
             </a:extLst>
           </p:cNvPr>
@@ -7689,7 +7783,7 @@
           <p:cNvPr id="10" name="">
             <a:extLst xmlns:a="http://schemas.openxmlformats.org/drawingml/2006/main">
               <a:ext uri="{FF2B5EF4-FFF2-40B4-BE49-F238E27FC236}">
-                <a16:creationId xmlns:a16="http://schemas.microsoft.com/office/drawing/2014/main" id="{A1B24A78-6E70-409E-84C2-3CD8E124EE34}"/>
+                <a16:creationId xmlns:a16="http://schemas.microsoft.com/office/drawing/2014/main" id="{4A75BE74-044E-4451-9A62-B2093C33FF83}"/>
               </a:ext>
             </a:extLst>
           </p:cNvPr>
@@ -7746,7 +7840,7 @@
         </p:xfrm>
         <a:graphic xmlns:a="http://schemas.openxmlformats.org/drawingml/2006/main">
           <a:graphicData uri="http://schemas.openxmlformats.org/drawingml/2006/chart">
-            <c:chart xmlns:r="http://schemas.openxmlformats.org/officeDocument/2006/relationships" xmlns:c="http://schemas.openxmlformats.org/drawingml/2006/chart" r:id="Rfd8058deaa9941cd"/>
+            <c:chart xmlns:r="http://schemas.openxmlformats.org/officeDocument/2006/relationships" xmlns:c="http://schemas.openxmlformats.org/drawingml/2006/chart" r:id="Rce41866fca3a4df0"/>
           </a:graphicData>
         </a:graphic>
       </p:graphicFrame>
@@ -7755,7 +7849,7 @@
           <p:cNvPr id="12" name="">
             <a:extLst xmlns:a="http://schemas.openxmlformats.org/drawingml/2006/main">
               <a:ext uri="{FF2B5EF4-FFF2-40B4-BE49-F238E27FC236}">
-                <a16:creationId xmlns:a16="http://schemas.microsoft.com/office/drawing/2014/main" id="{929030C3-9179-4F86-8BC2-19434DCFF00C}"/>
+                <a16:creationId xmlns:a16="http://schemas.microsoft.com/office/drawing/2014/main" id="{B5739B22-27DF-4078-A501-695C66A8C841}"/>
               </a:ext>
             </a:extLst>
           </p:cNvPr>
@@ -7805,7 +7899,7 @@
           <p:cNvPr id="13" name="">
             <a:extLst xmlns:a="http://schemas.openxmlformats.org/drawingml/2006/main">
               <a:ext uri="{FF2B5EF4-FFF2-40B4-BE49-F238E27FC236}">
-                <a16:creationId xmlns:a16="http://schemas.microsoft.com/office/drawing/2014/main" id="{DC6965B4-ACE3-4B88-85B5-369BB427D296}"/>
+                <a16:creationId xmlns:a16="http://schemas.microsoft.com/office/drawing/2014/main" id="{1E2B9163-4B55-4FD0-8AEE-D8FF793C5B1E}"/>
               </a:ext>
             </a:extLst>
           </p:cNvPr>
@@ -7855,7 +7949,7 @@
           <p:cNvPr id="14" name="">
             <a:extLst xmlns:a="http://schemas.openxmlformats.org/drawingml/2006/main">
               <a:ext uri="{FF2B5EF4-FFF2-40B4-BE49-F238E27FC236}">
-                <a16:creationId xmlns:a16="http://schemas.microsoft.com/office/drawing/2014/main" id="{08CBEF47-0CED-408F-9CE0-EFDBEF6C8DC0}"/>
+                <a16:creationId xmlns:a16="http://schemas.microsoft.com/office/drawing/2014/main" id="{561ED17A-A94D-4661-AB99-AC0E0F768B32}"/>
               </a:ext>
             </a:extLst>
           </p:cNvPr>
@@ -7905,7 +7999,7 @@
           <p:cNvPr id="15" name="">
             <a:extLst xmlns:a="http://schemas.openxmlformats.org/drawingml/2006/main">
               <a:ext uri="{FF2B5EF4-FFF2-40B4-BE49-F238E27FC236}">
-                <a16:creationId xmlns:a16="http://schemas.microsoft.com/office/drawing/2014/main" id="{110C5774-ECE2-46D7-8BCA-CB02AEADFD34}"/>
+                <a16:creationId xmlns:a16="http://schemas.microsoft.com/office/drawing/2014/main" id="{62A4E397-46B4-475C-B008-01CEC4FB3DCA}"/>
               </a:ext>
             </a:extLst>
           </p:cNvPr>
@@ -7953,7 +8047,7 @@
     </p:spTree>
     <p:extLst>
       <p:ext uri="{BB962C8B-B14F-4D97-AF65-F5344CB8AC3E}">
-        <p14:creationId xmlns:p14="http://schemas.microsoft.com/office/powerpoint/2010/main" val="1242662710"/>
+        <p14:creationId xmlns:p14="http://schemas.microsoft.com/office/powerpoint/2010/main" val="785577950"/>
       </p:ext>
     </p:extLst>
   </p:cSld>
@@ -7984,7 +8078,7 @@
           <p:cNvPr id="44" name="">
             <a:extLst xmlns:a="http://schemas.openxmlformats.org/drawingml/2006/main">
               <a:ext uri="{FF2B5EF4-FFF2-40B4-BE49-F238E27FC236}">
-                <a16:creationId xmlns:a16="http://schemas.microsoft.com/office/drawing/2014/main" id="{9301528F-B878-4644-8200-C836AF5C8109}"/>
+                <a16:creationId xmlns:a16="http://schemas.microsoft.com/office/drawing/2014/main" id="{94A6D775-67BF-4E56-BF83-868FD22DCC74}"/>
               </a:ext>
             </a:extLst>
           </p:cNvPr>
@@ -8034,7 +8128,7 @@
           <p:cNvPr id="2" name="">
             <a:extLst xmlns:a="http://schemas.openxmlformats.org/drawingml/2006/main">
               <a:ext uri="{FF2B5EF4-FFF2-40B4-BE49-F238E27FC236}">
-                <a16:creationId xmlns:a16="http://schemas.microsoft.com/office/drawing/2014/main" id="{7126E673-FBA9-42EF-B529-D50A2D7761E2}"/>
+                <a16:creationId xmlns:a16="http://schemas.microsoft.com/office/drawing/2014/main" id="{AA7384E0-B837-4286-A29B-7556F65040F6}"/>
               </a:ext>
             </a:extLst>
           </p:cNvPr>
@@ -8084,7 +8178,7 @@
           <p:cNvPr id="3" name="">
             <a:extLst xmlns:a="http://schemas.openxmlformats.org/drawingml/2006/main">
               <a:ext uri="{FF2B5EF4-FFF2-40B4-BE49-F238E27FC236}">
-                <a16:creationId xmlns:a16="http://schemas.microsoft.com/office/drawing/2014/main" id="{71DBCA6B-0401-4625-97AB-80C40F01BBB7}"/>
+                <a16:creationId xmlns:a16="http://schemas.microsoft.com/office/drawing/2014/main" id="{FBBED3F4-FD4F-457D-8F52-91A77633A059}"/>
               </a:ext>
             </a:extLst>
           </p:cNvPr>
@@ -8115,7 +8209,7 @@
           <p:cNvPr id="4" name="">
             <a:extLst xmlns:a="http://schemas.openxmlformats.org/drawingml/2006/main">
               <a:ext uri="{FF2B5EF4-FFF2-40B4-BE49-F238E27FC236}">
-                <a16:creationId xmlns:a16="http://schemas.microsoft.com/office/drawing/2014/main" id="{9C6654FB-815A-4C26-ABBA-667DE35F371D}"/>
+                <a16:creationId xmlns:a16="http://schemas.microsoft.com/office/drawing/2014/main" id="{B261F25E-FFC5-4C6E-BD45-3EDA9C97AC7E}"/>
               </a:ext>
             </a:extLst>
           </p:cNvPr>
@@ -8146,7 +8240,7 @@
           <p:cNvPr id="5" name="">
             <a:extLst xmlns:a="http://schemas.openxmlformats.org/drawingml/2006/main">
               <a:ext uri="{FF2B5EF4-FFF2-40B4-BE49-F238E27FC236}">
-                <a16:creationId xmlns:a16="http://schemas.microsoft.com/office/drawing/2014/main" id="{E380A20C-317C-4177-A4D4-F77CDB09396F}"/>
+                <a16:creationId xmlns:a16="http://schemas.microsoft.com/office/drawing/2014/main" id="{3C78A2B1-7766-4620-A423-F4D5F9DC113F}"/>
               </a:ext>
             </a:extLst>
           </p:cNvPr>
@@ -8177,7 +8271,7 @@
           <p:cNvPr id="6" name="">
             <a:extLst xmlns:a="http://schemas.openxmlformats.org/drawingml/2006/main">
               <a:ext uri="{FF2B5EF4-FFF2-40B4-BE49-F238E27FC236}">
-                <a16:creationId xmlns:a16="http://schemas.microsoft.com/office/drawing/2014/main" id="{CDF70C23-DE73-4BE1-9561-B6ABBF3A4D66}"/>
+                <a16:creationId xmlns:a16="http://schemas.microsoft.com/office/drawing/2014/main" id="{B183DE00-C48D-4336-B31C-E1159E2D2B44}"/>
               </a:ext>
             </a:extLst>
           </p:cNvPr>
@@ -8227,7 +8321,7 @@
           <p:cNvPr id="7" name="">
             <a:extLst xmlns:a="http://schemas.openxmlformats.org/drawingml/2006/main">
               <a:ext uri="{FF2B5EF4-FFF2-40B4-BE49-F238E27FC236}">
-                <a16:creationId xmlns:a16="http://schemas.microsoft.com/office/drawing/2014/main" id="{196258A7-4704-48A0-887F-CA300962B078}"/>
+                <a16:creationId xmlns:a16="http://schemas.microsoft.com/office/drawing/2014/main" id="{6E10202E-C149-454D-A9B1-8D013FC27F4F}"/>
               </a:ext>
             </a:extLst>
           </p:cNvPr>
@@ -8277,7 +8371,7 @@
           <p:cNvPr id="8" name="">
             <a:extLst xmlns:a="http://schemas.openxmlformats.org/drawingml/2006/main">
               <a:ext uri="{FF2B5EF4-FFF2-40B4-BE49-F238E27FC236}">
-                <a16:creationId xmlns:a16="http://schemas.microsoft.com/office/drawing/2014/main" id="{A3A0D3D4-60A6-4021-86D9-F32E17F64DD9}"/>
+                <a16:creationId xmlns:a16="http://schemas.microsoft.com/office/drawing/2014/main" id="{E5580501-AB5E-4F18-8F54-E1AE82CF2C2F}"/>
               </a:ext>
             </a:extLst>
           </p:cNvPr>
@@ -8327,7 +8421,7 @@
           <p:cNvPr id="9" name="">
             <a:extLst xmlns:a="http://schemas.openxmlformats.org/drawingml/2006/main">
               <a:ext uri="{FF2B5EF4-FFF2-40B4-BE49-F238E27FC236}">
-                <a16:creationId xmlns:a16="http://schemas.microsoft.com/office/drawing/2014/main" id="{A8F99225-F8A8-44F1-91D6-D015AE31BB9E}"/>
+                <a16:creationId xmlns:a16="http://schemas.microsoft.com/office/drawing/2014/main" id="{5DD8E510-AB9F-4D01-8C29-A20A7E1D7044}"/>
               </a:ext>
             </a:extLst>
           </p:cNvPr>
@@ -8377,7 +8471,7 @@
           <p:cNvPr id="10" name="">
             <a:extLst xmlns:a="http://schemas.openxmlformats.org/drawingml/2006/main">
               <a:ext uri="{FF2B5EF4-FFF2-40B4-BE49-F238E27FC236}">
-                <a16:creationId xmlns:a16="http://schemas.microsoft.com/office/drawing/2014/main" id="{A5910375-9B89-411F-BBBD-4E1F8191410B}"/>
+                <a16:creationId xmlns:a16="http://schemas.microsoft.com/office/drawing/2014/main" id="{658524EE-51DA-47EF-AEBC-BDC9238F5B8A}"/>
               </a:ext>
             </a:extLst>
           </p:cNvPr>
@@ -8427,7 +8521,7 @@
           <p:cNvPr id="11" name="">
             <a:extLst xmlns:a="http://schemas.openxmlformats.org/drawingml/2006/main">
               <a:ext uri="{FF2B5EF4-FFF2-40B4-BE49-F238E27FC236}">
-                <a16:creationId xmlns:a16="http://schemas.microsoft.com/office/drawing/2014/main" id="{9E1CCDAF-B49D-40B8-A2B9-F601A36E2006}"/>
+                <a16:creationId xmlns:a16="http://schemas.microsoft.com/office/drawing/2014/main" id="{5FB577F8-D4DB-467F-869A-5B3A57EBD5AC}"/>
               </a:ext>
             </a:extLst>
           </p:cNvPr>
@@ -8477,7 +8571,7 @@
           <p:cNvPr id="12" name="">
             <a:extLst xmlns:a="http://schemas.openxmlformats.org/drawingml/2006/main">
               <a:ext uri="{FF2B5EF4-FFF2-40B4-BE49-F238E27FC236}">
-                <a16:creationId xmlns:a16="http://schemas.microsoft.com/office/drawing/2014/main" id="{1E6035A4-9CDD-4649-BB9C-FEA2167844F3}"/>
+                <a16:creationId xmlns:a16="http://schemas.microsoft.com/office/drawing/2014/main" id="{4057485E-CB13-4803-B1E9-FD7964213C97}"/>
               </a:ext>
             </a:extLst>
           </p:cNvPr>
@@ -8527,7 +8621,7 @@
           <p:cNvPr id="13" name="">
             <a:extLst xmlns:a="http://schemas.openxmlformats.org/drawingml/2006/main">
               <a:ext uri="{FF2B5EF4-FFF2-40B4-BE49-F238E27FC236}">
-                <a16:creationId xmlns:a16="http://schemas.microsoft.com/office/drawing/2014/main" id="{F8658737-2430-4657-BE2C-41FE61DF1D15}"/>
+                <a16:creationId xmlns:a16="http://schemas.microsoft.com/office/drawing/2014/main" id="{C6DFF8F4-2274-49E7-B2C8-9390C9C702AD}"/>
               </a:ext>
             </a:extLst>
           </p:cNvPr>
@@ -8577,7 +8671,7 @@
           <p:cNvPr id="14" name="">
             <a:extLst xmlns:a="http://schemas.openxmlformats.org/drawingml/2006/main">
               <a:ext uri="{FF2B5EF4-FFF2-40B4-BE49-F238E27FC236}">
-                <a16:creationId xmlns:a16="http://schemas.microsoft.com/office/drawing/2014/main" id="{7CF9C8B4-7756-47BF-9369-276112A31B08}"/>
+                <a16:creationId xmlns:a16="http://schemas.microsoft.com/office/drawing/2014/main" id="{FEAF9FFA-9849-4D0B-A42D-4DCF4EB0B73F}"/>
               </a:ext>
             </a:extLst>
           </p:cNvPr>
@@ -8608,7 +8702,7 @@
           <p:cNvPr id="15" name="">
             <a:extLst xmlns:a="http://schemas.openxmlformats.org/drawingml/2006/main">
               <a:ext uri="{FF2B5EF4-FFF2-40B4-BE49-F238E27FC236}">
-                <a16:creationId xmlns:a16="http://schemas.microsoft.com/office/drawing/2014/main" id="{CE3B8511-BCAA-4A34-85FB-46741E6DC35E}"/>
+                <a16:creationId xmlns:a16="http://schemas.microsoft.com/office/drawing/2014/main" id="{7EC4C322-E5C9-4F5A-9617-AC3A3074879D}"/>
               </a:ext>
             </a:extLst>
           </p:cNvPr>
@@ -8639,7 +8733,7 @@
           <p:cNvPr id="16" name="">
             <a:extLst xmlns:a="http://schemas.openxmlformats.org/drawingml/2006/main">
               <a:ext uri="{FF2B5EF4-FFF2-40B4-BE49-F238E27FC236}">
-                <a16:creationId xmlns:a16="http://schemas.microsoft.com/office/drawing/2014/main" id="{D3C1AF20-BE16-45F5-9278-1A5A9604C051}"/>
+                <a16:creationId xmlns:a16="http://schemas.microsoft.com/office/drawing/2014/main" id="{7184ACDC-6B2A-4165-BC6F-4B2DF4054C32}"/>
               </a:ext>
             </a:extLst>
           </p:cNvPr>
@@ -8670,7 +8764,7 @@
           <p:cNvPr id="17" name="">
             <a:extLst xmlns:a="http://schemas.openxmlformats.org/drawingml/2006/main">
               <a:ext uri="{FF2B5EF4-FFF2-40B4-BE49-F238E27FC236}">
-                <a16:creationId xmlns:a16="http://schemas.microsoft.com/office/drawing/2014/main" id="{53E4BC49-9DFC-4099-A690-A8C295607806}"/>
+                <a16:creationId xmlns:a16="http://schemas.microsoft.com/office/drawing/2014/main" id="{0955287C-C04F-4F27-8858-BF058589E322}"/>
               </a:ext>
             </a:extLst>
           </p:cNvPr>
@@ -8701,7 +8795,7 @@
           <p:cNvPr id="18" name="">
             <a:extLst xmlns:a="http://schemas.openxmlformats.org/drawingml/2006/main">
               <a:ext uri="{FF2B5EF4-FFF2-40B4-BE49-F238E27FC236}">
-                <a16:creationId xmlns:a16="http://schemas.microsoft.com/office/drawing/2014/main" id="{597EED7B-E810-40A9-B237-42A940FDFCCE}"/>
+                <a16:creationId xmlns:a16="http://schemas.microsoft.com/office/drawing/2014/main" id="{87E7B2D0-5A64-408F-B0E7-563C0BDEF57C}"/>
               </a:ext>
             </a:extLst>
           </p:cNvPr>
@@ -8732,7 +8826,7 @@
           <p:cNvPr id="19" name="">
             <a:extLst xmlns:a="http://schemas.openxmlformats.org/drawingml/2006/main">
               <a:ext uri="{FF2B5EF4-FFF2-40B4-BE49-F238E27FC236}">
-                <a16:creationId xmlns:a16="http://schemas.microsoft.com/office/drawing/2014/main" id="{9C0F0E2D-A3F6-4A79-84F2-2CBE0426F134}"/>
+                <a16:creationId xmlns:a16="http://schemas.microsoft.com/office/drawing/2014/main" id="{F10659AD-2F65-4B49-89B3-846BED4FE7D0}"/>
               </a:ext>
             </a:extLst>
           </p:cNvPr>
@@ -8763,7 +8857,7 @@
           <p:cNvPr id="20" name="">
             <a:extLst xmlns:a="http://schemas.openxmlformats.org/drawingml/2006/main">
               <a:ext uri="{FF2B5EF4-FFF2-40B4-BE49-F238E27FC236}">
-                <a16:creationId xmlns:a16="http://schemas.microsoft.com/office/drawing/2014/main" id="{1DEF817D-FA06-49C6-B6B0-7D6F8AB2EF1F}"/>
+                <a16:creationId xmlns:a16="http://schemas.microsoft.com/office/drawing/2014/main" id="{8A56BF6E-3919-4C11-B8E1-1AFC7714A9F6}"/>
               </a:ext>
             </a:extLst>
           </p:cNvPr>
@@ -8794,7 +8888,7 @@
           <p:cNvPr id="21" name="">
             <a:extLst xmlns:a="http://schemas.openxmlformats.org/drawingml/2006/main">
               <a:ext uri="{FF2B5EF4-FFF2-40B4-BE49-F238E27FC236}">
-                <a16:creationId xmlns:a16="http://schemas.microsoft.com/office/drawing/2014/main" id="{692E0CA9-F8F0-487F-9FCD-C81CC3C0E500}"/>
+                <a16:creationId xmlns:a16="http://schemas.microsoft.com/office/drawing/2014/main" id="{E679D9B2-A7E9-410D-A39B-2E4A84986187}"/>
               </a:ext>
             </a:extLst>
           </p:cNvPr>
@@ -8825,7 +8919,7 @@
           <p:cNvPr id="22" name="">
             <a:extLst xmlns:a="http://schemas.openxmlformats.org/drawingml/2006/main">
               <a:ext uri="{FF2B5EF4-FFF2-40B4-BE49-F238E27FC236}">
-                <a16:creationId xmlns:a16="http://schemas.microsoft.com/office/drawing/2014/main" id="{C29D6617-C175-4A45-B92D-4685FF4F0620}"/>
+                <a16:creationId xmlns:a16="http://schemas.microsoft.com/office/drawing/2014/main" id="{EB64992A-0A1C-43A2-ADE5-C720981E1C53}"/>
               </a:ext>
             </a:extLst>
           </p:cNvPr>
@@ -8856,7 +8950,7 @@
           <p:cNvPr id="23" name="">
             <a:extLst xmlns:a="http://schemas.openxmlformats.org/drawingml/2006/main">
               <a:ext uri="{FF2B5EF4-FFF2-40B4-BE49-F238E27FC236}">
-                <a16:creationId xmlns:a16="http://schemas.microsoft.com/office/drawing/2014/main" id="{1D7E1508-4CB4-4E66-9B6D-91FB08E0C939}"/>
+                <a16:creationId xmlns:a16="http://schemas.microsoft.com/office/drawing/2014/main" id="{D3763015-4C97-4EBE-874A-A994671D5EC0}"/>
               </a:ext>
             </a:extLst>
           </p:cNvPr>
@@ -8887,7 +8981,7 @@
           <p:cNvPr id="24" name="">
             <a:extLst xmlns:a="http://schemas.openxmlformats.org/drawingml/2006/main">
               <a:ext uri="{FF2B5EF4-FFF2-40B4-BE49-F238E27FC236}">
-                <a16:creationId xmlns:a16="http://schemas.microsoft.com/office/drawing/2014/main" id="{A26AC59C-97B6-4299-806D-4CEF9A6D7486}"/>
+                <a16:creationId xmlns:a16="http://schemas.microsoft.com/office/drawing/2014/main" id="{A324AB94-375D-4E6F-8094-7227646FC948}"/>
               </a:ext>
             </a:extLst>
           </p:cNvPr>
@@ -8918,7 +9012,7 @@
           <p:cNvPr id="25" name="">
             <a:extLst xmlns:a="http://schemas.openxmlformats.org/drawingml/2006/main">
               <a:ext uri="{FF2B5EF4-FFF2-40B4-BE49-F238E27FC236}">
-                <a16:creationId xmlns:a16="http://schemas.microsoft.com/office/drawing/2014/main" id="{1DA988EA-522E-4251-AE6A-7B62B0971BC7}"/>
+                <a16:creationId xmlns:a16="http://schemas.microsoft.com/office/drawing/2014/main" id="{6FEB6C25-666C-4F5F-AED2-3370758C188F}"/>
               </a:ext>
             </a:extLst>
           </p:cNvPr>
@@ -8949,7 +9043,7 @@
           <p:cNvPr id="26" name="">
             <a:extLst xmlns:a="http://schemas.openxmlformats.org/drawingml/2006/main">
               <a:ext uri="{FF2B5EF4-FFF2-40B4-BE49-F238E27FC236}">
-                <a16:creationId xmlns:a16="http://schemas.microsoft.com/office/drawing/2014/main" id="{9691EC9F-A430-40FC-8215-E7AC3841B18D}"/>
+                <a16:creationId xmlns:a16="http://schemas.microsoft.com/office/drawing/2014/main" id="{DA3A2B3A-A085-4587-BEF1-D579EEC0514A}"/>
               </a:ext>
             </a:extLst>
           </p:cNvPr>
@@ -8980,7 +9074,7 @@
           <p:cNvPr id="27" name="">
             <a:extLst xmlns:a="http://schemas.openxmlformats.org/drawingml/2006/main">
               <a:ext uri="{FF2B5EF4-FFF2-40B4-BE49-F238E27FC236}">
-                <a16:creationId xmlns:a16="http://schemas.microsoft.com/office/drawing/2014/main" id="{30BD8186-9231-42C0-A951-397645C28598}"/>
+                <a16:creationId xmlns:a16="http://schemas.microsoft.com/office/drawing/2014/main" id="{290D576D-7E59-4DD2-981E-4FFD79C6439E}"/>
               </a:ext>
             </a:extLst>
           </p:cNvPr>
@@ -9011,7 +9105,7 @@
           <p:cNvPr id="28" name="">
             <a:extLst xmlns:a="http://schemas.openxmlformats.org/drawingml/2006/main">
               <a:ext uri="{FF2B5EF4-FFF2-40B4-BE49-F238E27FC236}">
-                <a16:creationId xmlns:a16="http://schemas.microsoft.com/office/drawing/2014/main" id="{F0215F58-7BC1-4A43-A350-D20EBB1DAC05}"/>
+                <a16:creationId xmlns:a16="http://schemas.microsoft.com/office/drawing/2014/main" id="{3D1C97BC-15AD-43C8-A620-192436E61DAA}"/>
               </a:ext>
             </a:extLst>
           </p:cNvPr>
@@ -9042,7 +9136,7 @@
           <p:cNvPr id="29" name="">
             <a:extLst xmlns:a="http://schemas.openxmlformats.org/drawingml/2006/main">
               <a:ext uri="{FF2B5EF4-FFF2-40B4-BE49-F238E27FC236}">
-                <a16:creationId xmlns:a16="http://schemas.microsoft.com/office/drawing/2014/main" id="{689DF332-7F87-44E3-A2F8-743C3CE4CA9F}"/>
+                <a16:creationId xmlns:a16="http://schemas.microsoft.com/office/drawing/2014/main" id="{095C1632-F126-4AF7-9DBE-7019D39E54BA}"/>
               </a:ext>
             </a:extLst>
           </p:cNvPr>
@@ -9073,7 +9167,7 @@
           <p:cNvPr id="30" name="">
             <a:extLst xmlns:a="http://schemas.openxmlformats.org/drawingml/2006/main">
               <a:ext uri="{FF2B5EF4-FFF2-40B4-BE49-F238E27FC236}">
-                <a16:creationId xmlns:a16="http://schemas.microsoft.com/office/drawing/2014/main" id="{D711B235-B83E-4054-9641-790D776324A7}"/>
+                <a16:creationId xmlns:a16="http://schemas.microsoft.com/office/drawing/2014/main" id="{73310D84-A90B-4B81-9454-D84727508B51}"/>
               </a:ext>
             </a:extLst>
           </p:cNvPr>
@@ -9104,7 +9198,7 @@
           <p:cNvPr id="31" name="">
             <a:extLst xmlns:a="http://schemas.openxmlformats.org/drawingml/2006/main">
               <a:ext uri="{FF2B5EF4-FFF2-40B4-BE49-F238E27FC236}">
-                <a16:creationId xmlns:a16="http://schemas.microsoft.com/office/drawing/2014/main" id="{4905AB18-F834-45BD-952F-65D1FE0D7256}"/>
+                <a16:creationId xmlns:a16="http://schemas.microsoft.com/office/drawing/2014/main" id="{BE7BDEEB-F101-4FED-AF23-A53449ADCD54}"/>
               </a:ext>
             </a:extLst>
           </p:cNvPr>
@@ -9135,7 +9229,7 @@
           <p:cNvPr id="32" name="">
             <a:extLst xmlns:a="http://schemas.openxmlformats.org/drawingml/2006/main">
               <a:ext uri="{FF2B5EF4-FFF2-40B4-BE49-F238E27FC236}">
-                <a16:creationId xmlns:a16="http://schemas.microsoft.com/office/drawing/2014/main" id="{DCFF84D0-C141-46DE-A328-61AE0DCA41F9}"/>
+                <a16:creationId xmlns:a16="http://schemas.microsoft.com/office/drawing/2014/main" id="{6642F80F-9442-41FD-A173-D77C87308536}"/>
               </a:ext>
             </a:extLst>
           </p:cNvPr>
@@ -9166,7 +9260,7 @@
           <p:cNvPr id="33" name="">
             <a:extLst xmlns:a="http://schemas.openxmlformats.org/drawingml/2006/main">
               <a:ext uri="{FF2B5EF4-FFF2-40B4-BE49-F238E27FC236}">
-                <a16:creationId xmlns:a16="http://schemas.microsoft.com/office/drawing/2014/main" id="{EA3D4E51-974D-468D-9D77-AE97175935BD}"/>
+                <a16:creationId xmlns:a16="http://schemas.microsoft.com/office/drawing/2014/main" id="{89A2C0E0-AC63-4209-A3C6-4093ABEA4C85}"/>
               </a:ext>
             </a:extLst>
           </p:cNvPr>
@@ -9197,7 +9291,7 @@
           <p:cNvPr id="34" name="">
             <a:extLst xmlns:a="http://schemas.openxmlformats.org/drawingml/2006/main">
               <a:ext uri="{FF2B5EF4-FFF2-40B4-BE49-F238E27FC236}">
-                <a16:creationId xmlns:a16="http://schemas.microsoft.com/office/drawing/2014/main" id="{08630BC5-3ED3-466B-B91C-0F99FD985DDC}"/>
+                <a16:creationId xmlns:a16="http://schemas.microsoft.com/office/drawing/2014/main" id="{5ACF533F-BCD9-41F4-9EAF-60716EF6E313}"/>
               </a:ext>
             </a:extLst>
           </p:cNvPr>
@@ -9228,7 +9322,7 @@
           <p:cNvPr id="35" name="">
             <a:extLst xmlns:a="http://schemas.openxmlformats.org/drawingml/2006/main">
               <a:ext uri="{FF2B5EF4-FFF2-40B4-BE49-F238E27FC236}">
-                <a16:creationId xmlns:a16="http://schemas.microsoft.com/office/drawing/2014/main" id="{BA9BC4D0-5866-4582-8BF0-3618643CB680}"/>
+                <a16:creationId xmlns:a16="http://schemas.microsoft.com/office/drawing/2014/main" id="{436DC013-44B1-457D-B0BE-03C053AA1B9F}"/>
               </a:ext>
             </a:extLst>
           </p:cNvPr>
@@ -9278,7 +9372,7 @@
           <p:cNvPr id="36" name="">
             <a:extLst xmlns:a="http://schemas.openxmlformats.org/drawingml/2006/main">
               <a:ext uri="{FF2B5EF4-FFF2-40B4-BE49-F238E27FC236}">
-                <a16:creationId xmlns:a16="http://schemas.microsoft.com/office/drawing/2014/main" id="{05BD66E3-787C-4238-8D02-8F32428AD41B}"/>
+                <a16:creationId xmlns:a16="http://schemas.microsoft.com/office/drawing/2014/main" id="{663EA338-8713-420A-A89D-EF050664476D}"/>
               </a:ext>
             </a:extLst>
           </p:cNvPr>
@@ -9328,7 +9422,7 @@
           <p:cNvPr id="37" name="">
             <a:extLst xmlns:a="http://schemas.openxmlformats.org/drawingml/2006/main">
               <a:ext uri="{FF2B5EF4-FFF2-40B4-BE49-F238E27FC236}">
-                <a16:creationId xmlns:a16="http://schemas.microsoft.com/office/drawing/2014/main" id="{93CFDCC7-86E3-4B30-ACDC-CAFFA3CC3BB4}"/>
+                <a16:creationId xmlns:a16="http://schemas.microsoft.com/office/drawing/2014/main" id="{AC633CC3-F2B9-4AF1-8C39-AA61A9C7F253}"/>
               </a:ext>
             </a:extLst>
           </p:cNvPr>
@@ -9378,7 +9472,7 @@
           <p:cNvPr id="38" name="">
             <a:extLst xmlns:a="http://schemas.openxmlformats.org/drawingml/2006/main">
               <a:ext uri="{FF2B5EF4-FFF2-40B4-BE49-F238E27FC236}">
-                <a16:creationId xmlns:a16="http://schemas.microsoft.com/office/drawing/2014/main" id="{31112C69-1E99-4047-B3A3-7BE6ECD52052}"/>
+                <a16:creationId xmlns:a16="http://schemas.microsoft.com/office/drawing/2014/main" id="{15CEBD61-895E-4238-8133-E56D5F7DDAB0}"/>
               </a:ext>
             </a:extLst>
           </p:cNvPr>
@@ -9411,7 +9505,7 @@
           <p:cNvPr id="39" name="">
             <a:extLst xmlns:a="http://schemas.openxmlformats.org/drawingml/2006/main">
               <a:ext uri="{FF2B5EF4-FFF2-40B4-BE49-F238E27FC236}">
-                <a16:creationId xmlns:a16="http://schemas.microsoft.com/office/drawing/2014/main" id="{C6D87425-9171-4D58-9640-34FE6B6BCFBB}"/>
+                <a16:creationId xmlns:a16="http://schemas.microsoft.com/office/drawing/2014/main" id="{EDC375C8-A330-4292-9731-8F2B6E6C9BFF}"/>
               </a:ext>
             </a:extLst>
           </p:cNvPr>
@@ -9444,7 +9538,7 @@
           <p:cNvPr id="40" name="">
             <a:extLst xmlns:a="http://schemas.openxmlformats.org/drawingml/2006/main">
               <a:ext uri="{FF2B5EF4-FFF2-40B4-BE49-F238E27FC236}">
-                <a16:creationId xmlns:a16="http://schemas.microsoft.com/office/drawing/2014/main" id="{27E5B009-50C3-440F-B65B-7BD4E0864E7F}"/>
+                <a16:creationId xmlns:a16="http://schemas.microsoft.com/office/drawing/2014/main" id="{EF8121AF-19AC-41D9-B7E8-03211943F609}"/>
               </a:ext>
             </a:extLst>
           </p:cNvPr>
@@ -9475,7 +9569,7 @@
           <p:cNvPr id="41" name="">
             <a:extLst xmlns:a="http://schemas.openxmlformats.org/drawingml/2006/main">
               <a:ext uri="{FF2B5EF4-FFF2-40B4-BE49-F238E27FC236}">
-                <a16:creationId xmlns:a16="http://schemas.microsoft.com/office/drawing/2014/main" id="{3868628A-DE28-45FE-8227-0691945A5D15}"/>
+                <a16:creationId xmlns:a16="http://schemas.microsoft.com/office/drawing/2014/main" id="{4553F6B0-027E-4808-8AE5-E3297E19002D}"/>
               </a:ext>
             </a:extLst>
           </p:cNvPr>
@@ -9525,7 +9619,7 @@
           <p:cNvPr id="42" name="">
             <a:extLst xmlns:a="http://schemas.openxmlformats.org/drawingml/2006/main">
               <a:ext uri="{FF2B5EF4-FFF2-40B4-BE49-F238E27FC236}">
-                <a16:creationId xmlns:a16="http://schemas.microsoft.com/office/drawing/2014/main" id="{B4B38CEC-0EF9-43AA-A025-3AD4CC9E1A4B}"/>
+                <a16:creationId xmlns:a16="http://schemas.microsoft.com/office/drawing/2014/main" id="{EFD30EC7-A9AB-414A-9904-5B7E8A8660EB}"/>
               </a:ext>
             </a:extLst>
           </p:cNvPr>
@@ -9575,7 +9669,7 @@
           <p:cNvPr id="43" name="">
             <a:extLst xmlns:a="http://schemas.openxmlformats.org/drawingml/2006/main">
               <a:ext uri="{FF2B5EF4-FFF2-40B4-BE49-F238E27FC236}">
-                <a16:creationId xmlns:a16="http://schemas.microsoft.com/office/drawing/2014/main" id="{5B203196-66F5-4F77-A766-C96C576EF228}"/>
+                <a16:creationId xmlns:a16="http://schemas.microsoft.com/office/drawing/2014/main" id="{446646DD-63BB-4301-BF97-C2071AD881A8}"/>
               </a:ext>
             </a:extLst>
           </p:cNvPr>
@@ -9623,7 +9717,7 @@
     </p:spTree>
     <p:extLst>
       <p:ext uri="{BB962C8B-B14F-4D97-AF65-F5344CB8AC3E}">
-        <p14:creationId xmlns:p14="http://schemas.microsoft.com/office/powerpoint/2010/main" val="1667905743"/>
+        <p14:creationId xmlns:p14="http://schemas.microsoft.com/office/powerpoint/2010/main" val="646973946"/>
       </p:ext>
     </p:extLst>
   </p:cSld>
@@ -9654,7 +9748,7 @@
           <p:cNvPr id="28" name="">
             <a:extLst xmlns:a="http://schemas.openxmlformats.org/drawingml/2006/main">
               <a:ext uri="{FF2B5EF4-FFF2-40B4-BE49-F238E27FC236}">
-                <a16:creationId xmlns:a16="http://schemas.microsoft.com/office/drawing/2014/main" id="{6C4FF3EE-4A9B-4141-9BC7-EA68AA774619}"/>
+                <a16:creationId xmlns:a16="http://schemas.microsoft.com/office/drawing/2014/main" id="{3E57AC0C-2115-4728-B653-B2D0181ABD19}"/>
               </a:ext>
             </a:extLst>
           </p:cNvPr>
@@ -9704,7 +9798,7 @@
           <p:cNvPr id="2" name="">
             <a:extLst xmlns:a="http://schemas.openxmlformats.org/drawingml/2006/main">
               <a:ext uri="{FF2B5EF4-FFF2-40B4-BE49-F238E27FC236}">
-                <a16:creationId xmlns:a16="http://schemas.microsoft.com/office/drawing/2014/main" id="{3A4FE4A2-12D6-4C50-ABDA-73CC8F428355}"/>
+                <a16:creationId xmlns:a16="http://schemas.microsoft.com/office/drawing/2014/main" id="{02C50EC9-10A7-4CEA-B720-291968E9F916}"/>
               </a:ext>
             </a:extLst>
           </p:cNvPr>
@@ -9761,7 +9855,7 @@
         </p:xfrm>
         <a:graphic xmlns:a="http://schemas.openxmlformats.org/drawingml/2006/main">
           <a:graphicData uri="http://schemas.openxmlformats.org/drawingml/2006/chart">
-            <c:chart xmlns:r="http://schemas.openxmlformats.org/officeDocument/2006/relationships" xmlns:c="http://schemas.openxmlformats.org/drawingml/2006/chart" r:id="R7f6b2a1029444f31"/>
+            <c:chart xmlns:r="http://schemas.openxmlformats.org/officeDocument/2006/relationships" xmlns:c="http://schemas.openxmlformats.org/drawingml/2006/chart" r:id="R73c2e09a7d074e13"/>
           </a:graphicData>
         </a:graphic>
       </p:graphicFrame>
@@ -9770,7 +9864,7 @@
           <p:cNvPr id="4" name="">
             <a:extLst xmlns:a="http://schemas.openxmlformats.org/drawingml/2006/main">
               <a:ext uri="{FF2B5EF4-FFF2-40B4-BE49-F238E27FC236}">
-                <a16:creationId xmlns:a16="http://schemas.microsoft.com/office/drawing/2014/main" id="{B7CE1CB5-A1D1-46CC-89F5-622C37D6A985}"/>
+                <a16:creationId xmlns:a16="http://schemas.microsoft.com/office/drawing/2014/main" id="{B5AA1409-B664-451C-8D47-8280FD5F9925}"/>
               </a:ext>
             </a:extLst>
           </p:cNvPr>
@@ -9820,7 +9914,7 @@
           <p:cNvPr id="5" name="">
             <a:extLst xmlns:a="http://schemas.openxmlformats.org/drawingml/2006/main">
               <a:ext uri="{FF2B5EF4-FFF2-40B4-BE49-F238E27FC236}">
-                <a16:creationId xmlns:a16="http://schemas.microsoft.com/office/drawing/2014/main" id="{5227D7AE-DB11-4227-AD17-E76A1551C493}"/>
+                <a16:creationId xmlns:a16="http://schemas.microsoft.com/office/drawing/2014/main" id="{45BB01E6-6CBA-4104-9086-1AB271B4A45E}"/>
               </a:ext>
             </a:extLst>
           </p:cNvPr>
@@ -9870,7 +9964,7 @@
           <p:cNvPr id="6" name="">
             <a:extLst xmlns:a="http://schemas.openxmlformats.org/drawingml/2006/main">
               <a:ext uri="{FF2B5EF4-FFF2-40B4-BE49-F238E27FC236}">
-                <a16:creationId xmlns:a16="http://schemas.microsoft.com/office/drawing/2014/main" id="{75C2EE17-7A7C-43BA-A120-5A356A0C5E54}"/>
+                <a16:creationId xmlns:a16="http://schemas.microsoft.com/office/drawing/2014/main" id="{8AFE3945-701C-406F-99F0-AE22BF8684E3}"/>
               </a:ext>
             </a:extLst>
           </p:cNvPr>
@@ -9920,7 +10014,7 @@
           <p:cNvPr id="7" name="">
             <a:extLst xmlns:a="http://schemas.openxmlformats.org/drawingml/2006/main">
               <a:ext uri="{FF2B5EF4-FFF2-40B4-BE49-F238E27FC236}">
-                <a16:creationId xmlns:a16="http://schemas.microsoft.com/office/drawing/2014/main" id="{27F115C1-F85F-43B2-B9D3-7AA9A7703464}"/>
+                <a16:creationId xmlns:a16="http://schemas.microsoft.com/office/drawing/2014/main" id="{5F24600A-4694-4A43-BEAA-A20901E3F04D}"/>
               </a:ext>
             </a:extLst>
           </p:cNvPr>
@@ -9959,7 +10053,7 @@
           <p:cNvPr id="8" name="">
             <a:extLst xmlns:a="http://schemas.openxmlformats.org/drawingml/2006/main">
               <a:ext uri="{FF2B5EF4-FFF2-40B4-BE49-F238E27FC236}">
-                <a16:creationId xmlns:a16="http://schemas.microsoft.com/office/drawing/2014/main" id="{DDAADCE6-D200-4288-8DBC-9C3DA4E48C6C}"/>
+                <a16:creationId xmlns:a16="http://schemas.microsoft.com/office/drawing/2014/main" id="{1B8428D0-FA8E-41BA-9538-9E99B8A5A05D}"/>
               </a:ext>
             </a:extLst>
           </p:cNvPr>
@@ -10009,7 +10103,7 @@
           <p:cNvPr id="9" name="">
             <a:extLst xmlns:a="http://schemas.openxmlformats.org/drawingml/2006/main">
               <a:ext uri="{FF2B5EF4-FFF2-40B4-BE49-F238E27FC236}">
-                <a16:creationId xmlns:a16="http://schemas.microsoft.com/office/drawing/2014/main" id="{8F155A31-4A54-429C-90AE-175416B1EE4D}"/>
+                <a16:creationId xmlns:a16="http://schemas.microsoft.com/office/drawing/2014/main" id="{CA86E142-A8A1-44A9-A1A4-15FD476A7553}"/>
               </a:ext>
             </a:extLst>
           </p:cNvPr>
@@ -10059,7 +10153,7 @@
           <p:cNvPr id="10" name="">
             <a:extLst xmlns:a="http://schemas.openxmlformats.org/drawingml/2006/main">
               <a:ext uri="{FF2B5EF4-FFF2-40B4-BE49-F238E27FC236}">
-                <a16:creationId xmlns:a16="http://schemas.microsoft.com/office/drawing/2014/main" id="{54E2DA9F-641A-42DA-9505-F5A9CAECC1ED}"/>
+                <a16:creationId xmlns:a16="http://schemas.microsoft.com/office/drawing/2014/main" id="{62C23EFA-DC19-4AFA-BD8A-2D5A83B3DED5}"/>
               </a:ext>
             </a:extLst>
           </p:cNvPr>
@@ -10109,7 +10203,7 @@
           <p:cNvPr id="11" name="">
             <a:extLst xmlns:a="http://schemas.openxmlformats.org/drawingml/2006/main">
               <a:ext uri="{FF2B5EF4-FFF2-40B4-BE49-F238E27FC236}">
-                <a16:creationId xmlns:a16="http://schemas.microsoft.com/office/drawing/2014/main" id="{B430FD5F-0FCA-476A-A67D-E8180D9D9183}"/>
+                <a16:creationId xmlns:a16="http://schemas.microsoft.com/office/drawing/2014/main" id="{967D6935-9AAD-4B93-A9C9-082DEE9E43FF}"/>
               </a:ext>
             </a:extLst>
           </p:cNvPr>
@@ -10159,7 +10253,7 @@
           <p:cNvPr id="12" name="">
             <a:extLst xmlns:a="http://schemas.openxmlformats.org/drawingml/2006/main">
               <a:ext uri="{FF2B5EF4-FFF2-40B4-BE49-F238E27FC236}">
-                <a16:creationId xmlns:a16="http://schemas.microsoft.com/office/drawing/2014/main" id="{8CA42407-61E4-4203-B0E1-FFE28D457B99}"/>
+                <a16:creationId xmlns:a16="http://schemas.microsoft.com/office/drawing/2014/main" id="{FB712B05-6C80-46F4-AA12-D5555E033D72}"/>
               </a:ext>
             </a:extLst>
           </p:cNvPr>
@@ -10209,7 +10303,7 @@
           <p:cNvPr id="13" name="">
             <a:extLst xmlns:a="http://schemas.openxmlformats.org/drawingml/2006/main">
               <a:ext uri="{FF2B5EF4-FFF2-40B4-BE49-F238E27FC236}">
-                <a16:creationId xmlns:a16="http://schemas.microsoft.com/office/drawing/2014/main" id="{D23B3915-4FB3-4FDB-AE70-FFB07E5CAA70}"/>
+                <a16:creationId xmlns:a16="http://schemas.microsoft.com/office/drawing/2014/main" id="{A5326EBC-5713-40F7-A8B7-036A23B9F5D1}"/>
               </a:ext>
             </a:extLst>
           </p:cNvPr>
@@ -10259,7 +10353,7 @@
           <p:cNvPr id="14" name="">
             <a:extLst xmlns:a="http://schemas.openxmlformats.org/drawingml/2006/main">
               <a:ext uri="{FF2B5EF4-FFF2-40B4-BE49-F238E27FC236}">
-                <a16:creationId xmlns:a16="http://schemas.microsoft.com/office/drawing/2014/main" id="{CAA0EDD8-909D-4542-8FFC-D891C67712E5}"/>
+                <a16:creationId xmlns:a16="http://schemas.microsoft.com/office/drawing/2014/main" id="{2E1CF418-9921-479E-B209-69E4AE35FBD6}"/>
               </a:ext>
             </a:extLst>
           </p:cNvPr>
@@ -10309,7 +10403,7 @@
           <p:cNvPr id="15" name="">
             <a:extLst xmlns:a="http://schemas.openxmlformats.org/drawingml/2006/main">
               <a:ext uri="{FF2B5EF4-FFF2-40B4-BE49-F238E27FC236}">
-                <a16:creationId xmlns:a16="http://schemas.microsoft.com/office/drawing/2014/main" id="{2C64DF0A-3655-4E29-8C09-EE3AA595B7D2}"/>
+                <a16:creationId xmlns:a16="http://schemas.microsoft.com/office/drawing/2014/main" id="{B3A523CC-6191-4BE6-B5C6-7B1347B9B6F4}"/>
               </a:ext>
             </a:extLst>
           </p:cNvPr>
@@ -10359,7 +10453,7 @@
           <p:cNvPr id="16" name="">
             <a:extLst xmlns:a="http://schemas.openxmlformats.org/drawingml/2006/main">
               <a:ext uri="{FF2B5EF4-FFF2-40B4-BE49-F238E27FC236}">
-                <a16:creationId xmlns:a16="http://schemas.microsoft.com/office/drawing/2014/main" id="{252B1891-0C4A-4FD8-9195-7730CF243E2A}"/>
+                <a16:creationId xmlns:a16="http://schemas.microsoft.com/office/drawing/2014/main" id="{7FEA71C7-D096-4572-9FD9-3E7C765108A6}"/>
               </a:ext>
             </a:extLst>
           </p:cNvPr>
@@ -10390,7 +10484,7 @@
           <p:cNvPr id="17" name="">
             <a:extLst xmlns:a="http://schemas.openxmlformats.org/drawingml/2006/main">
               <a:ext uri="{FF2B5EF4-FFF2-40B4-BE49-F238E27FC236}">
-                <a16:creationId xmlns:a16="http://schemas.microsoft.com/office/drawing/2014/main" id="{97E32058-C83E-4E8C-8A1E-69C3B0F2FDBC}"/>
+                <a16:creationId xmlns:a16="http://schemas.microsoft.com/office/drawing/2014/main" id="{00535BCD-7DF4-4675-99FE-75C187EFBC5E}"/>
               </a:ext>
             </a:extLst>
           </p:cNvPr>
@@ -10440,7 +10534,7 @@
           <p:cNvPr id="18" name="">
             <a:extLst xmlns:a="http://schemas.openxmlformats.org/drawingml/2006/main">
               <a:ext uri="{FF2B5EF4-FFF2-40B4-BE49-F238E27FC236}">
-                <a16:creationId xmlns:a16="http://schemas.microsoft.com/office/drawing/2014/main" id="{1991E830-B8DF-4C98-A51F-01B7D0D5F08F}"/>
+                <a16:creationId xmlns:a16="http://schemas.microsoft.com/office/drawing/2014/main" id="{73172F3D-A1D5-4336-B5E0-2AF1D42022E6}"/>
               </a:ext>
             </a:extLst>
           </p:cNvPr>
@@ -10490,7 +10584,7 @@
           <p:cNvPr id="19" name="">
             <a:extLst xmlns:a="http://schemas.openxmlformats.org/drawingml/2006/main">
               <a:ext uri="{FF2B5EF4-FFF2-40B4-BE49-F238E27FC236}">
-                <a16:creationId xmlns:a16="http://schemas.microsoft.com/office/drawing/2014/main" id="{A317DB3F-0EA4-45E0-9DBD-A6C52ADAB496}"/>
+                <a16:creationId xmlns:a16="http://schemas.microsoft.com/office/drawing/2014/main" id="{2B1001A5-E667-4595-85FD-BEE8DB2985D1}"/>
               </a:ext>
             </a:extLst>
           </p:cNvPr>
@@ -10540,7 +10634,7 @@
           <p:cNvPr id="20" name="">
             <a:extLst xmlns:a="http://schemas.openxmlformats.org/drawingml/2006/main">
               <a:ext uri="{FF2B5EF4-FFF2-40B4-BE49-F238E27FC236}">
-                <a16:creationId xmlns:a16="http://schemas.microsoft.com/office/drawing/2014/main" id="{F7069486-1E32-471A-AA49-829C299FE1C5}"/>
+                <a16:creationId xmlns:a16="http://schemas.microsoft.com/office/drawing/2014/main" id="{B65EED74-8E9D-4ED3-8782-56ACAE32D97A}"/>
               </a:ext>
             </a:extLst>
           </p:cNvPr>
@@ -10590,7 +10684,7 @@
           <p:cNvPr id="21" name="">
             <a:extLst xmlns:a="http://schemas.openxmlformats.org/drawingml/2006/main">
               <a:ext uri="{FF2B5EF4-FFF2-40B4-BE49-F238E27FC236}">
-                <a16:creationId xmlns:a16="http://schemas.microsoft.com/office/drawing/2014/main" id="{4BD41692-C6B5-4486-AB24-01AE968F2A15}"/>
+                <a16:creationId xmlns:a16="http://schemas.microsoft.com/office/drawing/2014/main" id="{82D5079B-69C2-4FCD-8ACC-1360C35113D2}"/>
               </a:ext>
             </a:extLst>
           </p:cNvPr>
@@ -10640,7 +10734,7 @@
           <p:cNvPr id="22" name="">
             <a:extLst xmlns:a="http://schemas.openxmlformats.org/drawingml/2006/main">
               <a:ext uri="{FF2B5EF4-FFF2-40B4-BE49-F238E27FC236}">
-                <a16:creationId xmlns:a16="http://schemas.microsoft.com/office/drawing/2014/main" id="{08C21F02-DFBA-48D1-BE1F-20AF48416FF3}"/>
+                <a16:creationId xmlns:a16="http://schemas.microsoft.com/office/drawing/2014/main" id="{A3776426-2DA5-41A0-994B-079248DE09B3}"/>
               </a:ext>
             </a:extLst>
           </p:cNvPr>
@@ -10690,7 +10784,7 @@
           <p:cNvPr id="23" name="">
             <a:extLst xmlns:a="http://schemas.openxmlformats.org/drawingml/2006/main">
               <a:ext uri="{FF2B5EF4-FFF2-40B4-BE49-F238E27FC236}">
-                <a16:creationId xmlns:a16="http://schemas.microsoft.com/office/drawing/2014/main" id="{534EED3B-B22C-4FEF-A35C-6277B206567E}"/>
+                <a16:creationId xmlns:a16="http://schemas.microsoft.com/office/drawing/2014/main" id="{4117E49B-6BEC-44F1-A6B9-A547CBBDBA9A}"/>
               </a:ext>
             </a:extLst>
           </p:cNvPr>
@@ -10740,7 +10834,7 @@
           <p:cNvPr id="24" name="">
             <a:extLst xmlns:a="http://schemas.openxmlformats.org/drawingml/2006/main">
               <a:ext uri="{FF2B5EF4-FFF2-40B4-BE49-F238E27FC236}">
-                <a16:creationId xmlns:a16="http://schemas.microsoft.com/office/drawing/2014/main" id="{AF72D6C7-FC21-4E68-A1C9-918E74AFB34F}"/>
+                <a16:creationId xmlns:a16="http://schemas.microsoft.com/office/drawing/2014/main" id="{60B6376B-80A7-4A78-BB98-9A55697652E8}"/>
               </a:ext>
             </a:extLst>
           </p:cNvPr>
@@ -10790,7 +10884,7 @@
           <p:cNvPr id="25" name="">
             <a:extLst xmlns:a="http://schemas.openxmlformats.org/drawingml/2006/main">
               <a:ext uri="{FF2B5EF4-FFF2-40B4-BE49-F238E27FC236}">
-                <a16:creationId xmlns:a16="http://schemas.microsoft.com/office/drawing/2014/main" id="{3436CF08-B68F-4CD4-BB2D-2EFF7E1E2B4D}"/>
+                <a16:creationId xmlns:a16="http://schemas.microsoft.com/office/drawing/2014/main" id="{E9E4C233-7CCC-4D0F-8E98-3DBD07679E17}"/>
               </a:ext>
             </a:extLst>
           </p:cNvPr>
@@ -10840,7 +10934,7 @@
           <p:cNvPr id="26" name="">
             <a:extLst xmlns:a="http://schemas.openxmlformats.org/drawingml/2006/main">
               <a:ext uri="{FF2B5EF4-FFF2-40B4-BE49-F238E27FC236}">
-                <a16:creationId xmlns:a16="http://schemas.microsoft.com/office/drawing/2014/main" id="{AA66D2C2-48A0-490B-8218-D31DB9B6108B}"/>
+                <a16:creationId xmlns:a16="http://schemas.microsoft.com/office/drawing/2014/main" id="{F3C7EABC-B939-491E-8F1E-4A49EAA6F396}"/>
               </a:ext>
             </a:extLst>
           </p:cNvPr>
@@ -10890,7 +10984,7 @@
           <p:cNvPr id="27" name="">
             <a:extLst xmlns:a="http://schemas.openxmlformats.org/drawingml/2006/main">
               <a:ext uri="{FF2B5EF4-FFF2-40B4-BE49-F238E27FC236}">
-                <a16:creationId xmlns:a16="http://schemas.microsoft.com/office/drawing/2014/main" id="{4B9B1B7E-E346-408D-8E6A-600C9EE60D11}"/>
+                <a16:creationId xmlns:a16="http://schemas.microsoft.com/office/drawing/2014/main" id="{99AC39A7-D7D7-472C-8033-ECC2ECC6BA9A}"/>
               </a:ext>
             </a:extLst>
           </p:cNvPr>
@@ -10938,7 +11032,7 @@
     </p:spTree>
     <p:extLst>
       <p:ext uri="{BB962C8B-B14F-4D97-AF65-F5344CB8AC3E}">
-        <p14:creationId xmlns:p14="http://schemas.microsoft.com/office/powerpoint/2010/main" val="2126630293"/>
+        <p14:creationId xmlns:p14="http://schemas.microsoft.com/office/powerpoint/2010/main" val="1913178099"/>
       </p:ext>
     </p:extLst>
   </p:cSld>
@@ -10969,7 +11063,7 @@
           <p:cNvPr id="23" name="">
             <a:extLst xmlns:a="http://schemas.openxmlformats.org/drawingml/2006/main">
               <a:ext uri="{FF2B5EF4-FFF2-40B4-BE49-F238E27FC236}">
-                <a16:creationId xmlns:a16="http://schemas.microsoft.com/office/drawing/2014/main" id="{CE457593-A105-496C-8424-E4E34F5DD7F3}"/>
+                <a16:creationId xmlns:a16="http://schemas.microsoft.com/office/drawing/2014/main" id="{00BF0C20-1760-406F-B653-9E516E7AF566}"/>
               </a:ext>
             </a:extLst>
           </p:cNvPr>
@@ -11019,7 +11113,7 @@
           <p:cNvPr id="2" name="">
             <a:extLst xmlns:a="http://schemas.openxmlformats.org/drawingml/2006/main">
               <a:ext uri="{FF2B5EF4-FFF2-40B4-BE49-F238E27FC236}">
-                <a16:creationId xmlns:a16="http://schemas.microsoft.com/office/drawing/2014/main" id="{7C233DD7-F43A-45F6-8525-61A87EB73D52}"/>
+                <a16:creationId xmlns:a16="http://schemas.microsoft.com/office/drawing/2014/main" id="{733066A6-38AA-4F24-9254-1BB1317181B3}"/>
               </a:ext>
             </a:extLst>
           </p:cNvPr>
@@ -11069,7 +11163,7 @@
           <p:cNvPr id="3" name="">
             <a:extLst xmlns:a="http://schemas.openxmlformats.org/drawingml/2006/main">
               <a:ext uri="{FF2B5EF4-FFF2-40B4-BE49-F238E27FC236}">
-                <a16:creationId xmlns:a16="http://schemas.microsoft.com/office/drawing/2014/main" id="{6EBFCDC7-2FF6-4C19-B4FC-AA4F18E6DA46}"/>
+                <a16:creationId xmlns:a16="http://schemas.microsoft.com/office/drawing/2014/main" id="{E90A3392-FA7A-4F0E-924C-5E827E8886D5}"/>
               </a:ext>
             </a:extLst>
           </p:cNvPr>
@@ -11114,7 +11208,7 @@
           <p:nvPr/>
         </p:nvPicPr>
         <p:blipFill>
-          <a:blip xmlns:r="http://schemas.openxmlformats.org/officeDocument/2006/relationships" xmlns:a="http://schemas.openxmlformats.org/drawingml/2006/main" r:embed="Ree82b2f397624c71"/>
+          <a:blip xmlns:r="http://schemas.openxmlformats.org/officeDocument/2006/relationships" xmlns:a="http://schemas.openxmlformats.org/drawingml/2006/main" r:embed="R08708c6f2b1c42ef"/>
           <a:srcRect xmlns:a="http://schemas.openxmlformats.org/drawingml/2006/main" l="0" t="194" r="0" b="194"/>
           <a:stretch xmlns:a="http://schemas.openxmlformats.org/drawingml/2006/main">
             <a:fillRect l="0" t="0" r="0" b="0"/>
@@ -11137,7 +11231,7 @@
           <p:cNvPr id="5" name="">
             <a:extLst xmlns:a="http://schemas.openxmlformats.org/drawingml/2006/main">
               <a:ext uri="{FF2B5EF4-FFF2-40B4-BE49-F238E27FC236}">
-                <a16:creationId xmlns:a16="http://schemas.microsoft.com/office/drawing/2014/main" id="{2AC52991-282A-40FF-9FAD-BB8F05FE4741}"/>
+                <a16:creationId xmlns:a16="http://schemas.microsoft.com/office/drawing/2014/main" id="{73F7C3DE-91A9-4719-9D32-0CE03FC8EEE0}"/>
               </a:ext>
             </a:extLst>
           </p:cNvPr>
@@ -11168,7 +11262,7 @@
           <p:cNvPr id="6" name="">
             <a:extLst xmlns:a="http://schemas.openxmlformats.org/drawingml/2006/main">
               <a:ext uri="{FF2B5EF4-FFF2-40B4-BE49-F238E27FC236}">
-                <a16:creationId xmlns:a16="http://schemas.microsoft.com/office/drawing/2014/main" id="{3B1A8014-41CF-4EE6-B5AD-3C9EA2C8AE79}"/>
+                <a16:creationId xmlns:a16="http://schemas.microsoft.com/office/drawing/2014/main" id="{D7E180E2-55B3-4060-BB91-7FDD75AD0A58}"/>
               </a:ext>
             </a:extLst>
           </p:cNvPr>
@@ -11218,7 +11312,7 @@
           <p:cNvPr id="7" name="">
             <a:extLst xmlns:a="http://schemas.openxmlformats.org/drawingml/2006/main">
               <a:ext uri="{FF2B5EF4-FFF2-40B4-BE49-F238E27FC236}">
-                <a16:creationId xmlns:a16="http://schemas.microsoft.com/office/drawing/2014/main" id="{1AE3E26E-BE4D-4FAF-A218-7392D56073A2}"/>
+                <a16:creationId xmlns:a16="http://schemas.microsoft.com/office/drawing/2014/main" id="{58EF9E55-9584-4C1E-9E71-92225BC1AA34}"/>
               </a:ext>
             </a:extLst>
           </p:cNvPr>
@@ -11268,7 +11362,7 @@
           <p:cNvPr id="8" name="">
             <a:extLst xmlns:a="http://schemas.openxmlformats.org/drawingml/2006/main">
               <a:ext uri="{FF2B5EF4-FFF2-40B4-BE49-F238E27FC236}">
-                <a16:creationId xmlns:a16="http://schemas.microsoft.com/office/drawing/2014/main" id="{4E0FA74C-33D9-4C7E-AB16-EA0E19906E30}"/>
+                <a16:creationId xmlns:a16="http://schemas.microsoft.com/office/drawing/2014/main" id="{5C4939C7-B219-4D3B-B71D-7804F3B2C2EE}"/>
               </a:ext>
             </a:extLst>
           </p:cNvPr>
@@ -11318,7 +11412,7 @@
           <p:cNvPr id="9" name="">
             <a:extLst xmlns:a="http://schemas.openxmlformats.org/drawingml/2006/main">
               <a:ext uri="{FF2B5EF4-FFF2-40B4-BE49-F238E27FC236}">
-                <a16:creationId xmlns:a16="http://schemas.microsoft.com/office/drawing/2014/main" id="{CF6E7FCD-5AC1-45EC-8058-6FFD710947F6}"/>
+                <a16:creationId xmlns:a16="http://schemas.microsoft.com/office/drawing/2014/main" id="{C4C9CB9D-2EC8-4B3A-A87B-63856585BB9E}"/>
               </a:ext>
             </a:extLst>
           </p:cNvPr>
@@ -11349,7 +11443,7 @@
           <p:cNvPr id="10" name="">
             <a:extLst xmlns:a="http://schemas.openxmlformats.org/drawingml/2006/main">
               <a:ext uri="{FF2B5EF4-FFF2-40B4-BE49-F238E27FC236}">
-                <a16:creationId xmlns:a16="http://schemas.microsoft.com/office/drawing/2014/main" id="{4C2A3913-7D4B-456B-8952-8137938C40EC}"/>
+                <a16:creationId xmlns:a16="http://schemas.microsoft.com/office/drawing/2014/main" id="{2B1360A0-E2AE-40DF-8D73-B8EC979529E6}"/>
               </a:ext>
             </a:extLst>
           </p:cNvPr>
@@ -11380,7 +11474,7 @@
           <p:cNvPr id="11" name="">
             <a:extLst xmlns:a="http://schemas.openxmlformats.org/drawingml/2006/main">
               <a:ext uri="{FF2B5EF4-FFF2-40B4-BE49-F238E27FC236}">
-                <a16:creationId xmlns:a16="http://schemas.microsoft.com/office/drawing/2014/main" id="{4AC57921-3FD7-4B94-A959-40FFCE2B09CD}"/>
+                <a16:creationId xmlns:a16="http://schemas.microsoft.com/office/drawing/2014/main" id="{9194A713-99C7-452B-AABC-70744F8E3664}"/>
               </a:ext>
             </a:extLst>
           </p:cNvPr>
@@ -11430,7 +11524,7 @@
           <p:cNvPr id="12" name="">
             <a:extLst xmlns:a="http://schemas.openxmlformats.org/drawingml/2006/main">
               <a:ext uri="{FF2B5EF4-FFF2-40B4-BE49-F238E27FC236}">
-                <a16:creationId xmlns:a16="http://schemas.microsoft.com/office/drawing/2014/main" id="{D9C562C8-8AA5-4479-936C-6B370CAC67BF}"/>
+                <a16:creationId xmlns:a16="http://schemas.microsoft.com/office/drawing/2014/main" id="{F5141980-B0FD-4345-818A-E686257C5916}"/>
               </a:ext>
             </a:extLst>
           </p:cNvPr>
@@ -11480,7 +11574,7 @@
           <p:cNvPr id="13" name="">
             <a:extLst xmlns:a="http://schemas.openxmlformats.org/drawingml/2006/main">
               <a:ext uri="{FF2B5EF4-FFF2-40B4-BE49-F238E27FC236}">
-                <a16:creationId xmlns:a16="http://schemas.microsoft.com/office/drawing/2014/main" id="{0F8A40DC-026E-4005-B05A-D0316E185B5D}"/>
+                <a16:creationId xmlns:a16="http://schemas.microsoft.com/office/drawing/2014/main" id="{23D1C83A-F150-491A-9213-8793A832F73C}"/>
               </a:ext>
             </a:extLst>
           </p:cNvPr>
@@ -11530,7 +11624,7 @@
           <p:cNvPr id="14" name="">
             <a:extLst xmlns:a="http://schemas.openxmlformats.org/drawingml/2006/main">
               <a:ext uri="{FF2B5EF4-FFF2-40B4-BE49-F238E27FC236}">
-                <a16:creationId xmlns:a16="http://schemas.microsoft.com/office/drawing/2014/main" id="{F057C529-73D3-4153-A800-D0B366BDAA19}"/>
+                <a16:creationId xmlns:a16="http://schemas.microsoft.com/office/drawing/2014/main" id="{0EA68D7A-EADF-4933-BCB7-F05E62F30E0F}"/>
               </a:ext>
             </a:extLst>
           </p:cNvPr>
@@ -11561,7 +11655,7 @@
           <p:cNvPr id="15" name="">
             <a:extLst xmlns:a="http://schemas.openxmlformats.org/drawingml/2006/main">
               <a:ext uri="{FF2B5EF4-FFF2-40B4-BE49-F238E27FC236}">
-                <a16:creationId xmlns:a16="http://schemas.microsoft.com/office/drawing/2014/main" id="{36FF0917-339E-4398-9F41-CD7B11E86527}"/>
+                <a16:creationId xmlns:a16="http://schemas.microsoft.com/office/drawing/2014/main" id="{DB5A7B00-37EC-425C-A8DF-F11C7E89C2DA}"/>
               </a:ext>
             </a:extLst>
           </p:cNvPr>
@@ -11592,7 +11686,7 @@
           <p:cNvPr id="16" name="">
             <a:extLst xmlns:a="http://schemas.openxmlformats.org/drawingml/2006/main">
               <a:ext uri="{FF2B5EF4-FFF2-40B4-BE49-F238E27FC236}">
-                <a16:creationId xmlns:a16="http://schemas.microsoft.com/office/drawing/2014/main" id="{216FABBC-4904-408A-BE8F-015F563D557E}"/>
+                <a16:creationId xmlns:a16="http://schemas.microsoft.com/office/drawing/2014/main" id="{C9B4996B-3DD6-400D-83AE-5857049E7793}"/>
               </a:ext>
             </a:extLst>
           </p:cNvPr>
@@ -11642,7 +11736,7 @@
           <p:cNvPr id="17" name="">
             <a:extLst xmlns:a="http://schemas.openxmlformats.org/drawingml/2006/main">
               <a:ext uri="{FF2B5EF4-FFF2-40B4-BE49-F238E27FC236}">
-                <a16:creationId xmlns:a16="http://schemas.microsoft.com/office/drawing/2014/main" id="{031F8856-8982-4618-A470-7AFEA7DEB750}"/>
+                <a16:creationId xmlns:a16="http://schemas.microsoft.com/office/drawing/2014/main" id="{0AB662CC-3DAB-478E-853F-9415662DFC10}"/>
               </a:ext>
             </a:extLst>
           </p:cNvPr>
@@ -11692,7 +11786,7 @@
           <p:cNvPr id="18" name="">
             <a:extLst xmlns:a="http://schemas.openxmlformats.org/drawingml/2006/main">
               <a:ext uri="{FF2B5EF4-FFF2-40B4-BE49-F238E27FC236}">
-                <a16:creationId xmlns:a16="http://schemas.microsoft.com/office/drawing/2014/main" id="{3EBC16F0-2460-4F1D-8A8C-83C8F0EA3AA9}"/>
+                <a16:creationId xmlns:a16="http://schemas.microsoft.com/office/drawing/2014/main" id="{16E1B5FC-9AEB-4F4B-BA55-859DD34EE830}"/>
               </a:ext>
             </a:extLst>
           </p:cNvPr>
@@ -11742,7 +11836,7 @@
           <p:cNvPr id="19" name="">
             <a:extLst xmlns:a="http://schemas.openxmlformats.org/drawingml/2006/main">
               <a:ext uri="{FF2B5EF4-FFF2-40B4-BE49-F238E27FC236}">
-                <a16:creationId xmlns:a16="http://schemas.microsoft.com/office/drawing/2014/main" id="{B8BB7FA8-130B-4983-A85F-ED1EAD43BD2F}"/>
+                <a16:creationId xmlns:a16="http://schemas.microsoft.com/office/drawing/2014/main" id="{13DABE61-AC62-491A-B9CA-B58DC21752C1}"/>
               </a:ext>
             </a:extLst>
           </p:cNvPr>
@@ -11773,7 +11867,7 @@
           <p:cNvPr id="20" name="">
             <a:extLst xmlns:a="http://schemas.openxmlformats.org/drawingml/2006/main">
               <a:ext uri="{FF2B5EF4-FFF2-40B4-BE49-F238E27FC236}">
-                <a16:creationId xmlns:a16="http://schemas.microsoft.com/office/drawing/2014/main" id="{A2EC1877-BAFC-4803-9C8E-C13C58502232}"/>
+                <a16:creationId xmlns:a16="http://schemas.microsoft.com/office/drawing/2014/main" id="{A0719A5D-A35A-436D-B7F3-7514E1A6707C}"/>
               </a:ext>
             </a:extLst>
           </p:cNvPr>
@@ -11823,7 +11917,7 @@
           <p:cNvPr id="21" name="">
             <a:extLst xmlns:a="http://schemas.openxmlformats.org/drawingml/2006/main">
               <a:ext uri="{FF2B5EF4-FFF2-40B4-BE49-F238E27FC236}">
-                <a16:creationId xmlns:a16="http://schemas.microsoft.com/office/drawing/2014/main" id="{08675861-668C-4683-B46E-C99DBE904256}"/>
+                <a16:creationId xmlns:a16="http://schemas.microsoft.com/office/drawing/2014/main" id="{DF2015ED-B692-45F5-95EE-838865CA8B97}"/>
               </a:ext>
             </a:extLst>
           </p:cNvPr>
@@ -11873,7 +11967,7 @@
           <p:cNvPr id="22" name="">
             <a:extLst xmlns:a="http://schemas.openxmlformats.org/drawingml/2006/main">
               <a:ext uri="{FF2B5EF4-FFF2-40B4-BE49-F238E27FC236}">
-                <a16:creationId xmlns:a16="http://schemas.microsoft.com/office/drawing/2014/main" id="{914A79A1-EB7A-45C0-A352-24E5367FCE50}"/>
+                <a16:creationId xmlns:a16="http://schemas.microsoft.com/office/drawing/2014/main" id="{7577D4EF-47F2-4686-A734-F5C039E7AC57}"/>
               </a:ext>
             </a:extLst>
           </p:cNvPr>
@@ -11921,7 +12015,7 @@
     </p:spTree>
     <p:extLst>
       <p:ext uri="{BB962C8B-B14F-4D97-AF65-F5344CB8AC3E}">
-        <p14:creationId xmlns:p14="http://schemas.microsoft.com/office/powerpoint/2010/main" val="1918432341"/>
+        <p14:creationId xmlns:p14="http://schemas.microsoft.com/office/powerpoint/2010/main" val="1490278679"/>
       </p:ext>
     </p:extLst>
   </p:cSld>
@@ -11952,7 +12046,7 @@
           <p:cNvPr id="25" name="">
             <a:extLst xmlns:a="http://schemas.openxmlformats.org/drawingml/2006/main">
               <a:ext uri="{FF2B5EF4-FFF2-40B4-BE49-F238E27FC236}">
-                <a16:creationId xmlns:a16="http://schemas.microsoft.com/office/drawing/2014/main" id="{33B4E912-35D3-4E38-92C2-E600F6B6E80D}"/>
+                <a16:creationId xmlns:a16="http://schemas.microsoft.com/office/drawing/2014/main" id="{E265F002-124E-4604-BBA8-6DB177F645EF}"/>
               </a:ext>
             </a:extLst>
           </p:cNvPr>
@@ -12002,7 +12096,7 @@
           <p:cNvPr id="2" name="">
             <a:extLst xmlns:a="http://schemas.openxmlformats.org/drawingml/2006/main">
               <a:ext uri="{FF2B5EF4-FFF2-40B4-BE49-F238E27FC236}">
-                <a16:creationId xmlns:a16="http://schemas.microsoft.com/office/drawing/2014/main" id="{C3472ADE-BBC9-4960-BD60-B1AA7D150BF8}"/>
+                <a16:creationId xmlns:a16="http://schemas.microsoft.com/office/drawing/2014/main" id="{106A853B-998B-43A8-A0A2-19589AC9373A}"/>
               </a:ext>
             </a:extLst>
           </p:cNvPr>
@@ -12052,7 +12146,7 @@
           <p:cNvPr id="3" name="">
             <a:extLst xmlns:a="http://schemas.openxmlformats.org/drawingml/2006/main">
               <a:ext uri="{FF2B5EF4-FFF2-40B4-BE49-F238E27FC236}">
-                <a16:creationId xmlns:a16="http://schemas.microsoft.com/office/drawing/2014/main" id="{183109FB-18C1-4B65-8482-55AE016505ED}"/>
+                <a16:creationId xmlns:a16="http://schemas.microsoft.com/office/drawing/2014/main" id="{5B9CC42A-9623-4C0A-B01D-5B17399C221E}"/>
               </a:ext>
             </a:extLst>
           </p:cNvPr>
@@ -12097,7 +12191,7 @@
           <p:nvPr/>
         </p:nvPicPr>
         <p:blipFill>
-          <a:blip xmlns:r="http://schemas.openxmlformats.org/officeDocument/2006/relationships" xmlns:a="http://schemas.openxmlformats.org/drawingml/2006/main" r:embed="R4c17f49c35064948"/>
+          <a:blip xmlns:r="http://schemas.openxmlformats.org/officeDocument/2006/relationships" xmlns:a="http://schemas.openxmlformats.org/drawingml/2006/main" r:embed="Rce22e13f4cf64c9a"/>
           <a:stretch xmlns:a="http://schemas.openxmlformats.org/drawingml/2006/main"/>
         </p:blipFill>
         <p:spPr>
@@ -12117,7 +12211,7 @@
           <p:cNvPr id="5" name="">
             <a:extLst xmlns:a="http://schemas.openxmlformats.org/drawingml/2006/main">
               <a:ext uri="{FF2B5EF4-FFF2-40B4-BE49-F238E27FC236}">
-                <a16:creationId xmlns:a16="http://schemas.microsoft.com/office/drawing/2014/main" id="{594482E1-FA24-4311-8F2C-D23093754C35}"/>
+                <a16:creationId xmlns:a16="http://schemas.microsoft.com/office/drawing/2014/main" id="{AA7DC0E0-797F-43D5-9B7E-A054A159F083}"/>
               </a:ext>
             </a:extLst>
           </p:cNvPr>
@@ -12150,7 +12244,7 @@
           <p:cNvPr id="6" name="">
             <a:extLst xmlns:a="http://schemas.openxmlformats.org/drawingml/2006/main">
               <a:ext uri="{FF2B5EF4-FFF2-40B4-BE49-F238E27FC236}">
-                <a16:creationId xmlns:a16="http://schemas.microsoft.com/office/drawing/2014/main" id="{D56F50A9-5E37-4158-9D3C-CAF2D69528AD}"/>
+                <a16:creationId xmlns:a16="http://schemas.microsoft.com/office/drawing/2014/main" id="{FC2039D7-276B-4D2A-9361-7C6671A97266}"/>
               </a:ext>
             </a:extLst>
           </p:cNvPr>
@@ -12200,7 +12294,7 @@
           <p:cNvPr id="7" name="">
             <a:extLst xmlns:a="http://schemas.openxmlformats.org/drawingml/2006/main">
               <a:ext uri="{FF2B5EF4-FFF2-40B4-BE49-F238E27FC236}">
-                <a16:creationId xmlns:a16="http://schemas.microsoft.com/office/drawing/2014/main" id="{CF6D19EA-2465-4270-8680-3371CB563D47}"/>
+                <a16:creationId xmlns:a16="http://schemas.microsoft.com/office/drawing/2014/main" id="{FE9EF117-CEE0-49FB-80E9-9351AE24026F}"/>
               </a:ext>
             </a:extLst>
           </p:cNvPr>
@@ -12250,7 +12344,7 @@
           <p:cNvPr id="8" name="">
             <a:extLst xmlns:a="http://schemas.openxmlformats.org/drawingml/2006/main">
               <a:ext uri="{FF2B5EF4-FFF2-40B4-BE49-F238E27FC236}">
-                <a16:creationId xmlns:a16="http://schemas.microsoft.com/office/drawing/2014/main" id="{9F688306-D5C4-48FA-B8B4-9F5540EBB220}"/>
+                <a16:creationId xmlns:a16="http://schemas.microsoft.com/office/drawing/2014/main" id="{8D386FCC-687C-470D-9514-33BD7E5D6622}"/>
               </a:ext>
             </a:extLst>
           </p:cNvPr>
@@ -12283,7 +12377,7 @@
           <p:cNvPr id="9" name="">
             <a:extLst xmlns:a="http://schemas.openxmlformats.org/drawingml/2006/main">
               <a:ext uri="{FF2B5EF4-FFF2-40B4-BE49-F238E27FC236}">
-                <a16:creationId xmlns:a16="http://schemas.microsoft.com/office/drawing/2014/main" id="{09DD5C13-DD1D-4627-B3CB-40E8C81FDB40}"/>
+                <a16:creationId xmlns:a16="http://schemas.microsoft.com/office/drawing/2014/main" id="{F67A0A26-30FB-4C8F-963E-457D460DF15B}"/>
               </a:ext>
             </a:extLst>
           </p:cNvPr>
@@ -12333,7 +12427,7 @@
           <p:cNvPr id="10" name="">
             <a:extLst xmlns:a="http://schemas.openxmlformats.org/drawingml/2006/main">
               <a:ext uri="{FF2B5EF4-FFF2-40B4-BE49-F238E27FC236}">
-                <a16:creationId xmlns:a16="http://schemas.microsoft.com/office/drawing/2014/main" id="{6C104EB4-DB09-42A4-A844-6FEF78557842}"/>
+                <a16:creationId xmlns:a16="http://schemas.microsoft.com/office/drawing/2014/main" id="{EA09A097-D5F1-49BA-AE51-0EEA4BDDE06A}"/>
               </a:ext>
             </a:extLst>
           </p:cNvPr>
@@ -12383,7 +12477,7 @@
           <p:cNvPr id="11" name="">
             <a:extLst xmlns:a="http://schemas.openxmlformats.org/drawingml/2006/main">
               <a:ext uri="{FF2B5EF4-FFF2-40B4-BE49-F238E27FC236}">
-                <a16:creationId xmlns:a16="http://schemas.microsoft.com/office/drawing/2014/main" id="{2D4FBF41-9848-44E7-87FE-60C6B2BEDDC8}"/>
+                <a16:creationId xmlns:a16="http://schemas.microsoft.com/office/drawing/2014/main" id="{60A5ED91-05FC-419C-B40C-52E78C479DE8}"/>
               </a:ext>
             </a:extLst>
           </p:cNvPr>
@@ -12416,7 +12510,7 @@
           <p:cNvPr id="12" name="">
             <a:extLst xmlns:a="http://schemas.openxmlformats.org/drawingml/2006/main">
               <a:ext uri="{FF2B5EF4-FFF2-40B4-BE49-F238E27FC236}">
-                <a16:creationId xmlns:a16="http://schemas.microsoft.com/office/drawing/2014/main" id="{3B9448A3-4C1C-4CCE-B549-6B0645E9F465}"/>
+                <a16:creationId xmlns:a16="http://schemas.microsoft.com/office/drawing/2014/main" id="{4A00E631-06B5-4590-BB8D-964F1F800AAD}"/>
               </a:ext>
             </a:extLst>
           </p:cNvPr>
@@ -12466,7 +12560,7 @@
           <p:cNvPr id="13" name="">
             <a:extLst xmlns:a="http://schemas.openxmlformats.org/drawingml/2006/main">
               <a:ext uri="{FF2B5EF4-FFF2-40B4-BE49-F238E27FC236}">
-                <a16:creationId xmlns:a16="http://schemas.microsoft.com/office/drawing/2014/main" id="{3DB7BF10-E89F-45D1-AA14-9B84264ABA48}"/>
+                <a16:creationId xmlns:a16="http://schemas.microsoft.com/office/drawing/2014/main" id="{A1177FA8-368E-4D1D-B9EF-D6E0725CCC6E}"/>
               </a:ext>
             </a:extLst>
           </p:cNvPr>
@@ -12516,7 +12610,7 @@
           <p:cNvPr id="14" name="">
             <a:extLst xmlns:a="http://schemas.openxmlformats.org/drawingml/2006/main">
               <a:ext uri="{FF2B5EF4-FFF2-40B4-BE49-F238E27FC236}">
-                <a16:creationId xmlns:a16="http://schemas.microsoft.com/office/drawing/2014/main" id="{079E6C8F-4C5D-43A4-B932-8B773021E747}"/>
+                <a16:creationId xmlns:a16="http://schemas.microsoft.com/office/drawing/2014/main" id="{498C0C7D-59EB-4D5D-AC9E-6D7E720DD74E}"/>
               </a:ext>
             </a:extLst>
           </p:cNvPr>
@@ -12549,7 +12643,7 @@
           <p:cNvPr id="15" name="">
             <a:extLst xmlns:a="http://schemas.openxmlformats.org/drawingml/2006/main">
               <a:ext uri="{FF2B5EF4-FFF2-40B4-BE49-F238E27FC236}">
-                <a16:creationId xmlns:a16="http://schemas.microsoft.com/office/drawing/2014/main" id="{F64613DE-AA80-4981-BF2C-B1AF6C087234}"/>
+                <a16:creationId xmlns:a16="http://schemas.microsoft.com/office/drawing/2014/main" id="{0091F4EC-38B4-46F3-AFD8-CF9BAB713660}"/>
               </a:ext>
             </a:extLst>
           </p:cNvPr>
@@ -12599,7 +12693,7 @@
           <p:cNvPr id="16" name="">
             <a:extLst xmlns:a="http://schemas.openxmlformats.org/drawingml/2006/main">
               <a:ext uri="{FF2B5EF4-FFF2-40B4-BE49-F238E27FC236}">
-                <a16:creationId xmlns:a16="http://schemas.microsoft.com/office/drawing/2014/main" id="{2263BB7B-2AB8-4B51-B91F-FFFF42FBCD83}"/>
+                <a16:creationId xmlns:a16="http://schemas.microsoft.com/office/drawing/2014/main" id="{01CE5DEF-9FFE-4E38-AC4C-CB023657203A}"/>
               </a:ext>
             </a:extLst>
           </p:cNvPr>
@@ -12649,7 +12743,7 @@
           <p:cNvPr id="17" name="">
             <a:extLst xmlns:a="http://schemas.openxmlformats.org/drawingml/2006/main">
               <a:ext uri="{FF2B5EF4-FFF2-40B4-BE49-F238E27FC236}">
-                <a16:creationId xmlns:a16="http://schemas.microsoft.com/office/drawing/2014/main" id="{95CAA465-425B-428C-8702-9BFA5C86AE12}"/>
+                <a16:creationId xmlns:a16="http://schemas.microsoft.com/office/drawing/2014/main" id="{03D67368-3D08-4F9D-B333-6D79B725CC61}"/>
               </a:ext>
             </a:extLst>
           </p:cNvPr>
@@ -12680,7 +12774,7 @@
           <p:cNvPr id="18" name="">
             <a:extLst xmlns:a="http://schemas.openxmlformats.org/drawingml/2006/main">
               <a:ext uri="{FF2B5EF4-FFF2-40B4-BE49-F238E27FC236}">
-                <a16:creationId xmlns:a16="http://schemas.microsoft.com/office/drawing/2014/main" id="{905F705D-7DCB-43D4-83AC-AB12F39FDC64}"/>
+                <a16:creationId xmlns:a16="http://schemas.microsoft.com/office/drawing/2014/main" id="{5EA0EF76-3EF8-494D-BBF5-CE32C7622AAA}"/>
               </a:ext>
             </a:extLst>
           </p:cNvPr>
@@ -12730,7 +12824,7 @@
           <p:cNvPr id="19" name="">
             <a:extLst xmlns:a="http://schemas.openxmlformats.org/drawingml/2006/main">
               <a:ext uri="{FF2B5EF4-FFF2-40B4-BE49-F238E27FC236}">
-                <a16:creationId xmlns:a16="http://schemas.microsoft.com/office/drawing/2014/main" id="{AD6AF2F4-554D-43BC-B7D3-BBC0985B816D}"/>
+                <a16:creationId xmlns:a16="http://schemas.microsoft.com/office/drawing/2014/main" id="{3C6FAE63-25F9-47A2-A188-A898D852371A}"/>
               </a:ext>
             </a:extLst>
           </p:cNvPr>
@@ -12780,7 +12874,7 @@
           <p:cNvPr id="20" name="">
             <a:extLst xmlns:a="http://schemas.openxmlformats.org/drawingml/2006/main">
               <a:ext uri="{FF2B5EF4-FFF2-40B4-BE49-F238E27FC236}">
-                <a16:creationId xmlns:a16="http://schemas.microsoft.com/office/drawing/2014/main" id="{C6B0917F-9C2D-487F-B00C-43F095062EBD}"/>
+                <a16:creationId xmlns:a16="http://schemas.microsoft.com/office/drawing/2014/main" id="{54783D7E-7724-422D-8CCD-BE455D6A8613}"/>
               </a:ext>
             </a:extLst>
           </p:cNvPr>
@@ -12830,7 +12924,7 @@
           <p:cNvPr id="21" name="">
             <a:extLst xmlns:a="http://schemas.openxmlformats.org/drawingml/2006/main">
               <a:ext uri="{FF2B5EF4-FFF2-40B4-BE49-F238E27FC236}">
-                <a16:creationId xmlns:a16="http://schemas.microsoft.com/office/drawing/2014/main" id="{7115AB2B-9A5B-4420-8568-F8EFB0A4110E}"/>
+                <a16:creationId xmlns:a16="http://schemas.microsoft.com/office/drawing/2014/main" id="{67685207-E5DB-49CE-80D6-A18D292B3272}"/>
               </a:ext>
             </a:extLst>
           </p:cNvPr>
@@ -12863,7 +12957,7 @@
           <p:cNvPr id="22" name="">
             <a:extLst xmlns:a="http://schemas.openxmlformats.org/drawingml/2006/main">
               <a:ext uri="{FF2B5EF4-FFF2-40B4-BE49-F238E27FC236}">
-                <a16:creationId xmlns:a16="http://schemas.microsoft.com/office/drawing/2014/main" id="{C6B44732-3F1A-4A72-BCA7-7338F0E920F2}"/>
+                <a16:creationId xmlns:a16="http://schemas.microsoft.com/office/drawing/2014/main" id="{4AB40586-C186-41F6-8A85-9975D639C7B9}"/>
               </a:ext>
             </a:extLst>
           </p:cNvPr>
@@ -12913,7 +13007,7 @@
           <p:cNvPr id="23" name="">
             <a:extLst xmlns:a="http://schemas.openxmlformats.org/drawingml/2006/main">
               <a:ext uri="{FF2B5EF4-FFF2-40B4-BE49-F238E27FC236}">
-                <a16:creationId xmlns:a16="http://schemas.microsoft.com/office/drawing/2014/main" id="{7C63CB04-50B3-41FD-AD79-EFF8856DA3E1}"/>
+                <a16:creationId xmlns:a16="http://schemas.microsoft.com/office/drawing/2014/main" id="{E36AED90-5624-481D-9023-887C88723BC1}"/>
               </a:ext>
             </a:extLst>
           </p:cNvPr>
@@ -12963,7 +13057,7 @@
           <p:cNvPr id="24" name="">
             <a:extLst xmlns:a="http://schemas.openxmlformats.org/drawingml/2006/main">
               <a:ext uri="{FF2B5EF4-FFF2-40B4-BE49-F238E27FC236}">
-                <a16:creationId xmlns:a16="http://schemas.microsoft.com/office/drawing/2014/main" id="{2B419C2C-86D4-425C-AB84-94DE27DA37FA}"/>
+                <a16:creationId xmlns:a16="http://schemas.microsoft.com/office/drawing/2014/main" id="{0F67DB4D-475B-4582-B40D-AEB0188FAE0B}"/>
               </a:ext>
             </a:extLst>
           </p:cNvPr>
@@ -13011,7 +13105,7 @@
     </p:spTree>
     <p:extLst>
       <p:ext uri="{BB962C8B-B14F-4D97-AF65-F5344CB8AC3E}">
-        <p14:creationId xmlns:p14="http://schemas.microsoft.com/office/powerpoint/2010/main" val="1443347881"/>
+        <p14:creationId xmlns:p14="http://schemas.microsoft.com/office/powerpoint/2010/main" val="1506473445"/>
       </p:ext>
     </p:extLst>
   </p:cSld>
@@ -13042,7 +13136,7 @@
           <p:cNvPr id="24" name="">
             <a:extLst xmlns:a="http://schemas.openxmlformats.org/drawingml/2006/main">
               <a:ext uri="{FF2B5EF4-FFF2-40B4-BE49-F238E27FC236}">
-                <a16:creationId xmlns:a16="http://schemas.microsoft.com/office/drawing/2014/main" id="{8ECC102A-1E77-415A-A909-C2B74301DEED}"/>
+                <a16:creationId xmlns:a16="http://schemas.microsoft.com/office/drawing/2014/main" id="{6E7476D5-CE79-44A8-9675-1B06C4D8EB78}"/>
               </a:ext>
             </a:extLst>
           </p:cNvPr>
@@ -13092,7 +13186,7 @@
           <p:cNvPr id="2" name="">
             <a:extLst xmlns:a="http://schemas.openxmlformats.org/drawingml/2006/main">
               <a:ext uri="{FF2B5EF4-FFF2-40B4-BE49-F238E27FC236}">
-                <a16:creationId xmlns:a16="http://schemas.microsoft.com/office/drawing/2014/main" id="{D9367EB4-A5E4-45BC-A35B-E1EB2AF2759D}"/>
+                <a16:creationId xmlns:a16="http://schemas.microsoft.com/office/drawing/2014/main" id="{16083BAF-2239-4916-8EBF-07D52FC29C53}"/>
               </a:ext>
             </a:extLst>
           </p:cNvPr>
@@ -13142,7 +13236,7 @@
           <p:cNvPr id="3" name="">
             <a:extLst xmlns:a="http://schemas.openxmlformats.org/drawingml/2006/main">
               <a:ext uri="{FF2B5EF4-FFF2-40B4-BE49-F238E27FC236}">
-                <a16:creationId xmlns:a16="http://schemas.microsoft.com/office/drawing/2014/main" id="{865283A0-4942-44AF-8884-E51CD307EA0A}"/>
+                <a16:creationId xmlns:a16="http://schemas.microsoft.com/office/drawing/2014/main" id="{CC50A078-A936-486A-9766-B232EFDED5BB}"/>
               </a:ext>
             </a:extLst>
           </p:cNvPr>
@@ -13192,7 +13286,7 @@
           <p:cNvPr id="4" name="">
             <a:extLst xmlns:a="http://schemas.openxmlformats.org/drawingml/2006/main">
               <a:ext uri="{FF2B5EF4-FFF2-40B4-BE49-F238E27FC236}">
-                <a16:creationId xmlns:a16="http://schemas.microsoft.com/office/drawing/2014/main" id="{901D78B1-430E-4D78-AE59-F46D446E91CB}"/>
+                <a16:creationId xmlns:a16="http://schemas.microsoft.com/office/drawing/2014/main" id="{148BF828-B19B-4DAA-A57F-BBFAC8A2E492}"/>
               </a:ext>
             </a:extLst>
           </p:cNvPr>
@@ -13237,7 +13331,7 @@
           <p:nvPr/>
         </p:nvPicPr>
         <p:blipFill>
-          <a:blip xmlns:r="http://schemas.openxmlformats.org/officeDocument/2006/relationships" xmlns:a="http://schemas.openxmlformats.org/drawingml/2006/main" r:embed="Rf6b51087ea5d4713"/>
+          <a:blip xmlns:r="http://schemas.openxmlformats.org/officeDocument/2006/relationships" xmlns:a="http://schemas.openxmlformats.org/drawingml/2006/main" r:embed="R836ce34b81a44d94"/>
           <a:stretch xmlns:a="http://schemas.openxmlformats.org/drawingml/2006/main"/>
         </p:blipFill>
         <p:spPr>
@@ -13255,7 +13349,7 @@
           <p:cNvPr id="6" name="">
             <a:extLst xmlns:a="http://schemas.openxmlformats.org/drawingml/2006/main">
               <a:ext uri="{FF2B5EF4-FFF2-40B4-BE49-F238E27FC236}">
-                <a16:creationId xmlns:a16="http://schemas.microsoft.com/office/drawing/2014/main" id="{A4E333BA-1941-4791-AE17-7774DC8423BD}"/>
+                <a16:creationId xmlns:a16="http://schemas.microsoft.com/office/drawing/2014/main" id="{99D5BD28-4FDF-4E6B-A123-9DD482C4997B}"/>
               </a:ext>
             </a:extLst>
           </p:cNvPr>
@@ -13305,7 +13399,7 @@
           <p:cNvPr id="7" name="">
             <a:extLst xmlns:a="http://schemas.openxmlformats.org/drawingml/2006/main">
               <a:ext uri="{FF2B5EF4-FFF2-40B4-BE49-F238E27FC236}">
-                <a16:creationId xmlns:a16="http://schemas.microsoft.com/office/drawing/2014/main" id="{C55B3DA1-31D9-4362-AAD7-2AE5C1A90D87}"/>
+                <a16:creationId xmlns:a16="http://schemas.microsoft.com/office/drawing/2014/main" id="{C3009063-6349-4378-8E80-65105A1AC73F}"/>
               </a:ext>
             </a:extLst>
           </p:cNvPr>
@@ -13355,7 +13449,7 @@
           <p:cNvPr id="8" name="">
             <a:extLst xmlns:a="http://schemas.openxmlformats.org/drawingml/2006/main">
               <a:ext uri="{FF2B5EF4-FFF2-40B4-BE49-F238E27FC236}">
-                <a16:creationId xmlns:a16="http://schemas.microsoft.com/office/drawing/2014/main" id="{E9884AC6-CB6E-40B0-B998-660DBDF4D413}"/>
+                <a16:creationId xmlns:a16="http://schemas.microsoft.com/office/drawing/2014/main" id="{8085CA29-5CC7-4ACC-B657-A99C8F035BFC}"/>
               </a:ext>
             </a:extLst>
           </p:cNvPr>
@@ -13405,7 +13499,7 @@
           <p:cNvPr id="9" name="">
             <a:extLst xmlns:a="http://schemas.openxmlformats.org/drawingml/2006/main">
               <a:ext uri="{FF2B5EF4-FFF2-40B4-BE49-F238E27FC236}">
-                <a16:creationId xmlns:a16="http://schemas.microsoft.com/office/drawing/2014/main" id="{F21A7A8E-3A12-48E2-9825-546D5A9C69AB}"/>
+                <a16:creationId xmlns:a16="http://schemas.microsoft.com/office/drawing/2014/main" id="{8500558B-8B3E-4BAE-BCC7-5A52D7DEFC86}"/>
               </a:ext>
             </a:extLst>
           </p:cNvPr>
@@ -13455,7 +13549,7 @@
           <p:cNvPr id="10" name="">
             <a:extLst xmlns:a="http://schemas.openxmlformats.org/drawingml/2006/main">
               <a:ext uri="{FF2B5EF4-FFF2-40B4-BE49-F238E27FC236}">
-                <a16:creationId xmlns:a16="http://schemas.microsoft.com/office/drawing/2014/main" id="{3BB9F69C-4709-432D-8E9E-535836426D33}"/>
+                <a16:creationId xmlns:a16="http://schemas.microsoft.com/office/drawing/2014/main" id="{550090B0-FDE5-4DD5-8D0F-0C01D214B180}"/>
               </a:ext>
             </a:extLst>
           </p:cNvPr>
@@ -13486,7 +13580,7 @@
           <p:cNvPr id="11" name="">
             <a:extLst xmlns:a="http://schemas.openxmlformats.org/drawingml/2006/main">
               <a:ext uri="{FF2B5EF4-FFF2-40B4-BE49-F238E27FC236}">
-                <a16:creationId xmlns:a16="http://schemas.microsoft.com/office/drawing/2014/main" id="{09C03F40-11B8-4B4B-9F6F-C4D1483112A7}"/>
+                <a16:creationId xmlns:a16="http://schemas.microsoft.com/office/drawing/2014/main" id="{A7F5790B-6513-4A96-9A49-9A0D5B8F438A}"/>
               </a:ext>
             </a:extLst>
           </p:cNvPr>
@@ -13536,7 +13630,7 @@
           <p:cNvPr id="12" name="">
             <a:extLst xmlns:a="http://schemas.openxmlformats.org/drawingml/2006/main">
               <a:ext uri="{FF2B5EF4-FFF2-40B4-BE49-F238E27FC236}">
-                <a16:creationId xmlns:a16="http://schemas.microsoft.com/office/drawing/2014/main" id="{7991EC54-9618-40A0-AB06-A8A35F6D7E51}"/>
+                <a16:creationId xmlns:a16="http://schemas.microsoft.com/office/drawing/2014/main" id="{61C0877D-9117-4FEF-8A01-88EC6CD23F80}"/>
               </a:ext>
             </a:extLst>
           </p:cNvPr>
@@ -13586,7 +13680,7 @@
           <p:cNvPr id="13" name="">
             <a:extLst xmlns:a="http://schemas.openxmlformats.org/drawingml/2006/main">
               <a:ext uri="{FF2B5EF4-FFF2-40B4-BE49-F238E27FC236}">
-                <a16:creationId xmlns:a16="http://schemas.microsoft.com/office/drawing/2014/main" id="{93FA46A9-79BC-4236-9016-217D39AA4406}"/>
+                <a16:creationId xmlns:a16="http://schemas.microsoft.com/office/drawing/2014/main" id="{596D79D7-25BB-460C-86F1-FE31AF1085B9}"/>
               </a:ext>
             </a:extLst>
           </p:cNvPr>
@@ -13636,7 +13730,7 @@
           <p:cNvPr id="14" name="">
             <a:extLst xmlns:a="http://schemas.openxmlformats.org/drawingml/2006/main">
               <a:ext uri="{FF2B5EF4-FFF2-40B4-BE49-F238E27FC236}">
-                <a16:creationId xmlns:a16="http://schemas.microsoft.com/office/drawing/2014/main" id="{73C6FE1A-7306-4CB8-9362-A198175BF130}"/>
+                <a16:creationId xmlns:a16="http://schemas.microsoft.com/office/drawing/2014/main" id="{1CF7DB0E-8355-4500-B12B-6147706D6583}"/>
               </a:ext>
             </a:extLst>
           </p:cNvPr>
@@ -13667,7 +13761,7 @@
           <p:cNvPr id="15" name="">
             <a:extLst xmlns:a="http://schemas.openxmlformats.org/drawingml/2006/main">
               <a:ext uri="{FF2B5EF4-FFF2-40B4-BE49-F238E27FC236}">
-                <a16:creationId xmlns:a16="http://schemas.microsoft.com/office/drawing/2014/main" id="{5769114E-0F4E-444E-9159-6C39BDCC7678}"/>
+                <a16:creationId xmlns:a16="http://schemas.microsoft.com/office/drawing/2014/main" id="{E70DD45F-8125-479B-BDB2-17A570E88045}"/>
               </a:ext>
             </a:extLst>
           </p:cNvPr>
@@ -13717,7 +13811,7 @@
           <p:cNvPr id="16" name="">
             <a:extLst xmlns:a="http://schemas.openxmlformats.org/drawingml/2006/main">
               <a:ext uri="{FF2B5EF4-FFF2-40B4-BE49-F238E27FC236}">
-                <a16:creationId xmlns:a16="http://schemas.microsoft.com/office/drawing/2014/main" id="{4B1718A6-D9D9-438E-9941-E258EDCF4C8C}"/>
+                <a16:creationId xmlns:a16="http://schemas.microsoft.com/office/drawing/2014/main" id="{CEA4134B-8A53-4DF0-8EC4-31291B001480}"/>
               </a:ext>
             </a:extLst>
           </p:cNvPr>
@@ -13767,7 +13861,7 @@
           <p:cNvPr id="17" name="">
             <a:extLst xmlns:a="http://schemas.openxmlformats.org/drawingml/2006/main">
               <a:ext uri="{FF2B5EF4-FFF2-40B4-BE49-F238E27FC236}">
-                <a16:creationId xmlns:a16="http://schemas.microsoft.com/office/drawing/2014/main" id="{43513863-9463-4B41-BA54-2826C472B28B}"/>
+                <a16:creationId xmlns:a16="http://schemas.microsoft.com/office/drawing/2014/main" id="{7861F67A-B1E4-471F-9E02-CE1AEF3E734F}"/>
               </a:ext>
             </a:extLst>
           </p:cNvPr>
@@ -13817,7 +13911,7 @@
           <p:cNvPr id="18" name="">
             <a:extLst xmlns:a="http://schemas.openxmlformats.org/drawingml/2006/main">
               <a:ext uri="{FF2B5EF4-FFF2-40B4-BE49-F238E27FC236}">
-                <a16:creationId xmlns:a16="http://schemas.microsoft.com/office/drawing/2014/main" id="{FF1B4D06-3D6D-4BA3-9CFF-56F467B7A29E}"/>
+                <a16:creationId xmlns:a16="http://schemas.microsoft.com/office/drawing/2014/main" id="{5AD50710-2363-4E87-8056-F8DE4BDB7D1E}"/>
               </a:ext>
             </a:extLst>
           </p:cNvPr>
@@ -13848,7 +13942,7 @@
           <p:cNvPr id="19" name="">
             <a:extLst xmlns:a="http://schemas.openxmlformats.org/drawingml/2006/main">
               <a:ext uri="{FF2B5EF4-FFF2-40B4-BE49-F238E27FC236}">
-                <a16:creationId xmlns:a16="http://schemas.microsoft.com/office/drawing/2014/main" id="{230E67C1-337B-4199-B509-D47CEF948DC0}"/>
+                <a16:creationId xmlns:a16="http://schemas.microsoft.com/office/drawing/2014/main" id="{FA0BC9C8-6B72-4200-ADE2-44373BC9DED2}"/>
               </a:ext>
             </a:extLst>
           </p:cNvPr>
@@ -13898,7 +13992,7 @@
           <p:cNvPr id="20" name="">
             <a:extLst xmlns:a="http://schemas.openxmlformats.org/drawingml/2006/main">
               <a:ext uri="{FF2B5EF4-FFF2-40B4-BE49-F238E27FC236}">
-                <a16:creationId xmlns:a16="http://schemas.microsoft.com/office/drawing/2014/main" id="{B4067B7B-961D-4FD1-9733-8CBB7D8CB44A}"/>
+                <a16:creationId xmlns:a16="http://schemas.microsoft.com/office/drawing/2014/main" id="{A2CEA6C0-5862-46F6-A0FC-BA5E6A93264A}"/>
               </a:ext>
             </a:extLst>
           </p:cNvPr>
@@ -13948,7 +14042,7 @@
           <p:cNvPr id="21" name="">
             <a:extLst xmlns:a="http://schemas.openxmlformats.org/drawingml/2006/main">
               <a:ext uri="{FF2B5EF4-FFF2-40B4-BE49-F238E27FC236}">
-                <a16:creationId xmlns:a16="http://schemas.microsoft.com/office/drawing/2014/main" id="{F04B9FB5-2AE0-4275-9E81-5CB6363EB20A}"/>
+                <a16:creationId xmlns:a16="http://schemas.microsoft.com/office/drawing/2014/main" id="{4C4F28FB-19AD-45C3-8DBB-1AB5D982D1B4}"/>
               </a:ext>
             </a:extLst>
           </p:cNvPr>
@@ -13998,7 +14092,7 @@
           <p:cNvPr id="22" name="">
             <a:extLst xmlns:a="http://schemas.openxmlformats.org/drawingml/2006/main">
               <a:ext uri="{FF2B5EF4-FFF2-40B4-BE49-F238E27FC236}">
-                <a16:creationId xmlns:a16="http://schemas.microsoft.com/office/drawing/2014/main" id="{7493A4FB-2D23-4FD5-9C88-E8310ABFF5C1}"/>
+                <a16:creationId xmlns:a16="http://schemas.microsoft.com/office/drawing/2014/main" id="{8532DF6C-992A-4B63-BF9D-C44EFE4EBB88}"/>
               </a:ext>
             </a:extLst>
           </p:cNvPr>
@@ -14048,7 +14142,7 @@
           <p:cNvPr id="23" name="">
             <a:extLst xmlns:a="http://schemas.openxmlformats.org/drawingml/2006/main">
               <a:ext uri="{FF2B5EF4-FFF2-40B4-BE49-F238E27FC236}">
-                <a16:creationId xmlns:a16="http://schemas.microsoft.com/office/drawing/2014/main" id="{716A3C1A-6E7E-4625-BF9E-D0BDEB8E5075}"/>
+                <a16:creationId xmlns:a16="http://schemas.microsoft.com/office/drawing/2014/main" id="{70CF069D-79A8-496D-AA42-0533195D0C80}"/>
               </a:ext>
             </a:extLst>
           </p:cNvPr>
@@ -14096,7 +14190,7 @@
     </p:spTree>
     <p:extLst>
       <p:ext uri="{BB962C8B-B14F-4D97-AF65-F5344CB8AC3E}">
-        <p14:creationId xmlns:p14="http://schemas.microsoft.com/office/powerpoint/2010/main" val="1204814391"/>
+        <p14:creationId xmlns:p14="http://schemas.microsoft.com/office/powerpoint/2010/main" val="2090264826"/>
       </p:ext>
     </p:extLst>
   </p:cSld>
@@ -14104,9 +14198,9 @@
 </file>
 
 <file path=ppt/theme/theme1.xml><?xml version="1.0" encoding="utf-8"?>
-<a:theme xmlns:a="http://schemas.openxmlformats.org/drawingml/2006/main" name="ChatGPT">
+<a:theme xmlns:a="http://schemas.openxmlformats.org/drawingml/2006/main" name="Finly">
   <a:themeElements>
-    <a:clrScheme name="ChatGPT">
+    <a:clrScheme name="Finly">
       <a:dk1>
         <a:srgbClr val="000000"/>
       </a:dk1>
@@ -14156,7 +14250,7 @@
         <a:cs typeface="Calibri"/>
       </a:minorFont>
     </a:fontScheme>
-    <a:fmtScheme name="ChatGPT">
+    <a:fmtScheme name="Finly">
       <a:fillStyleLst>
         <a:solidFill>
           <a:schemeClr val="phClr"/>

</xml_diff>

<commit_message>
feat: publish verified first-close submission package
</commit_message>
<xml_diff>
--- a/public/judge/Finly_Consulting_Deck.pptx
+++ b/public/judge/Finly_Consulting_Deck.pptx
@@ -2,21 +2,21 @@
 <file path=ppt/presentation.xml><?xml version="1.0" encoding="utf-8"?>
 <p:presentation xmlns:p="http://schemas.openxmlformats.org/presentationml/2006/main">
   <p:sldMasterIdLst>
-    <p:sldMasterId xmlns:r="http://schemas.openxmlformats.org/officeDocument/2006/relationships" id="2147483648" r:id="Ra20923fac73747f5"/>
+    <p:sldMasterId xmlns:r="http://schemas.openxmlformats.org/officeDocument/2006/relationships" id="2147483648" r:id="Rdf22f5498f1a49e0"/>
   </p:sldMasterIdLst>
   <p:notesMasterIdLst>
-    <p:notesMasterId xmlns:r="http://schemas.openxmlformats.org/officeDocument/2006/relationships" r:id="Rd5fd90e74cfb4851"/>
+    <p:notesMasterId xmlns:r="http://schemas.openxmlformats.org/officeDocument/2006/relationships" r:id="R80d7584b0730449c"/>
   </p:notesMasterIdLst>
   <p:sldIdLst>
-    <p:sldId xmlns:r="http://schemas.openxmlformats.org/officeDocument/2006/relationships" id="256" r:id="Ra859c8bc387444aa"/>
-    <p:sldId xmlns:r="http://schemas.openxmlformats.org/officeDocument/2006/relationships" id="257" r:id="R3065e087c43b4367"/>
-    <p:sldId xmlns:r="http://schemas.openxmlformats.org/officeDocument/2006/relationships" id="258" r:id="Rfa38649777ee401c"/>
-    <p:sldId xmlns:r="http://schemas.openxmlformats.org/officeDocument/2006/relationships" id="259" r:id="R104f10e0387844c6"/>
-    <p:sldId xmlns:r="http://schemas.openxmlformats.org/officeDocument/2006/relationships" id="260" r:id="Re376941d3c1e4145"/>
-    <p:sldId xmlns:r="http://schemas.openxmlformats.org/officeDocument/2006/relationships" id="261" r:id="Re12dfaee93d846ba"/>
-    <p:sldId xmlns:r="http://schemas.openxmlformats.org/officeDocument/2006/relationships" id="262" r:id="R90185166963a4e15"/>
-    <p:sldId xmlns:r="http://schemas.openxmlformats.org/officeDocument/2006/relationships" id="263" r:id="R3e5c236902ad4745"/>
-    <p:sldId xmlns:r="http://schemas.openxmlformats.org/officeDocument/2006/relationships" id="264" r:id="R72a0ae7bbbde4482"/>
+    <p:sldId xmlns:r="http://schemas.openxmlformats.org/officeDocument/2006/relationships" id="256" r:id="R7a983326158a4340"/>
+    <p:sldId xmlns:r="http://schemas.openxmlformats.org/officeDocument/2006/relationships" id="257" r:id="Rf6a3338a53c64bdf"/>
+    <p:sldId xmlns:r="http://schemas.openxmlformats.org/officeDocument/2006/relationships" id="258" r:id="R8178ba2c251f4d9b"/>
+    <p:sldId xmlns:r="http://schemas.openxmlformats.org/officeDocument/2006/relationships" id="259" r:id="R66bf61bb9f534575"/>
+    <p:sldId xmlns:r="http://schemas.openxmlformats.org/officeDocument/2006/relationships" id="260" r:id="Rf1c8f45d82114764"/>
+    <p:sldId xmlns:r="http://schemas.openxmlformats.org/officeDocument/2006/relationships" id="261" r:id="R0634b4f885124f56"/>
+    <p:sldId xmlns:r="http://schemas.openxmlformats.org/officeDocument/2006/relationships" id="262" r:id="Rb61f9f751a9c466c"/>
+    <p:sldId xmlns:r="http://schemas.openxmlformats.org/officeDocument/2006/relationships" id="263" r:id="Ra63198fe5fe84375"/>
+    <p:sldId xmlns:r="http://schemas.openxmlformats.org/officeDocument/2006/relationships" id="264" r:id="Rf335c04b34d44d04"/>
   </p:sldIdLst>
   <p:sldSz cx="12192000" cy="6858000"/>
   <p:notesSz cx="6858000" cy="9144000"/>
@@ -166,9 +166,9 @@
 </file>
 
 <file path=ppt/notesMasters/theme/theme3.xml><?xml version="1.0" encoding="utf-8"?>
-<a:theme xmlns:a="http://schemas.openxmlformats.org/drawingml/2006/main" name="Finly">
+<a:theme xmlns:a="http://schemas.openxmlformats.org/drawingml/2006/main" name="ChatGPT">
   <a:themeElements>
-    <a:clrScheme name="Finly">
+    <a:clrScheme name="ChatGPT">
       <a:dk1>
         <a:srgbClr val="000000"/>
       </a:dk1>
@@ -218,7 +218,7 @@
         <a:cs typeface="Calibri"/>
       </a:minorFont>
     </a:fontScheme>
-    <a:fmtScheme name="Finly">
+    <a:fmtScheme name="ChatGPT">
       <a:fillStyleLst>
         <a:solidFill>
           <a:schemeClr val="phClr"/>
@@ -1005,12 +1005,22 @@
           </a:p>
           <a:p xmlns:a="http://schemas.openxmlformats.org/drawingml/2006/main">
             <a:r>
+              <a:t>- First-close measurement: https://owlsowo.github.io/finly-bot/data/competition_forward_profit_2026_08_31.json</a:t>
+            </a:r>
+          </a:p>
+          <a:p xmlns:a="http://schemas.openxmlformats.org/drawingml/2006/main">
+            <a:r>
               <a:t>- Verified starting equity: $100,000; per-trade risk ceiling: $500.</a:t>
             </a:r>
           </a:p>
           <a:p xmlns:a="http://schemas.openxmlformats.org/drawingml/2006/main">
             <a:r>
-              <a:t>- Screenshot is project-owned and records paper-account state.</a:t>
+              <a:t>- Exact first-close result: Finly +$95.32, SPY -$57.99, excess +$153.31.</a:t>
+            </a:r>
+          </a:p>
+          <a:p xmlns:a="http://schemas.openxmlformats.org/drawingml/2006/main">
+            <a:r>
+              <a:t>- Screenshot is project-owned and records the public paper-account dashboard.</a:t>
             </a:r>
           </a:p>
         </p:txBody>
@@ -1268,7 +1278,7 @@
   </p:cSld>
   <p:clrMap bg1="lt1" tx1="dk1" bg2="lt2" tx2="dk2" accent1="accent1" accent2="accent2" accent3="accent3" accent4="accent4" accent5="accent5" accent6="accent6" hlink="hlink" folHlink="folHlink"/>
   <p:sldLayoutIdLst>
-    <p:sldLayoutId xmlns:r="http://schemas.openxmlformats.org/officeDocument/2006/relationships" id="2147483649" r:id="R1d6fbef649444e03"/>
+    <p:sldLayoutId xmlns:r="http://schemas.openxmlformats.org/officeDocument/2006/relationships" id="2147483649" r:id="Re84b81b04a37475f"/>
   </p:sldLayoutIdLst>
   <p:txStyles>
     <p:titleStyle>
@@ -1551,9 +1561,9 @@
 </file>
 
 <file path=ppt/slideMasters/theme/theme2.xml><?xml version="1.0" encoding="utf-8"?>
-<a:theme xmlns:a="http://schemas.openxmlformats.org/drawingml/2006/main" name="Finly">
+<a:theme xmlns:a="http://schemas.openxmlformats.org/drawingml/2006/main" name="ChatGPT">
   <a:themeElements>
-    <a:clrScheme name="Finly">
+    <a:clrScheme name="ChatGPT">
       <a:dk1>
         <a:srgbClr val="000000"/>
       </a:dk1>
@@ -1603,7 +1613,7 @@
         <a:cs typeface="Calibri"/>
       </a:minorFont>
     </a:fontScheme>
-    <a:fmtScheme name="Finly">
+    <a:fmtScheme name="ChatGPT">
       <a:fillStyleLst>
         <a:solidFill>
           <a:schemeClr val="phClr"/>
@@ -3845,6 +3855,7 @@
     <c:plotArea>
       <c:lineChart>
         <c:grouping val="standard"/>
+        <c:varyColors val="0"/>
         <c:ser>
           <c:idx val="0"/>
           <c:order val="0"/>
@@ -3933,7 +3944,9 @@
               </c:pt>
             </c:numLit>
           </c:val>
+          <c:smooth val="0"/>
         </c:ser>
+        <c:smooth val="0"/>
         <c:axId val="48650112"/>
         <c:axId val="48672768"/>
       </c:lineChart>
@@ -4069,10 +4082,10 @@
           <p:nvPr/>
         </p:nvPicPr>
         <p:blipFill>
-          <a:blip xmlns:r="http://schemas.openxmlformats.org/officeDocument/2006/relationships" xmlns:a="http://schemas.openxmlformats.org/drawingml/2006/main" r:embed="R03041ff2cb554ddf">
+          <a:blip xmlns:r="http://schemas.openxmlformats.org/officeDocument/2006/relationships" xmlns:a="http://schemas.openxmlformats.org/drawingml/2006/main" r:embed="R34b39a7e199b481f">
             <a:extLst>
               <a:ext uri="{96DAC541-7B7A-43D3-8B79-37D633B846F1}">
-                <asvg:svgBlip xmlns:asvg="http://schemas.microsoft.com/office/drawing/2016/SVG/main" r:embed="R6151009f58734969"/>
+                <asvg:svgBlip xmlns:asvg="http://schemas.microsoft.com/office/drawing/2016/SVG/main" r:embed="R6cde38365a194891"/>
               </a:ext>
             </a:extLst>
           </a:blip>
@@ -4093,7 +4106,7 @@
           <p:cNvPr id="2" name="">
             <a:extLst xmlns:a="http://schemas.openxmlformats.org/drawingml/2006/main">
               <a:ext uri="{FF2B5EF4-FFF2-40B4-BE49-F238E27FC236}">
-                <a16:creationId xmlns:a16="http://schemas.microsoft.com/office/drawing/2014/main" id="{D8C92A00-A82D-4936-814C-476443017DCB}"/>
+                <a16:creationId xmlns:a16="http://schemas.microsoft.com/office/drawing/2014/main" id="{F5DE9A2B-1A78-4580-93DB-41A0CD6E1032}"/>
               </a:ext>
             </a:extLst>
           </p:cNvPr>
@@ -4143,7 +4156,7 @@
           <p:cNvPr id="3" name="">
             <a:extLst xmlns:a="http://schemas.openxmlformats.org/drawingml/2006/main">
               <a:ext uri="{FF2B5EF4-FFF2-40B4-BE49-F238E27FC236}">
-                <a16:creationId xmlns:a16="http://schemas.microsoft.com/office/drawing/2014/main" id="{F094C821-A297-426A-8C61-53AE228D55D1}"/>
+                <a16:creationId xmlns:a16="http://schemas.microsoft.com/office/drawing/2014/main" id="{0BB80313-4339-4AC6-9A9B-080D30F509B8}"/>
               </a:ext>
             </a:extLst>
           </p:cNvPr>
@@ -4193,7 +4206,7 @@
           <p:cNvPr id="4" name="">
             <a:extLst xmlns:a="http://schemas.openxmlformats.org/drawingml/2006/main">
               <a:ext uri="{FF2B5EF4-FFF2-40B4-BE49-F238E27FC236}">
-                <a16:creationId xmlns:a16="http://schemas.microsoft.com/office/drawing/2014/main" id="{4059BB64-708A-4F9D-B52F-E06F3E062AE2}"/>
+                <a16:creationId xmlns:a16="http://schemas.microsoft.com/office/drawing/2014/main" id="{09E27D70-4F2C-4B81-8AC9-813B7E286E60}"/>
               </a:ext>
             </a:extLst>
           </p:cNvPr>
@@ -4243,7 +4256,7 @@
           <p:cNvPr id="5" name="">
             <a:extLst xmlns:a="http://schemas.openxmlformats.org/drawingml/2006/main">
               <a:ext uri="{FF2B5EF4-FFF2-40B4-BE49-F238E27FC236}">
-                <a16:creationId xmlns:a16="http://schemas.microsoft.com/office/drawing/2014/main" id="{EBE1F904-7649-459B-A4C4-21E31B8A1B6F}"/>
+                <a16:creationId xmlns:a16="http://schemas.microsoft.com/office/drawing/2014/main" id="{CF2B4EB1-BE92-41E8-9662-0CF57EA70337}"/>
               </a:ext>
             </a:extLst>
           </p:cNvPr>
@@ -4293,7 +4306,7 @@
           <p:cNvPr id="6" name="">
             <a:extLst xmlns:a="http://schemas.openxmlformats.org/drawingml/2006/main">
               <a:ext uri="{FF2B5EF4-FFF2-40B4-BE49-F238E27FC236}">
-                <a16:creationId xmlns:a16="http://schemas.microsoft.com/office/drawing/2014/main" id="{BC5D4B2C-E5D5-4AA9-A940-7341E260C9E3}"/>
+                <a16:creationId xmlns:a16="http://schemas.microsoft.com/office/drawing/2014/main" id="{8506BC63-B4EC-47A8-8C4E-1C384BD72515}"/>
               </a:ext>
             </a:extLst>
           </p:cNvPr>
@@ -4328,10 +4341,10 @@
           <p:nvPr/>
         </p:nvPicPr>
         <p:blipFill>
-          <a:blip xmlns:r="http://schemas.openxmlformats.org/officeDocument/2006/relationships" xmlns:a="http://schemas.openxmlformats.org/drawingml/2006/main" r:embed="R23844e3f7d1d40ac">
+          <a:blip xmlns:r="http://schemas.openxmlformats.org/officeDocument/2006/relationships" xmlns:a="http://schemas.openxmlformats.org/drawingml/2006/main" r:embed="R6cc13d61a0a14fe6">
             <a:extLst>
               <a:ext uri="{96DAC541-7B7A-43D3-8B79-37D633B846F1}">
-                <asvg:svgBlip xmlns:asvg="http://schemas.microsoft.com/office/drawing/2016/SVG/main" r:embed="R55e1787ec784416f"/>
+                <asvg:svgBlip xmlns:asvg="http://schemas.microsoft.com/office/drawing/2016/SVG/main" r:embed="R77eb5dac18af476a"/>
               </a:ext>
             </a:extLst>
           </a:blip>
@@ -4352,7 +4365,7 @@
           <p:cNvPr id="8" name="">
             <a:extLst xmlns:a="http://schemas.openxmlformats.org/drawingml/2006/main">
               <a:ext uri="{FF2B5EF4-FFF2-40B4-BE49-F238E27FC236}">
-                <a16:creationId xmlns:a16="http://schemas.microsoft.com/office/drawing/2014/main" id="{F2F3A502-DB22-4687-9E24-33554847AF24}"/>
+                <a16:creationId xmlns:a16="http://schemas.microsoft.com/office/drawing/2014/main" id="{897FE396-5AE3-487F-B382-7CD7C66AE1F7}"/>
               </a:ext>
             </a:extLst>
           </p:cNvPr>
@@ -4402,7 +4415,7 @@
           <p:cNvPr id="9" name="">
             <a:extLst xmlns:a="http://schemas.openxmlformats.org/drawingml/2006/main">
               <a:ext uri="{FF2B5EF4-FFF2-40B4-BE49-F238E27FC236}">
-                <a16:creationId xmlns:a16="http://schemas.microsoft.com/office/drawing/2014/main" id="{64DAA205-F432-49F1-A406-7CB884967A40}"/>
+                <a16:creationId xmlns:a16="http://schemas.microsoft.com/office/drawing/2014/main" id="{259E38F9-7422-4247-8329-DB609070EB66}"/>
               </a:ext>
             </a:extLst>
           </p:cNvPr>
@@ -4452,7 +4465,7 @@
           <p:cNvPr id="10" name="">
             <a:extLst xmlns:a="http://schemas.openxmlformats.org/drawingml/2006/main">
               <a:ext uri="{FF2B5EF4-FFF2-40B4-BE49-F238E27FC236}">
-                <a16:creationId xmlns:a16="http://schemas.microsoft.com/office/drawing/2014/main" id="{F4DAA32D-B1F6-4A6D-A8C3-B5DDCD51184C}"/>
+                <a16:creationId xmlns:a16="http://schemas.microsoft.com/office/drawing/2014/main" id="{886DF06F-2E1B-4878-B1B9-161CA2914AA7}"/>
               </a:ext>
             </a:extLst>
           </p:cNvPr>
@@ -4483,7 +4496,7 @@
           <p:cNvPr id="11" name="">
             <a:extLst xmlns:a="http://schemas.openxmlformats.org/drawingml/2006/main">
               <a:ext uri="{FF2B5EF4-FFF2-40B4-BE49-F238E27FC236}">
-                <a16:creationId xmlns:a16="http://schemas.microsoft.com/office/drawing/2014/main" id="{4C5F75FF-86A7-4349-9587-B396073F4262}"/>
+                <a16:creationId xmlns:a16="http://schemas.microsoft.com/office/drawing/2014/main" id="{40AA1BA5-C0E7-41F2-99C4-6E0E8048EC3B}"/>
               </a:ext>
             </a:extLst>
           </p:cNvPr>
@@ -4533,7 +4546,7 @@
           <p:cNvPr id="12" name="">
             <a:extLst xmlns:a="http://schemas.openxmlformats.org/drawingml/2006/main">
               <a:ext uri="{FF2B5EF4-FFF2-40B4-BE49-F238E27FC236}">
-                <a16:creationId xmlns:a16="http://schemas.microsoft.com/office/drawing/2014/main" id="{121CE3E4-D462-495E-9A43-96EC37E5FA54}"/>
+                <a16:creationId xmlns:a16="http://schemas.microsoft.com/office/drawing/2014/main" id="{7B03D355-EF88-4FA6-A4A2-03F1B844CF85}"/>
               </a:ext>
             </a:extLst>
           </p:cNvPr>
@@ -4583,7 +4596,7 @@
           <p:cNvPr id="13" name="">
             <a:extLst xmlns:a="http://schemas.openxmlformats.org/drawingml/2006/main">
               <a:ext uri="{FF2B5EF4-FFF2-40B4-BE49-F238E27FC236}">
-                <a16:creationId xmlns:a16="http://schemas.microsoft.com/office/drawing/2014/main" id="{837DDC25-4EE9-4EA6-9FEB-4AD71C51BF83}"/>
+                <a16:creationId xmlns:a16="http://schemas.microsoft.com/office/drawing/2014/main" id="{69F5D654-5081-430D-8288-B8D6134F0DBE}"/>
               </a:ext>
             </a:extLst>
           </p:cNvPr>
@@ -4633,7 +4646,7 @@
           <p:cNvPr id="14" name="">
             <a:extLst xmlns:a="http://schemas.openxmlformats.org/drawingml/2006/main">
               <a:ext uri="{FF2B5EF4-FFF2-40B4-BE49-F238E27FC236}">
-                <a16:creationId xmlns:a16="http://schemas.microsoft.com/office/drawing/2014/main" id="{7911862F-9E22-4018-A0C4-6C8AD0E33948}"/>
+                <a16:creationId xmlns:a16="http://schemas.microsoft.com/office/drawing/2014/main" id="{303CBB3A-3B98-42D0-840F-70B520EB3502}"/>
               </a:ext>
             </a:extLst>
           </p:cNvPr>
@@ -4683,7 +4696,7 @@
           <p:cNvPr id="15" name="">
             <a:extLst xmlns:a="http://schemas.openxmlformats.org/drawingml/2006/main">
               <a:ext uri="{FF2B5EF4-FFF2-40B4-BE49-F238E27FC236}">
-                <a16:creationId xmlns:a16="http://schemas.microsoft.com/office/drawing/2014/main" id="{9CDB99CE-7C4E-4E96-ADED-F93FA7176518}"/>
+                <a16:creationId xmlns:a16="http://schemas.microsoft.com/office/drawing/2014/main" id="{AF97D7A9-A025-46BC-9FD9-EAF0507CDC7E}"/>
               </a:ext>
             </a:extLst>
           </p:cNvPr>
@@ -4733,7 +4746,7 @@
           <p:cNvPr id="16" name="">
             <a:extLst xmlns:a="http://schemas.openxmlformats.org/drawingml/2006/main">
               <a:ext uri="{FF2B5EF4-FFF2-40B4-BE49-F238E27FC236}">
-                <a16:creationId xmlns:a16="http://schemas.microsoft.com/office/drawing/2014/main" id="{73A41153-7190-4F8C-B9A5-976111FF3275}"/>
+                <a16:creationId xmlns:a16="http://schemas.microsoft.com/office/drawing/2014/main" id="{49D9DA84-AA5F-4D0C-9F2A-5E08846AF09D}"/>
               </a:ext>
             </a:extLst>
           </p:cNvPr>
@@ -4783,7 +4796,7 @@
           <p:cNvPr id="17" name="">
             <a:extLst xmlns:a="http://schemas.openxmlformats.org/drawingml/2006/main">
               <a:ext uri="{FF2B5EF4-FFF2-40B4-BE49-F238E27FC236}">
-                <a16:creationId xmlns:a16="http://schemas.microsoft.com/office/drawing/2014/main" id="{B91B1421-FE61-412D-B2B7-B85966AA2096}"/>
+                <a16:creationId xmlns:a16="http://schemas.microsoft.com/office/drawing/2014/main" id="{06A8D15C-B8A6-4012-827F-61485E88B0AF}"/>
               </a:ext>
             </a:extLst>
           </p:cNvPr>
@@ -4833,7 +4846,7 @@
           <p:cNvPr id="18" name="">
             <a:extLst xmlns:a="http://schemas.openxmlformats.org/drawingml/2006/main">
               <a:ext uri="{FF2B5EF4-FFF2-40B4-BE49-F238E27FC236}">
-                <a16:creationId xmlns:a16="http://schemas.microsoft.com/office/drawing/2014/main" id="{B352F10D-6281-448E-9795-DCFB3C0D65D3}"/>
+                <a16:creationId xmlns:a16="http://schemas.microsoft.com/office/drawing/2014/main" id="{D82E1B21-CC05-4EB1-A24D-FF5F9E9692C2}"/>
               </a:ext>
             </a:extLst>
           </p:cNvPr>
@@ -4883,7 +4896,7 @@
           <p:cNvPr id="19" name="">
             <a:extLst xmlns:a="http://schemas.openxmlformats.org/drawingml/2006/main">
               <a:ext uri="{FF2B5EF4-FFF2-40B4-BE49-F238E27FC236}">
-                <a16:creationId xmlns:a16="http://schemas.microsoft.com/office/drawing/2014/main" id="{85E7E7C1-9444-406E-82BE-BCB1E281FD24}"/>
+                <a16:creationId xmlns:a16="http://schemas.microsoft.com/office/drawing/2014/main" id="{089D356E-7B5A-45AE-B5D9-90869233D4E7}"/>
               </a:ext>
             </a:extLst>
           </p:cNvPr>
@@ -4933,7 +4946,7 @@
           <p:cNvPr id="20" name="">
             <a:extLst xmlns:a="http://schemas.openxmlformats.org/drawingml/2006/main">
               <a:ext uri="{FF2B5EF4-FFF2-40B4-BE49-F238E27FC236}">
-                <a16:creationId xmlns:a16="http://schemas.microsoft.com/office/drawing/2014/main" id="{186D3AD2-157A-4169-9215-ED84D0AFEB21}"/>
+                <a16:creationId xmlns:a16="http://schemas.microsoft.com/office/drawing/2014/main" id="{DFE3369C-0051-4890-B1E3-3A5A36113409}"/>
               </a:ext>
             </a:extLst>
           </p:cNvPr>
@@ -4983,7 +4996,7 @@
           <p:cNvPr id="21" name="">
             <a:extLst xmlns:a="http://schemas.openxmlformats.org/drawingml/2006/main">
               <a:ext uri="{FF2B5EF4-FFF2-40B4-BE49-F238E27FC236}">
-                <a16:creationId xmlns:a16="http://schemas.microsoft.com/office/drawing/2014/main" id="{B39DB5C3-3492-4E33-B8A3-FF2BC49093F6}"/>
+                <a16:creationId xmlns:a16="http://schemas.microsoft.com/office/drawing/2014/main" id="{235997A9-78E1-4FCC-A31B-0F1B6EFF4A20}"/>
               </a:ext>
             </a:extLst>
           </p:cNvPr>
@@ -5031,7 +5044,7 @@
     </p:spTree>
     <p:extLst>
       <p:ext uri="{BB962C8B-B14F-4D97-AF65-F5344CB8AC3E}">
-        <p14:creationId xmlns:p14="http://schemas.microsoft.com/office/powerpoint/2010/main" val="1589416300"/>
+        <p14:creationId xmlns:p14="http://schemas.microsoft.com/office/powerpoint/2010/main" val="1075597870"/>
       </p:ext>
     </p:extLst>
   </p:cSld>
@@ -5062,7 +5075,7 @@
           <p:cNvPr id="31" name="">
             <a:extLst xmlns:a="http://schemas.openxmlformats.org/drawingml/2006/main">
               <a:ext uri="{FF2B5EF4-FFF2-40B4-BE49-F238E27FC236}">
-                <a16:creationId xmlns:a16="http://schemas.microsoft.com/office/drawing/2014/main" id="{87DD4F5C-475F-4906-BB55-CB184AA41665}"/>
+                <a16:creationId xmlns:a16="http://schemas.microsoft.com/office/drawing/2014/main" id="{3838DD94-4632-46F2-9ED3-3CE2AD0F5ED4}"/>
               </a:ext>
             </a:extLst>
           </p:cNvPr>
@@ -5112,7 +5125,7 @@
           <p:cNvPr id="2" name="">
             <a:extLst xmlns:a="http://schemas.openxmlformats.org/drawingml/2006/main">
               <a:ext uri="{FF2B5EF4-FFF2-40B4-BE49-F238E27FC236}">
-                <a16:creationId xmlns:a16="http://schemas.microsoft.com/office/drawing/2014/main" id="{8B6B6714-B6AA-404A-90FF-0186DBF65FB8}"/>
+                <a16:creationId xmlns:a16="http://schemas.microsoft.com/office/drawing/2014/main" id="{2A40256B-ADDC-4309-9905-F4FCE3149C94}"/>
               </a:ext>
             </a:extLst>
           </p:cNvPr>
@@ -5162,7 +5175,7 @@
           <p:cNvPr id="3" name="">
             <a:extLst xmlns:a="http://schemas.openxmlformats.org/drawingml/2006/main">
               <a:ext uri="{FF2B5EF4-FFF2-40B4-BE49-F238E27FC236}">
-                <a16:creationId xmlns:a16="http://schemas.microsoft.com/office/drawing/2014/main" id="{F2015D3E-C1BD-4C0E-A198-8C2AE6DA40D6}"/>
+                <a16:creationId xmlns:a16="http://schemas.microsoft.com/office/drawing/2014/main" id="{49F765EC-0DF0-4E16-BEB8-761CBF38426B}"/>
               </a:ext>
             </a:extLst>
           </p:cNvPr>
@@ -5212,7 +5225,7 @@
           <p:cNvPr id="4" name="">
             <a:extLst xmlns:a="http://schemas.openxmlformats.org/drawingml/2006/main">
               <a:ext uri="{FF2B5EF4-FFF2-40B4-BE49-F238E27FC236}">
-                <a16:creationId xmlns:a16="http://schemas.microsoft.com/office/drawing/2014/main" id="{4961856B-E6E0-460D-BC14-5EC8448ECCFB}"/>
+                <a16:creationId xmlns:a16="http://schemas.microsoft.com/office/drawing/2014/main" id="{E91F0876-0234-4D81-85F7-A47209FBDB3E}"/>
               </a:ext>
             </a:extLst>
           </p:cNvPr>
@@ -5247,7 +5260,7 @@
           <p:cNvPr id="5" name="">
             <a:extLst xmlns:a="http://schemas.openxmlformats.org/drawingml/2006/main">
               <a:ext uri="{FF2B5EF4-FFF2-40B4-BE49-F238E27FC236}">
-                <a16:creationId xmlns:a16="http://schemas.microsoft.com/office/drawing/2014/main" id="{47F11E6C-E170-4EFB-9F24-C557DAF1FDFA}"/>
+                <a16:creationId xmlns:a16="http://schemas.microsoft.com/office/drawing/2014/main" id="{44E28156-E5D5-4DA6-B91E-6CF7BE7C8ED7}"/>
               </a:ext>
             </a:extLst>
           </p:cNvPr>
@@ -5297,7 +5310,7 @@
           <p:cNvPr id="6" name="">
             <a:extLst xmlns:a="http://schemas.openxmlformats.org/drawingml/2006/main">
               <a:ext uri="{FF2B5EF4-FFF2-40B4-BE49-F238E27FC236}">
-                <a16:creationId xmlns:a16="http://schemas.microsoft.com/office/drawing/2014/main" id="{4E466C0A-AB59-48F8-87D4-190FFEDC0AEE}"/>
+                <a16:creationId xmlns:a16="http://schemas.microsoft.com/office/drawing/2014/main" id="{198F8C36-BFFC-4B12-88E3-CC5B0C712A95}"/>
               </a:ext>
             </a:extLst>
           </p:cNvPr>
@@ -5347,7 +5360,7 @@
           <p:cNvPr id="7" name="">
             <a:extLst xmlns:a="http://schemas.openxmlformats.org/drawingml/2006/main">
               <a:ext uri="{FF2B5EF4-FFF2-40B4-BE49-F238E27FC236}">
-                <a16:creationId xmlns:a16="http://schemas.microsoft.com/office/drawing/2014/main" id="{5755D019-EFEF-4050-BF1A-3352075F215F}"/>
+                <a16:creationId xmlns:a16="http://schemas.microsoft.com/office/drawing/2014/main" id="{58D86257-564A-4E4B-9F45-40349012D973}"/>
               </a:ext>
             </a:extLst>
           </p:cNvPr>
@@ -5397,7 +5410,7 @@
           <p:cNvPr id="8" name="">
             <a:extLst xmlns:a="http://schemas.openxmlformats.org/drawingml/2006/main">
               <a:ext uri="{FF2B5EF4-FFF2-40B4-BE49-F238E27FC236}">
-                <a16:creationId xmlns:a16="http://schemas.microsoft.com/office/drawing/2014/main" id="{8049B0F2-38EC-4B24-8175-B1AE5102D249}"/>
+                <a16:creationId xmlns:a16="http://schemas.microsoft.com/office/drawing/2014/main" id="{3DC54E89-10C4-4C70-A7DD-E1A9BEA4C62D}"/>
               </a:ext>
             </a:extLst>
           </p:cNvPr>
@@ -5432,7 +5445,7 @@
           <p:cNvPr id="9" name="">
             <a:extLst xmlns:a="http://schemas.openxmlformats.org/drawingml/2006/main">
               <a:ext uri="{FF2B5EF4-FFF2-40B4-BE49-F238E27FC236}">
-                <a16:creationId xmlns:a16="http://schemas.microsoft.com/office/drawing/2014/main" id="{FF4E2159-E8D1-4100-BD16-CC3022F132BE}"/>
+                <a16:creationId xmlns:a16="http://schemas.microsoft.com/office/drawing/2014/main" id="{BFB1958E-9A7B-454D-8EBA-974CB3CA2005}"/>
               </a:ext>
             </a:extLst>
           </p:cNvPr>
@@ -5482,7 +5495,7 @@
           <p:cNvPr id="10" name="">
             <a:extLst xmlns:a="http://schemas.openxmlformats.org/drawingml/2006/main">
               <a:ext uri="{FF2B5EF4-FFF2-40B4-BE49-F238E27FC236}">
-                <a16:creationId xmlns:a16="http://schemas.microsoft.com/office/drawing/2014/main" id="{D93D0F06-EA0D-4C3D-8D51-768CE6345889}"/>
+                <a16:creationId xmlns:a16="http://schemas.microsoft.com/office/drawing/2014/main" id="{8AE93A02-2826-4AE6-8E17-B30DB5DC527C}"/>
               </a:ext>
             </a:extLst>
           </p:cNvPr>
@@ -5532,7 +5545,7 @@
           <p:cNvPr id="11" name="">
             <a:extLst xmlns:a="http://schemas.openxmlformats.org/drawingml/2006/main">
               <a:ext uri="{FF2B5EF4-FFF2-40B4-BE49-F238E27FC236}">
-                <a16:creationId xmlns:a16="http://schemas.microsoft.com/office/drawing/2014/main" id="{7A457646-6D8A-4B6C-AA6D-936EAD8B12C3}"/>
+                <a16:creationId xmlns:a16="http://schemas.microsoft.com/office/drawing/2014/main" id="{7A496355-02D0-41C1-BDC6-B68E96A06D5B}"/>
               </a:ext>
             </a:extLst>
           </p:cNvPr>
@@ -5582,7 +5595,7 @@
           <p:cNvPr id="12" name="">
             <a:extLst xmlns:a="http://schemas.openxmlformats.org/drawingml/2006/main">
               <a:ext uri="{FF2B5EF4-FFF2-40B4-BE49-F238E27FC236}">
-                <a16:creationId xmlns:a16="http://schemas.microsoft.com/office/drawing/2014/main" id="{73AA7D48-CD0E-422E-B863-0DB07E4FA5D0}"/>
+                <a16:creationId xmlns:a16="http://schemas.microsoft.com/office/drawing/2014/main" id="{EDDB08FE-6CB9-4EA8-B78D-93CDCE46B881}"/>
               </a:ext>
             </a:extLst>
           </p:cNvPr>
@@ -5617,7 +5630,7 @@
           <p:cNvPr id="13" name="">
             <a:extLst xmlns:a="http://schemas.openxmlformats.org/drawingml/2006/main">
               <a:ext uri="{FF2B5EF4-FFF2-40B4-BE49-F238E27FC236}">
-                <a16:creationId xmlns:a16="http://schemas.microsoft.com/office/drawing/2014/main" id="{17802042-A42A-41E9-BA85-C587CCAFDD32}"/>
+                <a16:creationId xmlns:a16="http://schemas.microsoft.com/office/drawing/2014/main" id="{41CBD046-8DDF-4718-AFEF-CB415B6AEFB2}"/>
               </a:ext>
             </a:extLst>
           </p:cNvPr>
@@ -5667,7 +5680,7 @@
           <p:cNvPr id="14" name="">
             <a:extLst xmlns:a="http://schemas.openxmlformats.org/drawingml/2006/main">
               <a:ext uri="{FF2B5EF4-FFF2-40B4-BE49-F238E27FC236}">
-                <a16:creationId xmlns:a16="http://schemas.microsoft.com/office/drawing/2014/main" id="{7A4F6E68-DE8B-462D-B39F-DAD744374858}"/>
+                <a16:creationId xmlns:a16="http://schemas.microsoft.com/office/drawing/2014/main" id="{C948DEC1-6F67-4B34-B0B6-102DB4AC2C28}"/>
               </a:ext>
             </a:extLst>
           </p:cNvPr>
@@ -5717,7 +5730,7 @@
           <p:cNvPr id="15" name="">
             <a:extLst xmlns:a="http://schemas.openxmlformats.org/drawingml/2006/main">
               <a:ext uri="{FF2B5EF4-FFF2-40B4-BE49-F238E27FC236}">
-                <a16:creationId xmlns:a16="http://schemas.microsoft.com/office/drawing/2014/main" id="{DDFB320C-F023-4070-A052-A8453FD250DD}"/>
+                <a16:creationId xmlns:a16="http://schemas.microsoft.com/office/drawing/2014/main" id="{B2E0686D-C023-4E7D-B748-47E7C55E6C0B}"/>
               </a:ext>
             </a:extLst>
           </p:cNvPr>
@@ -5767,7 +5780,7 @@
           <p:cNvPr id="16" name="">
             <a:extLst xmlns:a="http://schemas.openxmlformats.org/drawingml/2006/main">
               <a:ext uri="{FF2B5EF4-FFF2-40B4-BE49-F238E27FC236}">
-                <a16:creationId xmlns:a16="http://schemas.microsoft.com/office/drawing/2014/main" id="{735BB8C1-91C0-4650-B33C-6D1A2604388A}"/>
+                <a16:creationId xmlns:a16="http://schemas.microsoft.com/office/drawing/2014/main" id="{4FAB96A4-0AED-4C1F-B660-E14A8E958F1F}"/>
               </a:ext>
             </a:extLst>
           </p:cNvPr>
@@ -5802,7 +5815,7 @@
           <p:cNvPr id="17" name="">
             <a:extLst xmlns:a="http://schemas.openxmlformats.org/drawingml/2006/main">
               <a:ext uri="{FF2B5EF4-FFF2-40B4-BE49-F238E27FC236}">
-                <a16:creationId xmlns:a16="http://schemas.microsoft.com/office/drawing/2014/main" id="{A1FF97D0-2088-437A-852B-F59C4DFDE188}"/>
+                <a16:creationId xmlns:a16="http://schemas.microsoft.com/office/drawing/2014/main" id="{53E3D9FB-F92B-401B-8970-C0257CAF96BE}"/>
               </a:ext>
             </a:extLst>
           </p:cNvPr>
@@ -5852,7 +5865,7 @@
           <p:cNvPr id="18" name="">
             <a:extLst xmlns:a="http://schemas.openxmlformats.org/drawingml/2006/main">
               <a:ext uri="{FF2B5EF4-FFF2-40B4-BE49-F238E27FC236}">
-                <a16:creationId xmlns:a16="http://schemas.microsoft.com/office/drawing/2014/main" id="{B848BD36-6AEE-4734-B817-9A2B20875040}"/>
+                <a16:creationId xmlns:a16="http://schemas.microsoft.com/office/drawing/2014/main" id="{52F6798C-86ED-4551-9A30-6B5FB128D80E}"/>
               </a:ext>
             </a:extLst>
           </p:cNvPr>
@@ -5902,7 +5915,7 @@
           <p:cNvPr id="19" name="">
             <a:extLst xmlns:a="http://schemas.openxmlformats.org/drawingml/2006/main">
               <a:ext uri="{FF2B5EF4-FFF2-40B4-BE49-F238E27FC236}">
-                <a16:creationId xmlns:a16="http://schemas.microsoft.com/office/drawing/2014/main" id="{CD5A6ED1-9D3C-4BCB-B8E3-2E088157C30A}"/>
+                <a16:creationId xmlns:a16="http://schemas.microsoft.com/office/drawing/2014/main" id="{5D5A854E-1204-4CC5-9B37-101969952DB0}"/>
               </a:ext>
             </a:extLst>
           </p:cNvPr>
@@ -5952,7 +5965,7 @@
           <p:cNvPr id="20" name="">
             <a:extLst xmlns:a="http://schemas.openxmlformats.org/drawingml/2006/main">
               <a:ext uri="{FF2B5EF4-FFF2-40B4-BE49-F238E27FC236}">
-                <a16:creationId xmlns:a16="http://schemas.microsoft.com/office/drawing/2014/main" id="{5F90B219-0E64-4B65-9828-1EDC285ABF31}"/>
+                <a16:creationId xmlns:a16="http://schemas.microsoft.com/office/drawing/2014/main" id="{E3CE567B-9898-40F8-A058-8977EEC63753}"/>
               </a:ext>
             </a:extLst>
           </p:cNvPr>
@@ -5987,7 +6000,7 @@
           <p:cNvPr id="21" name="">
             <a:extLst xmlns:a="http://schemas.openxmlformats.org/drawingml/2006/main">
               <a:ext uri="{FF2B5EF4-FFF2-40B4-BE49-F238E27FC236}">
-                <a16:creationId xmlns:a16="http://schemas.microsoft.com/office/drawing/2014/main" id="{73EB8CA3-91FF-4788-A5E2-82DDD12BB9C3}"/>
+                <a16:creationId xmlns:a16="http://schemas.microsoft.com/office/drawing/2014/main" id="{A7CCA99A-285F-42B6-8E20-75EFF118DB24}"/>
               </a:ext>
             </a:extLst>
           </p:cNvPr>
@@ -6037,7 +6050,7 @@
           <p:cNvPr id="22" name="">
             <a:extLst xmlns:a="http://schemas.openxmlformats.org/drawingml/2006/main">
               <a:ext uri="{FF2B5EF4-FFF2-40B4-BE49-F238E27FC236}">
-                <a16:creationId xmlns:a16="http://schemas.microsoft.com/office/drawing/2014/main" id="{115A94FA-7D3C-4C2E-A200-863FA7B93735}"/>
+                <a16:creationId xmlns:a16="http://schemas.microsoft.com/office/drawing/2014/main" id="{D9ED1868-7471-4AFB-9CE7-1DD3E27D7E2E}"/>
               </a:ext>
             </a:extLst>
           </p:cNvPr>
@@ -6087,7 +6100,7 @@
           <p:cNvPr id="23" name="">
             <a:extLst xmlns:a="http://schemas.openxmlformats.org/drawingml/2006/main">
               <a:ext uri="{FF2B5EF4-FFF2-40B4-BE49-F238E27FC236}">
-                <a16:creationId xmlns:a16="http://schemas.microsoft.com/office/drawing/2014/main" id="{3C2FC5EF-6290-460D-A830-DAC15DCFD326}"/>
+                <a16:creationId xmlns:a16="http://schemas.microsoft.com/office/drawing/2014/main" id="{073E16FD-2F3D-47DB-ABD4-D796C787B5C7}"/>
               </a:ext>
             </a:extLst>
           </p:cNvPr>
@@ -6137,7 +6150,7 @@
           <p:cNvPr id="24" name="">
             <a:extLst xmlns:a="http://schemas.openxmlformats.org/drawingml/2006/main">
               <a:ext uri="{FF2B5EF4-FFF2-40B4-BE49-F238E27FC236}">
-                <a16:creationId xmlns:a16="http://schemas.microsoft.com/office/drawing/2014/main" id="{4272FC7A-9C1A-4294-8E68-73B54640AC49}"/>
+                <a16:creationId xmlns:a16="http://schemas.microsoft.com/office/drawing/2014/main" id="{87F3C8C9-6D30-4B28-BD7C-B7A94715A387}"/>
               </a:ext>
             </a:extLst>
           </p:cNvPr>
@@ -6170,7 +6183,7 @@
           <p:cNvPr id="25" name="">
             <a:extLst xmlns:a="http://schemas.openxmlformats.org/drawingml/2006/main">
               <a:ext uri="{FF2B5EF4-FFF2-40B4-BE49-F238E27FC236}">
-                <a16:creationId xmlns:a16="http://schemas.microsoft.com/office/drawing/2014/main" id="{1DAF4589-2274-4A9C-ACE0-3DF166BDC11E}"/>
+                <a16:creationId xmlns:a16="http://schemas.microsoft.com/office/drawing/2014/main" id="{BB99853F-3415-4CA4-AC3A-29AD7206728C}"/>
               </a:ext>
             </a:extLst>
           </p:cNvPr>
@@ -6220,7 +6233,7 @@
           <p:cNvPr id="26" name="">
             <a:extLst xmlns:a="http://schemas.openxmlformats.org/drawingml/2006/main">
               <a:ext uri="{FF2B5EF4-FFF2-40B4-BE49-F238E27FC236}">
-                <a16:creationId xmlns:a16="http://schemas.microsoft.com/office/drawing/2014/main" id="{2F10031B-94D8-4CDD-9374-35F20485B47D}"/>
+                <a16:creationId xmlns:a16="http://schemas.microsoft.com/office/drawing/2014/main" id="{440FBDEF-3F75-4A8D-ADEF-26F44DDF93B7}"/>
               </a:ext>
             </a:extLst>
           </p:cNvPr>
@@ -6251,7 +6264,7 @@
           <p:cNvPr id="27" name="">
             <a:extLst xmlns:a="http://schemas.openxmlformats.org/drawingml/2006/main">
               <a:ext uri="{FF2B5EF4-FFF2-40B4-BE49-F238E27FC236}">
-                <a16:creationId xmlns:a16="http://schemas.microsoft.com/office/drawing/2014/main" id="{50AD5A5B-4385-4A02-942D-A1A01BD77B57}"/>
+                <a16:creationId xmlns:a16="http://schemas.microsoft.com/office/drawing/2014/main" id="{9FAA9F7B-0D9C-4E29-89D4-9F0058421CD3}"/>
               </a:ext>
             </a:extLst>
           </p:cNvPr>
@@ -6301,7 +6314,7 @@
           <p:cNvPr id="28" name="">
             <a:extLst xmlns:a="http://schemas.openxmlformats.org/drawingml/2006/main">
               <a:ext uri="{FF2B5EF4-FFF2-40B4-BE49-F238E27FC236}">
-                <a16:creationId xmlns:a16="http://schemas.microsoft.com/office/drawing/2014/main" id="{CE1A981E-7057-42A1-92BA-1DEAF467451C}"/>
+                <a16:creationId xmlns:a16="http://schemas.microsoft.com/office/drawing/2014/main" id="{316C1409-4D53-423B-B4BA-37792C8F04C3}"/>
               </a:ext>
             </a:extLst>
           </p:cNvPr>
@@ -6351,7 +6364,7 @@
           <p:cNvPr id="29" name="">
             <a:extLst xmlns:a="http://schemas.openxmlformats.org/drawingml/2006/main">
               <a:ext uri="{FF2B5EF4-FFF2-40B4-BE49-F238E27FC236}">
-                <a16:creationId xmlns:a16="http://schemas.microsoft.com/office/drawing/2014/main" id="{48DF0614-DC17-4EC6-AB77-9CA0CA904A9C}"/>
+                <a16:creationId xmlns:a16="http://schemas.microsoft.com/office/drawing/2014/main" id="{4C8A8BD2-273C-44F0-BDE5-9E9E218AD3BB}"/>
               </a:ext>
             </a:extLst>
           </p:cNvPr>
@@ -6401,7 +6414,7 @@
           <p:cNvPr id="30" name="">
             <a:extLst xmlns:a="http://schemas.openxmlformats.org/drawingml/2006/main">
               <a:ext uri="{FF2B5EF4-FFF2-40B4-BE49-F238E27FC236}">
-                <a16:creationId xmlns:a16="http://schemas.microsoft.com/office/drawing/2014/main" id="{211F024D-3930-4245-9175-C3FB14BBDB52}"/>
+                <a16:creationId xmlns:a16="http://schemas.microsoft.com/office/drawing/2014/main" id="{E186DC00-A548-4E3F-A694-F5DC7EA37264}"/>
               </a:ext>
             </a:extLst>
           </p:cNvPr>
@@ -6449,7 +6462,7 @@
     </p:spTree>
     <p:extLst>
       <p:ext uri="{BB962C8B-B14F-4D97-AF65-F5344CB8AC3E}">
-        <p14:creationId xmlns:p14="http://schemas.microsoft.com/office/powerpoint/2010/main" val="884742971"/>
+        <p14:creationId xmlns:p14="http://schemas.microsoft.com/office/powerpoint/2010/main" val="420248491"/>
       </p:ext>
     </p:extLst>
   </p:cSld>
@@ -6480,7 +6493,7 @@
           <p:cNvPr id="20" name="">
             <a:extLst xmlns:a="http://schemas.openxmlformats.org/drawingml/2006/main">
               <a:ext uri="{FF2B5EF4-FFF2-40B4-BE49-F238E27FC236}">
-                <a16:creationId xmlns:a16="http://schemas.microsoft.com/office/drawing/2014/main" id="{BC4C72E1-C0A7-4E32-AC0F-ABBB736E7B36}"/>
+                <a16:creationId xmlns:a16="http://schemas.microsoft.com/office/drawing/2014/main" id="{A2A6E40B-26DB-4E8C-BF37-FD74BD1BA79F}"/>
               </a:ext>
             </a:extLst>
           </p:cNvPr>
@@ -6530,7 +6543,7 @@
           <p:cNvPr id="2" name="">
             <a:extLst xmlns:a="http://schemas.openxmlformats.org/drawingml/2006/main">
               <a:ext uri="{FF2B5EF4-FFF2-40B4-BE49-F238E27FC236}">
-                <a16:creationId xmlns:a16="http://schemas.microsoft.com/office/drawing/2014/main" id="{60D135D1-2FF3-4B6E-B69B-5BABF4D51FA0}"/>
+                <a16:creationId xmlns:a16="http://schemas.microsoft.com/office/drawing/2014/main" id="{BBEDFDB3-8D28-434B-9995-C51249EFDB47}"/>
               </a:ext>
             </a:extLst>
           </p:cNvPr>
@@ -6580,7 +6593,7 @@
           <p:cNvPr id="3" name="">
             <a:extLst xmlns:a="http://schemas.openxmlformats.org/drawingml/2006/main">
               <a:ext uri="{FF2B5EF4-FFF2-40B4-BE49-F238E27FC236}">
-                <a16:creationId xmlns:a16="http://schemas.microsoft.com/office/drawing/2014/main" id="{B798A631-A1A4-4BBA-B3E9-348CC6498A9B}"/>
+                <a16:creationId xmlns:a16="http://schemas.microsoft.com/office/drawing/2014/main" id="{58BA74B7-4C13-4E9B-81F4-4E7847B191A8}"/>
               </a:ext>
             </a:extLst>
           </p:cNvPr>
@@ -6625,7 +6638,7 @@
           <p:nvPr/>
         </p:nvPicPr>
         <p:blipFill>
-          <a:blip xmlns:r="http://schemas.openxmlformats.org/officeDocument/2006/relationships" xmlns:a="http://schemas.openxmlformats.org/drawingml/2006/main" r:embed="Rfea882470e714236"/>
+          <a:blip xmlns:r="http://schemas.openxmlformats.org/officeDocument/2006/relationships" xmlns:a="http://schemas.openxmlformats.org/drawingml/2006/main" r:embed="Rb21cde13324c4cb4"/>
           <a:stretch xmlns:a="http://schemas.openxmlformats.org/drawingml/2006/main"/>
         </p:blipFill>
         <p:spPr>
@@ -6645,7 +6658,7 @@
           <p:cNvPr id="5" name="">
             <a:extLst xmlns:a="http://schemas.openxmlformats.org/drawingml/2006/main">
               <a:ext uri="{FF2B5EF4-FFF2-40B4-BE49-F238E27FC236}">
-                <a16:creationId xmlns:a16="http://schemas.microsoft.com/office/drawing/2014/main" id="{AAD5F2DC-6F24-49B3-87AF-B2362A22190A}"/>
+                <a16:creationId xmlns:a16="http://schemas.microsoft.com/office/drawing/2014/main" id="{42F5631E-9EF7-4EBB-9C0F-C95435BBD325}"/>
               </a:ext>
             </a:extLst>
           </p:cNvPr>
@@ -6695,7 +6708,7 @@
           <p:cNvPr id="6" name="">
             <a:extLst xmlns:a="http://schemas.openxmlformats.org/drawingml/2006/main">
               <a:ext uri="{FF2B5EF4-FFF2-40B4-BE49-F238E27FC236}">
-                <a16:creationId xmlns:a16="http://schemas.microsoft.com/office/drawing/2014/main" id="{FEF4F438-F5A7-4FEF-85F7-13986C51D99B}"/>
+                <a16:creationId xmlns:a16="http://schemas.microsoft.com/office/drawing/2014/main" id="{5BA638EA-A95B-4944-A92E-FFD8F210297C}"/>
               </a:ext>
             </a:extLst>
           </p:cNvPr>
@@ -6745,7 +6758,7 @@
           <p:cNvPr id="7" name="">
             <a:extLst xmlns:a="http://schemas.openxmlformats.org/drawingml/2006/main">
               <a:ext uri="{FF2B5EF4-FFF2-40B4-BE49-F238E27FC236}">
-                <a16:creationId xmlns:a16="http://schemas.microsoft.com/office/drawing/2014/main" id="{B2300CE2-47CC-4CB1-BC3E-9AB5379EB2C8}"/>
+                <a16:creationId xmlns:a16="http://schemas.microsoft.com/office/drawing/2014/main" id="{7F9C5B47-5B53-455F-AAB9-EDDE62AFE5CC}"/>
               </a:ext>
             </a:extLst>
           </p:cNvPr>
@@ -6795,7 +6808,7 @@
           <p:cNvPr id="8" name="">
             <a:extLst xmlns:a="http://schemas.openxmlformats.org/drawingml/2006/main">
               <a:ext uri="{FF2B5EF4-FFF2-40B4-BE49-F238E27FC236}">
-                <a16:creationId xmlns:a16="http://schemas.microsoft.com/office/drawing/2014/main" id="{FFFF748D-A784-4126-BCA7-70630391A3E4}"/>
+                <a16:creationId xmlns:a16="http://schemas.microsoft.com/office/drawing/2014/main" id="{FDCFC992-347A-4280-92DF-AC9BF488BE45}"/>
               </a:ext>
             </a:extLst>
           </p:cNvPr>
@@ -6826,7 +6839,7 @@
           <p:cNvPr id="9" name="">
             <a:extLst xmlns:a="http://schemas.openxmlformats.org/drawingml/2006/main">
               <a:ext uri="{FF2B5EF4-FFF2-40B4-BE49-F238E27FC236}">
-                <a16:creationId xmlns:a16="http://schemas.microsoft.com/office/drawing/2014/main" id="{D8C80199-62F8-4C07-B7AB-79C8497669E7}"/>
+                <a16:creationId xmlns:a16="http://schemas.microsoft.com/office/drawing/2014/main" id="{820FFC28-8F72-4027-A523-FF3543875745}"/>
               </a:ext>
             </a:extLst>
           </p:cNvPr>
@@ -6876,7 +6889,7 @@
           <p:cNvPr id="10" name="">
             <a:extLst xmlns:a="http://schemas.openxmlformats.org/drawingml/2006/main">
               <a:ext uri="{FF2B5EF4-FFF2-40B4-BE49-F238E27FC236}">
-                <a16:creationId xmlns:a16="http://schemas.microsoft.com/office/drawing/2014/main" id="{880D7112-D1CD-4B8D-8776-63933615C93F}"/>
+                <a16:creationId xmlns:a16="http://schemas.microsoft.com/office/drawing/2014/main" id="{07856F6B-1F07-4C71-A9B7-FEF4A8E482B2}"/>
               </a:ext>
             </a:extLst>
           </p:cNvPr>
@@ -6926,7 +6939,7 @@
           <p:cNvPr id="11" name="">
             <a:extLst xmlns:a="http://schemas.openxmlformats.org/drawingml/2006/main">
               <a:ext uri="{FF2B5EF4-FFF2-40B4-BE49-F238E27FC236}">
-                <a16:creationId xmlns:a16="http://schemas.microsoft.com/office/drawing/2014/main" id="{7ACD712B-9FC8-4A90-B3C9-9D0A7D709909}"/>
+                <a16:creationId xmlns:a16="http://schemas.microsoft.com/office/drawing/2014/main" id="{9C0000E3-45A9-4C59-ADD0-ECE5A9C59FBF}"/>
               </a:ext>
             </a:extLst>
           </p:cNvPr>
@@ -6976,7 +6989,7 @@
           <p:cNvPr id="12" name="">
             <a:extLst xmlns:a="http://schemas.openxmlformats.org/drawingml/2006/main">
               <a:ext uri="{FF2B5EF4-FFF2-40B4-BE49-F238E27FC236}">
-                <a16:creationId xmlns:a16="http://schemas.microsoft.com/office/drawing/2014/main" id="{ACC4CF9A-114E-4A71-B9D5-72E046185424}"/>
+                <a16:creationId xmlns:a16="http://schemas.microsoft.com/office/drawing/2014/main" id="{8C22029A-7DBD-4DC2-9E1D-91BD426AB3AA}"/>
               </a:ext>
             </a:extLst>
           </p:cNvPr>
@@ -7007,7 +7020,7 @@
           <p:cNvPr id="13" name="">
             <a:extLst xmlns:a="http://schemas.openxmlformats.org/drawingml/2006/main">
               <a:ext uri="{FF2B5EF4-FFF2-40B4-BE49-F238E27FC236}">
-                <a16:creationId xmlns:a16="http://schemas.microsoft.com/office/drawing/2014/main" id="{8D63821A-50C0-4CF6-9FD8-64E8227E1120}"/>
+                <a16:creationId xmlns:a16="http://schemas.microsoft.com/office/drawing/2014/main" id="{FFEE2483-1395-466F-80F7-B98B47343FEB}"/>
               </a:ext>
             </a:extLst>
           </p:cNvPr>
@@ -7057,7 +7070,7 @@
           <p:cNvPr id="14" name="">
             <a:extLst xmlns:a="http://schemas.openxmlformats.org/drawingml/2006/main">
               <a:ext uri="{FF2B5EF4-FFF2-40B4-BE49-F238E27FC236}">
-                <a16:creationId xmlns:a16="http://schemas.microsoft.com/office/drawing/2014/main" id="{99402E5D-2561-49A7-B9A4-C4DAAFAB5877}"/>
+                <a16:creationId xmlns:a16="http://schemas.microsoft.com/office/drawing/2014/main" id="{17E1003E-1E32-4BAB-A984-A54C0BDC6A9A}"/>
               </a:ext>
             </a:extLst>
           </p:cNvPr>
@@ -7107,7 +7120,7 @@
           <p:cNvPr id="15" name="">
             <a:extLst xmlns:a="http://schemas.openxmlformats.org/drawingml/2006/main">
               <a:ext uri="{FF2B5EF4-FFF2-40B4-BE49-F238E27FC236}">
-                <a16:creationId xmlns:a16="http://schemas.microsoft.com/office/drawing/2014/main" id="{4A6BE1D5-9074-4543-8916-27B02E8762D7}"/>
+                <a16:creationId xmlns:a16="http://schemas.microsoft.com/office/drawing/2014/main" id="{0350FF8E-EE87-44D6-9F78-BE9BCB337D95}"/>
               </a:ext>
             </a:extLst>
           </p:cNvPr>
@@ -7157,7 +7170,7 @@
           <p:cNvPr id="16" name="">
             <a:extLst xmlns:a="http://schemas.openxmlformats.org/drawingml/2006/main">
               <a:ext uri="{FF2B5EF4-FFF2-40B4-BE49-F238E27FC236}">
-                <a16:creationId xmlns:a16="http://schemas.microsoft.com/office/drawing/2014/main" id="{F26E9216-1067-4FA1-BAFF-4F23CFBF3412}"/>
+                <a16:creationId xmlns:a16="http://schemas.microsoft.com/office/drawing/2014/main" id="{737C3EA3-BBB0-4F31-B1AE-41AD19E75B69}"/>
               </a:ext>
             </a:extLst>
           </p:cNvPr>
@@ -7188,7 +7201,7 @@
           <p:cNvPr id="17" name="">
             <a:extLst xmlns:a="http://schemas.openxmlformats.org/drawingml/2006/main">
               <a:ext uri="{FF2B5EF4-FFF2-40B4-BE49-F238E27FC236}">
-                <a16:creationId xmlns:a16="http://schemas.microsoft.com/office/drawing/2014/main" id="{E29AD6C3-9001-41EE-9F42-FE9344DFEB6E}"/>
+                <a16:creationId xmlns:a16="http://schemas.microsoft.com/office/drawing/2014/main" id="{D32E4968-EB95-41F9-8EC1-4E22D3D8BB24}"/>
               </a:ext>
             </a:extLst>
           </p:cNvPr>
@@ -7238,7 +7251,7 @@
           <p:cNvPr id="18" name="">
             <a:extLst xmlns:a="http://schemas.openxmlformats.org/drawingml/2006/main">
               <a:ext uri="{FF2B5EF4-FFF2-40B4-BE49-F238E27FC236}">
-                <a16:creationId xmlns:a16="http://schemas.microsoft.com/office/drawing/2014/main" id="{962C5A99-E6F7-4E4C-9962-13C60AFCD39E}"/>
+                <a16:creationId xmlns:a16="http://schemas.microsoft.com/office/drawing/2014/main" id="{BDA015D6-154B-4BA6-82B8-7849ACE96F8B}"/>
               </a:ext>
             </a:extLst>
           </p:cNvPr>
@@ -7288,7 +7301,7 @@
           <p:cNvPr id="19" name="">
             <a:extLst xmlns:a="http://schemas.openxmlformats.org/drawingml/2006/main">
               <a:ext uri="{FF2B5EF4-FFF2-40B4-BE49-F238E27FC236}">
-                <a16:creationId xmlns:a16="http://schemas.microsoft.com/office/drawing/2014/main" id="{7B2DF87B-0440-4CF2-9705-4A232A11290E}"/>
+                <a16:creationId xmlns:a16="http://schemas.microsoft.com/office/drawing/2014/main" id="{D59261E5-808C-47F1-B39F-26CE6CF1F279}"/>
               </a:ext>
             </a:extLst>
           </p:cNvPr>
@@ -7336,7 +7349,7 @@
     </p:spTree>
     <p:extLst>
       <p:ext uri="{BB962C8B-B14F-4D97-AF65-F5344CB8AC3E}">
-        <p14:creationId xmlns:p14="http://schemas.microsoft.com/office/powerpoint/2010/main" val="1964506173"/>
+        <p14:creationId xmlns:p14="http://schemas.microsoft.com/office/powerpoint/2010/main" val="1115141686"/>
       </p:ext>
     </p:extLst>
   </p:cSld>
@@ -7367,7 +7380,7 @@
           <p:cNvPr id="16" name="">
             <a:extLst xmlns:a="http://schemas.openxmlformats.org/drawingml/2006/main">
               <a:ext uri="{FF2B5EF4-FFF2-40B4-BE49-F238E27FC236}">
-                <a16:creationId xmlns:a16="http://schemas.microsoft.com/office/drawing/2014/main" id="{32343A67-2814-480D-944F-EA821F679094}"/>
+                <a16:creationId xmlns:a16="http://schemas.microsoft.com/office/drawing/2014/main" id="{4D62544A-2D12-4AE5-9E7C-A7693984AFBB}"/>
               </a:ext>
             </a:extLst>
           </p:cNvPr>
@@ -7417,7 +7430,7 @@
           <p:cNvPr id="2" name="">
             <a:extLst xmlns:a="http://schemas.openxmlformats.org/drawingml/2006/main">
               <a:ext uri="{FF2B5EF4-FFF2-40B4-BE49-F238E27FC236}">
-                <a16:creationId xmlns:a16="http://schemas.microsoft.com/office/drawing/2014/main" id="{C1697A02-B1FD-41D9-BCE9-9E02A0DE5A4C}"/>
+                <a16:creationId xmlns:a16="http://schemas.microsoft.com/office/drawing/2014/main" id="{5F936F0F-A917-47B2-AFE0-92E878BD6617}"/>
               </a:ext>
             </a:extLst>
           </p:cNvPr>
@@ -7457,7 +7470,7 @@
                   <a:srgbClr val="122A3E"/>
                 </a:solidFill>
               </a:rPr>
-              <a:t>$10,000 became $106,711—$38,629 ahead of SPY.</a:t>
+              <a:t>$10,000 became $106,711: $38,629 ahead of SPY.</a:t>
             </a:r>
           </a:p>
         </p:txBody>
@@ -7467,7 +7480,7 @@
           <p:cNvPr id="3" name="">
             <a:extLst xmlns:a="http://schemas.openxmlformats.org/drawingml/2006/main">
               <a:ext uri="{FF2B5EF4-FFF2-40B4-BE49-F238E27FC236}">
-                <a16:creationId xmlns:a16="http://schemas.microsoft.com/office/drawing/2014/main" id="{4F53DEE5-3C7F-4C9F-87E1-064DF57AC7B8}"/>
+                <a16:creationId xmlns:a16="http://schemas.microsoft.com/office/drawing/2014/main" id="{A2478ABD-927B-42B6-8A97-71F736ABB0B7}"/>
               </a:ext>
             </a:extLst>
           </p:cNvPr>
@@ -7524,7 +7537,7 @@
         </p:xfrm>
         <a:graphic xmlns:a="http://schemas.openxmlformats.org/drawingml/2006/main">
           <a:graphicData uri="http://schemas.openxmlformats.org/drawingml/2006/chart">
-            <c:chart xmlns:r="http://schemas.openxmlformats.org/officeDocument/2006/relationships" xmlns:c="http://schemas.openxmlformats.org/drawingml/2006/chart" r:id="R6936f2b5a5794d43"/>
+            <c:chart xmlns:r="http://schemas.openxmlformats.org/officeDocument/2006/relationships" xmlns:c="http://schemas.openxmlformats.org/drawingml/2006/chart" r:id="R05a2002ef1f04f63"/>
           </a:graphicData>
         </a:graphic>
       </p:graphicFrame>
@@ -7533,7 +7546,7 @@
           <p:cNvPr id="5" name="">
             <a:extLst xmlns:a="http://schemas.openxmlformats.org/drawingml/2006/main">
               <a:ext uri="{FF2B5EF4-FFF2-40B4-BE49-F238E27FC236}">
-                <a16:creationId xmlns:a16="http://schemas.microsoft.com/office/drawing/2014/main" id="{DDDD130B-04B2-4B53-B39F-09EAD849DD36}"/>
+                <a16:creationId xmlns:a16="http://schemas.microsoft.com/office/drawing/2014/main" id="{98BDBBB9-251B-4177-86E5-DB12A33AAB3A}"/>
               </a:ext>
             </a:extLst>
           </p:cNvPr>
@@ -7583,7 +7596,7 @@
           <p:cNvPr id="6" name="">
             <a:extLst xmlns:a="http://schemas.openxmlformats.org/drawingml/2006/main">
               <a:ext uri="{FF2B5EF4-FFF2-40B4-BE49-F238E27FC236}">
-                <a16:creationId xmlns:a16="http://schemas.microsoft.com/office/drawing/2014/main" id="{7BBF1CFC-0D7A-43F1-92F8-D6E3D6B6BA6D}"/>
+                <a16:creationId xmlns:a16="http://schemas.microsoft.com/office/drawing/2014/main" id="{3AAE256E-3092-40D4-914C-F8D17F73A18D}"/>
               </a:ext>
             </a:extLst>
           </p:cNvPr>
@@ -7633,7 +7646,7 @@
           <p:cNvPr id="7" name="">
             <a:extLst xmlns:a="http://schemas.openxmlformats.org/drawingml/2006/main">
               <a:ext uri="{FF2B5EF4-FFF2-40B4-BE49-F238E27FC236}">
-                <a16:creationId xmlns:a16="http://schemas.microsoft.com/office/drawing/2014/main" id="{6CE4B8DD-48EA-4E75-B576-7AF64B92E572}"/>
+                <a16:creationId xmlns:a16="http://schemas.microsoft.com/office/drawing/2014/main" id="{FEAFDE56-B0BB-4863-98A5-DC1F909DC61B}"/>
               </a:ext>
             </a:extLst>
           </p:cNvPr>
@@ -7683,7 +7696,7 @@
           <p:cNvPr id="8" name="">
             <a:extLst xmlns:a="http://schemas.openxmlformats.org/drawingml/2006/main">
               <a:ext uri="{FF2B5EF4-FFF2-40B4-BE49-F238E27FC236}">
-                <a16:creationId xmlns:a16="http://schemas.microsoft.com/office/drawing/2014/main" id="{D05C54F9-F9A2-420E-82DB-6F9B0475E1CA}"/>
+                <a16:creationId xmlns:a16="http://schemas.microsoft.com/office/drawing/2014/main" id="{5B75856B-F0D4-46AE-905D-59964157DE9C}"/>
               </a:ext>
             </a:extLst>
           </p:cNvPr>
@@ -7733,7 +7746,7 @@
           <p:cNvPr id="9" name="">
             <a:extLst xmlns:a="http://schemas.openxmlformats.org/drawingml/2006/main">
               <a:ext uri="{FF2B5EF4-FFF2-40B4-BE49-F238E27FC236}">
-                <a16:creationId xmlns:a16="http://schemas.microsoft.com/office/drawing/2014/main" id="{17BEB2D2-0AFE-4FC1-BF1E-E9DA65311A00}"/>
+                <a16:creationId xmlns:a16="http://schemas.microsoft.com/office/drawing/2014/main" id="{B92BA8BC-BBB6-4ECC-94CF-5D4EA3ACE463}"/>
               </a:ext>
             </a:extLst>
           </p:cNvPr>
@@ -7783,7 +7796,7 @@
           <p:cNvPr id="10" name="">
             <a:extLst xmlns:a="http://schemas.openxmlformats.org/drawingml/2006/main">
               <a:ext uri="{FF2B5EF4-FFF2-40B4-BE49-F238E27FC236}">
-                <a16:creationId xmlns:a16="http://schemas.microsoft.com/office/drawing/2014/main" id="{4A75BE74-044E-4451-9A62-B2093C33FF83}"/>
+                <a16:creationId xmlns:a16="http://schemas.microsoft.com/office/drawing/2014/main" id="{CC138C3A-93E4-4302-BC9F-B9BB56DF38D7}"/>
               </a:ext>
             </a:extLst>
           </p:cNvPr>
@@ -7840,7 +7853,7 @@
         </p:xfrm>
         <a:graphic xmlns:a="http://schemas.openxmlformats.org/drawingml/2006/main">
           <a:graphicData uri="http://schemas.openxmlformats.org/drawingml/2006/chart">
-            <c:chart xmlns:r="http://schemas.openxmlformats.org/officeDocument/2006/relationships" xmlns:c="http://schemas.openxmlformats.org/drawingml/2006/chart" r:id="Rce41866fca3a4df0"/>
+            <c:chart xmlns:r="http://schemas.openxmlformats.org/officeDocument/2006/relationships" xmlns:c="http://schemas.openxmlformats.org/drawingml/2006/chart" r:id="R944b709c18784625"/>
           </a:graphicData>
         </a:graphic>
       </p:graphicFrame>
@@ -7849,7 +7862,7 @@
           <p:cNvPr id="12" name="">
             <a:extLst xmlns:a="http://schemas.openxmlformats.org/drawingml/2006/main">
               <a:ext uri="{FF2B5EF4-FFF2-40B4-BE49-F238E27FC236}">
-                <a16:creationId xmlns:a16="http://schemas.microsoft.com/office/drawing/2014/main" id="{B5739B22-27DF-4078-A501-695C66A8C841}"/>
+                <a16:creationId xmlns:a16="http://schemas.microsoft.com/office/drawing/2014/main" id="{722D2972-01E0-46E0-8D67-944945A4B431}"/>
               </a:ext>
             </a:extLst>
           </p:cNvPr>
@@ -7899,7 +7912,7 @@
           <p:cNvPr id="13" name="">
             <a:extLst xmlns:a="http://schemas.openxmlformats.org/drawingml/2006/main">
               <a:ext uri="{FF2B5EF4-FFF2-40B4-BE49-F238E27FC236}">
-                <a16:creationId xmlns:a16="http://schemas.microsoft.com/office/drawing/2014/main" id="{1E2B9163-4B55-4FD0-8AEE-D8FF793C5B1E}"/>
+                <a16:creationId xmlns:a16="http://schemas.microsoft.com/office/drawing/2014/main" id="{FAB7257D-43D4-4DC9-A6AD-E07191F66AAB}"/>
               </a:ext>
             </a:extLst>
           </p:cNvPr>
@@ -7949,7 +7962,7 @@
           <p:cNvPr id="14" name="">
             <a:extLst xmlns:a="http://schemas.openxmlformats.org/drawingml/2006/main">
               <a:ext uri="{FF2B5EF4-FFF2-40B4-BE49-F238E27FC236}">
-                <a16:creationId xmlns:a16="http://schemas.microsoft.com/office/drawing/2014/main" id="{561ED17A-A94D-4661-AB99-AC0E0F768B32}"/>
+                <a16:creationId xmlns:a16="http://schemas.microsoft.com/office/drawing/2014/main" id="{6B16A5DD-CE64-44B9-84CE-DB6FD597DFB8}"/>
               </a:ext>
             </a:extLst>
           </p:cNvPr>
@@ -7999,7 +8012,7 @@
           <p:cNvPr id="15" name="">
             <a:extLst xmlns:a="http://schemas.openxmlformats.org/drawingml/2006/main">
               <a:ext uri="{FF2B5EF4-FFF2-40B4-BE49-F238E27FC236}">
-                <a16:creationId xmlns:a16="http://schemas.microsoft.com/office/drawing/2014/main" id="{62A4E397-46B4-475C-B008-01CEC4FB3DCA}"/>
+                <a16:creationId xmlns:a16="http://schemas.microsoft.com/office/drawing/2014/main" id="{F52B2DB4-6C57-4936-BF11-AE1116983734}"/>
               </a:ext>
             </a:extLst>
           </p:cNvPr>
@@ -8047,7 +8060,7 @@
     </p:spTree>
     <p:extLst>
       <p:ext uri="{BB962C8B-B14F-4D97-AF65-F5344CB8AC3E}">
-        <p14:creationId xmlns:p14="http://schemas.microsoft.com/office/powerpoint/2010/main" val="785577950"/>
+        <p14:creationId xmlns:p14="http://schemas.microsoft.com/office/powerpoint/2010/main" val="938461400"/>
       </p:ext>
     </p:extLst>
   </p:cSld>
@@ -8078,7 +8091,7 @@
           <p:cNvPr id="44" name="">
             <a:extLst xmlns:a="http://schemas.openxmlformats.org/drawingml/2006/main">
               <a:ext uri="{FF2B5EF4-FFF2-40B4-BE49-F238E27FC236}">
-                <a16:creationId xmlns:a16="http://schemas.microsoft.com/office/drawing/2014/main" id="{94A6D775-67BF-4E56-BF83-868FD22DCC74}"/>
+                <a16:creationId xmlns:a16="http://schemas.microsoft.com/office/drawing/2014/main" id="{4DEEF68A-2446-497C-B042-23E060E6711F}"/>
               </a:ext>
             </a:extLst>
           </p:cNvPr>
@@ -8128,7 +8141,7 @@
           <p:cNvPr id="2" name="">
             <a:extLst xmlns:a="http://schemas.openxmlformats.org/drawingml/2006/main">
               <a:ext uri="{FF2B5EF4-FFF2-40B4-BE49-F238E27FC236}">
-                <a16:creationId xmlns:a16="http://schemas.microsoft.com/office/drawing/2014/main" id="{AA7384E0-B837-4286-A29B-7556F65040F6}"/>
+                <a16:creationId xmlns:a16="http://schemas.microsoft.com/office/drawing/2014/main" id="{13666212-CE2F-4D5F-8D6E-EE44905131D3}"/>
               </a:ext>
             </a:extLst>
           </p:cNvPr>
@@ -8178,7 +8191,7 @@
           <p:cNvPr id="3" name="">
             <a:extLst xmlns:a="http://schemas.openxmlformats.org/drawingml/2006/main">
               <a:ext uri="{FF2B5EF4-FFF2-40B4-BE49-F238E27FC236}">
-                <a16:creationId xmlns:a16="http://schemas.microsoft.com/office/drawing/2014/main" id="{FBBED3F4-FD4F-457D-8F52-91A77633A059}"/>
+                <a16:creationId xmlns:a16="http://schemas.microsoft.com/office/drawing/2014/main" id="{9C7440EB-B205-4128-9D4E-33D8BBDD79B9}"/>
               </a:ext>
             </a:extLst>
           </p:cNvPr>
@@ -8209,7 +8222,7 @@
           <p:cNvPr id="4" name="">
             <a:extLst xmlns:a="http://schemas.openxmlformats.org/drawingml/2006/main">
               <a:ext uri="{FF2B5EF4-FFF2-40B4-BE49-F238E27FC236}">
-                <a16:creationId xmlns:a16="http://schemas.microsoft.com/office/drawing/2014/main" id="{B261F25E-FFC5-4C6E-BD45-3EDA9C97AC7E}"/>
+                <a16:creationId xmlns:a16="http://schemas.microsoft.com/office/drawing/2014/main" id="{3D848FBA-CC46-41E7-8EA4-03C51A68F623}"/>
               </a:ext>
             </a:extLst>
           </p:cNvPr>
@@ -8240,7 +8253,7 @@
           <p:cNvPr id="5" name="">
             <a:extLst xmlns:a="http://schemas.openxmlformats.org/drawingml/2006/main">
               <a:ext uri="{FF2B5EF4-FFF2-40B4-BE49-F238E27FC236}">
-                <a16:creationId xmlns:a16="http://schemas.microsoft.com/office/drawing/2014/main" id="{3C78A2B1-7766-4620-A423-F4D5F9DC113F}"/>
+                <a16:creationId xmlns:a16="http://schemas.microsoft.com/office/drawing/2014/main" id="{27E997EC-455B-4AC2-ACBC-7187064BDFAB}"/>
               </a:ext>
             </a:extLst>
           </p:cNvPr>
@@ -8271,7 +8284,7 @@
           <p:cNvPr id="6" name="">
             <a:extLst xmlns:a="http://schemas.openxmlformats.org/drawingml/2006/main">
               <a:ext uri="{FF2B5EF4-FFF2-40B4-BE49-F238E27FC236}">
-                <a16:creationId xmlns:a16="http://schemas.microsoft.com/office/drawing/2014/main" id="{B183DE00-C48D-4336-B31C-E1159E2D2B44}"/>
+                <a16:creationId xmlns:a16="http://schemas.microsoft.com/office/drawing/2014/main" id="{8C720B0B-6D5F-4001-AF68-78C4BCB872C0}"/>
               </a:ext>
             </a:extLst>
           </p:cNvPr>
@@ -8321,7 +8334,7 @@
           <p:cNvPr id="7" name="">
             <a:extLst xmlns:a="http://schemas.openxmlformats.org/drawingml/2006/main">
               <a:ext uri="{FF2B5EF4-FFF2-40B4-BE49-F238E27FC236}">
-                <a16:creationId xmlns:a16="http://schemas.microsoft.com/office/drawing/2014/main" id="{6E10202E-C149-454D-A9B1-8D013FC27F4F}"/>
+                <a16:creationId xmlns:a16="http://schemas.microsoft.com/office/drawing/2014/main" id="{D25160E3-667C-48E9-981A-A1B75EAF2968}"/>
               </a:ext>
             </a:extLst>
           </p:cNvPr>
@@ -8371,7 +8384,7 @@
           <p:cNvPr id="8" name="">
             <a:extLst xmlns:a="http://schemas.openxmlformats.org/drawingml/2006/main">
               <a:ext uri="{FF2B5EF4-FFF2-40B4-BE49-F238E27FC236}">
-                <a16:creationId xmlns:a16="http://schemas.microsoft.com/office/drawing/2014/main" id="{E5580501-AB5E-4F18-8F54-E1AE82CF2C2F}"/>
+                <a16:creationId xmlns:a16="http://schemas.microsoft.com/office/drawing/2014/main" id="{E0EE97CE-D5B8-431D-B206-EB1BB918E3EB}"/>
               </a:ext>
             </a:extLst>
           </p:cNvPr>
@@ -8421,7 +8434,7 @@
           <p:cNvPr id="9" name="">
             <a:extLst xmlns:a="http://schemas.openxmlformats.org/drawingml/2006/main">
               <a:ext uri="{FF2B5EF4-FFF2-40B4-BE49-F238E27FC236}">
-                <a16:creationId xmlns:a16="http://schemas.microsoft.com/office/drawing/2014/main" id="{5DD8E510-AB9F-4D01-8C29-A20A7E1D7044}"/>
+                <a16:creationId xmlns:a16="http://schemas.microsoft.com/office/drawing/2014/main" id="{11F6445A-F355-4A0B-AEFA-59FB1DBEAFCE}"/>
               </a:ext>
             </a:extLst>
           </p:cNvPr>
@@ -8471,7 +8484,7 @@
           <p:cNvPr id="10" name="">
             <a:extLst xmlns:a="http://schemas.openxmlformats.org/drawingml/2006/main">
               <a:ext uri="{FF2B5EF4-FFF2-40B4-BE49-F238E27FC236}">
-                <a16:creationId xmlns:a16="http://schemas.microsoft.com/office/drawing/2014/main" id="{658524EE-51DA-47EF-AEBC-BDC9238F5B8A}"/>
+                <a16:creationId xmlns:a16="http://schemas.microsoft.com/office/drawing/2014/main" id="{24E20A4F-0577-4DAD-BD5A-E2FDF704F5E6}"/>
               </a:ext>
             </a:extLst>
           </p:cNvPr>
@@ -8521,7 +8534,7 @@
           <p:cNvPr id="11" name="">
             <a:extLst xmlns:a="http://schemas.openxmlformats.org/drawingml/2006/main">
               <a:ext uri="{FF2B5EF4-FFF2-40B4-BE49-F238E27FC236}">
-                <a16:creationId xmlns:a16="http://schemas.microsoft.com/office/drawing/2014/main" id="{5FB577F8-D4DB-467F-869A-5B3A57EBD5AC}"/>
+                <a16:creationId xmlns:a16="http://schemas.microsoft.com/office/drawing/2014/main" id="{B3DABC05-E0F7-4283-8E79-97B2DB6CFDBD}"/>
               </a:ext>
             </a:extLst>
           </p:cNvPr>
@@ -8571,7 +8584,7 @@
           <p:cNvPr id="12" name="">
             <a:extLst xmlns:a="http://schemas.openxmlformats.org/drawingml/2006/main">
               <a:ext uri="{FF2B5EF4-FFF2-40B4-BE49-F238E27FC236}">
-                <a16:creationId xmlns:a16="http://schemas.microsoft.com/office/drawing/2014/main" id="{4057485E-CB13-4803-B1E9-FD7964213C97}"/>
+                <a16:creationId xmlns:a16="http://schemas.microsoft.com/office/drawing/2014/main" id="{D60D1F12-4B8E-49E3-B101-6CA078AC9C9E}"/>
               </a:ext>
             </a:extLst>
           </p:cNvPr>
@@ -8621,7 +8634,7 @@
           <p:cNvPr id="13" name="">
             <a:extLst xmlns:a="http://schemas.openxmlformats.org/drawingml/2006/main">
               <a:ext uri="{FF2B5EF4-FFF2-40B4-BE49-F238E27FC236}">
-                <a16:creationId xmlns:a16="http://schemas.microsoft.com/office/drawing/2014/main" id="{C6DFF8F4-2274-49E7-B2C8-9390C9C702AD}"/>
+                <a16:creationId xmlns:a16="http://schemas.microsoft.com/office/drawing/2014/main" id="{042B37DC-3AF2-4F0C-BF8A-B75A72D04E01}"/>
               </a:ext>
             </a:extLst>
           </p:cNvPr>
@@ -8671,7 +8684,7 @@
           <p:cNvPr id="14" name="">
             <a:extLst xmlns:a="http://schemas.openxmlformats.org/drawingml/2006/main">
               <a:ext uri="{FF2B5EF4-FFF2-40B4-BE49-F238E27FC236}">
-                <a16:creationId xmlns:a16="http://schemas.microsoft.com/office/drawing/2014/main" id="{FEAF9FFA-9849-4D0B-A42D-4DCF4EB0B73F}"/>
+                <a16:creationId xmlns:a16="http://schemas.microsoft.com/office/drawing/2014/main" id="{E008F81F-547B-4035-B379-8ED7C417C1B0}"/>
               </a:ext>
             </a:extLst>
           </p:cNvPr>
@@ -8702,7 +8715,7 @@
           <p:cNvPr id="15" name="">
             <a:extLst xmlns:a="http://schemas.openxmlformats.org/drawingml/2006/main">
               <a:ext uri="{FF2B5EF4-FFF2-40B4-BE49-F238E27FC236}">
-                <a16:creationId xmlns:a16="http://schemas.microsoft.com/office/drawing/2014/main" id="{7EC4C322-E5C9-4F5A-9617-AC3A3074879D}"/>
+                <a16:creationId xmlns:a16="http://schemas.microsoft.com/office/drawing/2014/main" id="{400D9E24-78B8-4F03-AABC-9154C77A4B44}"/>
               </a:ext>
             </a:extLst>
           </p:cNvPr>
@@ -8733,7 +8746,7 @@
           <p:cNvPr id="16" name="">
             <a:extLst xmlns:a="http://schemas.openxmlformats.org/drawingml/2006/main">
               <a:ext uri="{FF2B5EF4-FFF2-40B4-BE49-F238E27FC236}">
-                <a16:creationId xmlns:a16="http://schemas.microsoft.com/office/drawing/2014/main" id="{7184ACDC-6B2A-4165-BC6F-4B2DF4054C32}"/>
+                <a16:creationId xmlns:a16="http://schemas.microsoft.com/office/drawing/2014/main" id="{0E43AFE8-CCD6-4286-ACEA-2AA51582A79F}"/>
               </a:ext>
             </a:extLst>
           </p:cNvPr>
@@ -8764,7 +8777,7 @@
           <p:cNvPr id="17" name="">
             <a:extLst xmlns:a="http://schemas.openxmlformats.org/drawingml/2006/main">
               <a:ext uri="{FF2B5EF4-FFF2-40B4-BE49-F238E27FC236}">
-                <a16:creationId xmlns:a16="http://schemas.microsoft.com/office/drawing/2014/main" id="{0955287C-C04F-4F27-8858-BF058589E322}"/>
+                <a16:creationId xmlns:a16="http://schemas.microsoft.com/office/drawing/2014/main" id="{2611394D-15D4-4057-9897-73CE30D7632C}"/>
               </a:ext>
             </a:extLst>
           </p:cNvPr>
@@ -8795,7 +8808,7 @@
           <p:cNvPr id="18" name="">
             <a:extLst xmlns:a="http://schemas.openxmlformats.org/drawingml/2006/main">
               <a:ext uri="{FF2B5EF4-FFF2-40B4-BE49-F238E27FC236}">
-                <a16:creationId xmlns:a16="http://schemas.microsoft.com/office/drawing/2014/main" id="{87E7B2D0-5A64-408F-B0E7-563C0BDEF57C}"/>
+                <a16:creationId xmlns:a16="http://schemas.microsoft.com/office/drawing/2014/main" id="{460EA2CB-EB82-45A2-B13A-D7B896D36865}"/>
               </a:ext>
             </a:extLst>
           </p:cNvPr>
@@ -8826,7 +8839,7 @@
           <p:cNvPr id="19" name="">
             <a:extLst xmlns:a="http://schemas.openxmlformats.org/drawingml/2006/main">
               <a:ext uri="{FF2B5EF4-FFF2-40B4-BE49-F238E27FC236}">
-                <a16:creationId xmlns:a16="http://schemas.microsoft.com/office/drawing/2014/main" id="{F10659AD-2F65-4B49-89B3-846BED4FE7D0}"/>
+                <a16:creationId xmlns:a16="http://schemas.microsoft.com/office/drawing/2014/main" id="{EA4BDE0F-A59A-4F6D-8697-0584B2683889}"/>
               </a:ext>
             </a:extLst>
           </p:cNvPr>
@@ -8857,7 +8870,7 @@
           <p:cNvPr id="20" name="">
             <a:extLst xmlns:a="http://schemas.openxmlformats.org/drawingml/2006/main">
               <a:ext uri="{FF2B5EF4-FFF2-40B4-BE49-F238E27FC236}">
-                <a16:creationId xmlns:a16="http://schemas.microsoft.com/office/drawing/2014/main" id="{8A56BF6E-3919-4C11-B8E1-1AFC7714A9F6}"/>
+                <a16:creationId xmlns:a16="http://schemas.microsoft.com/office/drawing/2014/main" id="{29D2BFA7-5AD2-4A76-AD25-3E22D37DBAC8}"/>
               </a:ext>
             </a:extLst>
           </p:cNvPr>
@@ -8888,7 +8901,7 @@
           <p:cNvPr id="21" name="">
             <a:extLst xmlns:a="http://schemas.openxmlformats.org/drawingml/2006/main">
               <a:ext uri="{FF2B5EF4-FFF2-40B4-BE49-F238E27FC236}">
-                <a16:creationId xmlns:a16="http://schemas.microsoft.com/office/drawing/2014/main" id="{E679D9B2-A7E9-410D-A39B-2E4A84986187}"/>
+                <a16:creationId xmlns:a16="http://schemas.microsoft.com/office/drawing/2014/main" id="{482DC5F4-AB41-490E-B4A8-AD85886F58FF}"/>
               </a:ext>
             </a:extLst>
           </p:cNvPr>
@@ -8919,7 +8932,7 @@
           <p:cNvPr id="22" name="">
             <a:extLst xmlns:a="http://schemas.openxmlformats.org/drawingml/2006/main">
               <a:ext uri="{FF2B5EF4-FFF2-40B4-BE49-F238E27FC236}">
-                <a16:creationId xmlns:a16="http://schemas.microsoft.com/office/drawing/2014/main" id="{EB64992A-0A1C-43A2-ADE5-C720981E1C53}"/>
+                <a16:creationId xmlns:a16="http://schemas.microsoft.com/office/drawing/2014/main" id="{B6941686-B29F-43B4-A26E-9020D4675D85}"/>
               </a:ext>
             </a:extLst>
           </p:cNvPr>
@@ -8950,7 +8963,7 @@
           <p:cNvPr id="23" name="">
             <a:extLst xmlns:a="http://schemas.openxmlformats.org/drawingml/2006/main">
               <a:ext uri="{FF2B5EF4-FFF2-40B4-BE49-F238E27FC236}">
-                <a16:creationId xmlns:a16="http://schemas.microsoft.com/office/drawing/2014/main" id="{D3763015-4C97-4EBE-874A-A994671D5EC0}"/>
+                <a16:creationId xmlns:a16="http://schemas.microsoft.com/office/drawing/2014/main" id="{02F43CC2-A3DA-468B-B0BD-58B05631CB93}"/>
               </a:ext>
             </a:extLst>
           </p:cNvPr>
@@ -8981,7 +8994,7 @@
           <p:cNvPr id="24" name="">
             <a:extLst xmlns:a="http://schemas.openxmlformats.org/drawingml/2006/main">
               <a:ext uri="{FF2B5EF4-FFF2-40B4-BE49-F238E27FC236}">
-                <a16:creationId xmlns:a16="http://schemas.microsoft.com/office/drawing/2014/main" id="{A324AB94-375D-4E6F-8094-7227646FC948}"/>
+                <a16:creationId xmlns:a16="http://schemas.microsoft.com/office/drawing/2014/main" id="{1F81E2B9-AABB-4A83-BF1F-AC65EEA743F8}"/>
               </a:ext>
             </a:extLst>
           </p:cNvPr>
@@ -9012,7 +9025,7 @@
           <p:cNvPr id="25" name="">
             <a:extLst xmlns:a="http://schemas.openxmlformats.org/drawingml/2006/main">
               <a:ext uri="{FF2B5EF4-FFF2-40B4-BE49-F238E27FC236}">
-                <a16:creationId xmlns:a16="http://schemas.microsoft.com/office/drawing/2014/main" id="{6FEB6C25-666C-4F5F-AED2-3370758C188F}"/>
+                <a16:creationId xmlns:a16="http://schemas.microsoft.com/office/drawing/2014/main" id="{405F18A3-5626-4E6D-BD86-91CBAB2E5342}"/>
               </a:ext>
             </a:extLst>
           </p:cNvPr>
@@ -9043,7 +9056,7 @@
           <p:cNvPr id="26" name="">
             <a:extLst xmlns:a="http://schemas.openxmlformats.org/drawingml/2006/main">
               <a:ext uri="{FF2B5EF4-FFF2-40B4-BE49-F238E27FC236}">
-                <a16:creationId xmlns:a16="http://schemas.microsoft.com/office/drawing/2014/main" id="{DA3A2B3A-A085-4587-BEF1-D579EEC0514A}"/>
+                <a16:creationId xmlns:a16="http://schemas.microsoft.com/office/drawing/2014/main" id="{711080DC-DED4-4737-B619-30A5F70655A8}"/>
               </a:ext>
             </a:extLst>
           </p:cNvPr>
@@ -9074,7 +9087,7 @@
           <p:cNvPr id="27" name="">
             <a:extLst xmlns:a="http://schemas.openxmlformats.org/drawingml/2006/main">
               <a:ext uri="{FF2B5EF4-FFF2-40B4-BE49-F238E27FC236}">
-                <a16:creationId xmlns:a16="http://schemas.microsoft.com/office/drawing/2014/main" id="{290D576D-7E59-4DD2-981E-4FFD79C6439E}"/>
+                <a16:creationId xmlns:a16="http://schemas.microsoft.com/office/drawing/2014/main" id="{13796450-FBD9-4E6F-BE79-F2112E01DAF6}"/>
               </a:ext>
             </a:extLst>
           </p:cNvPr>
@@ -9105,7 +9118,7 @@
           <p:cNvPr id="28" name="">
             <a:extLst xmlns:a="http://schemas.openxmlformats.org/drawingml/2006/main">
               <a:ext uri="{FF2B5EF4-FFF2-40B4-BE49-F238E27FC236}">
-                <a16:creationId xmlns:a16="http://schemas.microsoft.com/office/drawing/2014/main" id="{3D1C97BC-15AD-43C8-A620-192436E61DAA}"/>
+                <a16:creationId xmlns:a16="http://schemas.microsoft.com/office/drawing/2014/main" id="{7F58B822-BDC2-438A-AEAB-4132DB167C86}"/>
               </a:ext>
             </a:extLst>
           </p:cNvPr>
@@ -9136,7 +9149,7 @@
           <p:cNvPr id="29" name="">
             <a:extLst xmlns:a="http://schemas.openxmlformats.org/drawingml/2006/main">
               <a:ext uri="{FF2B5EF4-FFF2-40B4-BE49-F238E27FC236}">
-                <a16:creationId xmlns:a16="http://schemas.microsoft.com/office/drawing/2014/main" id="{095C1632-F126-4AF7-9DBE-7019D39E54BA}"/>
+                <a16:creationId xmlns:a16="http://schemas.microsoft.com/office/drawing/2014/main" id="{0BCC5D9D-CECD-46A6-A7A8-E73D20F8A642}"/>
               </a:ext>
             </a:extLst>
           </p:cNvPr>
@@ -9167,7 +9180,7 @@
           <p:cNvPr id="30" name="">
             <a:extLst xmlns:a="http://schemas.openxmlformats.org/drawingml/2006/main">
               <a:ext uri="{FF2B5EF4-FFF2-40B4-BE49-F238E27FC236}">
-                <a16:creationId xmlns:a16="http://schemas.microsoft.com/office/drawing/2014/main" id="{73310D84-A90B-4B81-9454-D84727508B51}"/>
+                <a16:creationId xmlns:a16="http://schemas.microsoft.com/office/drawing/2014/main" id="{D3A2839C-726B-441B-BAA3-B5A75DF73855}"/>
               </a:ext>
             </a:extLst>
           </p:cNvPr>
@@ -9198,7 +9211,7 @@
           <p:cNvPr id="31" name="">
             <a:extLst xmlns:a="http://schemas.openxmlformats.org/drawingml/2006/main">
               <a:ext uri="{FF2B5EF4-FFF2-40B4-BE49-F238E27FC236}">
-                <a16:creationId xmlns:a16="http://schemas.microsoft.com/office/drawing/2014/main" id="{BE7BDEEB-F101-4FED-AF23-A53449ADCD54}"/>
+                <a16:creationId xmlns:a16="http://schemas.microsoft.com/office/drawing/2014/main" id="{4B6116E7-AC0D-43E4-8562-798643853006}"/>
               </a:ext>
             </a:extLst>
           </p:cNvPr>
@@ -9229,7 +9242,7 @@
           <p:cNvPr id="32" name="">
             <a:extLst xmlns:a="http://schemas.openxmlformats.org/drawingml/2006/main">
               <a:ext uri="{FF2B5EF4-FFF2-40B4-BE49-F238E27FC236}">
-                <a16:creationId xmlns:a16="http://schemas.microsoft.com/office/drawing/2014/main" id="{6642F80F-9442-41FD-A173-D77C87308536}"/>
+                <a16:creationId xmlns:a16="http://schemas.microsoft.com/office/drawing/2014/main" id="{5229FACF-C6AF-444F-ACA6-8103ED990A2F}"/>
               </a:ext>
             </a:extLst>
           </p:cNvPr>
@@ -9260,7 +9273,7 @@
           <p:cNvPr id="33" name="">
             <a:extLst xmlns:a="http://schemas.openxmlformats.org/drawingml/2006/main">
               <a:ext uri="{FF2B5EF4-FFF2-40B4-BE49-F238E27FC236}">
-                <a16:creationId xmlns:a16="http://schemas.microsoft.com/office/drawing/2014/main" id="{89A2C0E0-AC63-4209-A3C6-4093ABEA4C85}"/>
+                <a16:creationId xmlns:a16="http://schemas.microsoft.com/office/drawing/2014/main" id="{9E868680-4E5A-4DB6-81E8-DE3986CCF89C}"/>
               </a:ext>
             </a:extLst>
           </p:cNvPr>
@@ -9291,7 +9304,7 @@
           <p:cNvPr id="34" name="">
             <a:extLst xmlns:a="http://schemas.openxmlformats.org/drawingml/2006/main">
               <a:ext uri="{FF2B5EF4-FFF2-40B4-BE49-F238E27FC236}">
-                <a16:creationId xmlns:a16="http://schemas.microsoft.com/office/drawing/2014/main" id="{5ACF533F-BCD9-41F4-9EAF-60716EF6E313}"/>
+                <a16:creationId xmlns:a16="http://schemas.microsoft.com/office/drawing/2014/main" id="{2D901CDA-BCA2-4D01-B317-63BC7DA1A765}"/>
               </a:ext>
             </a:extLst>
           </p:cNvPr>
@@ -9322,7 +9335,7 @@
           <p:cNvPr id="35" name="">
             <a:extLst xmlns:a="http://schemas.openxmlformats.org/drawingml/2006/main">
               <a:ext uri="{FF2B5EF4-FFF2-40B4-BE49-F238E27FC236}">
-                <a16:creationId xmlns:a16="http://schemas.microsoft.com/office/drawing/2014/main" id="{436DC013-44B1-457D-B0BE-03C053AA1B9F}"/>
+                <a16:creationId xmlns:a16="http://schemas.microsoft.com/office/drawing/2014/main" id="{729B9C90-C29C-49E7-AAF7-585B2514FBF1}"/>
               </a:ext>
             </a:extLst>
           </p:cNvPr>
@@ -9372,7 +9385,7 @@
           <p:cNvPr id="36" name="">
             <a:extLst xmlns:a="http://schemas.openxmlformats.org/drawingml/2006/main">
               <a:ext uri="{FF2B5EF4-FFF2-40B4-BE49-F238E27FC236}">
-                <a16:creationId xmlns:a16="http://schemas.microsoft.com/office/drawing/2014/main" id="{663EA338-8713-420A-A89D-EF050664476D}"/>
+                <a16:creationId xmlns:a16="http://schemas.microsoft.com/office/drawing/2014/main" id="{599644F4-1BEC-4DD6-B421-05AFCEC0A8B7}"/>
               </a:ext>
             </a:extLst>
           </p:cNvPr>
@@ -9422,7 +9435,7 @@
           <p:cNvPr id="37" name="">
             <a:extLst xmlns:a="http://schemas.openxmlformats.org/drawingml/2006/main">
               <a:ext uri="{FF2B5EF4-FFF2-40B4-BE49-F238E27FC236}">
-                <a16:creationId xmlns:a16="http://schemas.microsoft.com/office/drawing/2014/main" id="{AC633CC3-F2B9-4AF1-8C39-AA61A9C7F253}"/>
+                <a16:creationId xmlns:a16="http://schemas.microsoft.com/office/drawing/2014/main" id="{096D1F79-E5A7-4C78-98AE-5B6EE2E3AEC0}"/>
               </a:ext>
             </a:extLst>
           </p:cNvPr>
@@ -9472,7 +9485,7 @@
           <p:cNvPr id="38" name="">
             <a:extLst xmlns:a="http://schemas.openxmlformats.org/drawingml/2006/main">
               <a:ext uri="{FF2B5EF4-FFF2-40B4-BE49-F238E27FC236}">
-                <a16:creationId xmlns:a16="http://schemas.microsoft.com/office/drawing/2014/main" id="{15CEBD61-895E-4238-8133-E56D5F7DDAB0}"/>
+                <a16:creationId xmlns:a16="http://schemas.microsoft.com/office/drawing/2014/main" id="{64AD3150-30B5-410A-8D57-9E05B346F6DA}"/>
               </a:ext>
             </a:extLst>
           </p:cNvPr>
@@ -9505,7 +9518,7 @@
           <p:cNvPr id="39" name="">
             <a:extLst xmlns:a="http://schemas.openxmlformats.org/drawingml/2006/main">
               <a:ext uri="{FF2B5EF4-FFF2-40B4-BE49-F238E27FC236}">
-                <a16:creationId xmlns:a16="http://schemas.microsoft.com/office/drawing/2014/main" id="{EDC375C8-A330-4292-9731-8F2B6E6C9BFF}"/>
+                <a16:creationId xmlns:a16="http://schemas.microsoft.com/office/drawing/2014/main" id="{3CBDD3A7-DB52-4728-90AD-11192B61ED13}"/>
               </a:ext>
             </a:extLst>
           </p:cNvPr>
@@ -9538,7 +9551,7 @@
           <p:cNvPr id="40" name="">
             <a:extLst xmlns:a="http://schemas.openxmlformats.org/drawingml/2006/main">
               <a:ext uri="{FF2B5EF4-FFF2-40B4-BE49-F238E27FC236}">
-                <a16:creationId xmlns:a16="http://schemas.microsoft.com/office/drawing/2014/main" id="{EF8121AF-19AC-41D9-B7E8-03211943F609}"/>
+                <a16:creationId xmlns:a16="http://schemas.microsoft.com/office/drawing/2014/main" id="{57D4E5A7-7D44-48E6-AA51-C5E075C6CD62}"/>
               </a:ext>
             </a:extLst>
           </p:cNvPr>
@@ -9569,7 +9582,7 @@
           <p:cNvPr id="41" name="">
             <a:extLst xmlns:a="http://schemas.openxmlformats.org/drawingml/2006/main">
               <a:ext uri="{FF2B5EF4-FFF2-40B4-BE49-F238E27FC236}">
-                <a16:creationId xmlns:a16="http://schemas.microsoft.com/office/drawing/2014/main" id="{4553F6B0-027E-4808-8AE5-E3297E19002D}"/>
+                <a16:creationId xmlns:a16="http://schemas.microsoft.com/office/drawing/2014/main" id="{607B6282-3185-4295-9C86-95B76E1207D3}"/>
               </a:ext>
             </a:extLst>
           </p:cNvPr>
@@ -9619,7 +9632,7 @@
           <p:cNvPr id="42" name="">
             <a:extLst xmlns:a="http://schemas.openxmlformats.org/drawingml/2006/main">
               <a:ext uri="{FF2B5EF4-FFF2-40B4-BE49-F238E27FC236}">
-                <a16:creationId xmlns:a16="http://schemas.microsoft.com/office/drawing/2014/main" id="{EFD30EC7-A9AB-414A-9904-5B7E8A8660EB}"/>
+                <a16:creationId xmlns:a16="http://schemas.microsoft.com/office/drawing/2014/main" id="{DC5F750C-741F-4772-B536-1AA551795DE4}"/>
               </a:ext>
             </a:extLst>
           </p:cNvPr>
@@ -9669,7 +9682,7 @@
           <p:cNvPr id="43" name="">
             <a:extLst xmlns:a="http://schemas.openxmlformats.org/drawingml/2006/main">
               <a:ext uri="{FF2B5EF4-FFF2-40B4-BE49-F238E27FC236}">
-                <a16:creationId xmlns:a16="http://schemas.microsoft.com/office/drawing/2014/main" id="{446646DD-63BB-4301-BF97-C2071AD881A8}"/>
+                <a16:creationId xmlns:a16="http://schemas.microsoft.com/office/drawing/2014/main" id="{292705C1-FEA3-4F5C-9881-5B8A1A367EA0}"/>
               </a:ext>
             </a:extLst>
           </p:cNvPr>
@@ -9717,7 +9730,7 @@
     </p:spTree>
     <p:extLst>
       <p:ext uri="{BB962C8B-B14F-4D97-AF65-F5344CB8AC3E}">
-        <p14:creationId xmlns:p14="http://schemas.microsoft.com/office/powerpoint/2010/main" val="646973946"/>
+        <p14:creationId xmlns:p14="http://schemas.microsoft.com/office/powerpoint/2010/main" val="1113075054"/>
       </p:ext>
     </p:extLst>
   </p:cSld>
@@ -9748,7 +9761,7 @@
           <p:cNvPr id="28" name="">
             <a:extLst xmlns:a="http://schemas.openxmlformats.org/drawingml/2006/main">
               <a:ext uri="{FF2B5EF4-FFF2-40B4-BE49-F238E27FC236}">
-                <a16:creationId xmlns:a16="http://schemas.microsoft.com/office/drawing/2014/main" id="{3E57AC0C-2115-4728-B653-B2D0181ABD19}"/>
+                <a16:creationId xmlns:a16="http://schemas.microsoft.com/office/drawing/2014/main" id="{552A16E9-02B4-4D1D-92C8-C914A53182A3}"/>
               </a:ext>
             </a:extLst>
           </p:cNvPr>
@@ -9798,7 +9811,7 @@
           <p:cNvPr id="2" name="">
             <a:extLst xmlns:a="http://schemas.openxmlformats.org/drawingml/2006/main">
               <a:ext uri="{FF2B5EF4-FFF2-40B4-BE49-F238E27FC236}">
-                <a16:creationId xmlns:a16="http://schemas.microsoft.com/office/drawing/2014/main" id="{02C50EC9-10A7-4CEA-B720-291968E9F916}"/>
+                <a16:creationId xmlns:a16="http://schemas.microsoft.com/office/drawing/2014/main" id="{5CBA9E2A-CE8A-4246-BFD5-EC52A9AC01C1}"/>
               </a:ext>
             </a:extLst>
           </p:cNvPr>
@@ -9855,7 +9868,7 @@
         </p:xfrm>
         <a:graphic xmlns:a="http://schemas.openxmlformats.org/drawingml/2006/main">
           <a:graphicData uri="http://schemas.openxmlformats.org/drawingml/2006/chart">
-            <c:chart xmlns:r="http://schemas.openxmlformats.org/officeDocument/2006/relationships" xmlns:c="http://schemas.openxmlformats.org/drawingml/2006/chart" r:id="R73c2e09a7d074e13"/>
+            <c:chart xmlns:r="http://schemas.openxmlformats.org/officeDocument/2006/relationships" xmlns:c="http://schemas.openxmlformats.org/drawingml/2006/chart" r:id="R22bcb711368c46f6"/>
           </a:graphicData>
         </a:graphic>
       </p:graphicFrame>
@@ -9864,7 +9877,7 @@
           <p:cNvPr id="4" name="">
             <a:extLst xmlns:a="http://schemas.openxmlformats.org/drawingml/2006/main">
               <a:ext uri="{FF2B5EF4-FFF2-40B4-BE49-F238E27FC236}">
-                <a16:creationId xmlns:a16="http://schemas.microsoft.com/office/drawing/2014/main" id="{B5AA1409-B664-451C-8D47-8280FD5F9925}"/>
+                <a16:creationId xmlns:a16="http://schemas.microsoft.com/office/drawing/2014/main" id="{01B80A4B-0B1D-4935-821E-58BEB9B6C580}"/>
               </a:ext>
             </a:extLst>
           </p:cNvPr>
@@ -9914,7 +9927,7 @@
           <p:cNvPr id="5" name="">
             <a:extLst xmlns:a="http://schemas.openxmlformats.org/drawingml/2006/main">
               <a:ext uri="{FF2B5EF4-FFF2-40B4-BE49-F238E27FC236}">
-                <a16:creationId xmlns:a16="http://schemas.microsoft.com/office/drawing/2014/main" id="{45BB01E6-6CBA-4104-9086-1AB271B4A45E}"/>
+                <a16:creationId xmlns:a16="http://schemas.microsoft.com/office/drawing/2014/main" id="{3752A090-CC97-4AF6-9C86-E15C590FBCE0}"/>
               </a:ext>
             </a:extLst>
           </p:cNvPr>
@@ -9964,7 +9977,7 @@
           <p:cNvPr id="6" name="">
             <a:extLst xmlns:a="http://schemas.openxmlformats.org/drawingml/2006/main">
               <a:ext uri="{FF2B5EF4-FFF2-40B4-BE49-F238E27FC236}">
-                <a16:creationId xmlns:a16="http://schemas.microsoft.com/office/drawing/2014/main" id="{8AFE3945-701C-406F-99F0-AE22BF8684E3}"/>
+                <a16:creationId xmlns:a16="http://schemas.microsoft.com/office/drawing/2014/main" id="{18EA36FB-6820-4501-B1EB-1EB59E49E37A}"/>
               </a:ext>
             </a:extLst>
           </p:cNvPr>
@@ -10014,7 +10027,7 @@
           <p:cNvPr id="7" name="">
             <a:extLst xmlns:a="http://schemas.openxmlformats.org/drawingml/2006/main">
               <a:ext uri="{FF2B5EF4-FFF2-40B4-BE49-F238E27FC236}">
-                <a16:creationId xmlns:a16="http://schemas.microsoft.com/office/drawing/2014/main" id="{5F24600A-4694-4A43-BEAA-A20901E3F04D}"/>
+                <a16:creationId xmlns:a16="http://schemas.microsoft.com/office/drawing/2014/main" id="{60D8C898-3279-4944-B3D9-F0E584B59B9F}"/>
               </a:ext>
             </a:extLst>
           </p:cNvPr>
@@ -10053,7 +10066,7 @@
           <p:cNvPr id="8" name="">
             <a:extLst xmlns:a="http://schemas.openxmlformats.org/drawingml/2006/main">
               <a:ext uri="{FF2B5EF4-FFF2-40B4-BE49-F238E27FC236}">
-                <a16:creationId xmlns:a16="http://schemas.microsoft.com/office/drawing/2014/main" id="{1B8428D0-FA8E-41BA-9538-9E99B8A5A05D}"/>
+                <a16:creationId xmlns:a16="http://schemas.microsoft.com/office/drawing/2014/main" id="{29303162-4ACD-4B63-9B8B-B792AFA6C316}"/>
               </a:ext>
             </a:extLst>
           </p:cNvPr>
@@ -10103,7 +10116,7 @@
           <p:cNvPr id="9" name="">
             <a:extLst xmlns:a="http://schemas.openxmlformats.org/drawingml/2006/main">
               <a:ext uri="{FF2B5EF4-FFF2-40B4-BE49-F238E27FC236}">
-                <a16:creationId xmlns:a16="http://schemas.microsoft.com/office/drawing/2014/main" id="{CA86E142-A8A1-44A9-A1A4-15FD476A7553}"/>
+                <a16:creationId xmlns:a16="http://schemas.microsoft.com/office/drawing/2014/main" id="{4E32C615-959C-4F77-8722-2A5A73C75A6C}"/>
               </a:ext>
             </a:extLst>
           </p:cNvPr>
@@ -10153,7 +10166,7 @@
           <p:cNvPr id="10" name="">
             <a:extLst xmlns:a="http://schemas.openxmlformats.org/drawingml/2006/main">
               <a:ext uri="{FF2B5EF4-FFF2-40B4-BE49-F238E27FC236}">
-                <a16:creationId xmlns:a16="http://schemas.microsoft.com/office/drawing/2014/main" id="{62C23EFA-DC19-4AFA-BD8A-2D5A83B3DED5}"/>
+                <a16:creationId xmlns:a16="http://schemas.microsoft.com/office/drawing/2014/main" id="{61D42DE3-F981-4595-9180-0EEA893FC849}"/>
               </a:ext>
             </a:extLst>
           </p:cNvPr>
@@ -10203,7 +10216,7 @@
           <p:cNvPr id="11" name="">
             <a:extLst xmlns:a="http://schemas.openxmlformats.org/drawingml/2006/main">
               <a:ext uri="{FF2B5EF4-FFF2-40B4-BE49-F238E27FC236}">
-                <a16:creationId xmlns:a16="http://schemas.microsoft.com/office/drawing/2014/main" id="{967D6935-9AAD-4B93-A9C9-082DEE9E43FF}"/>
+                <a16:creationId xmlns:a16="http://schemas.microsoft.com/office/drawing/2014/main" id="{62DD62DF-86BF-4D26-A839-725289F2629C}"/>
               </a:ext>
             </a:extLst>
           </p:cNvPr>
@@ -10253,7 +10266,7 @@
           <p:cNvPr id="12" name="">
             <a:extLst xmlns:a="http://schemas.openxmlformats.org/drawingml/2006/main">
               <a:ext uri="{FF2B5EF4-FFF2-40B4-BE49-F238E27FC236}">
-                <a16:creationId xmlns:a16="http://schemas.microsoft.com/office/drawing/2014/main" id="{FB712B05-6C80-46F4-AA12-D5555E033D72}"/>
+                <a16:creationId xmlns:a16="http://schemas.microsoft.com/office/drawing/2014/main" id="{31A0BF31-E11F-4ED0-AD75-63023562BF40}"/>
               </a:ext>
             </a:extLst>
           </p:cNvPr>
@@ -10303,7 +10316,7 @@
           <p:cNvPr id="13" name="">
             <a:extLst xmlns:a="http://schemas.openxmlformats.org/drawingml/2006/main">
               <a:ext uri="{FF2B5EF4-FFF2-40B4-BE49-F238E27FC236}">
-                <a16:creationId xmlns:a16="http://schemas.microsoft.com/office/drawing/2014/main" id="{A5326EBC-5713-40F7-A8B7-036A23B9F5D1}"/>
+                <a16:creationId xmlns:a16="http://schemas.microsoft.com/office/drawing/2014/main" id="{D08CB647-5AB5-4AC7-A319-1CC5B7043619}"/>
               </a:ext>
             </a:extLst>
           </p:cNvPr>
@@ -10353,7 +10366,7 @@
           <p:cNvPr id="14" name="">
             <a:extLst xmlns:a="http://schemas.openxmlformats.org/drawingml/2006/main">
               <a:ext uri="{FF2B5EF4-FFF2-40B4-BE49-F238E27FC236}">
-                <a16:creationId xmlns:a16="http://schemas.microsoft.com/office/drawing/2014/main" id="{2E1CF418-9921-479E-B209-69E4AE35FBD6}"/>
+                <a16:creationId xmlns:a16="http://schemas.microsoft.com/office/drawing/2014/main" id="{13E62455-EE82-48E9-8FDD-96733EE38293}"/>
               </a:ext>
             </a:extLst>
           </p:cNvPr>
@@ -10403,7 +10416,7 @@
           <p:cNvPr id="15" name="">
             <a:extLst xmlns:a="http://schemas.openxmlformats.org/drawingml/2006/main">
               <a:ext uri="{FF2B5EF4-FFF2-40B4-BE49-F238E27FC236}">
-                <a16:creationId xmlns:a16="http://schemas.microsoft.com/office/drawing/2014/main" id="{B3A523CC-6191-4BE6-B5C6-7B1347B9B6F4}"/>
+                <a16:creationId xmlns:a16="http://schemas.microsoft.com/office/drawing/2014/main" id="{FED3D2D3-10F0-4912-888F-2896ACB5D743}"/>
               </a:ext>
             </a:extLst>
           </p:cNvPr>
@@ -10453,7 +10466,7 @@
           <p:cNvPr id="16" name="">
             <a:extLst xmlns:a="http://schemas.openxmlformats.org/drawingml/2006/main">
               <a:ext uri="{FF2B5EF4-FFF2-40B4-BE49-F238E27FC236}">
-                <a16:creationId xmlns:a16="http://schemas.microsoft.com/office/drawing/2014/main" id="{7FEA71C7-D096-4572-9FD9-3E7C765108A6}"/>
+                <a16:creationId xmlns:a16="http://schemas.microsoft.com/office/drawing/2014/main" id="{8DB892BF-0B58-429F-A601-179822528D6F}"/>
               </a:ext>
             </a:extLst>
           </p:cNvPr>
@@ -10484,7 +10497,7 @@
           <p:cNvPr id="17" name="">
             <a:extLst xmlns:a="http://schemas.openxmlformats.org/drawingml/2006/main">
               <a:ext uri="{FF2B5EF4-FFF2-40B4-BE49-F238E27FC236}">
-                <a16:creationId xmlns:a16="http://schemas.microsoft.com/office/drawing/2014/main" id="{00535BCD-7DF4-4675-99FE-75C187EFBC5E}"/>
+                <a16:creationId xmlns:a16="http://schemas.microsoft.com/office/drawing/2014/main" id="{07959E59-DFCF-4C46-A7EA-2562685B998B}"/>
               </a:ext>
             </a:extLst>
           </p:cNvPr>
@@ -10534,7 +10547,7 @@
           <p:cNvPr id="18" name="">
             <a:extLst xmlns:a="http://schemas.openxmlformats.org/drawingml/2006/main">
               <a:ext uri="{FF2B5EF4-FFF2-40B4-BE49-F238E27FC236}">
-                <a16:creationId xmlns:a16="http://schemas.microsoft.com/office/drawing/2014/main" id="{73172F3D-A1D5-4336-B5E0-2AF1D42022E6}"/>
+                <a16:creationId xmlns:a16="http://schemas.microsoft.com/office/drawing/2014/main" id="{84EF0B19-3E71-47D7-9822-534D6FF5C745}"/>
               </a:ext>
             </a:extLst>
           </p:cNvPr>
@@ -10584,7 +10597,7 @@
           <p:cNvPr id="19" name="">
             <a:extLst xmlns:a="http://schemas.openxmlformats.org/drawingml/2006/main">
               <a:ext uri="{FF2B5EF4-FFF2-40B4-BE49-F238E27FC236}">
-                <a16:creationId xmlns:a16="http://schemas.microsoft.com/office/drawing/2014/main" id="{2B1001A5-E667-4595-85FD-BEE8DB2985D1}"/>
+                <a16:creationId xmlns:a16="http://schemas.microsoft.com/office/drawing/2014/main" id="{153498F2-8CAD-4E7C-9776-434F8D3A9E1C}"/>
               </a:ext>
             </a:extLst>
           </p:cNvPr>
@@ -10634,7 +10647,7 @@
           <p:cNvPr id="20" name="">
             <a:extLst xmlns:a="http://schemas.openxmlformats.org/drawingml/2006/main">
               <a:ext uri="{FF2B5EF4-FFF2-40B4-BE49-F238E27FC236}">
-                <a16:creationId xmlns:a16="http://schemas.microsoft.com/office/drawing/2014/main" id="{B65EED74-8E9D-4ED3-8782-56ACAE32D97A}"/>
+                <a16:creationId xmlns:a16="http://schemas.microsoft.com/office/drawing/2014/main" id="{BDB912BD-0D0C-4B1D-9CCC-739D4C1D2065}"/>
               </a:ext>
             </a:extLst>
           </p:cNvPr>
@@ -10684,7 +10697,7 @@
           <p:cNvPr id="21" name="">
             <a:extLst xmlns:a="http://schemas.openxmlformats.org/drawingml/2006/main">
               <a:ext uri="{FF2B5EF4-FFF2-40B4-BE49-F238E27FC236}">
-                <a16:creationId xmlns:a16="http://schemas.microsoft.com/office/drawing/2014/main" id="{82D5079B-69C2-4FCD-8ACC-1360C35113D2}"/>
+                <a16:creationId xmlns:a16="http://schemas.microsoft.com/office/drawing/2014/main" id="{A7E38BFE-31C6-4F73-AAF7-5B77F5E45333}"/>
               </a:ext>
             </a:extLst>
           </p:cNvPr>
@@ -10734,7 +10747,7 @@
           <p:cNvPr id="22" name="">
             <a:extLst xmlns:a="http://schemas.openxmlformats.org/drawingml/2006/main">
               <a:ext uri="{FF2B5EF4-FFF2-40B4-BE49-F238E27FC236}">
-                <a16:creationId xmlns:a16="http://schemas.microsoft.com/office/drawing/2014/main" id="{A3776426-2DA5-41A0-994B-079248DE09B3}"/>
+                <a16:creationId xmlns:a16="http://schemas.microsoft.com/office/drawing/2014/main" id="{1507BBB7-B802-4F0A-875B-9653C5AFDF92}"/>
               </a:ext>
             </a:extLst>
           </p:cNvPr>
@@ -10784,7 +10797,7 @@
           <p:cNvPr id="23" name="">
             <a:extLst xmlns:a="http://schemas.openxmlformats.org/drawingml/2006/main">
               <a:ext uri="{FF2B5EF4-FFF2-40B4-BE49-F238E27FC236}">
-                <a16:creationId xmlns:a16="http://schemas.microsoft.com/office/drawing/2014/main" id="{4117E49B-6BEC-44F1-A6B9-A547CBBDBA9A}"/>
+                <a16:creationId xmlns:a16="http://schemas.microsoft.com/office/drawing/2014/main" id="{A2A75908-48BA-4932-B739-99875C369D63}"/>
               </a:ext>
             </a:extLst>
           </p:cNvPr>
@@ -10834,7 +10847,7 @@
           <p:cNvPr id="24" name="">
             <a:extLst xmlns:a="http://schemas.openxmlformats.org/drawingml/2006/main">
               <a:ext uri="{FF2B5EF4-FFF2-40B4-BE49-F238E27FC236}">
-                <a16:creationId xmlns:a16="http://schemas.microsoft.com/office/drawing/2014/main" id="{60B6376B-80A7-4A78-BB98-9A55697652E8}"/>
+                <a16:creationId xmlns:a16="http://schemas.microsoft.com/office/drawing/2014/main" id="{E29C3EA7-3743-463B-BFD3-2BA50B821B97}"/>
               </a:ext>
             </a:extLst>
           </p:cNvPr>
@@ -10884,7 +10897,7 @@
           <p:cNvPr id="25" name="">
             <a:extLst xmlns:a="http://schemas.openxmlformats.org/drawingml/2006/main">
               <a:ext uri="{FF2B5EF4-FFF2-40B4-BE49-F238E27FC236}">
-                <a16:creationId xmlns:a16="http://schemas.microsoft.com/office/drawing/2014/main" id="{E9E4C233-7CCC-4D0F-8E98-3DBD07679E17}"/>
+                <a16:creationId xmlns:a16="http://schemas.microsoft.com/office/drawing/2014/main" id="{89E4D386-DE57-40B5-9633-67F89B0D1526}"/>
               </a:ext>
             </a:extLst>
           </p:cNvPr>
@@ -10934,7 +10947,7 @@
           <p:cNvPr id="26" name="">
             <a:extLst xmlns:a="http://schemas.openxmlformats.org/drawingml/2006/main">
               <a:ext uri="{FF2B5EF4-FFF2-40B4-BE49-F238E27FC236}">
-                <a16:creationId xmlns:a16="http://schemas.microsoft.com/office/drawing/2014/main" id="{F3C7EABC-B939-491E-8F1E-4A49EAA6F396}"/>
+                <a16:creationId xmlns:a16="http://schemas.microsoft.com/office/drawing/2014/main" id="{425C632A-6B2D-4DEC-AB60-1C950FC7A7B4}"/>
               </a:ext>
             </a:extLst>
           </p:cNvPr>
@@ -10984,7 +10997,7 @@
           <p:cNvPr id="27" name="">
             <a:extLst xmlns:a="http://schemas.openxmlformats.org/drawingml/2006/main">
               <a:ext uri="{FF2B5EF4-FFF2-40B4-BE49-F238E27FC236}">
-                <a16:creationId xmlns:a16="http://schemas.microsoft.com/office/drawing/2014/main" id="{99AC39A7-D7D7-472C-8033-ECC2ECC6BA9A}"/>
+                <a16:creationId xmlns:a16="http://schemas.microsoft.com/office/drawing/2014/main" id="{A9B64EE2-AB44-4C12-B18F-CEAF707D199D}"/>
               </a:ext>
             </a:extLst>
           </p:cNvPr>
@@ -11032,7 +11045,7 @@
     </p:spTree>
     <p:extLst>
       <p:ext uri="{BB962C8B-B14F-4D97-AF65-F5344CB8AC3E}">
-        <p14:creationId xmlns:p14="http://schemas.microsoft.com/office/powerpoint/2010/main" val="1913178099"/>
+        <p14:creationId xmlns:p14="http://schemas.microsoft.com/office/powerpoint/2010/main" val="1939932171"/>
       </p:ext>
     </p:extLst>
   </p:cSld>
@@ -11060,10 +11073,10 @@
       </p:grpSpPr>
       <p:sp>
         <p:nvSpPr>
-          <p:cNvPr id="23" name="">
-            <a:extLst xmlns:a="http://schemas.openxmlformats.org/drawingml/2006/main">
-              <a:ext uri="{FF2B5EF4-FFF2-40B4-BE49-F238E27FC236}">
-                <a16:creationId xmlns:a16="http://schemas.microsoft.com/office/drawing/2014/main" id="{00BF0C20-1760-406F-B653-9E516E7AF566}"/>
+          <p:cNvPr id="26" name="">
+            <a:extLst xmlns:a="http://schemas.openxmlformats.org/drawingml/2006/main">
+              <a:ext uri="{FF2B5EF4-FFF2-40B4-BE49-F238E27FC236}">
+                <a16:creationId xmlns:a16="http://schemas.microsoft.com/office/drawing/2014/main" id="{567F48D1-10B4-491D-8F2D-56C117D7FD83}"/>
               </a:ext>
             </a:extLst>
           </p:cNvPr>
@@ -11103,7 +11116,7 @@
                   <a:srgbClr val="B9DFD2"/>
                 </a:solidFill>
               </a:rPr>
-              <a:t>SEPARATE FORWARD SCORE</a:t>
+              <a:t>FIRST SESSION / CLOSING-BELL SCORE</a:t>
             </a:r>
           </a:p>
         </p:txBody>
@@ -11113,7 +11126,7 @@
           <p:cNvPr id="2" name="">
             <a:extLst xmlns:a="http://schemas.openxmlformats.org/drawingml/2006/main">
               <a:ext uri="{FF2B5EF4-FFF2-40B4-BE49-F238E27FC236}">
-                <a16:creationId xmlns:a16="http://schemas.microsoft.com/office/drawing/2014/main" id="{733066A6-38AA-4F24-9254-1BB1317181B3}"/>
+                <a16:creationId xmlns:a16="http://schemas.microsoft.com/office/drawing/2014/main" id="{D3FF4FE9-F301-453F-A730-67B4437E8D0D}"/>
               </a:ext>
             </a:extLst>
           </p:cNvPr>
@@ -11153,7 +11166,7 @@
                   <a:srgbClr val="FFFFFF"/>
                 </a:solidFill>
               </a:rPr>
-              <a:t>A human froze the allocation; the $100,000 account supplies the forward score.</a:t>
+              <a:t>Finly closed its first session $153.31 ahead of SPY.</a:t>
             </a:r>
           </a:p>
         </p:txBody>
@@ -11163,23 +11176,23 @@
           <p:cNvPr id="3" name="">
             <a:extLst xmlns:a="http://schemas.openxmlformats.org/drawingml/2006/main">
               <a:ext uri="{FF2B5EF4-FFF2-40B4-BE49-F238E27FC236}">
-                <a16:creationId xmlns:a16="http://schemas.microsoft.com/office/drawing/2014/main" id="{E90A3392-FA7A-4F0E-924C-5E827E8886D5}"/>
-              </a:ext>
-            </a:extLst>
-          </p:cNvPr>
-          <p:cNvSpPr>
-            <a:spLocks xmlns:a="http://schemas.openxmlformats.org/drawingml/2006/main" noGrp="1"/>
-          </p:cNvSpPr>
-          <p:nvPr/>
-        </p:nvSpPr>
-        <p:spPr>
-          <a:xfrm xmlns:a="http://schemas.openxmlformats.org/drawingml/2006/main">
-            <a:off x="561975" y="1990725"/>
-            <a:ext cx="7200900" cy="4076700"/>
+                <a16:creationId xmlns:a16="http://schemas.microsoft.com/office/drawing/2014/main" id="{BCBEF9D2-33B7-4C4F-9B02-A90C544330EB}"/>
+              </a:ext>
+            </a:extLst>
+          </p:cNvPr>
+          <p:cNvSpPr>
+            <a:spLocks xmlns:a="http://schemas.openxmlformats.org/drawingml/2006/main" noGrp="1"/>
+          </p:cNvSpPr>
+          <p:nvPr/>
+        </p:nvSpPr>
+        <p:spPr>
+          <a:xfrm xmlns:a="http://schemas.openxmlformats.org/drawingml/2006/main">
+            <a:off x="561975" y="2143125"/>
+            <a:ext cx="7200900" cy="2762250"/>
           </a:xfrm>
           <a:prstGeom xmlns:a="http://schemas.openxmlformats.org/drawingml/2006/main" prst="roundRect">
             <a:avLst>
-              <a:gd name="adj" fmla="val 2804"/>
+              <a:gd name="adj" fmla="val 4138"/>
             </a:avLst>
           </a:prstGeom>
           <a:solidFill xmlns:a="http://schemas.openxmlformats.org/drawingml/2006/main">
@@ -11201,27 +11214,24 @@
       </p:sp>
       <p:pic>
         <p:nvPicPr>
-          <p:cNvPr id="26" name=""/>
+          <p:cNvPr id="29" name=""/>
           <p:cNvPicPr>
             <a:picLocks xmlns:a="http://schemas.openxmlformats.org/drawingml/2006/main" noChangeAspect="1"/>
           </p:cNvPicPr>
           <p:nvPr/>
         </p:nvPicPr>
         <p:blipFill>
-          <a:blip xmlns:r="http://schemas.openxmlformats.org/officeDocument/2006/relationships" xmlns:a="http://schemas.openxmlformats.org/drawingml/2006/main" r:embed="R08708c6f2b1c42ef"/>
-          <a:srcRect xmlns:a="http://schemas.openxmlformats.org/drawingml/2006/main" l="0" t="194" r="0" b="194"/>
-          <a:stretch xmlns:a="http://schemas.openxmlformats.org/drawingml/2006/main">
-            <a:fillRect l="0" t="0" r="0" b="0"/>
-          </a:stretch>
+          <a:blip xmlns:r="http://schemas.openxmlformats.org/officeDocument/2006/relationships" xmlns:a="http://schemas.openxmlformats.org/drawingml/2006/main" r:embed="R0af1aeaac63e4d84"/>
+          <a:stretch xmlns:a="http://schemas.openxmlformats.org/drawingml/2006/main"/>
         </p:blipFill>
         <p:spPr>
           <a:xfrm xmlns:a="http://schemas.openxmlformats.org/drawingml/2006/main">
-            <a:off x="609600" y="2038350"/>
-            <a:ext cx="7105650" cy="3981450"/>
+            <a:off x="609600" y="2191941"/>
+            <a:ext cx="7105650" cy="2664619"/>
           </a:xfrm>
           <a:prstGeom xmlns:a="http://schemas.openxmlformats.org/drawingml/2006/main" prst="roundRect">
             <a:avLst>
-              <a:gd name="adj" fmla="val 1914"/>
+              <a:gd name="adj" fmla="val 2857"/>
             </a:avLst>
           </a:prstGeom>
         </p:spPr>
@@ -11231,7 +11241,138 @@
           <p:cNvPr id="5" name="">
             <a:extLst xmlns:a="http://schemas.openxmlformats.org/drawingml/2006/main">
               <a:ext uri="{FF2B5EF4-FFF2-40B4-BE49-F238E27FC236}">
-                <a16:creationId xmlns:a16="http://schemas.microsoft.com/office/drawing/2014/main" id="{73F7C3DE-91A9-4719-9D32-0CE03FC8EEE0}"/>
+                <a16:creationId xmlns:a16="http://schemas.microsoft.com/office/drawing/2014/main" id="{6DD4897A-DCF4-42EA-9F66-AD790254078A}"/>
+              </a:ext>
+            </a:extLst>
+          </p:cNvPr>
+          <p:cNvSpPr>
+            <a:spLocks xmlns:a="http://schemas.openxmlformats.org/drawingml/2006/main" noGrp="1"/>
+          </p:cNvSpPr>
+          <p:nvPr/>
+        </p:nvSpPr>
+        <p:spPr>
+          <a:xfrm xmlns:a="http://schemas.openxmlformats.org/drawingml/2006/main">
+            <a:off x="609600" y="5219700"/>
+            <a:ext cx="7105650" cy="19050"/>
+          </a:xfrm>
+          <a:prstGeom xmlns:a="http://schemas.openxmlformats.org/drawingml/2006/main" prst="rect">
+            <a:avLst/>
+          </a:prstGeom>
+          <a:solidFill xmlns:a="http://schemas.openxmlformats.org/drawingml/2006/main">
+            <a:srgbClr val="2F7D68"/>
+          </a:solidFill>
+          <a:ln xmlns:a="http://schemas.openxmlformats.org/drawingml/2006/main" w="0">
+            <a:noFill/>
+            <a:prstDash val="solid"/>
+          </a:ln>
+        </p:spPr>
+      </p:sp>
+      <p:sp>
+        <p:nvSpPr>
+          <p:cNvPr id="6" name="">
+            <a:extLst xmlns:a="http://schemas.openxmlformats.org/drawingml/2006/main">
+              <a:ext uri="{FF2B5EF4-FFF2-40B4-BE49-F238E27FC236}">
+                <a16:creationId xmlns:a16="http://schemas.microsoft.com/office/drawing/2014/main" id="{2C6B65FF-B4CA-4977-BDC0-80DE0B417585}"/>
+              </a:ext>
+            </a:extLst>
+          </p:cNvPr>
+          <p:cNvSpPr>
+            <a:spLocks xmlns:a="http://schemas.openxmlformats.org/drawingml/2006/main" noGrp="1"/>
+          </p:cNvSpPr>
+          <p:nvPr/>
+        </p:nvSpPr>
+        <p:spPr>
+          <a:xfrm xmlns:a="http://schemas.openxmlformats.org/drawingml/2006/main">
+            <a:off x="609600" y="5410200"/>
+            <a:ext cx="7105650" cy="285750"/>
+          </a:xfrm>
+          <a:prstGeom xmlns:a="http://schemas.openxmlformats.org/drawingml/2006/main" prst="rect">
+            <a:avLst/>
+          </a:prstGeom>
+          <a:noFill xmlns:a="http://schemas.openxmlformats.org/drawingml/2006/main"/>
+          <a:ln xmlns:a="http://schemas.openxmlformats.org/drawingml/2006/main" w="0">
+            <a:noFill/>
+            <a:prstDash val="solid"/>
+          </a:ln>
+        </p:spPr>
+        <p:txBody>
+          <a:bodyPr xmlns:a="http://schemas.openxmlformats.org/drawingml/2006/main"/>
+          <a:lstStyle xmlns:a="http://schemas.openxmlformats.org/drawingml/2006/main"/>
+          <a:p xmlns:a="http://schemas.openxmlformats.org/drawingml/2006/main">
+            <a:pPr algn="l">
+              <a:defRPr sz="1650" b="1" i="0">
+                <a:solidFill>
+                  <a:srgbClr val="B9DFD2"/>
+                </a:solidFill>
+              </a:defRPr>
+            </a:pPr>
+            <a:r>
+              <a:rPr sz="1650" b="1" i="0">
+                <a:solidFill>
+                  <a:srgbClr val="B9DFD2"/>
+                </a:solidFill>
+              </a:rPr>
+              <a:t>One receipt, one baseline, one timestamp.</a:t>
+            </a:r>
+          </a:p>
+        </p:txBody>
+      </p:sp>
+      <p:sp>
+        <p:nvSpPr>
+          <p:cNvPr id="7" name="">
+            <a:extLst xmlns:a="http://schemas.openxmlformats.org/drawingml/2006/main">
+              <a:ext uri="{FF2B5EF4-FFF2-40B4-BE49-F238E27FC236}">
+                <a16:creationId xmlns:a16="http://schemas.microsoft.com/office/drawing/2014/main" id="{23422B39-49C9-4E5F-A074-2375D399674F}"/>
+              </a:ext>
+            </a:extLst>
+          </p:cNvPr>
+          <p:cNvSpPr>
+            <a:spLocks xmlns:a="http://schemas.openxmlformats.org/drawingml/2006/main" noGrp="1"/>
+          </p:cNvSpPr>
+          <p:nvPr/>
+        </p:nvSpPr>
+        <p:spPr>
+          <a:xfrm xmlns:a="http://schemas.openxmlformats.org/drawingml/2006/main">
+            <a:off x="609600" y="5772150"/>
+            <a:ext cx="7105650" cy="438150"/>
+          </a:xfrm>
+          <a:prstGeom xmlns:a="http://schemas.openxmlformats.org/drawingml/2006/main" prst="rect">
+            <a:avLst/>
+          </a:prstGeom>
+          <a:noFill xmlns:a="http://schemas.openxmlformats.org/drawingml/2006/main"/>
+          <a:ln xmlns:a="http://schemas.openxmlformats.org/drawingml/2006/main" w="0">
+            <a:noFill/>
+            <a:prstDash val="solid"/>
+          </a:ln>
+        </p:spPr>
+        <p:txBody>
+          <a:bodyPr xmlns:a="http://schemas.openxmlformats.org/drawingml/2006/main"/>
+          <a:lstStyle xmlns:a="http://schemas.openxmlformats.org/drawingml/2006/main"/>
+          <a:p xmlns:a="http://schemas.openxmlformats.org/drawingml/2006/main">
+            <a:pPr algn="l">
+              <a:defRPr sz="1425" b="0" i="0">
+                <a:solidFill>
+                  <a:srgbClr val="FFFFFF"/>
+                </a:solidFill>
+              </a:defRPr>
+            </a:pPr>
+            <a:r>
+              <a:rPr sz="1425" b="0" i="0">
+                <a:solidFill>
+                  <a:srgbClr val="FFFFFF"/>
+                </a:solidFill>
+              </a:rPr>
+              <a:t>The public evidence file reconciles 15 broker fills and zero external cashflows.</a:t>
+            </a:r>
+          </a:p>
+        </p:txBody>
+      </p:sp>
+      <p:sp>
+        <p:nvSpPr>
+          <p:cNvPr id="8" name="">
+            <a:extLst xmlns:a="http://schemas.openxmlformats.org/drawingml/2006/main">
+              <a:ext uri="{FF2B5EF4-FFF2-40B4-BE49-F238E27FC236}">
+                <a16:creationId xmlns:a16="http://schemas.microsoft.com/office/drawing/2014/main" id="{471D53E9-2166-493F-B559-E3FED64C64D6}"/>
               </a:ext>
             </a:extLst>
           </p:cNvPr>
@@ -11243,6 +11384,430 @@
         <p:spPr>
           <a:xfrm xmlns:a="http://schemas.openxmlformats.org/drawingml/2006/main">
             <a:off x="8172450" y="2152650"/>
+            <a:ext cx="514350" cy="514350"/>
+          </a:xfrm>
+          <a:prstGeom xmlns:a="http://schemas.openxmlformats.org/drawingml/2006/main" prst="ellipse">
+            <a:avLst/>
+          </a:prstGeom>
+          <a:solidFill xmlns:a="http://schemas.openxmlformats.org/drawingml/2006/main">
+            <a:srgbClr val="B9DFD2"/>
+          </a:solidFill>
+          <a:ln xmlns:a="http://schemas.openxmlformats.org/drawingml/2006/main" w="0">
+            <a:noFill/>
+            <a:prstDash val="solid"/>
+          </a:ln>
+        </p:spPr>
+      </p:sp>
+      <p:sp>
+        <p:nvSpPr>
+          <p:cNvPr id="9" name="">
+            <a:extLst xmlns:a="http://schemas.openxmlformats.org/drawingml/2006/main">
+              <a:ext uri="{FF2B5EF4-FFF2-40B4-BE49-F238E27FC236}">
+                <a16:creationId xmlns:a16="http://schemas.microsoft.com/office/drawing/2014/main" id="{DB898D8A-75DB-47FC-811D-1F8FC9367B30}"/>
+              </a:ext>
+            </a:extLst>
+          </p:cNvPr>
+          <p:cNvSpPr>
+            <a:spLocks xmlns:a="http://schemas.openxmlformats.org/drawingml/2006/main" noGrp="1"/>
+          </p:cNvSpPr>
+          <p:nvPr/>
+        </p:nvSpPr>
+        <p:spPr>
+          <a:xfrm xmlns:a="http://schemas.openxmlformats.org/drawingml/2006/main">
+            <a:off x="8296275" y="2238375"/>
+            <a:ext cx="266700" cy="285750"/>
+          </a:xfrm>
+          <a:prstGeom xmlns:a="http://schemas.openxmlformats.org/drawingml/2006/main" prst="rect">
+            <a:avLst/>
+          </a:prstGeom>
+          <a:noFill xmlns:a="http://schemas.openxmlformats.org/drawingml/2006/main"/>
+          <a:ln xmlns:a="http://schemas.openxmlformats.org/drawingml/2006/main" w="0">
+            <a:noFill/>
+            <a:prstDash val="solid"/>
+          </a:ln>
+        </p:spPr>
+        <p:txBody>
+          <a:bodyPr xmlns:a="http://schemas.openxmlformats.org/drawingml/2006/main"/>
+          <a:lstStyle xmlns:a="http://schemas.openxmlformats.org/drawingml/2006/main"/>
+          <a:p xmlns:a="http://schemas.openxmlformats.org/drawingml/2006/main">
+            <a:pPr algn="ctr">
+              <a:defRPr sz="1650" b="1" i="0">
+                <a:solidFill>
+                  <a:srgbClr val="0B2942"/>
+                </a:solidFill>
+              </a:defRPr>
+            </a:pPr>
+            <a:r>
+              <a:rPr sz="1650" b="1" i="0">
+                <a:solidFill>
+                  <a:srgbClr val="0B2942"/>
+                </a:solidFill>
+              </a:rPr>
+              <a:t>1</a:t>
+            </a:r>
+          </a:p>
+        </p:txBody>
+      </p:sp>
+      <p:sp>
+        <p:nvSpPr>
+          <p:cNvPr id="10" name="">
+            <a:extLst xmlns:a="http://schemas.openxmlformats.org/drawingml/2006/main">
+              <a:ext uri="{FF2B5EF4-FFF2-40B4-BE49-F238E27FC236}">
+                <a16:creationId xmlns:a16="http://schemas.microsoft.com/office/drawing/2014/main" id="{52AE4D0D-11FA-415B-8697-3709E416C805}"/>
+              </a:ext>
+            </a:extLst>
+          </p:cNvPr>
+          <p:cNvSpPr>
+            <a:spLocks xmlns:a="http://schemas.openxmlformats.org/drawingml/2006/main" noGrp="1"/>
+          </p:cNvSpPr>
+          <p:nvPr/>
+        </p:nvSpPr>
+        <p:spPr>
+          <a:xfrm xmlns:a="http://schemas.openxmlformats.org/drawingml/2006/main">
+            <a:off x="8877300" y="2133600"/>
+            <a:ext cx="2000250" cy="247650"/>
+          </a:xfrm>
+          <a:prstGeom xmlns:a="http://schemas.openxmlformats.org/drawingml/2006/main" prst="rect">
+            <a:avLst/>
+          </a:prstGeom>
+          <a:noFill xmlns:a="http://schemas.openxmlformats.org/drawingml/2006/main"/>
+          <a:ln xmlns:a="http://schemas.openxmlformats.org/drawingml/2006/main" w="0">
+            <a:noFill/>
+            <a:prstDash val="solid"/>
+          </a:ln>
+        </p:spPr>
+        <p:txBody>
+          <a:bodyPr xmlns:a="http://schemas.openxmlformats.org/drawingml/2006/main"/>
+          <a:lstStyle xmlns:a="http://schemas.openxmlformats.org/drawingml/2006/main"/>
+          <a:p xmlns:a="http://schemas.openxmlformats.org/drawingml/2006/main">
+            <a:pPr algn="l">
+              <a:defRPr sz="1125" b="1" i="0">
+                <a:solidFill>
+                  <a:srgbClr val="B9DFD2"/>
+                </a:solidFill>
+              </a:defRPr>
+            </a:pPr>
+            <a:r>
+              <a:rPr sz="1125" b="1" i="0">
+                <a:solidFill>
+                  <a:srgbClr val="B9DFD2"/>
+                </a:solidFill>
+              </a:rPr>
+              <a:t>FINLY</a:t>
+            </a:r>
+          </a:p>
+        </p:txBody>
+      </p:sp>
+      <p:sp>
+        <p:nvSpPr>
+          <p:cNvPr id="11" name="">
+            <a:extLst xmlns:a="http://schemas.openxmlformats.org/drawingml/2006/main">
+              <a:ext uri="{FF2B5EF4-FFF2-40B4-BE49-F238E27FC236}">
+                <a16:creationId xmlns:a16="http://schemas.microsoft.com/office/drawing/2014/main" id="{8E8C1C36-F24A-4C8B-A05D-DB169C3AF93B}"/>
+              </a:ext>
+            </a:extLst>
+          </p:cNvPr>
+          <p:cNvSpPr>
+            <a:spLocks xmlns:a="http://schemas.openxmlformats.org/drawingml/2006/main" noGrp="1"/>
+          </p:cNvSpPr>
+          <p:nvPr/>
+        </p:nvSpPr>
+        <p:spPr>
+          <a:xfrm xmlns:a="http://schemas.openxmlformats.org/drawingml/2006/main">
+            <a:off x="8877300" y="2419350"/>
+            <a:ext cx="2571750" cy="400050"/>
+          </a:xfrm>
+          <a:prstGeom xmlns:a="http://schemas.openxmlformats.org/drawingml/2006/main" prst="rect">
+            <a:avLst/>
+          </a:prstGeom>
+          <a:noFill xmlns:a="http://schemas.openxmlformats.org/drawingml/2006/main"/>
+          <a:ln xmlns:a="http://schemas.openxmlformats.org/drawingml/2006/main" w="0">
+            <a:noFill/>
+            <a:prstDash val="solid"/>
+          </a:ln>
+        </p:spPr>
+        <p:txBody>
+          <a:bodyPr xmlns:a="http://schemas.openxmlformats.org/drawingml/2006/main"/>
+          <a:lstStyle xmlns:a="http://schemas.openxmlformats.org/drawingml/2006/main"/>
+          <a:p xmlns:a="http://schemas.openxmlformats.org/drawingml/2006/main">
+            <a:pPr algn="l">
+              <a:defRPr sz="1875" b="1" i="0">
+                <a:solidFill>
+                  <a:srgbClr val="FFFFFF"/>
+                </a:solidFill>
+              </a:defRPr>
+            </a:pPr>
+            <a:r>
+              <a:rPr sz="1875" b="1" i="0">
+                <a:solidFill>
+                  <a:srgbClr val="FFFFFF"/>
+                </a:solidFill>
+              </a:rPr>
+              <a:t>+$95.32</a:t>
+            </a:r>
+          </a:p>
+        </p:txBody>
+      </p:sp>
+      <p:sp>
+        <p:nvSpPr>
+          <p:cNvPr id="12" name="">
+            <a:extLst xmlns:a="http://schemas.openxmlformats.org/drawingml/2006/main">
+              <a:ext uri="{FF2B5EF4-FFF2-40B4-BE49-F238E27FC236}">
+                <a16:creationId xmlns:a16="http://schemas.microsoft.com/office/drawing/2014/main" id="{FB373BB0-D2D7-40AB-B3EA-42BCD3B964F2}"/>
+              </a:ext>
+            </a:extLst>
+          </p:cNvPr>
+          <p:cNvSpPr>
+            <a:spLocks xmlns:a="http://schemas.openxmlformats.org/drawingml/2006/main" noGrp="1"/>
+          </p:cNvSpPr>
+          <p:nvPr/>
+        </p:nvSpPr>
+        <p:spPr>
+          <a:xfrm xmlns:a="http://schemas.openxmlformats.org/drawingml/2006/main">
+            <a:off x="8410575" y="2743200"/>
+            <a:ext cx="28575" cy="457200"/>
+          </a:xfrm>
+          <a:prstGeom xmlns:a="http://schemas.openxmlformats.org/drawingml/2006/main" prst="rect">
+            <a:avLst/>
+          </a:prstGeom>
+          <a:solidFill xmlns:a="http://schemas.openxmlformats.org/drawingml/2006/main">
+            <a:srgbClr val="527187"/>
+          </a:solidFill>
+          <a:ln xmlns:a="http://schemas.openxmlformats.org/drawingml/2006/main" w="0">
+            <a:noFill/>
+            <a:prstDash val="solid"/>
+          </a:ln>
+        </p:spPr>
+      </p:sp>
+      <p:sp>
+        <p:nvSpPr>
+          <p:cNvPr id="13" name="">
+            <a:extLst xmlns:a="http://schemas.openxmlformats.org/drawingml/2006/main">
+              <a:ext uri="{FF2B5EF4-FFF2-40B4-BE49-F238E27FC236}">
+                <a16:creationId xmlns:a16="http://schemas.microsoft.com/office/drawing/2014/main" id="{12DEDF6E-D5EB-47FF-AEB7-A2B5E66D5E02}"/>
+              </a:ext>
+            </a:extLst>
+          </p:cNvPr>
+          <p:cNvSpPr>
+            <a:spLocks xmlns:a="http://schemas.openxmlformats.org/drawingml/2006/main" noGrp="1"/>
+          </p:cNvSpPr>
+          <p:nvPr/>
+        </p:nvSpPr>
+        <p:spPr>
+          <a:xfrm xmlns:a="http://schemas.openxmlformats.org/drawingml/2006/main">
+            <a:off x="8172450" y="3276600"/>
+            <a:ext cx="514350" cy="514350"/>
+          </a:xfrm>
+          <a:prstGeom xmlns:a="http://schemas.openxmlformats.org/drawingml/2006/main" prst="ellipse">
+            <a:avLst/>
+          </a:prstGeom>
+          <a:solidFill xmlns:a="http://schemas.openxmlformats.org/drawingml/2006/main">
+            <a:srgbClr val="E56B5D"/>
+          </a:solidFill>
+          <a:ln xmlns:a="http://schemas.openxmlformats.org/drawingml/2006/main" w="0">
+            <a:noFill/>
+            <a:prstDash val="solid"/>
+          </a:ln>
+        </p:spPr>
+      </p:sp>
+      <p:sp>
+        <p:nvSpPr>
+          <p:cNvPr id="14" name="">
+            <a:extLst xmlns:a="http://schemas.openxmlformats.org/drawingml/2006/main">
+              <a:ext uri="{FF2B5EF4-FFF2-40B4-BE49-F238E27FC236}">
+                <a16:creationId xmlns:a16="http://schemas.microsoft.com/office/drawing/2014/main" id="{D894DBCD-0A4B-49CA-B73F-72F6FC9E264D}"/>
+              </a:ext>
+            </a:extLst>
+          </p:cNvPr>
+          <p:cNvSpPr>
+            <a:spLocks xmlns:a="http://schemas.openxmlformats.org/drawingml/2006/main" noGrp="1"/>
+          </p:cNvSpPr>
+          <p:nvPr/>
+        </p:nvSpPr>
+        <p:spPr>
+          <a:xfrm xmlns:a="http://schemas.openxmlformats.org/drawingml/2006/main">
+            <a:off x="8296275" y="3362325"/>
+            <a:ext cx="266700" cy="285750"/>
+          </a:xfrm>
+          <a:prstGeom xmlns:a="http://schemas.openxmlformats.org/drawingml/2006/main" prst="rect">
+            <a:avLst/>
+          </a:prstGeom>
+          <a:noFill xmlns:a="http://schemas.openxmlformats.org/drawingml/2006/main"/>
+          <a:ln xmlns:a="http://schemas.openxmlformats.org/drawingml/2006/main" w="0">
+            <a:noFill/>
+            <a:prstDash val="solid"/>
+          </a:ln>
+        </p:spPr>
+        <p:txBody>
+          <a:bodyPr xmlns:a="http://schemas.openxmlformats.org/drawingml/2006/main"/>
+          <a:lstStyle xmlns:a="http://schemas.openxmlformats.org/drawingml/2006/main"/>
+          <a:p xmlns:a="http://schemas.openxmlformats.org/drawingml/2006/main">
+            <a:pPr algn="ctr">
+              <a:defRPr sz="1650" b="1" i="0">
+                <a:solidFill>
+                  <a:srgbClr val="0B2942"/>
+                </a:solidFill>
+              </a:defRPr>
+            </a:pPr>
+            <a:r>
+              <a:rPr sz="1650" b="1" i="0">
+                <a:solidFill>
+                  <a:srgbClr val="0B2942"/>
+                </a:solidFill>
+              </a:rPr>
+              <a:t>2</a:t>
+            </a:r>
+          </a:p>
+        </p:txBody>
+      </p:sp>
+      <p:sp>
+        <p:nvSpPr>
+          <p:cNvPr id="15" name="">
+            <a:extLst xmlns:a="http://schemas.openxmlformats.org/drawingml/2006/main">
+              <a:ext uri="{FF2B5EF4-FFF2-40B4-BE49-F238E27FC236}">
+                <a16:creationId xmlns:a16="http://schemas.microsoft.com/office/drawing/2014/main" id="{DFBA6043-9FC0-47F8-9F9D-EA9B4A30D57F}"/>
+              </a:ext>
+            </a:extLst>
+          </p:cNvPr>
+          <p:cNvSpPr>
+            <a:spLocks xmlns:a="http://schemas.openxmlformats.org/drawingml/2006/main" noGrp="1"/>
+          </p:cNvSpPr>
+          <p:nvPr/>
+        </p:nvSpPr>
+        <p:spPr>
+          <a:xfrm xmlns:a="http://schemas.openxmlformats.org/drawingml/2006/main">
+            <a:off x="8877300" y="3257550"/>
+            <a:ext cx="2000250" cy="247650"/>
+          </a:xfrm>
+          <a:prstGeom xmlns:a="http://schemas.openxmlformats.org/drawingml/2006/main" prst="rect">
+            <a:avLst/>
+          </a:prstGeom>
+          <a:noFill xmlns:a="http://schemas.openxmlformats.org/drawingml/2006/main"/>
+          <a:ln xmlns:a="http://schemas.openxmlformats.org/drawingml/2006/main" w="0">
+            <a:noFill/>
+            <a:prstDash val="solid"/>
+          </a:ln>
+        </p:spPr>
+        <p:txBody>
+          <a:bodyPr xmlns:a="http://schemas.openxmlformats.org/drawingml/2006/main"/>
+          <a:lstStyle xmlns:a="http://schemas.openxmlformats.org/drawingml/2006/main"/>
+          <a:p xmlns:a="http://schemas.openxmlformats.org/drawingml/2006/main">
+            <a:pPr algn="l">
+              <a:defRPr sz="1125" b="1" i="0">
+                <a:solidFill>
+                  <a:srgbClr val="E56B5D"/>
+                </a:solidFill>
+              </a:defRPr>
+            </a:pPr>
+            <a:r>
+              <a:rPr sz="1125" b="1" i="0">
+                <a:solidFill>
+                  <a:srgbClr val="E56B5D"/>
+                </a:solidFill>
+              </a:rPr>
+              <a:t>SPY</a:t>
+            </a:r>
+          </a:p>
+        </p:txBody>
+      </p:sp>
+      <p:sp>
+        <p:nvSpPr>
+          <p:cNvPr id="16" name="">
+            <a:extLst xmlns:a="http://schemas.openxmlformats.org/drawingml/2006/main">
+              <a:ext uri="{FF2B5EF4-FFF2-40B4-BE49-F238E27FC236}">
+                <a16:creationId xmlns:a16="http://schemas.microsoft.com/office/drawing/2014/main" id="{60F826F4-8A15-4E40-B6E6-FD333FFD087F}"/>
+              </a:ext>
+            </a:extLst>
+          </p:cNvPr>
+          <p:cNvSpPr>
+            <a:spLocks xmlns:a="http://schemas.openxmlformats.org/drawingml/2006/main" noGrp="1"/>
+          </p:cNvSpPr>
+          <p:nvPr/>
+        </p:nvSpPr>
+        <p:spPr>
+          <a:xfrm xmlns:a="http://schemas.openxmlformats.org/drawingml/2006/main">
+            <a:off x="8877300" y="3543300"/>
+            <a:ext cx="2571750" cy="400050"/>
+          </a:xfrm>
+          <a:prstGeom xmlns:a="http://schemas.openxmlformats.org/drawingml/2006/main" prst="rect">
+            <a:avLst/>
+          </a:prstGeom>
+          <a:noFill xmlns:a="http://schemas.openxmlformats.org/drawingml/2006/main"/>
+          <a:ln xmlns:a="http://schemas.openxmlformats.org/drawingml/2006/main" w="0">
+            <a:noFill/>
+            <a:prstDash val="solid"/>
+          </a:ln>
+        </p:spPr>
+        <p:txBody>
+          <a:bodyPr xmlns:a="http://schemas.openxmlformats.org/drawingml/2006/main"/>
+          <a:lstStyle xmlns:a="http://schemas.openxmlformats.org/drawingml/2006/main"/>
+          <a:p xmlns:a="http://schemas.openxmlformats.org/drawingml/2006/main">
+            <a:pPr algn="l">
+              <a:defRPr sz="1875" b="1" i="0">
+                <a:solidFill>
+                  <a:srgbClr val="FFFFFF"/>
+                </a:solidFill>
+              </a:defRPr>
+            </a:pPr>
+            <a:r>
+              <a:rPr sz="1875" b="1" i="0">
+                <a:solidFill>
+                  <a:srgbClr val="FFFFFF"/>
+                </a:solidFill>
+              </a:rPr>
+              <a:t>-$57.99</a:t>
+            </a:r>
+          </a:p>
+        </p:txBody>
+      </p:sp>
+      <p:sp>
+        <p:nvSpPr>
+          <p:cNvPr id="17" name="">
+            <a:extLst xmlns:a="http://schemas.openxmlformats.org/drawingml/2006/main">
+              <a:ext uri="{FF2B5EF4-FFF2-40B4-BE49-F238E27FC236}">
+                <a16:creationId xmlns:a16="http://schemas.microsoft.com/office/drawing/2014/main" id="{CC0A9CCE-0A48-4733-8D97-ADC5391FC74B}"/>
+              </a:ext>
+            </a:extLst>
+          </p:cNvPr>
+          <p:cNvSpPr>
+            <a:spLocks xmlns:a="http://schemas.openxmlformats.org/drawingml/2006/main" noGrp="1"/>
+          </p:cNvSpPr>
+          <p:nvPr/>
+        </p:nvSpPr>
+        <p:spPr>
+          <a:xfrm xmlns:a="http://schemas.openxmlformats.org/drawingml/2006/main">
+            <a:off x="8410575" y="3867150"/>
+            <a:ext cx="28575" cy="457200"/>
+          </a:xfrm>
+          <a:prstGeom xmlns:a="http://schemas.openxmlformats.org/drawingml/2006/main" prst="rect">
+            <a:avLst/>
+          </a:prstGeom>
+          <a:solidFill xmlns:a="http://schemas.openxmlformats.org/drawingml/2006/main">
+            <a:srgbClr val="527187"/>
+          </a:solidFill>
+          <a:ln xmlns:a="http://schemas.openxmlformats.org/drawingml/2006/main" w="0">
+            <a:noFill/>
+            <a:prstDash val="solid"/>
+          </a:ln>
+        </p:spPr>
+      </p:sp>
+      <p:sp>
+        <p:nvSpPr>
+          <p:cNvPr id="18" name="">
+            <a:extLst xmlns:a="http://schemas.openxmlformats.org/drawingml/2006/main">
+              <a:ext uri="{FF2B5EF4-FFF2-40B4-BE49-F238E27FC236}">
+                <a16:creationId xmlns:a16="http://schemas.microsoft.com/office/drawing/2014/main" id="{64B3FB01-04F9-49FF-A1AB-4429EB3EDD66}"/>
+              </a:ext>
+            </a:extLst>
+          </p:cNvPr>
+          <p:cNvSpPr>
+            <a:spLocks xmlns:a="http://schemas.openxmlformats.org/drawingml/2006/main" noGrp="1"/>
+          </p:cNvSpPr>
+          <p:nvPr/>
+        </p:nvSpPr>
+        <p:spPr>
+          <a:xfrm xmlns:a="http://schemas.openxmlformats.org/drawingml/2006/main">
+            <a:off x="8172450" y="4400550"/>
             <a:ext cx="514350" cy="514350"/>
           </a:xfrm>
           <a:prstGeom xmlns:a="http://schemas.openxmlformats.org/drawingml/2006/main" prst="ellipse">
@@ -11259,21 +11824,21 @@
       </p:sp>
       <p:sp>
         <p:nvSpPr>
-          <p:cNvPr id="6" name="">
-            <a:extLst xmlns:a="http://schemas.openxmlformats.org/drawingml/2006/main">
-              <a:ext uri="{FF2B5EF4-FFF2-40B4-BE49-F238E27FC236}">
-                <a16:creationId xmlns:a16="http://schemas.microsoft.com/office/drawing/2014/main" id="{D7E180E2-55B3-4060-BB91-7FDD75AD0A58}"/>
-              </a:ext>
-            </a:extLst>
-          </p:cNvPr>
-          <p:cNvSpPr>
-            <a:spLocks xmlns:a="http://schemas.openxmlformats.org/drawingml/2006/main" noGrp="1"/>
-          </p:cNvSpPr>
-          <p:nvPr/>
-        </p:nvSpPr>
-        <p:spPr>
-          <a:xfrm xmlns:a="http://schemas.openxmlformats.org/drawingml/2006/main">
-            <a:off x="8296275" y="2238375"/>
+          <p:cNvPr id="19" name="">
+            <a:extLst xmlns:a="http://schemas.openxmlformats.org/drawingml/2006/main">
+              <a:ext uri="{FF2B5EF4-FFF2-40B4-BE49-F238E27FC236}">
+                <a16:creationId xmlns:a16="http://schemas.microsoft.com/office/drawing/2014/main" id="{7B7CFC65-A746-421E-821B-CD92A8BAF922}"/>
+              </a:ext>
+            </a:extLst>
+          </p:cNvPr>
+          <p:cNvSpPr>
+            <a:spLocks xmlns:a="http://schemas.openxmlformats.org/drawingml/2006/main" noGrp="1"/>
+          </p:cNvSpPr>
+          <p:nvPr/>
+        </p:nvSpPr>
+        <p:spPr>
+          <a:xfrm xmlns:a="http://schemas.openxmlformats.org/drawingml/2006/main">
+            <a:off x="8296275" y="4486275"/>
             <a:ext cx="266700" cy="285750"/>
           </a:xfrm>
           <a:prstGeom xmlns:a="http://schemas.openxmlformats.org/drawingml/2006/main" prst="rect">
@@ -11302,28 +11867,28 @@
                   <a:srgbClr val="0B2942"/>
                 </a:solidFill>
               </a:rPr>
-              <a:t>1</a:t>
-            </a:r>
-          </a:p>
-        </p:txBody>
-      </p:sp>
-      <p:sp>
-        <p:nvSpPr>
-          <p:cNvPr id="7" name="">
-            <a:extLst xmlns:a="http://schemas.openxmlformats.org/drawingml/2006/main">
-              <a:ext uri="{FF2B5EF4-FFF2-40B4-BE49-F238E27FC236}">
-                <a16:creationId xmlns:a16="http://schemas.microsoft.com/office/drawing/2014/main" id="{58EF9E55-9584-4C1E-9E71-92225BC1AA34}"/>
-              </a:ext>
-            </a:extLst>
-          </p:cNvPr>
-          <p:cNvSpPr>
-            <a:spLocks xmlns:a="http://schemas.openxmlformats.org/drawingml/2006/main" noGrp="1"/>
-          </p:cNvSpPr>
-          <p:nvPr/>
-        </p:nvSpPr>
-        <p:spPr>
-          <a:xfrm xmlns:a="http://schemas.openxmlformats.org/drawingml/2006/main">
-            <a:off x="8877300" y="2133600"/>
+              <a:t>3</a:t>
+            </a:r>
+          </a:p>
+        </p:txBody>
+      </p:sp>
+      <p:sp>
+        <p:nvSpPr>
+          <p:cNvPr id="20" name="">
+            <a:extLst xmlns:a="http://schemas.openxmlformats.org/drawingml/2006/main">
+              <a:ext uri="{FF2B5EF4-FFF2-40B4-BE49-F238E27FC236}">
+                <a16:creationId xmlns:a16="http://schemas.microsoft.com/office/drawing/2014/main" id="{AEB77374-67B3-4879-A544-547B97F7598C}"/>
+              </a:ext>
+            </a:extLst>
+          </p:cNvPr>
+          <p:cNvSpPr>
+            <a:spLocks xmlns:a="http://schemas.openxmlformats.org/drawingml/2006/main" noGrp="1"/>
+          </p:cNvSpPr>
+          <p:nvPr/>
+        </p:nvSpPr>
+        <p:spPr>
+          <a:xfrm xmlns:a="http://schemas.openxmlformats.org/drawingml/2006/main">
+            <a:off x="8877300" y="4381500"/>
             <a:ext cx="2000250" cy="247650"/>
           </a:xfrm>
           <a:prstGeom xmlns:a="http://schemas.openxmlformats.org/drawingml/2006/main" prst="rect">
@@ -11352,28 +11917,28 @@
                   <a:srgbClr val="F2C66D"/>
                 </a:solidFill>
               </a:rPr>
-              <a:t>REPLAY</a:t>
-            </a:r>
-          </a:p>
-        </p:txBody>
-      </p:sp>
-      <p:sp>
-        <p:nvSpPr>
-          <p:cNvPr id="8" name="">
-            <a:extLst xmlns:a="http://schemas.openxmlformats.org/drawingml/2006/main">
-              <a:ext uri="{FF2B5EF4-FFF2-40B4-BE49-F238E27FC236}">
-                <a16:creationId xmlns:a16="http://schemas.microsoft.com/office/drawing/2014/main" id="{5C4939C7-B219-4D3B-B71D-7804F3B2C2EE}"/>
-              </a:ext>
-            </a:extLst>
-          </p:cNvPr>
-          <p:cNvSpPr>
-            <a:spLocks xmlns:a="http://schemas.openxmlformats.org/drawingml/2006/main" noGrp="1"/>
-          </p:cNvSpPr>
-          <p:nvPr/>
-        </p:nvSpPr>
-        <p:spPr>
-          <a:xfrm xmlns:a="http://schemas.openxmlformats.org/drawingml/2006/main">
-            <a:off x="8877300" y="2419350"/>
+              <a:t>ADVANTAGE</a:t>
+            </a:r>
+          </a:p>
+        </p:txBody>
+      </p:sp>
+      <p:sp>
+        <p:nvSpPr>
+          <p:cNvPr id="21" name="">
+            <a:extLst xmlns:a="http://schemas.openxmlformats.org/drawingml/2006/main">
+              <a:ext uri="{FF2B5EF4-FFF2-40B4-BE49-F238E27FC236}">
+                <a16:creationId xmlns:a16="http://schemas.microsoft.com/office/drawing/2014/main" id="{C434E465-38AB-463A-AE31-44EAD9DC3D39}"/>
+              </a:ext>
+            </a:extLst>
+          </p:cNvPr>
+          <p:cNvSpPr>
+            <a:spLocks xmlns:a="http://schemas.openxmlformats.org/drawingml/2006/main" noGrp="1"/>
+          </p:cNvSpPr>
+          <p:nvPr/>
+        </p:nvSpPr>
+        <p:spPr>
+          <a:xfrm xmlns:a="http://schemas.openxmlformats.org/drawingml/2006/main">
+            <a:off x="8877300" y="4667250"/>
             <a:ext cx="2571750" cy="400050"/>
           </a:xfrm>
           <a:prstGeom xmlns:a="http://schemas.openxmlformats.org/drawingml/2006/main" prst="rect">
@@ -11402,441 +11967,17 @@
                   <a:srgbClr val="FFFFFF"/>
                 </a:solidFill>
               </a:rPr>
-              <a:t>$10k → $106,711</a:t>
-            </a:r>
-          </a:p>
-        </p:txBody>
-      </p:sp>
-      <p:sp>
-        <p:nvSpPr>
-          <p:cNvPr id="9" name="">
-            <a:extLst xmlns:a="http://schemas.openxmlformats.org/drawingml/2006/main">
-              <a:ext uri="{FF2B5EF4-FFF2-40B4-BE49-F238E27FC236}">
-                <a16:creationId xmlns:a16="http://schemas.microsoft.com/office/drawing/2014/main" id="{C4C9CB9D-2EC8-4B3A-A87B-63856585BB9E}"/>
-              </a:ext>
-            </a:extLst>
-          </p:cNvPr>
-          <p:cNvSpPr>
-            <a:spLocks xmlns:a="http://schemas.openxmlformats.org/drawingml/2006/main" noGrp="1"/>
-          </p:cNvSpPr>
-          <p:nvPr/>
-        </p:nvSpPr>
-        <p:spPr>
-          <a:xfrm xmlns:a="http://schemas.openxmlformats.org/drawingml/2006/main">
-            <a:off x="8410575" y="2743200"/>
-            <a:ext cx="28575" cy="457200"/>
-          </a:xfrm>
-          <a:prstGeom xmlns:a="http://schemas.openxmlformats.org/drawingml/2006/main" prst="rect">
-            <a:avLst/>
-          </a:prstGeom>
-          <a:solidFill xmlns:a="http://schemas.openxmlformats.org/drawingml/2006/main">
-            <a:srgbClr val="527187"/>
-          </a:solidFill>
-          <a:ln xmlns:a="http://schemas.openxmlformats.org/drawingml/2006/main" w="0">
-            <a:noFill/>
-            <a:prstDash val="solid"/>
-          </a:ln>
-        </p:spPr>
-      </p:sp>
-      <p:sp>
-        <p:nvSpPr>
-          <p:cNvPr id="10" name="">
-            <a:extLst xmlns:a="http://schemas.openxmlformats.org/drawingml/2006/main">
-              <a:ext uri="{FF2B5EF4-FFF2-40B4-BE49-F238E27FC236}">
-                <a16:creationId xmlns:a16="http://schemas.microsoft.com/office/drawing/2014/main" id="{2B1360A0-E2AE-40DF-8D73-B8EC979529E6}"/>
-              </a:ext>
-            </a:extLst>
-          </p:cNvPr>
-          <p:cNvSpPr>
-            <a:spLocks xmlns:a="http://schemas.openxmlformats.org/drawingml/2006/main" noGrp="1"/>
-          </p:cNvSpPr>
-          <p:nvPr/>
-        </p:nvSpPr>
-        <p:spPr>
-          <a:xfrm xmlns:a="http://schemas.openxmlformats.org/drawingml/2006/main">
-            <a:off x="8172450" y="3276600"/>
-            <a:ext cx="514350" cy="514350"/>
-          </a:xfrm>
-          <a:prstGeom xmlns:a="http://schemas.openxmlformats.org/drawingml/2006/main" prst="ellipse">
-            <a:avLst/>
-          </a:prstGeom>
-          <a:solidFill xmlns:a="http://schemas.openxmlformats.org/drawingml/2006/main">
-            <a:srgbClr val="B9DFD2"/>
-          </a:solidFill>
-          <a:ln xmlns:a="http://schemas.openxmlformats.org/drawingml/2006/main" w="0">
-            <a:noFill/>
-            <a:prstDash val="solid"/>
-          </a:ln>
-        </p:spPr>
-      </p:sp>
-      <p:sp>
-        <p:nvSpPr>
-          <p:cNvPr id="11" name="">
-            <a:extLst xmlns:a="http://schemas.openxmlformats.org/drawingml/2006/main">
-              <a:ext uri="{FF2B5EF4-FFF2-40B4-BE49-F238E27FC236}">
-                <a16:creationId xmlns:a16="http://schemas.microsoft.com/office/drawing/2014/main" id="{9194A713-99C7-452B-AABC-70744F8E3664}"/>
-              </a:ext>
-            </a:extLst>
-          </p:cNvPr>
-          <p:cNvSpPr>
-            <a:spLocks xmlns:a="http://schemas.openxmlformats.org/drawingml/2006/main" noGrp="1"/>
-          </p:cNvSpPr>
-          <p:nvPr/>
-        </p:nvSpPr>
-        <p:spPr>
-          <a:xfrm xmlns:a="http://schemas.openxmlformats.org/drawingml/2006/main">
-            <a:off x="8296275" y="3362325"/>
-            <a:ext cx="266700" cy="285750"/>
-          </a:xfrm>
-          <a:prstGeom xmlns:a="http://schemas.openxmlformats.org/drawingml/2006/main" prst="rect">
-            <a:avLst/>
-          </a:prstGeom>
-          <a:noFill xmlns:a="http://schemas.openxmlformats.org/drawingml/2006/main"/>
-          <a:ln xmlns:a="http://schemas.openxmlformats.org/drawingml/2006/main" w="0">
-            <a:noFill/>
-            <a:prstDash val="solid"/>
-          </a:ln>
-        </p:spPr>
-        <p:txBody>
-          <a:bodyPr xmlns:a="http://schemas.openxmlformats.org/drawingml/2006/main"/>
-          <a:lstStyle xmlns:a="http://schemas.openxmlformats.org/drawingml/2006/main"/>
-          <a:p xmlns:a="http://schemas.openxmlformats.org/drawingml/2006/main">
-            <a:pPr algn="ctr">
-              <a:defRPr sz="1650" b="1" i="0">
-                <a:solidFill>
-                  <a:srgbClr val="0B2942"/>
-                </a:solidFill>
-              </a:defRPr>
-            </a:pPr>
-            <a:r>
-              <a:rPr sz="1650" b="1" i="0">
-                <a:solidFill>
-                  <a:srgbClr val="0B2942"/>
-                </a:solidFill>
-              </a:rPr>
-              <a:t>2</a:t>
-            </a:r>
-          </a:p>
-        </p:txBody>
-      </p:sp>
-      <p:sp>
-        <p:nvSpPr>
-          <p:cNvPr id="12" name="">
-            <a:extLst xmlns:a="http://schemas.openxmlformats.org/drawingml/2006/main">
-              <a:ext uri="{FF2B5EF4-FFF2-40B4-BE49-F238E27FC236}">
-                <a16:creationId xmlns:a16="http://schemas.microsoft.com/office/drawing/2014/main" id="{F5141980-B0FD-4345-818A-E686257C5916}"/>
-              </a:ext>
-            </a:extLst>
-          </p:cNvPr>
-          <p:cNvSpPr>
-            <a:spLocks xmlns:a="http://schemas.openxmlformats.org/drawingml/2006/main" noGrp="1"/>
-          </p:cNvSpPr>
-          <p:nvPr/>
-        </p:nvSpPr>
-        <p:spPr>
-          <a:xfrm xmlns:a="http://schemas.openxmlformats.org/drawingml/2006/main">
-            <a:off x="8877300" y="3257550"/>
-            <a:ext cx="2000250" cy="247650"/>
-          </a:xfrm>
-          <a:prstGeom xmlns:a="http://schemas.openxmlformats.org/drawingml/2006/main" prst="rect">
-            <a:avLst/>
-          </a:prstGeom>
-          <a:noFill xmlns:a="http://schemas.openxmlformats.org/drawingml/2006/main"/>
-          <a:ln xmlns:a="http://schemas.openxmlformats.org/drawingml/2006/main" w="0">
-            <a:noFill/>
-            <a:prstDash val="solid"/>
-          </a:ln>
-        </p:spPr>
-        <p:txBody>
-          <a:bodyPr xmlns:a="http://schemas.openxmlformats.org/drawingml/2006/main"/>
-          <a:lstStyle xmlns:a="http://schemas.openxmlformats.org/drawingml/2006/main"/>
-          <a:p xmlns:a="http://schemas.openxmlformats.org/drawingml/2006/main">
-            <a:pPr algn="l">
-              <a:defRPr sz="1125" b="1" i="0">
-                <a:solidFill>
-                  <a:srgbClr val="B9DFD2"/>
-                </a:solidFill>
-              </a:defRPr>
-            </a:pPr>
-            <a:r>
-              <a:rPr sz="1125" b="1" i="0">
-                <a:solidFill>
-                  <a:srgbClr val="B9DFD2"/>
-                </a:solidFill>
-              </a:rPr>
-              <a:t>FREEZE</a:t>
-            </a:r>
-          </a:p>
-        </p:txBody>
-      </p:sp>
-      <p:sp>
-        <p:nvSpPr>
-          <p:cNvPr id="13" name="">
-            <a:extLst xmlns:a="http://schemas.openxmlformats.org/drawingml/2006/main">
-              <a:ext uri="{FF2B5EF4-FFF2-40B4-BE49-F238E27FC236}">
-                <a16:creationId xmlns:a16="http://schemas.microsoft.com/office/drawing/2014/main" id="{23D1C83A-F150-491A-9213-8793A832F73C}"/>
-              </a:ext>
-            </a:extLst>
-          </p:cNvPr>
-          <p:cNvSpPr>
-            <a:spLocks xmlns:a="http://schemas.openxmlformats.org/drawingml/2006/main" noGrp="1"/>
-          </p:cNvSpPr>
-          <p:nvPr/>
-        </p:nvSpPr>
-        <p:spPr>
-          <a:xfrm xmlns:a="http://schemas.openxmlformats.org/drawingml/2006/main">
-            <a:off x="8877300" y="3543300"/>
-            <a:ext cx="2571750" cy="400050"/>
-          </a:xfrm>
-          <a:prstGeom xmlns:a="http://schemas.openxmlformats.org/drawingml/2006/main" prst="rect">
-            <a:avLst/>
-          </a:prstGeom>
-          <a:noFill xmlns:a="http://schemas.openxmlformats.org/drawingml/2006/main"/>
-          <a:ln xmlns:a="http://schemas.openxmlformats.org/drawingml/2006/main" w="0">
-            <a:noFill/>
-            <a:prstDash val="solid"/>
-          </a:ln>
-        </p:spPr>
-        <p:txBody>
-          <a:bodyPr xmlns:a="http://schemas.openxmlformats.org/drawingml/2006/main"/>
-          <a:lstStyle xmlns:a="http://schemas.openxmlformats.org/drawingml/2006/main"/>
-          <a:p xmlns:a="http://schemas.openxmlformats.org/drawingml/2006/main">
-            <a:pPr algn="l">
-              <a:defRPr sz="1875" b="1" i="0">
-                <a:solidFill>
-                  <a:srgbClr val="FFFFFF"/>
-                </a:solidFill>
-              </a:defRPr>
-            </a:pPr>
-            <a:r>
-              <a:rPr sz="1875" b="1" i="0">
-                <a:solidFill>
-                  <a:srgbClr val="FFFFFF"/>
-                </a:solidFill>
-              </a:rPr>
-              <a:t>Human-selected rule</a:t>
-            </a:r>
-          </a:p>
-        </p:txBody>
-      </p:sp>
-      <p:sp>
-        <p:nvSpPr>
-          <p:cNvPr id="14" name="">
-            <a:extLst xmlns:a="http://schemas.openxmlformats.org/drawingml/2006/main">
-              <a:ext uri="{FF2B5EF4-FFF2-40B4-BE49-F238E27FC236}">
-                <a16:creationId xmlns:a16="http://schemas.microsoft.com/office/drawing/2014/main" id="{0EA68D7A-EADF-4933-BCB7-F05E62F30E0F}"/>
-              </a:ext>
-            </a:extLst>
-          </p:cNvPr>
-          <p:cNvSpPr>
-            <a:spLocks xmlns:a="http://schemas.openxmlformats.org/drawingml/2006/main" noGrp="1"/>
-          </p:cNvSpPr>
-          <p:nvPr/>
-        </p:nvSpPr>
-        <p:spPr>
-          <a:xfrm xmlns:a="http://schemas.openxmlformats.org/drawingml/2006/main">
-            <a:off x="8410575" y="3867150"/>
-            <a:ext cx="28575" cy="457200"/>
-          </a:xfrm>
-          <a:prstGeom xmlns:a="http://schemas.openxmlformats.org/drawingml/2006/main" prst="rect">
-            <a:avLst/>
-          </a:prstGeom>
-          <a:solidFill xmlns:a="http://schemas.openxmlformats.org/drawingml/2006/main">
-            <a:srgbClr val="527187"/>
-          </a:solidFill>
-          <a:ln xmlns:a="http://schemas.openxmlformats.org/drawingml/2006/main" w="0">
-            <a:noFill/>
-            <a:prstDash val="solid"/>
-          </a:ln>
-        </p:spPr>
-      </p:sp>
-      <p:sp>
-        <p:nvSpPr>
-          <p:cNvPr id="15" name="">
-            <a:extLst xmlns:a="http://schemas.openxmlformats.org/drawingml/2006/main">
-              <a:ext uri="{FF2B5EF4-FFF2-40B4-BE49-F238E27FC236}">
-                <a16:creationId xmlns:a16="http://schemas.microsoft.com/office/drawing/2014/main" id="{DB5A7B00-37EC-425C-A8DF-F11C7E89C2DA}"/>
-              </a:ext>
-            </a:extLst>
-          </p:cNvPr>
-          <p:cNvSpPr>
-            <a:spLocks xmlns:a="http://schemas.openxmlformats.org/drawingml/2006/main" noGrp="1"/>
-          </p:cNvSpPr>
-          <p:nvPr/>
-        </p:nvSpPr>
-        <p:spPr>
-          <a:xfrm xmlns:a="http://schemas.openxmlformats.org/drawingml/2006/main">
-            <a:off x="8172450" y="4400550"/>
-            <a:ext cx="514350" cy="514350"/>
-          </a:xfrm>
-          <a:prstGeom xmlns:a="http://schemas.openxmlformats.org/drawingml/2006/main" prst="ellipse">
-            <a:avLst/>
-          </a:prstGeom>
-          <a:solidFill xmlns:a="http://schemas.openxmlformats.org/drawingml/2006/main">
-            <a:srgbClr val="E56B5D"/>
-          </a:solidFill>
-          <a:ln xmlns:a="http://schemas.openxmlformats.org/drawingml/2006/main" w="0">
-            <a:noFill/>
-            <a:prstDash val="solid"/>
-          </a:ln>
-        </p:spPr>
-      </p:sp>
-      <p:sp>
-        <p:nvSpPr>
-          <p:cNvPr id="16" name="">
-            <a:extLst xmlns:a="http://schemas.openxmlformats.org/drawingml/2006/main">
-              <a:ext uri="{FF2B5EF4-FFF2-40B4-BE49-F238E27FC236}">
-                <a16:creationId xmlns:a16="http://schemas.microsoft.com/office/drawing/2014/main" id="{C9B4996B-3DD6-400D-83AE-5857049E7793}"/>
-              </a:ext>
-            </a:extLst>
-          </p:cNvPr>
-          <p:cNvSpPr>
-            <a:spLocks xmlns:a="http://schemas.openxmlformats.org/drawingml/2006/main" noGrp="1"/>
-          </p:cNvSpPr>
-          <p:nvPr/>
-        </p:nvSpPr>
-        <p:spPr>
-          <a:xfrm xmlns:a="http://schemas.openxmlformats.org/drawingml/2006/main">
-            <a:off x="8296275" y="4486275"/>
-            <a:ext cx="266700" cy="285750"/>
-          </a:xfrm>
-          <a:prstGeom xmlns:a="http://schemas.openxmlformats.org/drawingml/2006/main" prst="rect">
-            <a:avLst/>
-          </a:prstGeom>
-          <a:noFill xmlns:a="http://schemas.openxmlformats.org/drawingml/2006/main"/>
-          <a:ln xmlns:a="http://schemas.openxmlformats.org/drawingml/2006/main" w="0">
-            <a:noFill/>
-            <a:prstDash val="solid"/>
-          </a:ln>
-        </p:spPr>
-        <p:txBody>
-          <a:bodyPr xmlns:a="http://schemas.openxmlformats.org/drawingml/2006/main"/>
-          <a:lstStyle xmlns:a="http://schemas.openxmlformats.org/drawingml/2006/main"/>
-          <a:p xmlns:a="http://schemas.openxmlformats.org/drawingml/2006/main">
-            <a:pPr algn="ctr">
-              <a:defRPr sz="1650" b="1" i="0">
-                <a:solidFill>
-                  <a:srgbClr val="0B2942"/>
-                </a:solidFill>
-              </a:defRPr>
-            </a:pPr>
-            <a:r>
-              <a:rPr sz="1650" b="1" i="0">
-                <a:solidFill>
-                  <a:srgbClr val="0B2942"/>
-                </a:solidFill>
-              </a:rPr>
-              <a:t>3</a:t>
-            </a:r>
-          </a:p>
-        </p:txBody>
-      </p:sp>
-      <p:sp>
-        <p:nvSpPr>
-          <p:cNvPr id="17" name="">
-            <a:extLst xmlns:a="http://schemas.openxmlformats.org/drawingml/2006/main">
-              <a:ext uri="{FF2B5EF4-FFF2-40B4-BE49-F238E27FC236}">
-                <a16:creationId xmlns:a16="http://schemas.microsoft.com/office/drawing/2014/main" id="{0AB662CC-3DAB-478E-853F-9415662DFC10}"/>
-              </a:ext>
-            </a:extLst>
-          </p:cNvPr>
-          <p:cNvSpPr>
-            <a:spLocks xmlns:a="http://schemas.openxmlformats.org/drawingml/2006/main" noGrp="1"/>
-          </p:cNvSpPr>
-          <p:nvPr/>
-        </p:nvSpPr>
-        <p:spPr>
-          <a:xfrm xmlns:a="http://schemas.openxmlformats.org/drawingml/2006/main">
-            <a:off x="8877300" y="4381500"/>
-            <a:ext cx="2000250" cy="247650"/>
-          </a:xfrm>
-          <a:prstGeom xmlns:a="http://schemas.openxmlformats.org/drawingml/2006/main" prst="rect">
-            <a:avLst/>
-          </a:prstGeom>
-          <a:noFill xmlns:a="http://schemas.openxmlformats.org/drawingml/2006/main"/>
-          <a:ln xmlns:a="http://schemas.openxmlformats.org/drawingml/2006/main" w="0">
-            <a:noFill/>
-            <a:prstDash val="solid"/>
-          </a:ln>
-        </p:spPr>
-        <p:txBody>
-          <a:bodyPr xmlns:a="http://schemas.openxmlformats.org/drawingml/2006/main"/>
-          <a:lstStyle xmlns:a="http://schemas.openxmlformats.org/drawingml/2006/main"/>
-          <a:p xmlns:a="http://schemas.openxmlformats.org/drawingml/2006/main">
-            <a:pPr algn="l">
-              <a:defRPr sz="1125" b="1" i="0">
-                <a:solidFill>
-                  <a:srgbClr val="E56B5D"/>
-                </a:solidFill>
-              </a:defRPr>
-            </a:pPr>
-            <a:r>
-              <a:rPr sz="1125" b="1" i="0">
-                <a:solidFill>
-                  <a:srgbClr val="E56B5D"/>
-                </a:solidFill>
-              </a:rPr>
-              <a:t>SCORE</a:t>
-            </a:r>
-          </a:p>
-        </p:txBody>
-      </p:sp>
-      <p:sp>
-        <p:nvSpPr>
-          <p:cNvPr id="18" name="">
-            <a:extLst xmlns:a="http://schemas.openxmlformats.org/drawingml/2006/main">
-              <a:ext uri="{FF2B5EF4-FFF2-40B4-BE49-F238E27FC236}">
-                <a16:creationId xmlns:a16="http://schemas.microsoft.com/office/drawing/2014/main" id="{16E1B5FC-9AEB-4F4B-BA55-859DD34EE830}"/>
-              </a:ext>
-            </a:extLst>
-          </p:cNvPr>
-          <p:cNvSpPr>
-            <a:spLocks xmlns:a="http://schemas.openxmlformats.org/drawingml/2006/main" noGrp="1"/>
-          </p:cNvSpPr>
-          <p:nvPr/>
-        </p:nvSpPr>
-        <p:spPr>
-          <a:xfrm xmlns:a="http://schemas.openxmlformats.org/drawingml/2006/main">
-            <a:off x="8877300" y="4667250"/>
-            <a:ext cx="2571750" cy="400050"/>
-          </a:xfrm>
-          <a:prstGeom xmlns:a="http://schemas.openxmlformats.org/drawingml/2006/main" prst="rect">
-            <a:avLst/>
-          </a:prstGeom>
-          <a:noFill xmlns:a="http://schemas.openxmlformats.org/drawingml/2006/main"/>
-          <a:ln xmlns:a="http://schemas.openxmlformats.org/drawingml/2006/main" w="0">
-            <a:noFill/>
-            <a:prstDash val="solid"/>
-          </a:ln>
-        </p:spPr>
-        <p:txBody>
-          <a:bodyPr xmlns:a="http://schemas.openxmlformats.org/drawingml/2006/main"/>
-          <a:lstStyle xmlns:a="http://schemas.openxmlformats.org/drawingml/2006/main"/>
-          <a:p xmlns:a="http://schemas.openxmlformats.org/drawingml/2006/main">
-            <a:pPr algn="l">
-              <a:defRPr sz="1875" b="1" i="0">
-                <a:solidFill>
-                  <a:srgbClr val="FFFFFF"/>
-                </a:solidFill>
-              </a:defRPr>
-            </a:pPr>
-            <a:r>
-              <a:rPr sz="1875" b="1" i="0">
-                <a:solidFill>
-                  <a:srgbClr val="FFFFFF"/>
-                </a:solidFill>
-              </a:rPr>
-              <a:t>$100,000 baseline</a:t>
-            </a:r>
-          </a:p>
-        </p:txBody>
-      </p:sp>
-      <p:sp>
-        <p:nvSpPr>
-          <p:cNvPr id="19" name="">
-            <a:extLst xmlns:a="http://schemas.openxmlformats.org/drawingml/2006/main">
-              <a:ext uri="{FF2B5EF4-FFF2-40B4-BE49-F238E27FC236}">
-                <a16:creationId xmlns:a16="http://schemas.microsoft.com/office/drawing/2014/main" id="{13DABE61-AC62-491A-B9CA-B58DC21752C1}"/>
+              <a:t>+$153.31</a:t>
+            </a:r>
+          </a:p>
+        </p:txBody>
+      </p:sp>
+      <p:sp>
+        <p:nvSpPr>
+          <p:cNvPr id="22" name="">
+            <a:extLst xmlns:a="http://schemas.openxmlformats.org/drawingml/2006/main">
+              <a:ext uri="{FF2B5EF4-FFF2-40B4-BE49-F238E27FC236}">
+                <a16:creationId xmlns:a16="http://schemas.microsoft.com/office/drawing/2014/main" id="{7A0DEE6C-FF38-4ECE-96D6-D755D2F31576}"/>
               </a:ext>
             </a:extLst>
           </p:cNvPr>
@@ -11864,22 +12005,22 @@
       </p:sp>
       <p:sp>
         <p:nvSpPr>
-          <p:cNvPr id="20" name="">
-            <a:extLst xmlns:a="http://schemas.openxmlformats.org/drawingml/2006/main">
-              <a:ext uri="{FF2B5EF4-FFF2-40B4-BE49-F238E27FC236}">
-                <a16:creationId xmlns:a16="http://schemas.microsoft.com/office/drawing/2014/main" id="{A0719A5D-A35A-436D-B7F3-7514E1A6707C}"/>
-              </a:ext>
-            </a:extLst>
-          </p:cNvPr>
-          <p:cNvSpPr>
-            <a:spLocks xmlns:a="http://schemas.openxmlformats.org/drawingml/2006/main" noGrp="1"/>
-          </p:cNvSpPr>
-          <p:nvPr/>
-        </p:nvSpPr>
-        <p:spPr>
-          <a:xfrm xmlns:a="http://schemas.openxmlformats.org/drawingml/2006/main">
-            <a:off x="8172450" y="5810250"/>
-            <a:ext cx="3276600" cy="533400"/>
+          <p:cNvPr id="23" name="">
+            <a:extLst xmlns:a="http://schemas.openxmlformats.org/drawingml/2006/main">
+              <a:ext uri="{FF2B5EF4-FFF2-40B4-BE49-F238E27FC236}">
+                <a16:creationId xmlns:a16="http://schemas.microsoft.com/office/drawing/2014/main" id="{0AE5A6C2-597C-4B2A-AC40-00071E011BBA}"/>
+              </a:ext>
+            </a:extLst>
+          </p:cNvPr>
+          <p:cNvSpPr>
+            <a:spLocks xmlns:a="http://schemas.openxmlformats.org/drawingml/2006/main" noGrp="1"/>
+          </p:cNvSpPr>
+          <p:nvPr/>
+        </p:nvSpPr>
+        <p:spPr>
+          <a:xfrm xmlns:a="http://schemas.openxmlformats.org/drawingml/2006/main">
+            <a:off x="8172450" y="5772150"/>
+            <a:ext cx="3276600" cy="590550"/>
           </a:xfrm>
           <a:prstGeom xmlns:a="http://schemas.openxmlformats.org/drawingml/2006/main" prst="rect">
             <a:avLst/>
@@ -11895,29 +12036,29 @@
           <a:lstStyle xmlns:a="http://schemas.openxmlformats.org/drawingml/2006/main"/>
           <a:p xmlns:a="http://schemas.openxmlformats.org/drawingml/2006/main">
             <a:pPr algn="l">
-              <a:defRPr sz="1500" b="1" i="0">
+              <a:defRPr sz="1350" b="1" i="0">
                 <a:solidFill>
                   <a:srgbClr val="B9DFD2"/>
                 </a:solidFill>
               </a:defRPr>
             </a:pPr>
             <a:r>
-              <a:rPr sz="1500" b="1" i="0">
+              <a:rPr sz="1350" b="1" i="0">
                 <a:solidFill>
                   <a:srgbClr val="B9DFD2"/>
                 </a:solidFill>
               </a:rPr>
-              <a:t>Historical upside nominates the test. The account—not the backtest—settles it.</a:t>
-            </a:r>
-          </a:p>
-        </p:txBody>
-      </p:sp>
-      <p:sp>
-        <p:nvSpPr>
-          <p:cNvPr id="21" name="">
-            <a:extLst xmlns:a="http://schemas.openxmlformats.org/drawingml/2006/main">
-              <a:ext uri="{FF2B5EF4-FFF2-40B4-BE49-F238E27FC236}">
-                <a16:creationId xmlns:a16="http://schemas.microsoft.com/office/drawing/2014/main" id="{DF2015ED-B692-45F5-95EE-838865CA8B97}"/>
+              <a:t>Same $100k baseline · exact 4:00 p.m. ET · 15 broker fills · zero cashflows</a:t>
+            </a:r>
+          </a:p>
+        </p:txBody>
+      </p:sp>
+      <p:sp>
+        <p:nvSpPr>
+          <p:cNvPr id="24" name="">
+            <a:extLst xmlns:a="http://schemas.openxmlformats.org/drawingml/2006/main">
+              <a:ext uri="{FF2B5EF4-FFF2-40B4-BE49-F238E27FC236}">
+                <a16:creationId xmlns:a16="http://schemas.microsoft.com/office/drawing/2014/main" id="{E7A3D57B-1736-4E78-B3A6-649AE23F220F}"/>
               </a:ext>
             </a:extLst>
           </p:cNvPr>
@@ -11964,10 +12105,10 @@
       </p:sp>
       <p:sp>
         <p:nvSpPr>
-          <p:cNvPr id="22" name="">
-            <a:extLst xmlns:a="http://schemas.openxmlformats.org/drawingml/2006/main">
-              <a:ext uri="{FF2B5EF4-FFF2-40B4-BE49-F238E27FC236}">
-                <a16:creationId xmlns:a16="http://schemas.microsoft.com/office/drawing/2014/main" id="{7577D4EF-47F2-4686-A734-F5C039E7AC57}"/>
+          <p:cNvPr id="25" name="">
+            <a:extLst xmlns:a="http://schemas.openxmlformats.org/drawingml/2006/main">
+              <a:ext uri="{FF2B5EF4-FFF2-40B4-BE49-F238E27FC236}">
+                <a16:creationId xmlns:a16="http://schemas.microsoft.com/office/drawing/2014/main" id="{0A3C259E-0EC4-4EC6-B11D-23BA3761B869}"/>
               </a:ext>
             </a:extLst>
           </p:cNvPr>
@@ -12015,7 +12156,7 @@
     </p:spTree>
     <p:extLst>
       <p:ext uri="{BB962C8B-B14F-4D97-AF65-F5344CB8AC3E}">
-        <p14:creationId xmlns:p14="http://schemas.microsoft.com/office/powerpoint/2010/main" val="1490278679"/>
+        <p14:creationId xmlns:p14="http://schemas.microsoft.com/office/powerpoint/2010/main" val="1397277636"/>
       </p:ext>
     </p:extLst>
   </p:cSld>
@@ -12046,7 +12187,7 @@
           <p:cNvPr id="25" name="">
             <a:extLst xmlns:a="http://schemas.openxmlformats.org/drawingml/2006/main">
               <a:ext uri="{FF2B5EF4-FFF2-40B4-BE49-F238E27FC236}">
-                <a16:creationId xmlns:a16="http://schemas.microsoft.com/office/drawing/2014/main" id="{E265F002-124E-4604-BBA8-6DB177F645EF}"/>
+                <a16:creationId xmlns:a16="http://schemas.microsoft.com/office/drawing/2014/main" id="{9EDFEFA3-A9D9-47F8-9A1E-A4DBC12A88FB}"/>
               </a:ext>
             </a:extLst>
           </p:cNvPr>
@@ -12096,7 +12237,7 @@
           <p:cNvPr id="2" name="">
             <a:extLst xmlns:a="http://schemas.openxmlformats.org/drawingml/2006/main">
               <a:ext uri="{FF2B5EF4-FFF2-40B4-BE49-F238E27FC236}">
-                <a16:creationId xmlns:a16="http://schemas.microsoft.com/office/drawing/2014/main" id="{106A853B-998B-43A8-A0A2-19589AC9373A}"/>
+                <a16:creationId xmlns:a16="http://schemas.microsoft.com/office/drawing/2014/main" id="{E82C4D9B-08C6-4BD1-B946-037E44FCF3DF}"/>
               </a:ext>
             </a:extLst>
           </p:cNvPr>
@@ -12146,7 +12287,7 @@
           <p:cNvPr id="3" name="">
             <a:extLst xmlns:a="http://schemas.openxmlformats.org/drawingml/2006/main">
               <a:ext uri="{FF2B5EF4-FFF2-40B4-BE49-F238E27FC236}">
-                <a16:creationId xmlns:a16="http://schemas.microsoft.com/office/drawing/2014/main" id="{5B9CC42A-9623-4C0A-B01D-5B17399C221E}"/>
+                <a16:creationId xmlns:a16="http://schemas.microsoft.com/office/drawing/2014/main" id="{80397D02-A776-4BA6-A946-008B4EAC458F}"/>
               </a:ext>
             </a:extLst>
           </p:cNvPr>
@@ -12191,7 +12332,7 @@
           <p:nvPr/>
         </p:nvPicPr>
         <p:blipFill>
-          <a:blip xmlns:r="http://schemas.openxmlformats.org/officeDocument/2006/relationships" xmlns:a="http://schemas.openxmlformats.org/drawingml/2006/main" r:embed="Rce22e13f4cf64c9a"/>
+          <a:blip xmlns:r="http://schemas.openxmlformats.org/officeDocument/2006/relationships" xmlns:a="http://schemas.openxmlformats.org/drawingml/2006/main" r:embed="R754f684686434895"/>
           <a:stretch xmlns:a="http://schemas.openxmlformats.org/drawingml/2006/main"/>
         </p:blipFill>
         <p:spPr>
@@ -12211,7 +12352,7 @@
           <p:cNvPr id="5" name="">
             <a:extLst xmlns:a="http://schemas.openxmlformats.org/drawingml/2006/main">
               <a:ext uri="{FF2B5EF4-FFF2-40B4-BE49-F238E27FC236}">
-                <a16:creationId xmlns:a16="http://schemas.microsoft.com/office/drawing/2014/main" id="{AA7DC0E0-797F-43D5-9B7E-A054A159F083}"/>
+                <a16:creationId xmlns:a16="http://schemas.microsoft.com/office/drawing/2014/main" id="{0A6EEE0D-FC93-4F1A-A891-20E5590A88D5}"/>
               </a:ext>
             </a:extLst>
           </p:cNvPr>
@@ -12244,7 +12385,7 @@
           <p:cNvPr id="6" name="">
             <a:extLst xmlns:a="http://schemas.openxmlformats.org/drawingml/2006/main">
               <a:ext uri="{FF2B5EF4-FFF2-40B4-BE49-F238E27FC236}">
-                <a16:creationId xmlns:a16="http://schemas.microsoft.com/office/drawing/2014/main" id="{FC2039D7-276B-4D2A-9361-7C6671A97266}"/>
+                <a16:creationId xmlns:a16="http://schemas.microsoft.com/office/drawing/2014/main" id="{CE7348A6-D20E-4A33-9E12-EEABCFB77DA8}"/>
               </a:ext>
             </a:extLst>
           </p:cNvPr>
@@ -12294,7 +12435,7 @@
           <p:cNvPr id="7" name="">
             <a:extLst xmlns:a="http://schemas.openxmlformats.org/drawingml/2006/main">
               <a:ext uri="{FF2B5EF4-FFF2-40B4-BE49-F238E27FC236}">
-                <a16:creationId xmlns:a16="http://schemas.microsoft.com/office/drawing/2014/main" id="{FE9EF117-CEE0-49FB-80E9-9351AE24026F}"/>
+                <a16:creationId xmlns:a16="http://schemas.microsoft.com/office/drawing/2014/main" id="{F4E6A9C9-CA5E-472A-B64A-922D7B3BF596}"/>
               </a:ext>
             </a:extLst>
           </p:cNvPr>
@@ -12344,7 +12485,7 @@
           <p:cNvPr id="8" name="">
             <a:extLst xmlns:a="http://schemas.openxmlformats.org/drawingml/2006/main">
               <a:ext uri="{FF2B5EF4-FFF2-40B4-BE49-F238E27FC236}">
-                <a16:creationId xmlns:a16="http://schemas.microsoft.com/office/drawing/2014/main" id="{8D386FCC-687C-470D-9514-33BD7E5D6622}"/>
+                <a16:creationId xmlns:a16="http://schemas.microsoft.com/office/drawing/2014/main" id="{85B6609B-E42F-41C8-8BAB-3919C65959F5}"/>
               </a:ext>
             </a:extLst>
           </p:cNvPr>
@@ -12377,7 +12518,7 @@
           <p:cNvPr id="9" name="">
             <a:extLst xmlns:a="http://schemas.openxmlformats.org/drawingml/2006/main">
               <a:ext uri="{FF2B5EF4-FFF2-40B4-BE49-F238E27FC236}">
-                <a16:creationId xmlns:a16="http://schemas.microsoft.com/office/drawing/2014/main" id="{F67A0A26-30FB-4C8F-963E-457D460DF15B}"/>
+                <a16:creationId xmlns:a16="http://schemas.microsoft.com/office/drawing/2014/main" id="{A67B0145-A11C-41E9-8C2A-47D6F38702FB}"/>
               </a:ext>
             </a:extLst>
           </p:cNvPr>
@@ -12427,7 +12568,7 @@
           <p:cNvPr id="10" name="">
             <a:extLst xmlns:a="http://schemas.openxmlformats.org/drawingml/2006/main">
               <a:ext uri="{FF2B5EF4-FFF2-40B4-BE49-F238E27FC236}">
-                <a16:creationId xmlns:a16="http://schemas.microsoft.com/office/drawing/2014/main" id="{EA09A097-D5F1-49BA-AE51-0EEA4BDDE06A}"/>
+                <a16:creationId xmlns:a16="http://schemas.microsoft.com/office/drawing/2014/main" id="{4490921B-4C60-4A79-B71E-FDB06166AD52}"/>
               </a:ext>
             </a:extLst>
           </p:cNvPr>
@@ -12477,7 +12618,7 @@
           <p:cNvPr id="11" name="">
             <a:extLst xmlns:a="http://schemas.openxmlformats.org/drawingml/2006/main">
               <a:ext uri="{FF2B5EF4-FFF2-40B4-BE49-F238E27FC236}">
-                <a16:creationId xmlns:a16="http://schemas.microsoft.com/office/drawing/2014/main" id="{60A5ED91-05FC-419C-B40C-52E78C479DE8}"/>
+                <a16:creationId xmlns:a16="http://schemas.microsoft.com/office/drawing/2014/main" id="{B5ED9DCC-80ED-48CE-A0DB-61437B605853}"/>
               </a:ext>
             </a:extLst>
           </p:cNvPr>
@@ -12510,7 +12651,7 @@
           <p:cNvPr id="12" name="">
             <a:extLst xmlns:a="http://schemas.openxmlformats.org/drawingml/2006/main">
               <a:ext uri="{FF2B5EF4-FFF2-40B4-BE49-F238E27FC236}">
-                <a16:creationId xmlns:a16="http://schemas.microsoft.com/office/drawing/2014/main" id="{4A00E631-06B5-4590-BB8D-964F1F800AAD}"/>
+                <a16:creationId xmlns:a16="http://schemas.microsoft.com/office/drawing/2014/main" id="{BFC5F1D7-DFFC-428E-91D8-DF7BEDCDC372}"/>
               </a:ext>
             </a:extLst>
           </p:cNvPr>
@@ -12560,7 +12701,7 @@
           <p:cNvPr id="13" name="">
             <a:extLst xmlns:a="http://schemas.openxmlformats.org/drawingml/2006/main">
               <a:ext uri="{FF2B5EF4-FFF2-40B4-BE49-F238E27FC236}">
-                <a16:creationId xmlns:a16="http://schemas.microsoft.com/office/drawing/2014/main" id="{A1177FA8-368E-4D1D-B9EF-D6E0725CCC6E}"/>
+                <a16:creationId xmlns:a16="http://schemas.microsoft.com/office/drawing/2014/main" id="{A825EA0E-26F0-4072-B0B3-E32A09DFC603}"/>
               </a:ext>
             </a:extLst>
           </p:cNvPr>
@@ -12610,7 +12751,7 @@
           <p:cNvPr id="14" name="">
             <a:extLst xmlns:a="http://schemas.openxmlformats.org/drawingml/2006/main">
               <a:ext uri="{FF2B5EF4-FFF2-40B4-BE49-F238E27FC236}">
-                <a16:creationId xmlns:a16="http://schemas.microsoft.com/office/drawing/2014/main" id="{498C0C7D-59EB-4D5D-AC9E-6D7E720DD74E}"/>
+                <a16:creationId xmlns:a16="http://schemas.microsoft.com/office/drawing/2014/main" id="{A1819BCA-B27B-4635-834F-F4A94C9954D8}"/>
               </a:ext>
             </a:extLst>
           </p:cNvPr>
@@ -12643,7 +12784,7 @@
           <p:cNvPr id="15" name="">
             <a:extLst xmlns:a="http://schemas.openxmlformats.org/drawingml/2006/main">
               <a:ext uri="{FF2B5EF4-FFF2-40B4-BE49-F238E27FC236}">
-                <a16:creationId xmlns:a16="http://schemas.microsoft.com/office/drawing/2014/main" id="{0091F4EC-38B4-46F3-AFD8-CF9BAB713660}"/>
+                <a16:creationId xmlns:a16="http://schemas.microsoft.com/office/drawing/2014/main" id="{CDC33A48-2BA9-4EFA-8B9A-27786EB71F39}"/>
               </a:ext>
             </a:extLst>
           </p:cNvPr>
@@ -12693,7 +12834,7 @@
           <p:cNvPr id="16" name="">
             <a:extLst xmlns:a="http://schemas.openxmlformats.org/drawingml/2006/main">
               <a:ext uri="{FF2B5EF4-FFF2-40B4-BE49-F238E27FC236}">
-                <a16:creationId xmlns:a16="http://schemas.microsoft.com/office/drawing/2014/main" id="{01CE5DEF-9FFE-4E38-AC4C-CB023657203A}"/>
+                <a16:creationId xmlns:a16="http://schemas.microsoft.com/office/drawing/2014/main" id="{D729EB00-A0B8-4472-9305-9FACACEADDDF}"/>
               </a:ext>
             </a:extLst>
           </p:cNvPr>
@@ -12743,7 +12884,7 @@
           <p:cNvPr id="17" name="">
             <a:extLst xmlns:a="http://schemas.openxmlformats.org/drawingml/2006/main">
               <a:ext uri="{FF2B5EF4-FFF2-40B4-BE49-F238E27FC236}">
-                <a16:creationId xmlns:a16="http://schemas.microsoft.com/office/drawing/2014/main" id="{03D67368-3D08-4F9D-B333-6D79B725CC61}"/>
+                <a16:creationId xmlns:a16="http://schemas.microsoft.com/office/drawing/2014/main" id="{24464404-E21C-4CE7-A63C-A285A7B19CA4}"/>
               </a:ext>
             </a:extLst>
           </p:cNvPr>
@@ -12774,7 +12915,7 @@
           <p:cNvPr id="18" name="">
             <a:extLst xmlns:a="http://schemas.openxmlformats.org/drawingml/2006/main">
               <a:ext uri="{FF2B5EF4-FFF2-40B4-BE49-F238E27FC236}">
-                <a16:creationId xmlns:a16="http://schemas.microsoft.com/office/drawing/2014/main" id="{5EA0EF76-3EF8-494D-BBF5-CE32C7622AAA}"/>
+                <a16:creationId xmlns:a16="http://schemas.microsoft.com/office/drawing/2014/main" id="{F9EDCB21-9052-4903-B0D8-DD917BE4EE23}"/>
               </a:ext>
             </a:extLst>
           </p:cNvPr>
@@ -12814,7 +12955,7 @@
                   <a:srgbClr val="2F7D68"/>
                 </a:solidFill>
               </a:rPr>
-              <a:t>806</a:t>
+              <a:t>809</a:t>
             </a:r>
           </a:p>
         </p:txBody>
@@ -12824,7 +12965,7 @@
           <p:cNvPr id="19" name="">
             <a:extLst xmlns:a="http://schemas.openxmlformats.org/drawingml/2006/main">
               <a:ext uri="{FF2B5EF4-FFF2-40B4-BE49-F238E27FC236}">
-                <a16:creationId xmlns:a16="http://schemas.microsoft.com/office/drawing/2014/main" id="{3C6FAE63-25F9-47A2-A188-A898D852371A}"/>
+                <a16:creationId xmlns:a16="http://schemas.microsoft.com/office/drawing/2014/main" id="{C8DB4E2A-366C-4B63-B0D6-8D93449A78BA}"/>
               </a:ext>
             </a:extLst>
           </p:cNvPr>
@@ -12874,7 +13015,7 @@
           <p:cNvPr id="20" name="">
             <a:extLst xmlns:a="http://schemas.openxmlformats.org/drawingml/2006/main">
               <a:ext uri="{FF2B5EF4-FFF2-40B4-BE49-F238E27FC236}">
-                <a16:creationId xmlns:a16="http://schemas.microsoft.com/office/drawing/2014/main" id="{54783D7E-7724-422D-8CCD-BE455D6A8613}"/>
+                <a16:creationId xmlns:a16="http://schemas.microsoft.com/office/drawing/2014/main" id="{EA3FDCFA-F2C4-4AC4-B841-20E040AFE3C1}"/>
               </a:ext>
             </a:extLst>
           </p:cNvPr>
@@ -12914,7 +13055,7 @@
                   <a:srgbClr val="122A3E"/>
                 </a:solidFill>
               </a:rPr>
-              <a:t>804 passed  ·  0 failed  ·  2 skipped</a:t>
+              <a:t>807 passed  ·  0 failed  ·  2 skipped</a:t>
             </a:r>
           </a:p>
         </p:txBody>
@@ -12924,7 +13065,7 @@
           <p:cNvPr id="21" name="">
             <a:extLst xmlns:a="http://schemas.openxmlformats.org/drawingml/2006/main">
               <a:ext uri="{FF2B5EF4-FFF2-40B4-BE49-F238E27FC236}">
-                <a16:creationId xmlns:a16="http://schemas.microsoft.com/office/drawing/2014/main" id="{67685207-E5DB-49CE-80D6-A18D292B3272}"/>
+                <a16:creationId xmlns:a16="http://schemas.microsoft.com/office/drawing/2014/main" id="{048A416C-D7F1-4D85-93B6-903E4AA8C906}"/>
               </a:ext>
             </a:extLst>
           </p:cNvPr>
@@ -12957,7 +13098,7 @@
           <p:cNvPr id="22" name="">
             <a:extLst xmlns:a="http://schemas.openxmlformats.org/drawingml/2006/main">
               <a:ext uri="{FF2B5EF4-FFF2-40B4-BE49-F238E27FC236}">
-                <a16:creationId xmlns:a16="http://schemas.microsoft.com/office/drawing/2014/main" id="{4AB40586-C186-41F6-8A85-9975D639C7B9}"/>
+                <a16:creationId xmlns:a16="http://schemas.microsoft.com/office/drawing/2014/main" id="{443723AC-5B63-4A1A-BCB7-4BC4D7855529}"/>
               </a:ext>
             </a:extLst>
           </p:cNvPr>
@@ -13007,7 +13148,7 @@
           <p:cNvPr id="23" name="">
             <a:extLst xmlns:a="http://schemas.openxmlformats.org/drawingml/2006/main">
               <a:ext uri="{FF2B5EF4-FFF2-40B4-BE49-F238E27FC236}">
-                <a16:creationId xmlns:a16="http://schemas.microsoft.com/office/drawing/2014/main" id="{E36AED90-5624-481D-9023-887C88723BC1}"/>
+                <a16:creationId xmlns:a16="http://schemas.microsoft.com/office/drawing/2014/main" id="{013EB44D-8AA8-4B8B-9BD0-B2510EA12A24}"/>
               </a:ext>
             </a:extLst>
           </p:cNvPr>
@@ -13057,7 +13198,7 @@
           <p:cNvPr id="24" name="">
             <a:extLst xmlns:a="http://schemas.openxmlformats.org/drawingml/2006/main">
               <a:ext uri="{FF2B5EF4-FFF2-40B4-BE49-F238E27FC236}">
-                <a16:creationId xmlns:a16="http://schemas.microsoft.com/office/drawing/2014/main" id="{0F67DB4D-475B-4582-B40D-AEB0188FAE0B}"/>
+                <a16:creationId xmlns:a16="http://schemas.microsoft.com/office/drawing/2014/main" id="{2263DB3E-7131-41A2-887B-68DCD57C65F7}"/>
               </a:ext>
             </a:extLst>
           </p:cNvPr>
@@ -13105,7 +13246,7 @@
     </p:spTree>
     <p:extLst>
       <p:ext uri="{BB962C8B-B14F-4D97-AF65-F5344CB8AC3E}">
-        <p14:creationId xmlns:p14="http://schemas.microsoft.com/office/powerpoint/2010/main" val="1506473445"/>
+        <p14:creationId xmlns:p14="http://schemas.microsoft.com/office/powerpoint/2010/main" val="2102635706"/>
       </p:ext>
     </p:extLst>
   </p:cSld>
@@ -13136,7 +13277,7 @@
           <p:cNvPr id="24" name="">
             <a:extLst xmlns:a="http://schemas.openxmlformats.org/drawingml/2006/main">
               <a:ext uri="{FF2B5EF4-FFF2-40B4-BE49-F238E27FC236}">
-                <a16:creationId xmlns:a16="http://schemas.microsoft.com/office/drawing/2014/main" id="{6E7476D5-CE79-44A8-9675-1B06C4D8EB78}"/>
+                <a16:creationId xmlns:a16="http://schemas.microsoft.com/office/drawing/2014/main" id="{80129921-3F48-4916-818E-D5687EE46894}"/>
               </a:ext>
             </a:extLst>
           </p:cNvPr>
@@ -13186,7 +13327,7 @@
           <p:cNvPr id="2" name="">
             <a:extLst xmlns:a="http://schemas.openxmlformats.org/drawingml/2006/main">
               <a:ext uri="{FF2B5EF4-FFF2-40B4-BE49-F238E27FC236}">
-                <a16:creationId xmlns:a16="http://schemas.microsoft.com/office/drawing/2014/main" id="{16083BAF-2239-4916-8EBF-07D52FC29C53}"/>
+                <a16:creationId xmlns:a16="http://schemas.microsoft.com/office/drawing/2014/main" id="{CDFCCC15-690D-4173-A4FF-4416835E0184}"/>
               </a:ext>
             </a:extLst>
           </p:cNvPr>
@@ -13236,7 +13377,7 @@
           <p:cNvPr id="3" name="">
             <a:extLst xmlns:a="http://schemas.openxmlformats.org/drawingml/2006/main">
               <a:ext uri="{FF2B5EF4-FFF2-40B4-BE49-F238E27FC236}">
-                <a16:creationId xmlns:a16="http://schemas.microsoft.com/office/drawing/2014/main" id="{CC50A078-A936-486A-9766-B232EFDED5BB}"/>
+                <a16:creationId xmlns:a16="http://schemas.microsoft.com/office/drawing/2014/main" id="{545E0CBF-1432-4EB2-A50C-7AE2D325E483}"/>
               </a:ext>
             </a:extLst>
           </p:cNvPr>
@@ -13276,7 +13417,7 @@
                   <a:srgbClr val="627078"/>
                 </a:solidFill>
               </a:rPr>
-              <a:t>Watch the account. Challenge a decision. Inspect the code.</a:t>
+              <a:t>$153.31 ahead at the first close. Now challenge the decision and inspect the code.</a:t>
             </a:r>
           </a:p>
         </p:txBody>
@@ -13286,7 +13427,7 @@
           <p:cNvPr id="4" name="">
             <a:extLst xmlns:a="http://schemas.openxmlformats.org/drawingml/2006/main">
               <a:ext uri="{FF2B5EF4-FFF2-40B4-BE49-F238E27FC236}">
-                <a16:creationId xmlns:a16="http://schemas.microsoft.com/office/drawing/2014/main" id="{148BF828-B19B-4DAA-A57F-BBFAC8A2E492}"/>
+                <a16:creationId xmlns:a16="http://schemas.microsoft.com/office/drawing/2014/main" id="{D2F9554E-4B59-4F36-8858-7EE6C683687C}"/>
               </a:ext>
             </a:extLst>
           </p:cNvPr>
@@ -13331,7 +13472,7 @@
           <p:nvPr/>
         </p:nvPicPr>
         <p:blipFill>
-          <a:blip xmlns:r="http://schemas.openxmlformats.org/officeDocument/2006/relationships" xmlns:a="http://schemas.openxmlformats.org/drawingml/2006/main" r:embed="R836ce34b81a44d94"/>
+          <a:blip xmlns:r="http://schemas.openxmlformats.org/officeDocument/2006/relationships" xmlns:a="http://schemas.openxmlformats.org/drawingml/2006/main" r:embed="R86a27993fe5d4626"/>
           <a:stretch xmlns:a="http://schemas.openxmlformats.org/drawingml/2006/main"/>
         </p:blipFill>
         <p:spPr>
@@ -13349,7 +13490,7 @@
           <p:cNvPr id="6" name="">
             <a:extLst xmlns:a="http://schemas.openxmlformats.org/drawingml/2006/main">
               <a:ext uri="{FF2B5EF4-FFF2-40B4-BE49-F238E27FC236}">
-                <a16:creationId xmlns:a16="http://schemas.microsoft.com/office/drawing/2014/main" id="{99D5BD28-4FDF-4E6B-A123-9DD482C4997B}"/>
+                <a16:creationId xmlns:a16="http://schemas.microsoft.com/office/drawing/2014/main" id="{319F0BA5-82D2-4452-B1E1-D8CCB0B740EE}"/>
               </a:ext>
             </a:extLst>
           </p:cNvPr>
@@ -13399,7 +13540,7 @@
           <p:cNvPr id="7" name="">
             <a:extLst xmlns:a="http://schemas.openxmlformats.org/drawingml/2006/main">
               <a:ext uri="{FF2B5EF4-FFF2-40B4-BE49-F238E27FC236}">
-                <a16:creationId xmlns:a16="http://schemas.microsoft.com/office/drawing/2014/main" id="{C3009063-6349-4378-8E80-65105A1AC73F}"/>
+                <a16:creationId xmlns:a16="http://schemas.microsoft.com/office/drawing/2014/main" id="{A4749911-3362-41CF-9413-6B3EE92634BB}"/>
               </a:ext>
             </a:extLst>
           </p:cNvPr>
@@ -13449,7 +13590,7 @@
           <p:cNvPr id="8" name="">
             <a:extLst xmlns:a="http://schemas.openxmlformats.org/drawingml/2006/main">
               <a:ext uri="{FF2B5EF4-FFF2-40B4-BE49-F238E27FC236}">
-                <a16:creationId xmlns:a16="http://schemas.microsoft.com/office/drawing/2014/main" id="{8085CA29-5CC7-4ACC-B657-A99C8F035BFC}"/>
+                <a16:creationId xmlns:a16="http://schemas.microsoft.com/office/drawing/2014/main" id="{FCAD73A3-DA3E-4BB2-A716-7808A2A3AA2F}"/>
               </a:ext>
             </a:extLst>
           </p:cNvPr>
@@ -13499,7 +13640,7 @@
           <p:cNvPr id="9" name="">
             <a:extLst xmlns:a="http://schemas.openxmlformats.org/drawingml/2006/main">
               <a:ext uri="{FF2B5EF4-FFF2-40B4-BE49-F238E27FC236}">
-                <a16:creationId xmlns:a16="http://schemas.microsoft.com/office/drawing/2014/main" id="{8500558B-8B3E-4BAE-BCC7-5A52D7DEFC86}"/>
+                <a16:creationId xmlns:a16="http://schemas.microsoft.com/office/drawing/2014/main" id="{034170AA-8DDA-45FC-9E63-70FC80B48885}"/>
               </a:ext>
             </a:extLst>
           </p:cNvPr>
@@ -13549,7 +13690,7 @@
           <p:cNvPr id="10" name="">
             <a:extLst xmlns:a="http://schemas.openxmlformats.org/drawingml/2006/main">
               <a:ext uri="{FF2B5EF4-FFF2-40B4-BE49-F238E27FC236}">
-                <a16:creationId xmlns:a16="http://schemas.microsoft.com/office/drawing/2014/main" id="{550090B0-FDE5-4DD5-8D0F-0C01D214B180}"/>
+                <a16:creationId xmlns:a16="http://schemas.microsoft.com/office/drawing/2014/main" id="{47FB5C86-77DC-400F-9786-542C67E07A13}"/>
               </a:ext>
             </a:extLst>
           </p:cNvPr>
@@ -13580,7 +13721,7 @@
           <p:cNvPr id="11" name="">
             <a:extLst xmlns:a="http://schemas.openxmlformats.org/drawingml/2006/main">
               <a:ext uri="{FF2B5EF4-FFF2-40B4-BE49-F238E27FC236}">
-                <a16:creationId xmlns:a16="http://schemas.microsoft.com/office/drawing/2014/main" id="{A7F5790B-6513-4A96-9A49-9A0D5B8F438A}"/>
+                <a16:creationId xmlns:a16="http://schemas.microsoft.com/office/drawing/2014/main" id="{3977B08D-1521-4A2E-8CA1-9FFA63A6F64E}"/>
               </a:ext>
             </a:extLst>
           </p:cNvPr>
@@ -13630,7 +13771,7 @@
           <p:cNvPr id="12" name="">
             <a:extLst xmlns:a="http://schemas.openxmlformats.org/drawingml/2006/main">
               <a:ext uri="{FF2B5EF4-FFF2-40B4-BE49-F238E27FC236}">
-                <a16:creationId xmlns:a16="http://schemas.microsoft.com/office/drawing/2014/main" id="{61C0877D-9117-4FEF-8A01-88EC6CD23F80}"/>
+                <a16:creationId xmlns:a16="http://schemas.microsoft.com/office/drawing/2014/main" id="{B1A21EE9-05A3-4BF5-BC84-90756B23779D}"/>
               </a:ext>
             </a:extLst>
           </p:cNvPr>
@@ -13680,7 +13821,7 @@
           <p:cNvPr id="13" name="">
             <a:extLst xmlns:a="http://schemas.openxmlformats.org/drawingml/2006/main">
               <a:ext uri="{FF2B5EF4-FFF2-40B4-BE49-F238E27FC236}">
-                <a16:creationId xmlns:a16="http://schemas.microsoft.com/office/drawing/2014/main" id="{596D79D7-25BB-460C-86F1-FE31AF1085B9}"/>
+                <a16:creationId xmlns:a16="http://schemas.microsoft.com/office/drawing/2014/main" id="{41B5B5DE-B26A-4519-A9DE-BFAEA29915F3}"/>
               </a:ext>
             </a:extLst>
           </p:cNvPr>
@@ -13730,7 +13871,7 @@
           <p:cNvPr id="14" name="">
             <a:extLst xmlns:a="http://schemas.openxmlformats.org/drawingml/2006/main">
               <a:ext uri="{FF2B5EF4-FFF2-40B4-BE49-F238E27FC236}">
-                <a16:creationId xmlns:a16="http://schemas.microsoft.com/office/drawing/2014/main" id="{1CF7DB0E-8355-4500-B12B-6147706D6583}"/>
+                <a16:creationId xmlns:a16="http://schemas.microsoft.com/office/drawing/2014/main" id="{6F6FF4C8-915E-420C-98FF-6BF8372628F2}"/>
               </a:ext>
             </a:extLst>
           </p:cNvPr>
@@ -13761,7 +13902,7 @@
           <p:cNvPr id="15" name="">
             <a:extLst xmlns:a="http://schemas.openxmlformats.org/drawingml/2006/main">
               <a:ext uri="{FF2B5EF4-FFF2-40B4-BE49-F238E27FC236}">
-                <a16:creationId xmlns:a16="http://schemas.microsoft.com/office/drawing/2014/main" id="{E70DD45F-8125-479B-BDB2-17A570E88045}"/>
+                <a16:creationId xmlns:a16="http://schemas.microsoft.com/office/drawing/2014/main" id="{F876A519-91E6-4FFC-9D27-5484365C11A1}"/>
               </a:ext>
             </a:extLst>
           </p:cNvPr>
@@ -13811,7 +13952,7 @@
           <p:cNvPr id="16" name="">
             <a:extLst xmlns:a="http://schemas.openxmlformats.org/drawingml/2006/main">
               <a:ext uri="{FF2B5EF4-FFF2-40B4-BE49-F238E27FC236}">
-                <a16:creationId xmlns:a16="http://schemas.microsoft.com/office/drawing/2014/main" id="{CEA4134B-8A53-4DF0-8EC4-31291B001480}"/>
+                <a16:creationId xmlns:a16="http://schemas.microsoft.com/office/drawing/2014/main" id="{E86C5DAA-EDA9-47B6-AA34-40CEE7601161}"/>
               </a:ext>
             </a:extLst>
           </p:cNvPr>
@@ -13861,7 +14002,7 @@
           <p:cNvPr id="17" name="">
             <a:extLst xmlns:a="http://schemas.openxmlformats.org/drawingml/2006/main">
               <a:ext uri="{FF2B5EF4-FFF2-40B4-BE49-F238E27FC236}">
-                <a16:creationId xmlns:a16="http://schemas.microsoft.com/office/drawing/2014/main" id="{7861F67A-B1E4-471F-9E02-CE1AEF3E734F}"/>
+                <a16:creationId xmlns:a16="http://schemas.microsoft.com/office/drawing/2014/main" id="{6E7F482C-9CD4-4C4F-A809-A4CDDF01BA8E}"/>
               </a:ext>
             </a:extLst>
           </p:cNvPr>
@@ -13911,7 +14052,7 @@
           <p:cNvPr id="18" name="">
             <a:extLst xmlns:a="http://schemas.openxmlformats.org/drawingml/2006/main">
               <a:ext uri="{FF2B5EF4-FFF2-40B4-BE49-F238E27FC236}">
-                <a16:creationId xmlns:a16="http://schemas.microsoft.com/office/drawing/2014/main" id="{5AD50710-2363-4E87-8056-F8DE4BDB7D1E}"/>
+                <a16:creationId xmlns:a16="http://schemas.microsoft.com/office/drawing/2014/main" id="{F34962E6-AC24-4472-8642-36FE378AFCFC}"/>
               </a:ext>
             </a:extLst>
           </p:cNvPr>
@@ -13942,7 +14083,7 @@
           <p:cNvPr id="19" name="">
             <a:extLst xmlns:a="http://schemas.openxmlformats.org/drawingml/2006/main">
               <a:ext uri="{FF2B5EF4-FFF2-40B4-BE49-F238E27FC236}">
-                <a16:creationId xmlns:a16="http://schemas.microsoft.com/office/drawing/2014/main" id="{FA0BC9C8-6B72-4200-ADE2-44373BC9DED2}"/>
+                <a16:creationId xmlns:a16="http://schemas.microsoft.com/office/drawing/2014/main" id="{C4DBAF07-F51E-48A6-A0A7-54DB3396C77F}"/>
               </a:ext>
             </a:extLst>
           </p:cNvPr>
@@ -13954,7 +14095,7 @@
         <p:spPr>
           <a:xfrm xmlns:a="http://schemas.openxmlformats.org/drawingml/2006/main">
             <a:off x="609600" y="5848350"/>
-            <a:ext cx="8858250" cy="419100"/>
+            <a:ext cx="10763250" cy="381000"/>
           </a:xfrm>
           <a:prstGeom xmlns:a="http://schemas.openxmlformats.org/drawingml/2006/main" prst="rect">
             <a:avLst/>
@@ -13970,19 +14111,19 @@
           <a:lstStyle xmlns:a="http://schemas.openxmlformats.org/drawingml/2006/main"/>
           <a:p xmlns:a="http://schemas.openxmlformats.org/drawingml/2006/main">
             <a:pPr algn="l">
-              <a:defRPr sz="2250" b="1" i="0">
+              <a:defRPr sz="2175" b="1" i="0">
                 <a:solidFill>
                   <a:srgbClr val="2F7D68"/>
                 </a:solidFill>
               </a:defRPr>
             </a:pPr>
             <a:r>
-              <a:rPr sz="2250" b="1" i="0">
+              <a:rPr sz="2175" b="1" i="0">
                 <a:solidFill>
                   <a:srgbClr val="2F7D68"/>
                 </a:solidFill>
               </a:rPr>
-              <a:t>Historical upside. Forward score. Every decision inspectable.</a:t>
+              <a:t>Historical upside. First-close proof. Every decision inspectable.</a:t>
             </a:r>
           </a:p>
         </p:txBody>
@@ -13992,7 +14133,7 @@
           <p:cNvPr id="20" name="">
             <a:extLst xmlns:a="http://schemas.openxmlformats.org/drawingml/2006/main">
               <a:ext uri="{FF2B5EF4-FFF2-40B4-BE49-F238E27FC236}">
-                <a16:creationId xmlns:a16="http://schemas.microsoft.com/office/drawing/2014/main" id="{A2CEA6C0-5862-46F6-A0FC-BA5E6A93264A}"/>
+                <a16:creationId xmlns:a16="http://schemas.microsoft.com/office/drawing/2014/main" id="{728145C5-AE40-4C59-9AE9-F1A0837E173E}"/>
               </a:ext>
             </a:extLst>
           </p:cNvPr>
@@ -14042,7 +14183,7 @@
           <p:cNvPr id="21" name="">
             <a:extLst xmlns:a="http://schemas.openxmlformats.org/drawingml/2006/main">
               <a:ext uri="{FF2B5EF4-FFF2-40B4-BE49-F238E27FC236}">
-                <a16:creationId xmlns:a16="http://schemas.microsoft.com/office/drawing/2014/main" id="{4C4F28FB-19AD-45C3-8DBB-1AB5D982D1B4}"/>
+                <a16:creationId xmlns:a16="http://schemas.microsoft.com/office/drawing/2014/main" id="{06DECAA8-F09F-42D2-B40A-2C4CA27B4482}"/>
               </a:ext>
             </a:extLst>
           </p:cNvPr>
@@ -14092,7 +14233,7 @@
           <p:cNvPr id="22" name="">
             <a:extLst xmlns:a="http://schemas.openxmlformats.org/drawingml/2006/main">
               <a:ext uri="{FF2B5EF4-FFF2-40B4-BE49-F238E27FC236}">
-                <a16:creationId xmlns:a16="http://schemas.microsoft.com/office/drawing/2014/main" id="{8532DF6C-992A-4B63-BF9D-C44EFE4EBB88}"/>
+                <a16:creationId xmlns:a16="http://schemas.microsoft.com/office/drawing/2014/main" id="{AC40B215-3691-4731-8830-0BFB200C4AC6}"/>
               </a:ext>
             </a:extLst>
           </p:cNvPr>
@@ -14142,7 +14283,7 @@
           <p:cNvPr id="23" name="">
             <a:extLst xmlns:a="http://schemas.openxmlformats.org/drawingml/2006/main">
               <a:ext uri="{FF2B5EF4-FFF2-40B4-BE49-F238E27FC236}">
-                <a16:creationId xmlns:a16="http://schemas.microsoft.com/office/drawing/2014/main" id="{70CF069D-79A8-496D-AA42-0533195D0C80}"/>
+                <a16:creationId xmlns:a16="http://schemas.microsoft.com/office/drawing/2014/main" id="{EE3B55E3-A100-4805-94D6-FC6F125C9124}"/>
               </a:ext>
             </a:extLst>
           </p:cNvPr>
@@ -14190,7 +14331,7 @@
     </p:spTree>
     <p:extLst>
       <p:ext uri="{BB962C8B-B14F-4D97-AF65-F5344CB8AC3E}">
-        <p14:creationId xmlns:p14="http://schemas.microsoft.com/office/powerpoint/2010/main" val="2090264826"/>
+        <p14:creationId xmlns:p14="http://schemas.microsoft.com/office/powerpoint/2010/main" val="1718919056"/>
       </p:ext>
     </p:extLst>
   </p:cSld>
@@ -14198,9 +14339,9 @@
 </file>
 
 <file path=ppt/theme/theme1.xml><?xml version="1.0" encoding="utf-8"?>
-<a:theme xmlns:a="http://schemas.openxmlformats.org/drawingml/2006/main" name="Finly">
+<a:theme xmlns:a="http://schemas.openxmlformats.org/drawingml/2006/main" name="ChatGPT">
   <a:themeElements>
-    <a:clrScheme name="Finly">
+    <a:clrScheme name="ChatGPT">
       <a:dk1>
         <a:srgbClr val="000000"/>
       </a:dk1>
@@ -14250,7 +14391,7 @@
         <a:cs typeface="Calibri"/>
       </a:minorFont>
     </a:fontScheme>
-    <a:fmtScheme name="Finly">
+    <a:fmtScheme name="ChatGPT">
       <a:fillStyleLst>
         <a:solidFill>
           <a:schemeClr val="phClr"/>

</xml_diff>

<commit_message>
Clarify Finly for public and technical judges
</commit_message>
<xml_diff>
--- a/public/judge/Finly_Consulting_Deck.pptx
+++ b/public/judge/Finly_Consulting_Deck.pptx
@@ -2,21 +2,21 @@
 <file path=ppt/presentation.xml><?xml version="1.0" encoding="utf-8"?>
 <p:presentation xmlns:p="http://schemas.openxmlformats.org/presentationml/2006/main">
   <p:sldMasterIdLst>
-    <p:sldMasterId xmlns:r="http://schemas.openxmlformats.org/officeDocument/2006/relationships" id="2147483648" r:id="R717fff05e14240c7"/>
+    <p:sldMasterId xmlns:r="http://schemas.openxmlformats.org/officeDocument/2006/relationships" id="2147483648" r:id="Rd64c731fc6d543f9"/>
   </p:sldMasterIdLst>
   <p:notesMasterIdLst>
-    <p:notesMasterId xmlns:r="http://schemas.openxmlformats.org/officeDocument/2006/relationships" r:id="R5ed72c1e437545fd"/>
+    <p:notesMasterId xmlns:r="http://schemas.openxmlformats.org/officeDocument/2006/relationships" r:id="R074184e44c7947f4"/>
   </p:notesMasterIdLst>
   <p:sldIdLst>
-    <p:sldId xmlns:r="http://schemas.openxmlformats.org/officeDocument/2006/relationships" id="256" r:id="R6dffc87ba0024914"/>
-    <p:sldId xmlns:r="http://schemas.openxmlformats.org/officeDocument/2006/relationships" id="257" r:id="Re4d275001c684163"/>
-    <p:sldId xmlns:r="http://schemas.openxmlformats.org/officeDocument/2006/relationships" id="258" r:id="R87bdb07b5ce6434d"/>
-    <p:sldId xmlns:r="http://schemas.openxmlformats.org/officeDocument/2006/relationships" id="259" r:id="Rc3862a69f9b14070"/>
-    <p:sldId xmlns:r="http://schemas.openxmlformats.org/officeDocument/2006/relationships" id="260" r:id="R28cc5034260a426f"/>
-    <p:sldId xmlns:r="http://schemas.openxmlformats.org/officeDocument/2006/relationships" id="261" r:id="Rbd9db375b464404c"/>
-    <p:sldId xmlns:r="http://schemas.openxmlformats.org/officeDocument/2006/relationships" id="262" r:id="R5dd8a24f9aba4a90"/>
-    <p:sldId xmlns:r="http://schemas.openxmlformats.org/officeDocument/2006/relationships" id="263" r:id="Rfbcc2a7c1bb0469b"/>
-    <p:sldId xmlns:r="http://schemas.openxmlformats.org/officeDocument/2006/relationships" id="264" r:id="R1b8a7783484b4616"/>
+    <p:sldId xmlns:r="http://schemas.openxmlformats.org/officeDocument/2006/relationships" id="256" r:id="R8f7dd82d27ee400d"/>
+    <p:sldId xmlns:r="http://schemas.openxmlformats.org/officeDocument/2006/relationships" id="257" r:id="R1418cd57459946ca"/>
+    <p:sldId xmlns:r="http://schemas.openxmlformats.org/officeDocument/2006/relationships" id="258" r:id="R97fe41cdffbf4c65"/>
+    <p:sldId xmlns:r="http://schemas.openxmlformats.org/officeDocument/2006/relationships" id="259" r:id="Rac6dc751e0e443b2"/>
+    <p:sldId xmlns:r="http://schemas.openxmlformats.org/officeDocument/2006/relationships" id="260" r:id="R7e3c452e413a4e14"/>
+    <p:sldId xmlns:r="http://schemas.openxmlformats.org/officeDocument/2006/relationships" id="261" r:id="R2a1ac9083bcb401c"/>
+    <p:sldId xmlns:r="http://schemas.openxmlformats.org/officeDocument/2006/relationships" id="262" r:id="R7084b52038294af5"/>
+    <p:sldId xmlns:r="http://schemas.openxmlformats.org/officeDocument/2006/relationships" id="263" r:id="R4d30fe0dcb7941d9"/>
+    <p:sldId xmlns:r="http://schemas.openxmlformats.org/officeDocument/2006/relationships" id="264" r:id="R89e7187c2b2e4ea8"/>
   </p:sldIdLst>
   <p:sldSz cx="12192000" cy="6858000"/>
   <p:notesSz cx="6858000" cy="9144000"/>
@@ -630,7 +630,7 @@
           </a:p>
           <a:p xmlns:a="http://schemas.openxmlformats.org/drawingml/2006/main">
             <a:r>
-              <a:t>- Interactive product: https://owlsowo.github.io/finly-bot/#demo</a:t>
+              <a:t>- Interactive product: https://owlsowo.github.io/finly-bot/#controls</a:t>
             </a:r>
           </a:p>
           <a:p xmlns:a="http://schemas.openxmlformats.org/drawingml/2006/main">
@@ -815,12 +815,12 @@
           </a:p>
           <a:p xmlns:a="http://schemas.openxmlformats.org/drawingml/2006/main">
             <a:r>
-              <a:t>- Evidence record: 21218 observations, 21/21 positive anchors.</a:t>
+              <a:t>- Evidence record: 21218 observations, 21/21 positive schedule offsets.</a:t>
             </a:r>
           </a:p>
           <a:p xmlns:a="http://schemas.openxmlformats.org/drawingml/2006/main">
             <a:r>
-              <a:t>- Industry-proxy historical stress test; separate from live broker performance.</a:t>
+              <a:t>- Industry-proxy reconstruction; separate from live broker performance and not independent validation. It passed 8/9 precommitted gates but failed the multiple-testing-adjusted statistical gate.</a:t>
             </a:r>
           </a:p>
         </p:txBody>
@@ -1278,7 +1278,7 @@
   </p:cSld>
   <p:clrMap bg1="lt1" tx1="dk1" bg2="lt2" tx2="dk2" accent1="accent1" accent2="accent2" accent3="accent3" accent4="accent4" accent5="accent5" accent6="accent6" hlink="hlink" folHlink="folHlink"/>
   <p:sldLayoutIdLst>
-    <p:sldLayoutId xmlns:r="http://schemas.openxmlformats.org/officeDocument/2006/relationships" id="2147483649" r:id="R78ca42f8d68c41bc"/>
+    <p:sldLayoutId xmlns:r="http://schemas.openxmlformats.org/officeDocument/2006/relationships" id="2147483649" r:id="R35fb1957e40c44a6"/>
   </p:sldLayoutIdLst>
   <p:txStyles>
     <p:titleStyle>
@@ -1816,7 +1816,7 @@
           <c:idx val="0"/>
           <c:order val="0"/>
           <c:tx>
-            <c:v>Finly G4</c:v>
+            <c:v>Finly Core</c:v>
           </c:tx>
           <c:spPr>
             <a:ln xmlns:a="http://schemas.openxmlformats.org/drawingml/2006/main" w="38100">
@@ -2265,7 +2265,7 @@
           <c:idx val="1"/>
           <c:order val="1"/>
           <c:tx>
-            <c:v>SPY</c:v>
+            <c:v>SPY · S&amp;P 500 tracker</c:v>
           </c:tx>
           <c:spPr>
             <a:ln xmlns:a="http://schemas.openxmlformats.org/drawingml/2006/main" w="28575">
@@ -11006,7 +11006,7 @@
           <p:nvPr/>
         </p:nvPicPr>
         <p:blipFill>
-          <a:blip xmlns:r="http://schemas.openxmlformats.org/officeDocument/2006/relationships" xmlns:a="http://schemas.openxmlformats.org/drawingml/2006/main" r:embed="Rc9aedf3502e44335"/>
+          <a:blip xmlns:r="http://schemas.openxmlformats.org/officeDocument/2006/relationships" xmlns:a="http://schemas.openxmlformats.org/drawingml/2006/main" r:embed="R58ba394dfb7d451d"/>
           <a:stretch xmlns:a="http://schemas.openxmlformats.org/drawingml/2006/main"/>
         </p:blipFill>
         <p:spPr>
@@ -11024,7 +11024,7 @@
           <p:cNvPr id="2" name="">
             <a:extLst xmlns:a="http://schemas.openxmlformats.org/drawingml/2006/main">
               <a:ext uri="{FF2B5EF4-FFF2-40B4-BE49-F238E27FC236}">
-                <a16:creationId xmlns:a16="http://schemas.microsoft.com/office/drawing/2014/main" id="{AD90EAA2-760A-46CC-A5A0-6746B06D3225}"/>
+                <a16:creationId xmlns:a16="http://schemas.microsoft.com/office/drawing/2014/main" id="{11FE4909-D815-41BB-82C9-D6D16545328B}"/>
               </a:ext>
             </a:extLst>
           </p:cNvPr>
@@ -11074,7 +11074,7 @@
           <p:cNvPr id="3" name="">
             <a:extLst xmlns:a="http://schemas.openxmlformats.org/drawingml/2006/main">
               <a:ext uri="{FF2B5EF4-FFF2-40B4-BE49-F238E27FC236}">
-                <a16:creationId xmlns:a16="http://schemas.microsoft.com/office/drawing/2014/main" id="{80024471-A600-47DD-8CB6-02EBE1861227}"/>
+                <a16:creationId xmlns:a16="http://schemas.microsoft.com/office/drawing/2014/main" id="{5427DA63-7FF0-4718-A246-262E86E440B2}"/>
               </a:ext>
             </a:extLst>
           </p:cNvPr>
@@ -11114,7 +11114,7 @@
                   <a:srgbClr val="B9DFD2"/>
                 </a:solidFill>
               </a:rPr>
-              <a:t>AI RESEARCH WITH CHECKED EXECUTION</a:t>
+              <a:t>A TESTED PORTFOLIO + A RISK-CONTROLLED AI ASSISTANT</a:t>
             </a:r>
           </a:p>
         </p:txBody>
@@ -11124,7 +11124,7 @@
           <p:cNvPr id="4" name="">
             <a:extLst xmlns:a="http://schemas.openxmlformats.org/drawingml/2006/main">
               <a:ext uri="{FF2B5EF4-FFF2-40B4-BE49-F238E27FC236}">
-                <a16:creationId xmlns:a16="http://schemas.microsoft.com/office/drawing/2014/main" id="{F591A3B4-24EC-4120-B0D4-FDBA9ABA1878}"/>
+                <a16:creationId xmlns:a16="http://schemas.microsoft.com/office/drawing/2014/main" id="{AA1A4446-661A-410E-A23E-4BB30A985944}"/>
               </a:ext>
             </a:extLst>
           </p:cNvPr>
@@ -11152,19 +11152,19 @@
           <a:lstStyle xmlns:a="http://schemas.openxmlformats.org/drawingml/2006/main"/>
           <a:p xmlns:a="http://schemas.openxmlformats.org/drawingml/2006/main">
             <a:pPr algn="l">
-              <a:defRPr sz="3750" b="1" i="0">
+              <a:defRPr sz="3600" b="1" i="0">
                 <a:solidFill>
                   <a:srgbClr val="FFFFFF"/>
                 </a:solidFill>
               </a:defRPr>
             </a:pPr>
             <a:r>
-              <a:rPr sz="3750" b="1" i="0">
+              <a:rPr sz="3600" b="1" i="0">
                 <a:solidFill>
                   <a:srgbClr val="FFFFFF"/>
                 </a:solidFill>
               </a:rPr>
-              <a:t>Finly turns AI research into a checked Alpaca paper order.</a:t>
+              <a:t>Finly combines a market-tested base portfolio with an AI options assistant.</a:t>
             </a:r>
           </a:p>
         </p:txBody>
@@ -11174,7 +11174,7 @@
           <p:cNvPr id="5" name="">
             <a:extLst xmlns:a="http://schemas.openxmlformats.org/drawingml/2006/main">
               <a:ext uri="{FF2B5EF4-FFF2-40B4-BE49-F238E27FC236}">
-                <a16:creationId xmlns:a16="http://schemas.microsoft.com/office/drawing/2014/main" id="{2BCF6638-DBBF-4EBB-9752-6ADFC2A6DDB4}"/>
+                <a16:creationId xmlns:a16="http://schemas.microsoft.com/office/drawing/2014/main" id="{0E9CC69E-0F73-4877-8197-464823A3A1B3}"/>
               </a:ext>
             </a:extLst>
           </p:cNvPr>
@@ -11214,7 +11214,7 @@
                   <a:srgbClr val="D7E3E5"/>
                 </a:solidFill>
               </a:rPr>
-              <a:t>The model explains the market. Code fixes the risk, builds the order, and can still stop it.</a:t>
+              <a:t>AI studies the market. Rules set the risk, build the trade, and can still stop it.</a:t>
             </a:r>
           </a:p>
         </p:txBody>
@@ -11224,7 +11224,7 @@
           <p:cNvPr id="6" name="">
             <a:extLst xmlns:a="http://schemas.openxmlformats.org/drawingml/2006/main">
               <a:ext uri="{FF2B5EF4-FFF2-40B4-BE49-F238E27FC236}">
-                <a16:creationId xmlns:a16="http://schemas.microsoft.com/office/drawing/2014/main" id="{F1036A91-47C8-457D-B3FB-2AAE0C372E24}"/>
+                <a16:creationId xmlns:a16="http://schemas.microsoft.com/office/drawing/2014/main" id="{A50C7B92-F64E-43E0-BE8E-0C8B3AE374A2}"/>
               </a:ext>
             </a:extLst>
           </p:cNvPr>
@@ -11259,7 +11259,7 @@
           <p:nvPr/>
         </p:nvPicPr>
         <p:blipFill>
-          <a:blip xmlns:r="http://schemas.openxmlformats.org/officeDocument/2006/relationships" xmlns:a="http://schemas.openxmlformats.org/drawingml/2006/main" r:embed="R0262f3dee69c48d6"/>
+          <a:blip xmlns:r="http://schemas.openxmlformats.org/officeDocument/2006/relationships" xmlns:a="http://schemas.openxmlformats.org/drawingml/2006/main" r:embed="Rfe187efd24c14d41"/>
           <a:stretch xmlns:a="http://schemas.openxmlformats.org/drawingml/2006/main"/>
         </p:blipFill>
         <p:spPr>
@@ -11277,19 +11277,19 @@
           <p:cNvPr id="8" name="">
             <a:extLst xmlns:a="http://schemas.openxmlformats.org/drawingml/2006/main">
               <a:ext uri="{FF2B5EF4-FFF2-40B4-BE49-F238E27FC236}">
-                <a16:creationId xmlns:a16="http://schemas.microsoft.com/office/drawing/2014/main" id="{14E0689F-6B68-4D2F-9406-F08C02A8CF48}"/>
-              </a:ext>
-            </a:extLst>
-          </p:cNvPr>
-          <p:cNvSpPr>
-            <a:spLocks xmlns:a="http://schemas.openxmlformats.org/drawingml/2006/main" noGrp="1"/>
-          </p:cNvSpPr>
-          <p:nvPr/>
-        </p:nvSpPr>
-        <p:spPr>
-          <a:xfrm xmlns:a="http://schemas.openxmlformats.org/drawingml/2006/main">
-            <a:off x="6762750" y="3676650"/>
-            <a:ext cx="3943350" cy="400050"/>
+                <a16:creationId xmlns:a16="http://schemas.microsoft.com/office/drawing/2014/main" id="{DAA4F876-5EF4-4DD6-8F26-4C8AF31141F7}"/>
+              </a:ext>
+            </a:extLst>
+          </p:cNvPr>
+          <p:cNvSpPr>
+            <a:spLocks xmlns:a="http://schemas.openxmlformats.org/drawingml/2006/main" noGrp="1"/>
+          </p:cNvSpPr>
+          <p:nvPr/>
+        </p:nvSpPr>
+        <p:spPr>
+          <a:xfrm xmlns:a="http://schemas.openxmlformats.org/drawingml/2006/main">
+            <a:off x="6572250" y="3676650"/>
+            <a:ext cx="4324350" cy="400050"/>
           </a:xfrm>
           <a:prstGeom xmlns:a="http://schemas.openxmlformats.org/drawingml/2006/main" prst="rect">
             <a:avLst/>
@@ -11305,19 +11305,19 @@
           <a:lstStyle xmlns:a="http://schemas.openxmlformats.org/drawingml/2006/main"/>
           <a:p xmlns:a="http://schemas.openxmlformats.org/drawingml/2006/main">
             <a:pPr algn="ctr">
-              <a:defRPr sz="1950" b="1" i="0">
+              <a:defRPr sz="1800" b="1" i="0">
                 <a:solidFill>
                   <a:srgbClr val="FFFFFF"/>
                 </a:solidFill>
               </a:defRPr>
             </a:pPr>
             <a:r>
-              <a:rPr sz="1950" b="1" i="0">
+              <a:rPr sz="1800" b="1" i="0">
                 <a:solidFill>
                   <a:srgbClr val="FFFFFF"/>
                 </a:solidFill>
               </a:rPr>
-              <a:t>AI  →  CODE  →  ALPACA</a:t>
+              <a:t>FINLY CORE  +  FINLY OPTIONS</a:t>
             </a:r>
           </a:p>
         </p:txBody>
@@ -11327,7 +11327,7 @@
           <p:cNvPr id="9" name="">
             <a:extLst xmlns:a="http://schemas.openxmlformats.org/drawingml/2006/main">
               <a:ext uri="{FF2B5EF4-FFF2-40B4-BE49-F238E27FC236}">
-                <a16:creationId xmlns:a16="http://schemas.microsoft.com/office/drawing/2014/main" id="{97A0D843-9C13-4A21-A5A1-51E5FDC399C9}"/>
+                <a16:creationId xmlns:a16="http://schemas.microsoft.com/office/drawing/2014/main" id="{8F58CB48-1E53-4020-947A-510F7A0135E1}"/>
               </a:ext>
             </a:extLst>
           </p:cNvPr>
@@ -11367,7 +11367,7 @@
                   <a:srgbClr val="B9DFD2"/>
                 </a:solidFill>
               </a:rPr>
-              <a:t>Interpret  ·  control  ·  execute</a:t>
+              <a:t>Base portfolio  ·  AI assistant</a:t>
             </a:r>
           </a:p>
         </p:txBody>
@@ -11377,7 +11377,7 @@
           <p:cNvPr id="10" name="">
             <a:extLst xmlns:a="http://schemas.openxmlformats.org/drawingml/2006/main">
               <a:ext uri="{FF2B5EF4-FFF2-40B4-BE49-F238E27FC236}">
-                <a16:creationId xmlns:a16="http://schemas.microsoft.com/office/drawing/2014/main" id="{67347397-5C23-4757-9D94-94B848761A6D}"/>
+                <a16:creationId xmlns:a16="http://schemas.microsoft.com/office/drawing/2014/main" id="{C0DE3DFF-4DCF-4A37-AFE3-A4E9667D0F4B}"/>
               </a:ext>
             </a:extLst>
           </p:cNvPr>
@@ -11408,7 +11408,7 @@
           <p:cNvPr id="11" name="">
             <a:extLst xmlns:a="http://schemas.openxmlformats.org/drawingml/2006/main">
               <a:ext uri="{FF2B5EF4-FFF2-40B4-BE49-F238E27FC236}">
-                <a16:creationId xmlns:a16="http://schemas.microsoft.com/office/drawing/2014/main" id="{554398BE-140F-4648-8B2C-5C897060C150}"/>
+                <a16:creationId xmlns:a16="http://schemas.microsoft.com/office/drawing/2014/main" id="{71E4BCD5-5754-45D9-9732-6F73AE279109}"/>
               </a:ext>
             </a:extLst>
           </p:cNvPr>
@@ -11458,7 +11458,7 @@
           <p:cNvPr id="12" name="">
             <a:extLst xmlns:a="http://schemas.openxmlformats.org/drawingml/2006/main">
               <a:ext uri="{FF2B5EF4-FFF2-40B4-BE49-F238E27FC236}">
-                <a16:creationId xmlns:a16="http://schemas.microsoft.com/office/drawing/2014/main" id="{AD63EEA9-6D76-452F-9AD4-677D66B51658}"/>
+                <a16:creationId xmlns:a16="http://schemas.microsoft.com/office/drawing/2014/main" id="{4889EFFC-AD83-45F7-8038-AB53F9784C90}"/>
               </a:ext>
             </a:extLst>
           </p:cNvPr>
@@ -11508,7 +11508,7 @@
           <p:cNvPr id="13" name="">
             <a:extLst xmlns:a="http://schemas.openxmlformats.org/drawingml/2006/main">
               <a:ext uri="{FF2B5EF4-FFF2-40B4-BE49-F238E27FC236}">
-                <a16:creationId xmlns:a16="http://schemas.microsoft.com/office/drawing/2014/main" id="{52513503-53E8-412C-956E-D68D537F5C6A}"/>
+                <a16:creationId xmlns:a16="http://schemas.microsoft.com/office/drawing/2014/main" id="{142EE5C1-B537-4EC9-952B-73B5622CD109}"/>
               </a:ext>
             </a:extLst>
           </p:cNvPr>
@@ -11520,7 +11520,7 @@
         <p:spPr>
           <a:xfrm xmlns:a="http://schemas.openxmlformats.org/drawingml/2006/main">
             <a:off x="3429000" y="5257800"/>
-            <a:ext cx="2095500" cy="571500"/>
+            <a:ext cx="2286000" cy="571500"/>
           </a:xfrm>
           <a:prstGeom xmlns:a="http://schemas.openxmlformats.org/drawingml/2006/main" prst="rect">
             <a:avLst/>
@@ -11558,7 +11558,7 @@
           <p:cNvPr id="14" name="">
             <a:extLst xmlns:a="http://schemas.openxmlformats.org/drawingml/2006/main">
               <a:ext uri="{FF2B5EF4-FFF2-40B4-BE49-F238E27FC236}">
-                <a16:creationId xmlns:a16="http://schemas.microsoft.com/office/drawing/2014/main" id="{ED9C34AE-77B4-492B-9E99-BE32A0C38906}"/>
+                <a16:creationId xmlns:a16="http://schemas.microsoft.com/office/drawing/2014/main" id="{AC18A495-9243-4735-AA12-0956E2D124C3}"/>
               </a:ext>
             </a:extLst>
           </p:cNvPr>
@@ -11570,7 +11570,7 @@
         <p:spPr>
           <a:xfrm xmlns:a="http://schemas.openxmlformats.org/drawingml/2006/main">
             <a:off x="3429000" y="5781675"/>
-            <a:ext cx="2095500" cy="323850"/>
+            <a:ext cx="2286000" cy="323850"/>
           </a:xfrm>
           <a:prstGeom xmlns:a="http://schemas.openxmlformats.org/drawingml/2006/main" prst="rect">
             <a:avLst/>
@@ -11586,19 +11586,19 @@
           <a:lstStyle xmlns:a="http://schemas.openxmlformats.org/drawingml/2006/main"/>
           <a:p xmlns:a="http://schemas.openxmlformats.org/drawingml/2006/main">
             <a:pPr algn="l">
-              <a:defRPr sz="1125" b="1" i="0">
+              <a:defRPr sz="900" b="1" i="0">
                 <a:solidFill>
                   <a:srgbClr val="C5D4D8"/>
                 </a:solidFill>
               </a:defRPr>
             </a:pPr>
             <a:r>
-              <a:rPr sz="1125" b="1" i="0">
+              <a:rPr sz="900" b="1" i="0">
                 <a:solidFill>
                   <a:srgbClr val="C5D4D8"/>
                 </a:solidFill>
               </a:rPr>
-              <a:t>VERSUS SPY</a:t>
+              <a:t>VERSUS THE S&amp;P 500 TRACKER</a:t>
             </a:r>
           </a:p>
         </p:txBody>
@@ -11608,7 +11608,7 @@
           <p:cNvPr id="15" name="">
             <a:extLst xmlns:a="http://schemas.openxmlformats.org/drawingml/2006/main">
               <a:ext uri="{FF2B5EF4-FFF2-40B4-BE49-F238E27FC236}">
-                <a16:creationId xmlns:a16="http://schemas.microsoft.com/office/drawing/2014/main" id="{D92CE264-C5BF-41E9-B399-7B02227B3880}"/>
+                <a16:creationId xmlns:a16="http://schemas.microsoft.com/office/drawing/2014/main" id="{F81B862D-7BF5-4BFD-8461-3F1506850DCE}"/>
               </a:ext>
             </a:extLst>
           </p:cNvPr>
@@ -11648,7 +11648,7 @@
                   <a:srgbClr val="B9DFD2"/>
                 </a:solidFill>
               </a:rPr>
-              <a:t>$100,000</a:t>
+              <a:t>+$153.31</a:t>
             </a:r>
           </a:p>
         </p:txBody>
@@ -11658,7 +11658,7 @@
           <p:cNvPr id="16" name="">
             <a:extLst xmlns:a="http://schemas.openxmlformats.org/drawingml/2006/main">
               <a:ext uri="{FF2B5EF4-FFF2-40B4-BE49-F238E27FC236}">
-                <a16:creationId xmlns:a16="http://schemas.microsoft.com/office/drawing/2014/main" id="{D37766A5-7AE1-4D41-AB50-6A4BE66A9DBD}"/>
+                <a16:creationId xmlns:a16="http://schemas.microsoft.com/office/drawing/2014/main" id="{E2B2B69A-20F5-433C-9AD2-56996A0DFA68}"/>
               </a:ext>
             </a:extLst>
           </p:cNvPr>
@@ -11686,19 +11686,19 @@
           <a:lstStyle xmlns:a="http://schemas.openxmlformats.org/drawingml/2006/main"/>
           <a:p xmlns:a="http://schemas.openxmlformats.org/drawingml/2006/main">
             <a:pPr algn="l">
-              <a:defRPr sz="1125" b="1" i="0">
+              <a:defRPr sz="900" b="1" i="0">
                 <a:solidFill>
                   <a:srgbClr val="C5D4D8"/>
                 </a:solidFill>
               </a:defRPr>
             </a:pPr>
             <a:r>
-              <a:rPr sz="1125" b="1" i="0">
+              <a:rPr sz="900" b="1" i="0">
                 <a:solidFill>
                   <a:srgbClr val="C5D4D8"/>
                 </a:solidFill>
               </a:rPr>
-              <a:t>VERIFIED PAPER ACCOUNT</a:t>
+              <a:t>CORE VS S&amp;P TRACKER · DAY ONE</a:t>
             </a:r>
           </a:p>
         </p:txBody>
@@ -11708,7 +11708,7 @@
           <p:cNvPr id="17" name="">
             <a:extLst xmlns:a="http://schemas.openxmlformats.org/drawingml/2006/main">
               <a:ext uri="{FF2B5EF4-FFF2-40B4-BE49-F238E27FC236}">
-                <a16:creationId xmlns:a16="http://schemas.microsoft.com/office/drawing/2014/main" id="{623CBD99-59A8-49BD-BD11-5E72D457FB7E}"/>
+                <a16:creationId xmlns:a16="http://schemas.microsoft.com/office/drawing/2014/main" id="{CF9A107C-C48D-4ACF-A12A-ACE1E2DEFDCF}"/>
               </a:ext>
             </a:extLst>
           </p:cNvPr>
@@ -11758,7 +11758,7 @@
           <p:cNvPr id="18" name="">
             <a:extLst xmlns:a="http://schemas.openxmlformats.org/drawingml/2006/main">
               <a:ext uri="{FF2B5EF4-FFF2-40B4-BE49-F238E27FC236}">
-                <a16:creationId xmlns:a16="http://schemas.microsoft.com/office/drawing/2014/main" id="{DA370555-A4F2-4F08-A6E2-FE4D79B13581}"/>
+                <a16:creationId xmlns:a16="http://schemas.microsoft.com/office/drawing/2014/main" id="{514B9C1B-1974-4816-BAD1-07636F54DCC0}"/>
               </a:ext>
             </a:extLst>
           </p:cNvPr>
@@ -11808,7 +11808,7 @@
           <p:cNvPr id="19" name="">
             <a:extLst xmlns:a="http://schemas.openxmlformats.org/drawingml/2006/main">
               <a:ext uri="{FF2B5EF4-FFF2-40B4-BE49-F238E27FC236}">
-                <a16:creationId xmlns:a16="http://schemas.microsoft.com/office/drawing/2014/main" id="{BD151476-EB7E-4A29-9EC5-E9D94A457C2B}"/>
+                <a16:creationId xmlns:a16="http://schemas.microsoft.com/office/drawing/2014/main" id="{A5698271-0602-46A3-878E-FD6E740668F9}"/>
               </a:ext>
             </a:extLst>
           </p:cNvPr>
@@ -11858,7 +11858,7 @@
           <p:cNvPr id="20" name="">
             <a:extLst xmlns:a="http://schemas.openxmlformats.org/drawingml/2006/main">
               <a:ext uri="{FF2B5EF4-FFF2-40B4-BE49-F238E27FC236}">
-                <a16:creationId xmlns:a16="http://schemas.microsoft.com/office/drawing/2014/main" id="{E37767AD-F2D1-4683-9B9A-ABDCD541918A}"/>
+                <a16:creationId xmlns:a16="http://schemas.microsoft.com/office/drawing/2014/main" id="{69AA6327-173B-4BD4-8949-81EE2CBD3658}"/>
               </a:ext>
             </a:extLst>
           </p:cNvPr>
@@ -11908,7 +11908,7 @@
           <p:cNvPr id="21" name="">
             <a:extLst xmlns:a="http://schemas.openxmlformats.org/drawingml/2006/main">
               <a:ext uri="{FF2B5EF4-FFF2-40B4-BE49-F238E27FC236}">
-                <a16:creationId xmlns:a16="http://schemas.microsoft.com/office/drawing/2014/main" id="{CEC1C660-7892-4351-8505-2C75D15E48A0}"/>
+                <a16:creationId xmlns:a16="http://schemas.microsoft.com/office/drawing/2014/main" id="{3F17BFCE-C51D-4EE0-AB35-2F64E525D72E}"/>
               </a:ext>
             </a:extLst>
           </p:cNvPr>
@@ -11956,7 +11956,7 @@
     </p:spTree>
     <p:extLst>
       <p:ext uri="{BB962C8B-B14F-4D97-AF65-F5344CB8AC3E}">
-        <p14:creationId xmlns:p14="http://schemas.microsoft.com/office/powerpoint/2010/main" val="1144248906"/>
+        <p14:creationId xmlns:p14="http://schemas.microsoft.com/office/powerpoint/2010/main" val="1431594738"/>
       </p:ext>
     </p:extLst>
   </p:cSld>
@@ -11987,7 +11987,7 @@
           <p:cNvPr id="31" name="">
             <a:extLst xmlns:a="http://schemas.openxmlformats.org/drawingml/2006/main">
               <a:ext uri="{FF2B5EF4-FFF2-40B4-BE49-F238E27FC236}">
-                <a16:creationId xmlns:a16="http://schemas.microsoft.com/office/drawing/2014/main" id="{3E0F9231-3A05-4A30-84D9-74955523128E}"/>
+                <a16:creationId xmlns:a16="http://schemas.microsoft.com/office/drawing/2014/main" id="{1986C93C-BEA6-4C4C-96DC-AC484C5374B0}"/>
               </a:ext>
             </a:extLst>
           </p:cNvPr>
@@ -12037,7 +12037,7 @@
           <p:cNvPr id="2" name="">
             <a:extLst xmlns:a="http://schemas.openxmlformats.org/drawingml/2006/main">
               <a:ext uri="{FF2B5EF4-FFF2-40B4-BE49-F238E27FC236}">
-                <a16:creationId xmlns:a16="http://schemas.microsoft.com/office/drawing/2014/main" id="{3171DF3C-AFF9-40E0-887F-9D44E79E8922}"/>
+                <a16:creationId xmlns:a16="http://schemas.microsoft.com/office/drawing/2014/main" id="{B82A9406-D68F-4107-ADF6-318135800103}"/>
               </a:ext>
             </a:extLst>
           </p:cNvPr>
@@ -12065,19 +12065,19 @@
           <a:lstStyle xmlns:a="http://schemas.openxmlformats.org/drawingml/2006/main"/>
           <a:p xmlns:a="http://schemas.openxmlformats.org/drawingml/2006/main">
             <a:pPr algn="l">
-              <a:defRPr sz="3450" b="1" i="0">
+              <a:defRPr sz="3300" b="1" i="0">
                 <a:solidFill>
                   <a:srgbClr val="122A3E"/>
                 </a:solidFill>
               </a:defRPr>
             </a:pPr>
             <a:r>
-              <a:rPr sz="3450" b="1" i="0">
+              <a:rPr sz="3300" b="1" i="0">
                 <a:solidFill>
                   <a:srgbClr val="122A3E"/>
                 </a:solidFill>
               </a:rPr>
-              <a:t>Trading agents break when one model researches, sizes, and sends.</a:t>
+              <a:t>A trading bot is hard to trust when one model can research, size, and send.</a:t>
             </a:r>
           </a:p>
         </p:txBody>
@@ -12087,7 +12087,7 @@
           <p:cNvPr id="3" name="">
             <a:extLst xmlns:a="http://schemas.openxmlformats.org/drawingml/2006/main">
               <a:ext uri="{FF2B5EF4-FFF2-40B4-BE49-F238E27FC236}">
-                <a16:creationId xmlns:a16="http://schemas.microsoft.com/office/drawing/2014/main" id="{97E692A6-E872-4459-9071-59326AF2B355}"/>
+                <a16:creationId xmlns:a16="http://schemas.microsoft.com/office/drawing/2014/main" id="{4D84756F-D4BA-4B3D-9DE8-567721587148}"/>
               </a:ext>
             </a:extLst>
           </p:cNvPr>
@@ -12137,7 +12137,7 @@
           <p:cNvPr id="4" name="">
             <a:extLst xmlns:a="http://schemas.openxmlformats.org/drawingml/2006/main">
               <a:ext uri="{FF2B5EF4-FFF2-40B4-BE49-F238E27FC236}">
-                <a16:creationId xmlns:a16="http://schemas.microsoft.com/office/drawing/2014/main" id="{35D88B7C-8238-43D8-99F2-CFF497BE6C82}"/>
+                <a16:creationId xmlns:a16="http://schemas.microsoft.com/office/drawing/2014/main" id="{3E95A1F4-1275-4CD1-AC79-BED0FA8401EC}"/>
               </a:ext>
             </a:extLst>
           </p:cNvPr>
@@ -12172,7 +12172,7 @@
           <p:cNvPr id="5" name="">
             <a:extLst xmlns:a="http://schemas.openxmlformats.org/drawingml/2006/main">
               <a:ext uri="{FF2B5EF4-FFF2-40B4-BE49-F238E27FC236}">
-                <a16:creationId xmlns:a16="http://schemas.microsoft.com/office/drawing/2014/main" id="{4131B0F4-DCB7-4AD6-B70B-EBA58B6BA29A}"/>
+                <a16:creationId xmlns:a16="http://schemas.microsoft.com/office/drawing/2014/main" id="{1A819FD9-F4B2-4173-8B9E-442D9A46D13D}"/>
               </a:ext>
             </a:extLst>
           </p:cNvPr>
@@ -12222,7 +12222,7 @@
           <p:cNvPr id="6" name="">
             <a:extLst xmlns:a="http://schemas.openxmlformats.org/drawingml/2006/main">
               <a:ext uri="{FF2B5EF4-FFF2-40B4-BE49-F238E27FC236}">
-                <a16:creationId xmlns:a16="http://schemas.microsoft.com/office/drawing/2014/main" id="{C2E050BF-D5B3-40F6-BFFB-F2B45F262E58}"/>
+                <a16:creationId xmlns:a16="http://schemas.microsoft.com/office/drawing/2014/main" id="{3646EE5F-353F-4ECD-91F8-14FC899874C6}"/>
               </a:ext>
             </a:extLst>
           </p:cNvPr>
@@ -12272,7 +12272,7 @@
           <p:cNvPr id="7" name="">
             <a:extLst xmlns:a="http://schemas.openxmlformats.org/drawingml/2006/main">
               <a:ext uri="{FF2B5EF4-FFF2-40B4-BE49-F238E27FC236}">
-                <a16:creationId xmlns:a16="http://schemas.microsoft.com/office/drawing/2014/main" id="{B01AA9C5-EE9B-40FD-97D0-A471C9337AAB}"/>
+                <a16:creationId xmlns:a16="http://schemas.microsoft.com/office/drawing/2014/main" id="{F4E7FA92-00D3-425F-8E3A-1D39967BE81C}"/>
               </a:ext>
             </a:extLst>
           </p:cNvPr>
@@ -12322,7 +12322,7 @@
           <p:cNvPr id="8" name="">
             <a:extLst xmlns:a="http://schemas.openxmlformats.org/drawingml/2006/main">
               <a:ext uri="{FF2B5EF4-FFF2-40B4-BE49-F238E27FC236}">
-                <a16:creationId xmlns:a16="http://schemas.microsoft.com/office/drawing/2014/main" id="{D27551B8-A9B8-421E-879C-7351BD969669}"/>
+                <a16:creationId xmlns:a16="http://schemas.microsoft.com/office/drawing/2014/main" id="{8B7E2E6E-B911-40FB-B72A-0590D2B49945}"/>
               </a:ext>
             </a:extLst>
           </p:cNvPr>
@@ -12357,7 +12357,7 @@
           <p:cNvPr id="9" name="">
             <a:extLst xmlns:a="http://schemas.openxmlformats.org/drawingml/2006/main">
               <a:ext uri="{FF2B5EF4-FFF2-40B4-BE49-F238E27FC236}">
-                <a16:creationId xmlns:a16="http://schemas.microsoft.com/office/drawing/2014/main" id="{C489A832-ACD2-4785-A110-11C1663D523F}"/>
+                <a16:creationId xmlns:a16="http://schemas.microsoft.com/office/drawing/2014/main" id="{0C168686-25CE-435C-83F4-41CC27E337D0}"/>
               </a:ext>
             </a:extLst>
           </p:cNvPr>
@@ -12407,7 +12407,7 @@
           <p:cNvPr id="10" name="">
             <a:extLst xmlns:a="http://schemas.openxmlformats.org/drawingml/2006/main">
               <a:ext uri="{FF2B5EF4-FFF2-40B4-BE49-F238E27FC236}">
-                <a16:creationId xmlns:a16="http://schemas.microsoft.com/office/drawing/2014/main" id="{C09E4F0C-8FAD-4E31-960C-6C06D86B5386}"/>
+                <a16:creationId xmlns:a16="http://schemas.microsoft.com/office/drawing/2014/main" id="{AFB11398-0BFA-43F5-9A82-845CF2A035F9}"/>
               </a:ext>
             </a:extLst>
           </p:cNvPr>
@@ -12457,7 +12457,7 @@
           <p:cNvPr id="11" name="">
             <a:extLst xmlns:a="http://schemas.openxmlformats.org/drawingml/2006/main">
               <a:ext uri="{FF2B5EF4-FFF2-40B4-BE49-F238E27FC236}">
-                <a16:creationId xmlns:a16="http://schemas.microsoft.com/office/drawing/2014/main" id="{B3C24A2E-6FFF-42FA-8A25-3B735632F78F}"/>
+                <a16:creationId xmlns:a16="http://schemas.microsoft.com/office/drawing/2014/main" id="{1B29A568-3C38-45D0-B979-62495D0E763D}"/>
               </a:ext>
             </a:extLst>
           </p:cNvPr>
@@ -12507,7 +12507,7 @@
           <p:cNvPr id="12" name="">
             <a:extLst xmlns:a="http://schemas.openxmlformats.org/drawingml/2006/main">
               <a:ext uri="{FF2B5EF4-FFF2-40B4-BE49-F238E27FC236}">
-                <a16:creationId xmlns:a16="http://schemas.microsoft.com/office/drawing/2014/main" id="{D20DEC0E-4234-4C6A-9A35-4BDBC2E58187}"/>
+                <a16:creationId xmlns:a16="http://schemas.microsoft.com/office/drawing/2014/main" id="{9F2E7579-2F1B-4228-A463-E4924309A0F1}"/>
               </a:ext>
             </a:extLst>
           </p:cNvPr>
@@ -12542,7 +12542,7 @@
           <p:cNvPr id="13" name="">
             <a:extLst xmlns:a="http://schemas.openxmlformats.org/drawingml/2006/main">
               <a:ext uri="{FF2B5EF4-FFF2-40B4-BE49-F238E27FC236}">
-                <a16:creationId xmlns:a16="http://schemas.microsoft.com/office/drawing/2014/main" id="{99582433-6A04-4550-8D1F-1D89B45AD4C1}"/>
+                <a16:creationId xmlns:a16="http://schemas.microsoft.com/office/drawing/2014/main" id="{B3D77583-849C-4416-B161-B372C484118E}"/>
               </a:ext>
             </a:extLst>
           </p:cNvPr>
@@ -12592,7 +12592,7 @@
           <p:cNvPr id="14" name="">
             <a:extLst xmlns:a="http://schemas.openxmlformats.org/drawingml/2006/main">
               <a:ext uri="{FF2B5EF4-FFF2-40B4-BE49-F238E27FC236}">
-                <a16:creationId xmlns:a16="http://schemas.microsoft.com/office/drawing/2014/main" id="{2E071F72-C2BF-4C8A-BBEC-F8CCE31701BC}"/>
+                <a16:creationId xmlns:a16="http://schemas.microsoft.com/office/drawing/2014/main" id="{FB3F763A-0DFC-4F1A-9756-1F8C2224890A}"/>
               </a:ext>
             </a:extLst>
           </p:cNvPr>
@@ -12642,7 +12642,7 @@
           <p:cNvPr id="15" name="">
             <a:extLst xmlns:a="http://schemas.openxmlformats.org/drawingml/2006/main">
               <a:ext uri="{FF2B5EF4-FFF2-40B4-BE49-F238E27FC236}">
-                <a16:creationId xmlns:a16="http://schemas.microsoft.com/office/drawing/2014/main" id="{5B25CE20-40F4-4A8B-A752-3A9BEF737A70}"/>
+                <a16:creationId xmlns:a16="http://schemas.microsoft.com/office/drawing/2014/main" id="{EC11FD19-C2F2-4EC1-9CC6-7F8424EAFD3E}"/>
               </a:ext>
             </a:extLst>
           </p:cNvPr>
@@ -12692,7 +12692,7 @@
           <p:cNvPr id="16" name="">
             <a:extLst xmlns:a="http://schemas.openxmlformats.org/drawingml/2006/main">
               <a:ext uri="{FF2B5EF4-FFF2-40B4-BE49-F238E27FC236}">
-                <a16:creationId xmlns:a16="http://schemas.microsoft.com/office/drawing/2014/main" id="{7F4A51E2-9B33-46E1-AFD4-F87575502600}"/>
+                <a16:creationId xmlns:a16="http://schemas.microsoft.com/office/drawing/2014/main" id="{C5BE9BA6-C89D-4136-8496-1016812BEB45}"/>
               </a:ext>
             </a:extLst>
           </p:cNvPr>
@@ -12727,7 +12727,7 @@
           <p:cNvPr id="17" name="">
             <a:extLst xmlns:a="http://schemas.openxmlformats.org/drawingml/2006/main">
               <a:ext uri="{FF2B5EF4-FFF2-40B4-BE49-F238E27FC236}">
-                <a16:creationId xmlns:a16="http://schemas.microsoft.com/office/drawing/2014/main" id="{105985E7-FD8F-456B-B052-7A47DF79F6D4}"/>
+                <a16:creationId xmlns:a16="http://schemas.microsoft.com/office/drawing/2014/main" id="{82ABC939-0C2A-431A-853A-E9E0720B29EE}"/>
               </a:ext>
             </a:extLst>
           </p:cNvPr>
@@ -12777,7 +12777,7 @@
           <p:cNvPr id="18" name="">
             <a:extLst xmlns:a="http://schemas.openxmlformats.org/drawingml/2006/main">
               <a:ext uri="{FF2B5EF4-FFF2-40B4-BE49-F238E27FC236}">
-                <a16:creationId xmlns:a16="http://schemas.microsoft.com/office/drawing/2014/main" id="{68ADECD2-DBA3-42A3-932B-70F515DE1240}"/>
+                <a16:creationId xmlns:a16="http://schemas.microsoft.com/office/drawing/2014/main" id="{5126FF4E-18E8-4AA1-A87B-4C4A8CF1EC07}"/>
               </a:ext>
             </a:extLst>
           </p:cNvPr>
@@ -12827,7 +12827,7 @@
           <p:cNvPr id="19" name="">
             <a:extLst xmlns:a="http://schemas.openxmlformats.org/drawingml/2006/main">
               <a:ext uri="{FF2B5EF4-FFF2-40B4-BE49-F238E27FC236}">
-                <a16:creationId xmlns:a16="http://schemas.microsoft.com/office/drawing/2014/main" id="{67DDED9F-6E76-4A87-93E0-6D2B6FF6A6E0}"/>
+                <a16:creationId xmlns:a16="http://schemas.microsoft.com/office/drawing/2014/main" id="{34C8E1DA-F8DE-48A4-8228-A7D139632375}"/>
               </a:ext>
             </a:extLst>
           </p:cNvPr>
@@ -12877,7 +12877,7 @@
           <p:cNvPr id="20" name="">
             <a:extLst xmlns:a="http://schemas.openxmlformats.org/drawingml/2006/main">
               <a:ext uri="{FF2B5EF4-FFF2-40B4-BE49-F238E27FC236}">
-                <a16:creationId xmlns:a16="http://schemas.microsoft.com/office/drawing/2014/main" id="{0BF4E476-CE53-43E5-BFFA-7474EC80D376}"/>
+                <a16:creationId xmlns:a16="http://schemas.microsoft.com/office/drawing/2014/main" id="{D2D3727C-2621-488F-BCE2-CF04CCD0EAD5}"/>
               </a:ext>
             </a:extLst>
           </p:cNvPr>
@@ -12912,7 +12912,7 @@
           <p:cNvPr id="21" name="">
             <a:extLst xmlns:a="http://schemas.openxmlformats.org/drawingml/2006/main">
               <a:ext uri="{FF2B5EF4-FFF2-40B4-BE49-F238E27FC236}">
-                <a16:creationId xmlns:a16="http://schemas.microsoft.com/office/drawing/2014/main" id="{39E72B0B-8E00-4226-8FA9-8B8C14341DA5}"/>
+                <a16:creationId xmlns:a16="http://schemas.microsoft.com/office/drawing/2014/main" id="{A51A1EE8-2BE3-4B8C-9383-637EECFA042F}"/>
               </a:ext>
             </a:extLst>
           </p:cNvPr>
@@ -12962,7 +12962,7 @@
           <p:cNvPr id="22" name="">
             <a:extLst xmlns:a="http://schemas.openxmlformats.org/drawingml/2006/main">
               <a:ext uri="{FF2B5EF4-FFF2-40B4-BE49-F238E27FC236}">
-                <a16:creationId xmlns:a16="http://schemas.microsoft.com/office/drawing/2014/main" id="{C071B5BF-7017-4309-9A2A-EBEA8ED6E5F7}"/>
+                <a16:creationId xmlns:a16="http://schemas.microsoft.com/office/drawing/2014/main" id="{E4E8D9E7-E900-4227-8701-4CF6D8F7BCAD}"/>
               </a:ext>
             </a:extLst>
           </p:cNvPr>
@@ -13012,7 +13012,7 @@
           <p:cNvPr id="23" name="">
             <a:extLst xmlns:a="http://schemas.openxmlformats.org/drawingml/2006/main">
               <a:ext uri="{FF2B5EF4-FFF2-40B4-BE49-F238E27FC236}">
-                <a16:creationId xmlns:a16="http://schemas.microsoft.com/office/drawing/2014/main" id="{323EA14F-B5C5-49B6-81E4-B95CC071DB39}"/>
+                <a16:creationId xmlns:a16="http://schemas.microsoft.com/office/drawing/2014/main" id="{3898A2FD-00B3-408D-8D01-1F7730CD9D39}"/>
               </a:ext>
             </a:extLst>
           </p:cNvPr>
@@ -13062,7 +13062,7 @@
           <p:cNvPr id="24" name="">
             <a:extLst xmlns:a="http://schemas.openxmlformats.org/drawingml/2006/main">
               <a:ext uri="{FF2B5EF4-FFF2-40B4-BE49-F238E27FC236}">
-                <a16:creationId xmlns:a16="http://schemas.microsoft.com/office/drawing/2014/main" id="{4DAA3233-4742-40BB-9C64-4AD72BD6B8F7}"/>
+                <a16:creationId xmlns:a16="http://schemas.microsoft.com/office/drawing/2014/main" id="{7C9FB78C-9857-48D5-BF15-2F6207D37572}"/>
               </a:ext>
             </a:extLst>
           </p:cNvPr>
@@ -13095,7 +13095,7 @@
           <p:cNvPr id="25" name="">
             <a:extLst xmlns:a="http://schemas.openxmlformats.org/drawingml/2006/main">
               <a:ext uri="{FF2B5EF4-FFF2-40B4-BE49-F238E27FC236}">
-                <a16:creationId xmlns:a16="http://schemas.microsoft.com/office/drawing/2014/main" id="{5168639D-A860-417E-BA65-A42ECBAF8B24}"/>
+                <a16:creationId xmlns:a16="http://schemas.microsoft.com/office/drawing/2014/main" id="{7B9311DD-6BE5-4AF3-A8A0-9400CE72153D}"/>
               </a:ext>
             </a:extLst>
           </p:cNvPr>
@@ -13145,7 +13145,7 @@
           <p:cNvPr id="26" name="">
             <a:extLst xmlns:a="http://schemas.openxmlformats.org/drawingml/2006/main">
               <a:ext uri="{FF2B5EF4-FFF2-40B4-BE49-F238E27FC236}">
-                <a16:creationId xmlns:a16="http://schemas.microsoft.com/office/drawing/2014/main" id="{9C5E9252-6E27-4A3C-B0DD-8F9A2E9A0825}"/>
+                <a16:creationId xmlns:a16="http://schemas.microsoft.com/office/drawing/2014/main" id="{2E0314FA-B99B-42B8-85DE-D90B9178E518}"/>
               </a:ext>
             </a:extLst>
           </p:cNvPr>
@@ -13176,7 +13176,7 @@
           <p:cNvPr id="27" name="">
             <a:extLst xmlns:a="http://schemas.openxmlformats.org/drawingml/2006/main">
               <a:ext uri="{FF2B5EF4-FFF2-40B4-BE49-F238E27FC236}">
-                <a16:creationId xmlns:a16="http://schemas.microsoft.com/office/drawing/2014/main" id="{25153099-AF81-40CF-82C3-54FC127E86A4}"/>
+                <a16:creationId xmlns:a16="http://schemas.microsoft.com/office/drawing/2014/main" id="{B0295A7A-BA9B-401D-B464-B15515ED1DE9}"/>
               </a:ext>
             </a:extLst>
           </p:cNvPr>
@@ -13216,7 +13216,7 @@
                   <a:srgbClr val="2F7D68"/>
                 </a:solidFill>
               </a:rPr>
-              <a:t>Useful AI judgment—without unchecked account control.</a:t>
+              <a:t>Useful AI judgment—without handing the model the account keys.</a:t>
             </a:r>
           </a:p>
         </p:txBody>
@@ -13226,7 +13226,7 @@
           <p:cNvPr id="28" name="">
             <a:extLst xmlns:a="http://schemas.openxmlformats.org/drawingml/2006/main">
               <a:ext uri="{FF2B5EF4-FFF2-40B4-BE49-F238E27FC236}">
-                <a16:creationId xmlns:a16="http://schemas.microsoft.com/office/drawing/2014/main" id="{47E3B7D9-8440-4490-A0FD-0602723044AC}"/>
+                <a16:creationId xmlns:a16="http://schemas.microsoft.com/office/drawing/2014/main" id="{6D375671-0487-4112-BD53-7DA34509EBD3}"/>
               </a:ext>
             </a:extLst>
           </p:cNvPr>
@@ -13254,19 +13254,19 @@
           <a:lstStyle xmlns:a="http://schemas.openxmlformats.org/drawingml/2006/main"/>
           <a:p xmlns:a="http://schemas.openxmlformats.org/drawingml/2006/main">
             <a:pPr algn="l">
-              <a:defRPr sz="1800" b="0" i="0">
+              <a:defRPr sz="1725" b="0" i="0">
                 <a:solidFill>
                   <a:srgbClr val="627078"/>
                 </a:solidFill>
               </a:defRPr>
             </a:pPr>
             <a:r>
-              <a:rPr sz="1800" b="0" i="0">
+              <a:rPr sz="1725" b="0" i="0">
                 <a:solidFill>
                   <a:srgbClr val="627078"/>
                 </a:solidFill>
               </a:rPr>
-              <a:t>Finly keeps exposure, option legs, broker fields, and execution permission in deterministic code.</a:t>
+              <a:t>Finly's rules choose the maximum risk, the exact option pair, the order details, and whether a trade may be sent.</a:t>
             </a:r>
           </a:p>
         </p:txBody>
@@ -13276,7 +13276,7 @@
           <p:cNvPr id="29" name="">
             <a:extLst xmlns:a="http://schemas.openxmlformats.org/drawingml/2006/main">
               <a:ext uri="{FF2B5EF4-FFF2-40B4-BE49-F238E27FC236}">
-                <a16:creationId xmlns:a16="http://schemas.microsoft.com/office/drawing/2014/main" id="{34E027CB-5853-46A5-A33D-F5E3B2D35DF8}"/>
+                <a16:creationId xmlns:a16="http://schemas.microsoft.com/office/drawing/2014/main" id="{763959F6-82A8-4968-BDFF-CEFE6C26FFF5}"/>
               </a:ext>
             </a:extLst>
           </p:cNvPr>
@@ -13326,7 +13326,7 @@
           <p:cNvPr id="30" name="">
             <a:extLst xmlns:a="http://schemas.openxmlformats.org/drawingml/2006/main">
               <a:ext uri="{FF2B5EF4-FFF2-40B4-BE49-F238E27FC236}">
-                <a16:creationId xmlns:a16="http://schemas.microsoft.com/office/drawing/2014/main" id="{1B67DDF0-0D57-425E-B9C2-1CE0FDBFA5DB}"/>
+                <a16:creationId xmlns:a16="http://schemas.microsoft.com/office/drawing/2014/main" id="{1042A1F8-5D0C-404F-B9B6-DA31CADEBC46}"/>
               </a:ext>
             </a:extLst>
           </p:cNvPr>
@@ -13374,7 +13374,7 @@
     </p:spTree>
     <p:extLst>
       <p:ext uri="{BB962C8B-B14F-4D97-AF65-F5344CB8AC3E}">
-        <p14:creationId xmlns:p14="http://schemas.microsoft.com/office/powerpoint/2010/main" val="2081686745"/>
+        <p14:creationId xmlns:p14="http://schemas.microsoft.com/office/powerpoint/2010/main" val="516956928"/>
       </p:ext>
     </p:extLst>
   </p:cSld>
@@ -13405,7 +13405,7 @@
           <p:cNvPr id="20" name="">
             <a:extLst xmlns:a="http://schemas.openxmlformats.org/drawingml/2006/main">
               <a:ext uri="{FF2B5EF4-FFF2-40B4-BE49-F238E27FC236}">
-                <a16:creationId xmlns:a16="http://schemas.microsoft.com/office/drawing/2014/main" id="{867BD893-C4E8-4A37-A2A8-D4FE6A55B023}"/>
+                <a16:creationId xmlns:a16="http://schemas.microsoft.com/office/drawing/2014/main" id="{7C8FF1BD-BCC8-4C37-B3E3-CE91507762C0}"/>
               </a:ext>
             </a:extLst>
           </p:cNvPr>
@@ -13455,7 +13455,7 @@
           <p:cNvPr id="2" name="">
             <a:extLst xmlns:a="http://schemas.openxmlformats.org/drawingml/2006/main">
               <a:ext uri="{FF2B5EF4-FFF2-40B4-BE49-F238E27FC236}">
-                <a16:creationId xmlns:a16="http://schemas.microsoft.com/office/drawing/2014/main" id="{50CAC021-84DD-452F-B353-0AB66D743108}"/>
+                <a16:creationId xmlns:a16="http://schemas.microsoft.com/office/drawing/2014/main" id="{CEB46C4B-9312-490E-A880-792A835231F7}"/>
               </a:ext>
             </a:extLst>
           </p:cNvPr>
@@ -13495,7 +13495,7 @@
                   <a:srgbClr val="FFFFFF"/>
                 </a:solidFill>
               </a:rPr>
-              <a:t>Finly gives AI the judgment; deterministic code keeps the keys.</a:t>
+              <a:t>AI explains the opportunity. Rules decide whether money can move.</a:t>
             </a:r>
           </a:p>
         </p:txBody>
@@ -13505,7 +13505,7 @@
           <p:cNvPr id="3" name="">
             <a:extLst xmlns:a="http://schemas.openxmlformats.org/drawingml/2006/main">
               <a:ext uri="{FF2B5EF4-FFF2-40B4-BE49-F238E27FC236}">
-                <a16:creationId xmlns:a16="http://schemas.microsoft.com/office/drawing/2014/main" id="{D741705A-9987-45C3-ABD7-31DF88621191}"/>
+                <a16:creationId xmlns:a16="http://schemas.microsoft.com/office/drawing/2014/main" id="{C539A7E8-A338-4188-A06E-55AADD26EB4A}"/>
               </a:ext>
             </a:extLst>
           </p:cNvPr>
@@ -13550,7 +13550,7 @@
           <p:nvPr/>
         </p:nvPicPr>
         <p:blipFill>
-          <a:blip xmlns:r="http://schemas.openxmlformats.org/officeDocument/2006/relationships" xmlns:a="http://schemas.openxmlformats.org/drawingml/2006/main" r:embed="R138460ac4b494bd3"/>
+          <a:blip xmlns:r="http://schemas.openxmlformats.org/officeDocument/2006/relationships" xmlns:a="http://schemas.openxmlformats.org/drawingml/2006/main" r:embed="R1b8eb6b49d304d96"/>
           <a:stretch xmlns:a="http://schemas.openxmlformats.org/drawingml/2006/main"/>
         </p:blipFill>
         <p:spPr>
@@ -13570,7 +13570,7 @@
           <p:cNvPr id="5" name="">
             <a:extLst xmlns:a="http://schemas.openxmlformats.org/drawingml/2006/main">
               <a:ext uri="{FF2B5EF4-FFF2-40B4-BE49-F238E27FC236}">
-                <a16:creationId xmlns:a16="http://schemas.microsoft.com/office/drawing/2014/main" id="{7087B393-F358-4BC1-BF55-93DD4A91073A}"/>
+                <a16:creationId xmlns:a16="http://schemas.microsoft.com/office/drawing/2014/main" id="{8449D7D5-DAC5-46EC-A3EB-446927F85882}"/>
               </a:ext>
             </a:extLst>
           </p:cNvPr>
@@ -13620,7 +13620,7 @@
           <p:cNvPr id="6" name="">
             <a:extLst xmlns:a="http://schemas.openxmlformats.org/drawingml/2006/main">
               <a:ext uri="{FF2B5EF4-FFF2-40B4-BE49-F238E27FC236}">
-                <a16:creationId xmlns:a16="http://schemas.microsoft.com/office/drawing/2014/main" id="{C236DC3B-37BC-4420-9AA4-6B0B9946A740}"/>
+                <a16:creationId xmlns:a16="http://schemas.microsoft.com/office/drawing/2014/main" id="{4D134D7E-217A-4B98-9C9D-C86C7046FAC3}"/>
               </a:ext>
             </a:extLst>
           </p:cNvPr>
@@ -13660,7 +13660,7 @@
                   <a:srgbClr val="B9DFD2"/>
                 </a:solidFill>
               </a:rPr>
-              <a:t>MODEL</a:t>
+              <a:t>RESEARCH</a:t>
             </a:r>
           </a:p>
         </p:txBody>
@@ -13670,7 +13670,7 @@
           <p:cNvPr id="7" name="">
             <a:extLst xmlns:a="http://schemas.openxmlformats.org/drawingml/2006/main">
               <a:ext uri="{FF2B5EF4-FFF2-40B4-BE49-F238E27FC236}">
-                <a16:creationId xmlns:a16="http://schemas.microsoft.com/office/drawing/2014/main" id="{C7D70E09-9EC4-4497-8E42-875783D36AE5}"/>
+                <a16:creationId xmlns:a16="http://schemas.microsoft.com/office/drawing/2014/main" id="{5125BADB-C2C9-4917-81AD-F26782050DD4}"/>
               </a:ext>
             </a:extLst>
           </p:cNvPr>
@@ -13710,7 +13710,7 @@
                   <a:srgbClr val="FFFFFF"/>
                 </a:solidFill>
               </a:rPr>
-              <a:t>Assess the evidence</a:t>
+              <a:t>Read market evidence</a:t>
             </a:r>
           </a:p>
         </p:txBody>
@@ -13720,7 +13720,7 @@
           <p:cNvPr id="8" name="">
             <a:extLst xmlns:a="http://schemas.openxmlformats.org/drawingml/2006/main">
               <a:ext uri="{FF2B5EF4-FFF2-40B4-BE49-F238E27FC236}">
-                <a16:creationId xmlns:a16="http://schemas.microsoft.com/office/drawing/2014/main" id="{9F669171-837A-4FF4-9EE4-D2047ECA34B6}"/>
+                <a16:creationId xmlns:a16="http://schemas.microsoft.com/office/drawing/2014/main" id="{1CA394FF-A019-493A-8891-7DC966DF9380}"/>
               </a:ext>
             </a:extLst>
           </p:cNvPr>
@@ -13751,7 +13751,7 @@
           <p:cNvPr id="9" name="">
             <a:extLst xmlns:a="http://schemas.openxmlformats.org/drawingml/2006/main">
               <a:ext uri="{FF2B5EF4-FFF2-40B4-BE49-F238E27FC236}">
-                <a16:creationId xmlns:a16="http://schemas.microsoft.com/office/drawing/2014/main" id="{A22C90AD-BED3-4B0E-805A-F270B74BB917}"/>
+                <a16:creationId xmlns:a16="http://schemas.microsoft.com/office/drawing/2014/main" id="{ED2D9C21-B7A0-40B2-AC1B-201763E836DF}"/>
               </a:ext>
             </a:extLst>
           </p:cNvPr>
@@ -13801,7 +13801,7 @@
           <p:cNvPr id="10" name="">
             <a:extLst xmlns:a="http://schemas.openxmlformats.org/drawingml/2006/main">
               <a:ext uri="{FF2B5EF4-FFF2-40B4-BE49-F238E27FC236}">
-                <a16:creationId xmlns:a16="http://schemas.microsoft.com/office/drawing/2014/main" id="{E1134892-0D92-4742-9ED8-C68559C0FC3A}"/>
+                <a16:creationId xmlns:a16="http://schemas.microsoft.com/office/drawing/2014/main" id="{6FB34B8B-254C-46C2-B52B-D10AE4A57998}"/>
               </a:ext>
             </a:extLst>
           </p:cNvPr>
@@ -13841,7 +13841,7 @@
                   <a:srgbClr val="F2C66D"/>
                 </a:solidFill>
               </a:rPr>
-              <a:t>CODE</a:t>
+              <a:t>RISK RULES</a:t>
             </a:r>
           </a:p>
         </p:txBody>
@@ -13851,7 +13851,7 @@
           <p:cNvPr id="11" name="">
             <a:extLst xmlns:a="http://schemas.openxmlformats.org/drawingml/2006/main">
               <a:ext uri="{FF2B5EF4-FFF2-40B4-BE49-F238E27FC236}">
-                <a16:creationId xmlns:a16="http://schemas.microsoft.com/office/drawing/2014/main" id="{8BB6568E-2F6F-4FCF-91F7-42EE93B80164}"/>
+                <a16:creationId xmlns:a16="http://schemas.microsoft.com/office/drawing/2014/main" id="{F66C1363-19FB-4D4D-B347-8233119CF914}"/>
               </a:ext>
             </a:extLst>
           </p:cNvPr>
@@ -13891,7 +13891,7 @@
                   <a:srgbClr val="FFFFFF"/>
                 </a:solidFill>
               </a:rPr>
-              <a:t>Aggregate, size, and build</a:t>
+              <a:t>Set the loss and build</a:t>
             </a:r>
           </a:p>
         </p:txBody>
@@ -13901,7 +13901,7 @@
           <p:cNvPr id="12" name="">
             <a:extLst xmlns:a="http://schemas.openxmlformats.org/drawingml/2006/main">
               <a:ext uri="{FF2B5EF4-FFF2-40B4-BE49-F238E27FC236}">
-                <a16:creationId xmlns:a16="http://schemas.microsoft.com/office/drawing/2014/main" id="{8552309D-7721-4A72-A962-20E06410C26B}"/>
+                <a16:creationId xmlns:a16="http://schemas.microsoft.com/office/drawing/2014/main" id="{3A378443-A129-449F-A989-89D090F647EF}"/>
               </a:ext>
             </a:extLst>
           </p:cNvPr>
@@ -13932,7 +13932,7 @@
           <p:cNvPr id="13" name="">
             <a:extLst xmlns:a="http://schemas.openxmlformats.org/drawingml/2006/main">
               <a:ext uri="{FF2B5EF4-FFF2-40B4-BE49-F238E27FC236}">
-                <a16:creationId xmlns:a16="http://schemas.microsoft.com/office/drawing/2014/main" id="{BDA5AB92-9985-4D50-AADF-61262083EE73}"/>
+                <a16:creationId xmlns:a16="http://schemas.microsoft.com/office/drawing/2014/main" id="{EB25C0F5-574A-4DD9-958A-E0B31A465F27}"/>
               </a:ext>
             </a:extLst>
           </p:cNvPr>
@@ -13982,7 +13982,7 @@
           <p:cNvPr id="14" name="">
             <a:extLst xmlns:a="http://schemas.openxmlformats.org/drawingml/2006/main">
               <a:ext uri="{FF2B5EF4-FFF2-40B4-BE49-F238E27FC236}">
-                <a16:creationId xmlns:a16="http://schemas.microsoft.com/office/drawing/2014/main" id="{69BA0DCB-F601-49F2-863B-8C58B48FF623}"/>
+                <a16:creationId xmlns:a16="http://schemas.microsoft.com/office/drawing/2014/main" id="{CDCE44AA-A622-42F4-AE2A-0DA05E33069D}"/>
               </a:ext>
             </a:extLst>
           </p:cNvPr>
@@ -14022,7 +14022,7 @@
                   <a:srgbClr val="E56B5D"/>
                 </a:solidFill>
               </a:rPr>
-              <a:t>GATE</a:t>
+              <a:t>FINAL CHECK</a:t>
             </a:r>
           </a:p>
         </p:txBody>
@@ -14032,7 +14032,7 @@
           <p:cNvPr id="15" name="">
             <a:extLst xmlns:a="http://schemas.openxmlformats.org/drawingml/2006/main">
               <a:ext uri="{FF2B5EF4-FFF2-40B4-BE49-F238E27FC236}">
-                <a16:creationId xmlns:a16="http://schemas.microsoft.com/office/drawing/2014/main" id="{78F921A3-29E6-4D58-9D7C-F0A0BC5B7EFB}"/>
+                <a16:creationId xmlns:a16="http://schemas.microsoft.com/office/drawing/2014/main" id="{EFB2F24F-19B6-4B13-8D65-88D5F7735243}"/>
               </a:ext>
             </a:extLst>
           </p:cNvPr>
@@ -14082,7 +14082,7 @@
           <p:cNvPr id="16" name="">
             <a:extLst xmlns:a="http://schemas.openxmlformats.org/drawingml/2006/main">
               <a:ext uri="{FF2B5EF4-FFF2-40B4-BE49-F238E27FC236}">
-                <a16:creationId xmlns:a16="http://schemas.microsoft.com/office/drawing/2014/main" id="{D31F2614-0D8A-41EA-88CD-2AA91CE6E3CD}"/>
+                <a16:creationId xmlns:a16="http://schemas.microsoft.com/office/drawing/2014/main" id="{8E089FF8-8F24-42C6-9369-DE1F438FE9AB}"/>
               </a:ext>
             </a:extLst>
           </p:cNvPr>
@@ -14113,7 +14113,7 @@
           <p:cNvPr id="17" name="">
             <a:extLst xmlns:a="http://schemas.openxmlformats.org/drawingml/2006/main">
               <a:ext uri="{FF2B5EF4-FFF2-40B4-BE49-F238E27FC236}">
-                <a16:creationId xmlns:a16="http://schemas.microsoft.com/office/drawing/2014/main" id="{CA60B255-8FBB-4469-9850-AD3AA68EE68F}"/>
+                <a16:creationId xmlns:a16="http://schemas.microsoft.com/office/drawing/2014/main" id="{69459322-F9E3-4489-B77D-656B48CB40A0}"/>
               </a:ext>
             </a:extLst>
           </p:cNvPr>
@@ -14141,19 +14141,19 @@
           <a:lstStyle xmlns:a="http://schemas.openxmlformats.org/drawingml/2006/main"/>
           <a:p xmlns:a="http://schemas.openxmlformats.org/drawingml/2006/main">
             <a:pPr algn="l">
-              <a:defRPr sz="1800" b="1" i="0">
+              <a:defRPr sz="1725" b="1" i="0">
                 <a:solidFill>
                   <a:srgbClr val="B9DFD2"/>
                 </a:solidFill>
               </a:defRPr>
             </a:pPr>
             <a:r>
-              <a:rPr sz="1800" b="1" i="0">
+              <a:rPr sz="1725" b="1" i="0">
                 <a:solidFill>
                   <a:srgbClr val="B9DFD2"/>
                 </a:solidFill>
               </a:rPr>
-              <a:t>The model may explain or veto. It never writes broker fields.</a:t>
+              <a:t>The model may explain or veto. It cannot choose size or write the broker order.</a:t>
             </a:r>
           </a:p>
         </p:txBody>
@@ -14163,7 +14163,7 @@
           <p:cNvPr id="18" name="">
             <a:extLst xmlns:a="http://schemas.openxmlformats.org/drawingml/2006/main">
               <a:ext uri="{FF2B5EF4-FFF2-40B4-BE49-F238E27FC236}">
-                <a16:creationId xmlns:a16="http://schemas.microsoft.com/office/drawing/2014/main" id="{BB366898-39E7-44C1-9135-EF739F3F33A3}"/>
+                <a16:creationId xmlns:a16="http://schemas.microsoft.com/office/drawing/2014/main" id="{09247A68-86C1-4D85-8A21-217EDBACAD8E}"/>
               </a:ext>
             </a:extLst>
           </p:cNvPr>
@@ -14213,7 +14213,7 @@
           <p:cNvPr id="19" name="">
             <a:extLst xmlns:a="http://schemas.openxmlformats.org/drawingml/2006/main">
               <a:ext uri="{FF2B5EF4-FFF2-40B4-BE49-F238E27FC236}">
-                <a16:creationId xmlns:a16="http://schemas.microsoft.com/office/drawing/2014/main" id="{00E0B08B-332E-4621-940F-7A409FF6DCDC}"/>
+                <a16:creationId xmlns:a16="http://schemas.microsoft.com/office/drawing/2014/main" id="{ECDFF23F-E6A1-4318-910F-C24BB87CD208}"/>
               </a:ext>
             </a:extLst>
           </p:cNvPr>
@@ -14261,7 +14261,7 @@
     </p:spTree>
     <p:extLst>
       <p:ext uri="{BB962C8B-B14F-4D97-AF65-F5344CB8AC3E}">
-        <p14:creationId xmlns:p14="http://schemas.microsoft.com/office/powerpoint/2010/main" val="834105618"/>
+        <p14:creationId xmlns:p14="http://schemas.microsoft.com/office/powerpoint/2010/main" val="1165586973"/>
       </p:ext>
     </p:extLst>
   </p:cSld>
@@ -14289,10 +14289,10 @@
       </p:grpSpPr>
       <p:sp>
         <p:nvSpPr>
-          <p:cNvPr id="17" name="">
-            <a:extLst xmlns:a="http://schemas.openxmlformats.org/drawingml/2006/main">
-              <a:ext uri="{FF2B5EF4-FFF2-40B4-BE49-F238E27FC236}">
-                <a16:creationId xmlns:a16="http://schemas.microsoft.com/office/drawing/2014/main" id="{4110A182-DDB3-4EA9-B224-EFE666BB8CB8}"/>
+          <p:cNvPr id="18" name="">
+            <a:extLst xmlns:a="http://schemas.openxmlformats.org/drawingml/2006/main">
+              <a:ext uri="{FF2B5EF4-FFF2-40B4-BE49-F238E27FC236}">
+                <a16:creationId xmlns:a16="http://schemas.microsoft.com/office/drawing/2014/main" id="{5AC01FD0-C3D6-405F-856B-7DEB93383E5B}"/>
               </a:ext>
             </a:extLst>
           </p:cNvPr>
@@ -14342,7 +14342,7 @@
           <p:cNvPr id="2" name="">
             <a:extLst xmlns:a="http://schemas.openxmlformats.org/drawingml/2006/main">
               <a:ext uri="{FF2B5EF4-FFF2-40B4-BE49-F238E27FC236}">
-                <a16:creationId xmlns:a16="http://schemas.microsoft.com/office/drawing/2014/main" id="{EA1F4D72-ED40-44ED-A7F0-D34B651C3E98}"/>
+                <a16:creationId xmlns:a16="http://schemas.microsoft.com/office/drawing/2014/main" id="{302B8132-9857-41F2-8650-572CC8E072A3}"/>
               </a:ext>
             </a:extLst>
           </p:cNvPr>
@@ -14392,19 +14392,19 @@
           <p:cNvPr id="3" name="">
             <a:extLst xmlns:a="http://schemas.openxmlformats.org/drawingml/2006/main">
               <a:ext uri="{FF2B5EF4-FFF2-40B4-BE49-F238E27FC236}">
-                <a16:creationId xmlns:a16="http://schemas.microsoft.com/office/drawing/2014/main" id="{EEE2AB90-6FE0-4B67-9FF6-82A378E2CAE7}"/>
-              </a:ext>
-            </a:extLst>
-          </p:cNvPr>
-          <p:cNvSpPr>
-            <a:spLocks xmlns:a="http://schemas.openxmlformats.org/drawingml/2006/main" noGrp="1"/>
-          </p:cNvSpPr>
-          <p:nvPr/>
-        </p:nvSpPr>
-        <p:spPr>
-          <a:xfrm xmlns:a="http://schemas.openxmlformats.org/drawingml/2006/main">
-            <a:off x="628650" y="1438275"/>
-            <a:ext cx="7620000" cy="266700"/>
+                <a16:creationId xmlns:a16="http://schemas.microsoft.com/office/drawing/2014/main" id="{000419D9-12C3-4CE7-9AE0-CCC7CEAAB44B}"/>
+              </a:ext>
+            </a:extLst>
+          </p:cNvPr>
+          <p:cNvSpPr>
+            <a:spLocks xmlns:a="http://schemas.openxmlformats.org/drawingml/2006/main" noGrp="1"/>
+          </p:cNvSpPr>
+          <p:nvPr/>
+        </p:nvSpPr>
+        <p:spPr>
+          <a:xfrm xmlns:a="http://schemas.openxmlformats.org/drawingml/2006/main">
+            <a:off x="628650" y="1409700"/>
+            <a:ext cx="10477500" cy="266700"/>
           </a:xfrm>
           <a:prstGeom xmlns:a="http://schemas.openxmlformats.org/drawingml/2006/main" prst="rect">
             <a:avLst/>
@@ -14420,45 +14420,95 @@
           <a:lstStyle xmlns:a="http://schemas.openxmlformats.org/drawingml/2006/main"/>
           <a:p xmlns:a="http://schemas.openxmlformats.org/drawingml/2006/main">
             <a:pPr algn="l">
-              <a:defRPr sz="1425" b="0" i="0">
+              <a:defRPr sz="1275" b="0" i="0">
                 <a:solidFill>
                   <a:srgbClr val="627078"/>
                 </a:solidFill>
               </a:defRPr>
             </a:pPr>
             <a:r>
-              <a:rPr sz="1425" b="0" i="0">
+              <a:rPr sz="1275" b="0" i="0">
                 <a:solidFill>
                   <a:srgbClr val="627078"/>
                 </a:solidFill>
               </a:rPr>
-              <a:t>2013–2026 · identical starting capital · modeled 5 bp one-way costs</a:t>
+              <a:t>Finly Core is the rules-based four-fund portfolio: roughly half QQQ, half three trend-selected sectors, and 3% cash.</a:t>
+            </a:r>
+          </a:p>
+        </p:txBody>
+      </p:sp>
+      <p:sp>
+        <p:nvSpPr>
+          <p:cNvPr id="4" name="">
+            <a:extLst xmlns:a="http://schemas.openxmlformats.org/drawingml/2006/main">
+              <a:ext uri="{FF2B5EF4-FFF2-40B4-BE49-F238E27FC236}">
+                <a16:creationId xmlns:a16="http://schemas.microsoft.com/office/drawing/2014/main" id="{8A14DCA1-1C4C-4D21-B212-B9E145F28BDA}"/>
+              </a:ext>
+            </a:extLst>
+          </p:cNvPr>
+          <p:cNvSpPr>
+            <a:spLocks xmlns:a="http://schemas.openxmlformats.org/drawingml/2006/main" noGrp="1"/>
+          </p:cNvSpPr>
+          <p:nvPr/>
+        </p:nvSpPr>
+        <p:spPr>
+          <a:xfrm xmlns:a="http://schemas.openxmlformats.org/drawingml/2006/main">
+            <a:off x="628650" y="1676400"/>
+            <a:ext cx="8096250" cy="228600"/>
+          </a:xfrm>
+          <a:prstGeom xmlns:a="http://schemas.openxmlformats.org/drawingml/2006/main" prst="rect">
+            <a:avLst/>
+          </a:prstGeom>
+          <a:noFill xmlns:a="http://schemas.openxmlformats.org/drawingml/2006/main"/>
+          <a:ln xmlns:a="http://schemas.openxmlformats.org/drawingml/2006/main" w="0">
+            <a:noFill/>
+            <a:prstDash val="solid"/>
+          </a:ln>
+        </p:spPr>
+        <p:txBody>
+          <a:bodyPr xmlns:a="http://schemas.openxmlformats.org/drawingml/2006/main"/>
+          <a:lstStyle xmlns:a="http://schemas.openxmlformats.org/drawingml/2006/main"/>
+          <a:p xmlns:a="http://schemas.openxmlformats.org/drawingml/2006/main">
+            <a:pPr algn="l">
+              <a:defRPr sz="1200" b="0" i="0">
+                <a:solidFill>
+                  <a:srgbClr val="627078"/>
+                </a:solidFill>
+              </a:defRPr>
+            </a:pPr>
+            <a:r>
+              <a:rPr sz="1200" b="0" i="0">
+                <a:solidFill>
+                  <a:srgbClr val="627078"/>
+                </a:solidFill>
+              </a:rPr>
+              <a:t>2013–2026 · same $10,000 start · modeled 0.05% cost per buy or sell</a:t>
             </a:r>
           </a:p>
         </p:txBody>
       </p:sp>
       <p:graphicFrame>
         <p:nvGraphicFramePr>
-          <p:cNvPr id="20" name="Chart"/>
+          <p:cNvPr id="22" name="Chart"/>
           <p:cNvGraphicFramePr/>
           <p:nvPr/>
         </p:nvGraphicFramePr>
         <p:xfrm>
-          <a:off xmlns:a="http://schemas.openxmlformats.org/drawingml/2006/main" x="609600" y="1924050"/>
-          <a:ext xmlns:a="http://schemas.openxmlformats.org/drawingml/2006/main" cx="8667750" cy="3048000"/>
+          <a:off xmlns:a="http://schemas.openxmlformats.org/drawingml/2006/main" x="609600" y="2000250"/>
+          <a:ext xmlns:a="http://schemas.openxmlformats.org/drawingml/2006/main" cx="8667750" cy="2971800"/>
         </p:xfrm>
         <a:graphic xmlns:a="http://schemas.openxmlformats.org/drawingml/2006/main">
           <a:graphicData uri="http://schemas.openxmlformats.org/drawingml/2006/chart">
-            <c:chart xmlns:r="http://schemas.openxmlformats.org/officeDocument/2006/relationships" xmlns:c="http://schemas.openxmlformats.org/drawingml/2006/chart" r:id="R36741bb618e64cca"/>
+            <c:chart xmlns:r="http://schemas.openxmlformats.org/officeDocument/2006/relationships" xmlns:c="http://schemas.openxmlformats.org/drawingml/2006/chart" r:id="Rd693f4b01aca4870"/>
           </a:graphicData>
         </a:graphic>
       </p:graphicFrame>
       <p:sp>
         <p:nvSpPr>
-          <p:cNvPr id="5" name="">
-            <a:extLst xmlns:a="http://schemas.openxmlformats.org/drawingml/2006/main">
-              <a:ext uri="{FF2B5EF4-FFF2-40B4-BE49-F238E27FC236}">
-                <a16:creationId xmlns:a16="http://schemas.microsoft.com/office/drawing/2014/main" id="{6271C6DB-DA2F-4266-BE02-46A94E7BB9BA}"/>
+          <p:cNvPr id="6" name="">
+            <a:extLst xmlns:a="http://schemas.openxmlformats.org/drawingml/2006/main">
+              <a:ext uri="{FF2B5EF4-FFF2-40B4-BE49-F238E27FC236}">
+                <a16:creationId xmlns:a16="http://schemas.microsoft.com/office/drawing/2014/main" id="{201FCF0A-398D-4A07-AAEA-4D4A28D0118D}"/>
               </a:ext>
             </a:extLst>
           </p:cNvPr>
@@ -14505,10 +14555,10 @@
       </p:sp>
       <p:sp>
         <p:nvSpPr>
-          <p:cNvPr id="6" name="">
-            <a:extLst xmlns:a="http://schemas.openxmlformats.org/drawingml/2006/main">
-              <a:ext uri="{FF2B5EF4-FFF2-40B4-BE49-F238E27FC236}">
-                <a16:creationId xmlns:a16="http://schemas.microsoft.com/office/drawing/2014/main" id="{6842F263-B659-4EE3-8B89-ACB0E1697356}"/>
+          <p:cNvPr id="7" name="">
+            <a:extLst xmlns:a="http://schemas.openxmlformats.org/drawingml/2006/main">
+              <a:ext uri="{FF2B5EF4-FFF2-40B4-BE49-F238E27FC236}">
+                <a16:creationId xmlns:a16="http://schemas.microsoft.com/office/drawing/2014/main" id="{99DEE45E-55C6-44E6-98B9-C1B87ED82D2F}"/>
               </a:ext>
             </a:extLst>
           </p:cNvPr>
@@ -14555,10 +14605,10 @@
       </p:sp>
       <p:sp>
         <p:nvSpPr>
-          <p:cNvPr id="7" name="">
-            <a:extLst xmlns:a="http://schemas.openxmlformats.org/drawingml/2006/main">
-              <a:ext uri="{FF2B5EF4-FFF2-40B4-BE49-F238E27FC236}">
-                <a16:creationId xmlns:a16="http://schemas.microsoft.com/office/drawing/2014/main" id="{8624335A-41A4-40DD-8F5A-59E41F2191F5}"/>
+          <p:cNvPr id="8" name="">
+            <a:extLst xmlns:a="http://schemas.openxmlformats.org/drawingml/2006/main">
+              <a:ext uri="{FF2B5EF4-FFF2-40B4-BE49-F238E27FC236}">
+                <a16:creationId xmlns:a16="http://schemas.microsoft.com/office/drawing/2014/main" id="{3139BDDC-ED9D-4052-98F2-EF3E5EA26344}"/>
               </a:ext>
             </a:extLst>
           </p:cNvPr>
@@ -14605,10 +14655,10 @@
       </p:sp>
       <p:sp>
         <p:nvSpPr>
-          <p:cNvPr id="8" name="">
-            <a:extLst xmlns:a="http://schemas.openxmlformats.org/drawingml/2006/main">
-              <a:ext uri="{FF2B5EF4-FFF2-40B4-BE49-F238E27FC236}">
-                <a16:creationId xmlns:a16="http://schemas.microsoft.com/office/drawing/2014/main" id="{F3990AA1-F7FE-4CF9-990B-2042D89FA1EF}"/>
+          <p:cNvPr id="9" name="">
+            <a:extLst xmlns:a="http://schemas.openxmlformats.org/drawingml/2006/main">
+              <a:ext uri="{FF2B5EF4-FFF2-40B4-BE49-F238E27FC236}">
+                <a16:creationId xmlns:a16="http://schemas.microsoft.com/office/drawing/2014/main" id="{4EEDBE21-CE18-4FD0-9C66-2BAF4394837F}"/>
               </a:ext>
             </a:extLst>
           </p:cNvPr>
@@ -14655,10 +14705,10 @@
       </p:sp>
       <p:sp>
         <p:nvSpPr>
-          <p:cNvPr id="9" name="">
-            <a:extLst xmlns:a="http://schemas.openxmlformats.org/drawingml/2006/main">
-              <a:ext uri="{FF2B5EF4-FFF2-40B4-BE49-F238E27FC236}">
-                <a16:creationId xmlns:a16="http://schemas.microsoft.com/office/drawing/2014/main" id="{17C09CBE-EB40-4F44-9902-25F992BB6B20}"/>
+          <p:cNvPr id="10" name="">
+            <a:extLst xmlns:a="http://schemas.openxmlformats.org/drawingml/2006/main">
+              <a:ext uri="{FF2B5EF4-FFF2-40B4-BE49-F238E27FC236}">
+                <a16:creationId xmlns:a16="http://schemas.microsoft.com/office/drawing/2014/main" id="{F74EDEA7-490B-43AD-9C71-D739F7B48A52}"/>
               </a:ext>
             </a:extLst>
           </p:cNvPr>
@@ -14705,10 +14755,10 @@
       </p:sp>
       <p:sp>
         <p:nvSpPr>
-          <p:cNvPr id="10" name="">
-            <a:extLst xmlns:a="http://schemas.openxmlformats.org/drawingml/2006/main">
-              <a:ext uri="{FF2B5EF4-FFF2-40B4-BE49-F238E27FC236}">
-                <a16:creationId xmlns:a16="http://schemas.microsoft.com/office/drawing/2014/main" id="{3ADEBF46-6D4F-45DB-B25D-8B5138AB5B93}"/>
+          <p:cNvPr id="11" name="">
+            <a:extLst xmlns:a="http://schemas.openxmlformats.org/drawingml/2006/main">
+              <a:ext uri="{FF2B5EF4-FFF2-40B4-BE49-F238E27FC236}">
+                <a16:creationId xmlns:a16="http://schemas.microsoft.com/office/drawing/2014/main" id="{5BAB54F1-F6AB-4011-A5B2-8EF63A00AF62}"/>
               </a:ext>
             </a:extLst>
           </p:cNvPr>
@@ -14755,7 +14805,7 @@
       </p:sp>
       <p:graphicFrame>
         <p:nvGraphicFramePr>
-          <p:cNvPr id="27" name="Chart"/>
+          <p:cNvPr id="29" name="Chart"/>
           <p:cNvGraphicFramePr/>
           <p:nvPr/>
         </p:nvGraphicFramePr>
@@ -14765,16 +14815,16 @@
         </p:xfrm>
         <a:graphic xmlns:a="http://schemas.openxmlformats.org/drawingml/2006/main">
           <a:graphicData uri="http://schemas.openxmlformats.org/drawingml/2006/chart">
-            <c:chart xmlns:r="http://schemas.openxmlformats.org/officeDocument/2006/relationships" xmlns:c="http://schemas.openxmlformats.org/drawingml/2006/chart" r:id="Rf4975e14a0234796"/>
+            <c:chart xmlns:r="http://schemas.openxmlformats.org/officeDocument/2006/relationships" xmlns:c="http://schemas.openxmlformats.org/drawingml/2006/chart" r:id="Ra1ccf97e81d248d6"/>
           </a:graphicData>
         </a:graphic>
       </p:graphicFrame>
       <p:sp>
         <p:nvSpPr>
-          <p:cNvPr id="12" name="">
-            <a:extLst xmlns:a="http://schemas.openxmlformats.org/drawingml/2006/main">
-              <a:ext uri="{FF2B5EF4-FFF2-40B4-BE49-F238E27FC236}">
-                <a16:creationId xmlns:a16="http://schemas.microsoft.com/office/drawing/2014/main" id="{D1894BCC-0D99-4D1B-A9AF-07BE882A9D8E}"/>
+          <p:cNvPr id="13" name="">
+            <a:extLst xmlns:a="http://schemas.openxmlformats.org/drawingml/2006/main">
+              <a:ext uri="{FF2B5EF4-FFF2-40B4-BE49-F238E27FC236}">
+                <a16:creationId xmlns:a16="http://schemas.microsoft.com/office/drawing/2014/main" id="{BCA49960-522F-4774-8CBF-7F903639C481}"/>
               </a:ext>
             </a:extLst>
           </p:cNvPr>
@@ -14786,7 +14836,7 @@
         <p:spPr>
           <a:xfrm xmlns:a="http://schemas.openxmlformats.org/drawingml/2006/main">
             <a:off x="1752600" y="4972050"/>
-            <a:ext cx="1143000" cy="190500"/>
+            <a:ext cx="2476500" cy="190500"/>
           </a:xfrm>
           <a:prstGeom xmlns:a="http://schemas.openxmlformats.org/drawingml/2006/main" prst="rect">
             <a:avLst/>
@@ -14814,17 +14864,17 @@
                   <a:srgbClr val="627078"/>
                 </a:solidFill>
               </a:rPr>
-              <a:t>DRAWDOWN</a:t>
+              <a:t>DECLINE FROM A PREVIOUS HIGH</a:t>
             </a:r>
           </a:p>
         </p:txBody>
       </p:sp>
       <p:sp>
         <p:nvSpPr>
-          <p:cNvPr id="13" name="">
-            <a:extLst xmlns:a="http://schemas.openxmlformats.org/drawingml/2006/main">
-              <a:ext uri="{FF2B5EF4-FFF2-40B4-BE49-F238E27FC236}">
-                <a16:creationId xmlns:a16="http://schemas.microsoft.com/office/drawing/2014/main" id="{495CC59C-D5F7-469F-972C-1AB706EF6608}"/>
+          <p:cNvPr id="14" name="">
+            <a:extLst xmlns:a="http://schemas.openxmlformats.org/drawingml/2006/main">
+              <a:ext uri="{FF2B5EF4-FFF2-40B4-BE49-F238E27FC236}">
+                <a16:creationId xmlns:a16="http://schemas.microsoft.com/office/drawing/2014/main" id="{FC520FC9-0BE2-4DC2-91AE-4F8958D5E5ED}"/>
               </a:ext>
             </a:extLst>
           </p:cNvPr>
@@ -14864,17 +14914,17 @@
                   <a:srgbClr val="627078"/>
                 </a:solidFill>
               </a:rPr>
-              <a:t>MAX DRAWDOWN</a:t>
+              <a:t>WORST DECLINE</a:t>
             </a:r>
           </a:p>
         </p:txBody>
       </p:sp>
       <p:sp>
         <p:nvSpPr>
-          <p:cNvPr id="14" name="">
-            <a:extLst xmlns:a="http://schemas.openxmlformats.org/drawingml/2006/main">
-              <a:ext uri="{FF2B5EF4-FFF2-40B4-BE49-F238E27FC236}">
-                <a16:creationId xmlns:a16="http://schemas.microsoft.com/office/drawing/2014/main" id="{A3ADF422-E1C6-4480-A6FB-469945A2A997}"/>
+          <p:cNvPr id="15" name="">
+            <a:extLst xmlns:a="http://schemas.openxmlformats.org/drawingml/2006/main">
+              <a:ext uri="{FF2B5EF4-FFF2-40B4-BE49-F238E27FC236}">
+                <a16:creationId xmlns:a16="http://schemas.microsoft.com/office/drawing/2014/main" id="{FAB73D92-92B1-4944-895B-DEB06AE35BCF}"/>
               </a:ext>
             </a:extLst>
           </p:cNvPr>
@@ -14938,10 +14988,10 @@
       </p:sp>
       <p:sp>
         <p:nvSpPr>
-          <p:cNvPr id="15" name="">
-            <a:extLst xmlns:a="http://schemas.openxmlformats.org/drawingml/2006/main">
-              <a:ext uri="{FF2B5EF4-FFF2-40B4-BE49-F238E27FC236}">
-                <a16:creationId xmlns:a16="http://schemas.microsoft.com/office/drawing/2014/main" id="{504C3AE3-FC8E-4793-80BF-CCCB49CFCD40}"/>
+          <p:cNvPr id="16" name="">
+            <a:extLst xmlns:a="http://schemas.openxmlformats.org/drawingml/2006/main">
+              <a:ext uri="{FF2B5EF4-FFF2-40B4-BE49-F238E27FC236}">
+                <a16:creationId xmlns:a16="http://schemas.microsoft.com/office/drawing/2014/main" id="{6176B05D-F5FA-4014-A206-4119AD65C76E}"/>
               </a:ext>
             </a:extLst>
           </p:cNvPr>
@@ -14988,10 +15038,10 @@
       </p:sp>
       <p:sp>
         <p:nvSpPr>
-          <p:cNvPr id="16" name="">
-            <a:extLst xmlns:a="http://schemas.openxmlformats.org/drawingml/2006/main">
-              <a:ext uri="{FF2B5EF4-FFF2-40B4-BE49-F238E27FC236}">
-                <a16:creationId xmlns:a16="http://schemas.microsoft.com/office/drawing/2014/main" id="{195B730D-5471-4AE9-9F3D-E4D5FD692683}"/>
+          <p:cNvPr id="17" name="">
+            <a:extLst xmlns:a="http://schemas.openxmlformats.org/drawingml/2006/main">
+              <a:ext uri="{FF2B5EF4-FFF2-40B4-BE49-F238E27FC236}">
+                <a16:creationId xmlns:a16="http://schemas.microsoft.com/office/drawing/2014/main" id="{2AD6531E-D0DD-4ED1-B6F7-662F377AC9B4}"/>
               </a:ext>
             </a:extLst>
           </p:cNvPr>
@@ -15039,7 +15089,7 @@
     </p:spTree>
     <p:extLst>
       <p:ext uri="{BB962C8B-B14F-4D97-AF65-F5344CB8AC3E}">
-        <p14:creationId xmlns:p14="http://schemas.microsoft.com/office/powerpoint/2010/main" val="1161442064"/>
+        <p14:creationId xmlns:p14="http://schemas.microsoft.com/office/powerpoint/2010/main" val="757387756"/>
       </p:ext>
     </p:extLst>
   </p:cSld>
@@ -15070,7 +15120,7 @@
           <p:cNvPr id="45" name="">
             <a:extLst xmlns:a="http://schemas.openxmlformats.org/drawingml/2006/main">
               <a:ext uri="{FF2B5EF4-FFF2-40B4-BE49-F238E27FC236}">
-                <a16:creationId xmlns:a16="http://schemas.microsoft.com/office/drawing/2014/main" id="{1CCEB1F6-DBF2-4424-B4F5-A32662CB7357}"/>
+                <a16:creationId xmlns:a16="http://schemas.microsoft.com/office/drawing/2014/main" id="{49FFCFDB-78D0-49B2-A419-A64944A7F598}"/>
               </a:ext>
             </a:extLst>
           </p:cNvPr>
@@ -15110,7 +15160,7 @@
                   <a:srgbClr val="F2C66D"/>
                 </a:solidFill>
               </a:rPr>
-              <a:t>OUT-OF-ERA STRESS TEST</a:t>
+              <a:t>A SEPARATE HISTORICAL STRESS TEST</a:t>
             </a:r>
           </a:p>
         </p:txBody>
@@ -15120,7 +15170,7 @@
           <p:cNvPr id="2" name="">
             <a:extLst xmlns:a="http://schemas.openxmlformats.org/drawingml/2006/main">
               <a:ext uri="{FF2B5EF4-FFF2-40B4-BE49-F238E27FC236}">
-                <a16:creationId xmlns:a16="http://schemas.microsoft.com/office/drawing/2014/main" id="{4DD5A562-AF58-45BE-A9EF-96319ABE42DE}"/>
+                <a16:creationId xmlns:a16="http://schemas.microsoft.com/office/drawing/2014/main" id="{506DC54A-9CA1-4208-95EF-6C7DEB5339B4}"/>
               </a:ext>
             </a:extLst>
           </p:cNvPr>
@@ -15148,19 +15198,19 @@
           <a:lstStyle xmlns:a="http://schemas.openxmlformats.org/drawingml/2006/main"/>
           <a:p xmlns:a="http://schemas.openxmlformats.org/drawingml/2006/main">
             <a:pPr algn="l">
-              <a:defRPr sz="3375" b="1" i="0">
+              <a:defRPr sz="3075" b="1" i="0">
                 <a:solidFill>
                   <a:srgbClr val="FFFFFF"/>
                 </a:solidFill>
               </a:defRPr>
             </a:pPr>
             <a:r>
-              <a:rPr sz="3375" b="1" i="0">
+              <a:rPr sz="3075" b="1" i="0">
                 <a:solidFill>
                   <a:srgbClr val="FFFFFF"/>
                 </a:solidFill>
               </a:rPr>
-              <a:t>The edge survived 80 earlier years, 21 timing choices, and 5× higher costs.</a:t>
+              <a:t>An 80-year industry test stayed ahead over the full period under every monthly start date tested.</a:t>
             </a:r>
           </a:p>
         </p:txBody>
@@ -15170,7 +15220,7 @@
           <p:cNvPr id="3" name="">
             <a:extLst xmlns:a="http://schemas.openxmlformats.org/drawingml/2006/main">
               <a:ext uri="{FF2B5EF4-FFF2-40B4-BE49-F238E27FC236}">
-                <a16:creationId xmlns:a16="http://schemas.microsoft.com/office/drawing/2014/main" id="{ED5A95F2-D5CF-4BA4-A2BC-28CA1EF8597C}"/>
+                <a16:creationId xmlns:a16="http://schemas.microsoft.com/office/drawing/2014/main" id="{4DC127E0-F527-461C-BD14-0AA3C6471AD2}"/>
               </a:ext>
             </a:extLst>
           </p:cNvPr>
@@ -15201,7 +15251,7 @@
           <p:cNvPr id="4" name="">
             <a:extLst xmlns:a="http://schemas.openxmlformats.org/drawingml/2006/main">
               <a:ext uri="{FF2B5EF4-FFF2-40B4-BE49-F238E27FC236}">
-                <a16:creationId xmlns:a16="http://schemas.microsoft.com/office/drawing/2014/main" id="{F408B52D-2DA9-44E8-9ACD-C8C0BE66A94F}"/>
+                <a16:creationId xmlns:a16="http://schemas.microsoft.com/office/drawing/2014/main" id="{7D87879C-96F7-4978-BB95-9DF2FD0257FD}"/>
               </a:ext>
             </a:extLst>
           </p:cNvPr>
@@ -15232,7 +15282,7 @@
           <p:cNvPr id="5" name="">
             <a:extLst xmlns:a="http://schemas.openxmlformats.org/drawingml/2006/main">
               <a:ext uri="{FF2B5EF4-FFF2-40B4-BE49-F238E27FC236}">
-                <a16:creationId xmlns:a16="http://schemas.microsoft.com/office/drawing/2014/main" id="{BBB2A8D8-2367-47B9-A1CB-EA8F7C9E6C98}"/>
+                <a16:creationId xmlns:a16="http://schemas.microsoft.com/office/drawing/2014/main" id="{456829EE-EF84-4DEE-B5E5-68AACA18FC7A}"/>
               </a:ext>
             </a:extLst>
           </p:cNvPr>
@@ -15263,7 +15313,7 @@
           <p:cNvPr id="6" name="">
             <a:extLst xmlns:a="http://schemas.openxmlformats.org/drawingml/2006/main">
               <a:ext uri="{FF2B5EF4-FFF2-40B4-BE49-F238E27FC236}">
-                <a16:creationId xmlns:a16="http://schemas.microsoft.com/office/drawing/2014/main" id="{4336458D-0EA6-49A0-A277-9656D21352F1}"/>
+                <a16:creationId xmlns:a16="http://schemas.microsoft.com/office/drawing/2014/main" id="{4D3071C7-DF31-439C-8D64-626F3AE226D3}"/>
               </a:ext>
             </a:extLst>
           </p:cNvPr>
@@ -15313,7 +15363,7 @@
           <p:cNvPr id="7" name="">
             <a:extLst xmlns:a="http://schemas.openxmlformats.org/drawingml/2006/main">
               <a:ext uri="{FF2B5EF4-FFF2-40B4-BE49-F238E27FC236}">
-                <a16:creationId xmlns:a16="http://schemas.microsoft.com/office/drawing/2014/main" id="{6EBF30CF-3183-48C3-958E-DAB9EB554BDE}"/>
+                <a16:creationId xmlns:a16="http://schemas.microsoft.com/office/drawing/2014/main" id="{C9D516B3-12ED-485E-AED5-66ADE021B308}"/>
               </a:ext>
             </a:extLst>
           </p:cNvPr>
@@ -15363,7 +15413,7 @@
           <p:cNvPr id="8" name="">
             <a:extLst xmlns:a="http://schemas.openxmlformats.org/drawingml/2006/main">
               <a:ext uri="{FF2B5EF4-FFF2-40B4-BE49-F238E27FC236}">
-                <a16:creationId xmlns:a16="http://schemas.microsoft.com/office/drawing/2014/main" id="{1B8B1A0E-8028-47D6-8B4E-8998DA32AB4A}"/>
+                <a16:creationId xmlns:a16="http://schemas.microsoft.com/office/drawing/2014/main" id="{A0ADFD0F-714D-4931-A25A-FC20CA55B721}"/>
               </a:ext>
             </a:extLst>
           </p:cNvPr>
@@ -15413,7 +15463,7 @@
           <p:cNvPr id="9" name="">
             <a:extLst xmlns:a="http://schemas.openxmlformats.org/drawingml/2006/main">
               <a:ext uri="{FF2B5EF4-FFF2-40B4-BE49-F238E27FC236}">
-                <a16:creationId xmlns:a16="http://schemas.microsoft.com/office/drawing/2014/main" id="{6BAD7AE6-B7A8-4076-B358-4F1FF52711EF}"/>
+                <a16:creationId xmlns:a16="http://schemas.microsoft.com/office/drawing/2014/main" id="{D170E840-250D-4C90-84D4-6F216C86BC13}"/>
               </a:ext>
             </a:extLst>
           </p:cNvPr>
@@ -15463,7 +15513,7 @@
           <p:cNvPr id="10" name="">
             <a:extLst xmlns:a="http://schemas.openxmlformats.org/drawingml/2006/main">
               <a:ext uri="{FF2B5EF4-FFF2-40B4-BE49-F238E27FC236}">
-                <a16:creationId xmlns:a16="http://schemas.microsoft.com/office/drawing/2014/main" id="{B140C37A-BE6F-44D7-AB0B-05E6598BBE95}"/>
+                <a16:creationId xmlns:a16="http://schemas.microsoft.com/office/drawing/2014/main" id="{F80D7D22-62E9-44CA-9F00-FF0E60867ABB}"/>
               </a:ext>
             </a:extLst>
           </p:cNvPr>
@@ -15513,7 +15563,7 @@
           <p:cNvPr id="11" name="">
             <a:extLst xmlns:a="http://schemas.openxmlformats.org/drawingml/2006/main">
               <a:ext uri="{FF2B5EF4-FFF2-40B4-BE49-F238E27FC236}">
-                <a16:creationId xmlns:a16="http://schemas.microsoft.com/office/drawing/2014/main" id="{04F9B5B9-D79F-45C5-AEF0-638BCBB083C5}"/>
+                <a16:creationId xmlns:a16="http://schemas.microsoft.com/office/drawing/2014/main" id="{D9A13C61-2673-45E4-AE27-B92B23030C05}"/>
               </a:ext>
             </a:extLst>
           </p:cNvPr>
@@ -15553,7 +15603,7 @@
                   <a:srgbClr val="C4D4D8"/>
                 </a:solidFill>
               </a:rPr>
-              <a:t>FINLY ANNUALIZED</a:t>
+              <a:t>FINLY GROWTH PER YEAR</a:t>
             </a:r>
           </a:p>
         </p:txBody>
@@ -15563,7 +15613,7 @@
           <p:cNvPr id="12" name="">
             <a:extLst xmlns:a="http://schemas.openxmlformats.org/drawingml/2006/main">
               <a:ext uri="{FF2B5EF4-FFF2-40B4-BE49-F238E27FC236}">
-                <a16:creationId xmlns:a16="http://schemas.microsoft.com/office/drawing/2014/main" id="{328F00FC-04B5-4778-BD65-D7B2AFA6726E}"/>
+                <a16:creationId xmlns:a16="http://schemas.microsoft.com/office/drawing/2014/main" id="{327A20F8-E8DF-4329-9794-D0670E48F371}"/>
               </a:ext>
             </a:extLst>
           </p:cNvPr>
@@ -15613,7 +15663,7 @@
           <p:cNvPr id="13" name="">
             <a:extLst xmlns:a="http://schemas.openxmlformats.org/drawingml/2006/main">
               <a:ext uri="{FF2B5EF4-FFF2-40B4-BE49-F238E27FC236}">
-                <a16:creationId xmlns:a16="http://schemas.microsoft.com/office/drawing/2014/main" id="{E9D200FD-0EDC-4041-821B-688A7402BECA}"/>
+                <a16:creationId xmlns:a16="http://schemas.microsoft.com/office/drawing/2014/main" id="{754290BB-4BC8-4ABB-B3F3-6EDF7E3B002C}"/>
               </a:ext>
             </a:extLst>
           </p:cNvPr>
@@ -15663,7 +15713,7 @@
           <p:cNvPr id="14" name="">
             <a:extLst xmlns:a="http://schemas.openxmlformats.org/drawingml/2006/main">
               <a:ext uri="{FF2B5EF4-FFF2-40B4-BE49-F238E27FC236}">
-                <a16:creationId xmlns:a16="http://schemas.microsoft.com/office/drawing/2014/main" id="{62BE357B-FC81-42FA-918D-ED4B770496EC}"/>
+                <a16:creationId xmlns:a16="http://schemas.microsoft.com/office/drawing/2014/main" id="{5DA63D3D-CDF9-44E5-B3A4-179A0A816EFA}"/>
               </a:ext>
             </a:extLst>
           </p:cNvPr>
@@ -15703,7 +15753,7 @@
                   <a:srgbClr val="C4D4D8"/>
                 </a:solidFill>
               </a:rPr>
-              <a:t>REBALANCE ANCHORS POSITIVE</a:t>
+              <a:t>MONTHLY START DATES</a:t>
             </a:r>
           </a:p>
         </p:txBody>
@@ -15713,7 +15763,7 @@
           <p:cNvPr id="15" name="">
             <a:extLst xmlns:a="http://schemas.openxmlformats.org/drawingml/2006/main">
               <a:ext uri="{FF2B5EF4-FFF2-40B4-BE49-F238E27FC236}">
-                <a16:creationId xmlns:a16="http://schemas.microsoft.com/office/drawing/2014/main" id="{2290873D-C75E-48AD-A5FE-D2397073D24C}"/>
+                <a16:creationId xmlns:a16="http://schemas.microsoft.com/office/drawing/2014/main" id="{15CDF685-83E1-41EF-B63B-01C9C2C2DDD5}"/>
               </a:ext>
             </a:extLst>
           </p:cNvPr>
@@ -15744,7 +15794,7 @@
           <p:cNvPr id="16" name="">
             <a:extLst xmlns:a="http://schemas.openxmlformats.org/drawingml/2006/main">
               <a:ext uri="{FF2B5EF4-FFF2-40B4-BE49-F238E27FC236}">
-                <a16:creationId xmlns:a16="http://schemas.microsoft.com/office/drawing/2014/main" id="{AB64D276-4C15-480A-BC78-07CF47BF0BEE}"/>
+                <a16:creationId xmlns:a16="http://schemas.microsoft.com/office/drawing/2014/main" id="{42E5338B-E46A-4C39-81F9-5AAEEFBC8ED8}"/>
               </a:ext>
             </a:extLst>
           </p:cNvPr>
@@ -15775,7 +15825,7 @@
           <p:cNvPr id="17" name="">
             <a:extLst xmlns:a="http://schemas.openxmlformats.org/drawingml/2006/main">
               <a:ext uri="{FF2B5EF4-FFF2-40B4-BE49-F238E27FC236}">
-                <a16:creationId xmlns:a16="http://schemas.microsoft.com/office/drawing/2014/main" id="{BC3EAD35-49A9-4AF6-AB42-574120E8B2EC}"/>
+                <a16:creationId xmlns:a16="http://schemas.microsoft.com/office/drawing/2014/main" id="{AF59280A-0CFD-4EBC-82E3-6D8569C47444}"/>
               </a:ext>
             </a:extLst>
           </p:cNvPr>
@@ -15806,7 +15856,7 @@
           <p:cNvPr id="18" name="">
             <a:extLst xmlns:a="http://schemas.openxmlformats.org/drawingml/2006/main">
               <a:ext uri="{FF2B5EF4-FFF2-40B4-BE49-F238E27FC236}">
-                <a16:creationId xmlns:a16="http://schemas.microsoft.com/office/drawing/2014/main" id="{D3C240EA-FED1-4100-94FC-A3C6B864A645}"/>
+                <a16:creationId xmlns:a16="http://schemas.microsoft.com/office/drawing/2014/main" id="{1A0D5F1D-9F38-4ADB-9697-4EE95A28A924}"/>
               </a:ext>
             </a:extLst>
           </p:cNvPr>
@@ -15837,7 +15887,7 @@
           <p:cNvPr id="19" name="">
             <a:extLst xmlns:a="http://schemas.openxmlformats.org/drawingml/2006/main">
               <a:ext uri="{FF2B5EF4-FFF2-40B4-BE49-F238E27FC236}">
-                <a16:creationId xmlns:a16="http://schemas.microsoft.com/office/drawing/2014/main" id="{A19313DA-BD23-4120-825B-DC2C04153C87}"/>
+                <a16:creationId xmlns:a16="http://schemas.microsoft.com/office/drawing/2014/main" id="{26DA1D88-0F2F-4DB4-8F4D-81CA0F0383A5}"/>
               </a:ext>
             </a:extLst>
           </p:cNvPr>
@@ -15868,7 +15918,7 @@
           <p:cNvPr id="20" name="">
             <a:extLst xmlns:a="http://schemas.openxmlformats.org/drawingml/2006/main">
               <a:ext uri="{FF2B5EF4-FFF2-40B4-BE49-F238E27FC236}">
-                <a16:creationId xmlns:a16="http://schemas.microsoft.com/office/drawing/2014/main" id="{6B9DDF3C-6BE9-46D7-BA73-0BA1CBE2C69A}"/>
+                <a16:creationId xmlns:a16="http://schemas.microsoft.com/office/drawing/2014/main" id="{5F4B1FDC-614A-4909-82B5-A10F3FC30DA5}"/>
               </a:ext>
             </a:extLst>
           </p:cNvPr>
@@ -15899,7 +15949,7 @@
           <p:cNvPr id="21" name="">
             <a:extLst xmlns:a="http://schemas.openxmlformats.org/drawingml/2006/main">
               <a:ext uri="{FF2B5EF4-FFF2-40B4-BE49-F238E27FC236}">
-                <a16:creationId xmlns:a16="http://schemas.microsoft.com/office/drawing/2014/main" id="{A6462530-FA6C-402B-BFB0-9D984CA8DAD9}"/>
+                <a16:creationId xmlns:a16="http://schemas.microsoft.com/office/drawing/2014/main" id="{3EBEE86A-5D65-4167-B4A4-64C84E9B5D5C}"/>
               </a:ext>
             </a:extLst>
           </p:cNvPr>
@@ -15930,7 +15980,7 @@
           <p:cNvPr id="22" name="">
             <a:extLst xmlns:a="http://schemas.openxmlformats.org/drawingml/2006/main">
               <a:ext uri="{FF2B5EF4-FFF2-40B4-BE49-F238E27FC236}">
-                <a16:creationId xmlns:a16="http://schemas.microsoft.com/office/drawing/2014/main" id="{3F09E341-EB8E-42DC-B474-99D9D8AD66ED}"/>
+                <a16:creationId xmlns:a16="http://schemas.microsoft.com/office/drawing/2014/main" id="{3B0DD942-0DAF-4715-90DF-72503BE19E9D}"/>
               </a:ext>
             </a:extLst>
           </p:cNvPr>
@@ -15961,7 +16011,7 @@
           <p:cNvPr id="23" name="">
             <a:extLst xmlns:a="http://schemas.openxmlformats.org/drawingml/2006/main">
               <a:ext uri="{FF2B5EF4-FFF2-40B4-BE49-F238E27FC236}">
-                <a16:creationId xmlns:a16="http://schemas.microsoft.com/office/drawing/2014/main" id="{D7D90B2E-F099-4504-A9FD-71A3BDA77A5D}"/>
+                <a16:creationId xmlns:a16="http://schemas.microsoft.com/office/drawing/2014/main" id="{60109571-590A-4A55-9B66-0092F2B8F9F5}"/>
               </a:ext>
             </a:extLst>
           </p:cNvPr>
@@ -15992,7 +16042,7 @@
           <p:cNvPr id="24" name="">
             <a:extLst xmlns:a="http://schemas.openxmlformats.org/drawingml/2006/main">
               <a:ext uri="{FF2B5EF4-FFF2-40B4-BE49-F238E27FC236}">
-                <a16:creationId xmlns:a16="http://schemas.microsoft.com/office/drawing/2014/main" id="{EE51733B-8F5A-402F-B197-207DEADB6E87}"/>
+                <a16:creationId xmlns:a16="http://schemas.microsoft.com/office/drawing/2014/main" id="{FF25EE17-6678-436D-B0D7-6E4FAEEDC8B7}"/>
               </a:ext>
             </a:extLst>
           </p:cNvPr>
@@ -16023,7 +16073,7 @@
           <p:cNvPr id="25" name="">
             <a:extLst xmlns:a="http://schemas.openxmlformats.org/drawingml/2006/main">
               <a:ext uri="{FF2B5EF4-FFF2-40B4-BE49-F238E27FC236}">
-                <a16:creationId xmlns:a16="http://schemas.microsoft.com/office/drawing/2014/main" id="{2020E1BA-E0E0-4C7A-9F6E-ECBE87AA811A}"/>
+                <a16:creationId xmlns:a16="http://schemas.microsoft.com/office/drawing/2014/main" id="{7D8C9B5A-D1CB-4CEC-9789-67861BD178B3}"/>
               </a:ext>
             </a:extLst>
           </p:cNvPr>
@@ -16054,7 +16104,7 @@
           <p:cNvPr id="26" name="">
             <a:extLst xmlns:a="http://schemas.openxmlformats.org/drawingml/2006/main">
               <a:ext uri="{FF2B5EF4-FFF2-40B4-BE49-F238E27FC236}">
-                <a16:creationId xmlns:a16="http://schemas.microsoft.com/office/drawing/2014/main" id="{1FF6F718-CD70-45B9-8209-BD895CE3818A}"/>
+                <a16:creationId xmlns:a16="http://schemas.microsoft.com/office/drawing/2014/main" id="{AD8D2FBA-E5BC-44D5-84EF-8289BF8825EE}"/>
               </a:ext>
             </a:extLst>
           </p:cNvPr>
@@ -16085,7 +16135,7 @@
           <p:cNvPr id="27" name="">
             <a:extLst xmlns:a="http://schemas.openxmlformats.org/drawingml/2006/main">
               <a:ext uri="{FF2B5EF4-FFF2-40B4-BE49-F238E27FC236}">
-                <a16:creationId xmlns:a16="http://schemas.microsoft.com/office/drawing/2014/main" id="{53346AF1-D33D-4E94-B210-2A0DEE0BFC6C}"/>
+                <a16:creationId xmlns:a16="http://schemas.microsoft.com/office/drawing/2014/main" id="{1BAF171F-111D-452B-AF99-382CD1474DC1}"/>
               </a:ext>
             </a:extLst>
           </p:cNvPr>
@@ -16116,7 +16166,7 @@
           <p:cNvPr id="28" name="">
             <a:extLst xmlns:a="http://schemas.openxmlformats.org/drawingml/2006/main">
               <a:ext uri="{FF2B5EF4-FFF2-40B4-BE49-F238E27FC236}">
-                <a16:creationId xmlns:a16="http://schemas.microsoft.com/office/drawing/2014/main" id="{0AC0CCB7-3990-42B0-8343-9AFF986BD655}"/>
+                <a16:creationId xmlns:a16="http://schemas.microsoft.com/office/drawing/2014/main" id="{968F4E4F-1213-47BD-A4E8-43B1F997BEFA}"/>
               </a:ext>
             </a:extLst>
           </p:cNvPr>
@@ -16147,7 +16197,7 @@
           <p:cNvPr id="29" name="">
             <a:extLst xmlns:a="http://schemas.openxmlformats.org/drawingml/2006/main">
               <a:ext uri="{FF2B5EF4-FFF2-40B4-BE49-F238E27FC236}">
-                <a16:creationId xmlns:a16="http://schemas.microsoft.com/office/drawing/2014/main" id="{EB226A44-A971-49E2-88A2-741D1786F8F2}"/>
+                <a16:creationId xmlns:a16="http://schemas.microsoft.com/office/drawing/2014/main" id="{B5251065-56B6-4A9C-A1BD-C1ADB5D76EB1}"/>
               </a:ext>
             </a:extLst>
           </p:cNvPr>
@@ -16178,7 +16228,7 @@
           <p:cNvPr id="30" name="">
             <a:extLst xmlns:a="http://schemas.openxmlformats.org/drawingml/2006/main">
               <a:ext uri="{FF2B5EF4-FFF2-40B4-BE49-F238E27FC236}">
-                <a16:creationId xmlns:a16="http://schemas.microsoft.com/office/drawing/2014/main" id="{37642A6E-561C-4D13-BAAD-D2DCF2A2E072}"/>
+                <a16:creationId xmlns:a16="http://schemas.microsoft.com/office/drawing/2014/main" id="{88E66139-DA3B-431B-869E-50E97F13554F}"/>
               </a:ext>
             </a:extLst>
           </p:cNvPr>
@@ -16209,7 +16259,7 @@
           <p:cNvPr id="31" name="">
             <a:extLst xmlns:a="http://schemas.openxmlformats.org/drawingml/2006/main">
               <a:ext uri="{FF2B5EF4-FFF2-40B4-BE49-F238E27FC236}">
-                <a16:creationId xmlns:a16="http://schemas.microsoft.com/office/drawing/2014/main" id="{D5490325-215A-49DB-B5E4-31650B1F03E4}"/>
+                <a16:creationId xmlns:a16="http://schemas.microsoft.com/office/drawing/2014/main" id="{EE1B2766-CA4A-4D1C-A949-CE72602D6F73}"/>
               </a:ext>
             </a:extLst>
           </p:cNvPr>
@@ -16240,7 +16290,7 @@
           <p:cNvPr id="32" name="">
             <a:extLst xmlns:a="http://schemas.openxmlformats.org/drawingml/2006/main">
               <a:ext uri="{FF2B5EF4-FFF2-40B4-BE49-F238E27FC236}">
-                <a16:creationId xmlns:a16="http://schemas.microsoft.com/office/drawing/2014/main" id="{1FFDB495-49CB-422B-BE26-460645696D3F}"/>
+                <a16:creationId xmlns:a16="http://schemas.microsoft.com/office/drawing/2014/main" id="{5A4D51DD-ADB2-41EA-B0CA-B127BE3315F6}"/>
               </a:ext>
             </a:extLst>
           </p:cNvPr>
@@ -16271,7 +16321,7 @@
           <p:cNvPr id="33" name="">
             <a:extLst xmlns:a="http://schemas.openxmlformats.org/drawingml/2006/main">
               <a:ext uri="{FF2B5EF4-FFF2-40B4-BE49-F238E27FC236}">
-                <a16:creationId xmlns:a16="http://schemas.microsoft.com/office/drawing/2014/main" id="{635D0BF8-7525-4485-A242-56B51E17FA25}"/>
+                <a16:creationId xmlns:a16="http://schemas.microsoft.com/office/drawing/2014/main" id="{30E644A3-4B4E-47E7-916B-E1F1667A698D}"/>
               </a:ext>
             </a:extLst>
           </p:cNvPr>
@@ -16302,7 +16352,7 @@
           <p:cNvPr id="34" name="">
             <a:extLst xmlns:a="http://schemas.openxmlformats.org/drawingml/2006/main">
               <a:ext uri="{FF2B5EF4-FFF2-40B4-BE49-F238E27FC236}">
-                <a16:creationId xmlns:a16="http://schemas.microsoft.com/office/drawing/2014/main" id="{3C6D312B-6239-4615-9BCE-1268818965B9}"/>
+                <a16:creationId xmlns:a16="http://schemas.microsoft.com/office/drawing/2014/main" id="{AA37738D-0065-4922-9449-99B76441F35F}"/>
               </a:ext>
             </a:extLst>
           </p:cNvPr>
@@ -16333,7 +16383,7 @@
           <p:cNvPr id="35" name="">
             <a:extLst xmlns:a="http://schemas.openxmlformats.org/drawingml/2006/main">
               <a:ext uri="{FF2B5EF4-FFF2-40B4-BE49-F238E27FC236}">
-                <a16:creationId xmlns:a16="http://schemas.microsoft.com/office/drawing/2014/main" id="{BA4CFFFC-4254-4425-B23C-73279AB8280E}"/>
+                <a16:creationId xmlns:a16="http://schemas.microsoft.com/office/drawing/2014/main" id="{128AB91C-4AFD-497F-A720-1005D1948D87}"/>
               </a:ext>
             </a:extLst>
           </p:cNvPr>
@@ -16364,7 +16414,7 @@
           <p:cNvPr id="36" name="">
             <a:extLst xmlns:a="http://schemas.openxmlformats.org/drawingml/2006/main">
               <a:ext uri="{FF2B5EF4-FFF2-40B4-BE49-F238E27FC236}">
-                <a16:creationId xmlns:a16="http://schemas.microsoft.com/office/drawing/2014/main" id="{2F38AC31-C548-45C6-8D1E-FCBC6278C49B}"/>
+                <a16:creationId xmlns:a16="http://schemas.microsoft.com/office/drawing/2014/main" id="{0DD74EB1-99AD-4D3D-BC4F-6785E9DF360A}"/>
               </a:ext>
             </a:extLst>
           </p:cNvPr>
@@ -16392,19 +16442,19 @@
           <a:lstStyle xmlns:a="http://schemas.openxmlformats.org/drawingml/2006/main"/>
           <a:p xmlns:a="http://schemas.openxmlformats.org/drawingml/2006/main">
             <a:pPr algn="l">
-              <a:defRPr sz="3600" b="1" i="0">
+              <a:defRPr sz="3000" b="1" i="0">
                 <a:solidFill>
                   <a:srgbClr val="F2C66D"/>
                 </a:solidFill>
               </a:defRPr>
             </a:pPr>
             <a:r>
-              <a:rPr sz="3600" b="1" i="0">
+              <a:rPr sz="3000" b="1" i="0">
                 <a:solidFill>
                   <a:srgbClr val="F2C66D"/>
                 </a:solidFill>
               </a:rPr>
-              <a:t>+2.45 pp</a:t>
+              <a:t>+2.45 points</a:t>
             </a:r>
           </a:p>
         </p:txBody>
@@ -16414,7 +16464,7 @@
           <p:cNvPr id="37" name="">
             <a:extLst xmlns:a="http://schemas.openxmlformats.org/drawingml/2006/main">
               <a:ext uri="{FF2B5EF4-FFF2-40B4-BE49-F238E27FC236}">
-                <a16:creationId xmlns:a16="http://schemas.microsoft.com/office/drawing/2014/main" id="{E9E96CF6-3242-4D07-A193-3DF6A3C7F4B3}"/>
+                <a16:creationId xmlns:a16="http://schemas.microsoft.com/office/drawing/2014/main" id="{2A056646-BBB4-46BB-AD63-04E123503654}"/>
               </a:ext>
             </a:extLst>
           </p:cNvPr>
@@ -16454,7 +16504,7 @@
                   <a:srgbClr val="C4D4D8"/>
                 </a:solidFill>
               </a:rPr>
-              <a:t>EDGE AT 25 BP COSTS</a:t>
+              <a:t>EDGE AT 0.25% TRADING COSTS</a:t>
             </a:r>
           </a:p>
         </p:txBody>
@@ -16464,19 +16514,19 @@
           <p:cNvPr id="38" name="">
             <a:extLst xmlns:a="http://schemas.openxmlformats.org/drawingml/2006/main">
               <a:ext uri="{FF2B5EF4-FFF2-40B4-BE49-F238E27FC236}">
-                <a16:creationId xmlns:a16="http://schemas.microsoft.com/office/drawing/2014/main" id="{58B1F6DD-0FD5-4A1B-AB7B-CAE8BF844FC7}"/>
-              </a:ext>
-            </a:extLst>
-          </p:cNvPr>
-          <p:cNvSpPr>
-            <a:spLocks xmlns:a="http://schemas.openxmlformats.org/drawingml/2006/main" noGrp="1"/>
-          </p:cNvSpPr>
-          <p:nvPr/>
-        </p:nvSpPr>
-        <p:spPr>
-          <a:xfrm xmlns:a="http://schemas.openxmlformats.org/drawingml/2006/main">
-            <a:off x="8477250" y="4286250"/>
-            <a:ext cx="2762250" cy="323850"/>
+                <a16:creationId xmlns:a16="http://schemas.microsoft.com/office/drawing/2014/main" id="{76DC5873-5489-49B3-B45D-30CA9BE143AA}"/>
+              </a:ext>
+            </a:extLst>
+          </p:cNvPr>
+          <p:cNvSpPr>
+            <a:spLocks xmlns:a="http://schemas.openxmlformats.org/drawingml/2006/main" noGrp="1"/>
+          </p:cNvSpPr>
+          <p:nvPr/>
+        </p:nvSpPr>
+        <p:spPr>
+          <a:xfrm xmlns:a="http://schemas.openxmlformats.org/drawingml/2006/main">
+            <a:off x="8382000" y="4286250"/>
+            <a:ext cx="3048000" cy="323850"/>
           </a:xfrm>
           <a:prstGeom xmlns:a="http://schemas.openxmlformats.org/drawingml/2006/main" prst="rect">
             <a:avLst/>
@@ -16492,19 +16542,19 @@
           <a:lstStyle xmlns:a="http://schemas.openxmlformats.org/drawingml/2006/main"/>
           <a:p xmlns:a="http://schemas.openxmlformats.org/drawingml/2006/main">
             <a:pPr algn="l">
-              <a:defRPr sz="1575" b="1" i="0">
+              <a:defRPr sz="1350" b="1" i="0">
                 <a:solidFill>
                   <a:srgbClr val="FFFFFF"/>
                 </a:solidFill>
               </a:defRPr>
             </a:pPr>
             <a:r>
-              <a:rPr sz="1575" b="1" i="0">
+              <a:rPr sz="1350" b="1" i="0">
                 <a:solidFill>
                   <a:srgbClr val="FFFFFF"/>
                 </a:solidFill>
               </a:rPr>
-              <a:t>5 bp  →  10 bp  →  25 bp</a:t>
+              <a:t>0.05%  →  0.10%  →  0.25%</a:t>
             </a:r>
           </a:p>
         </p:txBody>
@@ -16514,7 +16564,7 @@
           <p:cNvPr id="39" name="">
             <a:extLst xmlns:a="http://schemas.openxmlformats.org/drawingml/2006/main">
               <a:ext uri="{FF2B5EF4-FFF2-40B4-BE49-F238E27FC236}">
-                <a16:creationId xmlns:a16="http://schemas.microsoft.com/office/drawing/2014/main" id="{7905A8AC-F618-4F0A-BD69-B7AB0F478920}"/>
+                <a16:creationId xmlns:a16="http://schemas.microsoft.com/office/drawing/2014/main" id="{611D03CE-654C-4A2B-A769-DCE8BB1DC0A1}"/>
               </a:ext>
             </a:extLst>
           </p:cNvPr>
@@ -16547,7 +16597,7 @@
           <p:cNvPr id="40" name="">
             <a:extLst xmlns:a="http://schemas.openxmlformats.org/drawingml/2006/main">
               <a:ext uri="{FF2B5EF4-FFF2-40B4-BE49-F238E27FC236}">
-                <a16:creationId xmlns:a16="http://schemas.microsoft.com/office/drawing/2014/main" id="{FE6394D4-20DA-41AD-8A5B-C214F43C9157}"/>
+                <a16:creationId xmlns:a16="http://schemas.microsoft.com/office/drawing/2014/main" id="{BE57496A-5119-4B83-9261-D2247FC8EDD8}"/>
               </a:ext>
             </a:extLst>
           </p:cNvPr>
@@ -16580,7 +16630,7 @@
           <p:cNvPr id="41" name="">
             <a:extLst xmlns:a="http://schemas.openxmlformats.org/drawingml/2006/main">
               <a:ext uri="{FF2B5EF4-FFF2-40B4-BE49-F238E27FC236}">
-                <a16:creationId xmlns:a16="http://schemas.microsoft.com/office/drawing/2014/main" id="{A01AC210-A133-4933-92CE-EC3DB7FFF570}"/>
+                <a16:creationId xmlns:a16="http://schemas.microsoft.com/office/drawing/2014/main" id="{B5BCC5A0-CFB5-4D73-81D4-F80AD7D05142}"/>
               </a:ext>
             </a:extLst>
           </p:cNvPr>
@@ -16611,7 +16661,7 @@
           <p:cNvPr id="42" name="">
             <a:extLst xmlns:a="http://schemas.openxmlformats.org/drawingml/2006/main">
               <a:ext uri="{FF2B5EF4-FFF2-40B4-BE49-F238E27FC236}">
-                <a16:creationId xmlns:a16="http://schemas.microsoft.com/office/drawing/2014/main" id="{5878F79F-3789-4786-8327-5C34445697EF}"/>
+                <a16:creationId xmlns:a16="http://schemas.microsoft.com/office/drawing/2014/main" id="{EB4EF58F-E759-46D5-AB0D-D4D07E9D6313}"/>
               </a:ext>
             </a:extLst>
           </p:cNvPr>
@@ -16651,7 +16701,7 @@
                   <a:srgbClr val="B9DFD2"/>
                 </a:solidFill>
               </a:rPr>
-              <a:t>Maximum drawdown was 16.31 percentage points shallower than the market proxy.</a:t>
+              <a:t>Its worst decline was 16.31 percentage points smaller than the market proxy.</a:t>
             </a:r>
           </a:p>
         </p:txBody>
@@ -16661,7 +16711,7 @@
           <p:cNvPr id="43" name="">
             <a:extLst xmlns:a="http://schemas.openxmlformats.org/drawingml/2006/main">
               <a:ext uri="{FF2B5EF4-FFF2-40B4-BE49-F238E27FC236}">
-                <a16:creationId xmlns:a16="http://schemas.microsoft.com/office/drawing/2014/main" id="{949E2598-FFA9-4903-8CCB-DFF6931802CA}"/>
+                <a16:creationId xmlns:a16="http://schemas.microsoft.com/office/drawing/2014/main" id="{79CF9B82-10E4-4519-A133-9AE38EE8BAEE}"/>
               </a:ext>
             </a:extLst>
           </p:cNvPr>
@@ -16711,7 +16761,7 @@
           <p:cNvPr id="44" name="">
             <a:extLst xmlns:a="http://schemas.openxmlformats.org/drawingml/2006/main">
               <a:ext uri="{FF2B5EF4-FFF2-40B4-BE49-F238E27FC236}">
-                <a16:creationId xmlns:a16="http://schemas.microsoft.com/office/drawing/2014/main" id="{43DE14AF-0857-4D0F-9BB1-D75C96A778CD}"/>
+                <a16:creationId xmlns:a16="http://schemas.microsoft.com/office/drawing/2014/main" id="{79AA07B3-07F2-4427-99D1-D358FBB47155}"/>
               </a:ext>
             </a:extLst>
           </p:cNvPr>
@@ -16759,7 +16809,7 @@
     </p:spTree>
     <p:extLst>
       <p:ext uri="{BB962C8B-B14F-4D97-AF65-F5344CB8AC3E}">
-        <p14:creationId xmlns:p14="http://schemas.microsoft.com/office/powerpoint/2010/main" val="370636997"/>
+        <p14:creationId xmlns:p14="http://schemas.microsoft.com/office/powerpoint/2010/main" val="1064011693"/>
       </p:ext>
     </p:extLst>
   </p:cSld>
@@ -16790,7 +16840,7 @@
           <p:cNvPr id="28" name="">
             <a:extLst xmlns:a="http://schemas.openxmlformats.org/drawingml/2006/main">
               <a:ext uri="{FF2B5EF4-FFF2-40B4-BE49-F238E27FC236}">
-                <a16:creationId xmlns:a16="http://schemas.microsoft.com/office/drawing/2014/main" id="{79577CF6-E12C-4D74-901C-8A16ADD0922D}"/>
+                <a16:creationId xmlns:a16="http://schemas.microsoft.com/office/drawing/2014/main" id="{ABF3A682-DD62-40FE-9713-E04BBC58715F}"/>
               </a:ext>
             </a:extLst>
           </p:cNvPr>
@@ -16830,7 +16880,7 @@
                   <a:srgbClr val="2F7D68"/>
                 </a:solidFill>
               </a:rPr>
-              <a:t>DEFINED-RISK OPTIONS</a:t>
+              <a:t>ILLUSTRATIVE OPTIONS PROOF</a:t>
             </a:r>
           </a:p>
         </p:txBody>
@@ -16840,7 +16890,7 @@
           <p:cNvPr id="2" name="">
             <a:extLst xmlns:a="http://schemas.openxmlformats.org/drawingml/2006/main">
               <a:ext uri="{FF2B5EF4-FFF2-40B4-BE49-F238E27FC236}">
-                <a16:creationId xmlns:a16="http://schemas.microsoft.com/office/drawing/2014/main" id="{CD53E31D-BEB8-4BB7-AFBC-A3C9CF7ACB92}"/>
+                <a16:creationId xmlns:a16="http://schemas.microsoft.com/office/drawing/2014/main" id="{C4964984-B4A6-4DF1-9C3B-804750234BD0}"/>
               </a:ext>
             </a:extLst>
           </p:cNvPr>
@@ -16868,19 +16918,19 @@
           <a:lstStyle xmlns:a="http://schemas.openxmlformats.org/drawingml/2006/main"/>
           <a:p xmlns:a="http://schemas.openxmlformats.org/drawingml/2006/main">
             <a:pPr algn="l">
-              <a:defRPr sz="3450" b="1" i="0">
+              <a:defRPr sz="3300" b="1" i="0">
                 <a:solidFill>
                   <a:srgbClr val="122A3E"/>
                 </a:solidFill>
               </a:defRPr>
             </a:pPr>
             <a:r>
-              <a:rPr sz="3450" b="1" i="0">
+              <a:rPr sz="3300" b="1" i="0">
                 <a:solidFill>
                   <a:srgbClr val="122A3E"/>
                 </a:solidFill>
               </a:rPr>
-              <a:t>Every options proposal arrives with its worst case already fixed.</a:t>
+              <a:t>Before Finly prepares an options order, it fixes the most the trade can lose.</a:t>
             </a:r>
           </a:p>
         </p:txBody>
@@ -16897,7 +16947,7 @@
         </p:xfrm>
         <a:graphic xmlns:a="http://schemas.openxmlformats.org/drawingml/2006/main">
           <a:graphicData uri="http://schemas.openxmlformats.org/drawingml/2006/chart">
-            <c:chart xmlns:r="http://schemas.openxmlformats.org/officeDocument/2006/relationships" xmlns:c="http://schemas.openxmlformats.org/drawingml/2006/chart" r:id="Rab8b7796ba234f13"/>
+            <c:chart xmlns:r="http://schemas.openxmlformats.org/officeDocument/2006/relationships" xmlns:c="http://schemas.openxmlformats.org/drawingml/2006/chart" r:id="Rb8e96da1d7f44d2d"/>
           </a:graphicData>
         </a:graphic>
       </p:graphicFrame>
@@ -16906,7 +16956,7 @@
           <p:cNvPr id="4" name="">
             <a:extLst xmlns:a="http://schemas.openxmlformats.org/drawingml/2006/main">
               <a:ext uri="{FF2B5EF4-FFF2-40B4-BE49-F238E27FC236}">
-                <a16:creationId xmlns:a16="http://schemas.microsoft.com/office/drawing/2014/main" id="{4D6F742F-81D0-4570-A3AB-537984AB65FC}"/>
+                <a16:creationId xmlns:a16="http://schemas.microsoft.com/office/drawing/2014/main" id="{9B93ACC7-C500-4B8D-8C76-A3DDEA397211}"/>
               </a:ext>
             </a:extLst>
           </p:cNvPr>
@@ -16956,7 +17006,7 @@
           <p:cNvPr id="5" name="">
             <a:extLst xmlns:a="http://schemas.openxmlformats.org/drawingml/2006/main">
               <a:ext uri="{FF2B5EF4-FFF2-40B4-BE49-F238E27FC236}">
-                <a16:creationId xmlns:a16="http://schemas.microsoft.com/office/drawing/2014/main" id="{08543AE3-3860-4411-A071-D3582B5337B1}"/>
+                <a16:creationId xmlns:a16="http://schemas.microsoft.com/office/drawing/2014/main" id="{4C163292-8AF9-40A8-B60F-062A13E93FC9}"/>
               </a:ext>
             </a:extLst>
           </p:cNvPr>
@@ -17006,7 +17056,7 @@
           <p:cNvPr id="6" name="">
             <a:extLst xmlns:a="http://schemas.openxmlformats.org/drawingml/2006/main">
               <a:ext uri="{FF2B5EF4-FFF2-40B4-BE49-F238E27FC236}">
-                <a16:creationId xmlns:a16="http://schemas.microsoft.com/office/drawing/2014/main" id="{FCCAEE9C-60EF-4615-8E30-0FE92000A8EB}"/>
+                <a16:creationId xmlns:a16="http://schemas.microsoft.com/office/drawing/2014/main" id="{5700A23A-0F24-4E66-A317-B4F97E308D64}"/>
               </a:ext>
             </a:extLst>
           </p:cNvPr>
@@ -17056,7 +17106,7 @@
           <p:cNvPr id="7" name="">
             <a:extLst xmlns:a="http://schemas.openxmlformats.org/drawingml/2006/main">
               <a:ext uri="{FF2B5EF4-FFF2-40B4-BE49-F238E27FC236}">
-                <a16:creationId xmlns:a16="http://schemas.microsoft.com/office/drawing/2014/main" id="{00A3EDA5-820A-4F17-99F0-E25426154FFF}"/>
+                <a16:creationId xmlns:a16="http://schemas.microsoft.com/office/drawing/2014/main" id="{41E779EF-B446-4599-9876-475CD9420DAA}"/>
               </a:ext>
             </a:extLst>
           </p:cNvPr>
@@ -17095,7 +17145,7 @@
           <p:cNvPr id="8" name="">
             <a:extLst xmlns:a="http://schemas.openxmlformats.org/drawingml/2006/main">
               <a:ext uri="{FF2B5EF4-FFF2-40B4-BE49-F238E27FC236}">
-                <a16:creationId xmlns:a16="http://schemas.microsoft.com/office/drawing/2014/main" id="{9BCD4C2F-3EB9-46AC-AB7C-2AC74C6E2FF9}"/>
+                <a16:creationId xmlns:a16="http://schemas.microsoft.com/office/drawing/2014/main" id="{8A71F274-350A-48CB-81F1-E1D7E2CBE206}"/>
               </a:ext>
             </a:extLst>
           </p:cNvPr>
@@ -17135,7 +17185,7 @@
                   <a:srgbClr val="B9DFD2"/>
                 </a:solidFill>
               </a:rPr>
-              <a:t>ALPACA-COMPATIBLE PAPER ORDER</a:t>
+              <a:t>ILLUSTRATIVE TWO-OPTION TRADE</a:t>
             </a:r>
           </a:p>
         </p:txBody>
@@ -17145,7 +17195,7 @@
           <p:cNvPr id="9" name="">
             <a:extLst xmlns:a="http://schemas.openxmlformats.org/drawingml/2006/main">
               <a:ext uri="{FF2B5EF4-FFF2-40B4-BE49-F238E27FC236}">
-                <a16:creationId xmlns:a16="http://schemas.microsoft.com/office/drawing/2014/main" id="{B534D23A-306F-4EF6-AA7D-F5BEDE03C85F}"/>
+                <a16:creationId xmlns:a16="http://schemas.microsoft.com/office/drawing/2014/main" id="{B4EA2CF9-4D2B-488B-BDC8-7BB32D8ED0A8}"/>
               </a:ext>
             </a:extLst>
           </p:cNvPr>
@@ -17185,7 +17235,7 @@
                   <a:srgbClr val="FFFFFF"/>
                 </a:solidFill>
               </a:rPr>
-              <a:t>SPY bear-put vertical</a:t>
+              <a:t>SPY falling-price plan</a:t>
             </a:r>
           </a:p>
         </p:txBody>
@@ -17195,7 +17245,7 @@
           <p:cNvPr id="10" name="">
             <a:extLst xmlns:a="http://schemas.openxmlformats.org/drawingml/2006/main">
               <a:ext uri="{FF2B5EF4-FFF2-40B4-BE49-F238E27FC236}">
-                <a16:creationId xmlns:a16="http://schemas.microsoft.com/office/drawing/2014/main" id="{49D29598-FDE4-4747-9189-C0E62870D129}"/>
+                <a16:creationId xmlns:a16="http://schemas.microsoft.com/office/drawing/2014/main" id="{C52F766A-1600-4ED4-B672-46849A3B6B67}"/>
               </a:ext>
             </a:extLst>
           </p:cNvPr>
@@ -17245,7 +17295,7 @@
           <p:cNvPr id="11" name="">
             <a:extLst xmlns:a="http://schemas.openxmlformats.org/drawingml/2006/main">
               <a:ext uri="{FF2B5EF4-FFF2-40B4-BE49-F238E27FC236}">
-                <a16:creationId xmlns:a16="http://schemas.microsoft.com/office/drawing/2014/main" id="{CDB528B6-3C52-4D41-873B-4F3C262A4CA5}"/>
+                <a16:creationId xmlns:a16="http://schemas.microsoft.com/office/drawing/2014/main" id="{E1450FBE-7322-44D0-B79A-888C225F98E6}"/>
               </a:ext>
             </a:extLst>
           </p:cNvPr>
@@ -17295,7 +17345,7 @@
           <p:cNvPr id="12" name="">
             <a:extLst xmlns:a="http://schemas.openxmlformats.org/drawingml/2006/main">
               <a:ext uri="{FF2B5EF4-FFF2-40B4-BE49-F238E27FC236}">
-                <a16:creationId xmlns:a16="http://schemas.microsoft.com/office/drawing/2014/main" id="{DA812805-80CE-4EC1-9617-DAA83C47087B}"/>
+                <a16:creationId xmlns:a16="http://schemas.microsoft.com/office/drawing/2014/main" id="{3D20A698-ED9B-4757-8912-438D892562D1}"/>
               </a:ext>
             </a:extLst>
           </p:cNvPr>
@@ -17345,7 +17395,7 @@
           <p:cNvPr id="13" name="">
             <a:extLst xmlns:a="http://schemas.openxmlformats.org/drawingml/2006/main">
               <a:ext uri="{FF2B5EF4-FFF2-40B4-BE49-F238E27FC236}">
-                <a16:creationId xmlns:a16="http://schemas.microsoft.com/office/drawing/2014/main" id="{E22A53FE-EB88-4110-B97C-2083C278D7D9}"/>
+                <a16:creationId xmlns:a16="http://schemas.microsoft.com/office/drawing/2014/main" id="{DFCFEBFB-4DEB-433C-80EE-11F7F16C7631}"/>
               </a:ext>
             </a:extLst>
           </p:cNvPr>
@@ -17395,7 +17445,7 @@
           <p:cNvPr id="14" name="">
             <a:extLst xmlns:a="http://schemas.openxmlformats.org/drawingml/2006/main">
               <a:ext uri="{FF2B5EF4-FFF2-40B4-BE49-F238E27FC236}">
-                <a16:creationId xmlns:a16="http://schemas.microsoft.com/office/drawing/2014/main" id="{311ED986-7DA5-4D9C-ACA5-5B12022B2306}"/>
+                <a16:creationId xmlns:a16="http://schemas.microsoft.com/office/drawing/2014/main" id="{3A9C578D-5378-4445-8F4E-FFC16F78DAF3}"/>
               </a:ext>
             </a:extLst>
           </p:cNvPr>
@@ -17445,7 +17495,7 @@
           <p:cNvPr id="15" name="">
             <a:extLst xmlns:a="http://schemas.openxmlformats.org/drawingml/2006/main">
               <a:ext uri="{FF2B5EF4-FFF2-40B4-BE49-F238E27FC236}">
-                <a16:creationId xmlns:a16="http://schemas.microsoft.com/office/drawing/2014/main" id="{6C0435DC-8CAB-4849-94C3-DAA66C0EA61A}"/>
+                <a16:creationId xmlns:a16="http://schemas.microsoft.com/office/drawing/2014/main" id="{076D8808-E456-413B-B271-E40A036FE755}"/>
               </a:ext>
             </a:extLst>
           </p:cNvPr>
@@ -17495,7 +17545,7 @@
           <p:cNvPr id="16" name="">
             <a:extLst xmlns:a="http://schemas.openxmlformats.org/drawingml/2006/main">
               <a:ext uri="{FF2B5EF4-FFF2-40B4-BE49-F238E27FC236}">
-                <a16:creationId xmlns:a16="http://schemas.microsoft.com/office/drawing/2014/main" id="{A5DC1C7C-22E7-45F4-AB57-95A4A4DCD40C}"/>
+                <a16:creationId xmlns:a16="http://schemas.microsoft.com/office/drawing/2014/main" id="{A282803F-B473-4D68-B731-B9F0F2CE9BA1}"/>
               </a:ext>
             </a:extLst>
           </p:cNvPr>
@@ -17526,7 +17576,7 @@
           <p:cNvPr id="17" name="">
             <a:extLst xmlns:a="http://schemas.openxmlformats.org/drawingml/2006/main">
               <a:ext uri="{FF2B5EF4-FFF2-40B4-BE49-F238E27FC236}">
-                <a16:creationId xmlns:a16="http://schemas.microsoft.com/office/drawing/2014/main" id="{7ADD4FA6-0C4F-456A-98F9-D9B1D6988DC9}"/>
+                <a16:creationId xmlns:a16="http://schemas.microsoft.com/office/drawing/2014/main" id="{8FF5CFF6-E533-42E7-8376-B6B716E73F7D}"/>
               </a:ext>
             </a:extLst>
           </p:cNvPr>
@@ -17566,7 +17616,7 @@
                   <a:srgbClr val="C4D4D8"/>
                 </a:solidFill>
               </a:rPr>
-              <a:t>Exact fields · one contract · synthetic fixture</a:t>
+              <a:t>Simulated plan · no broker order or fill</a:t>
             </a:r>
           </a:p>
         </p:txBody>
@@ -17576,7 +17626,7 @@
           <p:cNvPr id="18" name="">
             <a:extLst xmlns:a="http://schemas.openxmlformats.org/drawingml/2006/main">
               <a:ext uri="{FF2B5EF4-FFF2-40B4-BE49-F238E27FC236}">
-                <a16:creationId xmlns:a16="http://schemas.microsoft.com/office/drawing/2014/main" id="{FAF338B6-CF51-4ED9-84BF-66FD4FC7D732}"/>
+                <a16:creationId xmlns:a16="http://schemas.microsoft.com/office/drawing/2014/main" id="{B8939013-003A-47C1-BDD9-486D2A4119DC}"/>
               </a:ext>
             </a:extLst>
           </p:cNvPr>
@@ -17626,7 +17676,7 @@
           <p:cNvPr id="19" name="">
             <a:extLst xmlns:a="http://schemas.openxmlformats.org/drawingml/2006/main">
               <a:ext uri="{FF2B5EF4-FFF2-40B4-BE49-F238E27FC236}">
-                <a16:creationId xmlns:a16="http://schemas.microsoft.com/office/drawing/2014/main" id="{AD6D94AD-D486-419B-83ED-90BE9C26F1C0}"/>
+                <a16:creationId xmlns:a16="http://schemas.microsoft.com/office/drawing/2014/main" id="{B1498E25-D774-497B-8221-0DA1C3D7B212}"/>
               </a:ext>
             </a:extLst>
           </p:cNvPr>
@@ -17676,7 +17726,7 @@
           <p:cNvPr id="20" name="">
             <a:extLst xmlns:a="http://schemas.openxmlformats.org/drawingml/2006/main">
               <a:ext uri="{FF2B5EF4-FFF2-40B4-BE49-F238E27FC236}">
-                <a16:creationId xmlns:a16="http://schemas.microsoft.com/office/drawing/2014/main" id="{3EAD5A06-4E52-48E8-B588-D70A341D8A63}"/>
+                <a16:creationId xmlns:a16="http://schemas.microsoft.com/office/drawing/2014/main" id="{B045235A-BAD5-4AB3-B9C3-1293E68E0088}"/>
               </a:ext>
             </a:extLst>
           </p:cNvPr>
@@ -17726,7 +17776,7 @@
           <p:cNvPr id="21" name="">
             <a:extLst xmlns:a="http://schemas.openxmlformats.org/drawingml/2006/main">
               <a:ext uri="{FF2B5EF4-FFF2-40B4-BE49-F238E27FC236}">
-                <a16:creationId xmlns:a16="http://schemas.microsoft.com/office/drawing/2014/main" id="{B711AC8C-CF76-4FD3-A4C4-5B75E07A8CB9}"/>
+                <a16:creationId xmlns:a16="http://schemas.microsoft.com/office/drawing/2014/main" id="{304CDC35-287D-4D96-8BA1-FA44DD19C38A}"/>
               </a:ext>
             </a:extLst>
           </p:cNvPr>
@@ -17776,7 +17826,7 @@
           <p:cNvPr id="22" name="">
             <a:extLst xmlns:a="http://schemas.openxmlformats.org/drawingml/2006/main">
               <a:ext uri="{FF2B5EF4-FFF2-40B4-BE49-F238E27FC236}">
-                <a16:creationId xmlns:a16="http://schemas.microsoft.com/office/drawing/2014/main" id="{5D548B7F-FA0F-40D7-9EDE-594D133B7517}"/>
+                <a16:creationId xmlns:a16="http://schemas.microsoft.com/office/drawing/2014/main" id="{A4BF8F7A-2B32-4AF7-9851-7E2FDFD63FCB}"/>
               </a:ext>
             </a:extLst>
           </p:cNvPr>
@@ -17788,7 +17838,7 @@
         <p:spPr>
           <a:xfrm xmlns:a="http://schemas.openxmlformats.org/drawingml/2006/main">
             <a:off x="7239000" y="5543550"/>
-            <a:ext cx="1809750" cy="571500"/>
+            <a:ext cx="1905000" cy="571500"/>
           </a:xfrm>
           <a:prstGeom xmlns:a="http://schemas.openxmlformats.org/drawingml/2006/main" prst="rect">
             <a:avLst/>
@@ -17826,7 +17876,7 @@
           <p:cNvPr id="23" name="">
             <a:extLst xmlns:a="http://schemas.openxmlformats.org/drawingml/2006/main">
               <a:ext uri="{FF2B5EF4-FFF2-40B4-BE49-F238E27FC236}">
-                <a16:creationId xmlns:a16="http://schemas.microsoft.com/office/drawing/2014/main" id="{1F3644B2-1852-44A9-8D35-0F8F9036032A}"/>
+                <a16:creationId xmlns:a16="http://schemas.microsoft.com/office/drawing/2014/main" id="{8038D74E-8FC4-4139-9440-6F286CF9E053}"/>
               </a:ext>
             </a:extLst>
           </p:cNvPr>
@@ -17838,7 +17888,7 @@
         <p:spPr>
           <a:xfrm xmlns:a="http://schemas.openxmlformats.org/drawingml/2006/main">
             <a:off x="7239000" y="6067425"/>
-            <a:ext cx="1809750" cy="323850"/>
+            <a:ext cx="1905000" cy="323850"/>
           </a:xfrm>
           <a:prstGeom xmlns:a="http://schemas.openxmlformats.org/drawingml/2006/main" prst="rect">
             <a:avLst/>
@@ -17854,19 +17904,19 @@
           <a:lstStyle xmlns:a="http://schemas.openxmlformats.org/drawingml/2006/main"/>
           <a:p xmlns:a="http://schemas.openxmlformats.org/drawingml/2006/main">
             <a:pPr algn="l">
-              <a:defRPr sz="1125" b="1" i="0">
+              <a:defRPr sz="825" b="1" i="0">
                 <a:solidFill>
                   <a:srgbClr val="627078"/>
                 </a:solidFill>
               </a:defRPr>
             </a:pPr>
             <a:r>
-              <a:rPr sz="1125" b="1" i="0">
+              <a:rPr sz="825" b="1" i="0">
                 <a:solidFill>
                   <a:srgbClr val="627078"/>
                 </a:solidFill>
               </a:rPr>
-              <a:t>SOURCE REMOVALS</a:t>
+              <a:t>SOURCES REMOVED · SAME RESULT</a:t>
             </a:r>
           </a:p>
         </p:txBody>
@@ -17876,7 +17926,7 @@
           <p:cNvPr id="24" name="">
             <a:extLst xmlns:a="http://schemas.openxmlformats.org/drawingml/2006/main">
               <a:ext uri="{FF2B5EF4-FFF2-40B4-BE49-F238E27FC236}">
-                <a16:creationId xmlns:a16="http://schemas.microsoft.com/office/drawing/2014/main" id="{519E308C-7470-4F1F-A5FD-7E95380E0C87}"/>
+                <a16:creationId xmlns:a16="http://schemas.microsoft.com/office/drawing/2014/main" id="{84BF0A07-0E64-400E-BC33-5418FB795943}"/>
               </a:ext>
             </a:extLst>
           </p:cNvPr>
@@ -17926,7 +17976,7 @@
           <p:cNvPr id="25" name="">
             <a:extLst xmlns:a="http://schemas.openxmlformats.org/drawingml/2006/main">
               <a:ext uri="{FF2B5EF4-FFF2-40B4-BE49-F238E27FC236}">
-                <a16:creationId xmlns:a16="http://schemas.microsoft.com/office/drawing/2014/main" id="{57B1A64E-2223-46E4-93CD-5F80E2F5E8FF}"/>
+                <a16:creationId xmlns:a16="http://schemas.microsoft.com/office/drawing/2014/main" id="{C208FD8E-8FDB-4F40-8AC5-CBF2679C636C}"/>
               </a:ext>
             </a:extLst>
           </p:cNvPr>
@@ -17939,56 +17989,6 @@
           <a:xfrm xmlns:a="http://schemas.openxmlformats.org/drawingml/2006/main">
             <a:off x="9525000" y="6067425"/>
             <a:ext cx="2000250" cy="323850"/>
-          </a:xfrm>
-          <a:prstGeom xmlns:a="http://schemas.openxmlformats.org/drawingml/2006/main" prst="rect">
-            <a:avLst/>
-          </a:prstGeom>
-          <a:noFill xmlns:a="http://schemas.openxmlformats.org/drawingml/2006/main"/>
-          <a:ln xmlns:a="http://schemas.openxmlformats.org/drawingml/2006/main" w="0">
-            <a:noFill/>
-            <a:prstDash val="solid"/>
-          </a:ln>
-        </p:spPr>
-        <p:txBody>
-          <a:bodyPr xmlns:a="http://schemas.openxmlformats.org/drawingml/2006/main"/>
-          <a:lstStyle xmlns:a="http://schemas.openxmlformats.org/drawingml/2006/main"/>
-          <a:p xmlns:a="http://schemas.openxmlformats.org/drawingml/2006/main">
-            <a:pPr algn="l">
-              <a:defRPr sz="1125" b="1" i="0">
-                <a:solidFill>
-                  <a:srgbClr val="627078"/>
-                </a:solidFill>
-              </a:defRPr>
-            </a:pPr>
-            <a:r>
-              <a:rPr sz="1125" b="1" i="0">
-                <a:solidFill>
-                  <a:srgbClr val="627078"/>
-                </a:solidFill>
-              </a:rPr>
-              <a:t>INPUT SHOCKS</a:t>
-            </a:r>
-          </a:p>
-        </p:txBody>
-      </p:sp>
-      <p:sp>
-        <p:nvSpPr>
-          <p:cNvPr id="26" name="">
-            <a:extLst xmlns:a="http://schemas.openxmlformats.org/drawingml/2006/main">
-              <a:ext uri="{FF2B5EF4-FFF2-40B4-BE49-F238E27FC236}">
-                <a16:creationId xmlns:a16="http://schemas.microsoft.com/office/drawing/2014/main" id="{A9A61170-7D6E-412D-9264-1405A65CC023}"/>
-              </a:ext>
-            </a:extLst>
-          </p:cNvPr>
-          <p:cNvSpPr>
-            <a:spLocks xmlns:a="http://schemas.openxmlformats.org/drawingml/2006/main" noGrp="1"/>
-          </p:cNvSpPr>
-          <p:nvPr/>
-        </p:nvSpPr>
-        <p:spPr>
-          <a:xfrm xmlns:a="http://schemas.openxmlformats.org/drawingml/2006/main">
-            <a:off x="609600" y="6534150"/>
-            <a:ext cx="4191000" cy="171450"/>
           </a:xfrm>
           <a:prstGeom xmlns:a="http://schemas.openxmlformats.org/drawingml/2006/main" prst="rect">
             <a:avLst/>
@@ -18016,29 +18016,29 @@
                   <a:srgbClr val="627078"/>
                 </a:solidFill>
               </a:rPr>
-              <a:t>FINLY  /  ALPACA AI TRADING AGENTS</a:t>
+              <a:t>STILL VALID AFTER SMALL CHANGES</a:t>
             </a:r>
           </a:p>
         </p:txBody>
       </p:sp>
       <p:sp>
         <p:nvSpPr>
-          <p:cNvPr id="27" name="">
-            <a:extLst xmlns:a="http://schemas.openxmlformats.org/drawingml/2006/main">
-              <a:ext uri="{FF2B5EF4-FFF2-40B4-BE49-F238E27FC236}">
-                <a16:creationId xmlns:a16="http://schemas.microsoft.com/office/drawing/2014/main" id="{140E3CB5-2662-41F8-985D-8C1878A1A002}"/>
-              </a:ext>
-            </a:extLst>
-          </p:cNvPr>
-          <p:cNvSpPr>
-            <a:spLocks xmlns:a="http://schemas.openxmlformats.org/drawingml/2006/main" noGrp="1"/>
-          </p:cNvSpPr>
-          <p:nvPr/>
-        </p:nvSpPr>
-        <p:spPr>
-          <a:xfrm xmlns:a="http://schemas.openxmlformats.org/drawingml/2006/main">
-            <a:off x="11125200" y="6534150"/>
-            <a:ext cx="457200" cy="171450"/>
+          <p:cNvPr id="26" name="">
+            <a:extLst xmlns:a="http://schemas.openxmlformats.org/drawingml/2006/main">
+              <a:ext uri="{FF2B5EF4-FFF2-40B4-BE49-F238E27FC236}">
+                <a16:creationId xmlns:a16="http://schemas.microsoft.com/office/drawing/2014/main" id="{CC6C6548-4602-451F-913A-17E52C423F92}"/>
+              </a:ext>
+            </a:extLst>
+          </p:cNvPr>
+          <p:cNvSpPr>
+            <a:spLocks xmlns:a="http://schemas.openxmlformats.org/drawingml/2006/main" noGrp="1"/>
+          </p:cNvSpPr>
+          <p:nvPr/>
+        </p:nvSpPr>
+        <p:spPr>
+          <a:xfrm xmlns:a="http://schemas.openxmlformats.org/drawingml/2006/main">
+            <a:off x="609600" y="6534150"/>
+            <a:ext cx="4191000" cy="171450"/>
           </a:xfrm>
           <a:prstGeom xmlns:a="http://schemas.openxmlformats.org/drawingml/2006/main" prst="rect">
             <a:avLst/>
@@ -18053,7 +18053,7 @@
           <a:bodyPr xmlns:a="http://schemas.openxmlformats.org/drawingml/2006/main"/>
           <a:lstStyle xmlns:a="http://schemas.openxmlformats.org/drawingml/2006/main"/>
           <a:p xmlns:a="http://schemas.openxmlformats.org/drawingml/2006/main">
-            <a:pPr algn="r">
+            <a:pPr algn="l">
               <a:defRPr sz="825" b="1" i="0">
                 <a:solidFill>
                   <a:srgbClr val="627078"/>
@@ -18066,6 +18066,56 @@
                   <a:srgbClr val="627078"/>
                 </a:solidFill>
               </a:rPr>
+              <a:t>FINLY  /  ALPACA AI TRADING AGENTS</a:t>
+            </a:r>
+          </a:p>
+        </p:txBody>
+      </p:sp>
+      <p:sp>
+        <p:nvSpPr>
+          <p:cNvPr id="27" name="">
+            <a:extLst xmlns:a="http://schemas.openxmlformats.org/drawingml/2006/main">
+              <a:ext uri="{FF2B5EF4-FFF2-40B4-BE49-F238E27FC236}">
+                <a16:creationId xmlns:a16="http://schemas.microsoft.com/office/drawing/2014/main" id="{75BC0B2B-5683-4FA3-AD8C-9555DF6560A8}"/>
+              </a:ext>
+            </a:extLst>
+          </p:cNvPr>
+          <p:cNvSpPr>
+            <a:spLocks xmlns:a="http://schemas.openxmlformats.org/drawingml/2006/main" noGrp="1"/>
+          </p:cNvSpPr>
+          <p:nvPr/>
+        </p:nvSpPr>
+        <p:spPr>
+          <a:xfrm xmlns:a="http://schemas.openxmlformats.org/drawingml/2006/main">
+            <a:off x="11125200" y="6534150"/>
+            <a:ext cx="457200" cy="171450"/>
+          </a:xfrm>
+          <a:prstGeom xmlns:a="http://schemas.openxmlformats.org/drawingml/2006/main" prst="rect">
+            <a:avLst/>
+          </a:prstGeom>
+          <a:noFill xmlns:a="http://schemas.openxmlformats.org/drawingml/2006/main"/>
+          <a:ln xmlns:a="http://schemas.openxmlformats.org/drawingml/2006/main" w="0">
+            <a:noFill/>
+            <a:prstDash val="solid"/>
+          </a:ln>
+        </p:spPr>
+        <p:txBody>
+          <a:bodyPr xmlns:a="http://schemas.openxmlformats.org/drawingml/2006/main"/>
+          <a:lstStyle xmlns:a="http://schemas.openxmlformats.org/drawingml/2006/main"/>
+          <a:p xmlns:a="http://schemas.openxmlformats.org/drawingml/2006/main">
+            <a:pPr algn="r">
+              <a:defRPr sz="825" b="1" i="0">
+                <a:solidFill>
+                  <a:srgbClr val="627078"/>
+                </a:solidFill>
+              </a:defRPr>
+            </a:pPr>
+            <a:r>
+              <a:rPr sz="825" b="1" i="0">
+                <a:solidFill>
+                  <a:srgbClr val="627078"/>
+                </a:solidFill>
+              </a:rPr>
               <a:t>06</a:t>
             </a:r>
           </a:p>
@@ -18074,7 +18124,7 @@
     </p:spTree>
     <p:extLst>
       <p:ext uri="{BB962C8B-B14F-4D97-AF65-F5344CB8AC3E}">
-        <p14:creationId xmlns:p14="http://schemas.microsoft.com/office/powerpoint/2010/main" val="1349032965"/>
+        <p14:creationId xmlns:p14="http://schemas.microsoft.com/office/powerpoint/2010/main" val="452798481"/>
       </p:ext>
     </p:extLst>
   </p:cSld>
@@ -18102,10 +18152,10 @@
       </p:grpSpPr>
       <p:sp>
         <p:nvSpPr>
-          <p:cNvPr id="21" name="">
-            <a:extLst xmlns:a="http://schemas.openxmlformats.org/drawingml/2006/main">
-              <a:ext uri="{FF2B5EF4-FFF2-40B4-BE49-F238E27FC236}">
-                <a16:creationId xmlns:a16="http://schemas.microsoft.com/office/drawing/2014/main" id="{A2D4093A-EE83-4FE7-A3C1-67017CE2DF0D}"/>
+          <p:cNvPr id="31" name="">
+            <a:extLst xmlns:a="http://schemas.openxmlformats.org/drawingml/2006/main">
+              <a:ext uri="{FF2B5EF4-FFF2-40B4-BE49-F238E27FC236}">
+                <a16:creationId xmlns:a16="http://schemas.microsoft.com/office/drawing/2014/main" id="{54635A36-7979-448E-8A7A-9893959000E6}"/>
               </a:ext>
             </a:extLst>
           </p:cNvPr>
@@ -18145,7 +18195,7 @@
                   <a:srgbClr val="B9DFD2"/>
                 </a:solidFill>
               </a:rPr>
-              <a:t>FIRST SESSION / CLOSING-BELL SCORE</a:t>
+              <a:t>VERIFIED $100,000 PAPER ACCOUNT / FIRST CLOSE</a:t>
             </a:r>
           </a:p>
         </p:txBody>
@@ -18155,7 +18205,7 @@
           <p:cNvPr id="2" name="">
             <a:extLst xmlns:a="http://schemas.openxmlformats.org/drawingml/2006/main">
               <a:ext uri="{FF2B5EF4-FFF2-40B4-BE49-F238E27FC236}">
-                <a16:creationId xmlns:a16="http://schemas.microsoft.com/office/drawing/2014/main" id="{E49B7323-E2B1-4BC1-A924-10CAEC9F9469}"/>
+                <a16:creationId xmlns:a16="http://schemas.microsoft.com/office/drawing/2014/main" id="{7B8FD7A1-6C72-4801-AB60-6104DDE63ED9}"/>
               </a:ext>
             </a:extLst>
           </p:cNvPr>
@@ -18195,7 +18245,7 @@
                   <a:srgbClr val="FFFFFF"/>
                 </a:solidFill>
               </a:rPr>
-              <a:t>Finly closed its first session $153.31 ahead of SPY.</a:t>
+              <a:t>Finly Core closed its first session $153.31 ahead of SPY.</a:t>
             </a:r>
           </a:p>
         </p:txBody>
@@ -18205,29 +18255,29 @@
           <p:cNvPr id="3" name="">
             <a:extLst xmlns:a="http://schemas.openxmlformats.org/drawingml/2006/main">
               <a:ext uri="{FF2B5EF4-FFF2-40B4-BE49-F238E27FC236}">
-                <a16:creationId xmlns:a16="http://schemas.microsoft.com/office/drawing/2014/main" id="{C92C6975-E6C9-4C4D-AE17-59E59764E0F5}"/>
-              </a:ext>
-            </a:extLst>
-          </p:cNvPr>
-          <p:cNvSpPr>
-            <a:spLocks xmlns:a="http://schemas.openxmlformats.org/drawingml/2006/main" noGrp="1"/>
-          </p:cNvSpPr>
-          <p:nvPr/>
-        </p:nvSpPr>
-        <p:spPr>
-          <a:xfrm xmlns:a="http://schemas.openxmlformats.org/drawingml/2006/main">
-            <a:off x="561975" y="2143125"/>
-            <a:ext cx="7200900" cy="2762250"/>
+                <a16:creationId xmlns:a16="http://schemas.microsoft.com/office/drawing/2014/main" id="{E02CBFA4-8969-48A2-A06B-BA9A1BC6A17F}"/>
+              </a:ext>
+            </a:extLst>
+          </p:cNvPr>
+          <p:cNvSpPr>
+            <a:spLocks xmlns:a="http://schemas.openxmlformats.org/drawingml/2006/main" noGrp="1"/>
+          </p:cNvSpPr>
+          <p:nvPr/>
+        </p:nvSpPr>
+        <p:spPr>
+          <a:xfrm xmlns:a="http://schemas.openxmlformats.org/drawingml/2006/main">
+            <a:off x="609600" y="2190750"/>
+            <a:ext cx="7105650" cy="2667000"/>
           </a:xfrm>
           <a:prstGeom xmlns:a="http://schemas.openxmlformats.org/drawingml/2006/main" prst="roundRect">
             <a:avLst>
-              <a:gd name="adj" fmla="val 4138"/>
+              <a:gd name="adj" fmla="val 5714"/>
             </a:avLst>
           </a:prstGeom>
           <a:solidFill xmlns:a="http://schemas.openxmlformats.org/drawingml/2006/main">
             <a:srgbClr val="F6F1E8"/>
           </a:solidFill>
-          <a:ln xmlns:a="http://schemas.openxmlformats.org/drawingml/2006/main" w="9525">
+          <a:ln xmlns:a="http://schemas.openxmlformats.org/drawingml/2006/main" w="19050">
             <a:solidFill>
               <a:srgbClr val="B9DFD2"/>
             </a:solidFill>
@@ -18241,36 +18291,543 @@
           <a:fontRef xmlns:a="http://schemas.openxmlformats.org/drawingml/2006/main" idx="major"/>
         </p:style>
       </p:sp>
-      <p:pic>
-        <p:nvPicPr>
-          <p:cNvPr id="24" name=""/>
-          <p:cNvPicPr>
-            <a:picLocks xmlns:a="http://schemas.openxmlformats.org/drawingml/2006/main" noChangeAspect="1"/>
-          </p:cNvPicPr>
-          <p:nvPr/>
-        </p:nvPicPr>
-        <p:blipFill>
-          <a:blip xmlns:r="http://schemas.openxmlformats.org/officeDocument/2006/relationships" xmlns:a="http://schemas.openxmlformats.org/drawingml/2006/main" r:embed="Ra9951b6d40014d41"/>
-          <a:stretch xmlns:a="http://schemas.openxmlformats.org/drawingml/2006/main"/>
-        </p:blipFill>
-        <p:spPr>
-          <a:xfrm xmlns:a="http://schemas.openxmlformats.org/drawingml/2006/main">
-            <a:off x="609600" y="2191941"/>
-            <a:ext cx="7105650" cy="2664619"/>
-          </a:xfrm>
-          <a:prstGeom xmlns:a="http://schemas.openxmlformats.org/drawingml/2006/main" prst="roundRect">
-            <a:avLst>
-              <a:gd name="adj" fmla="val 2857"/>
-            </a:avLst>
-          </a:prstGeom>
-        </p:spPr>
-      </p:pic>
+      <p:sp>
+        <p:nvSpPr>
+          <p:cNvPr id="4" name="">
+            <a:extLst xmlns:a="http://schemas.openxmlformats.org/drawingml/2006/main">
+              <a:ext uri="{FF2B5EF4-FFF2-40B4-BE49-F238E27FC236}">
+                <a16:creationId xmlns:a16="http://schemas.microsoft.com/office/drawing/2014/main" id="{14DA6F82-0076-4932-9A90-38B0311B1274}"/>
+              </a:ext>
+            </a:extLst>
+          </p:cNvPr>
+          <p:cNvSpPr>
+            <a:spLocks xmlns:a="http://schemas.openxmlformats.org/drawingml/2006/main" noGrp="1"/>
+          </p:cNvSpPr>
+          <p:nvPr/>
+        </p:nvSpPr>
+        <p:spPr>
+          <a:xfrm xmlns:a="http://schemas.openxmlformats.org/drawingml/2006/main">
+            <a:off x="971550" y="2457450"/>
+            <a:ext cx="6191250" cy="228600"/>
+          </a:xfrm>
+          <a:prstGeom xmlns:a="http://schemas.openxmlformats.org/drawingml/2006/main" prst="rect">
+            <a:avLst/>
+          </a:prstGeom>
+          <a:noFill xmlns:a="http://schemas.openxmlformats.org/drawingml/2006/main"/>
+          <a:ln xmlns:a="http://schemas.openxmlformats.org/drawingml/2006/main" w="0">
+            <a:noFill/>
+            <a:prstDash val="solid"/>
+          </a:ln>
+        </p:spPr>
+        <p:txBody>
+          <a:bodyPr xmlns:a="http://schemas.openxmlformats.org/drawingml/2006/main"/>
+          <a:lstStyle xmlns:a="http://schemas.openxmlformats.org/drawingml/2006/main"/>
+          <a:p xmlns:a="http://schemas.openxmlformats.org/drawingml/2006/main">
+            <a:pPr algn="ctr">
+              <a:defRPr sz="1125" b="1" i="0">
+                <a:solidFill>
+                  <a:srgbClr val="2F7D68"/>
+                </a:solidFill>
+              </a:defRPr>
+            </a:pPr>
+            <a:r>
+              <a:rPr sz="1125" b="1" i="0">
+                <a:solidFill>
+                  <a:srgbClr val="2F7D68"/>
+                </a:solidFill>
+              </a:rPr>
+              <a:t>SAME $100,000 START</a:t>
+            </a:r>
+          </a:p>
+        </p:txBody>
+      </p:sp>
       <p:sp>
         <p:nvSpPr>
           <p:cNvPr id="5" name="">
             <a:extLst xmlns:a="http://schemas.openxmlformats.org/drawingml/2006/main">
               <a:ext uri="{FF2B5EF4-FFF2-40B4-BE49-F238E27FC236}">
-                <a16:creationId xmlns:a16="http://schemas.microsoft.com/office/drawing/2014/main" id="{F49A7141-C05D-464F-94D9-CE3516A9ECA0}"/>
+                <a16:creationId xmlns:a16="http://schemas.microsoft.com/office/drawing/2014/main" id="{B990360D-76C2-4D81-AD99-A77709C193BD}"/>
+              </a:ext>
+            </a:extLst>
+          </p:cNvPr>
+          <p:cNvSpPr>
+            <a:spLocks xmlns:a="http://schemas.openxmlformats.org/drawingml/2006/main" noGrp="1"/>
+          </p:cNvSpPr>
+          <p:nvPr/>
+        </p:nvSpPr>
+        <p:spPr>
+          <a:xfrm xmlns:a="http://schemas.openxmlformats.org/drawingml/2006/main">
+            <a:off x="990600" y="2895600"/>
+            <a:ext cx="1714500" cy="285750"/>
+          </a:xfrm>
+          <a:prstGeom xmlns:a="http://schemas.openxmlformats.org/drawingml/2006/main" prst="rect">
+            <a:avLst/>
+          </a:prstGeom>
+          <a:noFill xmlns:a="http://schemas.openxmlformats.org/drawingml/2006/main"/>
+          <a:ln xmlns:a="http://schemas.openxmlformats.org/drawingml/2006/main" w="0">
+            <a:noFill/>
+            <a:prstDash val="solid"/>
+          </a:ln>
+        </p:spPr>
+        <p:txBody>
+          <a:bodyPr xmlns:a="http://schemas.openxmlformats.org/drawingml/2006/main"/>
+          <a:lstStyle xmlns:a="http://schemas.openxmlformats.org/drawingml/2006/main"/>
+          <a:p xmlns:a="http://schemas.openxmlformats.org/drawingml/2006/main">
+            <a:pPr algn="ctr">
+              <a:defRPr sz="1350" b="1" i="0">
+                <a:solidFill>
+                  <a:srgbClr val="627078"/>
+                </a:solidFill>
+              </a:defRPr>
+            </a:pPr>
+            <a:r>
+              <a:rPr sz="1350" b="1" i="0">
+                <a:solidFill>
+                  <a:srgbClr val="627078"/>
+                </a:solidFill>
+              </a:rPr>
+              <a:t>9:30 A.M.</a:t>
+            </a:r>
+          </a:p>
+        </p:txBody>
+      </p:sp>
+      <p:sp>
+        <p:nvSpPr>
+          <p:cNvPr id="6" name="">
+            <a:extLst xmlns:a="http://schemas.openxmlformats.org/drawingml/2006/main">
+              <a:ext uri="{FF2B5EF4-FFF2-40B4-BE49-F238E27FC236}">
+                <a16:creationId xmlns:a16="http://schemas.microsoft.com/office/drawing/2014/main" id="{C60402B6-1798-434F-B4A3-A6BF9F988CC6}"/>
+              </a:ext>
+            </a:extLst>
+          </p:cNvPr>
+          <p:cNvSpPr>
+            <a:spLocks xmlns:a="http://schemas.openxmlformats.org/drawingml/2006/main" noGrp="1"/>
+          </p:cNvSpPr>
+          <p:nvPr/>
+        </p:nvSpPr>
+        <p:spPr>
+          <a:xfrm xmlns:a="http://schemas.openxmlformats.org/drawingml/2006/main">
+            <a:off x="971550" y="3257550"/>
+            <a:ext cx="1752600" cy="457200"/>
+          </a:xfrm>
+          <a:prstGeom xmlns:a="http://schemas.openxmlformats.org/drawingml/2006/main" prst="rect">
+            <a:avLst/>
+          </a:prstGeom>
+          <a:noFill xmlns:a="http://schemas.openxmlformats.org/drawingml/2006/main"/>
+          <a:ln xmlns:a="http://schemas.openxmlformats.org/drawingml/2006/main" w="0">
+            <a:noFill/>
+            <a:prstDash val="solid"/>
+          </a:ln>
+        </p:spPr>
+        <p:txBody>
+          <a:bodyPr xmlns:a="http://schemas.openxmlformats.org/drawingml/2006/main"/>
+          <a:lstStyle xmlns:a="http://schemas.openxmlformats.org/drawingml/2006/main"/>
+          <a:p xmlns:a="http://schemas.openxmlformats.org/drawingml/2006/main">
+            <a:pPr algn="ctr">
+              <a:defRPr sz="2550" b="1" i="0">
+                <a:solidFill>
+                  <a:srgbClr val="0B2942"/>
+                </a:solidFill>
+              </a:defRPr>
+            </a:pPr>
+            <a:r>
+              <a:rPr sz="2550" b="1" i="0">
+                <a:solidFill>
+                  <a:srgbClr val="0B2942"/>
+                </a:solidFill>
+              </a:rPr>
+              <a:t>$100,000</a:t>
+            </a:r>
+          </a:p>
+        </p:txBody>
+      </p:sp>
+      <p:sp>
+        <p:nvSpPr>
+          <p:cNvPr id="7" name="">
+            <a:extLst xmlns:a="http://schemas.openxmlformats.org/drawingml/2006/main">
+              <a:ext uri="{FF2B5EF4-FFF2-40B4-BE49-F238E27FC236}">
+                <a16:creationId xmlns:a16="http://schemas.microsoft.com/office/drawing/2014/main" id="{0507E47B-ABA5-4593-80D1-F7999E5AEE84}"/>
+              </a:ext>
+            </a:extLst>
+          </p:cNvPr>
+          <p:cNvSpPr>
+            <a:spLocks xmlns:a="http://schemas.openxmlformats.org/drawingml/2006/main" noGrp="1"/>
+          </p:cNvSpPr>
+          <p:nvPr/>
+        </p:nvSpPr>
+        <p:spPr>
+          <a:xfrm xmlns:a="http://schemas.openxmlformats.org/drawingml/2006/main">
+            <a:off x="3009900" y="3219450"/>
+            <a:ext cx="266700" cy="495300"/>
+          </a:xfrm>
+          <a:prstGeom xmlns:a="http://schemas.openxmlformats.org/drawingml/2006/main" prst="rect">
+            <a:avLst/>
+          </a:prstGeom>
+          <a:noFill xmlns:a="http://schemas.openxmlformats.org/drawingml/2006/main"/>
+          <a:ln xmlns:a="http://schemas.openxmlformats.org/drawingml/2006/main" w="0">
+            <a:noFill/>
+            <a:prstDash val="solid"/>
+          </a:ln>
+        </p:spPr>
+        <p:txBody>
+          <a:bodyPr xmlns:a="http://schemas.openxmlformats.org/drawingml/2006/main"/>
+          <a:lstStyle xmlns:a="http://schemas.openxmlformats.org/drawingml/2006/main"/>
+          <a:p xmlns:a="http://schemas.openxmlformats.org/drawingml/2006/main">
+            <a:pPr algn="ctr">
+              <a:defRPr sz="3450" b="1" i="0">
+                <a:solidFill>
+                  <a:srgbClr val="2F7D68"/>
+                </a:solidFill>
+              </a:defRPr>
+            </a:pPr>
+            <a:r>
+              <a:rPr sz="3450" b="1" i="0">
+                <a:solidFill>
+                  <a:srgbClr val="2F7D68"/>
+                </a:solidFill>
+              </a:rPr>
+              <a:t>›</a:t>
+            </a:r>
+          </a:p>
+        </p:txBody>
+      </p:sp>
+      <p:sp>
+        <p:nvSpPr>
+          <p:cNvPr id="8" name="">
+            <a:extLst xmlns:a="http://schemas.openxmlformats.org/drawingml/2006/main">
+              <a:ext uri="{FF2B5EF4-FFF2-40B4-BE49-F238E27FC236}">
+                <a16:creationId xmlns:a16="http://schemas.microsoft.com/office/drawing/2014/main" id="{E2134C8C-3415-48AB-A8B3-54017BFD1FA6}"/>
+              </a:ext>
+            </a:extLst>
+          </p:cNvPr>
+          <p:cNvSpPr>
+            <a:spLocks xmlns:a="http://schemas.openxmlformats.org/drawingml/2006/main" noGrp="1"/>
+          </p:cNvSpPr>
+          <p:nvPr/>
+        </p:nvSpPr>
+        <p:spPr>
+          <a:xfrm xmlns:a="http://schemas.openxmlformats.org/drawingml/2006/main">
+            <a:off x="3733800" y="2724150"/>
+            <a:ext cx="1809750" cy="285750"/>
+          </a:xfrm>
+          <a:prstGeom xmlns:a="http://schemas.openxmlformats.org/drawingml/2006/main" prst="rect">
+            <a:avLst/>
+          </a:prstGeom>
+          <a:noFill xmlns:a="http://schemas.openxmlformats.org/drawingml/2006/main"/>
+          <a:ln xmlns:a="http://schemas.openxmlformats.org/drawingml/2006/main" w="0">
+            <a:noFill/>
+            <a:prstDash val="solid"/>
+          </a:ln>
+        </p:spPr>
+        <p:txBody>
+          <a:bodyPr xmlns:a="http://schemas.openxmlformats.org/drawingml/2006/main"/>
+          <a:lstStyle xmlns:a="http://schemas.openxmlformats.org/drawingml/2006/main"/>
+          <a:p xmlns:a="http://schemas.openxmlformats.org/drawingml/2006/main">
+            <a:pPr algn="ctr">
+              <a:defRPr sz="1350" b="1" i="0">
+                <a:solidFill>
+                  <a:srgbClr val="2F7D68"/>
+                </a:solidFill>
+              </a:defRPr>
+            </a:pPr>
+            <a:r>
+              <a:rPr sz="1350" b="1" i="0">
+                <a:solidFill>
+                  <a:srgbClr val="2F7D68"/>
+                </a:solidFill>
+              </a:rPr>
+              <a:t>4:00 P.M.</a:t>
+            </a:r>
+          </a:p>
+        </p:txBody>
+      </p:sp>
+      <p:sp>
+        <p:nvSpPr>
+          <p:cNvPr id="9" name="">
+            <a:extLst xmlns:a="http://schemas.openxmlformats.org/drawingml/2006/main">
+              <a:ext uri="{FF2B5EF4-FFF2-40B4-BE49-F238E27FC236}">
+                <a16:creationId xmlns:a16="http://schemas.microsoft.com/office/drawing/2014/main" id="{49428A2E-5390-4ED8-914B-DBB770FB51E1}"/>
+              </a:ext>
+            </a:extLst>
+          </p:cNvPr>
+          <p:cNvSpPr>
+            <a:spLocks xmlns:a="http://schemas.openxmlformats.org/drawingml/2006/main" noGrp="1"/>
+          </p:cNvSpPr>
+          <p:nvPr/>
+        </p:nvSpPr>
+        <p:spPr>
+          <a:xfrm xmlns:a="http://schemas.openxmlformats.org/drawingml/2006/main">
+            <a:off x="3733800" y="3105150"/>
+            <a:ext cx="1809750" cy="228600"/>
+          </a:xfrm>
+          <a:prstGeom xmlns:a="http://schemas.openxmlformats.org/drawingml/2006/main" prst="rect">
+            <a:avLst/>
+          </a:prstGeom>
+          <a:noFill xmlns:a="http://schemas.openxmlformats.org/drawingml/2006/main"/>
+          <a:ln xmlns:a="http://schemas.openxmlformats.org/drawingml/2006/main" w="0">
+            <a:noFill/>
+            <a:prstDash val="solid"/>
+          </a:ln>
+        </p:spPr>
+        <p:txBody>
+          <a:bodyPr xmlns:a="http://schemas.openxmlformats.org/drawingml/2006/main"/>
+          <a:lstStyle xmlns:a="http://schemas.openxmlformats.org/drawingml/2006/main"/>
+          <a:p xmlns:a="http://schemas.openxmlformats.org/drawingml/2006/main">
+            <a:pPr algn="ctr">
+              <a:defRPr sz="1200" b="1" i="0">
+                <a:solidFill>
+                  <a:srgbClr val="2F7D68"/>
+                </a:solidFill>
+              </a:defRPr>
+            </a:pPr>
+            <a:r>
+              <a:rPr sz="1200" b="1" i="0">
+                <a:solidFill>
+                  <a:srgbClr val="2F7D68"/>
+                </a:solidFill>
+              </a:rPr>
+              <a:t>Finly Core</a:t>
+            </a:r>
+          </a:p>
+        </p:txBody>
+      </p:sp>
+      <p:sp>
+        <p:nvSpPr>
+          <p:cNvPr id="10" name="">
+            <a:extLst xmlns:a="http://schemas.openxmlformats.org/drawingml/2006/main">
+              <a:ext uri="{FF2B5EF4-FFF2-40B4-BE49-F238E27FC236}">
+                <a16:creationId xmlns:a16="http://schemas.microsoft.com/office/drawing/2014/main" id="{10CE47FC-DB3F-46CE-9266-9BB183088E4A}"/>
+              </a:ext>
+            </a:extLst>
+          </p:cNvPr>
+          <p:cNvSpPr>
+            <a:spLocks xmlns:a="http://schemas.openxmlformats.org/drawingml/2006/main" noGrp="1"/>
+          </p:cNvSpPr>
+          <p:nvPr/>
+        </p:nvSpPr>
+        <p:spPr>
+          <a:xfrm xmlns:a="http://schemas.openxmlformats.org/drawingml/2006/main">
+            <a:off x="3524250" y="3390900"/>
+            <a:ext cx="2228850" cy="419100"/>
+          </a:xfrm>
+          <a:prstGeom xmlns:a="http://schemas.openxmlformats.org/drawingml/2006/main" prst="rect">
+            <a:avLst/>
+          </a:prstGeom>
+          <a:noFill xmlns:a="http://schemas.openxmlformats.org/drawingml/2006/main"/>
+          <a:ln xmlns:a="http://schemas.openxmlformats.org/drawingml/2006/main" w="0">
+            <a:noFill/>
+            <a:prstDash val="solid"/>
+          </a:ln>
+        </p:spPr>
+        <p:txBody>
+          <a:bodyPr xmlns:a="http://schemas.openxmlformats.org/drawingml/2006/main"/>
+          <a:lstStyle xmlns:a="http://schemas.openxmlformats.org/drawingml/2006/main"/>
+          <a:p xmlns:a="http://schemas.openxmlformats.org/drawingml/2006/main">
+            <a:pPr algn="ctr">
+              <a:defRPr sz="2175" b="1" i="0">
+                <a:solidFill>
+                  <a:srgbClr val="0B2942"/>
+                </a:solidFill>
+              </a:defRPr>
+            </a:pPr>
+            <a:r>
+              <a:rPr sz="2175" b="1" i="0">
+                <a:solidFill>
+                  <a:srgbClr val="0B2942"/>
+                </a:solidFill>
+              </a:rPr>
+              <a:t>$100,095.32</a:t>
+            </a:r>
+          </a:p>
+        </p:txBody>
+      </p:sp>
+      <p:sp>
+        <p:nvSpPr>
+          <p:cNvPr id="11" name="">
+            <a:extLst xmlns:a="http://schemas.openxmlformats.org/drawingml/2006/main">
+              <a:ext uri="{FF2B5EF4-FFF2-40B4-BE49-F238E27FC236}">
+                <a16:creationId xmlns:a16="http://schemas.microsoft.com/office/drawing/2014/main" id="{80660698-EED4-4455-BE03-E30FF679023B}"/>
+              </a:ext>
+            </a:extLst>
+          </p:cNvPr>
+          <p:cNvSpPr>
+            <a:spLocks xmlns:a="http://schemas.openxmlformats.org/drawingml/2006/main" noGrp="1"/>
+          </p:cNvSpPr>
+          <p:nvPr/>
+        </p:nvSpPr>
+        <p:spPr>
+          <a:xfrm xmlns:a="http://schemas.openxmlformats.org/drawingml/2006/main">
+            <a:off x="5829300" y="3105150"/>
+            <a:ext cx="1428750" cy="228600"/>
+          </a:xfrm>
+          <a:prstGeom xmlns:a="http://schemas.openxmlformats.org/drawingml/2006/main" prst="rect">
+            <a:avLst/>
+          </a:prstGeom>
+          <a:noFill xmlns:a="http://schemas.openxmlformats.org/drawingml/2006/main"/>
+          <a:ln xmlns:a="http://schemas.openxmlformats.org/drawingml/2006/main" w="0">
+            <a:noFill/>
+            <a:prstDash val="solid"/>
+          </a:ln>
+        </p:spPr>
+        <p:txBody>
+          <a:bodyPr xmlns:a="http://schemas.openxmlformats.org/drawingml/2006/main"/>
+          <a:lstStyle xmlns:a="http://schemas.openxmlformats.org/drawingml/2006/main"/>
+          <a:p xmlns:a="http://schemas.openxmlformats.org/drawingml/2006/main">
+            <a:pPr algn="ctr">
+              <a:defRPr sz="1200" b="1" i="0">
+                <a:solidFill>
+                  <a:srgbClr val="E56B5D"/>
+                </a:solidFill>
+              </a:defRPr>
+            </a:pPr>
+            <a:r>
+              <a:rPr sz="1200" b="1" i="0">
+                <a:solidFill>
+                  <a:srgbClr val="E56B5D"/>
+                </a:solidFill>
+              </a:rPr>
+              <a:t>SPY</a:t>
+            </a:r>
+          </a:p>
+        </p:txBody>
+      </p:sp>
+      <p:sp>
+        <p:nvSpPr>
+          <p:cNvPr id="12" name="">
+            <a:extLst xmlns:a="http://schemas.openxmlformats.org/drawingml/2006/main">
+              <a:ext uri="{FF2B5EF4-FFF2-40B4-BE49-F238E27FC236}">
+                <a16:creationId xmlns:a16="http://schemas.microsoft.com/office/drawing/2014/main" id="{0695A647-6944-4C4C-8A59-A90A262D1F15}"/>
+              </a:ext>
+            </a:extLst>
+          </p:cNvPr>
+          <p:cNvSpPr>
+            <a:spLocks xmlns:a="http://schemas.openxmlformats.org/drawingml/2006/main" noGrp="1"/>
+          </p:cNvSpPr>
+          <p:nvPr/>
+        </p:nvSpPr>
+        <p:spPr>
+          <a:xfrm xmlns:a="http://schemas.openxmlformats.org/drawingml/2006/main">
+            <a:off x="5581650" y="3390900"/>
+            <a:ext cx="1924050" cy="419100"/>
+          </a:xfrm>
+          <a:prstGeom xmlns:a="http://schemas.openxmlformats.org/drawingml/2006/main" prst="rect">
+            <a:avLst/>
+          </a:prstGeom>
+          <a:noFill xmlns:a="http://schemas.openxmlformats.org/drawingml/2006/main"/>
+          <a:ln xmlns:a="http://schemas.openxmlformats.org/drawingml/2006/main" w="0">
+            <a:noFill/>
+            <a:prstDash val="solid"/>
+          </a:ln>
+        </p:spPr>
+        <p:txBody>
+          <a:bodyPr xmlns:a="http://schemas.openxmlformats.org/drawingml/2006/main"/>
+          <a:lstStyle xmlns:a="http://schemas.openxmlformats.org/drawingml/2006/main"/>
+          <a:p xmlns:a="http://schemas.openxmlformats.org/drawingml/2006/main">
+            <a:pPr algn="ctr">
+              <a:defRPr sz="2175" b="1" i="0">
+                <a:solidFill>
+                  <a:srgbClr val="0B2942"/>
+                </a:solidFill>
+              </a:defRPr>
+            </a:pPr>
+            <a:r>
+              <a:rPr sz="2175" b="1" i="0">
+                <a:solidFill>
+                  <a:srgbClr val="0B2942"/>
+                </a:solidFill>
+              </a:rPr>
+              <a:t>$99,942.01</a:t>
+            </a:r>
+          </a:p>
+        </p:txBody>
+      </p:sp>
+      <p:sp>
+        <p:nvSpPr>
+          <p:cNvPr id="13" name="">
+            <a:extLst xmlns:a="http://schemas.openxmlformats.org/drawingml/2006/main">
+              <a:ext uri="{FF2B5EF4-FFF2-40B4-BE49-F238E27FC236}">
+                <a16:creationId xmlns:a16="http://schemas.microsoft.com/office/drawing/2014/main" id="{DFE00D9E-DC0B-4153-8285-CCB10E3D36B8}"/>
+              </a:ext>
+            </a:extLst>
+          </p:cNvPr>
+          <p:cNvSpPr>
+            <a:spLocks xmlns:a="http://schemas.openxmlformats.org/drawingml/2006/main" noGrp="1"/>
+          </p:cNvSpPr>
+          <p:nvPr/>
+        </p:nvSpPr>
+        <p:spPr>
+          <a:xfrm xmlns:a="http://schemas.openxmlformats.org/drawingml/2006/main">
+            <a:off x="971550" y="4000500"/>
+            <a:ext cx="6286500" cy="9525"/>
+          </a:xfrm>
+          <a:prstGeom xmlns:a="http://schemas.openxmlformats.org/drawingml/2006/main" prst="rect">
+            <a:avLst/>
+          </a:prstGeom>
+          <a:solidFill xmlns:a="http://schemas.openxmlformats.org/drawingml/2006/main">
+            <a:srgbClr val="CAD4CE"/>
+          </a:solidFill>
+          <a:ln xmlns:a="http://schemas.openxmlformats.org/drawingml/2006/main" w="0">
+            <a:noFill/>
+            <a:prstDash val="solid"/>
+          </a:ln>
+        </p:spPr>
+      </p:sp>
+      <p:sp>
+        <p:nvSpPr>
+          <p:cNvPr id="14" name="">
+            <a:extLst xmlns:a="http://schemas.openxmlformats.org/drawingml/2006/main">
+              <a:ext uri="{FF2B5EF4-FFF2-40B4-BE49-F238E27FC236}">
+                <a16:creationId xmlns:a16="http://schemas.microsoft.com/office/drawing/2014/main" id="{C75465CA-0E42-4F82-9B77-34132F0BBA7D}"/>
+              </a:ext>
+            </a:extLst>
+          </p:cNvPr>
+          <p:cNvSpPr>
+            <a:spLocks xmlns:a="http://schemas.openxmlformats.org/drawingml/2006/main" noGrp="1"/>
+          </p:cNvSpPr>
+          <p:nvPr/>
+        </p:nvSpPr>
+        <p:spPr>
+          <a:xfrm xmlns:a="http://schemas.openxmlformats.org/drawingml/2006/main">
+            <a:off x="971550" y="4248150"/>
+            <a:ext cx="6286500" cy="323850"/>
+          </a:xfrm>
+          <a:prstGeom xmlns:a="http://schemas.openxmlformats.org/drawingml/2006/main" prst="rect">
+            <a:avLst/>
+          </a:prstGeom>
+          <a:noFill xmlns:a="http://schemas.openxmlformats.org/drawingml/2006/main"/>
+          <a:ln xmlns:a="http://schemas.openxmlformats.org/drawingml/2006/main" w="0">
+            <a:noFill/>
+            <a:prstDash val="solid"/>
+          </a:ln>
+        </p:spPr>
+        <p:txBody>
+          <a:bodyPr xmlns:a="http://schemas.openxmlformats.org/drawingml/2006/main"/>
+          <a:lstStyle xmlns:a="http://schemas.openxmlformats.org/drawingml/2006/main"/>
+          <a:p xmlns:a="http://schemas.openxmlformats.org/drawingml/2006/main">
+            <a:pPr algn="ctr">
+              <a:defRPr sz="1275" b="0" i="0">
+                <a:solidFill>
+                  <a:srgbClr val="627078"/>
+                </a:solidFill>
+              </a:defRPr>
+            </a:pPr>
+            <a:r>
+              <a:rPr sz="1275" b="0" i="0">
+                <a:solidFill>
+                  <a:srgbClr val="627078"/>
+                </a:solidFill>
+              </a:rPr>
+              <a:t>15 fills built the four-fund Core portfolio · no options position was open</a:t>
+            </a:r>
+          </a:p>
+        </p:txBody>
+      </p:sp>
+      <p:sp>
+        <p:nvSpPr>
+          <p:cNvPr id="15" name="">
+            <a:extLst xmlns:a="http://schemas.openxmlformats.org/drawingml/2006/main">
+              <a:ext uri="{FF2B5EF4-FFF2-40B4-BE49-F238E27FC236}">
+                <a16:creationId xmlns:a16="http://schemas.microsoft.com/office/drawing/2014/main" id="{124D4804-2535-4EFF-8AA7-FF9466A60084}"/>
               </a:ext>
             </a:extLst>
           </p:cNvPr>
@@ -18298,10 +18855,10 @@
       </p:sp>
       <p:sp>
         <p:nvSpPr>
-          <p:cNvPr id="6" name="">
-            <a:extLst xmlns:a="http://schemas.openxmlformats.org/drawingml/2006/main">
-              <a:ext uri="{FF2B5EF4-FFF2-40B4-BE49-F238E27FC236}">
-                <a16:creationId xmlns:a16="http://schemas.microsoft.com/office/drawing/2014/main" id="{47FFB3C7-1129-400F-8EED-A7D48910FAAD}"/>
+          <p:cNvPr id="16" name="">
+            <a:extLst xmlns:a="http://schemas.openxmlformats.org/drawingml/2006/main">
+              <a:ext uri="{FF2B5EF4-FFF2-40B4-BE49-F238E27FC236}">
+                <a16:creationId xmlns:a16="http://schemas.microsoft.com/office/drawing/2014/main" id="{4C9B12EB-4993-49D2-860D-28C8CEF51F96}"/>
               </a:ext>
             </a:extLst>
           </p:cNvPr>
@@ -18341,17 +18898,17 @@
                   <a:srgbClr val="B9DFD2"/>
                 </a:solidFill>
               </a:rPr>
-              <a:t>One receipt, one baseline, one timestamp.</a:t>
+              <a:t>One start, one close, one fair comparison.</a:t>
             </a:r>
           </a:p>
         </p:txBody>
       </p:sp>
       <p:sp>
         <p:nvSpPr>
-          <p:cNvPr id="7" name="">
-            <a:extLst xmlns:a="http://schemas.openxmlformats.org/drawingml/2006/main">
-              <a:ext uri="{FF2B5EF4-FFF2-40B4-BE49-F238E27FC236}">
-                <a16:creationId xmlns:a16="http://schemas.microsoft.com/office/drawing/2014/main" id="{7E457F91-D956-4327-BB1C-8B6544D48437}"/>
+          <p:cNvPr id="17" name="">
+            <a:extLst xmlns:a="http://schemas.openxmlformats.org/drawingml/2006/main">
+              <a:ext uri="{FF2B5EF4-FFF2-40B4-BE49-F238E27FC236}">
+                <a16:creationId xmlns:a16="http://schemas.microsoft.com/office/drawing/2014/main" id="{4E3A087F-A443-40F7-B637-5ED83DD20678}"/>
               </a:ext>
             </a:extLst>
           </p:cNvPr>
@@ -18379,29 +18936,29 @@
           <a:lstStyle xmlns:a="http://schemas.openxmlformats.org/drawingml/2006/main"/>
           <a:p xmlns:a="http://schemas.openxmlformats.org/drawingml/2006/main">
             <a:pPr algn="l">
-              <a:defRPr sz="1425" b="0" i="0">
+              <a:defRPr sz="1350" b="0" i="0">
                 <a:solidFill>
                   <a:srgbClr val="FFFFFF"/>
                 </a:solidFill>
               </a:defRPr>
             </a:pPr>
             <a:r>
-              <a:rPr sz="1425" b="0" i="0">
+              <a:rPr sz="1350" b="0" i="0">
                 <a:solidFill>
                   <a:srgbClr val="FFFFFF"/>
                 </a:solidFill>
               </a:rPr>
-              <a:t>The public evidence file reconciles 15 broker fills and zero external cashflows.</a:t>
+              <a:t>Finly Core produced this measured account result. The AI options demonstration is separate.</a:t>
             </a:r>
           </a:p>
         </p:txBody>
       </p:sp>
       <p:sp>
         <p:nvSpPr>
-          <p:cNvPr id="8" name="">
-            <a:extLst xmlns:a="http://schemas.openxmlformats.org/drawingml/2006/main">
-              <a:ext uri="{FF2B5EF4-FFF2-40B4-BE49-F238E27FC236}">
-                <a16:creationId xmlns:a16="http://schemas.microsoft.com/office/drawing/2014/main" id="{83E479A4-31D0-4014-9804-D1367299ABED}"/>
+          <p:cNvPr id="18" name="">
+            <a:extLst xmlns:a="http://schemas.openxmlformats.org/drawingml/2006/main">
+              <a:ext uri="{FF2B5EF4-FFF2-40B4-BE49-F238E27FC236}">
+                <a16:creationId xmlns:a16="http://schemas.microsoft.com/office/drawing/2014/main" id="{B22AE9B6-B67A-4571-89BE-7721AB0575F2}"/>
               </a:ext>
             </a:extLst>
           </p:cNvPr>
@@ -18413,7 +18970,7 @@
         <p:spPr>
           <a:xfrm xmlns:a="http://schemas.openxmlformats.org/drawingml/2006/main">
             <a:off x="8172450" y="2152650"/>
-            <a:ext cx="1428750" cy="228600"/>
+            <a:ext cx="1714500" cy="228600"/>
           </a:xfrm>
           <a:prstGeom xmlns:a="http://schemas.openxmlformats.org/drawingml/2006/main" prst="rect">
             <a:avLst/>
@@ -18441,17 +18998,17 @@
                   <a:srgbClr val="B9DFD2"/>
                 </a:solidFill>
               </a:rPr>
-              <a:t>FINLY</a:t>
+              <a:t>FINLY CORE</a:t>
             </a:r>
           </a:p>
         </p:txBody>
       </p:sp>
       <p:sp>
         <p:nvSpPr>
-          <p:cNvPr id="9" name="">
-            <a:extLst xmlns:a="http://schemas.openxmlformats.org/drawingml/2006/main">
-              <a:ext uri="{FF2B5EF4-FFF2-40B4-BE49-F238E27FC236}">
-                <a16:creationId xmlns:a16="http://schemas.microsoft.com/office/drawing/2014/main" id="{82919740-833C-49B2-AD2A-B1BF9F962211}"/>
+          <p:cNvPr id="19" name="">
+            <a:extLst xmlns:a="http://schemas.openxmlformats.org/drawingml/2006/main">
+              <a:ext uri="{FF2B5EF4-FFF2-40B4-BE49-F238E27FC236}">
+                <a16:creationId xmlns:a16="http://schemas.microsoft.com/office/drawing/2014/main" id="{78E8D375-62EA-49D2-8EAB-967BA76C7D92}"/>
               </a:ext>
             </a:extLst>
           </p:cNvPr>
@@ -18498,10 +19055,10 @@
       </p:sp>
       <p:sp>
         <p:nvSpPr>
-          <p:cNvPr id="10" name="">
-            <a:extLst xmlns:a="http://schemas.openxmlformats.org/drawingml/2006/main">
-              <a:ext uri="{FF2B5EF4-FFF2-40B4-BE49-F238E27FC236}">
-                <a16:creationId xmlns:a16="http://schemas.microsoft.com/office/drawing/2014/main" id="{EF5CEB3C-D807-4317-A512-5BDD974B16D2}"/>
+          <p:cNvPr id="20" name="">
+            <a:extLst xmlns:a="http://schemas.openxmlformats.org/drawingml/2006/main">
+              <a:ext uri="{FF2B5EF4-FFF2-40B4-BE49-F238E27FC236}">
+                <a16:creationId xmlns:a16="http://schemas.microsoft.com/office/drawing/2014/main" id="{62CF6EE3-6298-4018-BE9B-FA934EE8489A}"/>
               </a:ext>
             </a:extLst>
           </p:cNvPr>
@@ -18541,17 +19098,17 @@
                   <a:srgbClr val="C4D4D8"/>
                 </a:solidFill>
               </a:rPr>
-              <a:t>paper-account P&amp;L</a:t>
+              <a:t>virtual-money account profit</a:t>
             </a:r>
           </a:p>
         </p:txBody>
       </p:sp>
       <p:sp>
         <p:nvSpPr>
-          <p:cNvPr id="11" name="">
-            <a:extLst xmlns:a="http://schemas.openxmlformats.org/drawingml/2006/main">
-              <a:ext uri="{FF2B5EF4-FFF2-40B4-BE49-F238E27FC236}">
-                <a16:creationId xmlns:a16="http://schemas.microsoft.com/office/drawing/2014/main" id="{6DE8276B-F5F8-43AE-8B74-A479221F5A18}"/>
+          <p:cNvPr id="21" name="">
+            <a:extLst xmlns:a="http://schemas.openxmlformats.org/drawingml/2006/main">
+              <a:ext uri="{FF2B5EF4-FFF2-40B4-BE49-F238E27FC236}">
+                <a16:creationId xmlns:a16="http://schemas.microsoft.com/office/drawing/2014/main" id="{09316282-8FA4-4FC1-863E-99D59C8D4FC2}"/>
               </a:ext>
             </a:extLst>
           </p:cNvPr>
@@ -18579,10 +19136,10 @@
       </p:sp>
       <p:sp>
         <p:nvSpPr>
-          <p:cNvPr id="12" name="">
-            <a:extLst xmlns:a="http://schemas.openxmlformats.org/drawingml/2006/main">
-              <a:ext uri="{FF2B5EF4-FFF2-40B4-BE49-F238E27FC236}">
-                <a16:creationId xmlns:a16="http://schemas.microsoft.com/office/drawing/2014/main" id="{5B2141E1-CF2C-4C7E-8ACF-A391C095F3F8}"/>
+          <p:cNvPr id="22" name="">
+            <a:extLst xmlns:a="http://schemas.openxmlformats.org/drawingml/2006/main">
+              <a:ext uri="{FF2B5EF4-FFF2-40B4-BE49-F238E27FC236}">
+                <a16:creationId xmlns:a16="http://schemas.microsoft.com/office/drawing/2014/main" id="{FF4D736E-B311-413C-8740-BA4615195818}"/>
               </a:ext>
             </a:extLst>
           </p:cNvPr>
@@ -18594,7 +19151,7 @@
         <p:spPr>
           <a:xfrm xmlns:a="http://schemas.openxmlformats.org/drawingml/2006/main">
             <a:off x="8172450" y="3524250"/>
-            <a:ext cx="1428750" cy="228600"/>
+            <a:ext cx="2476500" cy="228600"/>
           </a:xfrm>
           <a:prstGeom xmlns:a="http://schemas.openxmlformats.org/drawingml/2006/main" prst="rect">
             <a:avLst/>
@@ -18622,17 +19179,17 @@
                   <a:srgbClr val="E56B5D"/>
                 </a:solidFill>
               </a:rPr>
-              <a:t>SPY</a:t>
+              <a:t>SPY · S&amp;P 500 TRACKER</a:t>
             </a:r>
           </a:p>
         </p:txBody>
       </p:sp>
       <p:sp>
         <p:nvSpPr>
-          <p:cNvPr id="13" name="">
-            <a:extLst xmlns:a="http://schemas.openxmlformats.org/drawingml/2006/main">
-              <a:ext uri="{FF2B5EF4-FFF2-40B4-BE49-F238E27FC236}">
-                <a16:creationId xmlns:a16="http://schemas.microsoft.com/office/drawing/2014/main" id="{D48E3B64-6CF9-4F86-A939-2B56817F384F}"/>
+          <p:cNvPr id="23" name="">
+            <a:extLst xmlns:a="http://schemas.openxmlformats.org/drawingml/2006/main">
+              <a:ext uri="{FF2B5EF4-FFF2-40B4-BE49-F238E27FC236}">
+                <a16:creationId xmlns:a16="http://schemas.microsoft.com/office/drawing/2014/main" id="{854408AB-B4F8-41FA-8AB5-BC1919CF4050}"/>
               </a:ext>
             </a:extLst>
           </p:cNvPr>
@@ -18679,10 +19236,10 @@
       </p:sp>
       <p:sp>
         <p:nvSpPr>
-          <p:cNvPr id="14" name="">
-            <a:extLst xmlns:a="http://schemas.openxmlformats.org/drawingml/2006/main">
-              <a:ext uri="{FF2B5EF4-FFF2-40B4-BE49-F238E27FC236}">
-                <a16:creationId xmlns:a16="http://schemas.microsoft.com/office/drawing/2014/main" id="{EB9CE761-5D35-40CB-8495-A7988E3EFF14}"/>
+          <p:cNvPr id="24" name="">
+            <a:extLst xmlns:a="http://schemas.openxmlformats.org/drawingml/2006/main">
+              <a:ext uri="{FF2B5EF4-FFF2-40B4-BE49-F238E27FC236}">
+                <a16:creationId xmlns:a16="http://schemas.microsoft.com/office/drawing/2014/main" id="{53F12AA5-5086-412B-93E7-318FAEDB6D82}"/>
               </a:ext>
             </a:extLst>
           </p:cNvPr>
@@ -18729,10 +19286,10 @@
       </p:sp>
       <p:sp>
         <p:nvSpPr>
-          <p:cNvPr id="15" name="">
-            <a:extLst xmlns:a="http://schemas.openxmlformats.org/drawingml/2006/main">
-              <a:ext uri="{FF2B5EF4-FFF2-40B4-BE49-F238E27FC236}">
-                <a16:creationId xmlns:a16="http://schemas.microsoft.com/office/drawing/2014/main" id="{D05E27FD-F491-4C3D-99D7-1A0421091177}"/>
+          <p:cNvPr id="25" name="">
+            <a:extLst xmlns:a="http://schemas.openxmlformats.org/drawingml/2006/main">
+              <a:ext uri="{FF2B5EF4-FFF2-40B4-BE49-F238E27FC236}">
+                <a16:creationId xmlns:a16="http://schemas.microsoft.com/office/drawing/2014/main" id="{BA57D9C8-8A7B-4026-B5F0-FDA0E1D6C1E9}"/>
               </a:ext>
             </a:extLst>
           </p:cNvPr>
@@ -18760,10 +19317,10 @@
       </p:sp>
       <p:sp>
         <p:nvSpPr>
-          <p:cNvPr id="16" name="">
-            <a:extLst xmlns:a="http://schemas.openxmlformats.org/drawingml/2006/main">
-              <a:ext uri="{FF2B5EF4-FFF2-40B4-BE49-F238E27FC236}">
-                <a16:creationId xmlns:a16="http://schemas.microsoft.com/office/drawing/2014/main" id="{084DCA05-F8EB-43B2-B3B3-45D1EE1DC443}"/>
+          <p:cNvPr id="26" name="">
+            <a:extLst xmlns:a="http://schemas.openxmlformats.org/drawingml/2006/main">
+              <a:ext uri="{FF2B5EF4-FFF2-40B4-BE49-F238E27FC236}">
+                <a16:creationId xmlns:a16="http://schemas.microsoft.com/office/drawing/2014/main" id="{FF84C797-F8D6-4322-A1EC-7C12CB489AB4}"/>
               </a:ext>
             </a:extLst>
           </p:cNvPr>
@@ -18810,10 +19367,10 @@
       </p:sp>
       <p:sp>
         <p:nvSpPr>
-          <p:cNvPr id="17" name="">
-            <a:extLst xmlns:a="http://schemas.openxmlformats.org/drawingml/2006/main">
-              <a:ext uri="{FF2B5EF4-FFF2-40B4-BE49-F238E27FC236}">
-                <a16:creationId xmlns:a16="http://schemas.microsoft.com/office/drawing/2014/main" id="{0EAC2612-FBDB-4A5A-A12C-EBAB839576A9}"/>
+          <p:cNvPr id="27" name="">
+            <a:extLst xmlns:a="http://schemas.openxmlformats.org/drawingml/2006/main">
+              <a:ext uri="{FF2B5EF4-FFF2-40B4-BE49-F238E27FC236}">
+                <a16:creationId xmlns:a16="http://schemas.microsoft.com/office/drawing/2014/main" id="{092C52EB-861D-45F2-AE32-18EDE879E96D}"/>
               </a:ext>
             </a:extLst>
           </p:cNvPr>
@@ -18860,10 +19417,10 @@
       </p:sp>
       <p:sp>
         <p:nvSpPr>
-          <p:cNvPr id="18" name="">
-            <a:extLst xmlns:a="http://schemas.openxmlformats.org/drawingml/2006/main">
-              <a:ext uri="{FF2B5EF4-FFF2-40B4-BE49-F238E27FC236}">
-                <a16:creationId xmlns:a16="http://schemas.microsoft.com/office/drawing/2014/main" id="{154ECFCE-CD87-4B8F-81DD-3FC985CA3EE8}"/>
+          <p:cNvPr id="28" name="">
+            <a:extLst xmlns:a="http://schemas.openxmlformats.org/drawingml/2006/main">
+              <a:ext uri="{FF2B5EF4-FFF2-40B4-BE49-F238E27FC236}">
+                <a16:creationId xmlns:a16="http://schemas.microsoft.com/office/drawing/2014/main" id="{C07E1FAC-0FE3-4221-ADBB-991AA4ABDF96}"/>
               </a:ext>
             </a:extLst>
           </p:cNvPr>
@@ -18903,17 +19460,17 @@
                   <a:srgbClr val="B9DFD2"/>
                 </a:solidFill>
               </a:rPr>
-              <a:t>Same $100k baseline · exact 4:00 p.m. ET · zero cashflows</a:t>
+              <a:t>Same $100k start · same 4:00 p.m. price · no deposits</a:t>
             </a:r>
           </a:p>
         </p:txBody>
       </p:sp>
       <p:sp>
         <p:nvSpPr>
-          <p:cNvPr id="19" name="">
-            <a:extLst xmlns:a="http://schemas.openxmlformats.org/drawingml/2006/main">
-              <a:ext uri="{FF2B5EF4-FFF2-40B4-BE49-F238E27FC236}">
-                <a16:creationId xmlns:a16="http://schemas.microsoft.com/office/drawing/2014/main" id="{AB59FB88-B242-4F45-B5B1-D4041DC67A50}"/>
+          <p:cNvPr id="29" name="">
+            <a:extLst xmlns:a="http://schemas.openxmlformats.org/drawingml/2006/main">
+              <a:ext uri="{FF2B5EF4-FFF2-40B4-BE49-F238E27FC236}">
+                <a16:creationId xmlns:a16="http://schemas.microsoft.com/office/drawing/2014/main" id="{181600A2-F754-4285-AD35-182AF3BD1807}"/>
               </a:ext>
             </a:extLst>
           </p:cNvPr>
@@ -18960,10 +19517,10 @@
       </p:sp>
       <p:sp>
         <p:nvSpPr>
-          <p:cNvPr id="20" name="">
-            <a:extLst xmlns:a="http://schemas.openxmlformats.org/drawingml/2006/main">
-              <a:ext uri="{FF2B5EF4-FFF2-40B4-BE49-F238E27FC236}">
-                <a16:creationId xmlns:a16="http://schemas.microsoft.com/office/drawing/2014/main" id="{16796D93-CE50-4005-9355-67308B5E778D}"/>
+          <p:cNvPr id="30" name="">
+            <a:extLst xmlns:a="http://schemas.openxmlformats.org/drawingml/2006/main">
+              <a:ext uri="{FF2B5EF4-FFF2-40B4-BE49-F238E27FC236}">
+                <a16:creationId xmlns:a16="http://schemas.microsoft.com/office/drawing/2014/main" id="{07D802F0-D91F-4846-9C5A-5A5B8F0A4E58}"/>
               </a:ext>
             </a:extLst>
           </p:cNvPr>
@@ -19011,7 +19568,7 @@
     </p:spTree>
     <p:extLst>
       <p:ext uri="{BB962C8B-B14F-4D97-AF65-F5344CB8AC3E}">
-        <p14:creationId xmlns:p14="http://schemas.microsoft.com/office/powerpoint/2010/main" val="306696360"/>
+        <p14:creationId xmlns:p14="http://schemas.microsoft.com/office/powerpoint/2010/main" val="1080517579"/>
       </p:ext>
     </p:extLst>
   </p:cSld>
@@ -19042,7 +19599,7 @@
           <p:cNvPr id="25" name="">
             <a:extLst xmlns:a="http://schemas.openxmlformats.org/drawingml/2006/main">
               <a:ext uri="{FF2B5EF4-FFF2-40B4-BE49-F238E27FC236}">
-                <a16:creationId xmlns:a16="http://schemas.microsoft.com/office/drawing/2014/main" id="{153A888D-486C-4CDB-86F3-FDE92B7B7C4E}"/>
+                <a16:creationId xmlns:a16="http://schemas.microsoft.com/office/drawing/2014/main" id="{03E05E01-82AF-40DF-967A-A7FA2DFDEFD9}"/>
               </a:ext>
             </a:extLst>
           </p:cNvPr>
@@ -19082,7 +19639,7 @@
                   <a:srgbClr val="2F7D68"/>
                 </a:solidFill>
               </a:rPr>
-              <a:t>OPERATIONAL PROOF</a:t>
+              <a:t>WHAT HAPPENS WHEN A CHECK FAILS</a:t>
             </a:r>
           </a:p>
         </p:txBody>
@@ -19092,7 +19649,7 @@
           <p:cNvPr id="2" name="">
             <a:extLst xmlns:a="http://schemas.openxmlformats.org/drawingml/2006/main">
               <a:ext uri="{FF2B5EF4-FFF2-40B4-BE49-F238E27FC236}">
-                <a16:creationId xmlns:a16="http://schemas.microsoft.com/office/drawing/2014/main" id="{4095F6DE-A611-43DE-8830-10C927E3042C}"/>
+                <a16:creationId xmlns:a16="http://schemas.microsoft.com/office/drawing/2014/main" id="{E89F2E86-F000-44B7-B39F-E39174D095C7}"/>
               </a:ext>
             </a:extLst>
           </p:cNvPr>
@@ -19132,7 +19689,7 @@
                   <a:srgbClr val="122A3E"/>
                 </a:solidFill>
               </a:rPr>
-              <a:t>Finly fails closed—and leaves a receipt.</a:t>
+              <a:t>Finly stops the trade—and records why.</a:t>
             </a:r>
           </a:p>
         </p:txBody>
@@ -19142,7 +19699,7 @@
           <p:cNvPr id="3" name="">
             <a:extLst xmlns:a="http://schemas.openxmlformats.org/drawingml/2006/main">
               <a:ext uri="{FF2B5EF4-FFF2-40B4-BE49-F238E27FC236}">
-                <a16:creationId xmlns:a16="http://schemas.microsoft.com/office/drawing/2014/main" id="{505CA403-A5AE-471B-BA1D-A8754145D44F}"/>
+                <a16:creationId xmlns:a16="http://schemas.microsoft.com/office/drawing/2014/main" id="{E397601E-F01B-475E-A5C1-E2AA6E622F49}"/>
               </a:ext>
             </a:extLst>
           </p:cNvPr>
@@ -19187,7 +19744,7 @@
           <p:nvPr/>
         </p:nvPicPr>
         <p:blipFill>
-          <a:blip xmlns:r="http://schemas.openxmlformats.org/officeDocument/2006/relationships" xmlns:a="http://schemas.openxmlformats.org/drawingml/2006/main" r:embed="R7c592ab5d9694bed"/>
+          <a:blip xmlns:r="http://schemas.openxmlformats.org/officeDocument/2006/relationships" xmlns:a="http://schemas.openxmlformats.org/drawingml/2006/main" r:embed="Ra1ba967815054614"/>
           <a:stretch xmlns:a="http://schemas.openxmlformats.org/drawingml/2006/main"/>
         </p:blipFill>
         <p:spPr>
@@ -19207,7 +19764,7 @@
           <p:cNvPr id="5" name="">
             <a:extLst xmlns:a="http://schemas.openxmlformats.org/drawingml/2006/main">
               <a:ext uri="{FF2B5EF4-FFF2-40B4-BE49-F238E27FC236}">
-                <a16:creationId xmlns:a16="http://schemas.microsoft.com/office/drawing/2014/main" id="{20C8C45B-0940-48A2-9A3E-ADA10FB32369}"/>
+                <a16:creationId xmlns:a16="http://schemas.microsoft.com/office/drawing/2014/main" id="{A58CCA12-C6EB-4F3A-A8C3-D143E9C4F4F6}"/>
               </a:ext>
             </a:extLst>
           </p:cNvPr>
@@ -19240,7 +19797,7 @@
           <p:cNvPr id="6" name="">
             <a:extLst xmlns:a="http://schemas.openxmlformats.org/drawingml/2006/main">
               <a:ext uri="{FF2B5EF4-FFF2-40B4-BE49-F238E27FC236}">
-                <a16:creationId xmlns:a16="http://schemas.microsoft.com/office/drawing/2014/main" id="{75A404CD-5F39-4E89-BF40-51D0DBD7CFA2}"/>
+                <a16:creationId xmlns:a16="http://schemas.microsoft.com/office/drawing/2014/main" id="{5965F19B-0E9D-4F75-A7E0-DF8E75EA9F97}"/>
               </a:ext>
             </a:extLst>
           </p:cNvPr>
@@ -19290,7 +19847,7 @@
           <p:cNvPr id="7" name="">
             <a:extLst xmlns:a="http://schemas.openxmlformats.org/drawingml/2006/main">
               <a:ext uri="{FF2B5EF4-FFF2-40B4-BE49-F238E27FC236}">
-                <a16:creationId xmlns:a16="http://schemas.microsoft.com/office/drawing/2014/main" id="{129CFB0F-D239-40F8-AFDE-65E321245596}"/>
+                <a16:creationId xmlns:a16="http://schemas.microsoft.com/office/drawing/2014/main" id="{FE1F6456-3A1F-4E8A-9D07-D0E8E3AEF98C}"/>
               </a:ext>
             </a:extLst>
           </p:cNvPr>
@@ -19340,7 +19897,7 @@
           <p:cNvPr id="8" name="">
             <a:extLst xmlns:a="http://schemas.openxmlformats.org/drawingml/2006/main">
               <a:ext uri="{FF2B5EF4-FFF2-40B4-BE49-F238E27FC236}">
-                <a16:creationId xmlns:a16="http://schemas.microsoft.com/office/drawing/2014/main" id="{075C8C9D-F3BD-4877-8368-BFE39577C870}"/>
+                <a16:creationId xmlns:a16="http://schemas.microsoft.com/office/drawing/2014/main" id="{21220026-B2E2-4D57-B8D8-7FF78AB80F63}"/>
               </a:ext>
             </a:extLst>
           </p:cNvPr>
@@ -19373,7 +19930,7 @@
           <p:cNvPr id="9" name="">
             <a:extLst xmlns:a="http://schemas.openxmlformats.org/drawingml/2006/main">
               <a:ext uri="{FF2B5EF4-FFF2-40B4-BE49-F238E27FC236}">
-                <a16:creationId xmlns:a16="http://schemas.microsoft.com/office/drawing/2014/main" id="{0B76B496-F661-4C93-8454-49656CA01E7E}"/>
+                <a16:creationId xmlns:a16="http://schemas.microsoft.com/office/drawing/2014/main" id="{45C04B1A-68C8-4F8E-83BF-A05DAB884946}"/>
               </a:ext>
             </a:extLst>
           </p:cNvPr>
@@ -19423,7 +19980,7 @@
           <p:cNvPr id="10" name="">
             <a:extLst xmlns:a="http://schemas.openxmlformats.org/drawingml/2006/main">
               <a:ext uri="{FF2B5EF4-FFF2-40B4-BE49-F238E27FC236}">
-                <a16:creationId xmlns:a16="http://schemas.microsoft.com/office/drawing/2014/main" id="{EDE039EC-3491-443C-9056-CAB2C1BA6770}"/>
+                <a16:creationId xmlns:a16="http://schemas.microsoft.com/office/drawing/2014/main" id="{308C1141-E228-48FE-9F00-270A3707C122}"/>
               </a:ext>
             </a:extLst>
           </p:cNvPr>
@@ -19473,7 +20030,7 @@
           <p:cNvPr id="11" name="">
             <a:extLst xmlns:a="http://schemas.openxmlformats.org/drawingml/2006/main">
               <a:ext uri="{FF2B5EF4-FFF2-40B4-BE49-F238E27FC236}">
-                <a16:creationId xmlns:a16="http://schemas.microsoft.com/office/drawing/2014/main" id="{EE860440-39E5-4671-ACE6-6BADB130C2B5}"/>
+                <a16:creationId xmlns:a16="http://schemas.microsoft.com/office/drawing/2014/main" id="{D56687C8-CD2F-44A0-A157-E455E0171484}"/>
               </a:ext>
             </a:extLst>
           </p:cNvPr>
@@ -19506,7 +20063,7 @@
           <p:cNvPr id="12" name="">
             <a:extLst xmlns:a="http://schemas.openxmlformats.org/drawingml/2006/main">
               <a:ext uri="{FF2B5EF4-FFF2-40B4-BE49-F238E27FC236}">
-                <a16:creationId xmlns:a16="http://schemas.microsoft.com/office/drawing/2014/main" id="{4D58923C-01DE-4B20-A411-20E6425325F2}"/>
+                <a16:creationId xmlns:a16="http://schemas.microsoft.com/office/drawing/2014/main" id="{54BF75C3-692D-4D2D-920F-6B496B472E02}"/>
               </a:ext>
             </a:extLst>
           </p:cNvPr>
@@ -19556,7 +20113,7 @@
           <p:cNvPr id="13" name="">
             <a:extLst xmlns:a="http://schemas.openxmlformats.org/drawingml/2006/main">
               <a:ext uri="{FF2B5EF4-FFF2-40B4-BE49-F238E27FC236}">
-                <a16:creationId xmlns:a16="http://schemas.microsoft.com/office/drawing/2014/main" id="{762EC1EA-58D7-4AE7-8504-FA32799B96E3}"/>
+                <a16:creationId xmlns:a16="http://schemas.microsoft.com/office/drawing/2014/main" id="{2DEC97EA-076E-4149-86F1-ED0DE28A695A}"/>
               </a:ext>
             </a:extLst>
           </p:cNvPr>
@@ -19606,7 +20163,7 @@
           <p:cNvPr id="14" name="">
             <a:extLst xmlns:a="http://schemas.openxmlformats.org/drawingml/2006/main">
               <a:ext uri="{FF2B5EF4-FFF2-40B4-BE49-F238E27FC236}">
-                <a16:creationId xmlns:a16="http://schemas.microsoft.com/office/drawing/2014/main" id="{E3642D0B-64E8-4364-9011-ED19DCC7DB1C}"/>
+                <a16:creationId xmlns:a16="http://schemas.microsoft.com/office/drawing/2014/main" id="{EC3EF62F-BCD9-4EE1-8BCC-D154D1F562C8}"/>
               </a:ext>
             </a:extLst>
           </p:cNvPr>
@@ -19639,7 +20196,7 @@
           <p:cNvPr id="15" name="">
             <a:extLst xmlns:a="http://schemas.openxmlformats.org/drawingml/2006/main">
               <a:ext uri="{FF2B5EF4-FFF2-40B4-BE49-F238E27FC236}">
-                <a16:creationId xmlns:a16="http://schemas.microsoft.com/office/drawing/2014/main" id="{8921D42B-5C13-4538-9738-8E6CB7813ADC}"/>
+                <a16:creationId xmlns:a16="http://schemas.microsoft.com/office/drawing/2014/main" id="{D8AE44FA-3A33-4BAB-A58A-CA4DA14CDC9F}"/>
               </a:ext>
             </a:extLst>
           </p:cNvPr>
@@ -19689,7 +20246,7 @@
           <p:cNvPr id="16" name="">
             <a:extLst xmlns:a="http://schemas.openxmlformats.org/drawingml/2006/main">
               <a:ext uri="{FF2B5EF4-FFF2-40B4-BE49-F238E27FC236}">
-                <a16:creationId xmlns:a16="http://schemas.microsoft.com/office/drawing/2014/main" id="{B50380D2-FB9D-4D1D-B239-A56474FE97E8}"/>
+                <a16:creationId xmlns:a16="http://schemas.microsoft.com/office/drawing/2014/main" id="{2005CC20-60BD-4499-9605-7638AC8B4621}"/>
               </a:ext>
             </a:extLst>
           </p:cNvPr>
@@ -19739,7 +20296,7 @@
           <p:cNvPr id="17" name="">
             <a:extLst xmlns:a="http://schemas.openxmlformats.org/drawingml/2006/main">
               <a:ext uri="{FF2B5EF4-FFF2-40B4-BE49-F238E27FC236}">
-                <a16:creationId xmlns:a16="http://schemas.microsoft.com/office/drawing/2014/main" id="{52491154-6A55-41A4-81C5-CC8CDBF07356}"/>
+                <a16:creationId xmlns:a16="http://schemas.microsoft.com/office/drawing/2014/main" id="{84C10888-ACD4-4BDA-BD15-599CD6D0834F}"/>
               </a:ext>
             </a:extLst>
           </p:cNvPr>
@@ -19770,7 +20327,7 @@
           <p:cNvPr id="18" name="">
             <a:extLst xmlns:a="http://schemas.openxmlformats.org/drawingml/2006/main">
               <a:ext uri="{FF2B5EF4-FFF2-40B4-BE49-F238E27FC236}">
-                <a16:creationId xmlns:a16="http://schemas.microsoft.com/office/drawing/2014/main" id="{D109B26C-0B57-4D4E-8692-03936896F489}"/>
+                <a16:creationId xmlns:a16="http://schemas.microsoft.com/office/drawing/2014/main" id="{4B4A46F1-F030-4B17-A9FC-FCC421C5E1D6}"/>
               </a:ext>
             </a:extLst>
           </p:cNvPr>
@@ -19820,7 +20377,7 @@
           <p:cNvPr id="19" name="">
             <a:extLst xmlns:a="http://schemas.openxmlformats.org/drawingml/2006/main">
               <a:ext uri="{FF2B5EF4-FFF2-40B4-BE49-F238E27FC236}">
-                <a16:creationId xmlns:a16="http://schemas.microsoft.com/office/drawing/2014/main" id="{8DFB63AA-B766-4C27-B6D8-BC5C8AEF2DEE}"/>
+                <a16:creationId xmlns:a16="http://schemas.microsoft.com/office/drawing/2014/main" id="{654FEEFA-697F-4FB6-B846-3A614BA6311E}"/>
               </a:ext>
             </a:extLst>
           </p:cNvPr>
@@ -19870,7 +20427,7 @@
           <p:cNvPr id="20" name="">
             <a:extLst xmlns:a="http://schemas.openxmlformats.org/drawingml/2006/main">
               <a:ext uri="{FF2B5EF4-FFF2-40B4-BE49-F238E27FC236}">
-                <a16:creationId xmlns:a16="http://schemas.microsoft.com/office/drawing/2014/main" id="{097FD995-7620-4BA5-8A4D-95ED90E199D6}"/>
+                <a16:creationId xmlns:a16="http://schemas.microsoft.com/office/drawing/2014/main" id="{C1C37687-A900-4FDF-8F8F-CF596733C827}"/>
               </a:ext>
             </a:extLst>
           </p:cNvPr>
@@ -19920,7 +20477,7 @@
           <p:cNvPr id="21" name="">
             <a:extLst xmlns:a="http://schemas.openxmlformats.org/drawingml/2006/main">
               <a:ext uri="{FF2B5EF4-FFF2-40B4-BE49-F238E27FC236}">
-                <a16:creationId xmlns:a16="http://schemas.microsoft.com/office/drawing/2014/main" id="{AB237FD7-950D-436D-864D-B6BCE96A7B8C}"/>
+                <a16:creationId xmlns:a16="http://schemas.microsoft.com/office/drawing/2014/main" id="{12F24B6D-E5BC-4DBB-BC72-480AB619CBEA}"/>
               </a:ext>
             </a:extLst>
           </p:cNvPr>
@@ -19953,7 +20510,7 @@
           <p:cNvPr id="22" name="">
             <a:extLst xmlns:a="http://schemas.openxmlformats.org/drawingml/2006/main">
               <a:ext uri="{FF2B5EF4-FFF2-40B4-BE49-F238E27FC236}">
-                <a16:creationId xmlns:a16="http://schemas.microsoft.com/office/drawing/2014/main" id="{27823040-9BB0-4AEA-B561-C5B56BBA647D}"/>
+                <a16:creationId xmlns:a16="http://schemas.microsoft.com/office/drawing/2014/main" id="{6E1948C2-D223-42AC-9EE9-ECE62BABB610}"/>
               </a:ext>
             </a:extLst>
           </p:cNvPr>
@@ -19981,19 +20538,19 @@
           <a:lstStyle xmlns:a="http://schemas.openxmlformats.org/drawingml/2006/main"/>
           <a:p xmlns:a="http://schemas.openxmlformats.org/drawingml/2006/main">
             <a:pPr algn="ctr">
-              <a:defRPr sz="1575" b="1" i="0">
+              <a:defRPr sz="1425" b="1" i="0">
                 <a:solidFill>
                   <a:srgbClr val="FFFFFF"/>
                 </a:solidFill>
               </a:defRPr>
             </a:pPr>
             <a:r>
-              <a:rPr sz="1575" b="1" i="0">
+              <a:rPr sz="1425" b="1" i="0">
                 <a:solidFill>
                   <a:srgbClr val="FFFFFF"/>
                 </a:solidFill>
               </a:rPr>
-              <a:t>Conflict → NO TRADE → $0 authorized loss</a:t>
+              <a:t>Conflicting evidence → no trade → $0 new options risk</a:t>
             </a:r>
           </a:p>
         </p:txBody>
@@ -20003,7 +20560,7 @@
           <p:cNvPr id="23" name="">
             <a:extLst xmlns:a="http://schemas.openxmlformats.org/drawingml/2006/main">
               <a:ext uri="{FF2B5EF4-FFF2-40B4-BE49-F238E27FC236}">
-                <a16:creationId xmlns:a16="http://schemas.microsoft.com/office/drawing/2014/main" id="{81D15A9D-8ED7-427B-A176-45D2C53D898C}"/>
+                <a16:creationId xmlns:a16="http://schemas.microsoft.com/office/drawing/2014/main" id="{F934A579-F9FC-4E5A-95D4-88DA19382D33}"/>
               </a:ext>
             </a:extLst>
           </p:cNvPr>
@@ -20053,7 +20610,7 @@
           <p:cNvPr id="24" name="">
             <a:extLst xmlns:a="http://schemas.openxmlformats.org/drawingml/2006/main">
               <a:ext uri="{FF2B5EF4-FFF2-40B4-BE49-F238E27FC236}">
-                <a16:creationId xmlns:a16="http://schemas.microsoft.com/office/drawing/2014/main" id="{46AF4F12-3135-4531-B69F-10BB1907B86A}"/>
+                <a16:creationId xmlns:a16="http://schemas.microsoft.com/office/drawing/2014/main" id="{9079E22D-D2AA-497A-A26B-AA11469B9AAD}"/>
               </a:ext>
             </a:extLst>
           </p:cNvPr>
@@ -20101,7 +20658,7 @@
     </p:spTree>
     <p:extLst>
       <p:ext uri="{BB962C8B-B14F-4D97-AF65-F5344CB8AC3E}">
-        <p14:creationId xmlns:p14="http://schemas.microsoft.com/office/powerpoint/2010/main" val="757002718"/>
+        <p14:creationId xmlns:p14="http://schemas.microsoft.com/office/powerpoint/2010/main" val="838697686"/>
       </p:ext>
     </p:extLst>
   </p:cSld>
@@ -20132,7 +20689,7 @@
           <p:cNvPr id="24" name="">
             <a:extLst xmlns:a="http://schemas.openxmlformats.org/drawingml/2006/main">
               <a:ext uri="{FF2B5EF4-FFF2-40B4-BE49-F238E27FC236}">
-                <a16:creationId xmlns:a16="http://schemas.microsoft.com/office/drawing/2014/main" id="{019F33EA-12B9-43C4-9FCE-1CF9229979C8}"/>
+                <a16:creationId xmlns:a16="http://schemas.microsoft.com/office/drawing/2014/main" id="{230A346F-DCCF-45F9-9F18-51FC813B2C69}"/>
               </a:ext>
             </a:extLst>
           </p:cNvPr>
@@ -20182,7 +20739,7 @@
           <p:cNvPr id="2" name="">
             <a:extLst xmlns:a="http://schemas.openxmlformats.org/drawingml/2006/main">
               <a:ext uri="{FF2B5EF4-FFF2-40B4-BE49-F238E27FC236}">
-                <a16:creationId xmlns:a16="http://schemas.microsoft.com/office/drawing/2014/main" id="{DFE148F4-511D-4109-8EC9-0A0B5FAF0691}"/>
+                <a16:creationId xmlns:a16="http://schemas.microsoft.com/office/drawing/2014/main" id="{D8B3BE30-4CA5-4FDB-A6F6-E055B0B71DBD}"/>
               </a:ext>
             </a:extLst>
           </p:cNvPr>
@@ -20232,7 +20789,7 @@
           <p:cNvPr id="3" name="">
             <a:extLst xmlns:a="http://schemas.openxmlformats.org/drawingml/2006/main">
               <a:ext uri="{FF2B5EF4-FFF2-40B4-BE49-F238E27FC236}">
-                <a16:creationId xmlns:a16="http://schemas.microsoft.com/office/drawing/2014/main" id="{9B1E17E3-5F02-42A0-800E-9753C24F5A8E}"/>
+                <a16:creationId xmlns:a16="http://schemas.microsoft.com/office/drawing/2014/main" id="{1DBF67CF-D51E-4761-92CB-2207F3E61424}"/>
               </a:ext>
             </a:extLst>
           </p:cNvPr>
@@ -20272,7 +20829,7 @@
                   <a:srgbClr val="627078"/>
                 </a:solidFill>
               </a:rPr>
-              <a:t>$153.31 ahead at the first close. Now challenge the decision and inspect the code.</a:t>
+              <a:t>$153.31 ahead after session one. Now try the decision demo and inspect the proof.</a:t>
             </a:r>
           </a:p>
         </p:txBody>
@@ -20282,7 +20839,7 @@
           <p:cNvPr id="4" name="">
             <a:extLst xmlns:a="http://schemas.openxmlformats.org/drawingml/2006/main">
               <a:ext uri="{FF2B5EF4-FFF2-40B4-BE49-F238E27FC236}">
-                <a16:creationId xmlns:a16="http://schemas.microsoft.com/office/drawing/2014/main" id="{8AA66195-D0EC-4E70-8B39-EC4E6BDF825B}"/>
+                <a16:creationId xmlns:a16="http://schemas.microsoft.com/office/drawing/2014/main" id="{4421E1DF-515D-482D-9500-EA460A92AD63}"/>
               </a:ext>
             </a:extLst>
           </p:cNvPr>
@@ -20327,7 +20884,7 @@
           <p:nvPr/>
         </p:nvPicPr>
         <p:blipFill>
-          <a:blip xmlns:r="http://schemas.openxmlformats.org/officeDocument/2006/relationships" xmlns:a="http://schemas.openxmlformats.org/drawingml/2006/main" r:embed="Rbda7f1c24e0e42dc"/>
+          <a:blip xmlns:r="http://schemas.openxmlformats.org/officeDocument/2006/relationships" xmlns:a="http://schemas.openxmlformats.org/drawingml/2006/main" r:embed="R2bed47038ed74515"/>
           <a:stretch xmlns:a="http://schemas.openxmlformats.org/drawingml/2006/main"/>
         </p:blipFill>
         <p:spPr>
@@ -20345,7 +20902,7 @@
           <p:cNvPr id="6" name="">
             <a:extLst xmlns:a="http://schemas.openxmlformats.org/drawingml/2006/main">
               <a:ext uri="{FF2B5EF4-FFF2-40B4-BE49-F238E27FC236}">
-                <a16:creationId xmlns:a16="http://schemas.microsoft.com/office/drawing/2014/main" id="{D9AEA227-9750-4DE5-A515-2AD3FF538B44}"/>
+                <a16:creationId xmlns:a16="http://schemas.microsoft.com/office/drawing/2014/main" id="{EE80DE87-80F1-49CE-ADFD-3630000996F8}"/>
               </a:ext>
             </a:extLst>
           </p:cNvPr>
@@ -20388,7 +20945,7 @@
                 <a:latin typeface="Arial"/>
                 <a:ea typeface="Arial"/>
                 <a:cs typeface="Arial"/>
-                <a:hlinkClick xmlns:r="http://schemas.openxmlformats.org/officeDocument/2006/relationships" r:id="Rb214e84fd73d4c95"/>
+                <a:hlinkClick xmlns:r="http://schemas.openxmlformats.org/officeDocument/2006/relationships" r:id="Rbbd9332d6dc14c12"/>
               </a:rPr>
               <a:t>SCAN TO OPEN FINLY</a:t>
             </a:r>
@@ -20400,7 +20957,7 @@
           <p:cNvPr id="7" name="">
             <a:extLst xmlns:a="http://schemas.openxmlformats.org/drawingml/2006/main">
               <a:ext uri="{FF2B5EF4-FFF2-40B4-BE49-F238E27FC236}">
-                <a16:creationId xmlns:a16="http://schemas.microsoft.com/office/drawing/2014/main" id="{23E0439F-002B-4B0A-800D-B8B1D6978813}"/>
+                <a16:creationId xmlns:a16="http://schemas.microsoft.com/office/drawing/2014/main" id="{F6C91C67-65AD-4AFA-B4F1-6AC330524A3B}"/>
               </a:ext>
             </a:extLst>
           </p:cNvPr>
@@ -20450,7 +21007,7 @@
           <p:cNvPr id="8" name="">
             <a:extLst xmlns:a="http://schemas.openxmlformats.org/drawingml/2006/main">
               <a:ext uri="{FF2B5EF4-FFF2-40B4-BE49-F238E27FC236}">
-                <a16:creationId xmlns:a16="http://schemas.microsoft.com/office/drawing/2014/main" id="{42409BE5-E4DA-48BF-8A0F-CAA168C5C892}"/>
+                <a16:creationId xmlns:a16="http://schemas.microsoft.com/office/drawing/2014/main" id="{DF388248-24DD-4088-BA53-B25AB5A35482}"/>
               </a:ext>
             </a:extLst>
           </p:cNvPr>
@@ -20500,7 +21057,7 @@
           <p:cNvPr id="9" name="">
             <a:extLst xmlns:a="http://schemas.openxmlformats.org/drawingml/2006/main">
               <a:ext uri="{FF2B5EF4-FFF2-40B4-BE49-F238E27FC236}">
-                <a16:creationId xmlns:a16="http://schemas.microsoft.com/office/drawing/2014/main" id="{5941CE5C-D5F9-4075-AF34-BB1467FAD264}"/>
+                <a16:creationId xmlns:a16="http://schemas.microsoft.com/office/drawing/2014/main" id="{546F7E8D-4E2E-41B1-BA4D-FFD874FD55D4}"/>
               </a:ext>
             </a:extLst>
           </p:cNvPr>
@@ -20540,7 +21097,7 @@
                   <a:srgbClr val="122A3E"/>
                 </a:solidFill>
               </a:rPr>
-              <a:t>Live $100k account</a:t>
+              <a:t>Live $100k paper account</a:t>
             </a:r>
           </a:p>
         </p:txBody>
@@ -20550,7 +21107,7 @@
           <p:cNvPr id="10" name="">
             <a:extLst xmlns:a="http://schemas.openxmlformats.org/drawingml/2006/main">
               <a:ext uri="{FF2B5EF4-FFF2-40B4-BE49-F238E27FC236}">
-                <a16:creationId xmlns:a16="http://schemas.microsoft.com/office/drawing/2014/main" id="{469D68BA-26B4-424B-92D7-1BBD76ED99E6}"/>
+                <a16:creationId xmlns:a16="http://schemas.microsoft.com/office/drawing/2014/main" id="{4752A09D-42E5-4B7E-B580-FDD71A3B7848}"/>
               </a:ext>
             </a:extLst>
           </p:cNvPr>
@@ -20581,7 +21138,7 @@
           <p:cNvPr id="11" name="">
             <a:extLst xmlns:a="http://schemas.openxmlformats.org/drawingml/2006/main">
               <a:ext uri="{FF2B5EF4-FFF2-40B4-BE49-F238E27FC236}">
-                <a16:creationId xmlns:a16="http://schemas.microsoft.com/office/drawing/2014/main" id="{C2F19DFA-E10A-4C20-BAE1-65E65D619DA4}"/>
+                <a16:creationId xmlns:a16="http://schemas.microsoft.com/office/drawing/2014/main" id="{66FCCDC1-ABC6-48D0-AE62-B159AABB4BAE}"/>
               </a:ext>
             </a:extLst>
           </p:cNvPr>
@@ -20631,7 +21188,7 @@
           <p:cNvPr id="12" name="">
             <a:extLst xmlns:a="http://schemas.openxmlformats.org/drawingml/2006/main">
               <a:ext uri="{FF2B5EF4-FFF2-40B4-BE49-F238E27FC236}">
-                <a16:creationId xmlns:a16="http://schemas.microsoft.com/office/drawing/2014/main" id="{2E888037-AACD-4A8D-A2FC-7EFC9DB4A07E}"/>
+                <a16:creationId xmlns:a16="http://schemas.microsoft.com/office/drawing/2014/main" id="{B34AE045-4F95-4C6D-A11D-32407E0B8EF6}"/>
               </a:ext>
             </a:extLst>
           </p:cNvPr>
@@ -20671,7 +21228,7 @@
                   <a:srgbClr val="E56B5D"/>
                 </a:solidFill>
               </a:rPr>
-              <a:t>CHALLENGE</a:t>
+              <a:t>TRY</a:t>
             </a:r>
           </a:p>
         </p:txBody>
@@ -20681,7 +21238,7 @@
           <p:cNvPr id="13" name="">
             <a:extLst xmlns:a="http://schemas.openxmlformats.org/drawingml/2006/main">
               <a:ext uri="{FF2B5EF4-FFF2-40B4-BE49-F238E27FC236}">
-                <a16:creationId xmlns:a16="http://schemas.microsoft.com/office/drawing/2014/main" id="{E17AACD1-1B93-4D4D-AA46-2C2F579217AC}"/>
+                <a16:creationId xmlns:a16="http://schemas.microsoft.com/office/drawing/2014/main" id="{5DEF4141-B8BC-4D38-8ECD-7B1916D4448E}"/>
               </a:ext>
             </a:extLst>
           </p:cNvPr>
@@ -20721,7 +21278,7 @@
                   <a:srgbClr val="122A3E"/>
                 </a:solidFill>
               </a:rPr>
-              <a:t>Aligned vs conflicting evidence</a:t>
+              <a:t>Evidence agrees vs conflicts</a:t>
             </a:r>
           </a:p>
         </p:txBody>
@@ -20731,7 +21288,7 @@
           <p:cNvPr id="14" name="">
             <a:extLst xmlns:a="http://schemas.openxmlformats.org/drawingml/2006/main">
               <a:ext uri="{FF2B5EF4-FFF2-40B4-BE49-F238E27FC236}">
-                <a16:creationId xmlns:a16="http://schemas.microsoft.com/office/drawing/2014/main" id="{9B7E83FB-662C-4101-8024-697AAA6A9407}"/>
+                <a16:creationId xmlns:a16="http://schemas.microsoft.com/office/drawing/2014/main" id="{BD39E3A7-5B08-47FA-B7EF-24957C59F925}"/>
               </a:ext>
             </a:extLst>
           </p:cNvPr>
@@ -20762,7 +21319,7 @@
           <p:cNvPr id="15" name="">
             <a:extLst xmlns:a="http://schemas.openxmlformats.org/drawingml/2006/main">
               <a:ext uri="{FF2B5EF4-FFF2-40B4-BE49-F238E27FC236}">
-                <a16:creationId xmlns:a16="http://schemas.microsoft.com/office/drawing/2014/main" id="{B1724408-3909-494A-97BC-EFEB12958FB3}"/>
+                <a16:creationId xmlns:a16="http://schemas.microsoft.com/office/drawing/2014/main" id="{FC87AB46-BAAB-42E0-999C-E9CC446B1770}"/>
               </a:ext>
             </a:extLst>
           </p:cNvPr>
@@ -20812,7 +21369,7 @@
           <p:cNvPr id="16" name="">
             <a:extLst xmlns:a="http://schemas.openxmlformats.org/drawingml/2006/main">
               <a:ext uri="{FF2B5EF4-FFF2-40B4-BE49-F238E27FC236}">
-                <a16:creationId xmlns:a16="http://schemas.microsoft.com/office/drawing/2014/main" id="{4B790796-806B-4D4A-978E-DDC03C532D1C}"/>
+                <a16:creationId xmlns:a16="http://schemas.microsoft.com/office/drawing/2014/main" id="{E4D75492-68B5-4401-8AD3-148586A95C51}"/>
               </a:ext>
             </a:extLst>
           </p:cNvPr>
@@ -20862,7 +21419,7 @@
           <p:cNvPr id="17" name="">
             <a:extLst xmlns:a="http://schemas.openxmlformats.org/drawingml/2006/main">
               <a:ext uri="{FF2B5EF4-FFF2-40B4-BE49-F238E27FC236}">
-                <a16:creationId xmlns:a16="http://schemas.microsoft.com/office/drawing/2014/main" id="{577FFEB2-BEE4-4B5F-82E0-C8873C0921E8}"/>
+                <a16:creationId xmlns:a16="http://schemas.microsoft.com/office/drawing/2014/main" id="{DC2ABA7B-5649-4C8B-B8D4-EF5E35BED14E}"/>
               </a:ext>
             </a:extLst>
           </p:cNvPr>
@@ -20902,7 +21459,7 @@
                   <a:srgbClr val="122A3E"/>
                 </a:solidFill>
               </a:rPr>
-              <a:t>Code, tests, and receipts</a:t>
+              <a:t>Code, tests, and decision records</a:t>
             </a:r>
           </a:p>
         </p:txBody>
@@ -20912,7 +21469,7 @@
           <p:cNvPr id="18" name="">
             <a:extLst xmlns:a="http://schemas.openxmlformats.org/drawingml/2006/main">
               <a:ext uri="{FF2B5EF4-FFF2-40B4-BE49-F238E27FC236}">
-                <a16:creationId xmlns:a16="http://schemas.microsoft.com/office/drawing/2014/main" id="{364E4EBC-5755-427D-ACAF-BF54FEE2A144}"/>
+                <a16:creationId xmlns:a16="http://schemas.microsoft.com/office/drawing/2014/main" id="{F5FC2B35-7F27-4AF1-A60A-237AD9C076B6}"/>
               </a:ext>
             </a:extLst>
           </p:cNvPr>
@@ -20943,7 +21500,7 @@
           <p:cNvPr id="19" name="">
             <a:extLst xmlns:a="http://schemas.openxmlformats.org/drawingml/2006/main">
               <a:ext uri="{FF2B5EF4-FFF2-40B4-BE49-F238E27FC236}">
-                <a16:creationId xmlns:a16="http://schemas.microsoft.com/office/drawing/2014/main" id="{BA62996C-8600-4CCD-BDAF-4862112275FD}"/>
+                <a16:creationId xmlns:a16="http://schemas.microsoft.com/office/drawing/2014/main" id="{8BB5A5A6-F269-483E-AA2F-534440B2CB31}"/>
               </a:ext>
             </a:extLst>
           </p:cNvPr>
@@ -20983,7 +21540,7 @@
                   <a:srgbClr val="2F7D68"/>
                 </a:solidFill>
               </a:rPr>
-              <a:t>Historical upside. First-close proof. Every decision inspectable.</a:t>
+              <a:t>Historical results. First-session proof. Every decision inspectable.</a:t>
             </a:r>
           </a:p>
         </p:txBody>
@@ -20993,7 +21550,7 @@
           <p:cNvPr id="20" name="">
             <a:extLst xmlns:a="http://schemas.openxmlformats.org/drawingml/2006/main">
               <a:ext uri="{FF2B5EF4-FFF2-40B4-BE49-F238E27FC236}">
-                <a16:creationId xmlns:a16="http://schemas.microsoft.com/office/drawing/2014/main" id="{4F632352-83B9-4465-A019-6F37D3750186}"/>
+                <a16:creationId xmlns:a16="http://schemas.microsoft.com/office/drawing/2014/main" id="{01076024-4CDB-4B9A-8F4C-43FED712DE6E}"/>
               </a:ext>
             </a:extLst>
           </p:cNvPr>
@@ -21036,7 +21593,7 @@
                 <a:latin typeface="Arial"/>
                 <a:ea typeface="Arial"/>
                 <a:cs typeface="Arial"/>
-                <a:hlinkClick xmlns:r="http://schemas.openxmlformats.org/officeDocument/2006/relationships" r:id="R3d0c745912924324"/>
+                <a:hlinkClick xmlns:r="http://schemas.openxmlformats.org/officeDocument/2006/relationships" r:id="Re49049cd368e4bd4"/>
               </a:rPr>
               <a:t>owlsowo.github.io/finly-bot</a:t>
             </a:r>
@@ -21048,7 +21605,7 @@
           <p:cNvPr id="21" name="">
             <a:extLst xmlns:a="http://schemas.openxmlformats.org/drawingml/2006/main">
               <a:ext uri="{FF2B5EF4-FFF2-40B4-BE49-F238E27FC236}">
-                <a16:creationId xmlns:a16="http://schemas.microsoft.com/office/drawing/2014/main" id="{828310F4-5EC8-4A00-A02A-54993CF3ED1D}"/>
+                <a16:creationId xmlns:a16="http://schemas.microsoft.com/office/drawing/2014/main" id="{0609A8B3-90DA-4D89-AB63-05926509ABE4}"/>
               </a:ext>
             </a:extLst>
           </p:cNvPr>
@@ -21098,7 +21655,7 @@
           <p:cNvPr id="22" name="">
             <a:extLst xmlns:a="http://schemas.openxmlformats.org/drawingml/2006/main">
               <a:ext uri="{FF2B5EF4-FFF2-40B4-BE49-F238E27FC236}">
-                <a16:creationId xmlns:a16="http://schemas.microsoft.com/office/drawing/2014/main" id="{7EF9CC42-3E6B-4D0C-881A-0F14777CF1EB}"/>
+                <a16:creationId xmlns:a16="http://schemas.microsoft.com/office/drawing/2014/main" id="{7B9755F3-CF3A-4764-8765-EA29F78D2969}"/>
               </a:ext>
             </a:extLst>
           </p:cNvPr>
@@ -21148,7 +21705,7 @@
           <p:cNvPr id="23" name="">
             <a:extLst xmlns:a="http://schemas.openxmlformats.org/drawingml/2006/main">
               <a:ext uri="{FF2B5EF4-FFF2-40B4-BE49-F238E27FC236}">
-                <a16:creationId xmlns:a16="http://schemas.microsoft.com/office/drawing/2014/main" id="{F77EA2DF-A21E-4800-B3FA-5B6B12223AA1}"/>
+                <a16:creationId xmlns:a16="http://schemas.microsoft.com/office/drawing/2014/main" id="{D94EECDA-4726-4726-9746-93C1586F8DC3}"/>
               </a:ext>
             </a:extLst>
           </p:cNvPr>
@@ -21196,7 +21753,7 @@
     </p:spTree>
     <p:extLst>
       <p:ext uri="{BB962C8B-B14F-4D97-AF65-F5344CB8AC3E}">
-        <p14:creationId xmlns:p14="http://schemas.microsoft.com/office/powerpoint/2010/main" val="1659264954"/>
+        <p14:creationId xmlns:p14="http://schemas.microsoft.com/office/powerpoint/2010/main" val="1092805728"/>
       </p:ext>
     </p:extLst>
   </p:cSld>

</xml_diff>

<commit_message>
Make Finly accessible to public and technical judges
</commit_message>
<xml_diff>
--- a/public/judge/Finly_Consulting_Deck.pptx
+++ b/public/judge/Finly_Consulting_Deck.pptx
@@ -2,21 +2,21 @@
 <file path=ppt/presentation.xml><?xml version="1.0" encoding="utf-8"?>
 <p:presentation xmlns:p="http://schemas.openxmlformats.org/presentationml/2006/main">
   <p:sldMasterIdLst>
-    <p:sldMasterId xmlns:r="http://schemas.openxmlformats.org/officeDocument/2006/relationships" id="2147483648" r:id="Rd64c731fc6d543f9"/>
+    <p:sldMasterId xmlns:r="http://schemas.openxmlformats.org/officeDocument/2006/relationships" id="2147483648" r:id="R07a508c04ba2425c"/>
   </p:sldMasterIdLst>
   <p:notesMasterIdLst>
-    <p:notesMasterId xmlns:r="http://schemas.openxmlformats.org/officeDocument/2006/relationships" r:id="R074184e44c7947f4"/>
+    <p:notesMasterId xmlns:r="http://schemas.openxmlformats.org/officeDocument/2006/relationships" r:id="Raa249330775243da"/>
   </p:notesMasterIdLst>
   <p:sldIdLst>
-    <p:sldId xmlns:r="http://schemas.openxmlformats.org/officeDocument/2006/relationships" id="256" r:id="R8f7dd82d27ee400d"/>
-    <p:sldId xmlns:r="http://schemas.openxmlformats.org/officeDocument/2006/relationships" id="257" r:id="R1418cd57459946ca"/>
-    <p:sldId xmlns:r="http://schemas.openxmlformats.org/officeDocument/2006/relationships" id="258" r:id="R97fe41cdffbf4c65"/>
-    <p:sldId xmlns:r="http://schemas.openxmlformats.org/officeDocument/2006/relationships" id="259" r:id="Rac6dc751e0e443b2"/>
-    <p:sldId xmlns:r="http://schemas.openxmlformats.org/officeDocument/2006/relationships" id="260" r:id="R7e3c452e413a4e14"/>
-    <p:sldId xmlns:r="http://schemas.openxmlformats.org/officeDocument/2006/relationships" id="261" r:id="R2a1ac9083bcb401c"/>
-    <p:sldId xmlns:r="http://schemas.openxmlformats.org/officeDocument/2006/relationships" id="262" r:id="R7084b52038294af5"/>
-    <p:sldId xmlns:r="http://schemas.openxmlformats.org/officeDocument/2006/relationships" id="263" r:id="R4d30fe0dcb7941d9"/>
-    <p:sldId xmlns:r="http://schemas.openxmlformats.org/officeDocument/2006/relationships" id="264" r:id="R89e7187c2b2e4ea8"/>
+    <p:sldId xmlns:r="http://schemas.openxmlformats.org/officeDocument/2006/relationships" id="256" r:id="R69620f76471245cc"/>
+    <p:sldId xmlns:r="http://schemas.openxmlformats.org/officeDocument/2006/relationships" id="257" r:id="Rc9185197c6b14a7b"/>
+    <p:sldId xmlns:r="http://schemas.openxmlformats.org/officeDocument/2006/relationships" id="258" r:id="Rc52954fcda614d94"/>
+    <p:sldId xmlns:r="http://schemas.openxmlformats.org/officeDocument/2006/relationships" id="259" r:id="Rc7925ed7fc29444c"/>
+    <p:sldId xmlns:r="http://schemas.openxmlformats.org/officeDocument/2006/relationships" id="260" r:id="R5e54fff383a641c2"/>
+    <p:sldId xmlns:r="http://schemas.openxmlformats.org/officeDocument/2006/relationships" id="261" r:id="R143f0492f46e4414"/>
+    <p:sldId xmlns:r="http://schemas.openxmlformats.org/officeDocument/2006/relationships" id="262" r:id="R703b9ad04fce423d"/>
+    <p:sldId xmlns:r="http://schemas.openxmlformats.org/officeDocument/2006/relationships" id="263" r:id="R5c0a9deb13774787"/>
+    <p:sldId xmlns:r="http://schemas.openxmlformats.org/officeDocument/2006/relationships" id="264" r:id="R4ed35da329bf47d2"/>
   </p:sldIdLst>
   <p:sldSz cx="12192000" cy="6858000"/>
   <p:notesSz cx="6858000" cy="9144000"/>
@@ -1278,7 +1278,7 @@
   </p:cSld>
   <p:clrMap bg1="lt1" tx1="dk1" bg2="lt2" tx2="dk2" accent1="accent1" accent2="accent2" accent3="accent3" accent4="accent4" accent5="accent5" accent6="accent6" hlink="hlink" folHlink="folHlink"/>
   <p:sldLayoutIdLst>
-    <p:sldLayoutId xmlns:r="http://schemas.openxmlformats.org/officeDocument/2006/relationships" id="2147483649" r:id="R35fb1957e40c44a6"/>
+    <p:sldLayoutId xmlns:r="http://schemas.openxmlformats.org/officeDocument/2006/relationships" id="2147483649" r:id="R75906ecdf8404303"/>
   </p:sldLayoutIdLst>
   <p:txStyles>
     <p:titleStyle>
@@ -1812,11 +1812,12 @@
     <c:plotArea>
       <c:lineChart>
         <c:grouping val="standard"/>
+        <c:varyColors val="0"/>
         <c:ser>
           <c:idx val="0"/>
           <c:order val="0"/>
           <c:tx>
-            <c:v>Finly Core</c:v>
+            <c:v>Finly</c:v>
           </c:tx>
           <c:spPr>
             <a:ln xmlns:a="http://schemas.openxmlformats.org/drawingml/2006/main" w="38100">
@@ -2842,6 +2843,7 @@
     <c:plotArea>
       <c:lineChart>
         <c:grouping val="standard"/>
+        <c:varyColors val="0"/>
         <c:ser>
           <c:idx val="0"/>
           <c:order val="0"/>
@@ -10999,14 +11001,14 @@
       </p:grpSpPr>
       <p:pic>
         <p:nvPicPr>
-          <p:cNvPr id="22" name=""/>
+          <p:cNvPr id="24" name=""/>
           <p:cNvPicPr>
             <a:picLocks xmlns:a="http://schemas.openxmlformats.org/drawingml/2006/main" noChangeAspect="1"/>
           </p:cNvPicPr>
           <p:nvPr/>
         </p:nvPicPr>
         <p:blipFill>
-          <a:blip xmlns:r="http://schemas.openxmlformats.org/officeDocument/2006/relationships" xmlns:a="http://schemas.openxmlformats.org/drawingml/2006/main" r:embed="R58ba394dfb7d451d"/>
+          <a:blip xmlns:r="http://schemas.openxmlformats.org/officeDocument/2006/relationships" xmlns:a="http://schemas.openxmlformats.org/drawingml/2006/main" r:embed="R271c37e865264078"/>
           <a:stretch xmlns:a="http://schemas.openxmlformats.org/drawingml/2006/main"/>
         </p:blipFill>
         <p:spPr>
@@ -11052,6 +11054,7 @@
           <a:lstStyle xmlns:a="http://schemas.openxmlformats.org/drawingml/2006/main"/>
           <a:p xmlns:a="http://schemas.openxmlformats.org/drawingml/2006/main">
             <a:pPr algn="l">
+              <a:buNone/>
               <a:defRPr sz="1800" b="1" i="0">
                 <a:solidFill>
                   <a:srgbClr val="FFFFFF"/>
@@ -11102,6 +11105,7 @@
           <a:lstStyle xmlns:a="http://schemas.openxmlformats.org/drawingml/2006/main"/>
           <a:p xmlns:a="http://schemas.openxmlformats.org/drawingml/2006/main">
             <a:pPr algn="l">
+              <a:buNone/>
               <a:defRPr sz="1125" b="1" i="0">
                 <a:solidFill>
                   <a:srgbClr val="B9DFD2"/>
@@ -11114,7 +11118,7 @@
                   <a:srgbClr val="B9DFD2"/>
                 </a:solidFill>
               </a:rPr>
-              <a:t>A TESTED PORTFOLIO + A RISK-CONTROLLED AI ASSISTANT</a:t>
+              <a:t>AI PAPER TRADING WITH BUILT-IN RISK CHECKS</a:t>
             </a:r>
           </a:p>
         </p:txBody>
@@ -11152,6 +11156,7 @@
           <a:lstStyle xmlns:a="http://schemas.openxmlformats.org/drawingml/2006/main"/>
           <a:p xmlns:a="http://schemas.openxmlformats.org/drawingml/2006/main">
             <a:pPr algn="l">
+              <a:buNone/>
               <a:defRPr sz="3600" b="1" i="0">
                 <a:solidFill>
                   <a:srgbClr val="FFFFFF"/>
@@ -11164,7 +11169,7 @@
                   <a:srgbClr val="FFFFFF"/>
                 </a:solidFill>
               </a:rPr>
-              <a:t>Finly combines a market-tested base portfolio with an AI options assistant.</a:t>
+              <a:t>AI explains the trade. Code controls the money.</a:t>
             </a:r>
           </a:p>
         </p:txBody>
@@ -11202,6 +11207,7 @@
           <a:lstStyle xmlns:a="http://schemas.openxmlformats.org/drawingml/2006/main"/>
           <a:p xmlns:a="http://schemas.openxmlformats.org/drawingml/2006/main">
             <a:pPr algn="l">
+              <a:buNone/>
               <a:defRPr sz="1800" b="0" i="0">
                 <a:solidFill>
                   <a:srgbClr val="D7E3E5"/>
@@ -11214,7 +11220,7 @@
                   <a:srgbClr val="D7E3E5"/>
                 </a:solidFill>
               </a:rPr>
-              <a:t>AI studies the market. Rules set the risk, build the trade, and can still stop it.</a:t>
+              <a:t>The base portfolio holds the account. AI may research a small options trade; fixed code caps its loss and can still stop the order.</a:t>
             </a:r>
           </a:p>
         </p:txBody>
@@ -11252,14 +11258,14 @@
       </p:sp>
       <p:pic>
         <p:nvPicPr>
-          <p:cNvPr id="28" name=""/>
+          <p:cNvPr id="30" name=""/>
           <p:cNvPicPr>
             <a:picLocks xmlns:a="http://schemas.openxmlformats.org/drawingml/2006/main" noChangeAspect="1"/>
           </p:cNvPicPr>
           <p:nvPr/>
         </p:nvPicPr>
         <p:blipFill>
-          <a:blip xmlns:r="http://schemas.openxmlformats.org/officeDocument/2006/relationships" xmlns:a="http://schemas.openxmlformats.org/drawingml/2006/main" r:embed="Rfe187efd24c14d41"/>
+          <a:blip xmlns:r="http://schemas.openxmlformats.org/officeDocument/2006/relationships" xmlns:a="http://schemas.openxmlformats.org/drawingml/2006/main" r:embed="R9a66e107b62f4ad6"/>
           <a:stretch xmlns:a="http://schemas.openxmlformats.org/drawingml/2006/main"/>
         </p:blipFill>
         <p:spPr>
@@ -11305,6 +11311,7 @@
           <a:lstStyle xmlns:a="http://schemas.openxmlformats.org/drawingml/2006/main"/>
           <a:p xmlns:a="http://schemas.openxmlformats.org/drawingml/2006/main">
             <a:pPr algn="ctr">
+              <a:buNone/>
               <a:defRPr sz="1800" b="1" i="0">
                 <a:solidFill>
                   <a:srgbClr val="FFFFFF"/>
@@ -11317,7 +11324,7 @@
                   <a:srgbClr val="FFFFFF"/>
                 </a:solidFill>
               </a:rPr>
-              <a:t>FINLY CORE  +  FINLY OPTIONS</a:t>
+              <a:t>MODEL EXPLAINS  ·  RULES DECIDE</a:t>
             </a:r>
           </a:p>
         </p:txBody>
@@ -11355,6 +11362,7 @@
           <a:lstStyle xmlns:a="http://schemas.openxmlformats.org/drawingml/2006/main"/>
           <a:p xmlns:a="http://schemas.openxmlformats.org/drawingml/2006/main">
             <a:pPr algn="ctr">
+              <a:buNone/>
               <a:defRPr sz="1350" b="0" i="0">
                 <a:solidFill>
                   <a:srgbClr val="B9DFD2"/>
@@ -11367,7 +11375,7 @@
                   <a:srgbClr val="B9DFD2"/>
                 </a:solidFill>
               </a:rPr>
-              <a:t>Base portfolio  ·  AI assistant</a:t>
+              <a:t>Base portfolio  ·  capped-risk options</a:t>
             </a:r>
           </a:p>
         </p:txBody>
@@ -11436,6 +11444,7 @@
           <a:lstStyle xmlns:a="http://schemas.openxmlformats.org/drawingml/2006/main"/>
           <a:p xmlns:a="http://schemas.openxmlformats.org/drawingml/2006/main">
             <a:pPr algn="l">
+              <a:buNone/>
               <a:defRPr sz="2850" b="1" i="0">
                 <a:solidFill>
                   <a:srgbClr val="F2C66D"/>
@@ -11486,6 +11495,7 @@
           <a:lstStyle xmlns:a="http://schemas.openxmlformats.org/drawingml/2006/main"/>
           <a:p xmlns:a="http://schemas.openxmlformats.org/drawingml/2006/main">
             <a:pPr algn="l">
+              <a:buNone/>
               <a:defRPr sz="1125" b="1" i="0">
                 <a:solidFill>
                   <a:srgbClr val="C5D4D8"/>
@@ -11536,6 +11546,7 @@
           <a:lstStyle xmlns:a="http://schemas.openxmlformats.org/drawingml/2006/main"/>
           <a:p xmlns:a="http://schemas.openxmlformats.org/drawingml/2006/main">
             <a:pPr algn="l">
+              <a:buNone/>
               <a:defRPr sz="2850" b="1" i="0">
                 <a:solidFill>
                   <a:srgbClr val="FFFFFF"/>
@@ -11586,6 +11597,7 @@
           <a:lstStyle xmlns:a="http://schemas.openxmlformats.org/drawingml/2006/main"/>
           <a:p xmlns:a="http://schemas.openxmlformats.org/drawingml/2006/main">
             <a:pPr algn="l">
+              <a:buNone/>
               <a:defRPr sz="900" b="1" i="0">
                 <a:solidFill>
                   <a:srgbClr val="C5D4D8"/>
@@ -11636,6 +11648,7 @@
           <a:lstStyle xmlns:a="http://schemas.openxmlformats.org/drawingml/2006/main"/>
           <a:p xmlns:a="http://schemas.openxmlformats.org/drawingml/2006/main">
             <a:pPr algn="l">
+              <a:buNone/>
               <a:defRPr sz="2850" b="1" i="0">
                 <a:solidFill>
                   <a:srgbClr val="B9DFD2"/>
@@ -11686,6 +11699,7 @@
           <a:lstStyle xmlns:a="http://schemas.openxmlformats.org/drawingml/2006/main"/>
           <a:p xmlns:a="http://schemas.openxmlformats.org/drawingml/2006/main">
             <a:pPr algn="l">
+              <a:buNone/>
               <a:defRPr sz="900" b="1" i="0">
                 <a:solidFill>
                   <a:srgbClr val="C5D4D8"/>
@@ -11698,7 +11712,7 @@
                   <a:srgbClr val="C5D4D8"/>
                 </a:solidFill>
               </a:rPr>
-              <a:t>CORE VS S&amp;P TRACKER · DAY ONE</a:t>
+              <a:t>FIRST PAPER SESSION VS SPY</a:t>
             </a:r>
           </a:p>
         </p:txBody>
@@ -11736,6 +11750,7 @@
           <a:lstStyle xmlns:a="http://schemas.openxmlformats.org/drawingml/2006/main"/>
           <a:p xmlns:a="http://schemas.openxmlformats.org/drawingml/2006/main">
             <a:pPr algn="l">
+              <a:buNone/>
               <a:defRPr sz="2850" b="1" i="0">
                 <a:solidFill>
                   <a:srgbClr val="E56B5D"/>
@@ -11786,6 +11801,7 @@
           <a:lstStyle xmlns:a="http://schemas.openxmlformats.org/drawingml/2006/main"/>
           <a:p xmlns:a="http://schemas.openxmlformats.org/drawingml/2006/main">
             <a:pPr algn="l">
+              <a:buNone/>
               <a:defRPr sz="975" b="1" i="0">
                 <a:solidFill>
                   <a:srgbClr val="C5D4D8"/>
@@ -11798,7 +11814,7 @@
                   <a:srgbClr val="C5D4D8"/>
                 </a:solidFill>
               </a:rPr>
-              <a:t>MAX LOSS / OPTIONS TRADE</a:t>
+              <a:t>MAX POSSIBLE LOSS / OPTIONS TRADE</a:t>
             </a:r>
           </a:p>
         </p:txBody>
@@ -11836,6 +11852,7 @@
           <a:lstStyle xmlns:a="http://schemas.openxmlformats.org/drawingml/2006/main"/>
           <a:p xmlns:a="http://schemas.openxmlformats.org/drawingml/2006/main">
             <a:pPr algn="l">
+              <a:buNone/>
               <a:defRPr sz="1200" b="0" i="0">
                 <a:solidFill>
                   <a:srgbClr val="AFC2C8"/>
@@ -11886,6 +11903,7 @@
           <a:lstStyle xmlns:a="http://schemas.openxmlformats.org/drawingml/2006/main"/>
           <a:p xmlns:a="http://schemas.openxmlformats.org/drawingml/2006/main">
             <a:pPr algn="l">
+              <a:buNone/>
               <a:defRPr sz="825" b="1" i="0">
                 <a:solidFill>
                   <a:srgbClr val="AFC2C8"/>
@@ -11936,6 +11954,7 @@
           <a:lstStyle xmlns:a="http://schemas.openxmlformats.org/drawingml/2006/main"/>
           <a:p xmlns:a="http://schemas.openxmlformats.org/drawingml/2006/main">
             <a:pPr algn="r">
+              <a:buNone/>
               <a:defRPr sz="825" b="1" i="0">
                 <a:solidFill>
                   <a:srgbClr val="AFC2C8"/>
@@ -12015,6 +12034,7 @@
           <a:lstStyle xmlns:a="http://schemas.openxmlformats.org/drawingml/2006/main"/>
           <a:p xmlns:a="http://schemas.openxmlformats.org/drawingml/2006/main">
             <a:pPr algn="l">
+              <a:buNone/>
               <a:defRPr sz="1125" b="1" i="0">
                 <a:solidFill>
                   <a:srgbClr val="2F7D68"/>
@@ -12065,6 +12085,7 @@
           <a:lstStyle xmlns:a="http://schemas.openxmlformats.org/drawingml/2006/main"/>
           <a:p xmlns:a="http://schemas.openxmlformats.org/drawingml/2006/main">
             <a:pPr algn="l">
+              <a:buNone/>
               <a:defRPr sz="3300" b="1" i="0">
                 <a:solidFill>
                   <a:srgbClr val="122A3E"/>
@@ -12115,6 +12136,7 @@
           <a:lstStyle xmlns:a="http://schemas.openxmlformats.org/drawingml/2006/main"/>
           <a:p xmlns:a="http://schemas.openxmlformats.org/drawingml/2006/main">
             <a:pPr algn="l">
+              <a:buNone/>
               <a:defRPr sz="1275" b="1" i="0">
                 <a:solidFill>
                   <a:srgbClr val="E56B5D"/>
@@ -12200,6 +12222,7 @@
           <a:lstStyle xmlns:a="http://schemas.openxmlformats.org/drawingml/2006/main"/>
           <a:p xmlns:a="http://schemas.openxmlformats.org/drawingml/2006/main">
             <a:pPr algn="ctr">
+              <a:buNone/>
               <a:defRPr sz="1725" b="1" i="0">
                 <a:solidFill>
                   <a:srgbClr val="122A3E"/>
@@ -12250,6 +12273,7 @@
           <a:lstStyle xmlns:a="http://schemas.openxmlformats.org/drawingml/2006/main"/>
           <a:p xmlns:a="http://schemas.openxmlformats.org/drawingml/2006/main">
             <a:pPr algn="ctr">
+              <a:buNone/>
               <a:defRPr sz="1275" b="0" i="0">
                 <a:solidFill>
                   <a:srgbClr val="627078"/>
@@ -12300,6 +12324,7 @@
           <a:lstStyle xmlns:a="http://schemas.openxmlformats.org/drawingml/2006/main"/>
           <a:p xmlns:a="http://schemas.openxmlformats.org/drawingml/2006/main">
             <a:pPr algn="ctr">
+              <a:buNone/>
               <a:defRPr sz="3450" b="1" i="0">
                 <a:solidFill>
                   <a:srgbClr val="E56B5D"/>
@@ -12385,6 +12410,7 @@
           <a:lstStyle xmlns:a="http://schemas.openxmlformats.org/drawingml/2006/main"/>
           <a:p xmlns:a="http://schemas.openxmlformats.org/drawingml/2006/main">
             <a:pPr algn="ctr">
+              <a:buNone/>
               <a:defRPr sz="1725" b="1" i="0">
                 <a:solidFill>
                   <a:srgbClr val="122A3E"/>
@@ -12435,6 +12461,7 @@
           <a:lstStyle xmlns:a="http://schemas.openxmlformats.org/drawingml/2006/main"/>
           <a:p xmlns:a="http://schemas.openxmlformats.org/drawingml/2006/main">
             <a:pPr algn="ctr">
+              <a:buNone/>
               <a:defRPr sz="1200" b="0" i="0">
                 <a:solidFill>
                   <a:srgbClr val="E56B5D"/>
@@ -12485,6 +12512,7 @@
           <a:lstStyle xmlns:a="http://schemas.openxmlformats.org/drawingml/2006/main"/>
           <a:p xmlns:a="http://schemas.openxmlformats.org/drawingml/2006/main">
             <a:pPr algn="l">
+              <a:buNone/>
               <a:defRPr sz="1275" b="1" i="0">
                 <a:solidFill>
                   <a:srgbClr val="2F7D68"/>
@@ -12570,6 +12598,7 @@
           <a:lstStyle xmlns:a="http://schemas.openxmlformats.org/drawingml/2006/main"/>
           <a:p xmlns:a="http://schemas.openxmlformats.org/drawingml/2006/main">
             <a:pPr algn="ctr">
+              <a:buNone/>
               <a:defRPr sz="1875" b="1" i="0">
                 <a:solidFill>
                   <a:srgbClr val="2F7D68"/>
@@ -12620,6 +12649,7 @@
           <a:lstStyle xmlns:a="http://schemas.openxmlformats.org/drawingml/2006/main"/>
           <a:p xmlns:a="http://schemas.openxmlformats.org/drawingml/2006/main">
             <a:pPr algn="ctr">
+              <a:buNone/>
               <a:defRPr sz="1275" b="0" i="0">
                 <a:solidFill>
                   <a:srgbClr val="627078"/>
@@ -12670,6 +12700,7 @@
           <a:lstStyle xmlns:a="http://schemas.openxmlformats.org/drawingml/2006/main"/>
           <a:p xmlns:a="http://schemas.openxmlformats.org/drawingml/2006/main">
             <a:pPr algn="ctr">
+              <a:buNone/>
               <a:defRPr sz="3450" b="1" i="0">
                 <a:solidFill>
                   <a:srgbClr val="2F7D68"/>
@@ -12755,6 +12786,7 @@
           <a:lstStyle xmlns:a="http://schemas.openxmlformats.org/drawingml/2006/main"/>
           <a:p xmlns:a="http://schemas.openxmlformats.org/drawingml/2006/main">
             <a:pPr algn="ctr">
+              <a:buNone/>
               <a:defRPr sz="1875" b="1" i="0">
                 <a:solidFill>
                   <a:srgbClr val="2F7D68"/>
@@ -12805,6 +12837,7 @@
           <a:lstStyle xmlns:a="http://schemas.openxmlformats.org/drawingml/2006/main"/>
           <a:p xmlns:a="http://schemas.openxmlformats.org/drawingml/2006/main">
             <a:pPr algn="ctr">
+              <a:buNone/>
               <a:defRPr sz="1275" b="0" i="0">
                 <a:solidFill>
                   <a:srgbClr val="627078"/>
@@ -12855,6 +12888,7 @@
           <a:lstStyle xmlns:a="http://schemas.openxmlformats.org/drawingml/2006/main"/>
           <a:p xmlns:a="http://schemas.openxmlformats.org/drawingml/2006/main">
             <a:pPr algn="ctr">
+              <a:buNone/>
               <a:defRPr sz="3450" b="1" i="0">
                 <a:solidFill>
                   <a:srgbClr val="2F7D68"/>
@@ -12940,6 +12974,7 @@
           <a:lstStyle xmlns:a="http://schemas.openxmlformats.org/drawingml/2006/main"/>
           <a:p xmlns:a="http://schemas.openxmlformats.org/drawingml/2006/main">
             <a:pPr algn="ctr">
+              <a:buNone/>
               <a:defRPr sz="1875" b="1" i="0">
                 <a:solidFill>
                   <a:srgbClr val="2F7D68"/>
@@ -12990,6 +13025,7 @@
           <a:lstStyle xmlns:a="http://schemas.openxmlformats.org/drawingml/2006/main"/>
           <a:p xmlns:a="http://schemas.openxmlformats.org/drawingml/2006/main">
             <a:pPr algn="ctr">
+              <a:buNone/>
               <a:defRPr sz="1275" b="0" i="0">
                 <a:solidFill>
                   <a:srgbClr val="627078"/>
@@ -13040,6 +13076,7 @@
           <a:lstStyle xmlns:a="http://schemas.openxmlformats.org/drawingml/2006/main"/>
           <a:p xmlns:a="http://schemas.openxmlformats.org/drawingml/2006/main">
             <a:pPr algn="ctr">
+              <a:buNone/>
               <a:defRPr sz="3450" b="1" i="0">
                 <a:solidFill>
                   <a:srgbClr val="2F7D68"/>
@@ -13123,6 +13160,7 @@
           <a:lstStyle xmlns:a="http://schemas.openxmlformats.org/drawingml/2006/main"/>
           <a:p xmlns:a="http://schemas.openxmlformats.org/drawingml/2006/main">
             <a:pPr algn="ctr">
+              <a:buNone/>
               <a:defRPr sz="1050" b="1" i="0">
                 <a:solidFill>
                   <a:srgbClr val="FFFFFF"/>
@@ -13204,6 +13242,7 @@
           <a:lstStyle xmlns:a="http://schemas.openxmlformats.org/drawingml/2006/main"/>
           <a:p xmlns:a="http://schemas.openxmlformats.org/drawingml/2006/main">
             <a:pPr algn="l">
+              <a:buNone/>
               <a:defRPr sz="2400" b="1" i="0">
                 <a:solidFill>
                   <a:srgbClr val="2F7D68"/>
@@ -13254,6 +13293,7 @@
           <a:lstStyle xmlns:a="http://schemas.openxmlformats.org/drawingml/2006/main"/>
           <a:p xmlns:a="http://schemas.openxmlformats.org/drawingml/2006/main">
             <a:pPr algn="l">
+              <a:buNone/>
               <a:defRPr sz="1725" b="0" i="0">
                 <a:solidFill>
                   <a:srgbClr val="627078"/>
@@ -13304,6 +13344,7 @@
           <a:lstStyle xmlns:a="http://schemas.openxmlformats.org/drawingml/2006/main"/>
           <a:p xmlns:a="http://schemas.openxmlformats.org/drawingml/2006/main">
             <a:pPr algn="l">
+              <a:buNone/>
               <a:defRPr sz="825" b="1" i="0">
                 <a:solidFill>
                   <a:srgbClr val="627078"/>
@@ -13354,6 +13395,7 @@
           <a:lstStyle xmlns:a="http://schemas.openxmlformats.org/drawingml/2006/main"/>
           <a:p xmlns:a="http://schemas.openxmlformats.org/drawingml/2006/main">
             <a:pPr algn="r">
+              <a:buNone/>
               <a:defRPr sz="825" b="1" i="0">
                 <a:solidFill>
                   <a:srgbClr val="627078"/>
@@ -13433,6 +13475,7 @@
           <a:lstStyle xmlns:a="http://schemas.openxmlformats.org/drawingml/2006/main"/>
           <a:p xmlns:a="http://schemas.openxmlformats.org/drawingml/2006/main">
             <a:pPr algn="l">
+              <a:buNone/>
               <a:defRPr sz="1125" b="1" i="0">
                 <a:solidFill>
                   <a:srgbClr val="B9DFD2"/>
@@ -13483,6 +13526,7 @@
           <a:lstStyle xmlns:a="http://schemas.openxmlformats.org/drawingml/2006/main"/>
           <a:p xmlns:a="http://schemas.openxmlformats.org/drawingml/2006/main">
             <a:pPr algn="l">
+              <a:buNone/>
               <a:defRPr sz="3450" b="1" i="0">
                 <a:solidFill>
                   <a:srgbClr val="FFFFFF"/>
@@ -13543,14 +13587,14 @@
       </p:sp>
       <p:pic>
         <p:nvPicPr>
-          <p:cNvPr id="23" name=""/>
+          <p:cNvPr id="25" name=""/>
           <p:cNvPicPr>
             <a:picLocks xmlns:a="http://schemas.openxmlformats.org/drawingml/2006/main" noChangeAspect="1"/>
           </p:cNvPicPr>
           <p:nvPr/>
         </p:nvPicPr>
         <p:blipFill>
-          <a:blip xmlns:r="http://schemas.openxmlformats.org/officeDocument/2006/relationships" xmlns:a="http://schemas.openxmlformats.org/drawingml/2006/main" r:embed="R1b8eb6b49d304d96"/>
+          <a:blip xmlns:r="http://schemas.openxmlformats.org/officeDocument/2006/relationships" xmlns:a="http://schemas.openxmlformats.org/drawingml/2006/main" r:embed="Rdc6f361541f14d46"/>
           <a:stretch xmlns:a="http://schemas.openxmlformats.org/drawingml/2006/main"/>
         </p:blipFill>
         <p:spPr>
@@ -13598,6 +13642,7 @@
           <a:lstStyle xmlns:a="http://schemas.openxmlformats.org/drawingml/2006/main"/>
           <a:p xmlns:a="http://schemas.openxmlformats.org/drawingml/2006/main">
             <a:pPr algn="l">
+              <a:buNone/>
               <a:defRPr sz="1350" b="1" i="0">
                 <a:solidFill>
                   <a:srgbClr val="B9DFD2"/>
@@ -13648,6 +13693,7 @@
           <a:lstStyle xmlns:a="http://schemas.openxmlformats.org/drawingml/2006/main"/>
           <a:p xmlns:a="http://schemas.openxmlformats.org/drawingml/2006/main">
             <a:pPr algn="l">
+              <a:buNone/>
               <a:defRPr sz="1200" b="1" i="0">
                 <a:solidFill>
                   <a:srgbClr val="B9DFD2"/>
@@ -13698,6 +13744,7 @@
           <a:lstStyle xmlns:a="http://schemas.openxmlformats.org/drawingml/2006/main"/>
           <a:p xmlns:a="http://schemas.openxmlformats.org/drawingml/2006/main">
             <a:pPr algn="l">
+              <a:buNone/>
               <a:defRPr sz="1950" b="1" i="0">
                 <a:solidFill>
                   <a:srgbClr val="FFFFFF"/>
@@ -13779,6 +13826,7 @@
           <a:lstStyle xmlns:a="http://schemas.openxmlformats.org/drawingml/2006/main"/>
           <a:p xmlns:a="http://schemas.openxmlformats.org/drawingml/2006/main">
             <a:pPr algn="l">
+              <a:buNone/>
               <a:defRPr sz="1350" b="1" i="0">
                 <a:solidFill>
                   <a:srgbClr val="F2C66D"/>
@@ -13829,6 +13877,7 @@
           <a:lstStyle xmlns:a="http://schemas.openxmlformats.org/drawingml/2006/main"/>
           <a:p xmlns:a="http://schemas.openxmlformats.org/drawingml/2006/main">
             <a:pPr algn="l">
+              <a:buNone/>
               <a:defRPr sz="1200" b="1" i="0">
                 <a:solidFill>
                   <a:srgbClr val="F2C66D"/>
@@ -13879,6 +13928,7 @@
           <a:lstStyle xmlns:a="http://schemas.openxmlformats.org/drawingml/2006/main"/>
           <a:p xmlns:a="http://schemas.openxmlformats.org/drawingml/2006/main">
             <a:pPr algn="l">
+              <a:buNone/>
               <a:defRPr sz="1950" b="1" i="0">
                 <a:solidFill>
                   <a:srgbClr val="FFFFFF"/>
@@ -13960,6 +14010,7 @@
           <a:lstStyle xmlns:a="http://schemas.openxmlformats.org/drawingml/2006/main"/>
           <a:p xmlns:a="http://schemas.openxmlformats.org/drawingml/2006/main">
             <a:pPr algn="l">
+              <a:buNone/>
               <a:defRPr sz="1350" b="1" i="0">
                 <a:solidFill>
                   <a:srgbClr val="E56B5D"/>
@@ -14010,6 +14061,7 @@
           <a:lstStyle xmlns:a="http://schemas.openxmlformats.org/drawingml/2006/main"/>
           <a:p xmlns:a="http://schemas.openxmlformats.org/drawingml/2006/main">
             <a:pPr algn="l">
+              <a:buNone/>
               <a:defRPr sz="1200" b="1" i="0">
                 <a:solidFill>
                   <a:srgbClr val="E56B5D"/>
@@ -14060,6 +14112,7 @@
           <a:lstStyle xmlns:a="http://schemas.openxmlformats.org/drawingml/2006/main"/>
           <a:p xmlns:a="http://schemas.openxmlformats.org/drawingml/2006/main">
             <a:pPr algn="l">
+              <a:buNone/>
               <a:defRPr sz="1950" b="1" i="0">
                 <a:solidFill>
                   <a:srgbClr val="FFFFFF"/>
@@ -14141,6 +14194,7 @@
           <a:lstStyle xmlns:a="http://schemas.openxmlformats.org/drawingml/2006/main"/>
           <a:p xmlns:a="http://schemas.openxmlformats.org/drawingml/2006/main">
             <a:pPr algn="l">
+              <a:buNone/>
               <a:defRPr sz="1725" b="1" i="0">
                 <a:solidFill>
                   <a:srgbClr val="B9DFD2"/>
@@ -14191,6 +14245,7 @@
           <a:lstStyle xmlns:a="http://schemas.openxmlformats.org/drawingml/2006/main"/>
           <a:p xmlns:a="http://schemas.openxmlformats.org/drawingml/2006/main">
             <a:pPr algn="l">
+              <a:buNone/>
               <a:defRPr sz="825" b="1" i="0">
                 <a:solidFill>
                   <a:srgbClr val="AFC2C8"/>
@@ -14241,6 +14296,7 @@
           <a:lstStyle xmlns:a="http://schemas.openxmlformats.org/drawingml/2006/main"/>
           <a:p xmlns:a="http://schemas.openxmlformats.org/drawingml/2006/main">
             <a:pPr algn="r">
+              <a:buNone/>
               <a:defRPr sz="825" b="1" i="0">
                 <a:solidFill>
                   <a:srgbClr val="AFC2C8"/>
@@ -14320,6 +14376,7 @@
           <a:lstStyle xmlns:a="http://schemas.openxmlformats.org/drawingml/2006/main"/>
           <a:p xmlns:a="http://schemas.openxmlformats.org/drawingml/2006/main">
             <a:pPr algn="l">
+              <a:buNone/>
               <a:defRPr sz="1125" b="1" i="0">
                 <a:solidFill>
                   <a:srgbClr val="2F7D68"/>
@@ -14370,6 +14427,7 @@
           <a:lstStyle xmlns:a="http://schemas.openxmlformats.org/drawingml/2006/main"/>
           <a:p xmlns:a="http://schemas.openxmlformats.org/drawingml/2006/main">
             <a:pPr algn="l">
+              <a:buNone/>
               <a:defRPr sz="3300" b="1" i="0">
                 <a:solidFill>
                   <a:srgbClr val="122A3E"/>
@@ -14420,6 +14478,7 @@
           <a:lstStyle xmlns:a="http://schemas.openxmlformats.org/drawingml/2006/main"/>
           <a:p xmlns:a="http://schemas.openxmlformats.org/drawingml/2006/main">
             <a:pPr algn="l">
+              <a:buNone/>
               <a:defRPr sz="1275" b="0" i="0">
                 <a:solidFill>
                   <a:srgbClr val="627078"/>
@@ -14432,7 +14491,7 @@
                   <a:srgbClr val="627078"/>
                 </a:solidFill>
               </a:rPr>
-              <a:t>Finly Core is the rules-based four-fund portfolio: roughly half QQQ, half three trend-selected sectors, and 3% cash.</a:t>
+              <a:t>Finly's base portfolio holds roughly half in QQQ, a Nasdaq-100 fund, half in three trend-selected sectors, and 3% in cash.</a:t>
             </a:r>
           </a:p>
         </p:txBody>
@@ -14470,6 +14529,7 @@
           <a:lstStyle xmlns:a="http://schemas.openxmlformats.org/drawingml/2006/main"/>
           <a:p xmlns:a="http://schemas.openxmlformats.org/drawingml/2006/main">
             <a:pPr algn="l">
+              <a:buNone/>
               <a:defRPr sz="1200" b="0" i="0">
                 <a:solidFill>
                   <a:srgbClr val="627078"/>
@@ -14489,7 +14549,7 @@
       </p:sp>
       <p:graphicFrame>
         <p:nvGraphicFramePr>
-          <p:cNvPr id="22" name="Chart"/>
+          <p:cNvPr id="25" name="Chart"/>
           <p:cNvGraphicFramePr/>
           <p:nvPr/>
         </p:nvGraphicFramePr>
@@ -14499,7 +14559,7 @@
         </p:xfrm>
         <a:graphic xmlns:a="http://schemas.openxmlformats.org/drawingml/2006/main">
           <a:graphicData uri="http://schemas.openxmlformats.org/drawingml/2006/chart">
-            <c:chart xmlns:r="http://schemas.openxmlformats.org/officeDocument/2006/relationships" xmlns:c="http://schemas.openxmlformats.org/drawingml/2006/chart" r:id="Rd693f4b01aca4870"/>
+            <c:chart xmlns:r="http://schemas.openxmlformats.org/officeDocument/2006/relationships" xmlns:c="http://schemas.openxmlformats.org/drawingml/2006/chart" r:id="R8c547c99d5624867"/>
           </a:graphicData>
         </a:graphic>
       </p:graphicFrame>
@@ -14536,6 +14596,7 @@
           <a:lstStyle xmlns:a="http://schemas.openxmlformats.org/drawingml/2006/main"/>
           <a:p xmlns:a="http://schemas.openxmlformats.org/drawingml/2006/main">
             <a:pPr algn="l">
+              <a:buNone/>
               <a:defRPr sz="3000" b="1" i="0">
                 <a:solidFill>
                   <a:srgbClr val="2F7D68"/>
@@ -14586,6 +14647,7 @@
           <a:lstStyle xmlns:a="http://schemas.openxmlformats.org/drawingml/2006/main"/>
           <a:p xmlns:a="http://schemas.openxmlformats.org/drawingml/2006/main">
             <a:pPr algn="l">
+              <a:buNone/>
               <a:defRPr sz="1125" b="1" i="0">
                 <a:solidFill>
                   <a:srgbClr val="627078"/>
@@ -14636,6 +14698,7 @@
           <a:lstStyle xmlns:a="http://schemas.openxmlformats.org/drawingml/2006/main"/>
           <a:p xmlns:a="http://schemas.openxmlformats.org/drawingml/2006/main">
             <a:pPr algn="l">
+              <a:buNone/>
               <a:defRPr sz="2700" b="1" i="0">
                 <a:solidFill>
                   <a:srgbClr val="0B2942"/>
@@ -14686,6 +14749,7 @@
           <a:lstStyle xmlns:a="http://schemas.openxmlformats.org/drawingml/2006/main"/>
           <a:p xmlns:a="http://schemas.openxmlformats.org/drawingml/2006/main">
             <a:pPr algn="l">
+              <a:buNone/>
               <a:defRPr sz="1125" b="1" i="0">
                 <a:solidFill>
                   <a:srgbClr val="627078"/>
@@ -14736,6 +14800,7 @@
           <a:lstStyle xmlns:a="http://schemas.openxmlformats.org/drawingml/2006/main"/>
           <a:p xmlns:a="http://schemas.openxmlformats.org/drawingml/2006/main">
             <a:pPr algn="l">
+              <a:buNone/>
               <a:defRPr sz="2550" b="1" i="0">
                 <a:solidFill>
                   <a:srgbClr val="2F7D68"/>
@@ -14786,6 +14851,7 @@
           <a:lstStyle xmlns:a="http://schemas.openxmlformats.org/drawingml/2006/main"/>
           <a:p xmlns:a="http://schemas.openxmlformats.org/drawingml/2006/main">
             <a:pPr algn="l">
+              <a:buNone/>
               <a:defRPr sz="1125" b="1" i="0">
                 <a:solidFill>
                   <a:srgbClr val="627078"/>
@@ -14805,7 +14871,7 @@
       </p:sp>
       <p:graphicFrame>
         <p:nvGraphicFramePr>
-          <p:cNvPr id="29" name="Chart"/>
+          <p:cNvPr id="32" name="Chart"/>
           <p:cNvGraphicFramePr/>
           <p:nvPr/>
         </p:nvGraphicFramePr>
@@ -14815,7 +14881,7 @@
         </p:xfrm>
         <a:graphic xmlns:a="http://schemas.openxmlformats.org/drawingml/2006/main">
           <a:graphicData uri="http://schemas.openxmlformats.org/drawingml/2006/chart">
-            <c:chart xmlns:r="http://schemas.openxmlformats.org/officeDocument/2006/relationships" xmlns:c="http://schemas.openxmlformats.org/drawingml/2006/chart" r:id="Ra1ccf97e81d248d6"/>
+            <c:chart xmlns:r="http://schemas.openxmlformats.org/officeDocument/2006/relationships" xmlns:c="http://schemas.openxmlformats.org/drawingml/2006/chart" r:id="R92cd5d21e5254e8e"/>
           </a:graphicData>
         </a:graphic>
       </p:graphicFrame>
@@ -14852,6 +14918,7 @@
           <a:lstStyle xmlns:a="http://schemas.openxmlformats.org/drawingml/2006/main"/>
           <a:p xmlns:a="http://schemas.openxmlformats.org/drawingml/2006/main">
             <a:pPr algn="l">
+              <a:buNone/>
               <a:defRPr sz="900" b="1" i="0">
                 <a:solidFill>
                   <a:srgbClr val="627078"/>
@@ -14902,6 +14969,7 @@
           <a:lstStyle xmlns:a="http://schemas.openxmlformats.org/drawingml/2006/main"/>
           <a:p xmlns:a="http://schemas.openxmlformats.org/drawingml/2006/main">
             <a:pPr algn="l">
+              <a:buNone/>
               <a:defRPr sz="975" b="1" i="0">
                 <a:solidFill>
                   <a:srgbClr val="627078"/>
@@ -14952,6 +15020,7 @@
           <a:lstStyle xmlns:a="http://schemas.openxmlformats.org/drawingml/2006/main"/>
           <a:p xmlns:a="http://schemas.openxmlformats.org/drawingml/2006/main">
             <a:pPr algn="l">
+              <a:buNone/>
               <a:defRPr sz="1350" b="1" i="0">
                 <a:solidFill>
                   <a:srgbClr val="122A3E"/>
@@ -14969,6 +15038,7 @@
           </a:p>
           <a:p xmlns:a="http://schemas.openxmlformats.org/drawingml/2006/main">
             <a:pPr algn="l">
+              <a:buNone/>
               <a:defRPr sz="1350" b="1" i="0">
                 <a:solidFill>
                   <a:srgbClr val="122A3E"/>
@@ -15019,6 +15089,7 @@
           <a:lstStyle xmlns:a="http://schemas.openxmlformats.org/drawingml/2006/main"/>
           <a:p xmlns:a="http://schemas.openxmlformats.org/drawingml/2006/main">
             <a:pPr algn="l">
+              <a:buNone/>
               <a:defRPr sz="825" b="1" i="0">
                 <a:solidFill>
                   <a:srgbClr val="627078"/>
@@ -15069,6 +15140,7 @@
           <a:lstStyle xmlns:a="http://schemas.openxmlformats.org/drawingml/2006/main"/>
           <a:p xmlns:a="http://schemas.openxmlformats.org/drawingml/2006/main">
             <a:pPr algn="r">
+              <a:buNone/>
               <a:defRPr sz="825" b="1" i="0">
                 <a:solidFill>
                   <a:srgbClr val="627078"/>
@@ -15148,6 +15220,7 @@
           <a:lstStyle xmlns:a="http://schemas.openxmlformats.org/drawingml/2006/main"/>
           <a:p xmlns:a="http://schemas.openxmlformats.org/drawingml/2006/main">
             <a:pPr algn="l">
+              <a:buNone/>
               <a:defRPr sz="1125" b="1" i="0">
                 <a:solidFill>
                   <a:srgbClr val="F2C66D"/>
@@ -15198,6 +15271,7 @@
           <a:lstStyle xmlns:a="http://schemas.openxmlformats.org/drawingml/2006/main"/>
           <a:p xmlns:a="http://schemas.openxmlformats.org/drawingml/2006/main">
             <a:pPr algn="l">
+              <a:buNone/>
               <a:defRPr sz="3075" b="1" i="0">
                 <a:solidFill>
                   <a:srgbClr val="FFFFFF"/>
@@ -15210,7 +15284,7 @@
                   <a:srgbClr val="FFFFFF"/>
                 </a:solidFill>
               </a:rPr>
-              <a:t>An 80-year industry test stayed ahead over the full period under every monthly start date tested.</a:t>
+              <a:t>An 80-year market test stayed ahead on all 21 tested monthly update days.</a:t>
             </a:r>
           </a:p>
         </p:txBody>
@@ -15341,6 +15415,7 @@
           <a:lstStyle xmlns:a="http://schemas.openxmlformats.org/drawingml/2006/main"/>
           <a:p xmlns:a="http://schemas.openxmlformats.org/drawingml/2006/main">
             <a:pPr algn="ctr">
+              <a:buNone/>
               <a:defRPr sz="1425" b="1" i="0">
                 <a:solidFill>
                   <a:srgbClr val="F2C66D"/>
@@ -15391,6 +15466,7 @@
           <a:lstStyle xmlns:a="http://schemas.openxmlformats.org/drawingml/2006/main"/>
           <a:p xmlns:a="http://schemas.openxmlformats.org/drawingml/2006/main">
             <a:pPr algn="ctr">
+              <a:buNone/>
               <a:defRPr sz="1425" b="1" i="0">
                 <a:solidFill>
                   <a:srgbClr val="F2C66D"/>
@@ -15441,6 +15517,7 @@
           <a:lstStyle xmlns:a="http://schemas.openxmlformats.org/drawingml/2006/main"/>
           <a:p xmlns:a="http://schemas.openxmlformats.org/drawingml/2006/main">
             <a:pPr algn="ctr">
+              <a:buNone/>
               <a:defRPr sz="2250" b="1" i="0">
                 <a:solidFill>
                   <a:srgbClr val="FFFFFF"/>
@@ -15491,6 +15568,7 @@
           <a:lstStyle xmlns:a="http://schemas.openxmlformats.org/drawingml/2006/main"/>
           <a:p xmlns:a="http://schemas.openxmlformats.org/drawingml/2006/main">
             <a:pPr algn="ctr">
+              <a:buNone/>
               <a:defRPr sz="975" b="1" i="0">
                 <a:solidFill>
                   <a:srgbClr val="F2C66D"/>
@@ -15503,7 +15581,7 @@
                   <a:srgbClr val="F2C66D"/>
                 </a:solidFill>
               </a:rPr>
-              <a:t>INDUSTRY-PROXY RECONSTRUCTION</a:t>
+              <a:t>SEPARATE PUBLIC INDUSTRY DATASET</a:t>
             </a:r>
           </a:p>
         </p:txBody>
@@ -15541,6 +15619,7 @@
           <a:lstStyle xmlns:a="http://schemas.openxmlformats.org/drawingml/2006/main"/>
           <a:p xmlns:a="http://schemas.openxmlformats.org/drawingml/2006/main">
             <a:pPr algn="l">
+              <a:buNone/>
               <a:defRPr sz="3600" b="1" i="0">
                 <a:solidFill>
                   <a:srgbClr val="B9DFD2"/>
@@ -15591,6 +15670,7 @@
           <a:lstStyle xmlns:a="http://schemas.openxmlformats.org/drawingml/2006/main"/>
           <a:p xmlns:a="http://schemas.openxmlformats.org/drawingml/2006/main">
             <a:pPr algn="l">
+              <a:buNone/>
               <a:defRPr sz="1125" b="1" i="0">
                 <a:solidFill>
                   <a:srgbClr val="C4D4D8"/>
@@ -15641,6 +15721,7 @@
           <a:lstStyle xmlns:a="http://schemas.openxmlformats.org/drawingml/2006/main"/>
           <a:p xmlns:a="http://schemas.openxmlformats.org/drawingml/2006/main">
             <a:pPr algn="l">
+              <a:buNone/>
               <a:defRPr sz="1650" b="0" i="0">
                 <a:solidFill>
                   <a:srgbClr val="FFFFFF"/>
@@ -15691,6 +15772,7 @@
           <a:lstStyle xmlns:a="http://schemas.openxmlformats.org/drawingml/2006/main"/>
           <a:p xmlns:a="http://schemas.openxmlformats.org/drawingml/2006/main">
             <a:pPr algn="l">
+              <a:buNone/>
               <a:defRPr sz="3600" b="1" i="0">
                 <a:solidFill>
                   <a:srgbClr val="F2C66D"/>
@@ -15741,6 +15823,7 @@
           <a:lstStyle xmlns:a="http://schemas.openxmlformats.org/drawingml/2006/main"/>
           <a:p xmlns:a="http://schemas.openxmlformats.org/drawingml/2006/main">
             <a:pPr algn="l">
+              <a:buNone/>
               <a:defRPr sz="1125" b="1" i="0">
                 <a:solidFill>
                   <a:srgbClr val="C4D4D8"/>
@@ -15753,7 +15836,7 @@
                   <a:srgbClr val="C4D4D8"/>
                 </a:solidFill>
               </a:rPr>
-              <a:t>MONTHLY START DATES</a:t>
+              <a:t>TESTED MONTHLY UPDATE DAYS</a:t>
             </a:r>
           </a:p>
         </p:txBody>
@@ -16442,6 +16525,7 @@
           <a:lstStyle xmlns:a="http://schemas.openxmlformats.org/drawingml/2006/main"/>
           <a:p xmlns:a="http://schemas.openxmlformats.org/drawingml/2006/main">
             <a:pPr algn="l">
+              <a:buNone/>
               <a:defRPr sz="3000" b="1" i="0">
                 <a:solidFill>
                   <a:srgbClr val="F2C66D"/>
@@ -16492,6 +16576,7 @@
           <a:lstStyle xmlns:a="http://schemas.openxmlformats.org/drawingml/2006/main"/>
           <a:p xmlns:a="http://schemas.openxmlformats.org/drawingml/2006/main">
             <a:pPr algn="l">
+              <a:buNone/>
               <a:defRPr sz="1125" b="1" i="0">
                 <a:solidFill>
                   <a:srgbClr val="C4D4D8"/>
@@ -16504,7 +16589,7 @@
                   <a:srgbClr val="C4D4D8"/>
                 </a:solidFill>
               </a:rPr>
-              <a:t>EDGE AT 0.25% TRADING COSTS</a:t>
+              <a:t>MORE ANNUAL RETURN AFTER 0.25% COSTS</a:t>
             </a:r>
           </a:p>
         </p:txBody>
@@ -16542,6 +16627,7 @@
           <a:lstStyle xmlns:a="http://schemas.openxmlformats.org/drawingml/2006/main"/>
           <a:p xmlns:a="http://schemas.openxmlformats.org/drawingml/2006/main">
             <a:pPr algn="l">
+              <a:buNone/>
               <a:defRPr sz="1350" b="1" i="0">
                 <a:solidFill>
                   <a:srgbClr val="FFFFFF"/>
@@ -16689,6 +16775,7 @@
           <a:lstStyle xmlns:a="http://schemas.openxmlformats.org/drawingml/2006/main"/>
           <a:p xmlns:a="http://schemas.openxmlformats.org/drawingml/2006/main">
             <a:pPr algn="l">
+              <a:buNone/>
               <a:defRPr sz="1950" b="1" i="0">
                 <a:solidFill>
                   <a:srgbClr val="B9DFD2"/>
@@ -16739,6 +16826,7 @@
           <a:lstStyle xmlns:a="http://schemas.openxmlformats.org/drawingml/2006/main"/>
           <a:p xmlns:a="http://schemas.openxmlformats.org/drawingml/2006/main">
             <a:pPr algn="l">
+              <a:buNone/>
               <a:defRPr sz="825" b="1" i="0">
                 <a:solidFill>
                   <a:srgbClr val="AFC2C8"/>
@@ -16789,6 +16877,7 @@
           <a:lstStyle xmlns:a="http://schemas.openxmlformats.org/drawingml/2006/main"/>
           <a:p xmlns:a="http://schemas.openxmlformats.org/drawingml/2006/main">
             <a:pPr algn="r">
+              <a:buNone/>
               <a:defRPr sz="825" b="1" i="0">
                 <a:solidFill>
                   <a:srgbClr val="AFC2C8"/>
@@ -16868,6 +16957,7 @@
           <a:lstStyle xmlns:a="http://schemas.openxmlformats.org/drawingml/2006/main"/>
           <a:p xmlns:a="http://schemas.openxmlformats.org/drawingml/2006/main">
             <a:pPr algn="l">
+              <a:buNone/>
               <a:defRPr sz="1125" b="1" i="0">
                 <a:solidFill>
                   <a:srgbClr val="2F7D68"/>
@@ -16918,6 +17008,7 @@
           <a:lstStyle xmlns:a="http://schemas.openxmlformats.org/drawingml/2006/main"/>
           <a:p xmlns:a="http://schemas.openxmlformats.org/drawingml/2006/main">
             <a:pPr algn="l">
+              <a:buNone/>
               <a:defRPr sz="3300" b="1" i="0">
                 <a:solidFill>
                   <a:srgbClr val="122A3E"/>
@@ -16937,7 +17028,7 @@
       </p:sp>
       <p:graphicFrame>
         <p:nvGraphicFramePr>
-          <p:cNvPr id="30" name="Chart"/>
+          <p:cNvPr id="32" name="Chart"/>
           <p:cNvGraphicFramePr/>
           <p:nvPr/>
         </p:nvGraphicFramePr>
@@ -16947,7 +17038,7 @@
         </p:xfrm>
         <a:graphic xmlns:a="http://schemas.openxmlformats.org/drawingml/2006/main">
           <a:graphicData uri="http://schemas.openxmlformats.org/drawingml/2006/chart">
-            <c:chart xmlns:r="http://schemas.openxmlformats.org/officeDocument/2006/relationships" xmlns:c="http://schemas.openxmlformats.org/drawingml/2006/chart" r:id="Rb8e96da1d7f44d2d"/>
+            <c:chart xmlns:r="http://schemas.openxmlformats.org/officeDocument/2006/relationships" xmlns:c="http://schemas.openxmlformats.org/drawingml/2006/chart" r:id="Rfd46da7f97d24f7f"/>
           </a:graphicData>
         </a:graphic>
       </p:graphicFrame>
@@ -16984,6 +17075,7 @@
           <a:lstStyle xmlns:a="http://schemas.openxmlformats.org/drawingml/2006/main"/>
           <a:p xmlns:a="http://schemas.openxmlformats.org/drawingml/2006/main">
             <a:pPr algn="l">
+              <a:buNone/>
               <a:defRPr sz="1050" b="1" i="0">
                 <a:solidFill>
                   <a:srgbClr val="627078"/>
@@ -17034,6 +17126,7 @@
           <a:lstStyle xmlns:a="http://schemas.openxmlformats.org/drawingml/2006/main"/>
           <a:p xmlns:a="http://schemas.openxmlformats.org/drawingml/2006/main">
             <a:pPr algn="l">
+              <a:buNone/>
               <a:defRPr sz="2100" b="1" i="0">
                 <a:solidFill>
                   <a:srgbClr val="2F7D68"/>
@@ -17084,6 +17177,7 @@
           <a:lstStyle xmlns:a="http://schemas.openxmlformats.org/drawingml/2006/main"/>
           <a:p xmlns:a="http://schemas.openxmlformats.org/drawingml/2006/main">
             <a:pPr algn="l">
+              <a:buNone/>
               <a:defRPr sz="2100" b="1" i="0">
                 <a:solidFill>
                   <a:srgbClr val="E56B5D"/>
@@ -17173,6 +17267,7 @@
           <a:lstStyle xmlns:a="http://schemas.openxmlformats.org/drawingml/2006/main"/>
           <a:p xmlns:a="http://schemas.openxmlformats.org/drawingml/2006/main">
             <a:pPr algn="l">
+              <a:buNone/>
               <a:defRPr sz="1200" b="1" i="0">
                 <a:solidFill>
                   <a:srgbClr val="B9DFD2"/>
@@ -17223,6 +17318,7 @@
           <a:lstStyle xmlns:a="http://schemas.openxmlformats.org/drawingml/2006/main"/>
           <a:p xmlns:a="http://schemas.openxmlformats.org/drawingml/2006/main">
             <a:pPr algn="l">
+              <a:buNone/>
               <a:defRPr sz="2250" b="1" i="0">
                 <a:solidFill>
                   <a:srgbClr val="FFFFFF"/>
@@ -17273,6 +17369,7 @@
           <a:lstStyle xmlns:a="http://schemas.openxmlformats.org/drawingml/2006/main"/>
           <a:p xmlns:a="http://schemas.openxmlformats.org/drawingml/2006/main">
             <a:pPr algn="l">
+              <a:buNone/>
               <a:defRPr sz="1200" b="1" i="0">
                 <a:solidFill>
                   <a:srgbClr val="F2C66D"/>
@@ -17323,6 +17420,7 @@
           <a:lstStyle xmlns:a="http://schemas.openxmlformats.org/drawingml/2006/main"/>
           <a:p xmlns:a="http://schemas.openxmlformats.org/drawingml/2006/main">
             <a:pPr algn="l">
+              <a:buNone/>
               <a:defRPr sz="1650" b="1" i="0">
                 <a:solidFill>
                   <a:srgbClr val="FFFFFF"/>
@@ -17373,6 +17471,7 @@
           <a:lstStyle xmlns:a="http://schemas.openxmlformats.org/drawingml/2006/main"/>
           <a:p xmlns:a="http://schemas.openxmlformats.org/drawingml/2006/main">
             <a:pPr algn="l">
+              <a:buNone/>
               <a:defRPr sz="1200" b="1" i="0">
                 <a:solidFill>
                   <a:srgbClr val="E56B5D"/>
@@ -17423,6 +17522,7 @@
           <a:lstStyle xmlns:a="http://schemas.openxmlformats.org/drawingml/2006/main"/>
           <a:p xmlns:a="http://schemas.openxmlformats.org/drawingml/2006/main">
             <a:pPr algn="l">
+              <a:buNone/>
               <a:defRPr sz="1650" b="1" i="0">
                 <a:solidFill>
                   <a:srgbClr val="FFFFFF"/>
@@ -17473,6 +17573,7 @@
           <a:lstStyle xmlns:a="http://schemas.openxmlformats.org/drawingml/2006/main"/>
           <a:p xmlns:a="http://schemas.openxmlformats.org/drawingml/2006/main">
             <a:pPr algn="l">
+              <a:buNone/>
               <a:defRPr sz="1200" b="1" i="0">
                 <a:solidFill>
                   <a:srgbClr val="F2C66D"/>
@@ -17523,6 +17624,7 @@
           <a:lstStyle xmlns:a="http://schemas.openxmlformats.org/drawingml/2006/main"/>
           <a:p xmlns:a="http://schemas.openxmlformats.org/drawingml/2006/main">
             <a:pPr algn="l">
+              <a:buNone/>
               <a:defRPr sz="1650" b="1" i="0">
                 <a:solidFill>
                   <a:srgbClr val="FFFFFF"/>
@@ -17604,6 +17706,7 @@
           <a:lstStyle xmlns:a="http://schemas.openxmlformats.org/drawingml/2006/main"/>
           <a:p xmlns:a="http://schemas.openxmlformats.org/drawingml/2006/main">
             <a:pPr algn="l">
+              <a:buNone/>
               <a:defRPr sz="1275" b="0" i="0">
                 <a:solidFill>
                   <a:srgbClr val="C4D4D8"/>
@@ -17654,6 +17757,7 @@
           <a:lstStyle xmlns:a="http://schemas.openxmlformats.org/drawingml/2006/main"/>
           <a:p xmlns:a="http://schemas.openxmlformats.org/drawingml/2006/main">
             <a:pPr algn="l">
+              <a:buNone/>
               <a:defRPr sz="2850" b="1" i="0">
                 <a:solidFill>
                   <a:srgbClr val="E56B5D"/>
@@ -17704,6 +17808,7 @@
           <a:lstStyle xmlns:a="http://schemas.openxmlformats.org/drawingml/2006/main"/>
           <a:p xmlns:a="http://schemas.openxmlformats.org/drawingml/2006/main">
             <a:pPr algn="l">
+              <a:buNone/>
               <a:defRPr sz="1125" b="1" i="0">
                 <a:solidFill>
                   <a:srgbClr val="627078"/>
@@ -17754,6 +17859,7 @@
           <a:lstStyle xmlns:a="http://schemas.openxmlformats.org/drawingml/2006/main"/>
           <a:p xmlns:a="http://schemas.openxmlformats.org/drawingml/2006/main">
             <a:pPr algn="l">
+              <a:buNone/>
               <a:defRPr sz="2850" b="1" i="0">
                 <a:solidFill>
                   <a:srgbClr val="2F7D68"/>
@@ -17804,6 +17910,7 @@
           <a:lstStyle xmlns:a="http://schemas.openxmlformats.org/drawingml/2006/main"/>
           <a:p xmlns:a="http://schemas.openxmlformats.org/drawingml/2006/main">
             <a:pPr algn="l">
+              <a:buNone/>
               <a:defRPr sz="1125" b="1" i="0">
                 <a:solidFill>
                   <a:srgbClr val="627078"/>
@@ -17854,6 +17961,7 @@
           <a:lstStyle xmlns:a="http://schemas.openxmlformats.org/drawingml/2006/main"/>
           <a:p xmlns:a="http://schemas.openxmlformats.org/drawingml/2006/main">
             <a:pPr algn="l">
+              <a:buNone/>
               <a:defRPr sz="2700" b="1" i="0">
                 <a:solidFill>
                   <a:srgbClr val="2F7D68"/>
@@ -17904,6 +18012,7 @@
           <a:lstStyle xmlns:a="http://schemas.openxmlformats.org/drawingml/2006/main"/>
           <a:p xmlns:a="http://schemas.openxmlformats.org/drawingml/2006/main">
             <a:pPr algn="l">
+              <a:buNone/>
               <a:defRPr sz="825" b="1" i="0">
                 <a:solidFill>
                   <a:srgbClr val="627078"/>
@@ -17916,7 +18025,7 @@
                   <a:srgbClr val="627078"/>
                 </a:solidFill>
               </a:rPr>
-              <a:t>SOURCES REMOVED · SAME RESULT</a:t>
+              <a:t>REMOVED ONE AT A TIME · SAME RESULT</a:t>
             </a:r>
           </a:p>
         </p:txBody>
@@ -17954,6 +18063,7 @@
           <a:lstStyle xmlns:a="http://schemas.openxmlformats.org/drawingml/2006/main"/>
           <a:p xmlns:a="http://schemas.openxmlformats.org/drawingml/2006/main">
             <a:pPr algn="l">
+              <a:buNone/>
               <a:defRPr sz="2700" b="1" i="0">
                 <a:solidFill>
                   <a:srgbClr val="2F7D68"/>
@@ -18004,6 +18114,7 @@
           <a:lstStyle xmlns:a="http://schemas.openxmlformats.org/drawingml/2006/main"/>
           <a:p xmlns:a="http://schemas.openxmlformats.org/drawingml/2006/main">
             <a:pPr algn="l">
+              <a:buNone/>
               <a:defRPr sz="825" b="1" i="0">
                 <a:solidFill>
                   <a:srgbClr val="627078"/>
@@ -18054,6 +18165,7 @@
           <a:lstStyle xmlns:a="http://schemas.openxmlformats.org/drawingml/2006/main"/>
           <a:p xmlns:a="http://schemas.openxmlformats.org/drawingml/2006/main">
             <a:pPr algn="l">
+              <a:buNone/>
               <a:defRPr sz="825" b="1" i="0">
                 <a:solidFill>
                   <a:srgbClr val="627078"/>
@@ -18104,6 +18216,7 @@
           <a:lstStyle xmlns:a="http://schemas.openxmlformats.org/drawingml/2006/main"/>
           <a:p xmlns:a="http://schemas.openxmlformats.org/drawingml/2006/main">
             <a:pPr algn="r">
+              <a:buNone/>
               <a:defRPr sz="825" b="1" i="0">
                 <a:solidFill>
                   <a:srgbClr val="627078"/>
@@ -18183,6 +18296,7 @@
           <a:lstStyle xmlns:a="http://schemas.openxmlformats.org/drawingml/2006/main"/>
           <a:p xmlns:a="http://schemas.openxmlformats.org/drawingml/2006/main">
             <a:pPr algn="l">
+              <a:buNone/>
               <a:defRPr sz="1125" b="1" i="0">
                 <a:solidFill>
                   <a:srgbClr val="B9DFD2"/>
@@ -18233,6 +18347,7 @@
           <a:lstStyle xmlns:a="http://schemas.openxmlformats.org/drawingml/2006/main"/>
           <a:p xmlns:a="http://schemas.openxmlformats.org/drawingml/2006/main">
             <a:pPr algn="l">
+              <a:buNone/>
               <a:defRPr sz="3300" b="1" i="0">
                 <a:solidFill>
                   <a:srgbClr val="FFFFFF"/>
@@ -18245,7 +18360,7 @@
                   <a:srgbClr val="FFFFFF"/>
                 </a:solidFill>
               </a:rPr>
-              <a:t>Finly Core closed its first session $153.31 ahead of SPY.</a:t>
+              <a:t>Finly closed its first paper session $153.31 ahead of SPY.</a:t>
             </a:r>
           </a:p>
         </p:txBody>
@@ -18324,6 +18439,7 @@
           <a:lstStyle xmlns:a="http://schemas.openxmlformats.org/drawingml/2006/main"/>
           <a:p xmlns:a="http://schemas.openxmlformats.org/drawingml/2006/main">
             <a:pPr algn="ctr">
+              <a:buNone/>
               <a:defRPr sz="1125" b="1" i="0">
                 <a:solidFill>
                   <a:srgbClr val="2F7D68"/>
@@ -18374,6 +18490,7 @@
           <a:lstStyle xmlns:a="http://schemas.openxmlformats.org/drawingml/2006/main"/>
           <a:p xmlns:a="http://schemas.openxmlformats.org/drawingml/2006/main">
             <a:pPr algn="ctr">
+              <a:buNone/>
               <a:defRPr sz="1350" b="1" i="0">
                 <a:solidFill>
                   <a:srgbClr val="627078"/>
@@ -18424,6 +18541,7 @@
           <a:lstStyle xmlns:a="http://schemas.openxmlformats.org/drawingml/2006/main"/>
           <a:p xmlns:a="http://schemas.openxmlformats.org/drawingml/2006/main">
             <a:pPr algn="ctr">
+              <a:buNone/>
               <a:defRPr sz="2550" b="1" i="0">
                 <a:solidFill>
                   <a:srgbClr val="0B2942"/>
@@ -18474,6 +18592,7 @@
           <a:lstStyle xmlns:a="http://schemas.openxmlformats.org/drawingml/2006/main"/>
           <a:p xmlns:a="http://schemas.openxmlformats.org/drawingml/2006/main">
             <a:pPr algn="ctr">
+              <a:buNone/>
               <a:defRPr sz="3450" b="1" i="0">
                 <a:solidFill>
                   <a:srgbClr val="2F7D68"/>
@@ -18524,6 +18643,7 @@
           <a:lstStyle xmlns:a="http://schemas.openxmlformats.org/drawingml/2006/main"/>
           <a:p xmlns:a="http://schemas.openxmlformats.org/drawingml/2006/main">
             <a:pPr algn="ctr">
+              <a:buNone/>
               <a:defRPr sz="1350" b="1" i="0">
                 <a:solidFill>
                   <a:srgbClr val="2F7D68"/>
@@ -18574,6 +18694,7 @@
           <a:lstStyle xmlns:a="http://schemas.openxmlformats.org/drawingml/2006/main"/>
           <a:p xmlns:a="http://schemas.openxmlformats.org/drawingml/2006/main">
             <a:pPr algn="ctr">
+              <a:buNone/>
               <a:defRPr sz="1200" b="1" i="0">
                 <a:solidFill>
                   <a:srgbClr val="2F7D68"/>
@@ -18586,7 +18707,7 @@
                   <a:srgbClr val="2F7D68"/>
                 </a:solidFill>
               </a:rPr>
-              <a:t>Finly Core</a:t>
+              <a:t>Finly</a:t>
             </a:r>
           </a:p>
         </p:txBody>
@@ -18624,6 +18745,7 @@
           <a:lstStyle xmlns:a="http://schemas.openxmlformats.org/drawingml/2006/main"/>
           <a:p xmlns:a="http://schemas.openxmlformats.org/drawingml/2006/main">
             <a:pPr algn="ctr">
+              <a:buNone/>
               <a:defRPr sz="2175" b="1" i="0">
                 <a:solidFill>
                   <a:srgbClr val="0B2942"/>
@@ -18674,6 +18796,7 @@
           <a:lstStyle xmlns:a="http://schemas.openxmlformats.org/drawingml/2006/main"/>
           <a:p xmlns:a="http://schemas.openxmlformats.org/drawingml/2006/main">
             <a:pPr algn="ctr">
+              <a:buNone/>
               <a:defRPr sz="1200" b="1" i="0">
                 <a:solidFill>
                   <a:srgbClr val="E56B5D"/>
@@ -18724,6 +18847,7 @@
           <a:lstStyle xmlns:a="http://schemas.openxmlformats.org/drawingml/2006/main"/>
           <a:p xmlns:a="http://schemas.openxmlformats.org/drawingml/2006/main">
             <a:pPr algn="ctr">
+              <a:buNone/>
               <a:defRPr sz="2175" b="1" i="0">
                 <a:solidFill>
                   <a:srgbClr val="0B2942"/>
@@ -18805,6 +18929,7 @@
           <a:lstStyle xmlns:a="http://schemas.openxmlformats.org/drawingml/2006/main"/>
           <a:p xmlns:a="http://schemas.openxmlformats.org/drawingml/2006/main">
             <a:pPr algn="ctr">
+              <a:buNone/>
               <a:defRPr sz="1275" b="0" i="0">
                 <a:solidFill>
                   <a:srgbClr val="627078"/>
@@ -18817,7 +18942,7 @@
                   <a:srgbClr val="627078"/>
                 </a:solidFill>
               </a:rPr>
-              <a:t>15 fills built the four-fund Core portfolio · no options position was open</a:t>
+              <a:t>15 fill events built the four-fund base portfolio · no options position was open</a:t>
             </a:r>
           </a:p>
         </p:txBody>
@@ -18886,6 +19011,7 @@
           <a:lstStyle xmlns:a="http://schemas.openxmlformats.org/drawingml/2006/main"/>
           <a:p xmlns:a="http://schemas.openxmlformats.org/drawingml/2006/main">
             <a:pPr algn="l">
+              <a:buNone/>
               <a:defRPr sz="1650" b="1" i="0">
                 <a:solidFill>
                   <a:srgbClr val="B9DFD2"/>
@@ -18936,6 +19062,7 @@
           <a:lstStyle xmlns:a="http://schemas.openxmlformats.org/drawingml/2006/main"/>
           <a:p xmlns:a="http://schemas.openxmlformats.org/drawingml/2006/main">
             <a:pPr algn="l">
+              <a:buNone/>
               <a:defRPr sz="1350" b="0" i="0">
                 <a:solidFill>
                   <a:srgbClr val="FFFFFF"/>
@@ -18948,7 +19075,7 @@
                   <a:srgbClr val="FFFFFF"/>
                 </a:solidFill>
               </a:rPr>
-              <a:t>Finly Core produced this measured account result. The AI options demonstration is separate.</a:t>
+              <a:t>The base portfolio produced this measured account result. The AI-assisted options demo is separate.</a:t>
             </a:r>
           </a:p>
         </p:txBody>
@@ -18986,6 +19113,7 @@
           <a:lstStyle xmlns:a="http://schemas.openxmlformats.org/drawingml/2006/main"/>
           <a:p xmlns:a="http://schemas.openxmlformats.org/drawingml/2006/main">
             <a:pPr algn="l">
+              <a:buNone/>
               <a:defRPr sz="1125" b="1" i="0">
                 <a:solidFill>
                   <a:srgbClr val="B9DFD2"/>
@@ -18998,7 +19126,7 @@
                   <a:srgbClr val="B9DFD2"/>
                 </a:solidFill>
               </a:rPr>
-              <a:t>FINLY CORE</a:t>
+              <a:t>FINLY</a:t>
             </a:r>
           </a:p>
         </p:txBody>
@@ -19036,6 +19164,7 @@
           <a:lstStyle xmlns:a="http://schemas.openxmlformats.org/drawingml/2006/main"/>
           <a:p xmlns:a="http://schemas.openxmlformats.org/drawingml/2006/main">
             <a:pPr algn="l">
+              <a:buNone/>
               <a:defRPr sz="2550" b="1" i="0">
                 <a:solidFill>
                   <a:srgbClr val="FFFFFF"/>
@@ -19086,6 +19215,7 @@
           <a:lstStyle xmlns:a="http://schemas.openxmlformats.org/drawingml/2006/main"/>
           <a:p xmlns:a="http://schemas.openxmlformats.org/drawingml/2006/main">
             <a:pPr algn="l">
+              <a:buNone/>
               <a:defRPr sz="1200" b="0" i="0">
                 <a:solidFill>
                   <a:srgbClr val="C4D4D8"/>
@@ -19167,6 +19297,7 @@
           <a:lstStyle xmlns:a="http://schemas.openxmlformats.org/drawingml/2006/main"/>
           <a:p xmlns:a="http://schemas.openxmlformats.org/drawingml/2006/main">
             <a:pPr algn="l">
+              <a:buNone/>
               <a:defRPr sz="1125" b="1" i="0">
                 <a:solidFill>
                   <a:srgbClr val="E56B5D"/>
@@ -19217,6 +19348,7 @@
           <a:lstStyle xmlns:a="http://schemas.openxmlformats.org/drawingml/2006/main"/>
           <a:p xmlns:a="http://schemas.openxmlformats.org/drawingml/2006/main">
             <a:pPr algn="l">
+              <a:buNone/>
               <a:defRPr sz="2550" b="1" i="0">
                 <a:solidFill>
                   <a:srgbClr val="FFFFFF"/>
@@ -19267,6 +19399,7 @@
           <a:lstStyle xmlns:a="http://schemas.openxmlformats.org/drawingml/2006/main"/>
           <a:p xmlns:a="http://schemas.openxmlformats.org/drawingml/2006/main">
             <a:pPr algn="l">
+              <a:buNone/>
               <a:defRPr sz="1200" b="0" i="0">
                 <a:solidFill>
                   <a:srgbClr val="C4D4D8"/>
@@ -19348,6 +19481,7 @@
           <a:lstStyle xmlns:a="http://schemas.openxmlformats.org/drawingml/2006/main"/>
           <a:p xmlns:a="http://schemas.openxmlformats.org/drawingml/2006/main">
             <a:pPr algn="l">
+              <a:buNone/>
               <a:defRPr sz="1125" b="1" i="0">
                 <a:solidFill>
                   <a:srgbClr val="F2C66D"/>
@@ -19398,6 +19532,7 @@
           <a:lstStyle xmlns:a="http://schemas.openxmlformats.org/drawingml/2006/main"/>
           <a:p xmlns:a="http://schemas.openxmlformats.org/drawingml/2006/main">
             <a:pPr algn="l">
+              <a:buNone/>
               <a:defRPr sz="2550" b="1" i="0">
                 <a:solidFill>
                   <a:srgbClr val="F2C66D"/>
@@ -19448,6 +19583,7 @@
           <a:lstStyle xmlns:a="http://schemas.openxmlformats.org/drawingml/2006/main"/>
           <a:p xmlns:a="http://schemas.openxmlformats.org/drawingml/2006/main">
             <a:pPr algn="l">
+              <a:buNone/>
               <a:defRPr sz="1200" b="1" i="0">
                 <a:solidFill>
                   <a:srgbClr val="B9DFD2"/>
@@ -19498,6 +19634,7 @@
           <a:lstStyle xmlns:a="http://schemas.openxmlformats.org/drawingml/2006/main"/>
           <a:p xmlns:a="http://schemas.openxmlformats.org/drawingml/2006/main">
             <a:pPr algn="l">
+              <a:buNone/>
               <a:defRPr sz="825" b="1" i="0">
                 <a:solidFill>
                   <a:srgbClr val="AFC2C8"/>
@@ -19548,6 +19685,7 @@
           <a:lstStyle xmlns:a="http://schemas.openxmlformats.org/drawingml/2006/main"/>
           <a:p xmlns:a="http://schemas.openxmlformats.org/drawingml/2006/main">
             <a:pPr algn="r">
+              <a:buNone/>
               <a:defRPr sz="825" b="1" i="0">
                 <a:solidFill>
                   <a:srgbClr val="AFC2C8"/>
@@ -19627,6 +19765,7 @@
           <a:lstStyle xmlns:a="http://schemas.openxmlformats.org/drawingml/2006/main"/>
           <a:p xmlns:a="http://schemas.openxmlformats.org/drawingml/2006/main">
             <a:pPr algn="l">
+              <a:buNone/>
               <a:defRPr sz="1125" b="1" i="0">
                 <a:solidFill>
                   <a:srgbClr val="2F7D68"/>
@@ -19677,6 +19816,7 @@
           <a:lstStyle xmlns:a="http://schemas.openxmlformats.org/drawingml/2006/main"/>
           <a:p xmlns:a="http://schemas.openxmlformats.org/drawingml/2006/main">
             <a:pPr algn="l">
+              <a:buNone/>
               <a:defRPr sz="3525" b="1" i="0">
                 <a:solidFill>
                   <a:srgbClr val="122A3E"/>
@@ -19737,14 +19877,14 @@
       </p:sp>
       <p:pic>
         <p:nvPicPr>
-          <p:cNvPr id="28" name=""/>
+          <p:cNvPr id="30" name=""/>
           <p:cNvPicPr>
             <a:picLocks xmlns:a="http://schemas.openxmlformats.org/drawingml/2006/main" noChangeAspect="1"/>
           </p:cNvPicPr>
           <p:nvPr/>
         </p:nvPicPr>
         <p:blipFill>
-          <a:blip xmlns:r="http://schemas.openxmlformats.org/officeDocument/2006/relationships" xmlns:a="http://schemas.openxmlformats.org/drawingml/2006/main" r:embed="Ra1ba967815054614"/>
+          <a:blip xmlns:r="http://schemas.openxmlformats.org/officeDocument/2006/relationships" xmlns:a="http://schemas.openxmlformats.org/drawingml/2006/main" r:embed="R465893e3f9474936"/>
           <a:stretch xmlns:a="http://schemas.openxmlformats.org/drawingml/2006/main"/>
         </p:blipFill>
         <p:spPr>
@@ -19825,6 +19965,7 @@
           <a:lstStyle xmlns:a="http://schemas.openxmlformats.org/drawingml/2006/main"/>
           <a:p xmlns:a="http://schemas.openxmlformats.org/drawingml/2006/main">
             <a:pPr algn="l">
+              <a:buNone/>
               <a:defRPr sz="1050" b="1" i="0">
                 <a:solidFill>
                   <a:srgbClr val="2F7D68"/>
@@ -19875,6 +20016,7 @@
           <a:lstStyle xmlns:a="http://schemas.openxmlformats.org/drawingml/2006/main"/>
           <a:p xmlns:a="http://schemas.openxmlformats.org/drawingml/2006/main">
             <a:pPr algn="l">
+              <a:buNone/>
               <a:defRPr sz="1800" b="1" i="0">
                 <a:solidFill>
                   <a:srgbClr val="122A3E"/>
@@ -19958,6 +20100,7 @@
           <a:lstStyle xmlns:a="http://schemas.openxmlformats.org/drawingml/2006/main"/>
           <a:p xmlns:a="http://schemas.openxmlformats.org/drawingml/2006/main">
             <a:pPr algn="l">
+              <a:buNone/>
               <a:defRPr sz="1050" b="1" i="0">
                 <a:solidFill>
                   <a:srgbClr val="F2C66D"/>
@@ -20008,6 +20151,7 @@
           <a:lstStyle xmlns:a="http://schemas.openxmlformats.org/drawingml/2006/main"/>
           <a:p xmlns:a="http://schemas.openxmlformats.org/drawingml/2006/main">
             <a:pPr algn="l">
+              <a:buNone/>
               <a:defRPr sz="1800" b="1" i="0">
                 <a:solidFill>
                   <a:srgbClr val="122A3E"/>
@@ -20091,6 +20235,7 @@
           <a:lstStyle xmlns:a="http://schemas.openxmlformats.org/drawingml/2006/main"/>
           <a:p xmlns:a="http://schemas.openxmlformats.org/drawingml/2006/main">
             <a:pPr algn="l">
+              <a:buNone/>
               <a:defRPr sz="1050" b="1" i="0">
                 <a:solidFill>
                   <a:srgbClr val="0B2942"/>
@@ -20141,6 +20286,7 @@
           <a:lstStyle xmlns:a="http://schemas.openxmlformats.org/drawingml/2006/main"/>
           <a:p xmlns:a="http://schemas.openxmlformats.org/drawingml/2006/main">
             <a:pPr algn="l">
+              <a:buNone/>
               <a:defRPr sz="1800" b="1" i="0">
                 <a:solidFill>
                   <a:srgbClr val="122A3E"/>
@@ -20224,6 +20370,7 @@
           <a:lstStyle xmlns:a="http://schemas.openxmlformats.org/drawingml/2006/main"/>
           <a:p xmlns:a="http://schemas.openxmlformats.org/drawingml/2006/main">
             <a:pPr algn="l">
+              <a:buNone/>
               <a:defRPr sz="1050" b="1" i="0">
                 <a:solidFill>
                   <a:srgbClr val="E56B5D"/>
@@ -20274,6 +20421,7 @@
           <a:lstStyle xmlns:a="http://schemas.openxmlformats.org/drawingml/2006/main"/>
           <a:p xmlns:a="http://schemas.openxmlformats.org/drawingml/2006/main">
             <a:pPr algn="l">
+              <a:buNone/>
               <a:defRPr sz="1800" b="1" i="0">
                 <a:solidFill>
                   <a:srgbClr val="122A3E"/>
@@ -20355,6 +20503,7 @@
           <a:lstStyle xmlns:a="http://schemas.openxmlformats.org/drawingml/2006/main"/>
           <a:p xmlns:a="http://schemas.openxmlformats.org/drawingml/2006/main">
             <a:pPr algn="l">
+              <a:buNone/>
               <a:defRPr sz="3450" b="1" i="0">
                 <a:solidFill>
                   <a:srgbClr val="2F7D68"/>
@@ -20405,6 +20554,7 @@
           <a:lstStyle xmlns:a="http://schemas.openxmlformats.org/drawingml/2006/main"/>
           <a:p xmlns:a="http://schemas.openxmlformats.org/drawingml/2006/main">
             <a:pPr algn="l">
+              <a:buNone/>
               <a:defRPr sz="1650" b="1" i="0">
                 <a:solidFill>
                   <a:srgbClr val="627078"/>
@@ -20417,7 +20567,7 @@
                   <a:srgbClr val="627078"/>
                 </a:solidFill>
               </a:rPr>
-              <a:t>tests discovered</a:t>
+              <a:t>automated tests</a:t>
             </a:r>
           </a:p>
         </p:txBody>
@@ -20455,6 +20605,7 @@
           <a:lstStyle xmlns:a="http://schemas.openxmlformats.org/drawingml/2006/main"/>
           <a:p xmlns:a="http://schemas.openxmlformats.org/drawingml/2006/main">
             <a:pPr algn="l">
+              <a:buNone/>
               <a:defRPr sz="1575" b="1" i="0">
                 <a:solidFill>
                   <a:srgbClr val="122A3E"/>
@@ -20538,6 +20689,7 @@
           <a:lstStyle xmlns:a="http://schemas.openxmlformats.org/drawingml/2006/main"/>
           <a:p xmlns:a="http://schemas.openxmlformats.org/drawingml/2006/main">
             <a:pPr algn="ctr">
+              <a:buNone/>
               <a:defRPr sz="1425" b="1" i="0">
                 <a:solidFill>
                   <a:srgbClr val="FFFFFF"/>
@@ -20588,6 +20740,7 @@
           <a:lstStyle xmlns:a="http://schemas.openxmlformats.org/drawingml/2006/main"/>
           <a:p xmlns:a="http://schemas.openxmlformats.org/drawingml/2006/main">
             <a:pPr algn="l">
+              <a:buNone/>
               <a:defRPr sz="825" b="1" i="0">
                 <a:solidFill>
                   <a:srgbClr val="627078"/>
@@ -20638,6 +20791,7 @@
           <a:lstStyle xmlns:a="http://schemas.openxmlformats.org/drawingml/2006/main"/>
           <a:p xmlns:a="http://schemas.openxmlformats.org/drawingml/2006/main">
             <a:pPr algn="r">
+              <a:buNone/>
               <a:defRPr sz="825" b="1" i="0">
                 <a:solidFill>
                   <a:srgbClr val="627078"/>
@@ -20717,6 +20871,7 @@
           <a:lstStyle xmlns:a="http://schemas.openxmlformats.org/drawingml/2006/main"/>
           <a:p xmlns:a="http://schemas.openxmlformats.org/drawingml/2006/main">
             <a:pPr algn="l">
+              <a:buNone/>
               <a:defRPr sz="1125" b="1" i="0">
                 <a:solidFill>
                   <a:srgbClr val="2F7D68"/>
@@ -20729,7 +20884,7 @@
                   <a:srgbClr val="2F7D68"/>
                 </a:solidFill>
               </a:rPr>
-              <a:t>JUDGE THE PRODUCT</a:t>
+              <a:t>OPEN FINLY</a:t>
             </a:r>
           </a:p>
         </p:txBody>
@@ -20767,6 +20922,7 @@
           <a:lstStyle xmlns:a="http://schemas.openxmlformats.org/drawingml/2006/main"/>
           <a:p xmlns:a="http://schemas.openxmlformats.org/drawingml/2006/main">
             <a:pPr algn="l">
+              <a:buNone/>
               <a:defRPr sz="4050" b="1" i="0">
                 <a:solidFill>
                   <a:srgbClr val="122A3E"/>
@@ -20779,7 +20935,7 @@
                   <a:srgbClr val="122A3E"/>
                 </a:solidFill>
               </a:rPr>
-              <a:t>Judge the live system—not the slide deck.</a:t>
+              <a:t>Watch the account. Try the decision. Inspect the proof.</a:t>
             </a:r>
           </a:p>
         </p:txBody>
@@ -20817,6 +20973,7 @@
           <a:lstStyle xmlns:a="http://schemas.openxmlformats.org/drawingml/2006/main"/>
           <a:p xmlns:a="http://schemas.openxmlformats.org/drawingml/2006/main">
             <a:pPr algn="l">
+              <a:buNone/>
               <a:defRPr sz="2100" b="0" i="0">
                 <a:solidFill>
                   <a:srgbClr val="627078"/>
@@ -20829,7 +20986,7 @@
                   <a:srgbClr val="627078"/>
                 </a:solidFill>
               </a:rPr>
-              <a:t>$153.31 ahead after session one. Now try the decision demo and inspect the proof.</a:t>
+              <a:t>Start with the short demo, then trace any result back to its source.</a:t>
             </a:r>
           </a:p>
         </p:txBody>
@@ -20877,14 +21034,14 @@
       </p:sp>
       <p:pic>
         <p:nvPicPr>
-          <p:cNvPr id="28" name=""/>
+          <p:cNvPr id="30" name=""/>
           <p:cNvPicPr>
             <a:picLocks xmlns:a="http://schemas.openxmlformats.org/drawingml/2006/main" noChangeAspect="1"/>
           </p:cNvPicPr>
           <p:nvPr/>
         </p:nvPicPr>
         <p:blipFill>
-          <a:blip xmlns:r="http://schemas.openxmlformats.org/officeDocument/2006/relationships" xmlns:a="http://schemas.openxmlformats.org/drawingml/2006/main" r:embed="R2bed47038ed74515"/>
+          <a:blip xmlns:r="http://schemas.openxmlformats.org/officeDocument/2006/relationships" xmlns:a="http://schemas.openxmlformats.org/drawingml/2006/main" r:embed="R30e14317740e459a"/>
           <a:stretch xmlns:a="http://schemas.openxmlformats.org/drawingml/2006/main"/>
         </p:blipFill>
         <p:spPr>
@@ -20945,7 +21102,7 @@
                 <a:latin typeface="Arial"/>
                 <a:ea typeface="Arial"/>
                 <a:cs typeface="Arial"/>
-                <a:hlinkClick xmlns:r="http://schemas.openxmlformats.org/officeDocument/2006/relationships" r:id="Rbbd9332d6dc14c12"/>
+                <a:hlinkClick xmlns:r="http://schemas.openxmlformats.org/officeDocument/2006/relationships" r:id="Rfc9c8a159c134da5"/>
               </a:rPr>
               <a:t>SCAN TO OPEN FINLY</a:t>
             </a:r>
@@ -20985,6 +21142,7 @@
           <a:lstStyle xmlns:a="http://schemas.openxmlformats.org/drawingml/2006/main"/>
           <a:p xmlns:a="http://schemas.openxmlformats.org/drawingml/2006/main">
             <a:pPr algn="l">
+              <a:buNone/>
               <a:defRPr sz="1350" b="1" i="0">
                 <a:solidFill>
                   <a:srgbClr val="2F7D68"/>
@@ -21035,6 +21193,7 @@
           <a:lstStyle xmlns:a="http://schemas.openxmlformats.org/drawingml/2006/main"/>
           <a:p xmlns:a="http://schemas.openxmlformats.org/drawingml/2006/main">
             <a:pPr algn="l">
+              <a:buNone/>
               <a:defRPr sz="1350" b="1" i="0">
                 <a:solidFill>
                   <a:srgbClr val="2F7D68"/>
@@ -21085,6 +21244,7 @@
           <a:lstStyle xmlns:a="http://schemas.openxmlformats.org/drawingml/2006/main"/>
           <a:p xmlns:a="http://schemas.openxmlformats.org/drawingml/2006/main">
             <a:pPr algn="l">
+              <a:buNone/>
               <a:defRPr sz="1875" b="1" i="0">
                 <a:solidFill>
                   <a:srgbClr val="122A3E"/>
@@ -21097,7 +21257,7 @@
                   <a:srgbClr val="122A3E"/>
                 </a:solidFill>
               </a:rPr>
-              <a:t>Live $100k paper account</a:t>
+              <a:t>The $100K paper account</a:t>
             </a:r>
           </a:p>
         </p:txBody>
@@ -21166,6 +21326,7 @@
           <a:lstStyle xmlns:a="http://schemas.openxmlformats.org/drawingml/2006/main"/>
           <a:p xmlns:a="http://schemas.openxmlformats.org/drawingml/2006/main">
             <a:pPr algn="l">
+              <a:buNone/>
               <a:defRPr sz="1350" b="1" i="0">
                 <a:solidFill>
                   <a:srgbClr val="E56B5D"/>
@@ -21216,6 +21377,7 @@
           <a:lstStyle xmlns:a="http://schemas.openxmlformats.org/drawingml/2006/main"/>
           <a:p xmlns:a="http://schemas.openxmlformats.org/drawingml/2006/main">
             <a:pPr algn="l">
+              <a:buNone/>
               <a:defRPr sz="1350" b="1" i="0">
                 <a:solidFill>
                   <a:srgbClr val="E56B5D"/>
@@ -21266,6 +21428,7 @@
           <a:lstStyle xmlns:a="http://schemas.openxmlformats.org/drawingml/2006/main"/>
           <a:p xmlns:a="http://schemas.openxmlformats.org/drawingml/2006/main">
             <a:pPr algn="l">
+              <a:buNone/>
               <a:defRPr sz="1875" b="1" i="0">
                 <a:solidFill>
                   <a:srgbClr val="122A3E"/>
@@ -21278,7 +21441,7 @@
                   <a:srgbClr val="122A3E"/>
                 </a:solidFill>
               </a:rPr>
-              <a:t>Evidence agrees vs conflicts</a:t>
+              <a:t>An approval and a refusal</a:t>
             </a:r>
           </a:p>
         </p:txBody>
@@ -21347,6 +21510,7 @@
           <a:lstStyle xmlns:a="http://schemas.openxmlformats.org/drawingml/2006/main"/>
           <a:p xmlns:a="http://schemas.openxmlformats.org/drawingml/2006/main">
             <a:pPr algn="l">
+              <a:buNone/>
               <a:defRPr sz="1350" b="1" i="0">
                 <a:solidFill>
                   <a:srgbClr val="0B2942"/>
@@ -21397,6 +21561,7 @@
           <a:lstStyle xmlns:a="http://schemas.openxmlformats.org/drawingml/2006/main"/>
           <a:p xmlns:a="http://schemas.openxmlformats.org/drawingml/2006/main">
             <a:pPr algn="l">
+              <a:buNone/>
               <a:defRPr sz="1350" b="1" i="0">
                 <a:solidFill>
                   <a:srgbClr val="0B2942"/>
@@ -21447,6 +21612,7 @@
           <a:lstStyle xmlns:a="http://schemas.openxmlformats.org/drawingml/2006/main"/>
           <a:p xmlns:a="http://schemas.openxmlformats.org/drawingml/2006/main">
             <a:pPr algn="l">
+              <a:buNone/>
               <a:defRPr sz="1875" b="1" i="0">
                 <a:solidFill>
                   <a:srgbClr val="122A3E"/>
@@ -21459,7 +21625,7 @@
                   <a:srgbClr val="122A3E"/>
                 </a:solidFill>
               </a:rPr>
-              <a:t>Code, tests, and decision records</a:t>
+              <a:t>Equations, tests, receipts, and code</a:t>
             </a:r>
           </a:p>
         </p:txBody>
@@ -21528,6 +21694,7 @@
           <a:lstStyle xmlns:a="http://schemas.openxmlformats.org/drawingml/2006/main"/>
           <a:p xmlns:a="http://schemas.openxmlformats.org/drawingml/2006/main">
             <a:pPr algn="l">
+              <a:buNone/>
               <a:defRPr sz="2175" b="1" i="0">
                 <a:solidFill>
                   <a:srgbClr val="2F7D68"/>
@@ -21540,7 +21707,7 @@
                   <a:srgbClr val="2F7D68"/>
                 </a:solidFill>
               </a:rPr>
-              <a:t>Historical results. First-session proof. Every decision inspectable.</a:t>
+              <a:t>First-session proof · 80 years of history · 809 automated checks</a:t>
             </a:r>
           </a:p>
         </p:txBody>
@@ -21593,7 +21760,7 @@
                 <a:latin typeface="Arial"/>
                 <a:ea typeface="Arial"/>
                 <a:cs typeface="Arial"/>
-                <a:hlinkClick xmlns:r="http://schemas.openxmlformats.org/officeDocument/2006/relationships" r:id="Re49049cd368e4bd4"/>
+                <a:hlinkClick xmlns:r="http://schemas.openxmlformats.org/officeDocument/2006/relationships" r:id="R39b3442ed2164de2"/>
               </a:rPr>
               <a:t>owlsowo.github.io/finly-bot</a:t>
             </a:r>
@@ -21633,6 +21800,7 @@
           <a:lstStyle xmlns:a="http://schemas.openxmlformats.org/drawingml/2006/main"/>
           <a:p xmlns:a="http://schemas.openxmlformats.org/drawingml/2006/main">
             <a:pPr algn="r">
+              <a:buNone/>
               <a:defRPr sz="1350" b="0" i="0">
                 <a:solidFill>
                   <a:srgbClr val="627078"/>
@@ -21683,6 +21851,7 @@
           <a:lstStyle xmlns:a="http://schemas.openxmlformats.org/drawingml/2006/main"/>
           <a:p xmlns:a="http://schemas.openxmlformats.org/drawingml/2006/main">
             <a:pPr algn="l">
+              <a:buNone/>
               <a:defRPr sz="825" b="1" i="0">
                 <a:solidFill>
                   <a:srgbClr val="627078"/>
@@ -21733,6 +21902,7 @@
           <a:lstStyle xmlns:a="http://schemas.openxmlformats.org/drawingml/2006/main"/>
           <a:p xmlns:a="http://schemas.openxmlformats.org/drawingml/2006/main">
             <a:pPr algn="r">
+              <a:buNone/>
               <a:defRPr sz="825" b="1" i="0">
                 <a:solidFill>
                   <a:srgbClr val="627078"/>

</xml_diff>

<commit_message>
Fix deck screenshot overlap and refresh demo
</commit_message>
<xml_diff>
--- a/public/judge/Finly_Consulting_Deck.pptx
+++ b/public/judge/Finly_Consulting_Deck.pptx
@@ -2,21 +2,21 @@
 <file path=ppt/presentation.xml><?xml version="1.0" encoding="utf-8"?>
 <p:presentation xmlns:p="http://schemas.openxmlformats.org/presentationml/2006/main">
   <p:sldMasterIdLst>
-    <p:sldMasterId xmlns:r="http://schemas.openxmlformats.org/officeDocument/2006/relationships" id="2147483648" r:id="R07a508c04ba2425c"/>
+    <p:sldMasterId xmlns:r="http://schemas.openxmlformats.org/officeDocument/2006/relationships" id="2147483648" r:id="R72d93b2084ca47f0"/>
   </p:sldMasterIdLst>
   <p:notesMasterIdLst>
-    <p:notesMasterId xmlns:r="http://schemas.openxmlformats.org/officeDocument/2006/relationships" r:id="Raa249330775243da"/>
+    <p:notesMasterId xmlns:r="http://schemas.openxmlformats.org/officeDocument/2006/relationships" r:id="Rcb8040e324a5456a"/>
   </p:notesMasterIdLst>
   <p:sldIdLst>
-    <p:sldId xmlns:r="http://schemas.openxmlformats.org/officeDocument/2006/relationships" id="256" r:id="R69620f76471245cc"/>
-    <p:sldId xmlns:r="http://schemas.openxmlformats.org/officeDocument/2006/relationships" id="257" r:id="Rc9185197c6b14a7b"/>
-    <p:sldId xmlns:r="http://schemas.openxmlformats.org/officeDocument/2006/relationships" id="258" r:id="Rc52954fcda614d94"/>
-    <p:sldId xmlns:r="http://schemas.openxmlformats.org/officeDocument/2006/relationships" id="259" r:id="Rc7925ed7fc29444c"/>
-    <p:sldId xmlns:r="http://schemas.openxmlformats.org/officeDocument/2006/relationships" id="260" r:id="R5e54fff383a641c2"/>
-    <p:sldId xmlns:r="http://schemas.openxmlformats.org/officeDocument/2006/relationships" id="261" r:id="R143f0492f46e4414"/>
-    <p:sldId xmlns:r="http://schemas.openxmlformats.org/officeDocument/2006/relationships" id="262" r:id="R703b9ad04fce423d"/>
-    <p:sldId xmlns:r="http://schemas.openxmlformats.org/officeDocument/2006/relationships" id="263" r:id="R5c0a9deb13774787"/>
-    <p:sldId xmlns:r="http://schemas.openxmlformats.org/officeDocument/2006/relationships" id="264" r:id="R4ed35da329bf47d2"/>
+    <p:sldId xmlns:r="http://schemas.openxmlformats.org/officeDocument/2006/relationships" id="256" r:id="R24021d7420884500"/>
+    <p:sldId xmlns:r="http://schemas.openxmlformats.org/officeDocument/2006/relationships" id="257" r:id="R11baa84e6c084d31"/>
+    <p:sldId xmlns:r="http://schemas.openxmlformats.org/officeDocument/2006/relationships" id="258" r:id="R82b3eb3bfd2e461c"/>
+    <p:sldId xmlns:r="http://schemas.openxmlformats.org/officeDocument/2006/relationships" id="259" r:id="Rf4b83e178bab4afb"/>
+    <p:sldId xmlns:r="http://schemas.openxmlformats.org/officeDocument/2006/relationships" id="260" r:id="Rde319df99c384fa6"/>
+    <p:sldId xmlns:r="http://schemas.openxmlformats.org/officeDocument/2006/relationships" id="261" r:id="R70862645775c4b75"/>
+    <p:sldId xmlns:r="http://schemas.openxmlformats.org/officeDocument/2006/relationships" id="262" r:id="R19b073de502047a0"/>
+    <p:sldId xmlns:r="http://schemas.openxmlformats.org/officeDocument/2006/relationships" id="263" r:id="Rd2f767eb61be4245"/>
+    <p:sldId xmlns:r="http://schemas.openxmlformats.org/officeDocument/2006/relationships" id="264" r:id="R16ec6031de45422a"/>
   </p:sldIdLst>
   <p:sldSz cx="12192000" cy="6858000"/>
   <p:notesSz cx="6858000" cy="9144000"/>
@@ -1278,7 +1278,7 @@
   </p:cSld>
   <p:clrMap bg1="lt1" tx1="dk1" bg2="lt2" tx2="dk2" accent1="accent1" accent2="accent2" accent3="accent3" accent4="accent4" accent5="accent5" accent6="accent6" hlink="hlink" folHlink="folHlink"/>
   <p:sldLayoutIdLst>
-    <p:sldLayoutId xmlns:r="http://schemas.openxmlformats.org/officeDocument/2006/relationships" id="2147483649" r:id="R75906ecdf8404303"/>
+    <p:sldLayoutId xmlns:r="http://schemas.openxmlformats.org/officeDocument/2006/relationships" id="2147483649" r:id="R88e4143a30ba430a"/>
   </p:sldLayoutIdLst>
   <p:txStyles>
     <p:titleStyle>
@@ -11008,7 +11008,7 @@
           <p:nvPr/>
         </p:nvPicPr>
         <p:blipFill>
-          <a:blip xmlns:r="http://schemas.openxmlformats.org/officeDocument/2006/relationships" xmlns:a="http://schemas.openxmlformats.org/drawingml/2006/main" r:embed="R271c37e865264078"/>
+          <a:blip xmlns:r="http://schemas.openxmlformats.org/officeDocument/2006/relationships" xmlns:a="http://schemas.openxmlformats.org/drawingml/2006/main" r:embed="Reb22179187bd4e83"/>
           <a:stretch xmlns:a="http://schemas.openxmlformats.org/drawingml/2006/main"/>
         </p:blipFill>
         <p:spPr>
@@ -11265,7 +11265,7 @@
           <p:nvPr/>
         </p:nvPicPr>
         <p:blipFill>
-          <a:blip xmlns:r="http://schemas.openxmlformats.org/officeDocument/2006/relationships" xmlns:a="http://schemas.openxmlformats.org/drawingml/2006/main" r:embed="R9a66e107b62f4ad6"/>
+          <a:blip xmlns:r="http://schemas.openxmlformats.org/officeDocument/2006/relationships" xmlns:a="http://schemas.openxmlformats.org/drawingml/2006/main" r:embed="R841f345d83274722"/>
           <a:stretch xmlns:a="http://schemas.openxmlformats.org/drawingml/2006/main"/>
         </p:blipFill>
         <p:spPr>
@@ -13594,8 +13594,11 @@
           <p:nvPr/>
         </p:nvPicPr>
         <p:blipFill>
-          <a:blip xmlns:r="http://schemas.openxmlformats.org/officeDocument/2006/relationships" xmlns:a="http://schemas.openxmlformats.org/drawingml/2006/main" r:embed="Rdc6f361541f14d46"/>
-          <a:stretch xmlns:a="http://schemas.openxmlformats.org/drawingml/2006/main"/>
+          <a:blip xmlns:r="http://schemas.openxmlformats.org/officeDocument/2006/relationships" xmlns:a="http://schemas.openxmlformats.org/drawingml/2006/main" r:embed="Rf929ed3c986049ea"/>
+          <a:srcRect xmlns:a="http://schemas.openxmlformats.org/drawingml/2006/main" l="0" t="0" r="0" b="0"/>
+          <a:stretch xmlns:a="http://schemas.openxmlformats.org/drawingml/2006/main">
+            <a:fillRect l="0" t="0" r="0" b="0"/>
+          </a:stretch>
         </p:blipFill>
         <p:spPr>
           <a:xfrm xmlns:a="http://schemas.openxmlformats.org/drawingml/2006/main">
@@ -14559,7 +14562,7 @@
         </p:xfrm>
         <a:graphic xmlns:a="http://schemas.openxmlformats.org/drawingml/2006/main">
           <a:graphicData uri="http://schemas.openxmlformats.org/drawingml/2006/chart">
-            <c:chart xmlns:r="http://schemas.openxmlformats.org/officeDocument/2006/relationships" xmlns:c="http://schemas.openxmlformats.org/drawingml/2006/chart" r:id="R8c547c99d5624867"/>
+            <c:chart xmlns:r="http://schemas.openxmlformats.org/officeDocument/2006/relationships" xmlns:c="http://schemas.openxmlformats.org/drawingml/2006/chart" r:id="R7be9107569ce4c24"/>
           </a:graphicData>
         </a:graphic>
       </p:graphicFrame>
@@ -14881,7 +14884,7 @@
         </p:xfrm>
         <a:graphic xmlns:a="http://schemas.openxmlformats.org/drawingml/2006/main">
           <a:graphicData uri="http://schemas.openxmlformats.org/drawingml/2006/chart">
-            <c:chart xmlns:r="http://schemas.openxmlformats.org/officeDocument/2006/relationships" xmlns:c="http://schemas.openxmlformats.org/drawingml/2006/chart" r:id="R92cd5d21e5254e8e"/>
+            <c:chart xmlns:r="http://schemas.openxmlformats.org/officeDocument/2006/relationships" xmlns:c="http://schemas.openxmlformats.org/drawingml/2006/chart" r:id="Reee7f5e79507469f"/>
           </a:graphicData>
         </a:graphic>
       </p:graphicFrame>
@@ -17038,7 +17041,7 @@
         </p:xfrm>
         <a:graphic xmlns:a="http://schemas.openxmlformats.org/drawingml/2006/main">
           <a:graphicData uri="http://schemas.openxmlformats.org/drawingml/2006/chart">
-            <c:chart xmlns:r="http://schemas.openxmlformats.org/officeDocument/2006/relationships" xmlns:c="http://schemas.openxmlformats.org/drawingml/2006/chart" r:id="Rfd46da7f97d24f7f"/>
+            <c:chart xmlns:r="http://schemas.openxmlformats.org/officeDocument/2006/relationships" xmlns:c="http://schemas.openxmlformats.org/drawingml/2006/chart" r:id="Rcaabf7c24d094946"/>
           </a:graphicData>
         </a:graphic>
       </p:graphicFrame>
@@ -19884,8 +19887,11 @@
           <p:nvPr/>
         </p:nvPicPr>
         <p:blipFill>
-          <a:blip xmlns:r="http://schemas.openxmlformats.org/officeDocument/2006/relationships" xmlns:a="http://schemas.openxmlformats.org/drawingml/2006/main" r:embed="R465893e3f9474936"/>
-          <a:stretch xmlns:a="http://schemas.openxmlformats.org/drawingml/2006/main"/>
+          <a:blip xmlns:r="http://schemas.openxmlformats.org/officeDocument/2006/relationships" xmlns:a="http://schemas.openxmlformats.org/drawingml/2006/main" r:embed="R1eb4d7d509d5461a"/>
+          <a:srcRect xmlns:a="http://schemas.openxmlformats.org/drawingml/2006/main" l="0" t="0" r="0" b="0"/>
+          <a:stretch xmlns:a="http://schemas.openxmlformats.org/drawingml/2006/main">
+            <a:fillRect l="0" t="0" r="0" b="0"/>
+          </a:stretch>
         </p:blipFill>
         <p:spPr>
           <a:xfrm xmlns:a="http://schemas.openxmlformats.org/drawingml/2006/main">
@@ -21041,7 +21047,7 @@
           <p:nvPr/>
         </p:nvPicPr>
         <p:blipFill>
-          <a:blip xmlns:r="http://schemas.openxmlformats.org/officeDocument/2006/relationships" xmlns:a="http://schemas.openxmlformats.org/drawingml/2006/main" r:embed="R30e14317740e459a"/>
+          <a:blip xmlns:r="http://schemas.openxmlformats.org/officeDocument/2006/relationships" xmlns:a="http://schemas.openxmlformats.org/drawingml/2006/main" r:embed="Rb4973caf40734806"/>
           <a:stretch xmlns:a="http://schemas.openxmlformats.org/drawingml/2006/main"/>
         </p:blipFill>
         <p:spPr>
@@ -21102,7 +21108,7 @@
                 <a:latin typeface="Arial"/>
                 <a:ea typeface="Arial"/>
                 <a:cs typeface="Arial"/>
-                <a:hlinkClick xmlns:r="http://schemas.openxmlformats.org/officeDocument/2006/relationships" r:id="Rfc9c8a159c134da5"/>
+                <a:hlinkClick xmlns:r="http://schemas.openxmlformats.org/officeDocument/2006/relationships" r:id="Ra6f8f69dedd047dd"/>
               </a:rPr>
               <a:t>SCAN TO OPEN FINLY</a:t>
             </a:r>
@@ -21760,7 +21766,7 @@
                 <a:latin typeface="Arial"/>
                 <a:ea typeface="Arial"/>
                 <a:cs typeface="Arial"/>
-                <a:hlinkClick xmlns:r="http://schemas.openxmlformats.org/officeDocument/2006/relationships" r:id="R39b3442ed2164de2"/>
+                <a:hlinkClick xmlns:r="http://schemas.openxmlformats.org/officeDocument/2006/relationships" r:id="R86185832c4f746b1"/>
               </a:rPr>
               <a:t>owlsowo.github.io/finly-bot</a:t>
             </a:r>

</xml_diff>

<commit_message>
Lead submission with historical SPY advantage
</commit_message>
<xml_diff>
--- a/public/judge/Finly_Consulting_Deck.pptx
+++ b/public/judge/Finly_Consulting_Deck.pptx
@@ -2,21 +2,21 @@
 <file path=ppt/presentation.xml><?xml version="1.0" encoding="utf-8"?>
 <p:presentation xmlns:p="http://schemas.openxmlformats.org/presentationml/2006/main">
   <p:sldMasterIdLst>
-    <p:sldMasterId xmlns:r="http://schemas.openxmlformats.org/officeDocument/2006/relationships" id="2147483648" r:id="R91283b3828ec4591"/>
+    <p:sldMasterId xmlns:r="http://schemas.openxmlformats.org/officeDocument/2006/relationships" id="2147483648" r:id="Rebbe78f04b114eed"/>
   </p:sldMasterIdLst>
   <p:notesMasterIdLst>
-    <p:notesMasterId xmlns:r="http://schemas.openxmlformats.org/officeDocument/2006/relationships" r:id="R1541216b1e354850"/>
+    <p:notesMasterId xmlns:r="http://schemas.openxmlformats.org/officeDocument/2006/relationships" r:id="Rca8a8f1d5e3d46f0"/>
   </p:notesMasterIdLst>
   <p:sldIdLst>
-    <p:sldId xmlns:r="http://schemas.openxmlformats.org/officeDocument/2006/relationships" id="256" r:id="Rf6251981b79f4f57"/>
-    <p:sldId xmlns:r="http://schemas.openxmlformats.org/officeDocument/2006/relationships" id="257" r:id="R92857efcf09440f2"/>
-    <p:sldId xmlns:r="http://schemas.openxmlformats.org/officeDocument/2006/relationships" id="258" r:id="R195b1c396547484a"/>
-    <p:sldId xmlns:r="http://schemas.openxmlformats.org/officeDocument/2006/relationships" id="259" r:id="R6c3d80107b654fb5"/>
-    <p:sldId xmlns:r="http://schemas.openxmlformats.org/officeDocument/2006/relationships" id="260" r:id="R1a283114be334305"/>
-    <p:sldId xmlns:r="http://schemas.openxmlformats.org/officeDocument/2006/relationships" id="261" r:id="R0fd799948e1b49b7"/>
-    <p:sldId xmlns:r="http://schemas.openxmlformats.org/officeDocument/2006/relationships" id="262" r:id="Re91ecbe380d34cb9"/>
-    <p:sldId xmlns:r="http://schemas.openxmlformats.org/officeDocument/2006/relationships" id="263" r:id="Rb6487ca5044747c4"/>
-    <p:sldId xmlns:r="http://schemas.openxmlformats.org/officeDocument/2006/relationships" id="264" r:id="Rfbbe38c899ac4eff"/>
+    <p:sldId xmlns:r="http://schemas.openxmlformats.org/officeDocument/2006/relationships" id="256" r:id="Redd0969a76114319"/>
+    <p:sldId xmlns:r="http://schemas.openxmlformats.org/officeDocument/2006/relationships" id="257" r:id="R33811576ea544c56"/>
+    <p:sldId xmlns:r="http://schemas.openxmlformats.org/officeDocument/2006/relationships" id="258" r:id="R76293acc265943cc"/>
+    <p:sldId xmlns:r="http://schemas.openxmlformats.org/officeDocument/2006/relationships" id="259" r:id="R9d38ec2053d145e0"/>
+    <p:sldId xmlns:r="http://schemas.openxmlformats.org/officeDocument/2006/relationships" id="260" r:id="R43d85ff21c38427c"/>
+    <p:sldId xmlns:r="http://schemas.openxmlformats.org/officeDocument/2006/relationships" id="261" r:id="R2b3010a07a2f4d0b"/>
+    <p:sldId xmlns:r="http://schemas.openxmlformats.org/officeDocument/2006/relationships" id="262" r:id="R6716859556b2467b"/>
+    <p:sldId xmlns:r="http://schemas.openxmlformats.org/officeDocument/2006/relationships" id="263" r:id="R136e481041f24e21"/>
+    <p:sldId xmlns:r="http://schemas.openxmlformats.org/officeDocument/2006/relationships" id="264" r:id="R631cd177f5184b01"/>
   </p:sldIdLst>
   <p:sldSz cx="12192000" cy="6858000"/>
   <p:notesSz cx="6858000" cy="9144000"/>
@@ -1258,7 +1258,7 @@
   </p:cSld>
   <p:clrMap bg1="lt1" tx1="dk1" bg2="lt2" tx2="dk2" accent1="accent1" accent2="accent2" accent3="accent3" accent4="accent4" accent5="accent5" accent6="accent6" hlink="hlink" folHlink="folHlink"/>
   <p:sldLayoutIdLst>
-    <p:sldLayoutId xmlns:r="http://schemas.openxmlformats.org/officeDocument/2006/relationships" id="2147483649" r:id="R8f4cfbe0ac794412"/>
+    <p:sldLayoutId xmlns:r="http://schemas.openxmlformats.org/officeDocument/2006/relationships" id="2147483649" r:id="R0430a9c0a66a455a"/>
   </p:sldLayoutIdLst>
   <p:txStyles>
     <p:titleStyle>
@@ -2843,7 +2843,7 @@
           <p:nvPr/>
         </p:nvPicPr>
         <p:blipFill>
-          <a:blip xmlns:r="http://schemas.openxmlformats.org/officeDocument/2006/relationships" xmlns:a="http://schemas.openxmlformats.org/drawingml/2006/main" r:embed="Rb71f38b7ba164729"/>
+          <a:blip xmlns:r="http://schemas.openxmlformats.org/officeDocument/2006/relationships" xmlns:a="http://schemas.openxmlformats.org/drawingml/2006/main" r:embed="R450a8d8907534736"/>
           <a:stretch xmlns:a="http://schemas.openxmlformats.org/drawingml/2006/main"/>
         </p:blipFill>
         <p:spPr>
@@ -2861,7 +2861,7 @@
           <p:cNvPr id="2" name="">
             <a:extLst xmlns:a="http://schemas.openxmlformats.org/drawingml/2006/main">
               <a:ext uri="{FF2B5EF4-FFF2-40B4-BE49-F238E27FC236}">
-                <a16:creationId xmlns:a16="http://schemas.microsoft.com/office/drawing/2014/main" id="{216B6D20-2CB7-481D-BFC3-F94DC963CB30}"/>
+                <a16:creationId xmlns:a16="http://schemas.microsoft.com/office/drawing/2014/main" id="{50BCC831-8E0E-4CD5-BECF-8F13B22F4361}"/>
               </a:ext>
             </a:extLst>
           </p:cNvPr>
@@ -2911,7 +2911,7 @@
           <p:cNvPr id="3" name="">
             <a:extLst xmlns:a="http://schemas.openxmlformats.org/drawingml/2006/main">
               <a:ext uri="{FF2B5EF4-FFF2-40B4-BE49-F238E27FC236}">
-                <a16:creationId xmlns:a16="http://schemas.microsoft.com/office/drawing/2014/main" id="{F62AA568-722C-4749-8230-A17DEC08555D}"/>
+                <a16:creationId xmlns:a16="http://schemas.microsoft.com/office/drawing/2014/main" id="{FCC153D6-F897-4DEC-B634-35DDD41E5719}"/>
               </a:ext>
             </a:extLst>
           </p:cNvPr>
@@ -2951,7 +2951,7 @@
                   <a:srgbClr val="B9DFD2"/>
                 </a:solidFill>
               </a:rPr>
-              <a:t>ONE AUTONOMOUS STRATEGY · TWO COORDINATED SLEEVES</a:t>
+              <a:t>2013–2026 HISTORICAL SIMULATION · AFTER MODELED COSTS</a:t>
             </a:r>
           </a:p>
         </p:txBody>
@@ -2961,7 +2961,7 @@
           <p:cNvPr id="4" name="">
             <a:extLst xmlns:a="http://schemas.openxmlformats.org/drawingml/2006/main">
               <a:ext uri="{FF2B5EF4-FFF2-40B4-BE49-F238E27FC236}">
-                <a16:creationId xmlns:a16="http://schemas.microsoft.com/office/drawing/2014/main" id="{5E8B6205-36AA-41FD-9354-79B3EA38DD65}"/>
+                <a16:creationId xmlns:a16="http://schemas.microsoft.com/office/drawing/2014/main" id="{00AE9883-D1DD-4BF9-918A-63717C4C9E83}"/>
               </a:ext>
             </a:extLst>
           </p:cNvPr>
@@ -2989,19 +2989,19 @@
           <a:lstStyle xmlns:a="http://schemas.openxmlformats.org/drawingml/2006/main"/>
           <a:p xmlns:a="http://schemas.openxmlformats.org/drawingml/2006/main">
             <a:pPr algn="l">
-              <a:defRPr sz="3600" b="1" i="0">
+              <a:defRPr sz="4050" b="1" i="0">
                 <a:solidFill>
                   <a:srgbClr val="FFFFFF"/>
                 </a:solidFill>
               </a:defRPr>
             </a:pPr>
             <a:r>
-              <a:rPr sz="3600" b="1" i="0">
+              <a:rPr sz="4050" b="1" i="0">
                 <a:solidFill>
                   <a:srgbClr val="FFFFFF"/>
                 </a:solidFill>
               </a:rPr>
-              <a:t>Finly pairs a tested allocation with capped-risk AI options.</a:t>
+              <a:t>Finly finished $38,629 ahead of SPY.</a:t>
             </a:r>
           </a:p>
         </p:txBody>
@@ -3011,19 +3011,19 @@
           <p:cNvPr id="5" name="">
             <a:extLst xmlns:a="http://schemas.openxmlformats.org/drawingml/2006/main">
               <a:ext uri="{FF2B5EF4-FFF2-40B4-BE49-F238E27FC236}">
-                <a16:creationId xmlns:a16="http://schemas.microsoft.com/office/drawing/2014/main" id="{7546C301-E410-4BEF-95F8-7DC2B38012CA}"/>
-              </a:ext>
-            </a:extLst>
-          </p:cNvPr>
-          <p:cNvSpPr>
-            <a:spLocks xmlns:a="http://schemas.openxmlformats.org/drawingml/2006/main" noGrp="1"/>
-          </p:cNvSpPr>
-          <p:nvPr/>
-        </p:nvSpPr>
-        <p:spPr>
-          <a:xfrm xmlns:a="http://schemas.openxmlformats.org/drawingml/2006/main">
-            <a:off x="609600" y="3962400"/>
-            <a:ext cx="4953000" cy="876300"/>
+                <a16:creationId xmlns:a16="http://schemas.microsoft.com/office/drawing/2014/main" id="{6DCC88D2-A8EB-428A-8AD8-397A9FBF4BFC}"/>
+              </a:ext>
+            </a:extLst>
+          </p:cNvPr>
+          <p:cNvSpPr>
+            <a:spLocks xmlns:a="http://schemas.openxmlformats.org/drawingml/2006/main" noGrp="1"/>
+          </p:cNvSpPr>
+          <p:nvPr/>
+        </p:nvSpPr>
+        <p:spPr>
+          <a:xfrm xmlns:a="http://schemas.openxmlformats.org/drawingml/2006/main">
+            <a:off x="609600" y="3810000"/>
+            <a:ext cx="5048250" cy="1028700"/>
           </a:xfrm>
           <a:prstGeom xmlns:a="http://schemas.openxmlformats.org/drawingml/2006/main" prst="rect">
             <a:avLst/>
@@ -3039,19 +3039,19 @@
           <a:lstStyle xmlns:a="http://schemas.openxmlformats.org/drawingml/2006/main"/>
           <a:p xmlns:a="http://schemas.openxmlformats.org/drawingml/2006/main">
             <a:pPr algn="l">
-              <a:defRPr sz="1650" b="0" i="0">
+              <a:defRPr sz="1575" b="0" i="0">
                 <a:solidFill>
                   <a:srgbClr val="D7E3E5"/>
                 </a:solidFill>
               </a:defRPr>
             </a:pPr>
             <a:r>
-              <a:rPr sz="1650" b="0" i="0">
+              <a:rPr sz="1575" b="0" i="0">
                 <a:solidFill>
                   <a:srgbClr val="D7E3E5"/>
                 </a:solidFill>
               </a:rPr>
-              <a:t>The allocation keeps the account invested. AI studies small options trades; fixed rules cap the risk and can still stop them.</a:t>
+              <a:t>The same $10,000 became $106,711 with Finly and $68,082 with the S&amp;P 500 tracker. The strategy now runs as a checked Alpaca paper-trading product.</a:t>
             </a:r>
           </a:p>
         </p:txBody>
@@ -3061,7 +3061,7 @@
           <p:cNvPr id="6" name="">
             <a:extLst xmlns:a="http://schemas.openxmlformats.org/drawingml/2006/main">
               <a:ext uri="{FF2B5EF4-FFF2-40B4-BE49-F238E27FC236}">
-                <a16:creationId xmlns:a16="http://schemas.microsoft.com/office/drawing/2014/main" id="{E363DEA9-0CA9-49A8-8F64-991335483004}"/>
+                <a16:creationId xmlns:a16="http://schemas.microsoft.com/office/drawing/2014/main" id="{F32AB83E-36F4-4E97-B4EC-ECDA1FA603A2}"/>
               </a:ext>
             </a:extLst>
           </p:cNvPr>
@@ -3096,7 +3096,7 @@
           <p:nvPr/>
         </p:nvPicPr>
         <p:blipFill>
-          <a:blip xmlns:r="http://schemas.openxmlformats.org/officeDocument/2006/relationships" xmlns:a="http://schemas.openxmlformats.org/drawingml/2006/main" r:embed="Ra6aacb04593741bf"/>
+          <a:blip xmlns:r="http://schemas.openxmlformats.org/officeDocument/2006/relationships" xmlns:a="http://schemas.openxmlformats.org/drawingml/2006/main" r:embed="R7cd7a5cbd99149ef"/>
           <a:stretch xmlns:a="http://schemas.openxmlformats.org/drawingml/2006/main"/>
         </p:blipFill>
         <p:spPr>
@@ -3114,7 +3114,7 @@
           <p:cNvPr id="8" name="">
             <a:extLst xmlns:a="http://schemas.openxmlformats.org/drawingml/2006/main">
               <a:ext uri="{FF2B5EF4-FFF2-40B4-BE49-F238E27FC236}">
-                <a16:creationId xmlns:a16="http://schemas.microsoft.com/office/drawing/2014/main" id="{99E9CF36-81E0-48C1-AAAA-16A313A0AB68}"/>
+                <a16:creationId xmlns:a16="http://schemas.microsoft.com/office/drawing/2014/main" id="{C2A8343C-600E-4C76-9115-981F37727A44}"/>
               </a:ext>
             </a:extLst>
           </p:cNvPr>
@@ -3164,7 +3164,7 @@
           <p:cNvPr id="9" name="">
             <a:extLst xmlns:a="http://schemas.openxmlformats.org/drawingml/2006/main">
               <a:ext uri="{FF2B5EF4-FFF2-40B4-BE49-F238E27FC236}">
-                <a16:creationId xmlns:a16="http://schemas.microsoft.com/office/drawing/2014/main" id="{F528CDE0-2D7E-414F-95AB-7DBDACD6C428}"/>
+                <a16:creationId xmlns:a16="http://schemas.microsoft.com/office/drawing/2014/main" id="{AF440823-C12B-425A-9EE6-C4771AAAC3DF}"/>
               </a:ext>
             </a:extLst>
           </p:cNvPr>
@@ -3214,7 +3214,7 @@
           <p:cNvPr id="10" name="">
             <a:extLst xmlns:a="http://schemas.openxmlformats.org/drawingml/2006/main">
               <a:ext uri="{FF2B5EF4-FFF2-40B4-BE49-F238E27FC236}">
-                <a16:creationId xmlns:a16="http://schemas.microsoft.com/office/drawing/2014/main" id="{7326AC69-B4B8-4E85-A14E-2A65232FD7B9}"/>
+                <a16:creationId xmlns:a16="http://schemas.microsoft.com/office/drawing/2014/main" id="{4E5BF725-7FE9-4AEA-AE44-CD4853A59ACC}"/>
               </a:ext>
             </a:extLst>
           </p:cNvPr>
@@ -3245,7 +3245,7 @@
           <p:cNvPr id="11" name="">
             <a:extLst xmlns:a="http://schemas.openxmlformats.org/drawingml/2006/main">
               <a:ext uri="{FF2B5EF4-FFF2-40B4-BE49-F238E27FC236}">
-                <a16:creationId xmlns:a16="http://schemas.microsoft.com/office/drawing/2014/main" id="{4BA39BAD-024C-4AA4-8B9B-E77A75D607B7}"/>
+                <a16:creationId xmlns:a16="http://schemas.microsoft.com/office/drawing/2014/main" id="{9A16A642-6BE4-41F8-910D-2DBE93629B1C}"/>
               </a:ext>
             </a:extLst>
           </p:cNvPr>
@@ -3295,7 +3295,7 @@
           <p:cNvPr id="12" name="">
             <a:extLst xmlns:a="http://schemas.openxmlformats.org/drawingml/2006/main">
               <a:ext uri="{FF2B5EF4-FFF2-40B4-BE49-F238E27FC236}">
-                <a16:creationId xmlns:a16="http://schemas.microsoft.com/office/drawing/2014/main" id="{227D95CB-7DDF-4BA7-8B63-177E2D479E7D}"/>
+                <a16:creationId xmlns:a16="http://schemas.microsoft.com/office/drawing/2014/main" id="{96F30A4A-97CD-4672-B33D-565891C16A8B}"/>
               </a:ext>
             </a:extLst>
           </p:cNvPr>
@@ -3323,19 +3323,19 @@
           <a:lstStyle xmlns:a="http://schemas.openxmlformats.org/drawingml/2006/main"/>
           <a:p xmlns:a="http://schemas.openxmlformats.org/drawingml/2006/main">
             <a:pPr algn="l">
-              <a:defRPr sz="1125" b="1" i="0">
+              <a:defRPr sz="900" b="1" i="0">
                 <a:solidFill>
                   <a:srgbClr val="C5D4D8"/>
                 </a:solidFill>
               </a:defRPr>
             </a:pPr>
             <a:r>
-              <a:rPr sz="1125" b="1" i="0">
+              <a:rPr sz="900" b="1" i="0">
                 <a:solidFill>
                   <a:srgbClr val="C5D4D8"/>
                 </a:solidFill>
               </a:rPr>
-              <a:t>HISTORICAL ENDING WEALTH</a:t>
+              <a:t>FINLY HISTORICAL ENDING WEALTH</a:t>
             </a:r>
           </a:p>
         </p:txBody>
@@ -3345,7 +3345,7 @@
           <p:cNvPr id="13" name="">
             <a:extLst xmlns:a="http://schemas.openxmlformats.org/drawingml/2006/main">
               <a:ext uri="{FF2B5EF4-FFF2-40B4-BE49-F238E27FC236}">
-                <a16:creationId xmlns:a16="http://schemas.microsoft.com/office/drawing/2014/main" id="{54F41F16-BDB9-4FC6-94FC-5FBB08ABC842}"/>
+                <a16:creationId xmlns:a16="http://schemas.microsoft.com/office/drawing/2014/main" id="{3DF342DB-6994-45D2-8E3B-552C47A6AE56}"/>
               </a:ext>
             </a:extLst>
           </p:cNvPr>
@@ -3385,7 +3385,7 @@
                   <a:srgbClr val="FFFFFF"/>
                 </a:solidFill>
               </a:rPr>
-              <a:t>+$38,629</a:t>
+              <a:t>$68,082</a:t>
             </a:r>
           </a:p>
         </p:txBody>
@@ -3395,7 +3395,7 @@
           <p:cNvPr id="14" name="">
             <a:extLst xmlns:a="http://schemas.openxmlformats.org/drawingml/2006/main">
               <a:ext uri="{FF2B5EF4-FFF2-40B4-BE49-F238E27FC236}">
-                <a16:creationId xmlns:a16="http://schemas.microsoft.com/office/drawing/2014/main" id="{4A94EBC1-2497-4386-B5CC-FB3B674FB78F}"/>
+                <a16:creationId xmlns:a16="http://schemas.microsoft.com/office/drawing/2014/main" id="{AA0E952C-0F26-4251-84D8-B07A41E12F8B}"/>
               </a:ext>
             </a:extLst>
           </p:cNvPr>
@@ -3435,7 +3435,7 @@
                   <a:srgbClr val="C5D4D8"/>
                 </a:solidFill>
               </a:rPr>
-              <a:t>VERSUS THE S&amp;P 500 TRACKER</a:t>
+              <a:t>SPY HISTORICAL ENDING WEALTH</a:t>
             </a:r>
           </a:p>
         </p:txBody>
@@ -3445,7 +3445,7 @@
           <p:cNvPr id="15" name="">
             <a:extLst xmlns:a="http://schemas.openxmlformats.org/drawingml/2006/main">
               <a:ext uri="{FF2B5EF4-FFF2-40B4-BE49-F238E27FC236}">
-                <a16:creationId xmlns:a16="http://schemas.microsoft.com/office/drawing/2014/main" id="{5F21FB9A-B4EA-4771-92FB-670BD2C364DD}"/>
+                <a16:creationId xmlns:a16="http://schemas.microsoft.com/office/drawing/2014/main" id="{CEED0FC8-0BC8-497A-990D-1CCFE53D9258}"/>
               </a:ext>
             </a:extLst>
           </p:cNvPr>
@@ -3495,7 +3495,7 @@
           <p:cNvPr id="16" name="">
             <a:extLst xmlns:a="http://schemas.openxmlformats.org/drawingml/2006/main">
               <a:ext uri="{FF2B5EF4-FFF2-40B4-BE49-F238E27FC236}">
-                <a16:creationId xmlns:a16="http://schemas.microsoft.com/office/drawing/2014/main" id="{A5CE90B2-854A-48D6-AB24-FF38A68B7995}"/>
+                <a16:creationId xmlns:a16="http://schemas.microsoft.com/office/drawing/2014/main" id="{8CBE0629-C950-49D3-B1F7-F073C5FB8900}"/>
               </a:ext>
             </a:extLst>
           </p:cNvPr>
@@ -3535,7 +3535,7 @@
                   <a:srgbClr val="C5D4D8"/>
                 </a:solidFill>
               </a:rPr>
-              <a:t>VS SPY THROUGH SEP 2</a:t>
+              <a:t>SEPARATE LIVE PAPER ADVANTAGE</a:t>
             </a:r>
           </a:p>
         </p:txBody>
@@ -3545,7 +3545,7 @@
           <p:cNvPr id="17" name="">
             <a:extLst xmlns:a="http://schemas.openxmlformats.org/drawingml/2006/main">
               <a:ext uri="{FF2B5EF4-FFF2-40B4-BE49-F238E27FC236}">
-                <a16:creationId xmlns:a16="http://schemas.microsoft.com/office/drawing/2014/main" id="{F7325751-8751-47CE-B8F3-5CB5B05463C1}"/>
+                <a16:creationId xmlns:a16="http://schemas.microsoft.com/office/drawing/2014/main" id="{31CF0A75-E9DC-4FAD-80B8-1BFF8DE36365}"/>
               </a:ext>
             </a:extLst>
           </p:cNvPr>
@@ -3595,7 +3595,7 @@
           <p:cNvPr id="18" name="">
             <a:extLst xmlns:a="http://schemas.openxmlformats.org/drawingml/2006/main">
               <a:ext uri="{FF2B5EF4-FFF2-40B4-BE49-F238E27FC236}">
-                <a16:creationId xmlns:a16="http://schemas.microsoft.com/office/drawing/2014/main" id="{C83725EF-0633-469C-B01A-45D169191EFF}"/>
+                <a16:creationId xmlns:a16="http://schemas.microsoft.com/office/drawing/2014/main" id="{9AD7BC5C-006D-4CB3-BB0C-502306754741}"/>
               </a:ext>
             </a:extLst>
           </p:cNvPr>
@@ -3645,7 +3645,7 @@
           <p:cNvPr id="19" name="">
             <a:extLst xmlns:a="http://schemas.openxmlformats.org/drawingml/2006/main">
               <a:ext uri="{FF2B5EF4-FFF2-40B4-BE49-F238E27FC236}">
-                <a16:creationId xmlns:a16="http://schemas.microsoft.com/office/drawing/2014/main" id="{20387ABF-6FF5-4F37-97AA-BD3813B906A5}"/>
+                <a16:creationId xmlns:a16="http://schemas.microsoft.com/office/drawing/2014/main" id="{232F9DD4-E1C6-420E-A283-CB40C708A610}"/>
               </a:ext>
             </a:extLst>
           </p:cNvPr>
@@ -3695,7 +3695,7 @@
           <p:cNvPr id="20" name="">
             <a:extLst xmlns:a="http://schemas.openxmlformats.org/drawingml/2006/main">
               <a:ext uri="{FF2B5EF4-FFF2-40B4-BE49-F238E27FC236}">
-                <a16:creationId xmlns:a16="http://schemas.microsoft.com/office/drawing/2014/main" id="{C676C241-DBF2-46BB-98E3-CEE73C3FFC63}"/>
+                <a16:creationId xmlns:a16="http://schemas.microsoft.com/office/drawing/2014/main" id="{E01DC580-6866-41A7-897A-75CFAEB2A30D}"/>
               </a:ext>
             </a:extLst>
           </p:cNvPr>
@@ -3745,7 +3745,7 @@
           <p:cNvPr id="21" name="">
             <a:extLst xmlns:a="http://schemas.openxmlformats.org/drawingml/2006/main">
               <a:ext uri="{FF2B5EF4-FFF2-40B4-BE49-F238E27FC236}">
-                <a16:creationId xmlns:a16="http://schemas.microsoft.com/office/drawing/2014/main" id="{D990B391-7F7E-45BD-ABE0-614755B8E09D}"/>
+                <a16:creationId xmlns:a16="http://schemas.microsoft.com/office/drawing/2014/main" id="{09C19FC1-F0CB-462F-AFA9-9E6239C4149E}"/>
               </a:ext>
             </a:extLst>
           </p:cNvPr>
@@ -3793,7 +3793,7 @@
     </p:spTree>
     <p:extLst>
       <p:ext uri="{BB962C8B-B14F-4D97-AF65-F5344CB8AC3E}">
-        <p14:creationId xmlns:p14="http://schemas.microsoft.com/office/powerpoint/2010/main" val="161856420"/>
+        <p14:creationId xmlns:p14="http://schemas.microsoft.com/office/powerpoint/2010/main" val="913717845"/>
       </p:ext>
     </p:extLst>
   </p:cSld>
@@ -3824,7 +3824,7 @@
           <p:cNvPr id="31" name="">
             <a:extLst xmlns:a="http://schemas.openxmlformats.org/drawingml/2006/main">
               <a:ext uri="{FF2B5EF4-FFF2-40B4-BE49-F238E27FC236}">
-                <a16:creationId xmlns:a16="http://schemas.microsoft.com/office/drawing/2014/main" id="{9EF5FB2C-2D24-4A93-83DC-B64106AD0EE0}"/>
+                <a16:creationId xmlns:a16="http://schemas.microsoft.com/office/drawing/2014/main" id="{D612C70C-C7C2-408F-B95C-C9B91BACD8F4}"/>
               </a:ext>
             </a:extLst>
           </p:cNvPr>
@@ -3874,7 +3874,7 @@
           <p:cNvPr id="2" name="">
             <a:extLst xmlns:a="http://schemas.openxmlformats.org/drawingml/2006/main">
               <a:ext uri="{FF2B5EF4-FFF2-40B4-BE49-F238E27FC236}">
-                <a16:creationId xmlns:a16="http://schemas.microsoft.com/office/drawing/2014/main" id="{B81CD92B-B27B-44AA-9EA8-6B19B8817D5D}"/>
+                <a16:creationId xmlns:a16="http://schemas.microsoft.com/office/drawing/2014/main" id="{7A3AB7B4-18E3-4B02-8CDE-BD37A195539E}"/>
               </a:ext>
             </a:extLst>
           </p:cNvPr>
@@ -3924,7 +3924,7 @@
           <p:cNvPr id="3" name="">
             <a:extLst xmlns:a="http://schemas.openxmlformats.org/drawingml/2006/main">
               <a:ext uri="{FF2B5EF4-FFF2-40B4-BE49-F238E27FC236}">
-                <a16:creationId xmlns:a16="http://schemas.microsoft.com/office/drawing/2014/main" id="{BADBDF30-9763-4440-B625-F561AB79A86C}"/>
+                <a16:creationId xmlns:a16="http://schemas.microsoft.com/office/drawing/2014/main" id="{58A608EE-3A01-4BC1-99CC-4B4737C52935}"/>
               </a:ext>
             </a:extLst>
           </p:cNvPr>
@@ -3974,7 +3974,7 @@
           <p:cNvPr id="4" name="">
             <a:extLst xmlns:a="http://schemas.openxmlformats.org/drawingml/2006/main">
               <a:ext uri="{FF2B5EF4-FFF2-40B4-BE49-F238E27FC236}">
-                <a16:creationId xmlns:a16="http://schemas.microsoft.com/office/drawing/2014/main" id="{2FC54872-F2D1-426C-B08E-ACFED422FEF5}"/>
+                <a16:creationId xmlns:a16="http://schemas.microsoft.com/office/drawing/2014/main" id="{E16F7E99-44DA-475F-BB10-FCA3CF415ECE}"/>
               </a:ext>
             </a:extLst>
           </p:cNvPr>
@@ -4009,7 +4009,7 @@
           <p:cNvPr id="5" name="">
             <a:extLst xmlns:a="http://schemas.openxmlformats.org/drawingml/2006/main">
               <a:ext uri="{FF2B5EF4-FFF2-40B4-BE49-F238E27FC236}">
-                <a16:creationId xmlns:a16="http://schemas.microsoft.com/office/drawing/2014/main" id="{C95880CB-46EC-481A-ADEB-59B6FBCF18C5}"/>
+                <a16:creationId xmlns:a16="http://schemas.microsoft.com/office/drawing/2014/main" id="{828B1DD4-3A12-4FC4-8FDB-B1C3FE95AA63}"/>
               </a:ext>
             </a:extLst>
           </p:cNvPr>
@@ -4059,7 +4059,7 @@
           <p:cNvPr id="6" name="">
             <a:extLst xmlns:a="http://schemas.openxmlformats.org/drawingml/2006/main">
               <a:ext uri="{FF2B5EF4-FFF2-40B4-BE49-F238E27FC236}">
-                <a16:creationId xmlns:a16="http://schemas.microsoft.com/office/drawing/2014/main" id="{87D56CF1-173C-4B71-83B5-54B34968DF46}"/>
+                <a16:creationId xmlns:a16="http://schemas.microsoft.com/office/drawing/2014/main" id="{64EE7131-F065-46E0-9DAE-9537053D96F5}"/>
               </a:ext>
             </a:extLst>
           </p:cNvPr>
@@ -4109,7 +4109,7 @@
           <p:cNvPr id="7" name="">
             <a:extLst xmlns:a="http://schemas.openxmlformats.org/drawingml/2006/main">
               <a:ext uri="{FF2B5EF4-FFF2-40B4-BE49-F238E27FC236}">
-                <a16:creationId xmlns:a16="http://schemas.microsoft.com/office/drawing/2014/main" id="{536386F1-55A7-49AB-9742-100AE3926201}"/>
+                <a16:creationId xmlns:a16="http://schemas.microsoft.com/office/drawing/2014/main" id="{90338800-116F-4CE9-9130-7CDD51DBF073}"/>
               </a:ext>
             </a:extLst>
           </p:cNvPr>
@@ -4159,7 +4159,7 @@
           <p:cNvPr id="8" name="">
             <a:extLst xmlns:a="http://schemas.openxmlformats.org/drawingml/2006/main">
               <a:ext uri="{FF2B5EF4-FFF2-40B4-BE49-F238E27FC236}">
-                <a16:creationId xmlns:a16="http://schemas.microsoft.com/office/drawing/2014/main" id="{762AA3CA-A237-4A2B-972A-0A856144F07E}"/>
+                <a16:creationId xmlns:a16="http://schemas.microsoft.com/office/drawing/2014/main" id="{820485FA-D55F-4F9D-B369-21B37E243791}"/>
               </a:ext>
             </a:extLst>
           </p:cNvPr>
@@ -4194,7 +4194,7 @@
           <p:cNvPr id="9" name="">
             <a:extLst xmlns:a="http://schemas.openxmlformats.org/drawingml/2006/main">
               <a:ext uri="{FF2B5EF4-FFF2-40B4-BE49-F238E27FC236}">
-                <a16:creationId xmlns:a16="http://schemas.microsoft.com/office/drawing/2014/main" id="{2B396236-1225-4E49-9AE0-26EF0470C051}"/>
+                <a16:creationId xmlns:a16="http://schemas.microsoft.com/office/drawing/2014/main" id="{E643C897-22ED-4F7C-A98A-B61F4852A10D}"/>
               </a:ext>
             </a:extLst>
           </p:cNvPr>
@@ -4244,7 +4244,7 @@
           <p:cNvPr id="10" name="">
             <a:extLst xmlns:a="http://schemas.openxmlformats.org/drawingml/2006/main">
               <a:ext uri="{FF2B5EF4-FFF2-40B4-BE49-F238E27FC236}">
-                <a16:creationId xmlns:a16="http://schemas.microsoft.com/office/drawing/2014/main" id="{687E9189-BB54-44E8-B713-49EDD9195139}"/>
+                <a16:creationId xmlns:a16="http://schemas.microsoft.com/office/drawing/2014/main" id="{34B58156-1462-46FD-936C-A84A6F4296CB}"/>
               </a:ext>
             </a:extLst>
           </p:cNvPr>
@@ -4294,7 +4294,7 @@
           <p:cNvPr id="11" name="">
             <a:extLst xmlns:a="http://schemas.openxmlformats.org/drawingml/2006/main">
               <a:ext uri="{FF2B5EF4-FFF2-40B4-BE49-F238E27FC236}">
-                <a16:creationId xmlns:a16="http://schemas.microsoft.com/office/drawing/2014/main" id="{E45B397C-42B2-4476-BA79-09DADF865CB8}"/>
+                <a16:creationId xmlns:a16="http://schemas.microsoft.com/office/drawing/2014/main" id="{1BF8648C-688A-4AB7-B2EC-8D4AD08D286C}"/>
               </a:ext>
             </a:extLst>
           </p:cNvPr>
@@ -4344,7 +4344,7 @@
           <p:cNvPr id="12" name="">
             <a:extLst xmlns:a="http://schemas.openxmlformats.org/drawingml/2006/main">
               <a:ext uri="{FF2B5EF4-FFF2-40B4-BE49-F238E27FC236}">
-                <a16:creationId xmlns:a16="http://schemas.microsoft.com/office/drawing/2014/main" id="{145662D2-196A-4586-9091-259BAFCBF0EA}"/>
+                <a16:creationId xmlns:a16="http://schemas.microsoft.com/office/drawing/2014/main" id="{A833F53F-1F5F-48C2-A1FC-6529CE8310B2}"/>
               </a:ext>
             </a:extLst>
           </p:cNvPr>
@@ -4379,7 +4379,7 @@
           <p:cNvPr id="13" name="">
             <a:extLst xmlns:a="http://schemas.openxmlformats.org/drawingml/2006/main">
               <a:ext uri="{FF2B5EF4-FFF2-40B4-BE49-F238E27FC236}">
-                <a16:creationId xmlns:a16="http://schemas.microsoft.com/office/drawing/2014/main" id="{497FD765-7D37-4D57-A614-01247B1952DA}"/>
+                <a16:creationId xmlns:a16="http://schemas.microsoft.com/office/drawing/2014/main" id="{0895FFC5-AA4E-4C1F-A9C0-304A25EFCA18}"/>
               </a:ext>
             </a:extLst>
           </p:cNvPr>
@@ -4429,7 +4429,7 @@
           <p:cNvPr id="14" name="">
             <a:extLst xmlns:a="http://schemas.openxmlformats.org/drawingml/2006/main">
               <a:ext uri="{FF2B5EF4-FFF2-40B4-BE49-F238E27FC236}">
-                <a16:creationId xmlns:a16="http://schemas.microsoft.com/office/drawing/2014/main" id="{E0B62CF1-2B1F-4799-A929-356A127211D8}"/>
+                <a16:creationId xmlns:a16="http://schemas.microsoft.com/office/drawing/2014/main" id="{2B7A132A-8192-49D0-ABB7-D054A4C4C5DE}"/>
               </a:ext>
             </a:extLst>
           </p:cNvPr>
@@ -4479,7 +4479,7 @@
           <p:cNvPr id="15" name="">
             <a:extLst xmlns:a="http://schemas.openxmlformats.org/drawingml/2006/main">
               <a:ext uri="{FF2B5EF4-FFF2-40B4-BE49-F238E27FC236}">
-                <a16:creationId xmlns:a16="http://schemas.microsoft.com/office/drawing/2014/main" id="{AC6B7EC0-6CFD-43E5-96F0-73E2AD63D849}"/>
+                <a16:creationId xmlns:a16="http://schemas.microsoft.com/office/drawing/2014/main" id="{A0D55616-7347-45D4-9BE6-384F346DD2CD}"/>
               </a:ext>
             </a:extLst>
           </p:cNvPr>
@@ -4529,7 +4529,7 @@
           <p:cNvPr id="16" name="">
             <a:extLst xmlns:a="http://schemas.openxmlformats.org/drawingml/2006/main">
               <a:ext uri="{FF2B5EF4-FFF2-40B4-BE49-F238E27FC236}">
-                <a16:creationId xmlns:a16="http://schemas.microsoft.com/office/drawing/2014/main" id="{07C90F2B-2753-4665-98F2-7253C9060B1B}"/>
+                <a16:creationId xmlns:a16="http://schemas.microsoft.com/office/drawing/2014/main" id="{E5C46DE6-1056-4825-B7FF-20C2742BA6E4}"/>
               </a:ext>
             </a:extLst>
           </p:cNvPr>
@@ -4564,7 +4564,7 @@
           <p:cNvPr id="17" name="">
             <a:extLst xmlns:a="http://schemas.openxmlformats.org/drawingml/2006/main">
               <a:ext uri="{FF2B5EF4-FFF2-40B4-BE49-F238E27FC236}">
-                <a16:creationId xmlns:a16="http://schemas.microsoft.com/office/drawing/2014/main" id="{798AD721-CDC4-4AB7-84F2-1BF921552200}"/>
+                <a16:creationId xmlns:a16="http://schemas.microsoft.com/office/drawing/2014/main" id="{4E292862-5C8B-4D35-94DA-96D3BEB5A69E}"/>
               </a:ext>
             </a:extLst>
           </p:cNvPr>
@@ -4614,7 +4614,7 @@
           <p:cNvPr id="18" name="">
             <a:extLst xmlns:a="http://schemas.openxmlformats.org/drawingml/2006/main">
               <a:ext uri="{FF2B5EF4-FFF2-40B4-BE49-F238E27FC236}">
-                <a16:creationId xmlns:a16="http://schemas.microsoft.com/office/drawing/2014/main" id="{9F25F3AE-157B-4A8A-A076-376FC882FBCA}"/>
+                <a16:creationId xmlns:a16="http://schemas.microsoft.com/office/drawing/2014/main" id="{9D7409D6-14A5-474F-87A3-6B21C8D62025}"/>
               </a:ext>
             </a:extLst>
           </p:cNvPr>
@@ -4664,7 +4664,7 @@
           <p:cNvPr id="19" name="">
             <a:extLst xmlns:a="http://schemas.openxmlformats.org/drawingml/2006/main">
               <a:ext uri="{FF2B5EF4-FFF2-40B4-BE49-F238E27FC236}">
-                <a16:creationId xmlns:a16="http://schemas.microsoft.com/office/drawing/2014/main" id="{B8FF5112-F724-46AF-A636-65AD2ABB9757}"/>
+                <a16:creationId xmlns:a16="http://schemas.microsoft.com/office/drawing/2014/main" id="{573CCB1E-CD90-49CF-AF13-6C036AF9ED62}"/>
               </a:ext>
             </a:extLst>
           </p:cNvPr>
@@ -4714,7 +4714,7 @@
           <p:cNvPr id="20" name="">
             <a:extLst xmlns:a="http://schemas.openxmlformats.org/drawingml/2006/main">
               <a:ext uri="{FF2B5EF4-FFF2-40B4-BE49-F238E27FC236}">
-                <a16:creationId xmlns:a16="http://schemas.microsoft.com/office/drawing/2014/main" id="{D7D5B85D-87CD-42ED-A97F-3655F0B05FD4}"/>
+                <a16:creationId xmlns:a16="http://schemas.microsoft.com/office/drawing/2014/main" id="{36E280DD-14A4-4260-BE3D-5C8BAA858E18}"/>
               </a:ext>
             </a:extLst>
           </p:cNvPr>
@@ -4749,7 +4749,7 @@
           <p:cNvPr id="21" name="">
             <a:extLst xmlns:a="http://schemas.openxmlformats.org/drawingml/2006/main">
               <a:ext uri="{FF2B5EF4-FFF2-40B4-BE49-F238E27FC236}">
-                <a16:creationId xmlns:a16="http://schemas.microsoft.com/office/drawing/2014/main" id="{AAFC40C9-77BD-48C6-98A3-F06ACD336912}"/>
+                <a16:creationId xmlns:a16="http://schemas.microsoft.com/office/drawing/2014/main" id="{070F86E5-F1C0-4118-9343-FEEC66399870}"/>
               </a:ext>
             </a:extLst>
           </p:cNvPr>
@@ -4799,7 +4799,7 @@
           <p:cNvPr id="22" name="">
             <a:extLst xmlns:a="http://schemas.openxmlformats.org/drawingml/2006/main">
               <a:ext uri="{FF2B5EF4-FFF2-40B4-BE49-F238E27FC236}">
-                <a16:creationId xmlns:a16="http://schemas.microsoft.com/office/drawing/2014/main" id="{5DBF4F98-8F96-440D-843D-5D39F28BAEA3}"/>
+                <a16:creationId xmlns:a16="http://schemas.microsoft.com/office/drawing/2014/main" id="{5FB4B4DE-4268-4A50-B3E4-CFE40E804FA9}"/>
               </a:ext>
             </a:extLst>
           </p:cNvPr>
@@ -4849,7 +4849,7 @@
           <p:cNvPr id="23" name="">
             <a:extLst xmlns:a="http://schemas.openxmlformats.org/drawingml/2006/main">
               <a:ext uri="{FF2B5EF4-FFF2-40B4-BE49-F238E27FC236}">
-                <a16:creationId xmlns:a16="http://schemas.microsoft.com/office/drawing/2014/main" id="{52B76DAC-F7FC-451A-9752-2A9A9A088233}"/>
+                <a16:creationId xmlns:a16="http://schemas.microsoft.com/office/drawing/2014/main" id="{B9F4454E-ADF1-4781-87D7-FD12640F1329}"/>
               </a:ext>
             </a:extLst>
           </p:cNvPr>
@@ -4899,7 +4899,7 @@
           <p:cNvPr id="24" name="">
             <a:extLst xmlns:a="http://schemas.openxmlformats.org/drawingml/2006/main">
               <a:ext uri="{FF2B5EF4-FFF2-40B4-BE49-F238E27FC236}">
-                <a16:creationId xmlns:a16="http://schemas.microsoft.com/office/drawing/2014/main" id="{291AA8E7-C57F-4DB5-9965-84F8ADA1A187}"/>
+                <a16:creationId xmlns:a16="http://schemas.microsoft.com/office/drawing/2014/main" id="{1C7EAD2F-FF27-4413-ADD8-AEE7F57F6B29}"/>
               </a:ext>
             </a:extLst>
           </p:cNvPr>
@@ -4932,7 +4932,7 @@
           <p:cNvPr id="25" name="">
             <a:extLst xmlns:a="http://schemas.openxmlformats.org/drawingml/2006/main">
               <a:ext uri="{FF2B5EF4-FFF2-40B4-BE49-F238E27FC236}">
-                <a16:creationId xmlns:a16="http://schemas.microsoft.com/office/drawing/2014/main" id="{EA35DD25-7C1E-4AC3-98A5-512878469DF1}"/>
+                <a16:creationId xmlns:a16="http://schemas.microsoft.com/office/drawing/2014/main" id="{5F049EDD-BF2C-43B8-8916-3C1885427BDB}"/>
               </a:ext>
             </a:extLst>
           </p:cNvPr>
@@ -4982,7 +4982,7 @@
           <p:cNvPr id="26" name="">
             <a:extLst xmlns:a="http://schemas.openxmlformats.org/drawingml/2006/main">
               <a:ext uri="{FF2B5EF4-FFF2-40B4-BE49-F238E27FC236}">
-                <a16:creationId xmlns:a16="http://schemas.microsoft.com/office/drawing/2014/main" id="{7553A47E-7CB0-493F-909B-12C00AEAD893}"/>
+                <a16:creationId xmlns:a16="http://schemas.microsoft.com/office/drawing/2014/main" id="{D4C7508E-FC3C-4424-8C80-C1A02A03A298}"/>
               </a:ext>
             </a:extLst>
           </p:cNvPr>
@@ -5013,7 +5013,7 @@
           <p:cNvPr id="27" name="">
             <a:extLst xmlns:a="http://schemas.openxmlformats.org/drawingml/2006/main">
               <a:ext uri="{FF2B5EF4-FFF2-40B4-BE49-F238E27FC236}">
-                <a16:creationId xmlns:a16="http://schemas.microsoft.com/office/drawing/2014/main" id="{E6CCFFCA-1333-4BD1-B763-42F778AF452D}"/>
+                <a16:creationId xmlns:a16="http://schemas.microsoft.com/office/drawing/2014/main" id="{8DCEFEC1-5F7D-408A-A3B3-BE765229E370}"/>
               </a:ext>
             </a:extLst>
           </p:cNvPr>
@@ -5063,7 +5063,7 @@
           <p:cNvPr id="28" name="">
             <a:extLst xmlns:a="http://schemas.openxmlformats.org/drawingml/2006/main">
               <a:ext uri="{FF2B5EF4-FFF2-40B4-BE49-F238E27FC236}">
-                <a16:creationId xmlns:a16="http://schemas.microsoft.com/office/drawing/2014/main" id="{C2221888-157A-4705-85E6-F437CA5558C2}"/>
+                <a16:creationId xmlns:a16="http://schemas.microsoft.com/office/drawing/2014/main" id="{E6CC1E47-028E-4971-B5BB-DF28931107E2}"/>
               </a:ext>
             </a:extLst>
           </p:cNvPr>
@@ -5113,7 +5113,7 @@
           <p:cNvPr id="29" name="">
             <a:extLst xmlns:a="http://schemas.openxmlformats.org/drawingml/2006/main">
               <a:ext uri="{FF2B5EF4-FFF2-40B4-BE49-F238E27FC236}">
-                <a16:creationId xmlns:a16="http://schemas.microsoft.com/office/drawing/2014/main" id="{7647C316-3E87-41D8-AB2B-921548A5C984}"/>
+                <a16:creationId xmlns:a16="http://schemas.microsoft.com/office/drawing/2014/main" id="{1D7EF1E5-E6AD-4FF8-B552-8C92ADE83211}"/>
               </a:ext>
             </a:extLst>
           </p:cNvPr>
@@ -5163,7 +5163,7 @@
           <p:cNvPr id="30" name="">
             <a:extLst xmlns:a="http://schemas.openxmlformats.org/drawingml/2006/main">
               <a:ext uri="{FF2B5EF4-FFF2-40B4-BE49-F238E27FC236}">
-                <a16:creationId xmlns:a16="http://schemas.microsoft.com/office/drawing/2014/main" id="{69695DED-53FA-40AE-8F22-66CC16717432}"/>
+                <a16:creationId xmlns:a16="http://schemas.microsoft.com/office/drawing/2014/main" id="{436DEA8C-3876-4EC6-A84C-1432303D121A}"/>
               </a:ext>
             </a:extLst>
           </p:cNvPr>
@@ -5211,7 +5211,7 @@
     </p:spTree>
     <p:extLst>
       <p:ext uri="{BB962C8B-B14F-4D97-AF65-F5344CB8AC3E}">
-        <p14:creationId xmlns:p14="http://schemas.microsoft.com/office/powerpoint/2010/main" val="1132417667"/>
+        <p14:creationId xmlns:p14="http://schemas.microsoft.com/office/powerpoint/2010/main" val="1596970698"/>
       </p:ext>
     </p:extLst>
   </p:cSld>
@@ -5242,7 +5242,7 @@
           <p:cNvPr id="29" name="">
             <a:extLst xmlns:a="http://schemas.openxmlformats.org/drawingml/2006/main">
               <a:ext uri="{FF2B5EF4-FFF2-40B4-BE49-F238E27FC236}">
-                <a16:creationId xmlns:a16="http://schemas.microsoft.com/office/drawing/2014/main" id="{56F71397-D80F-4D55-ABFB-C60606EDC20E}"/>
+                <a16:creationId xmlns:a16="http://schemas.microsoft.com/office/drawing/2014/main" id="{65E0F04F-64DD-4B5B-AF56-009FDE454289}"/>
               </a:ext>
             </a:extLst>
           </p:cNvPr>
@@ -5292,7 +5292,7 @@
           <p:cNvPr id="2" name="">
             <a:extLst xmlns:a="http://schemas.openxmlformats.org/drawingml/2006/main">
               <a:ext uri="{FF2B5EF4-FFF2-40B4-BE49-F238E27FC236}">
-                <a16:creationId xmlns:a16="http://schemas.microsoft.com/office/drawing/2014/main" id="{F7CE6F87-179D-4155-9F49-03A9A98BC237}"/>
+                <a16:creationId xmlns:a16="http://schemas.microsoft.com/office/drawing/2014/main" id="{864741AE-2289-40F0-87BA-03A1BC3E6EB5}"/>
               </a:ext>
             </a:extLst>
           </p:cNvPr>
@@ -5342,7 +5342,7 @@
           <p:cNvPr id="3" name="">
             <a:extLst xmlns:a="http://schemas.openxmlformats.org/drawingml/2006/main">
               <a:ext uri="{FF2B5EF4-FFF2-40B4-BE49-F238E27FC236}">
-                <a16:creationId xmlns:a16="http://schemas.microsoft.com/office/drawing/2014/main" id="{EC02DA55-0376-484A-8DD6-2B94C3CEBAC4}"/>
+                <a16:creationId xmlns:a16="http://schemas.microsoft.com/office/drawing/2014/main" id="{187E925B-96BF-43CF-963F-773942C6B2C6}"/>
               </a:ext>
             </a:extLst>
           </p:cNvPr>
@@ -5377,7 +5377,7 @@
           <p:cNvPr id="4" name="">
             <a:extLst xmlns:a="http://schemas.openxmlformats.org/drawingml/2006/main">
               <a:ext uri="{FF2B5EF4-FFF2-40B4-BE49-F238E27FC236}">
-                <a16:creationId xmlns:a16="http://schemas.microsoft.com/office/drawing/2014/main" id="{2410A360-B5A6-45E1-AF5A-92CC6673F9D2}"/>
+                <a16:creationId xmlns:a16="http://schemas.microsoft.com/office/drawing/2014/main" id="{903A2EB8-A057-431D-9A01-912A337032AA}"/>
               </a:ext>
             </a:extLst>
           </p:cNvPr>
@@ -5427,7 +5427,7 @@
           <p:cNvPr id="5" name="">
             <a:extLst xmlns:a="http://schemas.openxmlformats.org/drawingml/2006/main">
               <a:ext uri="{FF2B5EF4-FFF2-40B4-BE49-F238E27FC236}">
-                <a16:creationId xmlns:a16="http://schemas.microsoft.com/office/drawing/2014/main" id="{3FE66B11-B4CE-40B3-A9CB-842361873F99}"/>
+                <a16:creationId xmlns:a16="http://schemas.microsoft.com/office/drawing/2014/main" id="{ACB7C6A7-C509-42B5-939A-3F600BE0C313}"/>
               </a:ext>
             </a:extLst>
           </p:cNvPr>
@@ -5477,7 +5477,7 @@
           <p:cNvPr id="6" name="">
             <a:extLst xmlns:a="http://schemas.openxmlformats.org/drawingml/2006/main">
               <a:ext uri="{FF2B5EF4-FFF2-40B4-BE49-F238E27FC236}">
-                <a16:creationId xmlns:a16="http://schemas.microsoft.com/office/drawing/2014/main" id="{B78D1012-7259-4E11-81BF-BFB0C77868AE}"/>
+                <a16:creationId xmlns:a16="http://schemas.microsoft.com/office/drawing/2014/main" id="{26BA9944-403B-4796-9A5E-8B180B24CC27}"/>
               </a:ext>
             </a:extLst>
           </p:cNvPr>
@@ -5527,7 +5527,7 @@
           <p:cNvPr id="7" name="">
             <a:extLst xmlns:a="http://schemas.openxmlformats.org/drawingml/2006/main">
               <a:ext uri="{FF2B5EF4-FFF2-40B4-BE49-F238E27FC236}">
-                <a16:creationId xmlns:a16="http://schemas.microsoft.com/office/drawing/2014/main" id="{986F2A88-A18B-4ADC-A2E3-6CAAC24A249C}"/>
+                <a16:creationId xmlns:a16="http://schemas.microsoft.com/office/drawing/2014/main" id="{A75BCFD2-EBCC-43CD-AA8C-A8C3A3C50639}"/>
               </a:ext>
             </a:extLst>
           </p:cNvPr>
@@ -5577,7 +5577,7 @@
           <p:cNvPr id="8" name="">
             <a:extLst xmlns:a="http://schemas.openxmlformats.org/drawingml/2006/main">
               <a:ext uri="{FF2B5EF4-FFF2-40B4-BE49-F238E27FC236}">
-                <a16:creationId xmlns:a16="http://schemas.microsoft.com/office/drawing/2014/main" id="{620E3EC2-1ADA-4AE7-B385-CDCA571D3EBE}"/>
+                <a16:creationId xmlns:a16="http://schemas.microsoft.com/office/drawing/2014/main" id="{D9FFD815-D0A4-4E94-8096-839ACC0CA8B4}"/>
               </a:ext>
             </a:extLst>
           </p:cNvPr>
@@ -5612,7 +5612,7 @@
           <p:cNvPr id="9" name="">
             <a:extLst xmlns:a="http://schemas.openxmlformats.org/drawingml/2006/main">
               <a:ext uri="{FF2B5EF4-FFF2-40B4-BE49-F238E27FC236}">
-                <a16:creationId xmlns:a16="http://schemas.microsoft.com/office/drawing/2014/main" id="{4C1A8A7D-629D-4433-915C-1FB35A74EB71}"/>
+                <a16:creationId xmlns:a16="http://schemas.microsoft.com/office/drawing/2014/main" id="{176F5D26-2D3D-4960-98E0-A293BC5A696A}"/>
               </a:ext>
             </a:extLst>
           </p:cNvPr>
@@ -5662,7 +5662,7 @@
           <p:cNvPr id="10" name="">
             <a:extLst xmlns:a="http://schemas.openxmlformats.org/drawingml/2006/main">
               <a:ext uri="{FF2B5EF4-FFF2-40B4-BE49-F238E27FC236}">
-                <a16:creationId xmlns:a16="http://schemas.microsoft.com/office/drawing/2014/main" id="{047AB450-9150-4D3D-94BB-21EAB2F420DD}"/>
+                <a16:creationId xmlns:a16="http://schemas.microsoft.com/office/drawing/2014/main" id="{CCDD4DF3-1A3E-48E6-B568-5498C5547880}"/>
               </a:ext>
             </a:extLst>
           </p:cNvPr>
@@ -5712,7 +5712,7 @@
           <p:cNvPr id="11" name="">
             <a:extLst xmlns:a="http://schemas.openxmlformats.org/drawingml/2006/main">
               <a:ext uri="{FF2B5EF4-FFF2-40B4-BE49-F238E27FC236}">
-                <a16:creationId xmlns:a16="http://schemas.microsoft.com/office/drawing/2014/main" id="{0BF419CC-8898-47B6-8F39-8A265A678652}"/>
+                <a16:creationId xmlns:a16="http://schemas.microsoft.com/office/drawing/2014/main" id="{9A68CC20-06DB-4F17-9269-F4E8F84EC263}"/>
               </a:ext>
             </a:extLst>
           </p:cNvPr>
@@ -5762,7 +5762,7 @@
           <p:cNvPr id="12" name="">
             <a:extLst xmlns:a="http://schemas.openxmlformats.org/drawingml/2006/main">
               <a:ext uri="{FF2B5EF4-FFF2-40B4-BE49-F238E27FC236}">
-                <a16:creationId xmlns:a16="http://schemas.microsoft.com/office/drawing/2014/main" id="{816843E0-E852-463E-B7F6-3A3BAB10D1D7}"/>
+                <a16:creationId xmlns:a16="http://schemas.microsoft.com/office/drawing/2014/main" id="{80936A1E-D24D-4B16-862E-1DECADE0A792}"/>
               </a:ext>
             </a:extLst>
           </p:cNvPr>
@@ -5812,7 +5812,7 @@
           <p:cNvPr id="13" name="">
             <a:extLst xmlns:a="http://schemas.openxmlformats.org/drawingml/2006/main">
               <a:ext uri="{FF2B5EF4-FFF2-40B4-BE49-F238E27FC236}">
-                <a16:creationId xmlns:a16="http://schemas.microsoft.com/office/drawing/2014/main" id="{1819DDCC-0D6D-4E11-9059-E813953A71E6}"/>
+                <a16:creationId xmlns:a16="http://schemas.microsoft.com/office/drawing/2014/main" id="{C9728235-13BA-416C-9DE7-2D6E71D22313}"/>
               </a:ext>
             </a:extLst>
           </p:cNvPr>
@@ -5862,7 +5862,7 @@
           <p:cNvPr id="14" name="">
             <a:extLst xmlns:a="http://schemas.openxmlformats.org/drawingml/2006/main">
               <a:ext uri="{FF2B5EF4-FFF2-40B4-BE49-F238E27FC236}">
-                <a16:creationId xmlns:a16="http://schemas.microsoft.com/office/drawing/2014/main" id="{511332D2-5073-4689-A92B-C3B7485E02B3}"/>
+                <a16:creationId xmlns:a16="http://schemas.microsoft.com/office/drawing/2014/main" id="{6710E219-E4FC-457B-B200-252698AD9E44}"/>
               </a:ext>
             </a:extLst>
           </p:cNvPr>
@@ -5912,7 +5912,7 @@
           <p:cNvPr id="15" name="">
             <a:extLst xmlns:a="http://schemas.openxmlformats.org/drawingml/2006/main">
               <a:ext uri="{FF2B5EF4-FFF2-40B4-BE49-F238E27FC236}">
-                <a16:creationId xmlns:a16="http://schemas.microsoft.com/office/drawing/2014/main" id="{32000654-E124-460B-9702-CD2AD9C1EC12}"/>
+                <a16:creationId xmlns:a16="http://schemas.microsoft.com/office/drawing/2014/main" id="{33C45724-74CF-4E72-89AF-5B7588441C30}"/>
               </a:ext>
             </a:extLst>
           </p:cNvPr>
@@ -5947,7 +5947,7 @@
           <p:cNvPr id="16" name="">
             <a:extLst xmlns:a="http://schemas.openxmlformats.org/drawingml/2006/main">
               <a:ext uri="{FF2B5EF4-FFF2-40B4-BE49-F238E27FC236}">
-                <a16:creationId xmlns:a16="http://schemas.microsoft.com/office/drawing/2014/main" id="{0B77BAFB-F29A-45D0-A009-BE8726EE2FA3}"/>
+                <a16:creationId xmlns:a16="http://schemas.microsoft.com/office/drawing/2014/main" id="{816D97EB-F221-48E0-B0EC-7298412C6FCE}"/>
               </a:ext>
             </a:extLst>
           </p:cNvPr>
@@ -5997,7 +5997,7 @@
           <p:cNvPr id="17" name="">
             <a:extLst xmlns:a="http://schemas.openxmlformats.org/drawingml/2006/main">
               <a:ext uri="{FF2B5EF4-FFF2-40B4-BE49-F238E27FC236}">
-                <a16:creationId xmlns:a16="http://schemas.microsoft.com/office/drawing/2014/main" id="{A3301794-882D-4918-8A24-A4274AC7291F}"/>
+                <a16:creationId xmlns:a16="http://schemas.microsoft.com/office/drawing/2014/main" id="{69BFBF93-0FF4-4B70-A745-5D2BD1286DCA}"/>
               </a:ext>
             </a:extLst>
           </p:cNvPr>
@@ -6047,7 +6047,7 @@
           <p:cNvPr id="18" name="">
             <a:extLst xmlns:a="http://schemas.openxmlformats.org/drawingml/2006/main">
               <a:ext uri="{FF2B5EF4-FFF2-40B4-BE49-F238E27FC236}">
-                <a16:creationId xmlns:a16="http://schemas.microsoft.com/office/drawing/2014/main" id="{CF22BB5A-82DC-4DF6-90B2-6A69925BF666}"/>
+                <a16:creationId xmlns:a16="http://schemas.microsoft.com/office/drawing/2014/main" id="{544D72F6-43E1-4B8B-962F-932065DECC21}"/>
               </a:ext>
             </a:extLst>
           </p:cNvPr>
@@ -6097,7 +6097,7 @@
           <p:cNvPr id="19" name="">
             <a:extLst xmlns:a="http://schemas.openxmlformats.org/drawingml/2006/main">
               <a:ext uri="{FF2B5EF4-FFF2-40B4-BE49-F238E27FC236}">
-                <a16:creationId xmlns:a16="http://schemas.microsoft.com/office/drawing/2014/main" id="{28A5ACDF-DDCD-456E-9B9B-0A89C1C69AA1}"/>
+                <a16:creationId xmlns:a16="http://schemas.microsoft.com/office/drawing/2014/main" id="{BDCCCAB2-21AD-43F2-919C-EAE15134A113}"/>
               </a:ext>
             </a:extLst>
           </p:cNvPr>
@@ -6130,7 +6130,7 @@
           <p:cNvPr id="20" name="">
             <a:extLst xmlns:a="http://schemas.openxmlformats.org/drawingml/2006/main">
               <a:ext uri="{FF2B5EF4-FFF2-40B4-BE49-F238E27FC236}">
-                <a16:creationId xmlns:a16="http://schemas.microsoft.com/office/drawing/2014/main" id="{B0558C72-004E-4192-A416-56999AFEA838}"/>
+                <a16:creationId xmlns:a16="http://schemas.microsoft.com/office/drawing/2014/main" id="{4274EBE5-79C2-41C5-A4C4-92927FF543E6}"/>
               </a:ext>
             </a:extLst>
           </p:cNvPr>
@@ -6180,7 +6180,7 @@
           <p:cNvPr id="21" name="">
             <a:extLst xmlns:a="http://schemas.openxmlformats.org/drawingml/2006/main">
               <a:ext uri="{FF2B5EF4-FFF2-40B4-BE49-F238E27FC236}">
-                <a16:creationId xmlns:a16="http://schemas.microsoft.com/office/drawing/2014/main" id="{7B0A7120-4B40-4FDD-9FA6-13768DCE509B}"/>
+                <a16:creationId xmlns:a16="http://schemas.microsoft.com/office/drawing/2014/main" id="{8E31C2BF-EEF2-41BB-9E97-DA921D3BC60C}"/>
               </a:ext>
             </a:extLst>
           </p:cNvPr>
@@ -6230,7 +6230,7 @@
           <p:cNvPr id="22" name="">
             <a:extLst xmlns:a="http://schemas.openxmlformats.org/drawingml/2006/main">
               <a:ext uri="{FF2B5EF4-FFF2-40B4-BE49-F238E27FC236}">
-                <a16:creationId xmlns:a16="http://schemas.microsoft.com/office/drawing/2014/main" id="{4BF12B8F-2B86-4356-B329-0D5FA06D5840}"/>
+                <a16:creationId xmlns:a16="http://schemas.microsoft.com/office/drawing/2014/main" id="{515FD19A-1896-422D-ADCF-3F28290603BA}"/>
               </a:ext>
             </a:extLst>
           </p:cNvPr>
@@ -6263,7 +6263,7 @@
           <p:cNvPr id="23" name="">
             <a:extLst xmlns:a="http://schemas.openxmlformats.org/drawingml/2006/main">
               <a:ext uri="{FF2B5EF4-FFF2-40B4-BE49-F238E27FC236}">
-                <a16:creationId xmlns:a16="http://schemas.microsoft.com/office/drawing/2014/main" id="{818D55AC-0276-4EA2-A232-5A2DDEB87840}"/>
+                <a16:creationId xmlns:a16="http://schemas.microsoft.com/office/drawing/2014/main" id="{0664B9BB-E308-4286-B779-B24448C77879}"/>
               </a:ext>
             </a:extLst>
           </p:cNvPr>
@@ -6313,7 +6313,7 @@
           <p:cNvPr id="24" name="">
             <a:extLst xmlns:a="http://schemas.openxmlformats.org/drawingml/2006/main">
               <a:ext uri="{FF2B5EF4-FFF2-40B4-BE49-F238E27FC236}">
-                <a16:creationId xmlns:a16="http://schemas.microsoft.com/office/drawing/2014/main" id="{6DDA7F81-CAAC-4900-B344-771C05847DB3}"/>
+                <a16:creationId xmlns:a16="http://schemas.microsoft.com/office/drawing/2014/main" id="{BB411B8D-0F71-409A-8F1A-003EC30689C1}"/>
               </a:ext>
             </a:extLst>
           </p:cNvPr>
@@ -6363,7 +6363,7 @@
           <p:cNvPr id="25" name="">
             <a:extLst xmlns:a="http://schemas.openxmlformats.org/drawingml/2006/main">
               <a:ext uri="{FF2B5EF4-FFF2-40B4-BE49-F238E27FC236}">
-                <a16:creationId xmlns:a16="http://schemas.microsoft.com/office/drawing/2014/main" id="{688BBCFC-3D15-456D-AB6E-53412E3D30BC}"/>
+                <a16:creationId xmlns:a16="http://schemas.microsoft.com/office/drawing/2014/main" id="{A76D0018-01AC-4B1F-BA08-2627A06AE831}"/>
               </a:ext>
             </a:extLst>
           </p:cNvPr>
@@ -6394,7 +6394,7 @@
           <p:cNvPr id="26" name="">
             <a:extLst xmlns:a="http://schemas.openxmlformats.org/drawingml/2006/main">
               <a:ext uri="{FF2B5EF4-FFF2-40B4-BE49-F238E27FC236}">
-                <a16:creationId xmlns:a16="http://schemas.microsoft.com/office/drawing/2014/main" id="{57388B89-D36E-49F4-8448-66B58F0124DF}"/>
+                <a16:creationId xmlns:a16="http://schemas.microsoft.com/office/drawing/2014/main" id="{2FDCB771-FCAF-48AA-9C4B-E2B3483B5184}"/>
               </a:ext>
             </a:extLst>
           </p:cNvPr>
@@ -6444,7 +6444,7 @@
           <p:cNvPr id="27" name="">
             <a:extLst xmlns:a="http://schemas.openxmlformats.org/drawingml/2006/main">
               <a:ext uri="{FF2B5EF4-FFF2-40B4-BE49-F238E27FC236}">
-                <a16:creationId xmlns:a16="http://schemas.microsoft.com/office/drawing/2014/main" id="{BA72A000-A2AB-4C6C-A5E4-876D9A240EF3}"/>
+                <a16:creationId xmlns:a16="http://schemas.microsoft.com/office/drawing/2014/main" id="{D6A61669-7E77-48AD-9569-2D86AB22AB52}"/>
               </a:ext>
             </a:extLst>
           </p:cNvPr>
@@ -6494,7 +6494,7 @@
           <p:cNvPr id="28" name="">
             <a:extLst xmlns:a="http://schemas.openxmlformats.org/drawingml/2006/main">
               <a:ext uri="{FF2B5EF4-FFF2-40B4-BE49-F238E27FC236}">
-                <a16:creationId xmlns:a16="http://schemas.microsoft.com/office/drawing/2014/main" id="{28B45DA5-2482-4423-B381-DFD11D452FAC}"/>
+                <a16:creationId xmlns:a16="http://schemas.microsoft.com/office/drawing/2014/main" id="{8E8EB34E-91FC-4953-9A16-812BA0B97E28}"/>
               </a:ext>
             </a:extLst>
           </p:cNvPr>
@@ -6542,7 +6542,7 @@
     </p:spTree>
     <p:extLst>
       <p:ext uri="{BB962C8B-B14F-4D97-AF65-F5344CB8AC3E}">
-        <p14:creationId xmlns:p14="http://schemas.microsoft.com/office/powerpoint/2010/main" val="1935983986"/>
+        <p14:creationId xmlns:p14="http://schemas.microsoft.com/office/powerpoint/2010/main" val="2009466172"/>
       </p:ext>
     </p:extLst>
   </p:cSld>
@@ -6573,7 +6573,7 @@
           <p:cNvPr id="16" name="">
             <a:extLst xmlns:a="http://schemas.openxmlformats.org/drawingml/2006/main">
               <a:ext uri="{FF2B5EF4-FFF2-40B4-BE49-F238E27FC236}">
-                <a16:creationId xmlns:a16="http://schemas.microsoft.com/office/drawing/2014/main" id="{052E7BE7-780D-4B1A-90DB-49728233A2C3}"/>
+                <a16:creationId xmlns:a16="http://schemas.microsoft.com/office/drawing/2014/main" id="{C5BF2E41-3E11-4D5C-AA97-4FCD2F06F337}"/>
               </a:ext>
             </a:extLst>
           </p:cNvPr>
@@ -6623,7 +6623,7 @@
           <p:cNvPr id="2" name="">
             <a:extLst xmlns:a="http://schemas.openxmlformats.org/drawingml/2006/main">
               <a:ext uri="{FF2B5EF4-FFF2-40B4-BE49-F238E27FC236}">
-                <a16:creationId xmlns:a16="http://schemas.microsoft.com/office/drawing/2014/main" id="{77F31C33-89AE-44C4-A4B0-22387F1CF5A0}"/>
+                <a16:creationId xmlns:a16="http://schemas.microsoft.com/office/drawing/2014/main" id="{A391033C-BCB7-4E6A-8BE1-23A6091E1C92}"/>
               </a:ext>
             </a:extLst>
           </p:cNvPr>
@@ -6673,7 +6673,7 @@
           <p:cNvPr id="3" name="">
             <a:extLst xmlns:a="http://schemas.openxmlformats.org/drawingml/2006/main">
               <a:ext uri="{FF2B5EF4-FFF2-40B4-BE49-F238E27FC236}">
-                <a16:creationId xmlns:a16="http://schemas.microsoft.com/office/drawing/2014/main" id="{A44A6703-4F4A-4100-AC32-49410C0B5ECA}"/>
+                <a16:creationId xmlns:a16="http://schemas.microsoft.com/office/drawing/2014/main" id="{21D949C0-0E94-41D0-9DC9-77C5DAB72795}"/>
               </a:ext>
             </a:extLst>
           </p:cNvPr>
@@ -6723,7 +6723,7 @@
           <p:cNvPr id="4" name="">
             <a:extLst xmlns:a="http://schemas.openxmlformats.org/drawingml/2006/main">
               <a:ext uri="{FF2B5EF4-FFF2-40B4-BE49-F238E27FC236}">
-                <a16:creationId xmlns:a16="http://schemas.microsoft.com/office/drawing/2014/main" id="{97EB73AB-268B-4EF1-AF10-891E4A395D0E}"/>
+                <a16:creationId xmlns:a16="http://schemas.microsoft.com/office/drawing/2014/main" id="{F776CEB9-3FB0-43E1-9693-7D48937BB7C1}"/>
               </a:ext>
             </a:extLst>
           </p:cNvPr>
@@ -6780,7 +6780,7 @@
         </p:xfrm>
         <a:graphic xmlns:a="http://schemas.openxmlformats.org/drawingml/2006/main">
           <a:graphicData uri="http://schemas.openxmlformats.org/drawingml/2006/chart">
-            <c:chart xmlns:r="http://schemas.openxmlformats.org/officeDocument/2006/relationships" xmlns:c="http://schemas.openxmlformats.org/drawingml/2006/chart" r:id="Ra7287b3122c94e7c"/>
+            <c:chart xmlns:r="http://schemas.openxmlformats.org/officeDocument/2006/relationships" xmlns:c="http://schemas.openxmlformats.org/drawingml/2006/chart" r:id="R932e0c2c59be4f54"/>
           </a:graphicData>
         </a:graphic>
       </p:graphicFrame>
@@ -6789,7 +6789,7 @@
           <p:cNvPr id="6" name="">
             <a:extLst xmlns:a="http://schemas.openxmlformats.org/drawingml/2006/main">
               <a:ext uri="{FF2B5EF4-FFF2-40B4-BE49-F238E27FC236}">
-                <a16:creationId xmlns:a16="http://schemas.microsoft.com/office/drawing/2014/main" id="{9F893D6B-52B4-49B2-9429-4B668666D8E0}"/>
+                <a16:creationId xmlns:a16="http://schemas.microsoft.com/office/drawing/2014/main" id="{67573662-2E80-4110-BF2D-75AEF82315EC}"/>
               </a:ext>
             </a:extLst>
           </p:cNvPr>
@@ -6839,7 +6839,7 @@
           <p:cNvPr id="7" name="">
             <a:extLst xmlns:a="http://schemas.openxmlformats.org/drawingml/2006/main">
               <a:ext uri="{FF2B5EF4-FFF2-40B4-BE49-F238E27FC236}">
-                <a16:creationId xmlns:a16="http://schemas.microsoft.com/office/drawing/2014/main" id="{B7A0AEDC-3EE5-4C6F-A5D8-04A9ED6B77FE}"/>
+                <a16:creationId xmlns:a16="http://schemas.microsoft.com/office/drawing/2014/main" id="{CF94C7F3-E1BE-4FD5-B5CC-FE2816151185}"/>
               </a:ext>
             </a:extLst>
           </p:cNvPr>
@@ -6889,7 +6889,7 @@
           <p:cNvPr id="8" name="">
             <a:extLst xmlns:a="http://schemas.openxmlformats.org/drawingml/2006/main">
               <a:ext uri="{FF2B5EF4-FFF2-40B4-BE49-F238E27FC236}">
-                <a16:creationId xmlns:a16="http://schemas.microsoft.com/office/drawing/2014/main" id="{2EF142EB-6A7D-46B3-9041-FD57775DE259}"/>
+                <a16:creationId xmlns:a16="http://schemas.microsoft.com/office/drawing/2014/main" id="{7A692732-D806-4E4F-82F2-60DC5FCBE57C}"/>
               </a:ext>
             </a:extLst>
           </p:cNvPr>
@@ -6939,7 +6939,7 @@
           <p:cNvPr id="9" name="">
             <a:extLst xmlns:a="http://schemas.openxmlformats.org/drawingml/2006/main">
               <a:ext uri="{FF2B5EF4-FFF2-40B4-BE49-F238E27FC236}">
-                <a16:creationId xmlns:a16="http://schemas.microsoft.com/office/drawing/2014/main" id="{943B5379-38EF-4C08-992E-EB62E1DC0CEE}"/>
+                <a16:creationId xmlns:a16="http://schemas.microsoft.com/office/drawing/2014/main" id="{2B53F4BE-290A-46B7-8C99-F5FA50BEEE2B}"/>
               </a:ext>
             </a:extLst>
           </p:cNvPr>
@@ -6989,7 +6989,7 @@
           <p:cNvPr id="10" name="">
             <a:extLst xmlns:a="http://schemas.openxmlformats.org/drawingml/2006/main">
               <a:ext uri="{FF2B5EF4-FFF2-40B4-BE49-F238E27FC236}">
-                <a16:creationId xmlns:a16="http://schemas.microsoft.com/office/drawing/2014/main" id="{26880E8C-2A56-4882-BA37-52393BC165F7}"/>
+                <a16:creationId xmlns:a16="http://schemas.microsoft.com/office/drawing/2014/main" id="{8788E3D0-5792-414E-936D-0D6D10501846}"/>
               </a:ext>
             </a:extLst>
           </p:cNvPr>
@@ -7039,7 +7039,7 @@
           <p:cNvPr id="11" name="">
             <a:extLst xmlns:a="http://schemas.openxmlformats.org/drawingml/2006/main">
               <a:ext uri="{FF2B5EF4-FFF2-40B4-BE49-F238E27FC236}">
-                <a16:creationId xmlns:a16="http://schemas.microsoft.com/office/drawing/2014/main" id="{19B984C8-5D6F-482F-896E-06EB0B7DB698}"/>
+                <a16:creationId xmlns:a16="http://schemas.microsoft.com/office/drawing/2014/main" id="{A83324DA-194C-473F-BFDA-35F97476DBCC}"/>
               </a:ext>
             </a:extLst>
           </p:cNvPr>
@@ -7089,7 +7089,7 @@
           <p:cNvPr id="12" name="">
             <a:extLst xmlns:a="http://schemas.openxmlformats.org/drawingml/2006/main">
               <a:ext uri="{FF2B5EF4-FFF2-40B4-BE49-F238E27FC236}">
-                <a16:creationId xmlns:a16="http://schemas.microsoft.com/office/drawing/2014/main" id="{5E9442CE-E210-496F-85FE-DAF590861E80}"/>
+                <a16:creationId xmlns:a16="http://schemas.microsoft.com/office/drawing/2014/main" id="{DC39DD40-F52D-4918-A833-4237B805694A}"/>
               </a:ext>
             </a:extLst>
           </p:cNvPr>
@@ -7139,7 +7139,7 @@
           <p:cNvPr id="13" name="">
             <a:extLst xmlns:a="http://schemas.openxmlformats.org/drawingml/2006/main">
               <a:ext uri="{FF2B5EF4-FFF2-40B4-BE49-F238E27FC236}">
-                <a16:creationId xmlns:a16="http://schemas.microsoft.com/office/drawing/2014/main" id="{895EAD1A-405B-44F4-94E3-5F6328D3DE6A}"/>
+                <a16:creationId xmlns:a16="http://schemas.microsoft.com/office/drawing/2014/main" id="{344F65E5-1D6D-440D-A22F-C306A41C5BC7}"/>
               </a:ext>
             </a:extLst>
           </p:cNvPr>
@@ -7206,7 +7206,7 @@
           <p:cNvPr id="14" name="">
             <a:extLst xmlns:a="http://schemas.openxmlformats.org/drawingml/2006/main">
               <a:ext uri="{FF2B5EF4-FFF2-40B4-BE49-F238E27FC236}">
-                <a16:creationId xmlns:a16="http://schemas.microsoft.com/office/drawing/2014/main" id="{B7DA5FEE-0DC9-4424-892D-4B136B4B07EB}"/>
+                <a16:creationId xmlns:a16="http://schemas.microsoft.com/office/drawing/2014/main" id="{57B1AB9F-06CF-459F-8B81-DBF3B483ED79}"/>
               </a:ext>
             </a:extLst>
           </p:cNvPr>
@@ -7256,7 +7256,7 @@
           <p:cNvPr id="15" name="">
             <a:extLst xmlns:a="http://schemas.openxmlformats.org/drawingml/2006/main">
               <a:ext uri="{FF2B5EF4-FFF2-40B4-BE49-F238E27FC236}">
-                <a16:creationId xmlns:a16="http://schemas.microsoft.com/office/drawing/2014/main" id="{68B61270-DBAD-44AB-9960-DD368D1753E9}"/>
+                <a16:creationId xmlns:a16="http://schemas.microsoft.com/office/drawing/2014/main" id="{A65B92ED-CF1E-45E6-BBB4-CD20BAFA6115}"/>
               </a:ext>
             </a:extLst>
           </p:cNvPr>
@@ -7304,7 +7304,7 @@
     </p:spTree>
     <p:extLst>
       <p:ext uri="{BB962C8B-B14F-4D97-AF65-F5344CB8AC3E}">
-        <p14:creationId xmlns:p14="http://schemas.microsoft.com/office/powerpoint/2010/main" val="1173249003"/>
+        <p14:creationId xmlns:p14="http://schemas.microsoft.com/office/powerpoint/2010/main" val="723132423"/>
       </p:ext>
     </p:extLst>
   </p:cSld>
@@ -7335,7 +7335,7 @@
           <p:cNvPr id="45" name="">
             <a:extLst xmlns:a="http://schemas.openxmlformats.org/drawingml/2006/main">
               <a:ext uri="{FF2B5EF4-FFF2-40B4-BE49-F238E27FC236}">
-                <a16:creationId xmlns:a16="http://schemas.microsoft.com/office/drawing/2014/main" id="{9075B9A0-5E8F-4190-B6E6-9202FDDC557B}"/>
+                <a16:creationId xmlns:a16="http://schemas.microsoft.com/office/drawing/2014/main" id="{9EE9475A-2526-453B-9796-3E45D9678F9D}"/>
               </a:ext>
             </a:extLst>
           </p:cNvPr>
@@ -7385,7 +7385,7 @@
           <p:cNvPr id="2" name="">
             <a:extLst xmlns:a="http://schemas.openxmlformats.org/drawingml/2006/main">
               <a:ext uri="{FF2B5EF4-FFF2-40B4-BE49-F238E27FC236}">
-                <a16:creationId xmlns:a16="http://schemas.microsoft.com/office/drawing/2014/main" id="{334EED82-ED8F-4F64-BEFE-782003222C4B}"/>
+                <a16:creationId xmlns:a16="http://schemas.microsoft.com/office/drawing/2014/main" id="{CB13849C-121C-4EE9-9AD5-27897F79BC8E}"/>
               </a:ext>
             </a:extLst>
           </p:cNvPr>
@@ -7435,7 +7435,7 @@
           <p:cNvPr id="3" name="">
             <a:extLst xmlns:a="http://schemas.openxmlformats.org/drawingml/2006/main">
               <a:ext uri="{FF2B5EF4-FFF2-40B4-BE49-F238E27FC236}">
-                <a16:creationId xmlns:a16="http://schemas.microsoft.com/office/drawing/2014/main" id="{AA598F8B-6B41-4A01-96CC-C6DE56522F73}"/>
+                <a16:creationId xmlns:a16="http://schemas.microsoft.com/office/drawing/2014/main" id="{947BC976-205C-4520-ABE2-5BBB25E19B68}"/>
               </a:ext>
             </a:extLst>
           </p:cNvPr>
@@ -7466,7 +7466,7 @@
           <p:cNvPr id="4" name="">
             <a:extLst xmlns:a="http://schemas.openxmlformats.org/drawingml/2006/main">
               <a:ext uri="{FF2B5EF4-FFF2-40B4-BE49-F238E27FC236}">
-                <a16:creationId xmlns:a16="http://schemas.microsoft.com/office/drawing/2014/main" id="{F5FCA5A7-A6F1-4E05-B1EA-B7D981458098}"/>
+                <a16:creationId xmlns:a16="http://schemas.microsoft.com/office/drawing/2014/main" id="{675F4D1A-B294-4509-BDC1-B786884012B4}"/>
               </a:ext>
             </a:extLst>
           </p:cNvPr>
@@ -7497,7 +7497,7 @@
           <p:cNvPr id="5" name="">
             <a:extLst xmlns:a="http://schemas.openxmlformats.org/drawingml/2006/main">
               <a:ext uri="{FF2B5EF4-FFF2-40B4-BE49-F238E27FC236}">
-                <a16:creationId xmlns:a16="http://schemas.microsoft.com/office/drawing/2014/main" id="{15296184-FEE7-40EB-8256-19E5FCBCE9C8}"/>
+                <a16:creationId xmlns:a16="http://schemas.microsoft.com/office/drawing/2014/main" id="{BF1B9D74-A17A-441C-9355-A651A64395B2}"/>
               </a:ext>
             </a:extLst>
           </p:cNvPr>
@@ -7528,7 +7528,7 @@
           <p:cNvPr id="6" name="">
             <a:extLst xmlns:a="http://schemas.openxmlformats.org/drawingml/2006/main">
               <a:ext uri="{FF2B5EF4-FFF2-40B4-BE49-F238E27FC236}">
-                <a16:creationId xmlns:a16="http://schemas.microsoft.com/office/drawing/2014/main" id="{5FA91E5B-8D03-49D0-A013-DDF203EB8911}"/>
+                <a16:creationId xmlns:a16="http://schemas.microsoft.com/office/drawing/2014/main" id="{2928573C-F826-41F2-AE61-E28157E23A5E}"/>
               </a:ext>
             </a:extLst>
           </p:cNvPr>
@@ -7578,7 +7578,7 @@
           <p:cNvPr id="7" name="">
             <a:extLst xmlns:a="http://schemas.openxmlformats.org/drawingml/2006/main">
               <a:ext uri="{FF2B5EF4-FFF2-40B4-BE49-F238E27FC236}">
-                <a16:creationId xmlns:a16="http://schemas.microsoft.com/office/drawing/2014/main" id="{E05238E7-CFAF-4943-AF5B-7621C27FDA06}"/>
+                <a16:creationId xmlns:a16="http://schemas.microsoft.com/office/drawing/2014/main" id="{E0EC47E3-58E8-448C-9CFD-86B90B228FEB}"/>
               </a:ext>
             </a:extLst>
           </p:cNvPr>
@@ -7628,7 +7628,7 @@
           <p:cNvPr id="8" name="">
             <a:extLst xmlns:a="http://schemas.openxmlformats.org/drawingml/2006/main">
               <a:ext uri="{FF2B5EF4-FFF2-40B4-BE49-F238E27FC236}">
-                <a16:creationId xmlns:a16="http://schemas.microsoft.com/office/drawing/2014/main" id="{978C7DA1-DDC0-4DF9-8597-0C96FFB3150D}"/>
+                <a16:creationId xmlns:a16="http://schemas.microsoft.com/office/drawing/2014/main" id="{A6F64663-B4EC-49A8-BDFC-45ADFA562649}"/>
               </a:ext>
             </a:extLst>
           </p:cNvPr>
@@ -7678,7 +7678,7 @@
           <p:cNvPr id="9" name="">
             <a:extLst xmlns:a="http://schemas.openxmlformats.org/drawingml/2006/main">
               <a:ext uri="{FF2B5EF4-FFF2-40B4-BE49-F238E27FC236}">
-                <a16:creationId xmlns:a16="http://schemas.microsoft.com/office/drawing/2014/main" id="{5500272F-EEDC-4101-80E8-56C2703176A4}"/>
+                <a16:creationId xmlns:a16="http://schemas.microsoft.com/office/drawing/2014/main" id="{802760B0-3A9B-4FA8-9146-2E081F4BF1A3}"/>
               </a:ext>
             </a:extLst>
           </p:cNvPr>
@@ -7728,7 +7728,7 @@
           <p:cNvPr id="10" name="">
             <a:extLst xmlns:a="http://schemas.openxmlformats.org/drawingml/2006/main">
               <a:ext uri="{FF2B5EF4-FFF2-40B4-BE49-F238E27FC236}">
-                <a16:creationId xmlns:a16="http://schemas.microsoft.com/office/drawing/2014/main" id="{69E018CA-8D55-46AF-A9FF-887EC3E64DA3}"/>
+                <a16:creationId xmlns:a16="http://schemas.microsoft.com/office/drawing/2014/main" id="{9820CDE7-DE2A-410E-AACA-8DB32A1B8216}"/>
               </a:ext>
             </a:extLst>
           </p:cNvPr>
@@ -7778,7 +7778,7 @@
           <p:cNvPr id="11" name="">
             <a:extLst xmlns:a="http://schemas.openxmlformats.org/drawingml/2006/main">
               <a:ext uri="{FF2B5EF4-FFF2-40B4-BE49-F238E27FC236}">
-                <a16:creationId xmlns:a16="http://schemas.microsoft.com/office/drawing/2014/main" id="{16CFFA13-8228-4620-92E4-9538CBF781B4}"/>
+                <a16:creationId xmlns:a16="http://schemas.microsoft.com/office/drawing/2014/main" id="{AA3A83E7-FCCA-4C62-945E-0C463330855E}"/>
               </a:ext>
             </a:extLst>
           </p:cNvPr>
@@ -7828,7 +7828,7 @@
           <p:cNvPr id="12" name="">
             <a:extLst xmlns:a="http://schemas.openxmlformats.org/drawingml/2006/main">
               <a:ext uri="{FF2B5EF4-FFF2-40B4-BE49-F238E27FC236}">
-                <a16:creationId xmlns:a16="http://schemas.microsoft.com/office/drawing/2014/main" id="{6A9E2831-56C3-461B-B329-85A215B9ABAB}"/>
+                <a16:creationId xmlns:a16="http://schemas.microsoft.com/office/drawing/2014/main" id="{3B0AC5CD-6A3D-4A78-B73B-E114A8A93B8F}"/>
               </a:ext>
             </a:extLst>
           </p:cNvPr>
@@ -7878,7 +7878,7 @@
           <p:cNvPr id="13" name="">
             <a:extLst xmlns:a="http://schemas.openxmlformats.org/drawingml/2006/main">
               <a:ext uri="{FF2B5EF4-FFF2-40B4-BE49-F238E27FC236}">
-                <a16:creationId xmlns:a16="http://schemas.microsoft.com/office/drawing/2014/main" id="{A231E086-5E02-4E1F-8F5A-2CBAFC6845C2}"/>
+                <a16:creationId xmlns:a16="http://schemas.microsoft.com/office/drawing/2014/main" id="{BAE49331-B0C8-4305-ABB7-636FD2EBCE70}"/>
               </a:ext>
             </a:extLst>
           </p:cNvPr>
@@ -7928,7 +7928,7 @@
           <p:cNvPr id="14" name="">
             <a:extLst xmlns:a="http://schemas.openxmlformats.org/drawingml/2006/main">
               <a:ext uri="{FF2B5EF4-FFF2-40B4-BE49-F238E27FC236}">
-                <a16:creationId xmlns:a16="http://schemas.microsoft.com/office/drawing/2014/main" id="{E832FEFC-A46B-4004-BCF3-F5BB4F7A6A08}"/>
+                <a16:creationId xmlns:a16="http://schemas.microsoft.com/office/drawing/2014/main" id="{6BDA7C5C-DB1A-422E-96B3-7A8917D9CEEE}"/>
               </a:ext>
             </a:extLst>
           </p:cNvPr>
@@ -7978,7 +7978,7 @@
           <p:cNvPr id="15" name="">
             <a:extLst xmlns:a="http://schemas.openxmlformats.org/drawingml/2006/main">
               <a:ext uri="{FF2B5EF4-FFF2-40B4-BE49-F238E27FC236}">
-                <a16:creationId xmlns:a16="http://schemas.microsoft.com/office/drawing/2014/main" id="{3791D18C-CE4E-4F8B-A79C-F1CD4FC65BD6}"/>
+                <a16:creationId xmlns:a16="http://schemas.microsoft.com/office/drawing/2014/main" id="{84AAE38C-F27A-4809-9A80-E6B2CFA9E8A0}"/>
               </a:ext>
             </a:extLst>
           </p:cNvPr>
@@ -8009,7 +8009,7 @@
           <p:cNvPr id="16" name="">
             <a:extLst xmlns:a="http://schemas.openxmlformats.org/drawingml/2006/main">
               <a:ext uri="{FF2B5EF4-FFF2-40B4-BE49-F238E27FC236}">
-                <a16:creationId xmlns:a16="http://schemas.microsoft.com/office/drawing/2014/main" id="{EDDEFEEB-6C1F-418A-B67B-B6BDF91009FB}"/>
+                <a16:creationId xmlns:a16="http://schemas.microsoft.com/office/drawing/2014/main" id="{368EBAB3-B3D5-43B9-A612-4D0B8B6262E8}"/>
               </a:ext>
             </a:extLst>
           </p:cNvPr>
@@ -8040,7 +8040,7 @@
           <p:cNvPr id="17" name="">
             <a:extLst xmlns:a="http://schemas.openxmlformats.org/drawingml/2006/main">
               <a:ext uri="{FF2B5EF4-FFF2-40B4-BE49-F238E27FC236}">
-                <a16:creationId xmlns:a16="http://schemas.microsoft.com/office/drawing/2014/main" id="{C260B14C-1F17-489D-8BE9-F05F43CF55AF}"/>
+                <a16:creationId xmlns:a16="http://schemas.microsoft.com/office/drawing/2014/main" id="{3F8FB372-5975-4CCB-A5D5-B10DCFC7CC17}"/>
               </a:ext>
             </a:extLst>
           </p:cNvPr>
@@ -8071,7 +8071,7 @@
           <p:cNvPr id="18" name="">
             <a:extLst xmlns:a="http://schemas.openxmlformats.org/drawingml/2006/main">
               <a:ext uri="{FF2B5EF4-FFF2-40B4-BE49-F238E27FC236}">
-                <a16:creationId xmlns:a16="http://schemas.microsoft.com/office/drawing/2014/main" id="{3A2EA9E5-231A-43EF-94A9-06C47F236159}"/>
+                <a16:creationId xmlns:a16="http://schemas.microsoft.com/office/drawing/2014/main" id="{C4CC08A8-520A-4040-8F90-27C7553DC054}"/>
               </a:ext>
             </a:extLst>
           </p:cNvPr>
@@ -8102,7 +8102,7 @@
           <p:cNvPr id="19" name="">
             <a:extLst xmlns:a="http://schemas.openxmlformats.org/drawingml/2006/main">
               <a:ext uri="{FF2B5EF4-FFF2-40B4-BE49-F238E27FC236}">
-                <a16:creationId xmlns:a16="http://schemas.microsoft.com/office/drawing/2014/main" id="{9AC3DE51-291F-45AD-AA77-6DDB1D982800}"/>
+                <a16:creationId xmlns:a16="http://schemas.microsoft.com/office/drawing/2014/main" id="{0D7EBE69-FDF2-4CBB-A25A-48C31959EEBE}"/>
               </a:ext>
             </a:extLst>
           </p:cNvPr>
@@ -8133,7 +8133,7 @@
           <p:cNvPr id="20" name="">
             <a:extLst xmlns:a="http://schemas.openxmlformats.org/drawingml/2006/main">
               <a:ext uri="{FF2B5EF4-FFF2-40B4-BE49-F238E27FC236}">
-                <a16:creationId xmlns:a16="http://schemas.microsoft.com/office/drawing/2014/main" id="{4027B8DF-D65B-4F5F-9330-ACF573AB5F74}"/>
+                <a16:creationId xmlns:a16="http://schemas.microsoft.com/office/drawing/2014/main" id="{3679021E-1FED-4B22-85B0-76406D932C46}"/>
               </a:ext>
             </a:extLst>
           </p:cNvPr>
@@ -8164,7 +8164,7 @@
           <p:cNvPr id="21" name="">
             <a:extLst xmlns:a="http://schemas.openxmlformats.org/drawingml/2006/main">
               <a:ext uri="{FF2B5EF4-FFF2-40B4-BE49-F238E27FC236}">
-                <a16:creationId xmlns:a16="http://schemas.microsoft.com/office/drawing/2014/main" id="{8714816D-3C0F-4D44-80B3-4E3DD13FCCB8}"/>
+                <a16:creationId xmlns:a16="http://schemas.microsoft.com/office/drawing/2014/main" id="{149BD540-EEC7-4FBF-B1D1-2F599288613F}"/>
               </a:ext>
             </a:extLst>
           </p:cNvPr>
@@ -8195,7 +8195,7 @@
           <p:cNvPr id="22" name="">
             <a:extLst xmlns:a="http://schemas.openxmlformats.org/drawingml/2006/main">
               <a:ext uri="{FF2B5EF4-FFF2-40B4-BE49-F238E27FC236}">
-                <a16:creationId xmlns:a16="http://schemas.microsoft.com/office/drawing/2014/main" id="{AAB3AC3C-5014-49BF-BDC4-DAD8311AA479}"/>
+                <a16:creationId xmlns:a16="http://schemas.microsoft.com/office/drawing/2014/main" id="{A8FAADD2-5B17-4DC8-B648-31674B76EDE8}"/>
               </a:ext>
             </a:extLst>
           </p:cNvPr>
@@ -8226,7 +8226,7 @@
           <p:cNvPr id="23" name="">
             <a:extLst xmlns:a="http://schemas.openxmlformats.org/drawingml/2006/main">
               <a:ext uri="{FF2B5EF4-FFF2-40B4-BE49-F238E27FC236}">
-                <a16:creationId xmlns:a16="http://schemas.microsoft.com/office/drawing/2014/main" id="{D359186F-7762-4C15-A683-F2A62B6F5924}"/>
+                <a16:creationId xmlns:a16="http://schemas.microsoft.com/office/drawing/2014/main" id="{0AE2D632-EB1A-43A1-84D7-1DF6C93FC65B}"/>
               </a:ext>
             </a:extLst>
           </p:cNvPr>
@@ -8257,7 +8257,7 @@
           <p:cNvPr id="24" name="">
             <a:extLst xmlns:a="http://schemas.openxmlformats.org/drawingml/2006/main">
               <a:ext uri="{FF2B5EF4-FFF2-40B4-BE49-F238E27FC236}">
-                <a16:creationId xmlns:a16="http://schemas.microsoft.com/office/drawing/2014/main" id="{AFDBC05A-8459-45A3-A963-D3FB12E83870}"/>
+                <a16:creationId xmlns:a16="http://schemas.microsoft.com/office/drawing/2014/main" id="{B9F45FF0-ADA7-4248-A1EB-DEA52411F8CA}"/>
               </a:ext>
             </a:extLst>
           </p:cNvPr>
@@ -8288,7 +8288,7 @@
           <p:cNvPr id="25" name="">
             <a:extLst xmlns:a="http://schemas.openxmlformats.org/drawingml/2006/main">
               <a:ext uri="{FF2B5EF4-FFF2-40B4-BE49-F238E27FC236}">
-                <a16:creationId xmlns:a16="http://schemas.microsoft.com/office/drawing/2014/main" id="{552633A6-FE82-4C53-B048-9A6042A25C23}"/>
+                <a16:creationId xmlns:a16="http://schemas.microsoft.com/office/drawing/2014/main" id="{4F54ECD0-EC55-4559-B569-B30ECDE6CF27}"/>
               </a:ext>
             </a:extLst>
           </p:cNvPr>
@@ -8319,7 +8319,7 @@
           <p:cNvPr id="26" name="">
             <a:extLst xmlns:a="http://schemas.openxmlformats.org/drawingml/2006/main">
               <a:ext uri="{FF2B5EF4-FFF2-40B4-BE49-F238E27FC236}">
-                <a16:creationId xmlns:a16="http://schemas.microsoft.com/office/drawing/2014/main" id="{EA991622-C625-40AF-B3C1-4F101733E344}"/>
+                <a16:creationId xmlns:a16="http://schemas.microsoft.com/office/drawing/2014/main" id="{B41FCE1C-B793-469A-BD9F-D3AD074C832B}"/>
               </a:ext>
             </a:extLst>
           </p:cNvPr>
@@ -8350,7 +8350,7 @@
           <p:cNvPr id="27" name="">
             <a:extLst xmlns:a="http://schemas.openxmlformats.org/drawingml/2006/main">
               <a:ext uri="{FF2B5EF4-FFF2-40B4-BE49-F238E27FC236}">
-                <a16:creationId xmlns:a16="http://schemas.microsoft.com/office/drawing/2014/main" id="{65B3895E-2C4E-4B62-B33D-399A4F05953B}"/>
+                <a16:creationId xmlns:a16="http://schemas.microsoft.com/office/drawing/2014/main" id="{9905B8A6-B149-4326-9F21-9EC7CD3A270C}"/>
               </a:ext>
             </a:extLst>
           </p:cNvPr>
@@ -8381,7 +8381,7 @@
           <p:cNvPr id="28" name="">
             <a:extLst xmlns:a="http://schemas.openxmlformats.org/drawingml/2006/main">
               <a:ext uri="{FF2B5EF4-FFF2-40B4-BE49-F238E27FC236}">
-                <a16:creationId xmlns:a16="http://schemas.microsoft.com/office/drawing/2014/main" id="{2465353B-B302-4DB8-ADC5-41681B371FE0}"/>
+                <a16:creationId xmlns:a16="http://schemas.microsoft.com/office/drawing/2014/main" id="{A27CE09C-9FF0-49A1-A47E-1CE5B9B2F8E2}"/>
               </a:ext>
             </a:extLst>
           </p:cNvPr>
@@ -8412,7 +8412,7 @@
           <p:cNvPr id="29" name="">
             <a:extLst xmlns:a="http://schemas.openxmlformats.org/drawingml/2006/main">
               <a:ext uri="{FF2B5EF4-FFF2-40B4-BE49-F238E27FC236}">
-                <a16:creationId xmlns:a16="http://schemas.microsoft.com/office/drawing/2014/main" id="{6451127F-903E-491D-A5AE-E86A58BD8E71}"/>
+                <a16:creationId xmlns:a16="http://schemas.microsoft.com/office/drawing/2014/main" id="{3AF78EBC-F436-4A45-A362-4F9257C925EF}"/>
               </a:ext>
             </a:extLst>
           </p:cNvPr>
@@ -8443,7 +8443,7 @@
           <p:cNvPr id="30" name="">
             <a:extLst xmlns:a="http://schemas.openxmlformats.org/drawingml/2006/main">
               <a:ext uri="{FF2B5EF4-FFF2-40B4-BE49-F238E27FC236}">
-                <a16:creationId xmlns:a16="http://schemas.microsoft.com/office/drawing/2014/main" id="{511F57A7-762C-4D37-8F49-16534F6E3688}"/>
+                <a16:creationId xmlns:a16="http://schemas.microsoft.com/office/drawing/2014/main" id="{AC854343-9711-419C-8293-33E1296BC543}"/>
               </a:ext>
             </a:extLst>
           </p:cNvPr>
@@ -8474,7 +8474,7 @@
           <p:cNvPr id="31" name="">
             <a:extLst xmlns:a="http://schemas.openxmlformats.org/drawingml/2006/main">
               <a:ext uri="{FF2B5EF4-FFF2-40B4-BE49-F238E27FC236}">
-                <a16:creationId xmlns:a16="http://schemas.microsoft.com/office/drawing/2014/main" id="{9DD42C79-A6DF-4214-92B4-FF3BC7E97771}"/>
+                <a16:creationId xmlns:a16="http://schemas.microsoft.com/office/drawing/2014/main" id="{F96404E8-759E-428D-8894-07E1EFA0A192}"/>
               </a:ext>
             </a:extLst>
           </p:cNvPr>
@@ -8505,7 +8505,7 @@
           <p:cNvPr id="32" name="">
             <a:extLst xmlns:a="http://schemas.openxmlformats.org/drawingml/2006/main">
               <a:ext uri="{FF2B5EF4-FFF2-40B4-BE49-F238E27FC236}">
-                <a16:creationId xmlns:a16="http://schemas.microsoft.com/office/drawing/2014/main" id="{94772283-AFB3-4222-8B51-E7300FB41B13}"/>
+                <a16:creationId xmlns:a16="http://schemas.microsoft.com/office/drawing/2014/main" id="{3F277E54-191D-445C-BFE9-6842B17714F3}"/>
               </a:ext>
             </a:extLst>
           </p:cNvPr>
@@ -8536,7 +8536,7 @@
           <p:cNvPr id="33" name="">
             <a:extLst xmlns:a="http://schemas.openxmlformats.org/drawingml/2006/main">
               <a:ext uri="{FF2B5EF4-FFF2-40B4-BE49-F238E27FC236}">
-                <a16:creationId xmlns:a16="http://schemas.microsoft.com/office/drawing/2014/main" id="{75BF3F22-7ED7-4910-A651-EF226D19BEB5}"/>
+                <a16:creationId xmlns:a16="http://schemas.microsoft.com/office/drawing/2014/main" id="{97ACCF96-22D8-478A-B1D8-B5DA981A74E5}"/>
               </a:ext>
             </a:extLst>
           </p:cNvPr>
@@ -8567,7 +8567,7 @@
           <p:cNvPr id="34" name="">
             <a:extLst xmlns:a="http://schemas.openxmlformats.org/drawingml/2006/main">
               <a:ext uri="{FF2B5EF4-FFF2-40B4-BE49-F238E27FC236}">
-                <a16:creationId xmlns:a16="http://schemas.microsoft.com/office/drawing/2014/main" id="{A97ABD10-CF56-4827-AA75-7FEEC88584E8}"/>
+                <a16:creationId xmlns:a16="http://schemas.microsoft.com/office/drawing/2014/main" id="{BBBAE7F3-EAD3-44D7-BE45-A1C2B8F0E7BA}"/>
               </a:ext>
             </a:extLst>
           </p:cNvPr>
@@ -8598,7 +8598,7 @@
           <p:cNvPr id="35" name="">
             <a:extLst xmlns:a="http://schemas.openxmlformats.org/drawingml/2006/main">
               <a:ext uri="{FF2B5EF4-FFF2-40B4-BE49-F238E27FC236}">
-                <a16:creationId xmlns:a16="http://schemas.microsoft.com/office/drawing/2014/main" id="{CE725004-CBE7-4158-A92D-68F9D67EA589}"/>
+                <a16:creationId xmlns:a16="http://schemas.microsoft.com/office/drawing/2014/main" id="{9040A73C-3132-442F-9E7A-638D903F836A}"/>
               </a:ext>
             </a:extLst>
           </p:cNvPr>
@@ -8629,7 +8629,7 @@
           <p:cNvPr id="36" name="">
             <a:extLst xmlns:a="http://schemas.openxmlformats.org/drawingml/2006/main">
               <a:ext uri="{FF2B5EF4-FFF2-40B4-BE49-F238E27FC236}">
-                <a16:creationId xmlns:a16="http://schemas.microsoft.com/office/drawing/2014/main" id="{A0017E67-CE66-46AC-97B4-DFFFF5B8BDE9}"/>
+                <a16:creationId xmlns:a16="http://schemas.microsoft.com/office/drawing/2014/main" id="{7079B35F-5CC4-43C0-9B19-CFCF05CD9AED}"/>
               </a:ext>
             </a:extLst>
           </p:cNvPr>
@@ -8679,7 +8679,7 @@
           <p:cNvPr id="37" name="">
             <a:extLst xmlns:a="http://schemas.openxmlformats.org/drawingml/2006/main">
               <a:ext uri="{FF2B5EF4-FFF2-40B4-BE49-F238E27FC236}">
-                <a16:creationId xmlns:a16="http://schemas.microsoft.com/office/drawing/2014/main" id="{60BC0C2F-8A12-44C5-9CF3-F4831851B235}"/>
+                <a16:creationId xmlns:a16="http://schemas.microsoft.com/office/drawing/2014/main" id="{64A1A6EE-7C25-4DF9-9304-0D13529EEAE8}"/>
               </a:ext>
             </a:extLst>
           </p:cNvPr>
@@ -8729,7 +8729,7 @@
           <p:cNvPr id="38" name="">
             <a:extLst xmlns:a="http://schemas.openxmlformats.org/drawingml/2006/main">
               <a:ext uri="{FF2B5EF4-FFF2-40B4-BE49-F238E27FC236}">
-                <a16:creationId xmlns:a16="http://schemas.microsoft.com/office/drawing/2014/main" id="{10A01D04-3034-4B08-A2E8-CE48B1DD6BC5}"/>
+                <a16:creationId xmlns:a16="http://schemas.microsoft.com/office/drawing/2014/main" id="{88450BED-F472-48A7-AB52-A1B549B624DB}"/>
               </a:ext>
             </a:extLst>
           </p:cNvPr>
@@ -8779,7 +8779,7 @@
           <p:cNvPr id="39" name="">
             <a:extLst xmlns:a="http://schemas.openxmlformats.org/drawingml/2006/main">
               <a:ext uri="{FF2B5EF4-FFF2-40B4-BE49-F238E27FC236}">
-                <a16:creationId xmlns:a16="http://schemas.microsoft.com/office/drawing/2014/main" id="{2B745500-F46B-489C-B7CB-A627273990E5}"/>
+                <a16:creationId xmlns:a16="http://schemas.microsoft.com/office/drawing/2014/main" id="{A6AE5084-B0BB-4C6A-BBC9-BB1F1526D8D9}"/>
               </a:ext>
             </a:extLst>
           </p:cNvPr>
@@ -8812,7 +8812,7 @@
           <p:cNvPr id="40" name="">
             <a:extLst xmlns:a="http://schemas.openxmlformats.org/drawingml/2006/main">
               <a:ext uri="{FF2B5EF4-FFF2-40B4-BE49-F238E27FC236}">
-                <a16:creationId xmlns:a16="http://schemas.microsoft.com/office/drawing/2014/main" id="{45833E11-BD4D-470F-9BA3-BBEBD5508793}"/>
+                <a16:creationId xmlns:a16="http://schemas.microsoft.com/office/drawing/2014/main" id="{D711C205-A843-4AD9-9C0C-BF2E79B98344}"/>
               </a:ext>
             </a:extLst>
           </p:cNvPr>
@@ -8845,7 +8845,7 @@
           <p:cNvPr id="41" name="">
             <a:extLst xmlns:a="http://schemas.openxmlformats.org/drawingml/2006/main">
               <a:ext uri="{FF2B5EF4-FFF2-40B4-BE49-F238E27FC236}">
-                <a16:creationId xmlns:a16="http://schemas.microsoft.com/office/drawing/2014/main" id="{13894F8A-AFDE-4D81-97E4-C6317861174B}"/>
+                <a16:creationId xmlns:a16="http://schemas.microsoft.com/office/drawing/2014/main" id="{8EC53C3E-F8E1-4F2E-9831-13B0D969030A}"/>
               </a:ext>
             </a:extLst>
           </p:cNvPr>
@@ -8876,7 +8876,7 @@
           <p:cNvPr id="42" name="">
             <a:extLst xmlns:a="http://schemas.openxmlformats.org/drawingml/2006/main">
               <a:ext uri="{FF2B5EF4-FFF2-40B4-BE49-F238E27FC236}">
-                <a16:creationId xmlns:a16="http://schemas.microsoft.com/office/drawing/2014/main" id="{B5400772-7DE2-4702-ABC7-4CE6DF481C8F}"/>
+                <a16:creationId xmlns:a16="http://schemas.microsoft.com/office/drawing/2014/main" id="{D79CEFA7-F70C-4876-9F5B-A9E022501A15}"/>
               </a:ext>
             </a:extLst>
           </p:cNvPr>
@@ -8926,7 +8926,7 @@
           <p:cNvPr id="43" name="">
             <a:extLst xmlns:a="http://schemas.openxmlformats.org/drawingml/2006/main">
               <a:ext uri="{FF2B5EF4-FFF2-40B4-BE49-F238E27FC236}">
-                <a16:creationId xmlns:a16="http://schemas.microsoft.com/office/drawing/2014/main" id="{64E67370-6DEB-493B-ACEE-EF3D4EEC8581}"/>
+                <a16:creationId xmlns:a16="http://schemas.microsoft.com/office/drawing/2014/main" id="{279217AA-BE2C-4C41-BF4D-D8081B2A71AA}"/>
               </a:ext>
             </a:extLst>
           </p:cNvPr>
@@ -8976,7 +8976,7 @@
           <p:cNvPr id="44" name="">
             <a:extLst xmlns:a="http://schemas.openxmlformats.org/drawingml/2006/main">
               <a:ext uri="{FF2B5EF4-FFF2-40B4-BE49-F238E27FC236}">
-                <a16:creationId xmlns:a16="http://schemas.microsoft.com/office/drawing/2014/main" id="{24E56A41-3904-48D3-A88E-1776104244FC}"/>
+                <a16:creationId xmlns:a16="http://schemas.microsoft.com/office/drawing/2014/main" id="{46E39BBD-DE97-4434-8CBB-CE5D3B574564}"/>
               </a:ext>
             </a:extLst>
           </p:cNvPr>
@@ -9024,7 +9024,7 @@
     </p:spTree>
     <p:extLst>
       <p:ext uri="{BB962C8B-B14F-4D97-AF65-F5344CB8AC3E}">
-        <p14:creationId xmlns:p14="http://schemas.microsoft.com/office/powerpoint/2010/main" val="1780826296"/>
+        <p14:creationId xmlns:p14="http://schemas.microsoft.com/office/powerpoint/2010/main" val="1895170647"/>
       </p:ext>
     </p:extLst>
   </p:cSld>
@@ -9055,7 +9055,7 @@
           <p:cNvPr id="36" name="">
             <a:extLst xmlns:a="http://schemas.openxmlformats.org/drawingml/2006/main">
               <a:ext uri="{FF2B5EF4-FFF2-40B4-BE49-F238E27FC236}">
-                <a16:creationId xmlns:a16="http://schemas.microsoft.com/office/drawing/2014/main" id="{75B8E491-8381-4FBA-B164-8D105E837CDB}"/>
+                <a16:creationId xmlns:a16="http://schemas.microsoft.com/office/drawing/2014/main" id="{6A1FDA45-B653-4CF2-A0DD-289FE922E6D1}"/>
               </a:ext>
             </a:extLst>
           </p:cNvPr>
@@ -9105,7 +9105,7 @@
           <p:cNvPr id="2" name="">
             <a:extLst xmlns:a="http://schemas.openxmlformats.org/drawingml/2006/main">
               <a:ext uri="{FF2B5EF4-FFF2-40B4-BE49-F238E27FC236}">
-                <a16:creationId xmlns:a16="http://schemas.microsoft.com/office/drawing/2014/main" id="{BCACD74A-0E78-461C-B697-48760DB8E62F}"/>
+                <a16:creationId xmlns:a16="http://schemas.microsoft.com/office/drawing/2014/main" id="{F922980B-8BC1-427E-887C-C0F0FBC94209}"/>
               </a:ext>
             </a:extLst>
           </p:cNvPr>
@@ -9155,7 +9155,7 @@
           <p:cNvPr id="3" name="">
             <a:extLst xmlns:a="http://schemas.openxmlformats.org/drawingml/2006/main">
               <a:ext uri="{FF2B5EF4-FFF2-40B4-BE49-F238E27FC236}">
-                <a16:creationId xmlns:a16="http://schemas.microsoft.com/office/drawing/2014/main" id="{A39226FF-F366-4B7C-9428-E5FAFF40CF4C}"/>
+                <a16:creationId xmlns:a16="http://schemas.microsoft.com/office/drawing/2014/main" id="{CE11A863-93E9-4C7A-BA2D-F95FD5E54539}"/>
               </a:ext>
             </a:extLst>
           </p:cNvPr>
@@ -9205,7 +9205,7 @@
           <p:cNvPr id="4" name="">
             <a:extLst xmlns:a="http://schemas.openxmlformats.org/drawingml/2006/main">
               <a:ext uri="{FF2B5EF4-FFF2-40B4-BE49-F238E27FC236}">
-                <a16:creationId xmlns:a16="http://schemas.microsoft.com/office/drawing/2014/main" id="{55166C61-D936-4B1E-B63E-855FDFD57946}"/>
+                <a16:creationId xmlns:a16="http://schemas.microsoft.com/office/drawing/2014/main" id="{FC5A1110-84C8-4C73-92EF-39F2E132142B}"/>
               </a:ext>
             </a:extLst>
           </p:cNvPr>
@@ -9255,7 +9255,7 @@
           <p:cNvPr id="5" name="">
             <a:extLst xmlns:a="http://schemas.openxmlformats.org/drawingml/2006/main">
               <a:ext uri="{FF2B5EF4-FFF2-40B4-BE49-F238E27FC236}">
-                <a16:creationId xmlns:a16="http://schemas.microsoft.com/office/drawing/2014/main" id="{F1FCE7C4-0A8F-4E1E-AAEA-4EB28979F903}"/>
+                <a16:creationId xmlns:a16="http://schemas.microsoft.com/office/drawing/2014/main" id="{C0B4ED78-48B9-4CBA-A5FC-15A0D8A2113E}"/>
               </a:ext>
             </a:extLst>
           </p:cNvPr>
@@ -9290,7 +9290,7 @@
           <p:cNvPr id="6" name="">
             <a:extLst xmlns:a="http://schemas.openxmlformats.org/drawingml/2006/main">
               <a:ext uri="{FF2B5EF4-FFF2-40B4-BE49-F238E27FC236}">
-                <a16:creationId xmlns:a16="http://schemas.microsoft.com/office/drawing/2014/main" id="{40E1A632-C3D2-42B7-A90D-09E6AB849DB3}"/>
+                <a16:creationId xmlns:a16="http://schemas.microsoft.com/office/drawing/2014/main" id="{490EAA13-F3B2-4B25-B626-DB5C29A171DD}"/>
               </a:ext>
             </a:extLst>
           </p:cNvPr>
@@ -9340,7 +9340,7 @@
           <p:cNvPr id="7" name="">
             <a:extLst xmlns:a="http://schemas.openxmlformats.org/drawingml/2006/main">
               <a:ext uri="{FF2B5EF4-FFF2-40B4-BE49-F238E27FC236}">
-                <a16:creationId xmlns:a16="http://schemas.microsoft.com/office/drawing/2014/main" id="{E05945B3-226B-443E-A02A-518673CAD457}"/>
+                <a16:creationId xmlns:a16="http://schemas.microsoft.com/office/drawing/2014/main" id="{371C54C7-9B8A-48F3-994C-1117DFC6438C}"/>
               </a:ext>
             </a:extLst>
           </p:cNvPr>
@@ -9390,7 +9390,7 @@
           <p:cNvPr id="8" name="">
             <a:extLst xmlns:a="http://schemas.openxmlformats.org/drawingml/2006/main">
               <a:ext uri="{FF2B5EF4-FFF2-40B4-BE49-F238E27FC236}">
-                <a16:creationId xmlns:a16="http://schemas.microsoft.com/office/drawing/2014/main" id="{F2A1F3BD-6933-405E-AFEF-B4E02D90E4E5}"/>
+                <a16:creationId xmlns:a16="http://schemas.microsoft.com/office/drawing/2014/main" id="{283D42AC-6FAC-471F-B225-8AFA473D52A4}"/>
               </a:ext>
             </a:extLst>
           </p:cNvPr>
@@ -9440,7 +9440,7 @@
           <p:cNvPr id="9" name="">
             <a:extLst xmlns:a="http://schemas.openxmlformats.org/drawingml/2006/main">
               <a:ext uri="{FF2B5EF4-FFF2-40B4-BE49-F238E27FC236}">
-                <a16:creationId xmlns:a16="http://schemas.microsoft.com/office/drawing/2014/main" id="{38A025F4-9854-4FA1-96FE-E7CC88D92B08}"/>
+                <a16:creationId xmlns:a16="http://schemas.microsoft.com/office/drawing/2014/main" id="{F3ECD5C7-A9F8-49BE-ABD8-C86606874708}"/>
               </a:ext>
             </a:extLst>
           </p:cNvPr>
@@ -9490,7 +9490,7 @@
           <p:cNvPr id="10" name="">
             <a:extLst xmlns:a="http://schemas.openxmlformats.org/drawingml/2006/main">
               <a:ext uri="{FF2B5EF4-FFF2-40B4-BE49-F238E27FC236}">
-                <a16:creationId xmlns:a16="http://schemas.microsoft.com/office/drawing/2014/main" id="{DB08F637-4CE2-4C2B-A9B9-2B4C2E506334}"/>
+                <a16:creationId xmlns:a16="http://schemas.microsoft.com/office/drawing/2014/main" id="{A177EE0D-7BEA-45E0-A0A3-9EF45593D4FD}"/>
               </a:ext>
             </a:extLst>
           </p:cNvPr>
@@ -9525,7 +9525,7 @@
           <p:cNvPr id="11" name="">
             <a:extLst xmlns:a="http://schemas.openxmlformats.org/drawingml/2006/main">
               <a:ext uri="{FF2B5EF4-FFF2-40B4-BE49-F238E27FC236}">
-                <a16:creationId xmlns:a16="http://schemas.microsoft.com/office/drawing/2014/main" id="{0936CACB-4A39-4CE8-AF75-6AA16D0825B1}"/>
+                <a16:creationId xmlns:a16="http://schemas.microsoft.com/office/drawing/2014/main" id="{15A24C1F-8BFA-42E4-99EA-69055B382209}"/>
               </a:ext>
             </a:extLst>
           </p:cNvPr>
@@ -9575,7 +9575,7 @@
           <p:cNvPr id="12" name="">
             <a:extLst xmlns:a="http://schemas.openxmlformats.org/drawingml/2006/main">
               <a:ext uri="{FF2B5EF4-FFF2-40B4-BE49-F238E27FC236}">
-                <a16:creationId xmlns:a16="http://schemas.microsoft.com/office/drawing/2014/main" id="{F858DA45-C476-4A8C-906E-8645D764C80A}"/>
+                <a16:creationId xmlns:a16="http://schemas.microsoft.com/office/drawing/2014/main" id="{5500E35E-B416-4469-82AA-C74886A0DC15}"/>
               </a:ext>
             </a:extLst>
           </p:cNvPr>
@@ -9625,7 +9625,7 @@
           <p:cNvPr id="13" name="">
             <a:extLst xmlns:a="http://schemas.openxmlformats.org/drawingml/2006/main">
               <a:ext uri="{FF2B5EF4-FFF2-40B4-BE49-F238E27FC236}">
-                <a16:creationId xmlns:a16="http://schemas.microsoft.com/office/drawing/2014/main" id="{65C46064-4BA5-4470-BD88-06074CF8B76F}"/>
+                <a16:creationId xmlns:a16="http://schemas.microsoft.com/office/drawing/2014/main" id="{CD32D393-AF12-4F20-8558-512A623454D5}"/>
               </a:ext>
             </a:extLst>
           </p:cNvPr>
@@ -9660,7 +9660,7 @@
           <p:cNvPr id="14" name="">
             <a:extLst xmlns:a="http://schemas.openxmlformats.org/drawingml/2006/main">
               <a:ext uri="{FF2B5EF4-FFF2-40B4-BE49-F238E27FC236}">
-                <a16:creationId xmlns:a16="http://schemas.microsoft.com/office/drawing/2014/main" id="{DAAB58F5-821D-44F8-BF92-EA4687CD9A23}"/>
+                <a16:creationId xmlns:a16="http://schemas.microsoft.com/office/drawing/2014/main" id="{03900627-0527-4901-826C-B0378F64F16F}"/>
               </a:ext>
             </a:extLst>
           </p:cNvPr>
@@ -9710,7 +9710,7 @@
           <p:cNvPr id="15" name="">
             <a:extLst xmlns:a="http://schemas.openxmlformats.org/drawingml/2006/main">
               <a:ext uri="{FF2B5EF4-FFF2-40B4-BE49-F238E27FC236}">
-                <a16:creationId xmlns:a16="http://schemas.microsoft.com/office/drawing/2014/main" id="{A446FB3E-51D4-4C26-B014-C1CB46E8FBCC}"/>
+                <a16:creationId xmlns:a16="http://schemas.microsoft.com/office/drawing/2014/main" id="{0F29C49E-0EE8-4D31-AD00-C3B030B8E52F}"/>
               </a:ext>
             </a:extLst>
           </p:cNvPr>
@@ -9760,7 +9760,7 @@
           <p:cNvPr id="16" name="">
             <a:extLst xmlns:a="http://schemas.openxmlformats.org/drawingml/2006/main">
               <a:ext uri="{FF2B5EF4-FFF2-40B4-BE49-F238E27FC236}">
-                <a16:creationId xmlns:a16="http://schemas.microsoft.com/office/drawing/2014/main" id="{400BCC2A-E7CF-4B9E-B87D-5B9599118ED0}"/>
+                <a16:creationId xmlns:a16="http://schemas.microsoft.com/office/drawing/2014/main" id="{DA0EBCB6-6778-46D6-9295-37ED249E438D}"/>
               </a:ext>
             </a:extLst>
           </p:cNvPr>
@@ -9799,7 +9799,7 @@
           <p:cNvPr id="17" name="">
             <a:extLst xmlns:a="http://schemas.openxmlformats.org/drawingml/2006/main">
               <a:ext uri="{FF2B5EF4-FFF2-40B4-BE49-F238E27FC236}">
-                <a16:creationId xmlns:a16="http://schemas.microsoft.com/office/drawing/2014/main" id="{BE8B4020-0CB7-44C9-9D2F-C329FBE22D32}"/>
+                <a16:creationId xmlns:a16="http://schemas.microsoft.com/office/drawing/2014/main" id="{1EC21719-E779-446C-A2B6-8EED0AAC8A6D}"/>
               </a:ext>
             </a:extLst>
           </p:cNvPr>
@@ -9849,7 +9849,7 @@
           <p:cNvPr id="18" name="">
             <a:extLst xmlns:a="http://schemas.openxmlformats.org/drawingml/2006/main">
               <a:ext uri="{FF2B5EF4-FFF2-40B4-BE49-F238E27FC236}">
-                <a16:creationId xmlns:a16="http://schemas.microsoft.com/office/drawing/2014/main" id="{5C0DEFD0-73CC-475C-8ABF-DBF020751E89}"/>
+                <a16:creationId xmlns:a16="http://schemas.microsoft.com/office/drawing/2014/main" id="{99229D97-51A8-4D39-BA41-BBC8DFF6DCEB}"/>
               </a:ext>
             </a:extLst>
           </p:cNvPr>
@@ -9899,7 +9899,7 @@
           <p:cNvPr id="19" name="">
             <a:extLst xmlns:a="http://schemas.openxmlformats.org/drawingml/2006/main">
               <a:ext uri="{FF2B5EF4-FFF2-40B4-BE49-F238E27FC236}">
-                <a16:creationId xmlns:a16="http://schemas.microsoft.com/office/drawing/2014/main" id="{CAC9E05F-D3A7-4115-8D22-5D5A7BE0CB96}"/>
+                <a16:creationId xmlns:a16="http://schemas.microsoft.com/office/drawing/2014/main" id="{E0C5D7A2-9B25-4295-A55D-21DD28E4CAFE}"/>
               </a:ext>
             </a:extLst>
           </p:cNvPr>
@@ -9949,7 +9949,7 @@
           <p:cNvPr id="20" name="">
             <a:extLst xmlns:a="http://schemas.openxmlformats.org/drawingml/2006/main">
               <a:ext uri="{FF2B5EF4-FFF2-40B4-BE49-F238E27FC236}">
-                <a16:creationId xmlns:a16="http://schemas.microsoft.com/office/drawing/2014/main" id="{2FEA5E43-F27D-4F77-8BBB-33F8D053B7B4}"/>
+                <a16:creationId xmlns:a16="http://schemas.microsoft.com/office/drawing/2014/main" id="{D3D20CF8-FBA8-48A6-8793-DF0FCDCD2FCF}"/>
               </a:ext>
             </a:extLst>
           </p:cNvPr>
@@ -9999,7 +9999,7 @@
           <p:cNvPr id="21" name="">
             <a:extLst xmlns:a="http://schemas.openxmlformats.org/drawingml/2006/main">
               <a:ext uri="{FF2B5EF4-FFF2-40B4-BE49-F238E27FC236}">
-                <a16:creationId xmlns:a16="http://schemas.microsoft.com/office/drawing/2014/main" id="{80E84BBE-F4C3-4984-8BAC-BF01430BEAB4}"/>
+                <a16:creationId xmlns:a16="http://schemas.microsoft.com/office/drawing/2014/main" id="{1FDEBF33-0EF8-4783-BF30-8020E684FBC8}"/>
               </a:ext>
             </a:extLst>
           </p:cNvPr>
@@ -10049,7 +10049,7 @@
           <p:cNvPr id="22" name="">
             <a:extLst xmlns:a="http://schemas.openxmlformats.org/drawingml/2006/main">
               <a:ext uri="{FF2B5EF4-FFF2-40B4-BE49-F238E27FC236}">
-                <a16:creationId xmlns:a16="http://schemas.microsoft.com/office/drawing/2014/main" id="{29B84D07-A34E-4EFD-9692-A1A217B8D34A}"/>
+                <a16:creationId xmlns:a16="http://schemas.microsoft.com/office/drawing/2014/main" id="{8EC3CEB7-6BCE-42ED-934E-0E574E42D946}"/>
               </a:ext>
             </a:extLst>
           </p:cNvPr>
@@ -10099,7 +10099,7 @@
           <p:cNvPr id="23" name="">
             <a:extLst xmlns:a="http://schemas.openxmlformats.org/drawingml/2006/main">
               <a:ext uri="{FF2B5EF4-FFF2-40B4-BE49-F238E27FC236}">
-                <a16:creationId xmlns:a16="http://schemas.microsoft.com/office/drawing/2014/main" id="{011BB15B-92AE-49D3-BDDE-FC3C3E042DEC}"/>
+                <a16:creationId xmlns:a16="http://schemas.microsoft.com/office/drawing/2014/main" id="{308AB33E-11D9-4456-AD31-5A85DDCCF6EE}"/>
               </a:ext>
             </a:extLst>
           </p:cNvPr>
@@ -10149,7 +10149,7 @@
           <p:cNvPr id="24" name="">
             <a:extLst xmlns:a="http://schemas.openxmlformats.org/drawingml/2006/main">
               <a:ext uri="{FF2B5EF4-FFF2-40B4-BE49-F238E27FC236}">
-                <a16:creationId xmlns:a16="http://schemas.microsoft.com/office/drawing/2014/main" id="{80EF6323-D9E7-4C92-9D18-F0C0AE5B3D45}"/>
+                <a16:creationId xmlns:a16="http://schemas.microsoft.com/office/drawing/2014/main" id="{5EA9308E-9744-483E-86E2-0B54D51390DD}"/>
               </a:ext>
             </a:extLst>
           </p:cNvPr>
@@ -10199,7 +10199,7 @@
           <p:cNvPr id="25" name="">
             <a:extLst xmlns:a="http://schemas.openxmlformats.org/drawingml/2006/main">
               <a:ext uri="{FF2B5EF4-FFF2-40B4-BE49-F238E27FC236}">
-                <a16:creationId xmlns:a16="http://schemas.microsoft.com/office/drawing/2014/main" id="{E1E1FD1D-DAB8-42C7-A26D-0DC858CDEC81}"/>
+                <a16:creationId xmlns:a16="http://schemas.microsoft.com/office/drawing/2014/main" id="{4D2E1EC0-F158-4E0D-B0B9-75A87D73688D}"/>
               </a:ext>
             </a:extLst>
           </p:cNvPr>
@@ -10249,7 +10249,7 @@
           <p:cNvPr id="26" name="">
             <a:extLst xmlns:a="http://schemas.openxmlformats.org/drawingml/2006/main">
               <a:ext uri="{FF2B5EF4-FFF2-40B4-BE49-F238E27FC236}">
-                <a16:creationId xmlns:a16="http://schemas.microsoft.com/office/drawing/2014/main" id="{56A496C3-CC85-43E7-A041-E6A9476866AF}"/>
+                <a16:creationId xmlns:a16="http://schemas.microsoft.com/office/drawing/2014/main" id="{DDBA5A96-D2E3-49DF-8A0D-E9A0E702B8EC}"/>
               </a:ext>
             </a:extLst>
           </p:cNvPr>
@@ -10299,7 +10299,7 @@
           <p:cNvPr id="27" name="">
             <a:extLst xmlns:a="http://schemas.openxmlformats.org/drawingml/2006/main">
               <a:ext uri="{FF2B5EF4-FFF2-40B4-BE49-F238E27FC236}">
-                <a16:creationId xmlns:a16="http://schemas.microsoft.com/office/drawing/2014/main" id="{94835E55-0B49-4B73-A48A-6C928034AC27}"/>
+                <a16:creationId xmlns:a16="http://schemas.microsoft.com/office/drawing/2014/main" id="{4984DD10-8DEC-4579-BEC8-0D4EE09767B7}"/>
               </a:ext>
             </a:extLst>
           </p:cNvPr>
@@ -10349,7 +10349,7 @@
           <p:cNvPr id="28" name="">
             <a:extLst xmlns:a="http://schemas.openxmlformats.org/drawingml/2006/main">
               <a:ext uri="{FF2B5EF4-FFF2-40B4-BE49-F238E27FC236}">
-                <a16:creationId xmlns:a16="http://schemas.microsoft.com/office/drawing/2014/main" id="{E8395BF6-BF8B-404F-BB56-4D5D4EEC8FD4}"/>
+                <a16:creationId xmlns:a16="http://schemas.microsoft.com/office/drawing/2014/main" id="{EE7F59DC-18A0-473A-A404-6A4CB1D4FB76}"/>
               </a:ext>
             </a:extLst>
           </p:cNvPr>
@@ -10399,7 +10399,7 @@
           <p:cNvPr id="29" name="">
             <a:extLst xmlns:a="http://schemas.openxmlformats.org/drawingml/2006/main">
               <a:ext uri="{FF2B5EF4-FFF2-40B4-BE49-F238E27FC236}">
-                <a16:creationId xmlns:a16="http://schemas.microsoft.com/office/drawing/2014/main" id="{A1F01E52-3343-4A37-9714-C90E78829754}"/>
+                <a16:creationId xmlns:a16="http://schemas.microsoft.com/office/drawing/2014/main" id="{D9879BD8-F502-4390-99A3-E9C14BA1620F}"/>
               </a:ext>
             </a:extLst>
           </p:cNvPr>
@@ -10449,7 +10449,7 @@
           <p:cNvPr id="30" name="">
             <a:extLst xmlns:a="http://schemas.openxmlformats.org/drawingml/2006/main">
               <a:ext uri="{FF2B5EF4-FFF2-40B4-BE49-F238E27FC236}">
-                <a16:creationId xmlns:a16="http://schemas.microsoft.com/office/drawing/2014/main" id="{0DCD1AF0-C9FE-48D0-8E7C-0A2F6502C515}"/>
+                <a16:creationId xmlns:a16="http://schemas.microsoft.com/office/drawing/2014/main" id="{F017E171-1660-4570-878D-519BEAE68C53}"/>
               </a:ext>
             </a:extLst>
           </p:cNvPr>
@@ -10499,7 +10499,7 @@
           <p:cNvPr id="31" name="">
             <a:extLst xmlns:a="http://schemas.openxmlformats.org/drawingml/2006/main">
               <a:ext uri="{FF2B5EF4-FFF2-40B4-BE49-F238E27FC236}">
-                <a16:creationId xmlns:a16="http://schemas.microsoft.com/office/drawing/2014/main" id="{18382294-FB9A-42E3-9497-4B8CA1859033}"/>
+                <a16:creationId xmlns:a16="http://schemas.microsoft.com/office/drawing/2014/main" id="{6C693755-BDBD-4131-9643-F5C7B6877092}"/>
               </a:ext>
             </a:extLst>
           </p:cNvPr>
@@ -10549,7 +10549,7 @@
           <p:cNvPr id="32" name="">
             <a:extLst xmlns:a="http://schemas.openxmlformats.org/drawingml/2006/main">
               <a:ext uri="{FF2B5EF4-FFF2-40B4-BE49-F238E27FC236}">
-                <a16:creationId xmlns:a16="http://schemas.microsoft.com/office/drawing/2014/main" id="{F7417A7F-0933-4254-B52E-FC89F95A01FF}"/>
+                <a16:creationId xmlns:a16="http://schemas.microsoft.com/office/drawing/2014/main" id="{41D0FE4B-29C7-4577-A2A5-955FE1925A87}"/>
               </a:ext>
             </a:extLst>
           </p:cNvPr>
@@ -10599,7 +10599,7 @@
           <p:cNvPr id="33" name="">
             <a:extLst xmlns:a="http://schemas.openxmlformats.org/drawingml/2006/main">
               <a:ext uri="{FF2B5EF4-FFF2-40B4-BE49-F238E27FC236}">
-                <a16:creationId xmlns:a16="http://schemas.microsoft.com/office/drawing/2014/main" id="{3A8AF81E-2505-4B44-8B73-1E760A9E6586}"/>
+                <a16:creationId xmlns:a16="http://schemas.microsoft.com/office/drawing/2014/main" id="{5859209E-61D5-4D3A-A320-E8EACFD82561}"/>
               </a:ext>
             </a:extLst>
           </p:cNvPr>
@@ -10649,7 +10649,7 @@
           <p:cNvPr id="34" name="">
             <a:extLst xmlns:a="http://schemas.openxmlformats.org/drawingml/2006/main">
               <a:ext uri="{FF2B5EF4-FFF2-40B4-BE49-F238E27FC236}">
-                <a16:creationId xmlns:a16="http://schemas.microsoft.com/office/drawing/2014/main" id="{0DDB1A3E-A830-4FC1-9CE2-C1ED556151F4}"/>
+                <a16:creationId xmlns:a16="http://schemas.microsoft.com/office/drawing/2014/main" id="{CCD36181-EAE5-4CB0-8A5C-36BA61551257}"/>
               </a:ext>
             </a:extLst>
           </p:cNvPr>
@@ -10699,7 +10699,7 @@
           <p:cNvPr id="35" name="">
             <a:extLst xmlns:a="http://schemas.openxmlformats.org/drawingml/2006/main">
               <a:ext uri="{FF2B5EF4-FFF2-40B4-BE49-F238E27FC236}">
-                <a16:creationId xmlns:a16="http://schemas.microsoft.com/office/drawing/2014/main" id="{636B045D-3DD7-4240-B834-51B768F4B53B}"/>
+                <a16:creationId xmlns:a16="http://schemas.microsoft.com/office/drawing/2014/main" id="{2423ACA9-7095-44B1-A73F-53070B072788}"/>
               </a:ext>
             </a:extLst>
           </p:cNvPr>
@@ -10747,7 +10747,7 @@
     </p:spTree>
     <p:extLst>
       <p:ext uri="{BB962C8B-B14F-4D97-AF65-F5344CB8AC3E}">
-        <p14:creationId xmlns:p14="http://schemas.microsoft.com/office/powerpoint/2010/main" val="2044141227"/>
+        <p14:creationId xmlns:p14="http://schemas.microsoft.com/office/powerpoint/2010/main" val="1519102978"/>
       </p:ext>
     </p:extLst>
   </p:cSld>
@@ -10778,7 +10778,7 @@
           <p:cNvPr id="23" name="">
             <a:extLst xmlns:a="http://schemas.openxmlformats.org/drawingml/2006/main">
               <a:ext uri="{FF2B5EF4-FFF2-40B4-BE49-F238E27FC236}">
-                <a16:creationId xmlns:a16="http://schemas.microsoft.com/office/drawing/2014/main" id="{76C88908-7BEE-48C7-A8D1-C4219C9857A3}"/>
+                <a16:creationId xmlns:a16="http://schemas.microsoft.com/office/drawing/2014/main" id="{50A1821D-DC49-48A5-ACB0-9A31361F3B81}"/>
               </a:ext>
             </a:extLst>
           </p:cNvPr>
@@ -10828,7 +10828,7 @@
           <p:cNvPr id="2" name="">
             <a:extLst xmlns:a="http://schemas.openxmlformats.org/drawingml/2006/main">
               <a:ext uri="{FF2B5EF4-FFF2-40B4-BE49-F238E27FC236}">
-                <a16:creationId xmlns:a16="http://schemas.microsoft.com/office/drawing/2014/main" id="{C56F92D5-BC28-4764-BFA1-0E16E9AE8537}"/>
+                <a16:creationId xmlns:a16="http://schemas.microsoft.com/office/drawing/2014/main" id="{AE5FF6D5-67E1-499C-9D9A-0F07241C0D68}"/>
               </a:ext>
             </a:extLst>
           </p:cNvPr>
@@ -10878,7 +10878,7 @@
           <p:cNvPr id="3" name="">
             <a:extLst xmlns:a="http://schemas.openxmlformats.org/drawingml/2006/main">
               <a:ext uri="{FF2B5EF4-FFF2-40B4-BE49-F238E27FC236}">
-                <a16:creationId xmlns:a16="http://schemas.microsoft.com/office/drawing/2014/main" id="{9B10563D-7F9C-43C9-85F9-8E419748010E}"/>
+                <a16:creationId xmlns:a16="http://schemas.microsoft.com/office/drawing/2014/main" id="{19D83C45-E71D-46A3-805F-8019F9F2BFBD}"/>
               </a:ext>
             </a:extLst>
           </p:cNvPr>
@@ -10919,7 +10919,7 @@
           <p:cNvPr id="4" name="">
             <a:extLst xmlns:a="http://schemas.openxmlformats.org/drawingml/2006/main">
               <a:ext uri="{FF2B5EF4-FFF2-40B4-BE49-F238E27FC236}">
-                <a16:creationId xmlns:a16="http://schemas.microsoft.com/office/drawing/2014/main" id="{92F72AE2-32DD-4BE5-A845-544A98D9310C}"/>
+                <a16:creationId xmlns:a16="http://schemas.microsoft.com/office/drawing/2014/main" id="{7D3D4722-2D32-45D7-B756-FC28C8A505F2}"/>
               </a:ext>
             </a:extLst>
           </p:cNvPr>
@@ -10969,7 +10969,7 @@
           <p:cNvPr id="5" name="">
             <a:extLst xmlns:a="http://schemas.openxmlformats.org/drawingml/2006/main">
               <a:ext uri="{FF2B5EF4-FFF2-40B4-BE49-F238E27FC236}">
-                <a16:creationId xmlns:a16="http://schemas.microsoft.com/office/drawing/2014/main" id="{B1F090F7-8FC2-4E33-B43F-55BDA59C4463}"/>
+                <a16:creationId xmlns:a16="http://schemas.microsoft.com/office/drawing/2014/main" id="{679EB811-DBCB-4242-BEC0-65D139D6B3D1}"/>
               </a:ext>
             </a:extLst>
           </p:cNvPr>
@@ -11019,7 +11019,7 @@
           <p:cNvPr id="6" name="">
             <a:extLst xmlns:a="http://schemas.openxmlformats.org/drawingml/2006/main">
               <a:ext uri="{FF2B5EF4-FFF2-40B4-BE49-F238E27FC236}">
-                <a16:creationId xmlns:a16="http://schemas.microsoft.com/office/drawing/2014/main" id="{EC14DC0C-2F3E-4873-B37B-33C63A6ABCA4}"/>
+                <a16:creationId xmlns:a16="http://schemas.microsoft.com/office/drawing/2014/main" id="{1312A257-4AD9-49AE-8A52-4CF6898C488F}"/>
               </a:ext>
             </a:extLst>
           </p:cNvPr>
@@ -11069,7 +11069,7 @@
           <p:cNvPr id="7" name="">
             <a:extLst xmlns:a="http://schemas.openxmlformats.org/drawingml/2006/main">
               <a:ext uri="{FF2B5EF4-FFF2-40B4-BE49-F238E27FC236}">
-                <a16:creationId xmlns:a16="http://schemas.microsoft.com/office/drawing/2014/main" id="{0B51CD15-E67E-4AD5-B086-CA30BCA6FA20}"/>
+                <a16:creationId xmlns:a16="http://schemas.microsoft.com/office/drawing/2014/main" id="{0F5FB7E2-5331-4161-8DA3-0D295DB7E045}"/>
               </a:ext>
             </a:extLst>
           </p:cNvPr>
@@ -11119,7 +11119,7 @@
           <p:cNvPr id="8" name="">
             <a:extLst xmlns:a="http://schemas.openxmlformats.org/drawingml/2006/main">
               <a:ext uri="{FF2B5EF4-FFF2-40B4-BE49-F238E27FC236}">
-                <a16:creationId xmlns:a16="http://schemas.microsoft.com/office/drawing/2014/main" id="{EE58230E-632C-4678-BF99-8C3E019320F1}"/>
+                <a16:creationId xmlns:a16="http://schemas.microsoft.com/office/drawing/2014/main" id="{E3E5237E-DF95-4FF6-9122-F936984AAC7B}"/>
               </a:ext>
             </a:extLst>
           </p:cNvPr>
@@ -11150,7 +11150,7 @@
           <p:cNvPr id="9" name="">
             <a:extLst xmlns:a="http://schemas.openxmlformats.org/drawingml/2006/main">
               <a:ext uri="{FF2B5EF4-FFF2-40B4-BE49-F238E27FC236}">
-                <a16:creationId xmlns:a16="http://schemas.microsoft.com/office/drawing/2014/main" id="{E1D2439F-91EC-4853-A57F-05A988307C16}"/>
+                <a16:creationId xmlns:a16="http://schemas.microsoft.com/office/drawing/2014/main" id="{8EFA2B8A-FFB8-49E8-B56A-85CF9E2A8D3B}"/>
               </a:ext>
             </a:extLst>
           </p:cNvPr>
@@ -11200,7 +11200,7 @@
           <p:cNvPr id="10" name="">
             <a:extLst xmlns:a="http://schemas.openxmlformats.org/drawingml/2006/main">
               <a:ext uri="{FF2B5EF4-FFF2-40B4-BE49-F238E27FC236}">
-                <a16:creationId xmlns:a16="http://schemas.microsoft.com/office/drawing/2014/main" id="{B0A3084F-DF5D-47EE-B850-8E8C807CE51D}"/>
+                <a16:creationId xmlns:a16="http://schemas.microsoft.com/office/drawing/2014/main" id="{08C860DC-F51E-4374-BB50-442DF5AAD2AC}"/>
               </a:ext>
             </a:extLst>
           </p:cNvPr>
@@ -11250,7 +11250,7 @@
           <p:cNvPr id="11" name="">
             <a:extLst xmlns:a="http://schemas.openxmlformats.org/drawingml/2006/main">
               <a:ext uri="{FF2B5EF4-FFF2-40B4-BE49-F238E27FC236}">
-                <a16:creationId xmlns:a16="http://schemas.microsoft.com/office/drawing/2014/main" id="{E9B0C448-201B-472B-9260-B31EB2E36344}"/>
+                <a16:creationId xmlns:a16="http://schemas.microsoft.com/office/drawing/2014/main" id="{2FC680BB-C123-41A5-82AD-8C17620BA785}"/>
               </a:ext>
             </a:extLst>
           </p:cNvPr>
@@ -11300,7 +11300,7 @@
           <p:cNvPr id="12" name="">
             <a:extLst xmlns:a="http://schemas.openxmlformats.org/drawingml/2006/main">
               <a:ext uri="{FF2B5EF4-FFF2-40B4-BE49-F238E27FC236}">
-                <a16:creationId xmlns:a16="http://schemas.microsoft.com/office/drawing/2014/main" id="{71DEF22A-E96F-434B-96B6-B3049BAC9627}"/>
+                <a16:creationId xmlns:a16="http://schemas.microsoft.com/office/drawing/2014/main" id="{385B2D65-39FA-4DDA-82C2-CC6A5CCD4B47}"/>
               </a:ext>
             </a:extLst>
           </p:cNvPr>
@@ -11331,7 +11331,7 @@
           <p:cNvPr id="13" name="">
             <a:extLst xmlns:a="http://schemas.openxmlformats.org/drawingml/2006/main">
               <a:ext uri="{FF2B5EF4-FFF2-40B4-BE49-F238E27FC236}">
-                <a16:creationId xmlns:a16="http://schemas.microsoft.com/office/drawing/2014/main" id="{885734DE-FC2B-4CBA-AF0C-F3F978B8AD02}"/>
+                <a16:creationId xmlns:a16="http://schemas.microsoft.com/office/drawing/2014/main" id="{387ABD5C-0445-4A2A-922B-7229E2CE88E5}"/>
               </a:ext>
             </a:extLst>
           </p:cNvPr>
@@ -11381,7 +11381,7 @@
           <p:cNvPr id="14" name="">
             <a:extLst xmlns:a="http://schemas.openxmlformats.org/drawingml/2006/main">
               <a:ext uri="{FF2B5EF4-FFF2-40B4-BE49-F238E27FC236}">
-                <a16:creationId xmlns:a16="http://schemas.microsoft.com/office/drawing/2014/main" id="{F19EE6BC-AC32-4D54-8CC2-5D886DB9EA67}"/>
+                <a16:creationId xmlns:a16="http://schemas.microsoft.com/office/drawing/2014/main" id="{76B3ED56-D836-49B9-A8CF-61B43DDB47E8}"/>
               </a:ext>
             </a:extLst>
           </p:cNvPr>
@@ -11420,7 +11420,7 @@
           <p:cNvPr id="15" name="">
             <a:extLst xmlns:a="http://schemas.openxmlformats.org/drawingml/2006/main">
               <a:ext uri="{FF2B5EF4-FFF2-40B4-BE49-F238E27FC236}">
-                <a16:creationId xmlns:a16="http://schemas.microsoft.com/office/drawing/2014/main" id="{210D8F15-E03E-4D7E-8B0B-84E8A361C8AC}"/>
+                <a16:creationId xmlns:a16="http://schemas.microsoft.com/office/drawing/2014/main" id="{160CE69C-8685-43F1-B384-4E1676878858}"/>
               </a:ext>
             </a:extLst>
           </p:cNvPr>
@@ -11470,7 +11470,7 @@
           <p:cNvPr id="16" name="">
             <a:extLst xmlns:a="http://schemas.openxmlformats.org/drawingml/2006/main">
               <a:ext uri="{FF2B5EF4-FFF2-40B4-BE49-F238E27FC236}">
-                <a16:creationId xmlns:a16="http://schemas.microsoft.com/office/drawing/2014/main" id="{35017017-BA9E-4DA8-B71E-92B167C6BAAE}"/>
+                <a16:creationId xmlns:a16="http://schemas.microsoft.com/office/drawing/2014/main" id="{C2E0A6E3-ED5A-4D42-BBE9-CF868942C124}"/>
               </a:ext>
             </a:extLst>
           </p:cNvPr>
@@ -11520,7 +11520,7 @@
           <p:cNvPr id="17" name="">
             <a:extLst xmlns:a="http://schemas.openxmlformats.org/drawingml/2006/main">
               <a:ext uri="{FF2B5EF4-FFF2-40B4-BE49-F238E27FC236}">
-                <a16:creationId xmlns:a16="http://schemas.microsoft.com/office/drawing/2014/main" id="{C661FCC8-A316-4A4E-B86D-039FA47901C4}"/>
+                <a16:creationId xmlns:a16="http://schemas.microsoft.com/office/drawing/2014/main" id="{AB52E2F6-ED2B-46A0-8AED-854B42B55B1D}"/>
               </a:ext>
             </a:extLst>
           </p:cNvPr>
@@ -11570,7 +11570,7 @@
           <p:cNvPr id="18" name="">
             <a:extLst xmlns:a="http://schemas.openxmlformats.org/drawingml/2006/main">
               <a:ext uri="{FF2B5EF4-FFF2-40B4-BE49-F238E27FC236}">
-                <a16:creationId xmlns:a16="http://schemas.microsoft.com/office/drawing/2014/main" id="{139F8EE5-6F58-4B29-9067-FF7705A8B877}"/>
+                <a16:creationId xmlns:a16="http://schemas.microsoft.com/office/drawing/2014/main" id="{3FD176CD-CEEF-476B-AA63-1C7A8FB84B89}"/>
               </a:ext>
             </a:extLst>
           </p:cNvPr>
@@ -11620,7 +11620,7 @@
           <p:cNvPr id="19" name="">
             <a:extLst xmlns:a="http://schemas.openxmlformats.org/drawingml/2006/main">
               <a:ext uri="{FF2B5EF4-FFF2-40B4-BE49-F238E27FC236}">
-                <a16:creationId xmlns:a16="http://schemas.microsoft.com/office/drawing/2014/main" id="{5E0FCA6A-37AB-46E2-955B-4D079CA6D3E3}"/>
+                <a16:creationId xmlns:a16="http://schemas.microsoft.com/office/drawing/2014/main" id="{EC9565EE-E694-425D-B762-B147FA18650A}"/>
               </a:ext>
             </a:extLst>
           </p:cNvPr>
@@ -11651,7 +11651,7 @@
           <p:cNvPr id="20" name="">
             <a:extLst xmlns:a="http://schemas.openxmlformats.org/drawingml/2006/main">
               <a:ext uri="{FF2B5EF4-FFF2-40B4-BE49-F238E27FC236}">
-                <a16:creationId xmlns:a16="http://schemas.microsoft.com/office/drawing/2014/main" id="{C9F70299-EDC7-499C-920C-9F0D2C80DE3C}"/>
+                <a16:creationId xmlns:a16="http://schemas.microsoft.com/office/drawing/2014/main" id="{35FC69FE-AC01-4AA1-86C2-5A894CA4994B}"/>
               </a:ext>
             </a:extLst>
           </p:cNvPr>
@@ -11701,7 +11701,7 @@
           <p:cNvPr id="21" name="">
             <a:extLst xmlns:a="http://schemas.openxmlformats.org/drawingml/2006/main">
               <a:ext uri="{FF2B5EF4-FFF2-40B4-BE49-F238E27FC236}">
-                <a16:creationId xmlns:a16="http://schemas.microsoft.com/office/drawing/2014/main" id="{F4A0B1BD-EA41-4262-A60A-50DE71BF40E7}"/>
+                <a16:creationId xmlns:a16="http://schemas.microsoft.com/office/drawing/2014/main" id="{92984B63-15A6-4C40-B3F4-AA61723FFAFC}"/>
               </a:ext>
             </a:extLst>
           </p:cNvPr>
@@ -11751,7 +11751,7 @@
           <p:cNvPr id="22" name="">
             <a:extLst xmlns:a="http://schemas.openxmlformats.org/drawingml/2006/main">
               <a:ext uri="{FF2B5EF4-FFF2-40B4-BE49-F238E27FC236}">
-                <a16:creationId xmlns:a16="http://schemas.microsoft.com/office/drawing/2014/main" id="{71A94592-977C-4CB4-8437-4AC5CDD17655}"/>
+                <a16:creationId xmlns:a16="http://schemas.microsoft.com/office/drawing/2014/main" id="{CA72D948-4392-4E82-A919-D4606BFB22C8}"/>
               </a:ext>
             </a:extLst>
           </p:cNvPr>
@@ -11799,7 +11799,7 @@
     </p:spTree>
     <p:extLst>
       <p:ext uri="{BB962C8B-B14F-4D97-AF65-F5344CB8AC3E}">
-        <p14:creationId xmlns:p14="http://schemas.microsoft.com/office/powerpoint/2010/main" val="2099658716"/>
+        <p14:creationId xmlns:p14="http://schemas.microsoft.com/office/powerpoint/2010/main" val="1462204666"/>
       </p:ext>
     </p:extLst>
   </p:cSld>
@@ -11830,7 +11830,7 @@
           <p:cNvPr id="31" name="">
             <a:extLst xmlns:a="http://schemas.openxmlformats.org/drawingml/2006/main">
               <a:ext uri="{FF2B5EF4-FFF2-40B4-BE49-F238E27FC236}">
-                <a16:creationId xmlns:a16="http://schemas.microsoft.com/office/drawing/2014/main" id="{76FE3897-2419-4F22-AA50-21070D2004F9}"/>
+                <a16:creationId xmlns:a16="http://schemas.microsoft.com/office/drawing/2014/main" id="{A16B0294-ADBC-42BB-8C58-A45982E3C9F2}"/>
               </a:ext>
             </a:extLst>
           </p:cNvPr>
@@ -11880,7 +11880,7 @@
           <p:cNvPr id="2" name="">
             <a:extLst xmlns:a="http://schemas.openxmlformats.org/drawingml/2006/main">
               <a:ext uri="{FF2B5EF4-FFF2-40B4-BE49-F238E27FC236}">
-                <a16:creationId xmlns:a16="http://schemas.microsoft.com/office/drawing/2014/main" id="{F171A403-790A-48EE-A48A-8C26CD4BCFBE}"/>
+                <a16:creationId xmlns:a16="http://schemas.microsoft.com/office/drawing/2014/main" id="{13AD0B58-AF01-4AAD-A066-7C264CF020A0}"/>
               </a:ext>
             </a:extLst>
           </p:cNvPr>
@@ -11930,7 +11930,7 @@
           <p:cNvPr id="3" name="">
             <a:extLst xmlns:a="http://schemas.openxmlformats.org/drawingml/2006/main">
               <a:ext uri="{FF2B5EF4-FFF2-40B4-BE49-F238E27FC236}">
-                <a16:creationId xmlns:a16="http://schemas.microsoft.com/office/drawing/2014/main" id="{D990C4AD-9C02-48D1-B3EA-8C02B2A1E1F3}"/>
+                <a16:creationId xmlns:a16="http://schemas.microsoft.com/office/drawing/2014/main" id="{7F6AE0D8-4ABF-4D4C-BA09-878BD458A26F}"/>
               </a:ext>
             </a:extLst>
           </p:cNvPr>
@@ -11969,7 +11969,7 @@
           <p:cNvPr id="4" name="">
             <a:extLst xmlns:a="http://schemas.openxmlformats.org/drawingml/2006/main">
               <a:ext uri="{FF2B5EF4-FFF2-40B4-BE49-F238E27FC236}">
-                <a16:creationId xmlns:a16="http://schemas.microsoft.com/office/drawing/2014/main" id="{647005FF-F930-44F7-A5A7-AE7CD3514DD3}"/>
+                <a16:creationId xmlns:a16="http://schemas.microsoft.com/office/drawing/2014/main" id="{E82991D4-FDDA-4C77-8C84-E361234C601E}"/>
               </a:ext>
             </a:extLst>
           </p:cNvPr>
@@ -12019,7 +12019,7 @@
           <p:cNvPr id="5" name="">
             <a:extLst xmlns:a="http://schemas.openxmlformats.org/drawingml/2006/main">
               <a:ext uri="{FF2B5EF4-FFF2-40B4-BE49-F238E27FC236}">
-                <a16:creationId xmlns:a16="http://schemas.microsoft.com/office/drawing/2014/main" id="{CF0EDD95-5584-46FA-B9C0-2C01218FB0F5}"/>
+                <a16:creationId xmlns:a16="http://schemas.microsoft.com/office/drawing/2014/main" id="{C1238570-074F-4AEA-A133-9224D6E645F5}"/>
               </a:ext>
             </a:extLst>
           </p:cNvPr>
@@ -12069,7 +12069,7 @@
           <p:cNvPr id="6" name="">
             <a:extLst xmlns:a="http://schemas.openxmlformats.org/drawingml/2006/main">
               <a:ext uri="{FF2B5EF4-FFF2-40B4-BE49-F238E27FC236}">
-                <a16:creationId xmlns:a16="http://schemas.microsoft.com/office/drawing/2014/main" id="{3DCD9C6A-7B1D-4AE5-AFE2-ED7496E33897}"/>
+                <a16:creationId xmlns:a16="http://schemas.microsoft.com/office/drawing/2014/main" id="{71D3C84C-3AA8-4181-AB48-E07280B2BC05}"/>
               </a:ext>
             </a:extLst>
           </p:cNvPr>
@@ -12119,7 +12119,7 @@
           <p:cNvPr id="7" name="">
             <a:extLst xmlns:a="http://schemas.openxmlformats.org/drawingml/2006/main">
               <a:ext uri="{FF2B5EF4-FFF2-40B4-BE49-F238E27FC236}">
-                <a16:creationId xmlns:a16="http://schemas.microsoft.com/office/drawing/2014/main" id="{039EAA13-FC55-4BDF-BEFA-75607014F952}"/>
+                <a16:creationId xmlns:a16="http://schemas.microsoft.com/office/drawing/2014/main" id="{E5F80AD9-916D-4E98-82E9-C3CD2E40A139}"/>
               </a:ext>
             </a:extLst>
           </p:cNvPr>
@@ -12150,7 +12150,7 @@
           <p:cNvPr id="8" name="">
             <a:extLst xmlns:a="http://schemas.openxmlformats.org/drawingml/2006/main">
               <a:ext uri="{FF2B5EF4-FFF2-40B4-BE49-F238E27FC236}">
-                <a16:creationId xmlns:a16="http://schemas.microsoft.com/office/drawing/2014/main" id="{67A108D9-3E02-4DD0-A300-4227C1CCADA9}"/>
+                <a16:creationId xmlns:a16="http://schemas.microsoft.com/office/drawing/2014/main" id="{DFCBB09E-D21A-42CC-8EF3-39EED3FEA197}"/>
               </a:ext>
             </a:extLst>
           </p:cNvPr>
@@ -12200,7 +12200,7 @@
           <p:cNvPr id="9" name="">
             <a:extLst xmlns:a="http://schemas.openxmlformats.org/drawingml/2006/main">
               <a:ext uri="{FF2B5EF4-FFF2-40B4-BE49-F238E27FC236}">
-                <a16:creationId xmlns:a16="http://schemas.microsoft.com/office/drawing/2014/main" id="{572B2E88-AC08-4FC9-B5CC-FE3A92C7852D}"/>
+                <a16:creationId xmlns:a16="http://schemas.microsoft.com/office/drawing/2014/main" id="{E37D410E-4049-459C-9EFB-B248019F4AE6}"/>
               </a:ext>
             </a:extLst>
           </p:cNvPr>
@@ -12235,7 +12235,7 @@
           <p:cNvPr id="10" name="">
             <a:extLst xmlns:a="http://schemas.openxmlformats.org/drawingml/2006/main">
               <a:ext uri="{FF2B5EF4-FFF2-40B4-BE49-F238E27FC236}">
-                <a16:creationId xmlns:a16="http://schemas.microsoft.com/office/drawing/2014/main" id="{8C60877E-383E-4C01-83D3-8122B6B63635}"/>
+                <a16:creationId xmlns:a16="http://schemas.microsoft.com/office/drawing/2014/main" id="{5AA54032-AD7F-4924-BA53-8E6F9BD283AA}"/>
               </a:ext>
             </a:extLst>
           </p:cNvPr>
@@ -12285,7 +12285,7 @@
           <p:cNvPr id="11" name="">
             <a:extLst xmlns:a="http://schemas.openxmlformats.org/drawingml/2006/main">
               <a:ext uri="{FF2B5EF4-FFF2-40B4-BE49-F238E27FC236}">
-                <a16:creationId xmlns:a16="http://schemas.microsoft.com/office/drawing/2014/main" id="{A5CC0F38-5D56-4333-AF85-6A66C0AFB5C8}"/>
+                <a16:creationId xmlns:a16="http://schemas.microsoft.com/office/drawing/2014/main" id="{7DD225DC-290A-4B80-B27B-D42E344D364C}"/>
               </a:ext>
             </a:extLst>
           </p:cNvPr>
@@ -12316,7 +12316,7 @@
           <p:cNvPr id="12" name="">
             <a:extLst xmlns:a="http://schemas.openxmlformats.org/drawingml/2006/main">
               <a:ext uri="{FF2B5EF4-FFF2-40B4-BE49-F238E27FC236}">
-                <a16:creationId xmlns:a16="http://schemas.microsoft.com/office/drawing/2014/main" id="{36CB678C-11DA-47BC-88A5-9A8CF05649ED}"/>
+                <a16:creationId xmlns:a16="http://schemas.microsoft.com/office/drawing/2014/main" id="{33AA6A90-9656-45D0-92C0-04EE9C68AE5A}"/>
               </a:ext>
             </a:extLst>
           </p:cNvPr>
@@ -12366,7 +12366,7 @@
           <p:cNvPr id="13" name="">
             <a:extLst xmlns:a="http://schemas.openxmlformats.org/drawingml/2006/main">
               <a:ext uri="{FF2B5EF4-FFF2-40B4-BE49-F238E27FC236}">
-                <a16:creationId xmlns:a16="http://schemas.microsoft.com/office/drawing/2014/main" id="{08609527-0E66-4D9C-988E-1491A1A293C0}"/>
+                <a16:creationId xmlns:a16="http://schemas.microsoft.com/office/drawing/2014/main" id="{FEDD6D25-87FC-48F5-93BA-42FAA530D1D5}"/>
               </a:ext>
             </a:extLst>
           </p:cNvPr>
@@ -12416,7 +12416,7 @@
           <p:cNvPr id="14" name="">
             <a:extLst xmlns:a="http://schemas.openxmlformats.org/drawingml/2006/main">
               <a:ext uri="{FF2B5EF4-FFF2-40B4-BE49-F238E27FC236}">
-                <a16:creationId xmlns:a16="http://schemas.microsoft.com/office/drawing/2014/main" id="{018635A8-B108-42EA-A3E7-8DD6E3CA1802}"/>
+                <a16:creationId xmlns:a16="http://schemas.microsoft.com/office/drawing/2014/main" id="{5F0FCD56-DE2D-429F-8AA4-640691AD1AD0}"/>
               </a:ext>
             </a:extLst>
           </p:cNvPr>
@@ -12451,7 +12451,7 @@
           <p:cNvPr id="15" name="">
             <a:extLst xmlns:a="http://schemas.openxmlformats.org/drawingml/2006/main">
               <a:ext uri="{FF2B5EF4-FFF2-40B4-BE49-F238E27FC236}">
-                <a16:creationId xmlns:a16="http://schemas.microsoft.com/office/drawing/2014/main" id="{25CD3631-F97E-4665-A86A-FAC580BBB70C}"/>
+                <a16:creationId xmlns:a16="http://schemas.microsoft.com/office/drawing/2014/main" id="{58B67201-E960-4737-8E2A-41C79FECE8C1}"/>
               </a:ext>
             </a:extLst>
           </p:cNvPr>
@@ -12501,7 +12501,7 @@
           <p:cNvPr id="16" name="">
             <a:extLst xmlns:a="http://schemas.openxmlformats.org/drawingml/2006/main">
               <a:ext uri="{FF2B5EF4-FFF2-40B4-BE49-F238E27FC236}">
-                <a16:creationId xmlns:a16="http://schemas.microsoft.com/office/drawing/2014/main" id="{E86F118D-D5D6-464F-8E8F-4E39969321E0}"/>
+                <a16:creationId xmlns:a16="http://schemas.microsoft.com/office/drawing/2014/main" id="{0974B82D-44E4-4342-8411-BFB82494A479}"/>
               </a:ext>
             </a:extLst>
           </p:cNvPr>
@@ -12532,7 +12532,7 @@
           <p:cNvPr id="17" name="">
             <a:extLst xmlns:a="http://schemas.openxmlformats.org/drawingml/2006/main">
               <a:ext uri="{FF2B5EF4-FFF2-40B4-BE49-F238E27FC236}">
-                <a16:creationId xmlns:a16="http://schemas.microsoft.com/office/drawing/2014/main" id="{E0790B74-3657-4241-998B-FD31A1562982}"/>
+                <a16:creationId xmlns:a16="http://schemas.microsoft.com/office/drawing/2014/main" id="{F5FFFA42-03DA-4FB0-A4FD-AD3215699A4B}"/>
               </a:ext>
             </a:extLst>
           </p:cNvPr>
@@ -12582,7 +12582,7 @@
           <p:cNvPr id="18" name="">
             <a:extLst xmlns:a="http://schemas.openxmlformats.org/drawingml/2006/main">
               <a:ext uri="{FF2B5EF4-FFF2-40B4-BE49-F238E27FC236}">
-                <a16:creationId xmlns:a16="http://schemas.microsoft.com/office/drawing/2014/main" id="{6EB07726-BEBC-49E8-894E-DF0B02E2EEFF}"/>
+                <a16:creationId xmlns:a16="http://schemas.microsoft.com/office/drawing/2014/main" id="{DF5FDA39-9F16-4F50-B355-7E0B7B08D738}"/>
               </a:ext>
             </a:extLst>
           </p:cNvPr>
@@ -12632,7 +12632,7 @@
           <p:cNvPr id="19" name="">
             <a:extLst xmlns:a="http://schemas.openxmlformats.org/drawingml/2006/main">
               <a:ext uri="{FF2B5EF4-FFF2-40B4-BE49-F238E27FC236}">
-                <a16:creationId xmlns:a16="http://schemas.microsoft.com/office/drawing/2014/main" id="{56364438-DE07-451D-9401-935CA58117B0}"/>
+                <a16:creationId xmlns:a16="http://schemas.microsoft.com/office/drawing/2014/main" id="{254C1C55-EE72-438E-B7D2-74C5BC4004F6}"/>
               </a:ext>
             </a:extLst>
           </p:cNvPr>
@@ -12667,7 +12667,7 @@
           <p:cNvPr id="20" name="">
             <a:extLst xmlns:a="http://schemas.openxmlformats.org/drawingml/2006/main">
               <a:ext uri="{FF2B5EF4-FFF2-40B4-BE49-F238E27FC236}">
-                <a16:creationId xmlns:a16="http://schemas.microsoft.com/office/drawing/2014/main" id="{803590B7-0077-420F-AD6B-F9EC1B894F41}"/>
+                <a16:creationId xmlns:a16="http://schemas.microsoft.com/office/drawing/2014/main" id="{DDA1F3CB-417D-48DA-A7B3-A8B68C6D66B2}"/>
               </a:ext>
             </a:extLst>
           </p:cNvPr>
@@ -12717,7 +12717,7 @@
           <p:cNvPr id="21" name="">
             <a:extLst xmlns:a="http://schemas.openxmlformats.org/drawingml/2006/main">
               <a:ext uri="{FF2B5EF4-FFF2-40B4-BE49-F238E27FC236}">
-                <a16:creationId xmlns:a16="http://schemas.microsoft.com/office/drawing/2014/main" id="{72176AF3-D94F-42EB-B8A2-6B881DDA1BF0}"/>
+                <a16:creationId xmlns:a16="http://schemas.microsoft.com/office/drawing/2014/main" id="{CDB8589D-6A37-42BD-9967-B83146BA1208}"/>
               </a:ext>
             </a:extLst>
           </p:cNvPr>
@@ -12748,7 +12748,7 @@
           <p:cNvPr id="22" name="">
             <a:extLst xmlns:a="http://schemas.openxmlformats.org/drawingml/2006/main">
               <a:ext uri="{FF2B5EF4-FFF2-40B4-BE49-F238E27FC236}">
-                <a16:creationId xmlns:a16="http://schemas.microsoft.com/office/drawing/2014/main" id="{35ED5048-DE14-44A7-833F-2047F438D8F3}"/>
+                <a16:creationId xmlns:a16="http://schemas.microsoft.com/office/drawing/2014/main" id="{08AC950C-1575-42A9-81EB-CE947A518033}"/>
               </a:ext>
             </a:extLst>
           </p:cNvPr>
@@ -12798,7 +12798,7 @@
           <p:cNvPr id="23" name="">
             <a:extLst xmlns:a="http://schemas.openxmlformats.org/drawingml/2006/main">
               <a:ext uri="{FF2B5EF4-FFF2-40B4-BE49-F238E27FC236}">
-                <a16:creationId xmlns:a16="http://schemas.microsoft.com/office/drawing/2014/main" id="{D81DB02E-EC65-48F7-AD87-50F140B5986E}"/>
+                <a16:creationId xmlns:a16="http://schemas.microsoft.com/office/drawing/2014/main" id="{D83A3113-F3A3-4A9C-86F2-3A6D697A4C07}"/>
               </a:ext>
             </a:extLst>
           </p:cNvPr>
@@ -12848,7 +12848,7 @@
           <p:cNvPr id="24" name="">
             <a:extLst xmlns:a="http://schemas.openxmlformats.org/drawingml/2006/main">
               <a:ext uri="{FF2B5EF4-FFF2-40B4-BE49-F238E27FC236}">
-                <a16:creationId xmlns:a16="http://schemas.microsoft.com/office/drawing/2014/main" id="{8722428B-3ECB-43E4-9F41-4404305C109C}"/>
+                <a16:creationId xmlns:a16="http://schemas.microsoft.com/office/drawing/2014/main" id="{04375615-F5DF-4549-A5B4-3D03542EFBCF}"/>
               </a:ext>
             </a:extLst>
           </p:cNvPr>
@@ -12898,7 +12898,7 @@
           <p:cNvPr id="25" name="">
             <a:extLst xmlns:a="http://schemas.openxmlformats.org/drawingml/2006/main">
               <a:ext uri="{FF2B5EF4-FFF2-40B4-BE49-F238E27FC236}">
-                <a16:creationId xmlns:a16="http://schemas.microsoft.com/office/drawing/2014/main" id="{7ADA82EC-77FF-482C-A4BF-B604F3D79957}"/>
+                <a16:creationId xmlns:a16="http://schemas.microsoft.com/office/drawing/2014/main" id="{7D824922-3E04-4F9B-AD59-C09797F7EEEC}"/>
               </a:ext>
             </a:extLst>
           </p:cNvPr>
@@ -12948,7 +12948,7 @@
           <p:cNvPr id="26" name="">
             <a:extLst xmlns:a="http://schemas.openxmlformats.org/drawingml/2006/main">
               <a:ext uri="{FF2B5EF4-FFF2-40B4-BE49-F238E27FC236}">
-                <a16:creationId xmlns:a16="http://schemas.microsoft.com/office/drawing/2014/main" id="{0FC15DDB-17FA-43D0-B72F-AF6239A1E8C1}"/>
+                <a16:creationId xmlns:a16="http://schemas.microsoft.com/office/drawing/2014/main" id="{CCE11EE4-DCDB-40E6-BDA7-40A59616784D}"/>
               </a:ext>
             </a:extLst>
           </p:cNvPr>
@@ -12979,7 +12979,7 @@
           <p:cNvPr id="27" name="">
             <a:extLst xmlns:a="http://schemas.openxmlformats.org/drawingml/2006/main">
               <a:ext uri="{FF2B5EF4-FFF2-40B4-BE49-F238E27FC236}">
-                <a16:creationId xmlns:a16="http://schemas.microsoft.com/office/drawing/2014/main" id="{CE9CE46C-D630-47C7-AB4B-59CB61875156}"/>
+                <a16:creationId xmlns:a16="http://schemas.microsoft.com/office/drawing/2014/main" id="{4C874D9A-971D-4858-B262-08D16EDB1454}"/>
               </a:ext>
             </a:extLst>
           </p:cNvPr>
@@ -13029,7 +13029,7 @@
           <p:cNvPr id="28" name="">
             <a:extLst xmlns:a="http://schemas.openxmlformats.org/drawingml/2006/main">
               <a:ext uri="{FF2B5EF4-FFF2-40B4-BE49-F238E27FC236}">
-                <a16:creationId xmlns:a16="http://schemas.microsoft.com/office/drawing/2014/main" id="{A0FD9D97-2F4C-4C72-86CC-4467BBD33353}"/>
+                <a16:creationId xmlns:a16="http://schemas.microsoft.com/office/drawing/2014/main" id="{A5A5D6A7-AB22-44CE-8CFD-E02E3484B24C}"/>
               </a:ext>
             </a:extLst>
           </p:cNvPr>
@@ -13079,7 +13079,7 @@
           <p:cNvPr id="29" name="">
             <a:extLst xmlns:a="http://schemas.openxmlformats.org/drawingml/2006/main">
               <a:ext uri="{FF2B5EF4-FFF2-40B4-BE49-F238E27FC236}">
-                <a16:creationId xmlns:a16="http://schemas.microsoft.com/office/drawing/2014/main" id="{59CEAFF3-E7A7-4195-862C-BC9F75E289B8}"/>
+                <a16:creationId xmlns:a16="http://schemas.microsoft.com/office/drawing/2014/main" id="{DA874771-D836-4126-9190-A5D4F80AA1F1}"/>
               </a:ext>
             </a:extLst>
           </p:cNvPr>
@@ -13129,7 +13129,7 @@
           <p:cNvPr id="30" name="">
             <a:extLst xmlns:a="http://schemas.openxmlformats.org/drawingml/2006/main">
               <a:ext uri="{FF2B5EF4-FFF2-40B4-BE49-F238E27FC236}">
-                <a16:creationId xmlns:a16="http://schemas.microsoft.com/office/drawing/2014/main" id="{5CC68A4A-309A-4EFB-AAF0-55A3D6134AF3}"/>
+                <a16:creationId xmlns:a16="http://schemas.microsoft.com/office/drawing/2014/main" id="{05E97D54-8026-40F3-8E23-CC1ACF4737C1}"/>
               </a:ext>
             </a:extLst>
           </p:cNvPr>
@@ -13177,7 +13177,7 @@
     </p:spTree>
     <p:extLst>
       <p:ext uri="{BB962C8B-B14F-4D97-AF65-F5344CB8AC3E}">
-        <p14:creationId xmlns:p14="http://schemas.microsoft.com/office/powerpoint/2010/main" val="739834705"/>
+        <p14:creationId xmlns:p14="http://schemas.microsoft.com/office/powerpoint/2010/main" val="2065781740"/>
       </p:ext>
     </p:extLst>
   </p:cSld>
@@ -13208,7 +13208,7 @@
           <p:cNvPr id="24" name="">
             <a:extLst xmlns:a="http://schemas.openxmlformats.org/drawingml/2006/main">
               <a:ext uri="{FF2B5EF4-FFF2-40B4-BE49-F238E27FC236}">
-                <a16:creationId xmlns:a16="http://schemas.microsoft.com/office/drawing/2014/main" id="{9DF912A4-E4CB-4888-AD2C-6CB44A21BA1C}"/>
+                <a16:creationId xmlns:a16="http://schemas.microsoft.com/office/drawing/2014/main" id="{EE86007F-7F4F-449F-9D04-E226C63D330B}"/>
               </a:ext>
             </a:extLst>
           </p:cNvPr>
@@ -13258,7 +13258,7 @@
           <p:cNvPr id="2" name="">
             <a:extLst xmlns:a="http://schemas.openxmlformats.org/drawingml/2006/main">
               <a:ext uri="{FF2B5EF4-FFF2-40B4-BE49-F238E27FC236}">
-                <a16:creationId xmlns:a16="http://schemas.microsoft.com/office/drawing/2014/main" id="{42ADACC6-D13E-41EE-82E3-126912DBFC81}"/>
+                <a16:creationId xmlns:a16="http://schemas.microsoft.com/office/drawing/2014/main" id="{700B2037-8F0D-4D7D-8942-EBDA2C38360C}"/>
               </a:ext>
             </a:extLst>
           </p:cNvPr>
@@ -13298,7 +13298,7 @@
                   <a:srgbClr val="122A3E"/>
                 </a:solidFill>
               </a:rPr>
-              <a:t>Watch the account. Try the decision. Inspect the proof.</a:t>
+              <a:t>See why Finly finished $38,629 ahead of SPY.</a:t>
             </a:r>
           </a:p>
         </p:txBody>
@@ -13308,7 +13308,7 @@
           <p:cNvPr id="3" name="">
             <a:extLst xmlns:a="http://schemas.openxmlformats.org/drawingml/2006/main">
               <a:ext uri="{FF2B5EF4-FFF2-40B4-BE49-F238E27FC236}">
-                <a16:creationId xmlns:a16="http://schemas.microsoft.com/office/drawing/2014/main" id="{00AD4D16-649E-4562-A3AE-F4D8CBDD5A76}"/>
+                <a16:creationId xmlns:a16="http://schemas.microsoft.com/office/drawing/2014/main" id="{02DCBB22-DAD1-4A91-B6BF-D946C3F909C9}"/>
               </a:ext>
             </a:extLst>
           </p:cNvPr>
@@ -13320,7 +13320,7 @@
         <p:spPr>
           <a:xfrm xmlns:a="http://schemas.openxmlformats.org/drawingml/2006/main">
             <a:off x="609600" y="1981200"/>
-            <a:ext cx="7429500" cy="590550"/>
+            <a:ext cx="7429500" cy="723900"/>
           </a:xfrm>
           <a:prstGeom xmlns:a="http://schemas.openxmlformats.org/drawingml/2006/main" prst="rect">
             <a:avLst/>
@@ -13336,19 +13336,19 @@
           <a:lstStyle xmlns:a="http://schemas.openxmlformats.org/drawingml/2006/main"/>
           <a:p xmlns:a="http://schemas.openxmlformats.org/drawingml/2006/main">
             <a:pPr algn="l">
-              <a:defRPr sz="2025" b="0" i="0">
+              <a:defRPr sz="1950" b="0" i="0">
                 <a:solidFill>
                   <a:srgbClr val="627078"/>
                 </a:solidFill>
               </a:defRPr>
             </a:pPr>
             <a:r>
-              <a:rPr sz="2025" b="0" i="0">
+              <a:rPr sz="1950" b="0" i="0">
                 <a:solidFill>
                   <a:srgbClr val="627078"/>
                 </a:solidFill>
               </a:rPr>
-              <a:t>$426 ahead of SPY through September 2—and every headline links to evidence you can inspect.</a:t>
+              <a:t>Explore the 2013–2026 cost-modeled replay, then inspect the separate +$426 Alpaca paper result and every decision behind it.</a:t>
             </a:r>
           </a:p>
         </p:txBody>
@@ -13358,7 +13358,7 @@
           <p:cNvPr id="4" name="">
             <a:extLst xmlns:a="http://schemas.openxmlformats.org/drawingml/2006/main">
               <a:ext uri="{FF2B5EF4-FFF2-40B4-BE49-F238E27FC236}">
-                <a16:creationId xmlns:a16="http://schemas.microsoft.com/office/drawing/2014/main" id="{CC4E1572-79C6-4C1F-8165-A9AA6E50516D}"/>
+                <a16:creationId xmlns:a16="http://schemas.microsoft.com/office/drawing/2014/main" id="{7F08F3DF-1DD1-4270-B00B-37C728CA8CDD}"/>
               </a:ext>
             </a:extLst>
           </p:cNvPr>
@@ -13403,7 +13403,7 @@
           <p:nvPr/>
         </p:nvPicPr>
         <p:blipFill>
-          <a:blip xmlns:r="http://schemas.openxmlformats.org/officeDocument/2006/relationships" xmlns:a="http://schemas.openxmlformats.org/drawingml/2006/main" r:embed="R244ce5f401054397"/>
+          <a:blip xmlns:r="http://schemas.openxmlformats.org/officeDocument/2006/relationships" xmlns:a="http://schemas.openxmlformats.org/drawingml/2006/main" r:embed="Rbd6266fdcecf422d"/>
           <a:stretch xmlns:a="http://schemas.openxmlformats.org/drawingml/2006/main"/>
         </p:blipFill>
         <p:spPr>
@@ -13421,7 +13421,7 @@
           <p:cNvPr id="6" name="">
             <a:extLst xmlns:a="http://schemas.openxmlformats.org/drawingml/2006/main">
               <a:ext uri="{FF2B5EF4-FFF2-40B4-BE49-F238E27FC236}">
-                <a16:creationId xmlns:a16="http://schemas.microsoft.com/office/drawing/2014/main" id="{9AA8BBD7-CD90-44B9-87AD-5A9B2418D5A6}"/>
+                <a16:creationId xmlns:a16="http://schemas.microsoft.com/office/drawing/2014/main" id="{0A376166-3409-43D3-B74F-BE7B978724D4}"/>
               </a:ext>
             </a:extLst>
           </p:cNvPr>
@@ -13464,7 +13464,7 @@
                 <a:latin typeface="Arial"/>
                 <a:ea typeface="Arial"/>
                 <a:cs typeface="Arial"/>
-                <a:hlinkClick xmlns:r="http://schemas.openxmlformats.org/officeDocument/2006/relationships" r:id="Rad7efc709d904173"/>
+                <a:hlinkClick xmlns:r="http://schemas.openxmlformats.org/officeDocument/2006/relationships" r:id="Rf9d940d1142a4da8"/>
               </a:rPr>
               <a:t>SCAN TO OPEN FINLY</a:t>
             </a:r>
@@ -13476,7 +13476,7 @@
           <p:cNvPr id="7" name="">
             <a:extLst xmlns:a="http://schemas.openxmlformats.org/drawingml/2006/main">
               <a:ext uri="{FF2B5EF4-FFF2-40B4-BE49-F238E27FC236}">
-                <a16:creationId xmlns:a16="http://schemas.microsoft.com/office/drawing/2014/main" id="{C9FF7CD8-CCDB-4374-81F3-80D8C3AF341B}"/>
+                <a16:creationId xmlns:a16="http://schemas.microsoft.com/office/drawing/2014/main" id="{C685317F-78D5-400A-A219-D64DC1AC32FA}"/>
               </a:ext>
             </a:extLst>
           </p:cNvPr>
@@ -13526,7 +13526,7 @@
           <p:cNvPr id="8" name="">
             <a:extLst xmlns:a="http://schemas.openxmlformats.org/drawingml/2006/main">
               <a:ext uri="{FF2B5EF4-FFF2-40B4-BE49-F238E27FC236}">
-                <a16:creationId xmlns:a16="http://schemas.microsoft.com/office/drawing/2014/main" id="{B55AED38-E732-413B-8C61-1DB7EFCD6F77}"/>
+                <a16:creationId xmlns:a16="http://schemas.microsoft.com/office/drawing/2014/main" id="{83A9A58F-E12A-4E8B-AF35-7D3F3859AF64}"/>
               </a:ext>
             </a:extLst>
           </p:cNvPr>
@@ -13576,7 +13576,7 @@
           <p:cNvPr id="9" name="">
             <a:extLst xmlns:a="http://schemas.openxmlformats.org/drawingml/2006/main">
               <a:ext uri="{FF2B5EF4-FFF2-40B4-BE49-F238E27FC236}">
-                <a16:creationId xmlns:a16="http://schemas.microsoft.com/office/drawing/2014/main" id="{7CABF766-C3C3-4712-A806-3E466CFAFF18}"/>
+                <a16:creationId xmlns:a16="http://schemas.microsoft.com/office/drawing/2014/main" id="{6AA9EC4C-2E3A-49BE-8D9A-9D9920A674BE}"/>
               </a:ext>
             </a:extLst>
           </p:cNvPr>
@@ -13626,7 +13626,7 @@
           <p:cNvPr id="10" name="">
             <a:extLst xmlns:a="http://schemas.openxmlformats.org/drawingml/2006/main">
               <a:ext uri="{FF2B5EF4-FFF2-40B4-BE49-F238E27FC236}">
-                <a16:creationId xmlns:a16="http://schemas.microsoft.com/office/drawing/2014/main" id="{097B8266-3C82-469E-922F-94AD78F88BC6}"/>
+                <a16:creationId xmlns:a16="http://schemas.microsoft.com/office/drawing/2014/main" id="{99424F56-3CE0-43E3-AD00-459E8C684B76}"/>
               </a:ext>
             </a:extLst>
           </p:cNvPr>
@@ -13657,7 +13657,7 @@
           <p:cNvPr id="11" name="">
             <a:extLst xmlns:a="http://schemas.openxmlformats.org/drawingml/2006/main">
               <a:ext uri="{FF2B5EF4-FFF2-40B4-BE49-F238E27FC236}">
-                <a16:creationId xmlns:a16="http://schemas.microsoft.com/office/drawing/2014/main" id="{F2503EA6-BE29-49D1-9864-E0344C713783}"/>
+                <a16:creationId xmlns:a16="http://schemas.microsoft.com/office/drawing/2014/main" id="{2442EED4-3E5F-41F0-96CE-C8ADA3DC299B}"/>
               </a:ext>
             </a:extLst>
           </p:cNvPr>
@@ -13707,7 +13707,7 @@
           <p:cNvPr id="12" name="">
             <a:extLst xmlns:a="http://schemas.openxmlformats.org/drawingml/2006/main">
               <a:ext uri="{FF2B5EF4-FFF2-40B4-BE49-F238E27FC236}">
-                <a16:creationId xmlns:a16="http://schemas.microsoft.com/office/drawing/2014/main" id="{50A29F5E-013D-4096-94BB-1D19342E60C7}"/>
+                <a16:creationId xmlns:a16="http://schemas.microsoft.com/office/drawing/2014/main" id="{EE8F478B-E37D-4FEE-BF82-CC19FA640D3D}"/>
               </a:ext>
             </a:extLst>
           </p:cNvPr>
@@ -13757,7 +13757,7 @@
           <p:cNvPr id="13" name="">
             <a:extLst xmlns:a="http://schemas.openxmlformats.org/drawingml/2006/main">
               <a:ext uri="{FF2B5EF4-FFF2-40B4-BE49-F238E27FC236}">
-                <a16:creationId xmlns:a16="http://schemas.microsoft.com/office/drawing/2014/main" id="{76A4B4D6-14E5-4604-A49D-5215E5A5628B}"/>
+                <a16:creationId xmlns:a16="http://schemas.microsoft.com/office/drawing/2014/main" id="{D708CD28-9503-4CC1-8FBA-1C13AB6C986E}"/>
               </a:ext>
             </a:extLst>
           </p:cNvPr>
@@ -13807,7 +13807,7 @@
           <p:cNvPr id="14" name="">
             <a:extLst xmlns:a="http://schemas.openxmlformats.org/drawingml/2006/main">
               <a:ext uri="{FF2B5EF4-FFF2-40B4-BE49-F238E27FC236}">
-                <a16:creationId xmlns:a16="http://schemas.microsoft.com/office/drawing/2014/main" id="{A52D659C-5224-4F45-B7AE-0D0B8B9ED4E4}"/>
+                <a16:creationId xmlns:a16="http://schemas.microsoft.com/office/drawing/2014/main" id="{40DD0B28-0FA6-436D-BB8C-89F2510BFE78}"/>
               </a:ext>
             </a:extLst>
           </p:cNvPr>
@@ -13838,7 +13838,7 @@
           <p:cNvPr id="15" name="">
             <a:extLst xmlns:a="http://schemas.openxmlformats.org/drawingml/2006/main">
               <a:ext uri="{FF2B5EF4-FFF2-40B4-BE49-F238E27FC236}">
-                <a16:creationId xmlns:a16="http://schemas.microsoft.com/office/drawing/2014/main" id="{78D87229-1398-415D-A141-C4F47BB769EC}"/>
+                <a16:creationId xmlns:a16="http://schemas.microsoft.com/office/drawing/2014/main" id="{76DE2481-B0E1-4F17-948A-316F69228619}"/>
               </a:ext>
             </a:extLst>
           </p:cNvPr>
@@ -13888,7 +13888,7 @@
           <p:cNvPr id="16" name="">
             <a:extLst xmlns:a="http://schemas.openxmlformats.org/drawingml/2006/main">
               <a:ext uri="{FF2B5EF4-FFF2-40B4-BE49-F238E27FC236}">
-                <a16:creationId xmlns:a16="http://schemas.microsoft.com/office/drawing/2014/main" id="{9BE9DAB9-C592-489B-85F3-1092E93B86AB}"/>
+                <a16:creationId xmlns:a16="http://schemas.microsoft.com/office/drawing/2014/main" id="{4F1CB302-0EB1-4B66-86BA-AA68D9E0AC41}"/>
               </a:ext>
             </a:extLst>
           </p:cNvPr>
@@ -13938,7 +13938,7 @@
           <p:cNvPr id="17" name="">
             <a:extLst xmlns:a="http://schemas.openxmlformats.org/drawingml/2006/main">
               <a:ext uri="{FF2B5EF4-FFF2-40B4-BE49-F238E27FC236}">
-                <a16:creationId xmlns:a16="http://schemas.microsoft.com/office/drawing/2014/main" id="{8C141330-D7D5-4320-9FEB-118A421F36DC}"/>
+                <a16:creationId xmlns:a16="http://schemas.microsoft.com/office/drawing/2014/main" id="{776861AE-D567-43B5-85DA-379FBD345C4C}"/>
               </a:ext>
             </a:extLst>
           </p:cNvPr>
@@ -13988,7 +13988,7 @@
           <p:cNvPr id="18" name="">
             <a:extLst xmlns:a="http://schemas.openxmlformats.org/drawingml/2006/main">
               <a:ext uri="{FF2B5EF4-FFF2-40B4-BE49-F238E27FC236}">
-                <a16:creationId xmlns:a16="http://schemas.microsoft.com/office/drawing/2014/main" id="{23A57365-E89D-4443-AB2A-3F6173C5EF47}"/>
+                <a16:creationId xmlns:a16="http://schemas.microsoft.com/office/drawing/2014/main" id="{5C3F465E-F033-4BF5-8339-7CEB4DB8FA4C}"/>
               </a:ext>
             </a:extLst>
           </p:cNvPr>
@@ -14019,7 +14019,7 @@
           <p:cNvPr id="19" name="">
             <a:extLst xmlns:a="http://schemas.openxmlformats.org/drawingml/2006/main">
               <a:ext uri="{FF2B5EF4-FFF2-40B4-BE49-F238E27FC236}">
-                <a16:creationId xmlns:a16="http://schemas.microsoft.com/office/drawing/2014/main" id="{156A84D8-4AF1-4A51-A125-AC2F55BA8624}"/>
+                <a16:creationId xmlns:a16="http://schemas.microsoft.com/office/drawing/2014/main" id="{1A456D27-C432-488E-BCA3-02FC89015126}"/>
               </a:ext>
             </a:extLst>
           </p:cNvPr>
@@ -14069,7 +14069,7 @@
           <p:cNvPr id="20" name="">
             <a:extLst xmlns:a="http://schemas.openxmlformats.org/drawingml/2006/main">
               <a:ext uri="{FF2B5EF4-FFF2-40B4-BE49-F238E27FC236}">
-                <a16:creationId xmlns:a16="http://schemas.microsoft.com/office/drawing/2014/main" id="{604236B9-389C-4EFC-9057-614FA11E0BE1}"/>
+                <a16:creationId xmlns:a16="http://schemas.microsoft.com/office/drawing/2014/main" id="{DA87E62A-F74D-425E-844F-852935BD7AD9}"/>
               </a:ext>
             </a:extLst>
           </p:cNvPr>
@@ -14112,7 +14112,7 @@
                 <a:latin typeface="Arial"/>
                 <a:ea typeface="Arial"/>
                 <a:cs typeface="Arial"/>
-                <a:hlinkClick xmlns:r="http://schemas.openxmlformats.org/officeDocument/2006/relationships" r:id="R9d919eda949c4fa9"/>
+                <a:hlinkClick xmlns:r="http://schemas.openxmlformats.org/officeDocument/2006/relationships" r:id="R61c03be733904d37"/>
               </a:rPr>
               <a:t>owlsowo.github.io/finly-bot</a:t>
             </a:r>
@@ -14124,7 +14124,7 @@
           <p:cNvPr id="21" name="">
             <a:extLst xmlns:a="http://schemas.openxmlformats.org/drawingml/2006/main">
               <a:ext uri="{FF2B5EF4-FFF2-40B4-BE49-F238E27FC236}">
-                <a16:creationId xmlns:a16="http://schemas.microsoft.com/office/drawing/2014/main" id="{FB361DE7-F79A-49CA-875A-6C2988AC2A1C}"/>
+                <a16:creationId xmlns:a16="http://schemas.microsoft.com/office/drawing/2014/main" id="{711D78FC-C9B2-4054-AC75-6AF0AC346E76}"/>
               </a:ext>
             </a:extLst>
           </p:cNvPr>
@@ -14174,7 +14174,7 @@
           <p:cNvPr id="22" name="">
             <a:extLst xmlns:a="http://schemas.openxmlformats.org/drawingml/2006/main">
               <a:ext uri="{FF2B5EF4-FFF2-40B4-BE49-F238E27FC236}">
-                <a16:creationId xmlns:a16="http://schemas.microsoft.com/office/drawing/2014/main" id="{883FBBFE-F296-474C-8B15-0E22E440809D}"/>
+                <a16:creationId xmlns:a16="http://schemas.microsoft.com/office/drawing/2014/main" id="{ED513929-886E-4CEF-BB6C-E06FB7FB1F58}"/>
               </a:ext>
             </a:extLst>
           </p:cNvPr>
@@ -14224,7 +14224,7 @@
           <p:cNvPr id="23" name="">
             <a:extLst xmlns:a="http://schemas.openxmlformats.org/drawingml/2006/main">
               <a:ext uri="{FF2B5EF4-FFF2-40B4-BE49-F238E27FC236}">
-                <a16:creationId xmlns:a16="http://schemas.microsoft.com/office/drawing/2014/main" id="{3B812879-3156-43C9-96EB-F167BCD0A423}"/>
+                <a16:creationId xmlns:a16="http://schemas.microsoft.com/office/drawing/2014/main" id="{23608471-9BB0-4323-AAE5-0444D394A8D6}"/>
               </a:ext>
             </a:extLst>
           </p:cNvPr>
@@ -14272,7 +14272,7 @@
     </p:spTree>
     <p:extLst>
       <p:ext uri="{BB962C8B-B14F-4D97-AF65-F5344CB8AC3E}">
-        <p14:creationId xmlns:p14="http://schemas.microsoft.com/office/powerpoint/2010/main" val="1565074712"/>
+        <p14:creationId xmlns:p14="http://schemas.microsoft.com/office/powerpoint/2010/main" val="2007586742"/>
       </p:ext>
     </p:extLst>
   </p:cSld>

</xml_diff>